<commit_message>
Add object and subject of research to slide 2 of presentation
</commit_message>
<xml_diff>
--- a/docs/Визуализация науки на основе метаданных публикаций и журналов.pptx
+++ b/docs/Визуализация науки на основе метаданных публикаций и журналов.pptx
@@ -4668,8 +4668,8 @@
         </p:nvSpPr>
         <p:spPr>
           <a:xfrm>
-            <a:off x="457200" y="1143000"/>
-            <a:ext cx="11247120" cy="411480"/>
+            <a:off x="457200" y="2400000"/>
+            <a:ext cx="11247120" cy="270000"/>
           </a:xfrm>
           <a:prstGeom prst="rect">
             <a:avLst/>
@@ -4684,7 +4684,7 @@
           <a:p>
             <a:pPr algn="l"/>
             <a:r>
-              <a:rPr sz="1700" b="1" i="0">
+              <a:rPr sz="1500" b="1" i="0">
                 <a:solidFill>
                   <a:srgbClr val="23613F"/>
                 </a:solidFill>
@@ -4703,8 +4703,8 @@
         </p:nvSpPr>
         <p:spPr>
           <a:xfrm>
-            <a:off x="457200" y="1554480"/>
-            <a:ext cx="11247120" cy="822960"/>
+            <a:off x="457200" y="2680000"/>
+            <a:ext cx="11247120" cy="460000"/>
           </a:xfrm>
           <a:prstGeom prst="rect">
             <a:avLst/>
@@ -4719,7 +4719,7 @@
           <a:p>
             <a:pPr algn="l"/>
             <a:r>
-              <a:rPr sz="1700" b="0" i="0">
+              <a:rPr sz="1400" b="0" i="0">
                 <a:solidFill>
                   <a:srgbClr val="122017"/>
                 </a:solidFill>
@@ -4739,8 +4739,8 @@
         </p:nvSpPr>
         <p:spPr>
           <a:xfrm>
-            <a:off x="457200" y="2514600"/>
-            <a:ext cx="2743200" cy="365760"/>
+            <a:off x="457200" y="3200000"/>
+            <a:ext cx="2743200" cy="260000"/>
           </a:xfrm>
           <a:prstGeom prst="rect">
             <a:avLst/>
@@ -4755,7 +4755,7 @@
           <a:p>
             <a:pPr algn="l"/>
             <a:r>
-              <a:rPr sz="1700" b="1" i="0">
+              <a:rPr sz="1500" b="1" i="0">
                 <a:solidFill>
                   <a:srgbClr val="23613F"/>
                 </a:solidFill>
@@ -4774,8 +4774,8 @@
         </p:nvSpPr>
         <p:spPr>
           <a:xfrm>
-            <a:off x="457200" y="2926080"/>
-            <a:ext cx="11247120" cy="3474720"/>
+            <a:off x="457200" y="3500000"/>
+            <a:ext cx="11247120" cy="3300000"/>
           </a:xfrm>
           <a:prstGeom prst="rect">
             <a:avLst/>
@@ -4795,7 +4795,7 @@
               </a:spcBef>
             </a:pPr>
             <a:r>
-              <a:rPr sz="1600" b="0" i="0">
+              <a:rPr sz="1400" b="0" i="0">
                 <a:solidFill>
                   <a:srgbClr val="122017"/>
                 </a:solidFill>
@@ -4811,7 +4811,7 @@
               </a:spcBef>
             </a:pPr>
             <a:r>
-              <a:rPr sz="1600" b="0" i="0">
+              <a:rPr sz="1400" b="0" i="0">
                 <a:solidFill>
                   <a:srgbClr val="122017"/>
                 </a:solidFill>
@@ -4827,7 +4827,7 @@
               </a:spcBef>
             </a:pPr>
             <a:r>
-              <a:rPr sz="1600" b="0" i="0">
+              <a:rPr sz="1400" b="0" i="0">
                 <a:solidFill>
                   <a:srgbClr val="122017"/>
                 </a:solidFill>
@@ -4843,7 +4843,7 @@
               </a:spcBef>
             </a:pPr>
             <a:r>
-              <a:rPr sz="1600" b="0" i="0">
+              <a:rPr sz="1400" b="0" i="0">
                 <a:solidFill>
                   <a:srgbClr val="122017"/>
                 </a:solidFill>
@@ -4859,7 +4859,7 @@
               </a:spcBef>
             </a:pPr>
             <a:r>
-              <a:rPr sz="1600" b="0" i="0">
+              <a:rPr sz="1400" b="0" i="0">
                 <a:solidFill>
                   <a:srgbClr val="122017"/>
                 </a:solidFill>
@@ -4875,13 +4875,149 @@
               </a:spcBef>
             </a:pPr>
             <a:r>
-              <a:rPr sz="1600" b="0" i="0">
+              <a:rPr sz="1400" b="0" i="0">
                 <a:solidFill>
                   <a:srgbClr val="122017"/>
                 </a:solidFill>
                 <a:latin typeface="Calibri"/>
               </a:rPr>
               <a:t>  • Разработать REST API и браузерный интерфейс</a:t>
+            </a:r>
+          </a:p>
+        </p:txBody>
+      </p:sp>
+      <p:sp>
+        <p:nvSpPr>
+          <p:cNvPr id="9" name="TextBox 8"/>
+          <p:cNvSpPr txBox="1"/>
+          <p:nvPr/>
+        </p:nvSpPr>
+        <p:spPr>
+          <a:xfrm>
+            <a:off x="457200" y="1080000"/>
+            <a:ext cx="11247120" cy="260000"/>
+          </a:xfrm>
+          <a:prstGeom prst="rect">
+            <a:avLst/>
+          </a:prstGeom>
+          <a:noFill/>
+        </p:spPr>
+        <p:txBody>
+          <a:bodyPr wrap="square">
+            <a:spAutoFit/>
+          </a:bodyPr>
+          <a:lstStyle/>
+          <a:p>
+            <a:pPr algn="l"/>
+            <a:r>
+              <a:rPr b="1" sz="1500">
+                <a:solidFill>
+                  <a:srgbClr val="183528"/>
+                </a:solidFill>
+              </a:rPr>
+              <a:t>Объект исследования:</a:t>
+            </a:r>
+          </a:p>
+        </p:txBody>
+      </p:sp>
+      <p:sp>
+        <p:nvSpPr>
+          <p:cNvPr id="10" name="TextBox 9"/>
+          <p:cNvSpPr txBox="1"/>
+          <p:nvPr/>
+        </p:nvSpPr>
+        <p:spPr>
+          <a:xfrm>
+            <a:off x="457200" y="1340000"/>
+            <a:ext cx="11247120" cy="320000"/>
+          </a:xfrm>
+          <a:prstGeom prst="rect">
+            <a:avLst/>
+          </a:prstGeom>
+          <a:noFill/>
+        </p:spPr>
+        <p:txBody>
+          <a:bodyPr wrap="square">
+            <a:spAutoFit/>
+          </a:bodyPr>
+          <a:lstStyle/>
+          <a:p>
+            <a:pPr algn="l"/>
+            <a:r>
+              <a:rPr b="0" sz="1400">
+                <a:solidFill>
+                  <a:srgbClr val="1A1A1A"/>
+                </a:solidFill>
+              </a:rPr>
+              <a:t>Система метаданных научных публикаций и журналов, представленных в открытых библиографических каталогах.</a:t>
+            </a:r>
+          </a:p>
+        </p:txBody>
+      </p:sp>
+      <p:sp>
+        <p:nvSpPr>
+          <p:cNvPr id="11" name="TextBox 10"/>
+          <p:cNvSpPr txBox="1"/>
+          <p:nvPr/>
+        </p:nvSpPr>
+        <p:spPr>
+          <a:xfrm>
+            <a:off x="457200" y="1700000"/>
+            <a:ext cx="11247120" cy="260000"/>
+          </a:xfrm>
+          <a:prstGeom prst="rect">
+            <a:avLst/>
+          </a:prstGeom>
+          <a:noFill/>
+        </p:spPr>
+        <p:txBody>
+          <a:bodyPr wrap="square">
+            <a:spAutoFit/>
+          </a:bodyPr>
+          <a:lstStyle/>
+          <a:p>
+            <a:pPr algn="l"/>
+            <a:r>
+              <a:rPr b="1" sz="1500">
+                <a:solidFill>
+                  <a:srgbClr val="183528"/>
+                </a:solidFill>
+              </a:rPr>
+              <a:t>Предмет исследования:</a:t>
+            </a:r>
+          </a:p>
+        </p:txBody>
+      </p:sp>
+      <p:sp>
+        <p:nvSpPr>
+          <p:cNvPr id="12" name="TextBox 11"/>
+          <p:cNvSpPr txBox="1"/>
+          <p:nvPr/>
+        </p:nvSpPr>
+        <p:spPr>
+          <a:xfrm>
+            <a:off x="457200" y="1960000"/>
+            <a:ext cx="11247120" cy="380000"/>
+          </a:xfrm>
+          <a:prstGeom prst="rect">
+            <a:avLst/>
+          </a:prstGeom>
+          <a:noFill/>
+        </p:spPr>
+        <p:txBody>
+          <a:bodyPr wrap="square">
+            <a:spAutoFit/>
+          </a:bodyPr>
+          <a:lstStyle/>
+          <a:p>
+            <a:pPr algn="l"/>
+            <a:r>
+              <a:rPr b="0" sz="1400">
+                <a:solidFill>
+                  <a:srgbClr val="1A1A1A"/>
+                </a:solidFill>
+              </a:rPr>
+              <a:t>Методы интерактивной визуализации метаданных научных публикаций: географической карты аффилиаций авторов и графа связей между публикациями, авторами, журналами и организациями.</a:t>
             </a:r>
           </a:p>
         </p:txBody>

</xml_diff>

<commit_message>
Add glossary slide to presentation (slide 2)
</commit_message>
<xml_diff>
--- a/docs/Визуализация науки на основе метаданных публикаций и журналов.pptx
+++ b/docs/Визуализация науки на основе метаданных публикаций и журналов.pptx
@@ -6,6 +6,7 @@
   </p:sldMasterIdLst>
   <p:sldIdLst>
     <p:sldId id="256" r:id="rId7"/>
+    <p:sldId id="267" r:id="rId18"/>
     <p:sldId id="257" r:id="rId8"/>
     <p:sldId id="258" r:id="rId9"/>
     <p:sldId id="259" r:id="rId10"/>
@@ -4521,6 +4522,696 @@
           </a:p>
         </p:txBody>
       </p:sp>
+    </p:spTree>
+  </p:cSld>
+  <p:clrMapOvr>
+    <a:masterClrMapping/>
+  </p:clrMapOvr>
+</p:sld>
+</file>
+
+<file path=ppt/slides/slide12.xml><?xml version="1.0" encoding="utf-8"?>
+<p:sld xmlns:a="http://schemas.openxmlformats.org/drawingml/2006/main" xmlns:p="http://schemas.openxmlformats.org/presentationml/2006/main" xmlns:r="http://schemas.openxmlformats.org/officeDocument/2006/relationships">
+  <p:cSld>
+    <p:spTree>
+      <p:nvGrpSpPr>
+        <p:cNvPr id="1" name=""/>
+        <p:cNvGrpSpPr/>
+        <p:nvPr/>
+      </p:nvGrpSpPr>
+      <p:grpSpPr/>
+      <p:sp>
+        <p:nvSpPr>
+          <p:cNvPr id="2" name="TextBox 1"/>
+          <p:cNvSpPr txBox="1"/>
+          <p:nvPr/>
+        </p:nvSpPr>
+        <p:spPr>
+          <a:xfrm>
+            <a:off x="360000" y="200000"/>
+            <a:ext cx="11468952" cy="500000"/>
+          </a:xfrm>
+          <a:prstGeom prst="rect">
+            <a:avLst/>
+          </a:prstGeom>
+          <a:noFill/>
+        </p:spPr>
+        <p:txBody>
+          <a:bodyPr wrap="none">
+            <a:spAutoFit/>
+          </a:bodyPr>
+          <a:lstStyle/>
+          <a:p>
+            <a:pPr algn="ctr"/>
+            <a:r>
+              <a:rPr sz="2400" b="1">
+                <a:solidFill>
+                  <a:srgbClr val="1F497D"/>
+                </a:solidFill>
+              </a:rPr>
+              <a:t>Глоссарий</a:t>
+            </a:r>
+          </a:p>
+        </p:txBody>
+      </p:sp>
+      <p:graphicFrame>
+        <p:nvGraphicFramePr>
+          <p:cNvPr id="3" name="Table 2"/>
+          <p:cNvGraphicFramePr>
+            <a:graphicFrameLocks noGrp="1"/>
+          </p:cNvGraphicFramePr>
+          <p:nvPr/>
+        </p:nvGraphicFramePr>
+        <p:xfrm>
+          <a:off x="360000" y="750000"/>
+          <a:ext cx="5634476" cy="5958000"/>
+        </p:xfrm>
+        <a:graphic>
+          <a:graphicData uri="http://schemas.openxmlformats.org/drawingml/2006/table">
+            <a:tbl>
+              <a:tblPr firstRow="1" bandRow="1">
+                <a:tableStyleId>{5C22544A-7EE6-4342-B048-85BDC9FD1C3A}</a:tableStyleId>
+              </a:tblPr>
+              <a:tblGrid>
+                <a:gridCol w="2817238"/>
+                <a:gridCol w="2817238"/>
+              </a:tblGrid>
+              <a:tr h="541636">
+                <a:tc>
+                  <a:txBody>
+                    <a:bodyPr/>
+                    <a:lstStyle/>
+                    <a:p>
+                      <a:r>
+                        <a:t>Термин</a:t>
+                      </a:r>
+                    </a:p>
+                  </a:txBody>
+                  <a:tcPr/>
+                </a:tc>
+                <a:tc>
+                  <a:txBody>
+                    <a:bodyPr/>
+                    <a:lstStyle/>
+                    <a:p>
+                      <a:r>
+                        <a:t>Определение</a:t>
+                      </a:r>
+                    </a:p>
+                  </a:txBody>
+                  <a:tcPr/>
+                </a:tc>
+              </a:tr>
+              <a:tr h="541636">
+                <a:tc>
+                  <a:txBody>
+                    <a:bodyPr wrap="square"/>
+                    <a:lstStyle/>
+                    <a:p>
+                      <a:r>
+                        <a:rPr sz="800" b="1"/>
+                        <a:t>Метаданные публикации</a:t>
+                      </a:r>
+                    </a:p>
+                  </a:txBody>
+                  <a:tcPr/>
+                </a:tc>
+                <a:tc>
+                  <a:txBody>
+                    <a:bodyPr wrap="square"/>
+                    <a:lstStyle/>
+                    <a:p>
+                      <a:r>
+                        <a:rPr sz="800" b="0"/>
+                        <a:t>Название, авторы, год, журнал, DOI, темы — без полного текста</a:t>
+                      </a:r>
+                    </a:p>
+                  </a:txBody>
+                  <a:tcPr/>
+                </a:tc>
+              </a:tr>
+              <a:tr h="541636">
+                <a:tc>
+                  <a:txBody>
+                    <a:bodyPr wrap="square"/>
+                    <a:lstStyle/>
+                    <a:p>
+                      <a:r>
+                        <a:rPr sz="800" b="1"/>
+                        <a:t>OpenAlex</a:t>
+                      </a:r>
+                    </a:p>
+                  </a:txBody>
+                  <a:tcPr/>
+                </a:tc>
+                <a:tc>
+                  <a:txBody>
+                    <a:bodyPr wrap="square"/>
+                    <a:lstStyle/>
+                    <a:p>
+                      <a:r>
+                        <a:rPr sz="800" b="0"/>
+                        <a:t>Открытый бесплатный каталог научных публикаций; более 250 млн работ</a:t>
+                      </a:r>
+                    </a:p>
+                  </a:txBody>
+                  <a:tcPr/>
+                </a:tc>
+              </a:tr>
+              <a:tr h="541636">
+                <a:tc>
+                  <a:txBody>
+                    <a:bodyPr wrap="square"/>
+                    <a:lstStyle/>
+                    <a:p>
+                      <a:r>
+                        <a:rPr sz="800" b="1"/>
+                        <a:t>API</a:t>
+                      </a:r>
+                    </a:p>
+                  </a:txBody>
+                  <a:tcPr/>
+                </a:tc>
+                <a:tc>
+                  <a:txBody>
+                    <a:bodyPr wrap="square"/>
+                    <a:lstStyle/>
+                    <a:p>
+                      <a:r>
+                        <a:rPr sz="800" b="0"/>
+                        <a:t>Набор HTTP-запросов для получения данных из внешнего сервиса</a:t>
+                      </a:r>
+                    </a:p>
+                  </a:txBody>
+                  <a:tcPr/>
+                </a:tc>
+              </a:tr>
+              <a:tr h="541636">
+                <a:tc>
+                  <a:txBody>
+                    <a:bodyPr wrap="square"/>
+                    <a:lstStyle/>
+                    <a:p>
+                      <a:r>
+                        <a:rPr sz="800" b="1"/>
+                        <a:t>DOI</a:t>
+                      </a:r>
+                    </a:p>
+                  </a:txBody>
+                  <a:tcPr/>
+                </a:tc>
+                <a:tc>
+                  <a:txBody>
+                    <a:bodyPr wrap="square"/>
+                    <a:lstStyle/>
+                    <a:p>
+                      <a:r>
+                        <a:rPr sz="800" b="0"/>
+                        <a:t>Уникальный цифровой идентификатор научной публикации (10.XXXX/...)</a:t>
+                      </a:r>
+                    </a:p>
+                  </a:txBody>
+                  <a:tcPr/>
+                </a:tc>
+              </a:tr>
+              <a:tr h="541636">
+                <a:tc>
+                  <a:txBody>
+                    <a:bodyPr wrap="square"/>
+                    <a:lstStyle/>
+                    <a:p>
+                      <a:r>
+                        <a:rPr sz="800" b="1"/>
+                        <a:t>Аффилиация</a:t>
+                      </a:r>
+                    </a:p>
+                  </a:txBody>
+                  <a:tcPr/>
+                </a:tc>
+                <a:tc>
+                  <a:txBody>
+                    <a:bodyPr wrap="square"/>
+                    <a:lstStyle/>
+                    <a:p>
+                      <a:r>
+                        <a:rPr sz="800" b="0"/>
+                        <a:t>Организация, с которой связан автор на момент публикации</a:t>
+                      </a:r>
+                    </a:p>
+                  </a:txBody>
+                  <a:tcPr/>
+                </a:tc>
+              </a:tr>
+              <a:tr h="541636">
+                <a:tc>
+                  <a:txBody>
+                    <a:bodyPr wrap="square"/>
+                    <a:lstStyle/>
+                    <a:p>
+                      <a:r>
+                        <a:rPr sz="800" b="1"/>
+                        <a:t>Геокодирование</a:t>
+                      </a:r>
+                    </a:p>
+                  </a:txBody>
+                  <a:tcPr/>
+                </a:tc>
+                <a:tc>
+                  <a:txBody>
+                    <a:bodyPr wrap="square"/>
+                    <a:lstStyle/>
+                    <a:p>
+                      <a:r>
+                        <a:rPr sz="800" b="0"/>
+                        <a:t>Определение географических координат по названию места</a:t>
+                      </a:r>
+                    </a:p>
+                  </a:txBody>
+                  <a:tcPr/>
+                </a:tc>
+              </a:tr>
+              <a:tr h="541636">
+                <a:tc>
+                  <a:txBody>
+                    <a:bodyPr wrap="square"/>
+                    <a:lstStyle/>
+                    <a:p>
+                      <a:r>
+                        <a:rPr sz="800" b="1"/>
+                        <a:t>Граф</a:t>
+                      </a:r>
+                    </a:p>
+                  </a:txBody>
+                  <a:tcPr/>
+                </a:tc>
+                <a:tc>
+                  <a:txBody>
+                    <a:bodyPr wrap="square"/>
+                    <a:lstStyle/>
+                    <a:p>
+                      <a:r>
+                        <a:rPr sz="800" b="0"/>
+                        <a:t>Структура из узлов и рёбер; для визуализации отношений между объектами</a:t>
+                      </a:r>
+                    </a:p>
+                  </a:txBody>
+                  <a:tcPr/>
+                </a:tc>
+              </a:tr>
+              <a:tr h="541636">
+                <a:tc>
+                  <a:txBody>
+                    <a:bodyPr wrap="square"/>
+                    <a:lstStyle/>
+                    <a:p>
+                      <a:r>
+                        <a:rPr sz="800" b="1"/>
+                        <a:t>REST API</a:t>
+                      </a:r>
+                    </a:p>
+                  </a:txBody>
+                  <a:tcPr/>
+                </a:tc>
+                <a:tc>
+                  <a:txBody>
+                    <a:bodyPr wrap="square"/>
+                    <a:lstStyle/>
+                    <a:p>
+                      <a:r>
+                        <a:rPr sz="800" b="0"/>
+                        <a:t>Веб-сервис, где каждый ресурс доступен по URL через GET/POST</a:t>
+                      </a:r>
+                    </a:p>
+                  </a:txBody>
+                  <a:tcPr/>
+                </a:tc>
+              </a:tr>
+              <a:tr h="541636">
+                <a:tc>
+                  <a:txBody>
+                    <a:bodyPr wrap="square"/>
+                    <a:lstStyle/>
+                    <a:p>
+                      <a:r>
+                        <a:rPr sz="800" b="1"/>
+                        <a:t>PostgreSQL</a:t>
+                      </a:r>
+                    </a:p>
+                  </a:txBody>
+                  <a:tcPr/>
+                </a:tc>
+                <a:tc>
+                  <a:txBody>
+                    <a:bodyPr wrap="square"/>
+                    <a:lstStyle/>
+                    <a:p>
+                      <a:r>
+                        <a:rPr sz="800" b="0"/>
+                        <a:t>Реляционная СУБД с открытым исходным кодом</a:t>
+                      </a:r>
+                    </a:p>
+                  </a:txBody>
+                  <a:tcPr/>
+                </a:tc>
+              </a:tr>
+              <a:tr h="541640">
+                <a:tc>
+                  <a:txBody>
+                    <a:bodyPr wrap="square"/>
+                    <a:lstStyle/>
+                    <a:p>
+                      <a:r>
+                        <a:rPr sz="800" b="1"/>
+                        <a:t>gzip</a:t>
+                      </a:r>
+                    </a:p>
+                  </a:txBody>
+                  <a:tcPr/>
+                </a:tc>
+                <a:tc>
+                  <a:txBody>
+                    <a:bodyPr wrap="square"/>
+                    <a:lstStyle/>
+                    <a:p>
+                      <a:r>
+                        <a:rPr sz="800" b="0"/>
+                        <a:t>Алгоритм сжатия данных; уменьшает объём HTTP-ответов в 5–10 раз</a:t>
+                      </a:r>
+                    </a:p>
+                  </a:txBody>
+                  <a:tcPr/>
+                </a:tc>
+              </a:tr>
+            </a:tbl>
+          </a:graphicData>
+        </a:graphic>
+      </p:graphicFrame>
+      <p:graphicFrame>
+        <p:nvGraphicFramePr>
+          <p:cNvPr id="4" name="Table 3"/>
+          <p:cNvGraphicFramePr>
+            <a:graphicFrameLocks noGrp="1"/>
+          </p:cNvGraphicFramePr>
+          <p:nvPr/>
+        </p:nvGraphicFramePr>
+        <p:xfrm>
+          <a:off x="6194476" y="750000"/>
+          <a:ext cx="5634476" cy="5958000"/>
+        </p:xfrm>
+        <a:graphic>
+          <a:graphicData uri="http://schemas.openxmlformats.org/drawingml/2006/table">
+            <a:tbl>
+              <a:tblPr firstRow="1" bandRow="1">
+                <a:tableStyleId>{5C22544A-7EE6-4342-B048-85BDC9FD1C3A}</a:tableStyleId>
+              </a:tblPr>
+              <a:tblGrid>
+                <a:gridCol w="2817238"/>
+                <a:gridCol w="2817238"/>
+              </a:tblGrid>
+              <a:tr h="595800">
+                <a:tc>
+                  <a:txBody>
+                    <a:bodyPr wrap="square"/>
+                    <a:lstStyle/>
+                    <a:p>
+                      <a:r>
+                        <a:rPr sz="800" b="1"/>
+                        <a:t>Фасетная фильтрация</a:t>
+                      </a:r>
+                    </a:p>
+                  </a:txBody>
+                  <a:tcPr/>
+                </a:tc>
+                <a:tc>
+                  <a:txBody>
+                    <a:bodyPr wrap="square"/>
+                    <a:lstStyle/>
+                    <a:p>
+                      <a:r>
+                        <a:rPr sz="800"/>
+                        <a:t>Выбор в одном фильтре ограничивает варианты в других</a:t>
+                      </a:r>
+                    </a:p>
+                  </a:txBody>
+                  <a:tcPr/>
+                </a:tc>
+              </a:tr>
+              <a:tr h="595800">
+                <a:tc>
+                  <a:txBody>
+                    <a:bodyPr wrap="square"/>
+                    <a:lstStyle/>
+                    <a:p>
+                      <a:r>
+                        <a:rPr sz="800" b="1"/>
+                        <a:t>SVG</a:t>
+                      </a:r>
+                    </a:p>
+                  </a:txBody>
+                  <a:tcPr/>
+                </a:tc>
+                <a:tc>
+                  <a:txBody>
+                    <a:bodyPr wrap="square"/>
+                    <a:lstStyle/>
+                    <a:p>
+                      <a:r>
+                        <a:rPr sz="800"/>
+                        <a:t>XML-формат векторной графики в браузере; используется для графа</a:t>
+                      </a:r>
+                    </a:p>
+                  </a:txBody>
+                  <a:tcPr/>
+                </a:tc>
+              </a:tr>
+              <a:tr h="595800">
+                <a:tc>
+                  <a:txBody>
+                    <a:bodyPr wrap="square"/>
+                    <a:lstStyle/>
+                    <a:p>
+                      <a:r>
+                        <a:rPr sz="800" b="1"/>
+                        <a:t>Cursor pagination</a:t>
+                      </a:r>
+                    </a:p>
+                  </a:txBody>
+                  <a:tcPr/>
+                </a:tc>
+                <a:tc>
+                  <a:txBody>
+                    <a:bodyPr wrap="square"/>
+                    <a:lstStyle/>
+                    <a:p>
+                      <a:r>
+                        <a:rPr sz="800"/>
+                        <a:t>Постраничный обход через токены-курсоры без пропусков</a:t>
+                      </a:r>
+                    </a:p>
+                  </a:txBody>
+                  <a:tcPr/>
+                </a:tc>
+              </a:tr>
+              <a:tr h="595800">
+                <a:tc>
+                  <a:txBody>
+                    <a:bodyPr wrap="square"/>
+                    <a:lstStyle/>
+                    <a:p>
+                      <a:r>
+                        <a:rPr sz="800" b="1"/>
+                        <a:t>Библиометрия</a:t>
+                      </a:r>
+                    </a:p>
+                  </a:txBody>
+                  <a:tcPr/>
+                </a:tc>
+                <a:tc>
+                  <a:txBody>
+                    <a:bodyPr wrap="square"/>
+                    <a:lstStyle/>
+                    <a:p>
+                      <a:r>
+                        <a:rPr sz="800"/>
+                        <a:t>Количественный анализ публикаций: цитирования, коавторства</a:t>
+                      </a:r>
+                    </a:p>
+                  </a:txBody>
+                  <a:tcPr/>
+                </a:tc>
+              </a:tr>
+              <a:tr h="595800">
+                <a:tc>
+                  <a:txBody>
+                    <a:bodyPr wrap="square"/>
+                    <a:lstStyle/>
+                    <a:p>
+                      <a:r>
+                        <a:rPr sz="800" b="1"/>
+                        <a:t>Балл сходства</a:t>
+                      </a:r>
+                    </a:p>
+                  </a:txBody>
+                  <a:tcPr/>
+                </a:tc>
+                <a:tc>
+                  <a:txBody>
+                    <a:bodyPr wrap="square"/>
+                    <a:lstStyle/>
+                    <a:p>
+                      <a:r>
+                        <a:rPr sz="800"/>
+                        <a:t>Числовая мера близости двух публикаций по взвешенным признакам</a:t>
+                      </a:r>
+                    </a:p>
+                  </a:txBody>
+                  <a:tcPr/>
+                </a:tc>
+              </a:tr>
+              <a:tr h="595800">
+                <a:tc>
+                  <a:txBody>
+                    <a:bodyPr wrap="square"/>
+                    <a:lstStyle/>
+                    <a:p>
+                      <a:r>
+                        <a:rPr sz="800" b="1"/>
+                        <a:t>requestAnimationFrame</a:t>
+                      </a:r>
+                    </a:p>
+                  </a:txBody>
+                  <a:tcPr/>
+                </a:tc>
+                <a:tc>
+                  <a:txBody>
+                    <a:bodyPr wrap="square"/>
+                    <a:lstStyle/>
+                    <a:p>
+                      <a:r>
+                        <a:rPr sz="800"/>
+                        <a:t>Браузерный API для тяжёлых операций между кадрами</a:t>
+                      </a:r>
+                    </a:p>
+                  </a:txBody>
+                  <a:tcPr/>
+                </a:tc>
+              </a:tr>
+              <a:tr h="595800">
+                <a:tc>
+                  <a:txBody>
+                    <a:bodyPr wrap="square"/>
+                    <a:lstStyle/>
+                    <a:p>
+                      <a:r>
+                        <a:rPr sz="800" b="1"/>
+                        <a:t>ijson</a:t>
+                      </a:r>
+                    </a:p>
+                  </a:txBody>
+                  <a:tcPr/>
+                </a:tc>
+                <a:tc>
+                  <a:txBody>
+                    <a:bodyPr wrap="square"/>
+                    <a:lstStyle/>
+                    <a:p>
+                      <a:r>
+                        <a:rPr sz="800"/>
+                        <a:t>Python-библиотека для потокового чтения JSON без загрузки в память</a:t>
+                      </a:r>
+                    </a:p>
+                  </a:txBody>
+                  <a:tcPr/>
+                </a:tc>
+              </a:tr>
+              <a:tr h="595800">
+                <a:tc>
+                  <a:txBody>
+                    <a:bodyPr wrap="square"/>
+                    <a:lstStyle/>
+                    <a:p>
+                      <a:r>
+                        <a:rPr sz="800" b="1"/>
+                        <a:t>Savepoint</a:t>
+                      </a:r>
+                    </a:p>
+                  </a:txBody>
+                  <a:tcPr/>
+                </a:tc>
+                <a:tc>
+                  <a:txBody>
+                    <a:bodyPr wrap="square"/>
+                    <a:lstStyle/>
+                    <a:p>
+                      <a:r>
+                        <a:rPr sz="800"/>
+                        <a:t>Частичный откат транзакции PostgreSQL без потери остальных данных</a:t>
+                      </a:r>
+                    </a:p>
+                  </a:txBody>
+                  <a:tcPr/>
+                </a:tc>
+              </a:tr>
+              <a:tr h="595800">
+                <a:tc>
+                  <a:txBody>
+                    <a:bodyPr wrap="square"/>
+                    <a:lstStyle/>
+                    <a:p>
+                      <a:r>
+                        <a:rPr sz="800" b="1"/>
+                        <a:t>Force-directed layout</a:t>
+                      </a:r>
+                    </a:p>
+                  </a:txBody>
+                  <a:tcPr/>
+                </a:tc>
+                <a:tc>
+                  <a:txBody>
+                    <a:bodyPr wrap="square"/>
+                    <a:lstStyle/>
+                    <a:p>
+                      <a:r>
+                        <a:rPr sz="800"/>
+                        <a:t>Физическая симуляция размещения узлов графа</a:t>
+                      </a:r>
+                    </a:p>
+                  </a:txBody>
+                  <a:tcPr/>
+                </a:tc>
+              </a:tr>
+              <a:tr h="595800">
+                <a:tc>
+                  <a:txBody>
+                    <a:bodyPr wrap="square"/>
+                    <a:lstStyle/>
+                    <a:p>
+                      <a:r>
+                        <a:rPr sz="800" b="1"/>
+                        <a:t>Колоночная раскладка</a:t>
+                      </a:r>
+                    </a:p>
+                  </a:txBody>
+                  <a:tcPr/>
+                </a:tc>
+                <a:tc>
+                  <a:txBody>
+                    <a:bodyPr wrap="square"/>
+                    <a:lstStyle/>
+                    <a:p>
+                      <a:r>
+                        <a:rPr sz="800"/>
+                        <a:t>Каждый тип узла занимает фиксированную вертикальную колонку</a:t>
+                      </a:r>
+                    </a:p>
+                  </a:txBody>
+                  <a:tcPr/>
+                </a:tc>
+              </a:tr>
+            </a:tbl>
+          </a:graphicData>
+        </a:graphic>
+      </p:graphicFrame>
     </p:spTree>
   </p:cSld>
   <p:clrMapOvr>

</xml_diff>

<commit_message>
Generalize tasks on slide 4, add task completion note to results slide
https://claude.ai/code/session_01JXZNXE9oVEv7rsUiTvXR5D
</commit_message>
<xml_diff>
--- a/docs/Визуализация науки на основе метаданных публикаций и журналов.pptx
+++ b/docs/Визуализация науки на основе метаданных публикаций и журналов.pptx
@@ -6478,13 +6478,9 @@
           <a:p>
             <a:pPr algn="ctr"/>
             <a:r>
-              <a:rPr sz="1800" b="0" i="0">
-                <a:solidFill>
-                  <a:srgbClr val="FFFFFF"/>
-                </a:solidFill>
-                <a:latin typeface="Calibri"/>
-              </a:rPr>
-              <a:t>Разработанная система позволяет перейти от плоского списка статей
+              <a:rPr sz="1300"/>
+              <a:t>Все 6 задач решены в полном объёме.
+Разработанная система позволяет перейти от плоского списка статей
 к структурированному представлению научного ландшафта:
 карте с географией исследований и графу авторских и тематических связей.</a:t>
             </a:r>
@@ -6624,100 +6620,14 @@
       <p:grpSpPr/>
       <p:sp>
         <p:nvSpPr>
-          <p:cNvPr id="2" name="Rectangle 1"/>
-          <p:cNvSpPr/>
-          <p:nvPr/>
-        </p:nvSpPr>
-        <p:spPr>
-          <a:xfrm>
-            <a:off x="0" y="0"/>
-            <a:ext cx="12188952" cy="6858000"/>
-          </a:xfrm>
-          <a:prstGeom prst="rect">
-            <a:avLst/>
-          </a:prstGeom>
-          <a:solidFill>
-            <a:srgbClr val="F7FBF8"/>
-          </a:solidFill>
-          <a:ln>
-            <a:noFill/>
-          </a:ln>
-        </p:spPr>
-        <p:style>
-          <a:lnRef idx="1">
-            <a:schemeClr val="accent1"/>
-          </a:lnRef>
-          <a:fillRef idx="3">
-            <a:schemeClr val="accent1"/>
-          </a:fillRef>
-          <a:effectRef idx="2">
-            <a:schemeClr val="accent1"/>
-          </a:effectRef>
-          <a:fontRef idx="minor">
-            <a:schemeClr val="lt1"/>
-          </a:fontRef>
-        </p:style>
-        <p:txBody>
-          <a:bodyPr rtlCol="0" anchor="ctr"/>
-          <a:lstStyle/>
-          <a:p>
-            <a:pPr algn="ctr"/>
-          </a:p>
-        </p:txBody>
-      </p:sp>
-      <p:sp>
-        <p:nvSpPr>
-          <p:cNvPr id="3" name="Rectangle 2"/>
-          <p:cNvSpPr/>
-          <p:nvPr/>
-        </p:nvSpPr>
-        <p:spPr>
-          <a:xfrm>
-            <a:off x="0" y="0"/>
-            <a:ext cx="12188952" cy="1005840"/>
-          </a:xfrm>
-          <a:prstGeom prst="rect">
-            <a:avLst/>
-          </a:prstGeom>
-          <a:solidFill>
-            <a:srgbClr val="163126"/>
-          </a:solidFill>
-          <a:ln>
-            <a:noFill/>
-          </a:ln>
-        </p:spPr>
-        <p:style>
-          <a:lnRef idx="1">
-            <a:schemeClr val="accent1"/>
-          </a:lnRef>
-          <a:fillRef idx="3">
-            <a:schemeClr val="accent1"/>
-          </a:fillRef>
-          <a:effectRef idx="2">
-            <a:schemeClr val="accent1"/>
-          </a:effectRef>
-          <a:fontRef idx="minor">
-            <a:schemeClr val="lt1"/>
-          </a:fontRef>
-        </p:style>
-        <p:txBody>
-          <a:bodyPr rtlCol="0" anchor="ctr"/>
-          <a:lstStyle/>
-          <a:p>
-            <a:pPr algn="ctr"/>
-          </a:p>
-        </p:txBody>
-      </p:sp>
-      <p:sp>
-        <p:nvSpPr>
-          <p:cNvPr id="4" name="TextBox 3"/>
+          <p:cNvPr id="2" name="TextBox 1"/>
           <p:cNvSpPr txBox="1"/>
           <p:nvPr/>
         </p:nvSpPr>
         <p:spPr>
           <a:xfrm>
-            <a:off x="365760" y="164592"/>
-            <a:ext cx="11430000" cy="685800"/>
+            <a:off x="360000" y="200000"/>
+            <a:ext cx="11468952" cy="500000"/>
           </a:xfrm>
           <a:prstGeom prst="rect">
             <a:avLst/>
@@ -6725,560 +6635,661 @@
           <a:noFill/>
         </p:spPr>
         <p:txBody>
-          <a:bodyPr wrap="square">
+          <a:bodyPr wrap="none">
             <a:spAutoFit/>
           </a:bodyPr>
           <a:lstStyle/>
           <a:p>
-            <a:pPr algn="l"/>
-            <a:r>
-              <a:rPr sz="2600" b="1" i="0">
-                <a:solidFill>
-                  <a:srgbClr val="FFFFFF"/>
-                </a:solidFill>
-                <a:latin typeface="Calibri"/>
-              </a:rPr>
-              <a:t>Актуальность</a:t>
-            </a:r>
-          </a:p>
-        </p:txBody>
-      </p:sp>
-      <p:sp>
-        <p:nvSpPr>
-          <p:cNvPr id="5" name="Rectangle 4"/>
-          <p:cNvSpPr/>
-          <p:nvPr/>
-        </p:nvSpPr>
-        <p:spPr>
-          <a:xfrm>
-            <a:off x="365760" y="1188720"/>
-            <a:ext cx="2743200" cy="2286000"/>
-          </a:xfrm>
-          <a:prstGeom prst="rect">
-            <a:avLst/>
-          </a:prstGeom>
-          <a:solidFill>
-            <a:srgbClr val="FFFFFF"/>
-          </a:solidFill>
-          <a:ln w="9525">
-            <a:solidFill>
-              <a:srgbClr val="CFE0D6"/>
-            </a:solidFill>
-          </a:ln>
-        </p:spPr>
-        <p:style>
-          <a:lnRef idx="1">
-            <a:schemeClr val="accent1"/>
-          </a:lnRef>
-          <a:fillRef idx="3">
-            <a:schemeClr val="accent1"/>
-          </a:fillRef>
-          <a:effectRef idx="2">
-            <a:schemeClr val="accent1"/>
-          </a:effectRef>
-          <a:fontRef idx="minor">
-            <a:schemeClr val="lt1"/>
-          </a:fontRef>
-        </p:style>
-        <p:txBody>
-          <a:bodyPr rtlCol="0" anchor="ctr"/>
-          <a:lstStyle/>
-          <a:p>
             <a:pPr algn="ctr"/>
-          </a:p>
-        </p:txBody>
-      </p:sp>
-      <p:sp>
-        <p:nvSpPr>
-          <p:cNvPr id="6" name="TextBox 5"/>
-          <p:cNvSpPr txBox="1"/>
-          <p:nvPr/>
-        </p:nvSpPr>
-        <p:spPr>
-          <a:xfrm>
-            <a:off x="365760" y="1371600"/>
-            <a:ext cx="2743200" cy="1005840"/>
-          </a:xfrm>
-          <a:prstGeom prst="rect">
-            <a:avLst/>
-          </a:prstGeom>
-          <a:noFill/>
-        </p:spPr>
-        <p:txBody>
-          <a:bodyPr wrap="square">
-            <a:spAutoFit/>
-          </a:bodyPr>
-          <a:lstStyle/>
-          <a:p>
-            <a:pPr algn="ctr"/>
-            <a:r>
-              <a:rPr sz="3400" b="1" i="0">
-                <a:solidFill>
-                  <a:srgbClr val="23613F"/>
-                </a:solidFill>
-                <a:latin typeface="Calibri"/>
-              </a:rPr>
-              <a:t>250 млн+</a:t>
-            </a:r>
-          </a:p>
-        </p:txBody>
-      </p:sp>
-      <p:sp>
-        <p:nvSpPr>
-          <p:cNvPr id="7" name="TextBox 6"/>
-          <p:cNvSpPr txBox="1"/>
-          <p:nvPr/>
-        </p:nvSpPr>
-        <p:spPr>
-          <a:xfrm>
-            <a:off x="365760" y="2423160"/>
-            <a:ext cx="2743200" cy="914400"/>
-          </a:xfrm>
-          <a:prstGeom prst="rect">
-            <a:avLst/>
-          </a:prstGeom>
-          <a:noFill/>
-        </p:spPr>
-        <p:txBody>
-          <a:bodyPr wrap="square">
-            <a:spAutoFit/>
-          </a:bodyPr>
-          <a:lstStyle/>
-          <a:p>
-            <a:pPr algn="ctr"/>
-            <a:r>
-              <a:rPr sz="1400" b="0" i="0">
-                <a:solidFill>
-                  <a:srgbClr val="577166"/>
-                </a:solidFill>
-                <a:latin typeface="Calibri"/>
-              </a:rPr>
-              <a:t>научных работ
-в открытом доступе</a:t>
-            </a:r>
-          </a:p>
-        </p:txBody>
-      </p:sp>
-      <p:sp>
-        <p:nvSpPr>
-          <p:cNvPr id="8" name="Rectangle 7"/>
-          <p:cNvSpPr/>
-          <p:nvPr/>
-        </p:nvSpPr>
-        <p:spPr>
-          <a:xfrm>
-            <a:off x="3291840" y="1188720"/>
-            <a:ext cx="2743200" cy="2286000"/>
-          </a:xfrm>
-          <a:prstGeom prst="rect">
-            <a:avLst/>
-          </a:prstGeom>
-          <a:solidFill>
-            <a:srgbClr val="FFFFFF"/>
-          </a:solidFill>
-          <a:ln w="9525">
-            <a:solidFill>
-              <a:srgbClr val="CFE0D6"/>
-            </a:solidFill>
-          </a:ln>
-        </p:spPr>
-        <p:style>
-          <a:lnRef idx="1">
-            <a:schemeClr val="accent1"/>
-          </a:lnRef>
-          <a:fillRef idx="3">
-            <a:schemeClr val="accent1"/>
-          </a:fillRef>
-          <a:effectRef idx="2">
-            <a:schemeClr val="accent1"/>
-          </a:effectRef>
-          <a:fontRef idx="minor">
-            <a:schemeClr val="lt1"/>
-          </a:fontRef>
-        </p:style>
-        <p:txBody>
-          <a:bodyPr rtlCol="0" anchor="ctr"/>
-          <a:lstStyle/>
-          <a:p>
-            <a:pPr algn="ctr"/>
-          </a:p>
-        </p:txBody>
-      </p:sp>
-      <p:sp>
-        <p:nvSpPr>
-          <p:cNvPr id="9" name="TextBox 8"/>
-          <p:cNvSpPr txBox="1"/>
-          <p:nvPr/>
-        </p:nvSpPr>
-        <p:spPr>
-          <a:xfrm>
-            <a:off x="3291840" y="1371600"/>
-            <a:ext cx="2743200" cy="1005840"/>
-          </a:xfrm>
-          <a:prstGeom prst="rect">
-            <a:avLst/>
-          </a:prstGeom>
-          <a:noFill/>
-        </p:spPr>
-        <p:txBody>
-          <a:bodyPr wrap="square">
-            <a:spAutoFit/>
-          </a:bodyPr>
-          <a:lstStyle/>
-          <a:p>
-            <a:pPr algn="ctr"/>
-            <a:r>
-              <a:rPr sz="3400" b="1" i="0">
-                <a:solidFill>
-                  <a:srgbClr val="23613F"/>
-                </a:solidFill>
-                <a:latin typeface="Calibri"/>
-              </a:rPr>
-              <a:t>×2</a:t>
-            </a:r>
-          </a:p>
-        </p:txBody>
-      </p:sp>
-      <p:sp>
-        <p:nvSpPr>
-          <p:cNvPr id="10" name="TextBox 9"/>
-          <p:cNvSpPr txBox="1"/>
-          <p:nvPr/>
-        </p:nvSpPr>
-        <p:spPr>
-          <a:xfrm>
-            <a:off x="3291840" y="2423160"/>
-            <a:ext cx="2743200" cy="914400"/>
-          </a:xfrm>
-          <a:prstGeom prst="rect">
-            <a:avLst/>
-          </a:prstGeom>
-          <a:noFill/>
-        </p:spPr>
-        <p:txBody>
-          <a:bodyPr wrap="square">
-            <a:spAutoFit/>
-          </a:bodyPr>
-          <a:lstStyle/>
-          <a:p>
-            <a:pPr algn="ctr"/>
-            <a:r>
-              <a:rPr sz="1400" b="0" i="0">
-                <a:solidFill>
-                  <a:srgbClr val="577166"/>
-                </a:solidFill>
-                <a:latin typeface="Calibri"/>
-              </a:rPr>
-              <a:t>каждые 9 лет
-удваивается объём</a:t>
-            </a:r>
-          </a:p>
-        </p:txBody>
-      </p:sp>
-      <p:sp>
-        <p:nvSpPr>
-          <p:cNvPr id="11" name="Rectangle 10"/>
-          <p:cNvSpPr/>
-          <p:nvPr/>
-        </p:nvSpPr>
-        <p:spPr>
-          <a:xfrm>
-            <a:off x="6217920" y="1188720"/>
-            <a:ext cx="2743200" cy="2286000"/>
-          </a:xfrm>
-          <a:prstGeom prst="rect">
-            <a:avLst/>
-          </a:prstGeom>
-          <a:solidFill>
-            <a:srgbClr val="FFFFFF"/>
-          </a:solidFill>
-          <a:ln w="9525">
-            <a:solidFill>
-              <a:srgbClr val="CFE0D6"/>
-            </a:solidFill>
-          </a:ln>
-        </p:spPr>
-        <p:style>
-          <a:lnRef idx="1">
-            <a:schemeClr val="accent1"/>
-          </a:lnRef>
-          <a:fillRef idx="3">
-            <a:schemeClr val="accent1"/>
-          </a:fillRef>
-          <a:effectRef idx="2">
-            <a:schemeClr val="accent1"/>
-          </a:effectRef>
-          <a:fontRef idx="minor">
-            <a:schemeClr val="lt1"/>
-          </a:fontRef>
-        </p:style>
-        <p:txBody>
-          <a:bodyPr rtlCol="0" anchor="ctr"/>
-          <a:lstStyle/>
-          <a:p>
-            <a:pPr algn="ctr"/>
-          </a:p>
-        </p:txBody>
-      </p:sp>
-      <p:sp>
-        <p:nvSpPr>
-          <p:cNvPr id="12" name="TextBox 11"/>
-          <p:cNvSpPr txBox="1"/>
-          <p:nvPr/>
-        </p:nvSpPr>
-        <p:spPr>
-          <a:xfrm>
-            <a:off x="6217920" y="1371600"/>
-            <a:ext cx="2743200" cy="1005840"/>
-          </a:xfrm>
-          <a:prstGeom prst="rect">
-            <a:avLst/>
-          </a:prstGeom>
-          <a:noFill/>
-        </p:spPr>
-        <p:txBody>
-          <a:bodyPr wrap="square">
-            <a:spAutoFit/>
-          </a:bodyPr>
-          <a:lstStyle/>
-          <a:p>
-            <a:pPr algn="ctr"/>
-            <a:r>
-              <a:rPr sz="3400" b="1" i="0">
-                <a:solidFill>
-                  <a:srgbClr val="23613F"/>
-                </a:solidFill>
-                <a:latin typeface="Calibri"/>
-              </a:rPr>
-              <a:t>80,8%</a:t>
-            </a:r>
-          </a:p>
-        </p:txBody>
-      </p:sp>
-      <p:sp>
-        <p:nvSpPr>
-          <p:cNvPr id="13" name="TextBox 12"/>
-          <p:cNvSpPr txBox="1"/>
-          <p:nvPr/>
-        </p:nvSpPr>
-        <p:spPr>
-          <a:xfrm>
-            <a:off x="6217920" y="2423160"/>
-            <a:ext cx="2743200" cy="914400"/>
-          </a:xfrm>
-          <a:prstGeom prst="rect">
-            <a:avLst/>
-          </a:prstGeom>
-          <a:noFill/>
-        </p:spPr>
-        <p:txBody>
-          <a:bodyPr wrap="square">
-            <a:spAutoFit/>
-          </a:bodyPr>
-          <a:lstStyle/>
-          <a:p>
-            <a:pPr algn="ctr"/>
-            <a:r>
-              <a:rPr sz="1400" b="0" i="0">
-                <a:solidFill>
-                  <a:srgbClr val="577166"/>
-                </a:solidFill>
-                <a:latin typeface="Calibri"/>
-              </a:rPr>
-              <a:t>публикаций
-с геокоординатами</a:t>
-            </a:r>
-          </a:p>
-        </p:txBody>
-      </p:sp>
-      <p:sp>
-        <p:nvSpPr>
-          <p:cNvPr id="14" name="Rectangle 13"/>
-          <p:cNvSpPr/>
-          <p:nvPr/>
-        </p:nvSpPr>
-        <p:spPr>
-          <a:xfrm>
-            <a:off x="9144000" y="1188720"/>
-            <a:ext cx="2743200" cy="2286000"/>
-          </a:xfrm>
-          <a:prstGeom prst="rect">
-            <a:avLst/>
-          </a:prstGeom>
-          <a:solidFill>
-            <a:srgbClr val="FFFFFF"/>
-          </a:solidFill>
-          <a:ln w="9525">
-            <a:solidFill>
-              <a:srgbClr val="CFE0D6"/>
-            </a:solidFill>
-          </a:ln>
-        </p:spPr>
-        <p:style>
-          <a:lnRef idx="1">
-            <a:schemeClr val="accent1"/>
-          </a:lnRef>
-          <a:fillRef idx="3">
-            <a:schemeClr val="accent1"/>
-          </a:fillRef>
-          <a:effectRef idx="2">
-            <a:schemeClr val="accent1"/>
-          </a:effectRef>
-          <a:fontRef idx="minor">
-            <a:schemeClr val="lt1"/>
-          </a:fontRef>
-        </p:style>
-        <p:txBody>
-          <a:bodyPr rtlCol="0" anchor="ctr"/>
-          <a:lstStyle/>
-          <a:p>
-            <a:pPr algn="ctr"/>
-          </a:p>
-        </p:txBody>
-      </p:sp>
-      <p:sp>
-        <p:nvSpPr>
-          <p:cNvPr id="15" name="TextBox 14"/>
-          <p:cNvSpPr txBox="1"/>
-          <p:nvPr/>
-        </p:nvSpPr>
-        <p:spPr>
-          <a:xfrm>
-            <a:off x="9144000" y="1371600"/>
-            <a:ext cx="2743200" cy="1005840"/>
-          </a:xfrm>
-          <a:prstGeom prst="rect">
-            <a:avLst/>
-          </a:prstGeom>
-          <a:noFill/>
-        </p:spPr>
-        <p:txBody>
-          <a:bodyPr wrap="square">
-            <a:spAutoFit/>
-          </a:bodyPr>
-          <a:lstStyle/>
-          <a:p>
-            <a:pPr algn="ctr"/>
-            <a:r>
-              <a:rPr sz="3400" b="1" i="0">
-                <a:solidFill>
-                  <a:srgbClr val="23613F"/>
-                </a:solidFill>
-                <a:latin typeface="Calibri"/>
-              </a:rPr>
-              <a:t>9 994</a:t>
-            </a:r>
-          </a:p>
-        </p:txBody>
-      </p:sp>
-      <p:sp>
-        <p:nvSpPr>
-          <p:cNvPr id="16" name="TextBox 15"/>
-          <p:cNvSpPr txBox="1"/>
-          <p:nvPr/>
-        </p:nvSpPr>
-        <p:spPr>
-          <a:xfrm>
-            <a:off x="9144000" y="2423160"/>
-            <a:ext cx="2743200" cy="914400"/>
-          </a:xfrm>
-          <a:prstGeom prst="rect">
-            <a:avLst/>
-          </a:prstGeom>
-          <a:noFill/>
-        </p:spPr>
-        <p:txBody>
-          <a:bodyPr wrap="square">
-            <a:spAutoFit/>
-          </a:bodyPr>
-          <a:lstStyle/>
-          <a:p>
-            <a:pPr algn="ctr"/>
-            <a:r>
-              <a:rPr sz="1400" b="0" i="0">
-                <a:solidFill>
-                  <a:srgbClr val="577166"/>
-                </a:solidFill>
-                <a:latin typeface="Calibri"/>
-              </a:rPr>
-              <a:t>статей
-загружено в БД</a:t>
-            </a:r>
-          </a:p>
-        </p:txBody>
-      </p:sp>
-      <p:sp>
-        <p:nvSpPr>
-          <p:cNvPr id="17" name="TextBox 16"/>
-          <p:cNvSpPr txBox="1"/>
-          <p:nvPr/>
-        </p:nvSpPr>
-        <p:spPr>
-          <a:xfrm>
-            <a:off x="457200" y="3749039"/>
-            <a:ext cx="11247120" cy="1371600"/>
-          </a:xfrm>
-          <a:prstGeom prst="rect">
-            <a:avLst/>
-          </a:prstGeom>
-          <a:noFill/>
-        </p:spPr>
-        <p:txBody>
-          <a:bodyPr wrap="square">
-            <a:spAutoFit/>
-          </a:bodyPr>
-          <a:lstStyle/>
-          <a:p>
-            <a:pPr algn="l"/>
-            <a:r>
-              <a:rPr sz="1700" b="0" i="0">
-                <a:solidFill>
-                  <a:srgbClr val="122017"/>
-                </a:solidFill>
-                <a:latin typeface="Calibri"/>
-              </a:rPr>
-              <a:t>Традиционный поиск по ключевым словам находит конкретную статью,
-но не отвечает на более широкие вопросы: кто с кем сотрудничает,
-из каких стран приходят исследования, как менялась тематика со временем.</a:t>
-            </a:r>
-          </a:p>
-        </p:txBody>
-      </p:sp>
-      <p:sp>
-        <p:nvSpPr>
-          <p:cNvPr id="18" name="TextBox 17"/>
-          <p:cNvSpPr txBox="1"/>
-          <p:nvPr/>
-        </p:nvSpPr>
-        <p:spPr>
-          <a:xfrm>
-            <a:off x="457200" y="5303520"/>
-            <a:ext cx="11247120" cy="640080"/>
-          </a:xfrm>
-          <a:prstGeom prst="rect">
-            <a:avLst/>
-          </a:prstGeom>
-          <a:noFill/>
-        </p:spPr>
-        <p:txBody>
-          <a:bodyPr wrap="square">
-            <a:spAutoFit/>
-          </a:bodyPr>
-          <a:lstStyle/>
-          <a:p>
-            <a:pPr algn="l"/>
-            <a:r>
-              <a:rPr sz="1700" b="1" i="0">
-                <a:solidFill>
-                  <a:srgbClr val="23613F"/>
-                </a:solidFill>
-                <a:latin typeface="Calibri"/>
-              </a:rPr>
-              <a:t>Карта и граф превращают тысячи строк метаданных в наглядный научный ландшафт.</a:t>
-            </a:r>
-          </a:p>
-        </p:txBody>
-      </p:sp>
+            <a:r>
+              <a:rPr sz="2400" b="1">
+                <a:solidFill>
+                  <a:srgbClr val="1F497D"/>
+                </a:solidFill>
+              </a:rPr>
+              <a:t>Глоссарий</a:t>
+            </a:r>
+          </a:p>
+        </p:txBody>
+      </p:sp>
+      <p:graphicFrame>
+        <p:nvGraphicFramePr>
+          <p:cNvPr id="3" name="Table 2"/>
+          <p:cNvGraphicFramePr>
+            <a:graphicFrameLocks noGrp="1"/>
+          </p:cNvGraphicFramePr>
+          <p:nvPr/>
+        </p:nvGraphicFramePr>
+        <p:xfrm>
+          <a:off x="360000" y="750000"/>
+          <a:ext cx="5634476" cy="5958000"/>
+        </p:xfrm>
+        <a:graphic>
+          <a:graphicData uri="http://schemas.openxmlformats.org/drawingml/2006/table">
+            <a:tbl>
+              <a:tblPr firstRow="1" bandRow="1">
+                <a:tableStyleId>{5C22544A-7EE6-4342-B048-85BDC9FD1C3A}</a:tableStyleId>
+              </a:tblPr>
+              <a:tblGrid>
+                <a:gridCol w="2817238"/>
+                <a:gridCol w="2817238"/>
+              </a:tblGrid>
+              <a:tr h="541636">
+                <a:tc>
+                  <a:txBody>
+                    <a:bodyPr/>
+                    <a:lstStyle/>
+                    <a:p>
+                      <a:r>
+                        <a:t>Термин</a:t>
+                      </a:r>
+                    </a:p>
+                  </a:txBody>
+                  <a:tcPr/>
+                </a:tc>
+                <a:tc>
+                  <a:txBody>
+                    <a:bodyPr/>
+                    <a:lstStyle/>
+                    <a:p>
+                      <a:r>
+                        <a:t>Определение</a:t>
+                      </a:r>
+                    </a:p>
+                  </a:txBody>
+                  <a:tcPr/>
+                </a:tc>
+              </a:tr>
+              <a:tr h="541636">
+                <a:tc>
+                  <a:txBody>
+                    <a:bodyPr wrap="square"/>
+                    <a:lstStyle/>
+                    <a:p>
+                      <a:r>
+                        <a:rPr sz="800" b="1"/>
+                        <a:t>Метаданные публикации</a:t>
+                      </a:r>
+                    </a:p>
+                  </a:txBody>
+                  <a:tcPr/>
+                </a:tc>
+                <a:tc>
+                  <a:txBody>
+                    <a:bodyPr wrap="square"/>
+                    <a:lstStyle/>
+                    <a:p>
+                      <a:r>
+                        <a:rPr sz="800" b="0"/>
+                        <a:t>Название, авторы, год, журнал, DOI, темы — без полного текста</a:t>
+                      </a:r>
+                    </a:p>
+                  </a:txBody>
+                  <a:tcPr/>
+                </a:tc>
+              </a:tr>
+              <a:tr h="541636">
+                <a:tc>
+                  <a:txBody>
+                    <a:bodyPr wrap="square"/>
+                    <a:lstStyle/>
+                    <a:p>
+                      <a:r>
+                        <a:rPr sz="800" b="1"/>
+                        <a:t>OpenAlex</a:t>
+                      </a:r>
+                    </a:p>
+                  </a:txBody>
+                  <a:tcPr/>
+                </a:tc>
+                <a:tc>
+                  <a:txBody>
+                    <a:bodyPr wrap="square"/>
+                    <a:lstStyle/>
+                    <a:p>
+                      <a:r>
+                        <a:rPr sz="800" b="0"/>
+                        <a:t>Открытый бесплатный каталог научных публикаций; более 250 млн работ</a:t>
+                      </a:r>
+                    </a:p>
+                  </a:txBody>
+                  <a:tcPr/>
+                </a:tc>
+              </a:tr>
+              <a:tr h="541636">
+                <a:tc>
+                  <a:txBody>
+                    <a:bodyPr wrap="square"/>
+                    <a:lstStyle/>
+                    <a:p>
+                      <a:r>
+                        <a:rPr sz="800" b="1"/>
+                        <a:t>API</a:t>
+                      </a:r>
+                    </a:p>
+                  </a:txBody>
+                  <a:tcPr/>
+                </a:tc>
+                <a:tc>
+                  <a:txBody>
+                    <a:bodyPr wrap="square"/>
+                    <a:lstStyle/>
+                    <a:p>
+                      <a:r>
+                        <a:rPr sz="800" b="0"/>
+                        <a:t>Набор HTTP-запросов для получения данных из внешнего сервиса</a:t>
+                      </a:r>
+                    </a:p>
+                  </a:txBody>
+                  <a:tcPr/>
+                </a:tc>
+              </a:tr>
+              <a:tr h="541636">
+                <a:tc>
+                  <a:txBody>
+                    <a:bodyPr wrap="square"/>
+                    <a:lstStyle/>
+                    <a:p>
+                      <a:r>
+                        <a:rPr sz="800" b="1"/>
+                        <a:t>DOI</a:t>
+                      </a:r>
+                    </a:p>
+                  </a:txBody>
+                  <a:tcPr/>
+                </a:tc>
+                <a:tc>
+                  <a:txBody>
+                    <a:bodyPr wrap="square"/>
+                    <a:lstStyle/>
+                    <a:p>
+                      <a:r>
+                        <a:rPr sz="800" b="0"/>
+                        <a:t>Уникальный цифровой идентификатор научной публикации (10.XXXX/...)</a:t>
+                      </a:r>
+                    </a:p>
+                  </a:txBody>
+                  <a:tcPr/>
+                </a:tc>
+              </a:tr>
+              <a:tr h="541636">
+                <a:tc>
+                  <a:txBody>
+                    <a:bodyPr wrap="square"/>
+                    <a:lstStyle/>
+                    <a:p>
+                      <a:r>
+                        <a:rPr sz="800" b="1"/>
+                        <a:t>Аффилиация</a:t>
+                      </a:r>
+                    </a:p>
+                  </a:txBody>
+                  <a:tcPr/>
+                </a:tc>
+                <a:tc>
+                  <a:txBody>
+                    <a:bodyPr wrap="square"/>
+                    <a:lstStyle/>
+                    <a:p>
+                      <a:r>
+                        <a:rPr sz="800" b="0"/>
+                        <a:t>Организация, с которой связан автор на момент публикации</a:t>
+                      </a:r>
+                    </a:p>
+                  </a:txBody>
+                  <a:tcPr/>
+                </a:tc>
+              </a:tr>
+              <a:tr h="541636">
+                <a:tc>
+                  <a:txBody>
+                    <a:bodyPr wrap="square"/>
+                    <a:lstStyle/>
+                    <a:p>
+                      <a:r>
+                        <a:rPr sz="800" b="1"/>
+                        <a:t>Геокодирование</a:t>
+                      </a:r>
+                    </a:p>
+                  </a:txBody>
+                  <a:tcPr/>
+                </a:tc>
+                <a:tc>
+                  <a:txBody>
+                    <a:bodyPr wrap="square"/>
+                    <a:lstStyle/>
+                    <a:p>
+                      <a:r>
+                        <a:rPr sz="800" b="0"/>
+                        <a:t>Определение географических координат по названию места</a:t>
+                      </a:r>
+                    </a:p>
+                  </a:txBody>
+                  <a:tcPr/>
+                </a:tc>
+              </a:tr>
+              <a:tr h="541636">
+                <a:tc>
+                  <a:txBody>
+                    <a:bodyPr wrap="square"/>
+                    <a:lstStyle/>
+                    <a:p>
+                      <a:r>
+                        <a:rPr sz="800" b="1"/>
+                        <a:t>Граф</a:t>
+                      </a:r>
+                    </a:p>
+                  </a:txBody>
+                  <a:tcPr/>
+                </a:tc>
+                <a:tc>
+                  <a:txBody>
+                    <a:bodyPr wrap="square"/>
+                    <a:lstStyle/>
+                    <a:p>
+                      <a:r>
+                        <a:rPr sz="800" b="0"/>
+                        <a:t>Структура из узлов и рёбер; для визуализации отношений между объектами</a:t>
+                      </a:r>
+                    </a:p>
+                  </a:txBody>
+                  <a:tcPr/>
+                </a:tc>
+              </a:tr>
+              <a:tr h="541636">
+                <a:tc>
+                  <a:txBody>
+                    <a:bodyPr wrap="square"/>
+                    <a:lstStyle/>
+                    <a:p>
+                      <a:r>
+                        <a:rPr sz="800" b="1"/>
+                        <a:t>REST API</a:t>
+                      </a:r>
+                    </a:p>
+                  </a:txBody>
+                  <a:tcPr/>
+                </a:tc>
+                <a:tc>
+                  <a:txBody>
+                    <a:bodyPr wrap="square"/>
+                    <a:lstStyle/>
+                    <a:p>
+                      <a:r>
+                        <a:rPr sz="800" b="0"/>
+                        <a:t>Веб-сервис, где каждый ресурс доступен по URL через GET/POST</a:t>
+                      </a:r>
+                    </a:p>
+                  </a:txBody>
+                  <a:tcPr/>
+                </a:tc>
+              </a:tr>
+              <a:tr h="541636">
+                <a:tc>
+                  <a:txBody>
+                    <a:bodyPr wrap="square"/>
+                    <a:lstStyle/>
+                    <a:p>
+                      <a:r>
+                        <a:rPr sz="800" b="1"/>
+                        <a:t>PostgreSQL</a:t>
+                      </a:r>
+                    </a:p>
+                  </a:txBody>
+                  <a:tcPr/>
+                </a:tc>
+                <a:tc>
+                  <a:txBody>
+                    <a:bodyPr wrap="square"/>
+                    <a:lstStyle/>
+                    <a:p>
+                      <a:r>
+                        <a:rPr sz="800" b="0"/>
+                        <a:t>Реляционная СУБД с открытым исходным кодом</a:t>
+                      </a:r>
+                    </a:p>
+                  </a:txBody>
+                  <a:tcPr/>
+                </a:tc>
+              </a:tr>
+              <a:tr h="541640">
+                <a:tc>
+                  <a:txBody>
+                    <a:bodyPr wrap="square"/>
+                    <a:lstStyle/>
+                    <a:p>
+                      <a:r>
+                        <a:rPr sz="800" b="1"/>
+                        <a:t>gzip</a:t>
+                      </a:r>
+                    </a:p>
+                  </a:txBody>
+                  <a:tcPr/>
+                </a:tc>
+                <a:tc>
+                  <a:txBody>
+                    <a:bodyPr wrap="square"/>
+                    <a:lstStyle/>
+                    <a:p>
+                      <a:r>
+                        <a:rPr sz="800" b="0"/>
+                        <a:t>Алгоритм сжатия данных; уменьшает объём HTTP-ответов в 5–10 раз</a:t>
+                      </a:r>
+                    </a:p>
+                  </a:txBody>
+                  <a:tcPr/>
+                </a:tc>
+              </a:tr>
+            </a:tbl>
+          </a:graphicData>
+        </a:graphic>
+      </p:graphicFrame>
+      <p:graphicFrame>
+        <p:nvGraphicFramePr>
+          <p:cNvPr id="4" name="Table 3"/>
+          <p:cNvGraphicFramePr>
+            <a:graphicFrameLocks noGrp="1"/>
+          </p:cNvGraphicFramePr>
+          <p:nvPr/>
+        </p:nvGraphicFramePr>
+        <p:xfrm>
+          <a:off x="6194476" y="750000"/>
+          <a:ext cx="5634476" cy="5958000"/>
+        </p:xfrm>
+        <a:graphic>
+          <a:graphicData uri="http://schemas.openxmlformats.org/drawingml/2006/table">
+            <a:tbl>
+              <a:tblPr firstRow="1" bandRow="1">
+                <a:tableStyleId>{5C22544A-7EE6-4342-B048-85BDC9FD1C3A}</a:tableStyleId>
+              </a:tblPr>
+              <a:tblGrid>
+                <a:gridCol w="2817238"/>
+                <a:gridCol w="2817238"/>
+              </a:tblGrid>
+              <a:tr h="595800">
+                <a:tc>
+                  <a:txBody>
+                    <a:bodyPr wrap="square"/>
+                    <a:lstStyle/>
+                    <a:p>
+                      <a:r>
+                        <a:rPr sz="800" b="1"/>
+                        <a:t>Фасетная фильтрация</a:t>
+                      </a:r>
+                    </a:p>
+                  </a:txBody>
+                  <a:tcPr/>
+                </a:tc>
+                <a:tc>
+                  <a:txBody>
+                    <a:bodyPr wrap="square"/>
+                    <a:lstStyle/>
+                    <a:p>
+                      <a:r>
+                        <a:rPr sz="800"/>
+                        <a:t>Выбор в одном фильтре ограничивает варианты в других</a:t>
+                      </a:r>
+                    </a:p>
+                  </a:txBody>
+                  <a:tcPr/>
+                </a:tc>
+              </a:tr>
+              <a:tr h="595800">
+                <a:tc>
+                  <a:txBody>
+                    <a:bodyPr wrap="square"/>
+                    <a:lstStyle/>
+                    <a:p>
+                      <a:r>
+                        <a:rPr sz="800" b="1"/>
+                        <a:t>SVG</a:t>
+                      </a:r>
+                    </a:p>
+                  </a:txBody>
+                  <a:tcPr/>
+                </a:tc>
+                <a:tc>
+                  <a:txBody>
+                    <a:bodyPr wrap="square"/>
+                    <a:lstStyle/>
+                    <a:p>
+                      <a:r>
+                        <a:rPr sz="800"/>
+                        <a:t>XML-формат векторной графики в браузере; используется для графа</a:t>
+                      </a:r>
+                    </a:p>
+                  </a:txBody>
+                  <a:tcPr/>
+                </a:tc>
+              </a:tr>
+              <a:tr h="595800">
+                <a:tc>
+                  <a:txBody>
+                    <a:bodyPr wrap="square"/>
+                    <a:lstStyle/>
+                    <a:p>
+                      <a:r>
+                        <a:rPr sz="800" b="1"/>
+                        <a:t>Cursor pagination</a:t>
+                      </a:r>
+                    </a:p>
+                  </a:txBody>
+                  <a:tcPr/>
+                </a:tc>
+                <a:tc>
+                  <a:txBody>
+                    <a:bodyPr wrap="square"/>
+                    <a:lstStyle/>
+                    <a:p>
+                      <a:r>
+                        <a:rPr sz="800"/>
+                        <a:t>Постраничный обход через токены-курсоры без пропусков</a:t>
+                      </a:r>
+                    </a:p>
+                  </a:txBody>
+                  <a:tcPr/>
+                </a:tc>
+              </a:tr>
+              <a:tr h="595800">
+                <a:tc>
+                  <a:txBody>
+                    <a:bodyPr wrap="square"/>
+                    <a:lstStyle/>
+                    <a:p>
+                      <a:r>
+                        <a:rPr sz="800" b="1"/>
+                        <a:t>Библиометрия</a:t>
+                      </a:r>
+                    </a:p>
+                  </a:txBody>
+                  <a:tcPr/>
+                </a:tc>
+                <a:tc>
+                  <a:txBody>
+                    <a:bodyPr wrap="square"/>
+                    <a:lstStyle/>
+                    <a:p>
+                      <a:r>
+                        <a:rPr sz="800"/>
+                        <a:t>Количественный анализ публикаций: цитирования, коавторства</a:t>
+                      </a:r>
+                    </a:p>
+                  </a:txBody>
+                  <a:tcPr/>
+                </a:tc>
+              </a:tr>
+              <a:tr h="595800">
+                <a:tc>
+                  <a:txBody>
+                    <a:bodyPr wrap="square"/>
+                    <a:lstStyle/>
+                    <a:p>
+                      <a:r>
+                        <a:rPr sz="800" b="1"/>
+                        <a:t>Балл сходства</a:t>
+                      </a:r>
+                    </a:p>
+                  </a:txBody>
+                  <a:tcPr/>
+                </a:tc>
+                <a:tc>
+                  <a:txBody>
+                    <a:bodyPr wrap="square"/>
+                    <a:lstStyle/>
+                    <a:p>
+                      <a:r>
+                        <a:rPr sz="800"/>
+                        <a:t>Числовая мера близости двух публикаций по взвешенным признакам</a:t>
+                      </a:r>
+                    </a:p>
+                  </a:txBody>
+                  <a:tcPr/>
+                </a:tc>
+              </a:tr>
+              <a:tr h="595800">
+                <a:tc>
+                  <a:txBody>
+                    <a:bodyPr wrap="square"/>
+                    <a:lstStyle/>
+                    <a:p>
+                      <a:r>
+                        <a:rPr sz="800" b="1"/>
+                        <a:t>requestAnimationFrame</a:t>
+                      </a:r>
+                    </a:p>
+                  </a:txBody>
+                  <a:tcPr/>
+                </a:tc>
+                <a:tc>
+                  <a:txBody>
+                    <a:bodyPr wrap="square"/>
+                    <a:lstStyle/>
+                    <a:p>
+                      <a:r>
+                        <a:rPr sz="800"/>
+                        <a:t>Браузерный API для тяжёлых операций между кадрами</a:t>
+                      </a:r>
+                    </a:p>
+                  </a:txBody>
+                  <a:tcPr/>
+                </a:tc>
+              </a:tr>
+              <a:tr h="595800">
+                <a:tc>
+                  <a:txBody>
+                    <a:bodyPr wrap="square"/>
+                    <a:lstStyle/>
+                    <a:p>
+                      <a:r>
+                        <a:rPr sz="800" b="1"/>
+                        <a:t>ijson</a:t>
+                      </a:r>
+                    </a:p>
+                  </a:txBody>
+                  <a:tcPr/>
+                </a:tc>
+                <a:tc>
+                  <a:txBody>
+                    <a:bodyPr wrap="square"/>
+                    <a:lstStyle/>
+                    <a:p>
+                      <a:r>
+                        <a:rPr sz="800"/>
+                        <a:t>Python-библиотека для потокового чтения JSON без загрузки в память</a:t>
+                      </a:r>
+                    </a:p>
+                  </a:txBody>
+                  <a:tcPr/>
+                </a:tc>
+              </a:tr>
+              <a:tr h="595800">
+                <a:tc>
+                  <a:txBody>
+                    <a:bodyPr wrap="square"/>
+                    <a:lstStyle/>
+                    <a:p>
+                      <a:r>
+                        <a:rPr sz="800" b="1"/>
+                        <a:t>Savepoint</a:t>
+                      </a:r>
+                    </a:p>
+                  </a:txBody>
+                  <a:tcPr/>
+                </a:tc>
+                <a:tc>
+                  <a:txBody>
+                    <a:bodyPr wrap="square"/>
+                    <a:lstStyle/>
+                    <a:p>
+                      <a:r>
+                        <a:rPr sz="800"/>
+                        <a:t>Частичный откат транзакции PostgreSQL без потери остальных данных</a:t>
+                      </a:r>
+                    </a:p>
+                  </a:txBody>
+                  <a:tcPr/>
+                </a:tc>
+              </a:tr>
+              <a:tr h="595800">
+                <a:tc>
+                  <a:txBody>
+                    <a:bodyPr wrap="square"/>
+                    <a:lstStyle/>
+                    <a:p>
+                      <a:r>
+                        <a:rPr sz="800" b="1"/>
+                        <a:t>Force-directed layout</a:t>
+                      </a:r>
+                    </a:p>
+                  </a:txBody>
+                  <a:tcPr/>
+                </a:tc>
+                <a:tc>
+                  <a:txBody>
+                    <a:bodyPr wrap="square"/>
+                    <a:lstStyle/>
+                    <a:p>
+                      <a:r>
+                        <a:rPr sz="800"/>
+                        <a:t>Физическая симуляция размещения узлов графа</a:t>
+                      </a:r>
+                    </a:p>
+                  </a:txBody>
+                  <a:tcPr/>
+                </a:tc>
+              </a:tr>
+              <a:tr h="595800">
+                <a:tc>
+                  <a:txBody>
+                    <a:bodyPr wrap="square"/>
+                    <a:lstStyle/>
+                    <a:p>
+                      <a:r>
+                        <a:rPr sz="800" b="1"/>
+                        <a:t>Колоночная раскладка</a:t>
+                      </a:r>
+                    </a:p>
+                  </a:txBody>
+                  <a:tcPr/>
+                </a:tc>
+                <a:tc>
+                  <a:txBody>
+                    <a:bodyPr wrap="square"/>
+                    <a:lstStyle/>
+                    <a:p>
+                      <a:r>
+                        <a:rPr sz="800"/>
+                        <a:t>Каждый тип узла занимает фиксированную вертикальную колонку</a:t>
+                      </a:r>
+                    </a:p>
+                  </a:txBody>
+                  <a:tcPr/>
+                </a:tc>
+              </a:tr>
+            </a:tbl>
+          </a:graphicData>
+        </a:graphic>
+      </p:graphicFrame>
     </p:spTree>
   </p:cSld>
   <p:clrMapOvr>
@@ -7299,14 +7310,100 @@
       <p:grpSpPr/>
       <p:sp>
         <p:nvSpPr>
-          <p:cNvPr id="2" name="TextBox 1"/>
+          <p:cNvPr id="2" name="Rectangle 1"/>
+          <p:cNvSpPr/>
+          <p:nvPr/>
+        </p:nvSpPr>
+        <p:spPr>
+          <a:xfrm>
+            <a:off x="0" y="0"/>
+            <a:ext cx="12188952" cy="6858000"/>
+          </a:xfrm>
+          <a:prstGeom prst="rect">
+            <a:avLst/>
+          </a:prstGeom>
+          <a:solidFill>
+            <a:srgbClr val="F7FBF8"/>
+          </a:solidFill>
+          <a:ln>
+            <a:noFill/>
+          </a:ln>
+        </p:spPr>
+        <p:style>
+          <a:lnRef idx="1">
+            <a:schemeClr val="accent1"/>
+          </a:lnRef>
+          <a:fillRef idx="3">
+            <a:schemeClr val="accent1"/>
+          </a:fillRef>
+          <a:effectRef idx="2">
+            <a:schemeClr val="accent1"/>
+          </a:effectRef>
+          <a:fontRef idx="minor">
+            <a:schemeClr val="lt1"/>
+          </a:fontRef>
+        </p:style>
+        <p:txBody>
+          <a:bodyPr rtlCol="0" anchor="ctr"/>
+          <a:lstStyle/>
+          <a:p>
+            <a:pPr algn="ctr"/>
+          </a:p>
+        </p:txBody>
+      </p:sp>
+      <p:sp>
+        <p:nvSpPr>
+          <p:cNvPr id="3" name="Rectangle 2"/>
+          <p:cNvSpPr/>
+          <p:nvPr/>
+        </p:nvSpPr>
+        <p:spPr>
+          <a:xfrm>
+            <a:off x="0" y="0"/>
+            <a:ext cx="12188952" cy="1005840"/>
+          </a:xfrm>
+          <a:prstGeom prst="rect">
+            <a:avLst/>
+          </a:prstGeom>
+          <a:solidFill>
+            <a:srgbClr val="163126"/>
+          </a:solidFill>
+          <a:ln>
+            <a:noFill/>
+          </a:ln>
+        </p:spPr>
+        <p:style>
+          <a:lnRef idx="1">
+            <a:schemeClr val="accent1"/>
+          </a:lnRef>
+          <a:fillRef idx="3">
+            <a:schemeClr val="accent1"/>
+          </a:fillRef>
+          <a:effectRef idx="2">
+            <a:schemeClr val="accent1"/>
+          </a:effectRef>
+          <a:fontRef idx="minor">
+            <a:schemeClr val="lt1"/>
+          </a:fontRef>
+        </p:style>
+        <p:txBody>
+          <a:bodyPr rtlCol="0" anchor="ctr"/>
+          <a:lstStyle/>
+          <a:p>
+            <a:pPr algn="ctr"/>
+          </a:p>
+        </p:txBody>
+      </p:sp>
+      <p:sp>
+        <p:nvSpPr>
+          <p:cNvPr id="4" name="TextBox 3"/>
           <p:cNvSpPr txBox="1"/>
           <p:nvPr/>
         </p:nvSpPr>
         <p:spPr>
           <a:xfrm>
-            <a:off x="360000" y="200000"/>
-            <a:ext cx="11468952" cy="500000"/>
+            <a:off x="365760" y="164592"/>
+            <a:ext cx="11430000" cy="685800"/>
           </a:xfrm>
           <a:prstGeom prst="rect">
             <a:avLst/>
@@ -7314,661 +7411,560 @@
           <a:noFill/>
         </p:spPr>
         <p:txBody>
-          <a:bodyPr wrap="none">
+          <a:bodyPr wrap="square">
             <a:spAutoFit/>
           </a:bodyPr>
           <a:lstStyle/>
           <a:p>
+            <a:pPr algn="l"/>
+            <a:r>
+              <a:rPr sz="2600" b="1" i="0">
+                <a:solidFill>
+                  <a:srgbClr val="FFFFFF"/>
+                </a:solidFill>
+                <a:latin typeface="Calibri"/>
+              </a:rPr>
+              <a:t>Актуальность</a:t>
+            </a:r>
+          </a:p>
+        </p:txBody>
+      </p:sp>
+      <p:sp>
+        <p:nvSpPr>
+          <p:cNvPr id="5" name="Rectangle 4"/>
+          <p:cNvSpPr/>
+          <p:nvPr/>
+        </p:nvSpPr>
+        <p:spPr>
+          <a:xfrm>
+            <a:off x="365760" y="1188720"/>
+            <a:ext cx="2743200" cy="2286000"/>
+          </a:xfrm>
+          <a:prstGeom prst="rect">
+            <a:avLst/>
+          </a:prstGeom>
+          <a:solidFill>
+            <a:srgbClr val="FFFFFF"/>
+          </a:solidFill>
+          <a:ln w="9525">
+            <a:solidFill>
+              <a:srgbClr val="CFE0D6"/>
+            </a:solidFill>
+          </a:ln>
+        </p:spPr>
+        <p:style>
+          <a:lnRef idx="1">
+            <a:schemeClr val="accent1"/>
+          </a:lnRef>
+          <a:fillRef idx="3">
+            <a:schemeClr val="accent1"/>
+          </a:fillRef>
+          <a:effectRef idx="2">
+            <a:schemeClr val="accent1"/>
+          </a:effectRef>
+          <a:fontRef idx="minor">
+            <a:schemeClr val="lt1"/>
+          </a:fontRef>
+        </p:style>
+        <p:txBody>
+          <a:bodyPr rtlCol="0" anchor="ctr"/>
+          <a:lstStyle/>
+          <a:p>
             <a:pPr algn="ctr"/>
-            <a:r>
-              <a:rPr sz="2400" b="1">
-                <a:solidFill>
-                  <a:srgbClr val="1F497D"/>
-                </a:solidFill>
-              </a:rPr>
-              <a:t>Глоссарий</a:t>
-            </a:r>
-          </a:p>
-        </p:txBody>
-      </p:sp>
-      <p:graphicFrame>
-        <p:nvGraphicFramePr>
-          <p:cNvPr id="3" name="Table 2"/>
-          <p:cNvGraphicFramePr>
-            <a:graphicFrameLocks noGrp="1"/>
-          </p:cNvGraphicFramePr>
-          <p:nvPr/>
-        </p:nvGraphicFramePr>
-        <p:xfrm>
-          <a:off x="360000" y="750000"/>
-          <a:ext cx="5634476" cy="5958000"/>
-        </p:xfrm>
-        <a:graphic>
-          <a:graphicData uri="http://schemas.openxmlformats.org/drawingml/2006/table">
-            <a:tbl>
-              <a:tblPr firstRow="1" bandRow="1">
-                <a:tableStyleId>{5C22544A-7EE6-4342-B048-85BDC9FD1C3A}</a:tableStyleId>
-              </a:tblPr>
-              <a:tblGrid>
-                <a:gridCol w="2817238"/>
-                <a:gridCol w="2817238"/>
-              </a:tblGrid>
-              <a:tr h="541636">
-                <a:tc>
-                  <a:txBody>
-                    <a:bodyPr/>
-                    <a:lstStyle/>
-                    <a:p>
-                      <a:r>
-                        <a:t>Термин</a:t>
-                      </a:r>
-                    </a:p>
-                  </a:txBody>
-                  <a:tcPr/>
-                </a:tc>
-                <a:tc>
-                  <a:txBody>
-                    <a:bodyPr/>
-                    <a:lstStyle/>
-                    <a:p>
-                      <a:r>
-                        <a:t>Определение</a:t>
-                      </a:r>
-                    </a:p>
-                  </a:txBody>
-                  <a:tcPr/>
-                </a:tc>
-              </a:tr>
-              <a:tr h="541636">
-                <a:tc>
-                  <a:txBody>
-                    <a:bodyPr wrap="square"/>
-                    <a:lstStyle/>
-                    <a:p>
-                      <a:r>
-                        <a:rPr sz="800" b="1"/>
-                        <a:t>Метаданные публикации</a:t>
-                      </a:r>
-                    </a:p>
-                  </a:txBody>
-                  <a:tcPr/>
-                </a:tc>
-                <a:tc>
-                  <a:txBody>
-                    <a:bodyPr wrap="square"/>
-                    <a:lstStyle/>
-                    <a:p>
-                      <a:r>
-                        <a:rPr sz="800" b="0"/>
-                        <a:t>Название, авторы, год, журнал, DOI, темы — без полного текста</a:t>
-                      </a:r>
-                    </a:p>
-                  </a:txBody>
-                  <a:tcPr/>
-                </a:tc>
-              </a:tr>
-              <a:tr h="541636">
-                <a:tc>
-                  <a:txBody>
-                    <a:bodyPr wrap="square"/>
-                    <a:lstStyle/>
-                    <a:p>
-                      <a:r>
-                        <a:rPr sz="800" b="1"/>
-                        <a:t>OpenAlex</a:t>
-                      </a:r>
-                    </a:p>
-                  </a:txBody>
-                  <a:tcPr/>
-                </a:tc>
-                <a:tc>
-                  <a:txBody>
-                    <a:bodyPr wrap="square"/>
-                    <a:lstStyle/>
-                    <a:p>
-                      <a:r>
-                        <a:rPr sz="800" b="0"/>
-                        <a:t>Открытый бесплатный каталог научных публикаций; более 250 млн работ</a:t>
-                      </a:r>
-                    </a:p>
-                  </a:txBody>
-                  <a:tcPr/>
-                </a:tc>
-              </a:tr>
-              <a:tr h="541636">
-                <a:tc>
-                  <a:txBody>
-                    <a:bodyPr wrap="square"/>
-                    <a:lstStyle/>
-                    <a:p>
-                      <a:r>
-                        <a:rPr sz="800" b="1"/>
-                        <a:t>API</a:t>
-                      </a:r>
-                    </a:p>
-                  </a:txBody>
-                  <a:tcPr/>
-                </a:tc>
-                <a:tc>
-                  <a:txBody>
-                    <a:bodyPr wrap="square"/>
-                    <a:lstStyle/>
-                    <a:p>
-                      <a:r>
-                        <a:rPr sz="800" b="0"/>
-                        <a:t>Набор HTTP-запросов для получения данных из внешнего сервиса</a:t>
-                      </a:r>
-                    </a:p>
-                  </a:txBody>
-                  <a:tcPr/>
-                </a:tc>
-              </a:tr>
-              <a:tr h="541636">
-                <a:tc>
-                  <a:txBody>
-                    <a:bodyPr wrap="square"/>
-                    <a:lstStyle/>
-                    <a:p>
-                      <a:r>
-                        <a:rPr sz="800" b="1"/>
-                        <a:t>DOI</a:t>
-                      </a:r>
-                    </a:p>
-                  </a:txBody>
-                  <a:tcPr/>
-                </a:tc>
-                <a:tc>
-                  <a:txBody>
-                    <a:bodyPr wrap="square"/>
-                    <a:lstStyle/>
-                    <a:p>
-                      <a:r>
-                        <a:rPr sz="800" b="0"/>
-                        <a:t>Уникальный цифровой идентификатор научной публикации (10.XXXX/...)</a:t>
-                      </a:r>
-                    </a:p>
-                  </a:txBody>
-                  <a:tcPr/>
-                </a:tc>
-              </a:tr>
-              <a:tr h="541636">
-                <a:tc>
-                  <a:txBody>
-                    <a:bodyPr wrap="square"/>
-                    <a:lstStyle/>
-                    <a:p>
-                      <a:r>
-                        <a:rPr sz="800" b="1"/>
-                        <a:t>Аффилиация</a:t>
-                      </a:r>
-                    </a:p>
-                  </a:txBody>
-                  <a:tcPr/>
-                </a:tc>
-                <a:tc>
-                  <a:txBody>
-                    <a:bodyPr wrap="square"/>
-                    <a:lstStyle/>
-                    <a:p>
-                      <a:r>
-                        <a:rPr sz="800" b="0"/>
-                        <a:t>Организация, с которой связан автор на момент публикации</a:t>
-                      </a:r>
-                    </a:p>
-                  </a:txBody>
-                  <a:tcPr/>
-                </a:tc>
-              </a:tr>
-              <a:tr h="541636">
-                <a:tc>
-                  <a:txBody>
-                    <a:bodyPr wrap="square"/>
-                    <a:lstStyle/>
-                    <a:p>
-                      <a:r>
-                        <a:rPr sz="800" b="1"/>
-                        <a:t>Геокодирование</a:t>
-                      </a:r>
-                    </a:p>
-                  </a:txBody>
-                  <a:tcPr/>
-                </a:tc>
-                <a:tc>
-                  <a:txBody>
-                    <a:bodyPr wrap="square"/>
-                    <a:lstStyle/>
-                    <a:p>
-                      <a:r>
-                        <a:rPr sz="800" b="0"/>
-                        <a:t>Определение географических координат по названию места</a:t>
-                      </a:r>
-                    </a:p>
-                  </a:txBody>
-                  <a:tcPr/>
-                </a:tc>
-              </a:tr>
-              <a:tr h="541636">
-                <a:tc>
-                  <a:txBody>
-                    <a:bodyPr wrap="square"/>
-                    <a:lstStyle/>
-                    <a:p>
-                      <a:r>
-                        <a:rPr sz="800" b="1"/>
-                        <a:t>Граф</a:t>
-                      </a:r>
-                    </a:p>
-                  </a:txBody>
-                  <a:tcPr/>
-                </a:tc>
-                <a:tc>
-                  <a:txBody>
-                    <a:bodyPr wrap="square"/>
-                    <a:lstStyle/>
-                    <a:p>
-                      <a:r>
-                        <a:rPr sz="800" b="0"/>
-                        <a:t>Структура из узлов и рёбер; для визуализации отношений между объектами</a:t>
-                      </a:r>
-                    </a:p>
-                  </a:txBody>
-                  <a:tcPr/>
-                </a:tc>
-              </a:tr>
-              <a:tr h="541636">
-                <a:tc>
-                  <a:txBody>
-                    <a:bodyPr wrap="square"/>
-                    <a:lstStyle/>
-                    <a:p>
-                      <a:r>
-                        <a:rPr sz="800" b="1"/>
-                        <a:t>REST API</a:t>
-                      </a:r>
-                    </a:p>
-                  </a:txBody>
-                  <a:tcPr/>
-                </a:tc>
-                <a:tc>
-                  <a:txBody>
-                    <a:bodyPr wrap="square"/>
-                    <a:lstStyle/>
-                    <a:p>
-                      <a:r>
-                        <a:rPr sz="800" b="0"/>
-                        <a:t>Веб-сервис, где каждый ресурс доступен по URL через GET/POST</a:t>
-                      </a:r>
-                    </a:p>
-                  </a:txBody>
-                  <a:tcPr/>
-                </a:tc>
-              </a:tr>
-              <a:tr h="541636">
-                <a:tc>
-                  <a:txBody>
-                    <a:bodyPr wrap="square"/>
-                    <a:lstStyle/>
-                    <a:p>
-                      <a:r>
-                        <a:rPr sz="800" b="1"/>
-                        <a:t>PostgreSQL</a:t>
-                      </a:r>
-                    </a:p>
-                  </a:txBody>
-                  <a:tcPr/>
-                </a:tc>
-                <a:tc>
-                  <a:txBody>
-                    <a:bodyPr wrap="square"/>
-                    <a:lstStyle/>
-                    <a:p>
-                      <a:r>
-                        <a:rPr sz="800" b="0"/>
-                        <a:t>Реляционная СУБД с открытым исходным кодом</a:t>
-                      </a:r>
-                    </a:p>
-                  </a:txBody>
-                  <a:tcPr/>
-                </a:tc>
-              </a:tr>
-              <a:tr h="541640">
-                <a:tc>
-                  <a:txBody>
-                    <a:bodyPr wrap="square"/>
-                    <a:lstStyle/>
-                    <a:p>
-                      <a:r>
-                        <a:rPr sz="800" b="1"/>
-                        <a:t>gzip</a:t>
-                      </a:r>
-                    </a:p>
-                  </a:txBody>
-                  <a:tcPr/>
-                </a:tc>
-                <a:tc>
-                  <a:txBody>
-                    <a:bodyPr wrap="square"/>
-                    <a:lstStyle/>
-                    <a:p>
-                      <a:r>
-                        <a:rPr sz="800" b="0"/>
-                        <a:t>Алгоритм сжатия данных; уменьшает объём HTTP-ответов в 5–10 раз</a:t>
-                      </a:r>
-                    </a:p>
-                  </a:txBody>
-                  <a:tcPr/>
-                </a:tc>
-              </a:tr>
-            </a:tbl>
-          </a:graphicData>
-        </a:graphic>
-      </p:graphicFrame>
-      <p:graphicFrame>
-        <p:nvGraphicFramePr>
-          <p:cNvPr id="4" name="Table 3"/>
-          <p:cNvGraphicFramePr>
-            <a:graphicFrameLocks noGrp="1"/>
-          </p:cNvGraphicFramePr>
-          <p:nvPr/>
-        </p:nvGraphicFramePr>
-        <p:xfrm>
-          <a:off x="6194476" y="750000"/>
-          <a:ext cx="5634476" cy="5958000"/>
-        </p:xfrm>
-        <a:graphic>
-          <a:graphicData uri="http://schemas.openxmlformats.org/drawingml/2006/table">
-            <a:tbl>
-              <a:tblPr firstRow="1" bandRow="1">
-                <a:tableStyleId>{5C22544A-7EE6-4342-B048-85BDC9FD1C3A}</a:tableStyleId>
-              </a:tblPr>
-              <a:tblGrid>
-                <a:gridCol w="2817238"/>
-                <a:gridCol w="2817238"/>
-              </a:tblGrid>
-              <a:tr h="595800">
-                <a:tc>
-                  <a:txBody>
-                    <a:bodyPr wrap="square"/>
-                    <a:lstStyle/>
-                    <a:p>
-                      <a:r>
-                        <a:rPr sz="800" b="1"/>
-                        <a:t>Фасетная фильтрация</a:t>
-                      </a:r>
-                    </a:p>
-                  </a:txBody>
-                  <a:tcPr/>
-                </a:tc>
-                <a:tc>
-                  <a:txBody>
-                    <a:bodyPr wrap="square"/>
-                    <a:lstStyle/>
-                    <a:p>
-                      <a:r>
-                        <a:rPr sz="800"/>
-                        <a:t>Выбор в одном фильтре ограничивает варианты в других</a:t>
-                      </a:r>
-                    </a:p>
-                  </a:txBody>
-                  <a:tcPr/>
-                </a:tc>
-              </a:tr>
-              <a:tr h="595800">
-                <a:tc>
-                  <a:txBody>
-                    <a:bodyPr wrap="square"/>
-                    <a:lstStyle/>
-                    <a:p>
-                      <a:r>
-                        <a:rPr sz="800" b="1"/>
-                        <a:t>SVG</a:t>
-                      </a:r>
-                    </a:p>
-                  </a:txBody>
-                  <a:tcPr/>
-                </a:tc>
-                <a:tc>
-                  <a:txBody>
-                    <a:bodyPr wrap="square"/>
-                    <a:lstStyle/>
-                    <a:p>
-                      <a:r>
-                        <a:rPr sz="800"/>
-                        <a:t>XML-формат векторной графики в браузере; используется для графа</a:t>
-                      </a:r>
-                    </a:p>
-                  </a:txBody>
-                  <a:tcPr/>
-                </a:tc>
-              </a:tr>
-              <a:tr h="595800">
-                <a:tc>
-                  <a:txBody>
-                    <a:bodyPr wrap="square"/>
-                    <a:lstStyle/>
-                    <a:p>
-                      <a:r>
-                        <a:rPr sz="800" b="1"/>
-                        <a:t>Cursor pagination</a:t>
-                      </a:r>
-                    </a:p>
-                  </a:txBody>
-                  <a:tcPr/>
-                </a:tc>
-                <a:tc>
-                  <a:txBody>
-                    <a:bodyPr wrap="square"/>
-                    <a:lstStyle/>
-                    <a:p>
-                      <a:r>
-                        <a:rPr sz="800"/>
-                        <a:t>Постраничный обход через токены-курсоры без пропусков</a:t>
-                      </a:r>
-                    </a:p>
-                  </a:txBody>
-                  <a:tcPr/>
-                </a:tc>
-              </a:tr>
-              <a:tr h="595800">
-                <a:tc>
-                  <a:txBody>
-                    <a:bodyPr wrap="square"/>
-                    <a:lstStyle/>
-                    <a:p>
-                      <a:r>
-                        <a:rPr sz="800" b="1"/>
-                        <a:t>Библиометрия</a:t>
-                      </a:r>
-                    </a:p>
-                  </a:txBody>
-                  <a:tcPr/>
-                </a:tc>
-                <a:tc>
-                  <a:txBody>
-                    <a:bodyPr wrap="square"/>
-                    <a:lstStyle/>
-                    <a:p>
-                      <a:r>
-                        <a:rPr sz="800"/>
-                        <a:t>Количественный анализ публикаций: цитирования, коавторства</a:t>
-                      </a:r>
-                    </a:p>
-                  </a:txBody>
-                  <a:tcPr/>
-                </a:tc>
-              </a:tr>
-              <a:tr h="595800">
-                <a:tc>
-                  <a:txBody>
-                    <a:bodyPr wrap="square"/>
-                    <a:lstStyle/>
-                    <a:p>
-                      <a:r>
-                        <a:rPr sz="800" b="1"/>
-                        <a:t>Балл сходства</a:t>
-                      </a:r>
-                    </a:p>
-                  </a:txBody>
-                  <a:tcPr/>
-                </a:tc>
-                <a:tc>
-                  <a:txBody>
-                    <a:bodyPr wrap="square"/>
-                    <a:lstStyle/>
-                    <a:p>
-                      <a:r>
-                        <a:rPr sz="800"/>
-                        <a:t>Числовая мера близости двух публикаций по взвешенным признакам</a:t>
-                      </a:r>
-                    </a:p>
-                  </a:txBody>
-                  <a:tcPr/>
-                </a:tc>
-              </a:tr>
-              <a:tr h="595800">
-                <a:tc>
-                  <a:txBody>
-                    <a:bodyPr wrap="square"/>
-                    <a:lstStyle/>
-                    <a:p>
-                      <a:r>
-                        <a:rPr sz="800" b="1"/>
-                        <a:t>requestAnimationFrame</a:t>
-                      </a:r>
-                    </a:p>
-                  </a:txBody>
-                  <a:tcPr/>
-                </a:tc>
-                <a:tc>
-                  <a:txBody>
-                    <a:bodyPr wrap="square"/>
-                    <a:lstStyle/>
-                    <a:p>
-                      <a:r>
-                        <a:rPr sz="800"/>
-                        <a:t>Браузерный API для тяжёлых операций между кадрами</a:t>
-                      </a:r>
-                    </a:p>
-                  </a:txBody>
-                  <a:tcPr/>
-                </a:tc>
-              </a:tr>
-              <a:tr h="595800">
-                <a:tc>
-                  <a:txBody>
-                    <a:bodyPr wrap="square"/>
-                    <a:lstStyle/>
-                    <a:p>
-                      <a:r>
-                        <a:rPr sz="800" b="1"/>
-                        <a:t>ijson</a:t>
-                      </a:r>
-                    </a:p>
-                  </a:txBody>
-                  <a:tcPr/>
-                </a:tc>
-                <a:tc>
-                  <a:txBody>
-                    <a:bodyPr wrap="square"/>
-                    <a:lstStyle/>
-                    <a:p>
-                      <a:r>
-                        <a:rPr sz="800"/>
-                        <a:t>Python-библиотека для потокового чтения JSON без загрузки в память</a:t>
-                      </a:r>
-                    </a:p>
-                  </a:txBody>
-                  <a:tcPr/>
-                </a:tc>
-              </a:tr>
-              <a:tr h="595800">
-                <a:tc>
-                  <a:txBody>
-                    <a:bodyPr wrap="square"/>
-                    <a:lstStyle/>
-                    <a:p>
-                      <a:r>
-                        <a:rPr sz="800" b="1"/>
-                        <a:t>Savepoint</a:t>
-                      </a:r>
-                    </a:p>
-                  </a:txBody>
-                  <a:tcPr/>
-                </a:tc>
-                <a:tc>
-                  <a:txBody>
-                    <a:bodyPr wrap="square"/>
-                    <a:lstStyle/>
-                    <a:p>
-                      <a:r>
-                        <a:rPr sz="800"/>
-                        <a:t>Частичный откат транзакции PostgreSQL без потери остальных данных</a:t>
-                      </a:r>
-                    </a:p>
-                  </a:txBody>
-                  <a:tcPr/>
-                </a:tc>
-              </a:tr>
-              <a:tr h="595800">
-                <a:tc>
-                  <a:txBody>
-                    <a:bodyPr wrap="square"/>
-                    <a:lstStyle/>
-                    <a:p>
-                      <a:r>
-                        <a:rPr sz="800" b="1"/>
-                        <a:t>Force-directed layout</a:t>
-                      </a:r>
-                    </a:p>
-                  </a:txBody>
-                  <a:tcPr/>
-                </a:tc>
-                <a:tc>
-                  <a:txBody>
-                    <a:bodyPr wrap="square"/>
-                    <a:lstStyle/>
-                    <a:p>
-                      <a:r>
-                        <a:rPr sz="800"/>
-                        <a:t>Физическая симуляция размещения узлов графа</a:t>
-                      </a:r>
-                    </a:p>
-                  </a:txBody>
-                  <a:tcPr/>
-                </a:tc>
-              </a:tr>
-              <a:tr h="595800">
-                <a:tc>
-                  <a:txBody>
-                    <a:bodyPr wrap="square"/>
-                    <a:lstStyle/>
-                    <a:p>
-                      <a:r>
-                        <a:rPr sz="800" b="1"/>
-                        <a:t>Колоночная раскладка</a:t>
-                      </a:r>
-                    </a:p>
-                  </a:txBody>
-                  <a:tcPr/>
-                </a:tc>
-                <a:tc>
-                  <a:txBody>
-                    <a:bodyPr wrap="square"/>
-                    <a:lstStyle/>
-                    <a:p>
-                      <a:r>
-                        <a:rPr sz="800"/>
-                        <a:t>Каждый тип узла занимает фиксированную вертикальную колонку</a:t>
-                      </a:r>
-                    </a:p>
-                  </a:txBody>
-                  <a:tcPr/>
-                </a:tc>
-              </a:tr>
-            </a:tbl>
-          </a:graphicData>
-        </a:graphic>
-      </p:graphicFrame>
+          </a:p>
+        </p:txBody>
+      </p:sp>
+      <p:sp>
+        <p:nvSpPr>
+          <p:cNvPr id="6" name="TextBox 5"/>
+          <p:cNvSpPr txBox="1"/>
+          <p:nvPr/>
+        </p:nvSpPr>
+        <p:spPr>
+          <a:xfrm>
+            <a:off x="365760" y="1371600"/>
+            <a:ext cx="2743200" cy="1005840"/>
+          </a:xfrm>
+          <a:prstGeom prst="rect">
+            <a:avLst/>
+          </a:prstGeom>
+          <a:noFill/>
+        </p:spPr>
+        <p:txBody>
+          <a:bodyPr wrap="square">
+            <a:spAutoFit/>
+          </a:bodyPr>
+          <a:lstStyle/>
+          <a:p>
+            <a:pPr algn="ctr"/>
+            <a:r>
+              <a:rPr sz="3400" b="1" i="0">
+                <a:solidFill>
+                  <a:srgbClr val="23613F"/>
+                </a:solidFill>
+                <a:latin typeface="Calibri"/>
+              </a:rPr>
+              <a:t>250 млн+</a:t>
+            </a:r>
+          </a:p>
+        </p:txBody>
+      </p:sp>
+      <p:sp>
+        <p:nvSpPr>
+          <p:cNvPr id="7" name="TextBox 6"/>
+          <p:cNvSpPr txBox="1"/>
+          <p:nvPr/>
+        </p:nvSpPr>
+        <p:spPr>
+          <a:xfrm>
+            <a:off x="365760" y="2423160"/>
+            <a:ext cx="2743200" cy="914400"/>
+          </a:xfrm>
+          <a:prstGeom prst="rect">
+            <a:avLst/>
+          </a:prstGeom>
+          <a:noFill/>
+        </p:spPr>
+        <p:txBody>
+          <a:bodyPr wrap="square">
+            <a:spAutoFit/>
+          </a:bodyPr>
+          <a:lstStyle/>
+          <a:p>
+            <a:pPr algn="ctr"/>
+            <a:r>
+              <a:rPr sz="1400" b="0" i="0">
+                <a:solidFill>
+                  <a:srgbClr val="577166"/>
+                </a:solidFill>
+                <a:latin typeface="Calibri"/>
+              </a:rPr>
+              <a:t>научных работ
+в открытом доступе</a:t>
+            </a:r>
+          </a:p>
+        </p:txBody>
+      </p:sp>
+      <p:sp>
+        <p:nvSpPr>
+          <p:cNvPr id="8" name="Rectangle 7"/>
+          <p:cNvSpPr/>
+          <p:nvPr/>
+        </p:nvSpPr>
+        <p:spPr>
+          <a:xfrm>
+            <a:off x="3291840" y="1188720"/>
+            <a:ext cx="2743200" cy="2286000"/>
+          </a:xfrm>
+          <a:prstGeom prst="rect">
+            <a:avLst/>
+          </a:prstGeom>
+          <a:solidFill>
+            <a:srgbClr val="FFFFFF"/>
+          </a:solidFill>
+          <a:ln w="9525">
+            <a:solidFill>
+              <a:srgbClr val="CFE0D6"/>
+            </a:solidFill>
+          </a:ln>
+        </p:spPr>
+        <p:style>
+          <a:lnRef idx="1">
+            <a:schemeClr val="accent1"/>
+          </a:lnRef>
+          <a:fillRef idx="3">
+            <a:schemeClr val="accent1"/>
+          </a:fillRef>
+          <a:effectRef idx="2">
+            <a:schemeClr val="accent1"/>
+          </a:effectRef>
+          <a:fontRef idx="minor">
+            <a:schemeClr val="lt1"/>
+          </a:fontRef>
+        </p:style>
+        <p:txBody>
+          <a:bodyPr rtlCol="0" anchor="ctr"/>
+          <a:lstStyle/>
+          <a:p>
+            <a:pPr algn="ctr"/>
+          </a:p>
+        </p:txBody>
+      </p:sp>
+      <p:sp>
+        <p:nvSpPr>
+          <p:cNvPr id="9" name="TextBox 8"/>
+          <p:cNvSpPr txBox="1"/>
+          <p:nvPr/>
+        </p:nvSpPr>
+        <p:spPr>
+          <a:xfrm>
+            <a:off x="3291840" y="1371600"/>
+            <a:ext cx="2743200" cy="1005840"/>
+          </a:xfrm>
+          <a:prstGeom prst="rect">
+            <a:avLst/>
+          </a:prstGeom>
+          <a:noFill/>
+        </p:spPr>
+        <p:txBody>
+          <a:bodyPr wrap="square">
+            <a:spAutoFit/>
+          </a:bodyPr>
+          <a:lstStyle/>
+          <a:p>
+            <a:pPr algn="ctr"/>
+            <a:r>
+              <a:rPr sz="3400" b="1" i="0">
+                <a:solidFill>
+                  <a:srgbClr val="23613F"/>
+                </a:solidFill>
+                <a:latin typeface="Calibri"/>
+              </a:rPr>
+              <a:t>×2</a:t>
+            </a:r>
+          </a:p>
+        </p:txBody>
+      </p:sp>
+      <p:sp>
+        <p:nvSpPr>
+          <p:cNvPr id="10" name="TextBox 9"/>
+          <p:cNvSpPr txBox="1"/>
+          <p:nvPr/>
+        </p:nvSpPr>
+        <p:spPr>
+          <a:xfrm>
+            <a:off x="3291840" y="2423160"/>
+            <a:ext cx="2743200" cy="914400"/>
+          </a:xfrm>
+          <a:prstGeom prst="rect">
+            <a:avLst/>
+          </a:prstGeom>
+          <a:noFill/>
+        </p:spPr>
+        <p:txBody>
+          <a:bodyPr wrap="square">
+            <a:spAutoFit/>
+          </a:bodyPr>
+          <a:lstStyle/>
+          <a:p>
+            <a:pPr algn="ctr"/>
+            <a:r>
+              <a:rPr sz="1400" b="0" i="0">
+                <a:solidFill>
+                  <a:srgbClr val="577166"/>
+                </a:solidFill>
+                <a:latin typeface="Calibri"/>
+              </a:rPr>
+              <a:t>каждые 9 лет
+удваивается объём</a:t>
+            </a:r>
+          </a:p>
+        </p:txBody>
+      </p:sp>
+      <p:sp>
+        <p:nvSpPr>
+          <p:cNvPr id="11" name="Rectangle 10"/>
+          <p:cNvSpPr/>
+          <p:nvPr/>
+        </p:nvSpPr>
+        <p:spPr>
+          <a:xfrm>
+            <a:off x="6217920" y="1188720"/>
+            <a:ext cx="2743200" cy="2286000"/>
+          </a:xfrm>
+          <a:prstGeom prst="rect">
+            <a:avLst/>
+          </a:prstGeom>
+          <a:solidFill>
+            <a:srgbClr val="FFFFFF"/>
+          </a:solidFill>
+          <a:ln w="9525">
+            <a:solidFill>
+              <a:srgbClr val="CFE0D6"/>
+            </a:solidFill>
+          </a:ln>
+        </p:spPr>
+        <p:style>
+          <a:lnRef idx="1">
+            <a:schemeClr val="accent1"/>
+          </a:lnRef>
+          <a:fillRef idx="3">
+            <a:schemeClr val="accent1"/>
+          </a:fillRef>
+          <a:effectRef idx="2">
+            <a:schemeClr val="accent1"/>
+          </a:effectRef>
+          <a:fontRef idx="minor">
+            <a:schemeClr val="lt1"/>
+          </a:fontRef>
+        </p:style>
+        <p:txBody>
+          <a:bodyPr rtlCol="0" anchor="ctr"/>
+          <a:lstStyle/>
+          <a:p>
+            <a:pPr algn="ctr"/>
+          </a:p>
+        </p:txBody>
+      </p:sp>
+      <p:sp>
+        <p:nvSpPr>
+          <p:cNvPr id="12" name="TextBox 11"/>
+          <p:cNvSpPr txBox="1"/>
+          <p:nvPr/>
+        </p:nvSpPr>
+        <p:spPr>
+          <a:xfrm>
+            <a:off x="6217920" y="1371600"/>
+            <a:ext cx="2743200" cy="1005840"/>
+          </a:xfrm>
+          <a:prstGeom prst="rect">
+            <a:avLst/>
+          </a:prstGeom>
+          <a:noFill/>
+        </p:spPr>
+        <p:txBody>
+          <a:bodyPr wrap="square">
+            <a:spAutoFit/>
+          </a:bodyPr>
+          <a:lstStyle/>
+          <a:p>
+            <a:pPr algn="ctr"/>
+            <a:r>
+              <a:rPr sz="3400" b="1" i="0">
+                <a:solidFill>
+                  <a:srgbClr val="23613F"/>
+                </a:solidFill>
+                <a:latin typeface="Calibri"/>
+              </a:rPr>
+              <a:t>80,8%</a:t>
+            </a:r>
+          </a:p>
+        </p:txBody>
+      </p:sp>
+      <p:sp>
+        <p:nvSpPr>
+          <p:cNvPr id="13" name="TextBox 12"/>
+          <p:cNvSpPr txBox="1"/>
+          <p:nvPr/>
+        </p:nvSpPr>
+        <p:spPr>
+          <a:xfrm>
+            <a:off x="6217920" y="2423160"/>
+            <a:ext cx="2743200" cy="914400"/>
+          </a:xfrm>
+          <a:prstGeom prst="rect">
+            <a:avLst/>
+          </a:prstGeom>
+          <a:noFill/>
+        </p:spPr>
+        <p:txBody>
+          <a:bodyPr wrap="square">
+            <a:spAutoFit/>
+          </a:bodyPr>
+          <a:lstStyle/>
+          <a:p>
+            <a:pPr algn="ctr"/>
+            <a:r>
+              <a:rPr sz="1400" b="0" i="0">
+                <a:solidFill>
+                  <a:srgbClr val="577166"/>
+                </a:solidFill>
+                <a:latin typeface="Calibri"/>
+              </a:rPr>
+              <a:t>публикаций
+с геокоординатами</a:t>
+            </a:r>
+          </a:p>
+        </p:txBody>
+      </p:sp>
+      <p:sp>
+        <p:nvSpPr>
+          <p:cNvPr id="14" name="Rectangle 13"/>
+          <p:cNvSpPr/>
+          <p:nvPr/>
+        </p:nvSpPr>
+        <p:spPr>
+          <a:xfrm>
+            <a:off x="9144000" y="1188720"/>
+            <a:ext cx="2743200" cy="2286000"/>
+          </a:xfrm>
+          <a:prstGeom prst="rect">
+            <a:avLst/>
+          </a:prstGeom>
+          <a:solidFill>
+            <a:srgbClr val="FFFFFF"/>
+          </a:solidFill>
+          <a:ln w="9525">
+            <a:solidFill>
+              <a:srgbClr val="CFE0D6"/>
+            </a:solidFill>
+          </a:ln>
+        </p:spPr>
+        <p:style>
+          <a:lnRef idx="1">
+            <a:schemeClr val="accent1"/>
+          </a:lnRef>
+          <a:fillRef idx="3">
+            <a:schemeClr val="accent1"/>
+          </a:fillRef>
+          <a:effectRef idx="2">
+            <a:schemeClr val="accent1"/>
+          </a:effectRef>
+          <a:fontRef idx="minor">
+            <a:schemeClr val="lt1"/>
+          </a:fontRef>
+        </p:style>
+        <p:txBody>
+          <a:bodyPr rtlCol="0" anchor="ctr"/>
+          <a:lstStyle/>
+          <a:p>
+            <a:pPr algn="ctr"/>
+          </a:p>
+        </p:txBody>
+      </p:sp>
+      <p:sp>
+        <p:nvSpPr>
+          <p:cNvPr id="15" name="TextBox 14"/>
+          <p:cNvSpPr txBox="1"/>
+          <p:nvPr/>
+        </p:nvSpPr>
+        <p:spPr>
+          <a:xfrm>
+            <a:off x="9144000" y="1371600"/>
+            <a:ext cx="2743200" cy="1005840"/>
+          </a:xfrm>
+          <a:prstGeom prst="rect">
+            <a:avLst/>
+          </a:prstGeom>
+          <a:noFill/>
+        </p:spPr>
+        <p:txBody>
+          <a:bodyPr wrap="square">
+            <a:spAutoFit/>
+          </a:bodyPr>
+          <a:lstStyle/>
+          <a:p>
+            <a:pPr algn="ctr"/>
+            <a:r>
+              <a:rPr sz="3400" b="1" i="0">
+                <a:solidFill>
+                  <a:srgbClr val="23613F"/>
+                </a:solidFill>
+                <a:latin typeface="Calibri"/>
+              </a:rPr>
+              <a:t>9 994</a:t>
+            </a:r>
+          </a:p>
+        </p:txBody>
+      </p:sp>
+      <p:sp>
+        <p:nvSpPr>
+          <p:cNvPr id="16" name="TextBox 15"/>
+          <p:cNvSpPr txBox="1"/>
+          <p:nvPr/>
+        </p:nvSpPr>
+        <p:spPr>
+          <a:xfrm>
+            <a:off x="9144000" y="2423160"/>
+            <a:ext cx="2743200" cy="914400"/>
+          </a:xfrm>
+          <a:prstGeom prst="rect">
+            <a:avLst/>
+          </a:prstGeom>
+          <a:noFill/>
+        </p:spPr>
+        <p:txBody>
+          <a:bodyPr wrap="square">
+            <a:spAutoFit/>
+          </a:bodyPr>
+          <a:lstStyle/>
+          <a:p>
+            <a:pPr algn="ctr"/>
+            <a:r>
+              <a:rPr sz="1400" b="0" i="0">
+                <a:solidFill>
+                  <a:srgbClr val="577166"/>
+                </a:solidFill>
+                <a:latin typeface="Calibri"/>
+              </a:rPr>
+              <a:t>статей
+загружено в БД</a:t>
+            </a:r>
+          </a:p>
+        </p:txBody>
+      </p:sp>
+      <p:sp>
+        <p:nvSpPr>
+          <p:cNvPr id="17" name="TextBox 16"/>
+          <p:cNvSpPr txBox="1"/>
+          <p:nvPr/>
+        </p:nvSpPr>
+        <p:spPr>
+          <a:xfrm>
+            <a:off x="457200" y="3749039"/>
+            <a:ext cx="11247120" cy="1371600"/>
+          </a:xfrm>
+          <a:prstGeom prst="rect">
+            <a:avLst/>
+          </a:prstGeom>
+          <a:noFill/>
+        </p:spPr>
+        <p:txBody>
+          <a:bodyPr wrap="square">
+            <a:spAutoFit/>
+          </a:bodyPr>
+          <a:lstStyle/>
+          <a:p>
+            <a:pPr algn="l"/>
+            <a:r>
+              <a:rPr sz="1700" b="0" i="0">
+                <a:solidFill>
+                  <a:srgbClr val="122017"/>
+                </a:solidFill>
+                <a:latin typeface="Calibri"/>
+              </a:rPr>
+              <a:t>Традиционный поиск по ключевым словам находит конкретную статью,
+но не отвечает на более широкие вопросы: кто с кем сотрудничает,
+из каких стран приходят исследования, как менялась тематика со временем.</a:t>
+            </a:r>
+          </a:p>
+        </p:txBody>
+      </p:sp>
+      <p:sp>
+        <p:nvSpPr>
+          <p:cNvPr id="18" name="TextBox 17"/>
+          <p:cNvSpPr txBox="1"/>
+          <p:nvPr/>
+        </p:nvSpPr>
+        <p:spPr>
+          <a:xfrm>
+            <a:off x="457200" y="5303520"/>
+            <a:ext cx="11247120" cy="640080"/>
+          </a:xfrm>
+          <a:prstGeom prst="rect">
+            <a:avLst/>
+          </a:prstGeom>
+          <a:noFill/>
+        </p:spPr>
+        <p:txBody>
+          <a:bodyPr wrap="square">
+            <a:spAutoFit/>
+          </a:bodyPr>
+          <a:lstStyle/>
+          <a:p>
+            <a:pPr algn="l"/>
+            <a:r>
+              <a:rPr sz="1700" b="1" i="0">
+                <a:solidFill>
+                  <a:srgbClr val="23613F"/>
+                </a:solidFill>
+                <a:latin typeface="Calibri"/>
+              </a:rPr>
+              <a:t>Карта и граф превращают тысячи строк метаданных в наглядный научный ландшафт.</a:t>
+            </a:r>
+          </a:p>
+        </p:txBody>
+      </p:sp>
     </p:spTree>
   </p:cSld>
   <p:clrMapOvr>
@@ -8235,101 +8231,15 @@
             <a:spAutoFit/>
           </a:bodyPr>
           <a:lstStyle/>
-          <a:p/>
-          <a:p>
-            <a:pPr algn="l">
-              <a:spcBef>
-                <a:spcPts val="0"/>
-              </a:spcBef>
-            </a:pPr>
-            <a:r>
-              <a:rPr sz="1400" b="0" i="0">
-                <a:solidFill>
-                  <a:srgbClr val="122017"/>
-                </a:solidFill>
-                <a:latin typeface="Calibri"/>
-              </a:rPr>
-              <a:t>• Загрузить метаданные 10 000 публикаций из API OpenAlex</a:t>
-            </a:r>
-          </a:p>
-          <a:p>
-            <a:pPr algn="l">
-              <a:spcBef>
-                <a:spcPts val="400"/>
-              </a:spcBef>
-            </a:pPr>
-            <a:r>
-              <a:rPr sz="1400" b="0" i="0">
-                <a:solidFill>
-                  <a:srgbClr val="122017"/>
-                </a:solidFill>
-                <a:latin typeface="Calibri"/>
-              </a:rPr>
-              <a:t>  • Спроектировать базу данных PostgreSQL (7 таблиц)</a:t>
-            </a:r>
-          </a:p>
-          <a:p>
-            <a:pPr algn="l">
-              <a:spcBef>
-                <a:spcPts val="400"/>
-              </a:spcBef>
-            </a:pPr>
-            <a:r>
-              <a:rPr sz="1400" b="0" i="0">
-                <a:solidFill>
-                  <a:srgbClr val="122017"/>
-                </a:solidFill>
-                <a:latin typeface="Calibri"/>
-              </a:rPr>
-              <a:t>  • Геокодировать аффилиации авторов</a:t>
-            </a:r>
-          </a:p>
-          <a:p>
-            <a:pPr algn="l">
-              <a:spcBef>
-                <a:spcPts val="400"/>
-              </a:spcBef>
-            </a:pPr>
-            <a:r>
-              <a:rPr sz="1400" b="0" i="0">
-                <a:solidFill>
-                  <a:srgbClr val="122017"/>
-                </a:solidFill>
-                <a:latin typeface="Calibri"/>
-              </a:rPr>
-              <a:t>  • Реализовать интерактивную карту (Plotly)</a:t>
-            </a:r>
-          </a:p>
-          <a:p>
-            <a:pPr algn="l">
-              <a:spcBef>
-                <a:spcPts val="400"/>
-              </a:spcBef>
-            </a:pPr>
-            <a:r>
-              <a:rPr sz="1400" b="0" i="0">
-                <a:solidFill>
-                  <a:srgbClr val="122017"/>
-                </a:solidFill>
-                <a:latin typeface="Calibri"/>
-              </a:rPr>
-              <a:t>  • Реализовать граф связей (SVG, 5 режимов)</a:t>
-            </a:r>
-          </a:p>
-          <a:p>
-            <a:pPr algn="l">
-              <a:spcBef>
-                <a:spcPts val="400"/>
-              </a:spcBef>
-            </a:pPr>
-            <a:r>
-              <a:rPr sz="1400" b="0" i="0">
-                <a:solidFill>
-                  <a:srgbClr val="122017"/>
-                </a:solidFill>
-                <a:latin typeface="Calibri"/>
-              </a:rPr>
-              <a:t>  • Разработать REST API и браузерный интерфейс</a:t>
+          <a:p>
+            <a:r>
+              <a:rPr sz="1400"/>
+              <a:t>• Сбор данных из открытого API
+• Проектирование и наполнение базы данных
+• Географическая привязка организаций авторов
+• Реализация интерактивной карты публикаций
+• Построение графа связей между сущностями
+• Разработка серверного API и веб-интерфейса</a:t>
             </a:r>
           </a:p>
         </p:txBody>

</xml_diff>

<commit_message>
Rewrite tasks in perfective past tense on slide 4
</commit_message>
<xml_diff>
--- a/docs/Визуализация науки на основе метаданных публикаций и журналов.pptx
+++ b/docs/Визуализация науки на основе метаданных публикаций и журналов.pptx
@@ -8234,12 +8234,12 @@
           <a:p>
             <a:r>
               <a:rPr sz="1400"/>
-              <a:t>• Сбор данных из открытого API
-• Проектирование и наполнение базы данных
-• Географическая привязка организаций авторов
-• Реализация интерактивной карты публикаций
-• Построение графа связей между сущностями
-• Разработка серверного API и веб-интерфейса</a:t>
+              <a:t>• Собраны данные из открытого API OpenAlex
+• Спроектирована и наполнена реляционная база данных
+• Выполнена географическая привязка организаций авторов
+• Реализована интерактивная карта публикаций
+• Построен граф связей между публикациями, авторами и журналами
+• Разработаны серверный API и веб-интерфейс</a:t>
             </a:r>
           </a:p>
         </p:txBody>

</xml_diff>

<commit_message>
Expand comparison table: full words, larger size, full slide height
https://claude.ai/code/session_01JXZNXE9oVEv7rsUiTvXR5D
</commit_message>
<xml_diff>
--- a/docs/Визуализация науки на основе метаданных публикаций и журналов.pptx
+++ b/docs/Визуализация науки на основе метаданных публикаций и журналов.pptx
@@ -8484,8 +8484,8 @@
           <p:nvPr/>
         </p:nvGraphicFramePr>
         <p:xfrm>
-          <a:off x="200000" y="720000"/>
-          <a:ext cx="11788950" cy="6038000"/>
+          <a:off x="100000" y="680000"/>
+          <a:ext cx="11988950" cy="6128000"/>
         </p:xfrm>
         <a:graphic>
           <a:graphicData uri="http://schemas.openxmlformats.org/drawingml/2006/table">
@@ -8494,26 +8494,26 @@
                 <a:tableStyleId>{5C22544A-7EE6-4342-B048-85BDC9FD1C3A}</a:tableStyleId>
               </a:tblPr>
               <a:tblGrid>
-                <a:gridCol w="2100000"/>
-                <a:gridCol w="968895"/>
-                <a:gridCol w="968895"/>
-                <a:gridCol w="968895"/>
-                <a:gridCol w="968895"/>
-                <a:gridCol w="968895"/>
-                <a:gridCol w="968895"/>
-                <a:gridCol w="968895"/>
-                <a:gridCol w="968895"/>
-                <a:gridCol w="968895"/>
-                <a:gridCol w="968895"/>
+                <a:gridCol w="1350000"/>
+                <a:gridCol w="1063895"/>
+                <a:gridCol w="1063895"/>
+                <a:gridCol w="1063895"/>
+                <a:gridCol w="1063895"/>
+                <a:gridCol w="1063895"/>
+                <a:gridCol w="1063895"/>
+                <a:gridCol w="1063895"/>
+                <a:gridCol w="1063895"/>
+                <a:gridCol w="1063895"/>
+                <a:gridCol w="1063895"/>
               </a:tblGrid>
-              <a:tr h="670888">
-                <a:tc>
-                  <a:txBody>
-                    <a:bodyPr wrap="square"/>
-                    <a:lstStyle/>
-                    <a:p>
-                      <a:r>
-                        <a:rPr sz="750" b="1">
+              <a:tr h="612800">
+                <a:tc>
+                  <a:txBody>
+                    <a:bodyPr wrap="square"/>
+                    <a:lstStyle/>
+                    <a:p>
+                      <a:r>
+                        <a:rPr sz="900" b="1">
                           <a:solidFill>
                             <a:srgbClr val="FFFFFF"/>
                           </a:solidFill>
@@ -8534,7 +8534,7 @@
                     <a:lstStyle/>
                     <a:p>
                       <a:r>
-                        <a:rPr sz="750" b="1">
+                        <a:rPr sz="900" b="1">
                           <a:solidFill>
                             <a:srgbClr val="FFFFFF"/>
                           </a:solidFill>
@@ -8555,7 +8555,7 @@
                     <a:lstStyle/>
                     <a:p>
                       <a:r>
-                        <a:rPr sz="750" b="1">
+                        <a:rPr sz="900" b="1">
                           <a:solidFill>
                             <a:srgbClr val="FFFFFF"/>
                           </a:solidFill>
@@ -8576,7 +8576,7 @@
                     <a:lstStyle/>
                     <a:p>
                       <a:r>
-                        <a:rPr sz="750" b="1">
+                        <a:rPr sz="900" b="1">
                           <a:solidFill>
                             <a:srgbClr val="FFFFFF"/>
                           </a:solidFill>
@@ -8598,7 +8598,7 @@
                     <a:lstStyle/>
                     <a:p>
                       <a:r>
-                        <a:rPr sz="750" b="1">
+                        <a:rPr sz="900" b="1">
                           <a:solidFill>
                             <a:srgbClr val="FFFFFF"/>
                           </a:solidFill>
@@ -8619,7 +8619,7 @@
                     <a:lstStyle/>
                     <a:p>
                       <a:r>
-                        <a:rPr sz="750" b="1">
+                        <a:rPr sz="900" b="1">
                           <a:solidFill>
                             <a:srgbClr val="FFFFFF"/>
                           </a:solidFill>
@@ -8640,7 +8640,7 @@
                     <a:lstStyle/>
                     <a:p>
                       <a:r>
-                        <a:rPr sz="750" b="1">
+                        <a:rPr sz="900" b="1">
                           <a:solidFill>
                             <a:srgbClr val="FFFFFF"/>
                           </a:solidFill>
@@ -8661,7 +8661,7 @@
                     <a:lstStyle/>
                     <a:p>
                       <a:r>
-                        <a:rPr sz="750" b="1">
+                        <a:rPr sz="900" b="1">
                           <a:solidFill>
                             <a:srgbClr val="FFFFFF"/>
                           </a:solidFill>
@@ -8683,7 +8683,7 @@
                     <a:lstStyle/>
                     <a:p>
                       <a:r>
-                        <a:rPr sz="750" b="1">
+                        <a:rPr sz="900" b="1">
                           <a:solidFill>
                             <a:srgbClr val="FFFFFF"/>
                           </a:solidFill>
@@ -8704,7 +8704,7 @@
                     <a:lstStyle/>
                     <a:p>
                       <a:r>
-                        <a:rPr sz="750" b="1">
+                        <a:rPr sz="900" b="1">
                           <a:solidFill>
                             <a:srgbClr val="FFFFFF"/>
                           </a:solidFill>
@@ -8725,7 +8725,7 @@
                     <a:lstStyle/>
                     <a:p>
                       <a:r>
-                        <a:rPr sz="750" b="1">
+                        <a:rPr sz="900" b="1">
                           <a:solidFill>
                             <a:srgbClr val="FFFFFF"/>
                           </a:solidFill>
@@ -8742,14 +8742,257 @@
                   </a:tcPr>
                 </a:tc>
               </a:tr>
-              <a:tr h="670888">
-                <a:tc>
-                  <a:txBody>
-                    <a:bodyPr wrap="square"/>
-                    <a:lstStyle/>
-                    <a:p>
-                      <a:r>
-                        <a:rPr sz="700" b="1">
+              <a:tr h="612800">
+                <a:tc>
+                  <a:txBody>
+                    <a:bodyPr wrap="square"/>
+                    <a:lstStyle/>
+                    <a:p>
+                      <a:r>
+                        <a:rPr sz="900" b="1">
+                          <a:solidFill>
+                            <a:srgbClr val="FFFFFF"/>
+                          </a:solidFill>
+                        </a:rPr>
+                        <a:t>Год / статус
+(2025)</a:t>
+                      </a:r>
+                    </a:p>
+                  </a:txBody>
+                  <a:tcPr>
+                    <a:solidFill>
+                      <a:srgbClr val="2D5544"/>
+                    </a:solidFill>
+                  </a:tcPr>
+                </a:tc>
+                <a:tc>
+                  <a:txBody>
+                    <a:bodyPr wrap="square"/>
+                    <a:lstStyle/>
+                    <a:p>
+                      <a:r>
+                        <a:rPr sz="900" b="0">
+                          <a:solidFill>
+                            <a:srgbClr val="122017"/>
+                          </a:solidFill>
+                        </a:rPr>
+                        <a:t>2010
+активен</a:t>
+                      </a:r>
+                    </a:p>
+                  </a:txBody>
+                  <a:tcPr>
+                    <a:solidFill>
+                      <a:srgbClr val="F4FAF6"/>
+                    </a:solidFill>
+                  </a:tcPr>
+                </a:tc>
+                <a:tc>
+                  <a:txBody>
+                    <a:bodyPr wrap="square"/>
+                    <a:lstStyle/>
+                    <a:p>
+                      <a:r>
+                        <a:rPr sz="900" b="0">
+                          <a:solidFill>
+                            <a:srgbClr val="122017"/>
+                          </a:solidFill>
+                        </a:rPr>
+                        <a:t>2006
+активен</a:t>
+                      </a:r>
+                    </a:p>
+                  </a:txBody>
+                  <a:tcPr>
+                    <a:solidFill>
+                      <a:srgbClr val="F4FAF6"/>
+                    </a:solidFill>
+                  </a:tcPr>
+                </a:tc>
+                <a:tc>
+                  <a:txBody>
+                    <a:bodyPr wrap="square"/>
+                    <a:lstStyle/>
+                    <a:p>
+                      <a:r>
+                        <a:rPr sz="900" b="0">
+                          <a:solidFill>
+                            <a:srgbClr val="122017"/>
+                          </a:solidFill>
+                        </a:rPr>
+                        <a:t>2019
+активен</a:t>
+                      </a:r>
+                    </a:p>
+                  </a:txBody>
+                  <a:tcPr>
+                    <a:solidFill>
+                      <a:srgbClr val="F4FAF6"/>
+                    </a:solidFill>
+                  </a:tcPr>
+                </a:tc>
+                <a:tc>
+                  <a:txBody>
+                    <a:bodyPr wrap="square"/>
+                    <a:lstStyle/>
+                    <a:p>
+                      <a:r>
+                        <a:rPr sz="900" b="0">
+                          <a:solidFill>
+                            <a:srgbClr val="122017"/>
+                          </a:solidFill>
+                        </a:rPr>
+                        <a:t>2017
+активен</a:t>
+                      </a:r>
+                    </a:p>
+                  </a:txBody>
+                  <a:tcPr>
+                    <a:solidFill>
+                      <a:srgbClr val="F4FAF6"/>
+                    </a:solidFill>
+                  </a:tcPr>
+                </a:tc>
+                <a:tc>
+                  <a:txBody>
+                    <a:bodyPr wrap="square"/>
+                    <a:lstStyle/>
+                    <a:p>
+                      <a:r>
+                        <a:rPr sz="900" b="0">
+                          <a:solidFill>
+                            <a:srgbClr val="122017"/>
+                          </a:solidFill>
+                        </a:rPr>
+                        <a:t>2008
+активен</a:t>
+                      </a:r>
+                    </a:p>
+                  </a:txBody>
+                  <a:tcPr>
+                    <a:solidFill>
+                      <a:srgbClr val="F4FAF6"/>
+                    </a:solidFill>
+                  </a:tcPr>
+                </a:tc>
+                <a:tc>
+                  <a:txBody>
+                    <a:bodyPr wrap="square"/>
+                    <a:lstStyle/>
+                    <a:p>
+                      <a:r>
+                        <a:rPr sz="900" b="0">
+                          <a:solidFill>
+                            <a:srgbClr val="122017"/>
+                          </a:solidFill>
+                        </a:rPr>
+                        <a:t>2018
+активен</a:t>
+                      </a:r>
+                    </a:p>
+                  </a:txBody>
+                  <a:tcPr>
+                    <a:solidFill>
+                      <a:srgbClr val="F4FAF6"/>
+                    </a:solidFill>
+                  </a:tcPr>
+                </a:tc>
+                <a:tc>
+                  <a:txBody>
+                    <a:bodyPr wrap="square"/>
+                    <a:lstStyle/>
+                    <a:p>
+                      <a:r>
+                        <a:rPr sz="900" b="0">
+                          <a:solidFill>
+                            <a:srgbClr val="122017"/>
+                          </a:solidFill>
+                        </a:rPr>
+                        <a:t>2020
+активен</a:t>
+                      </a:r>
+                    </a:p>
+                  </a:txBody>
+                  <a:tcPr>
+                    <a:solidFill>
+                      <a:srgbClr val="F4FAF6"/>
+                    </a:solidFill>
+                  </a:tcPr>
+                </a:tc>
+                <a:tc>
+                  <a:txBody>
+                    <a:bodyPr wrap="square"/>
+                    <a:lstStyle/>
+                    <a:p>
+                      <a:r>
+                        <a:rPr sz="900" b="0">
+                          <a:solidFill>
+                            <a:srgbClr val="122017"/>
+                          </a:solidFill>
+                        </a:rPr>
+                        <a:t>2021
+активен</a:t>
+                      </a:r>
+                    </a:p>
+                  </a:txBody>
+                  <a:tcPr>
+                    <a:solidFill>
+                      <a:srgbClr val="F4FAF6"/>
+                    </a:solidFill>
+                  </a:tcPr>
+                </a:tc>
+                <a:tc>
+                  <a:txBody>
+                    <a:bodyPr wrap="square"/>
+                    <a:lstStyle/>
+                    <a:p>
+                      <a:r>
+                        <a:rPr sz="900" b="0">
+                          <a:solidFill>
+                            <a:srgbClr val="122017"/>
+                          </a:solidFill>
+                        </a:rPr>
+                        <a:t>2021
+активен</a:t>
+                      </a:r>
+                    </a:p>
+                  </a:txBody>
+                  <a:tcPr>
+                    <a:solidFill>
+                      <a:srgbClr val="F4FAF6"/>
+                    </a:solidFill>
+                  </a:tcPr>
+                </a:tc>
+                <a:tc>
+                  <a:txBody>
+                    <a:bodyPr wrap="square"/>
+                    <a:lstStyle/>
+                    <a:p>
+                      <a:r>
+                        <a:rPr sz="900" b="1">
+                          <a:solidFill>
+                            <a:srgbClr val="1F493D"/>
+                          </a:solidFill>
+                        </a:rPr>
+                        <a:t>2024</a:t>
+                      </a:r>
+                    </a:p>
+                  </a:txBody>
+                  <a:tcPr>
+                    <a:solidFill>
+                      <a:srgbClr val="E8F5ED"/>
+                    </a:solidFill>
+                  </a:tcPr>
+                </a:tc>
+              </a:tr>
+              <a:tr h="612800">
+                <a:tc>
+                  <a:txBody>
+                    <a:bodyPr wrap="square"/>
+                    <a:lstStyle/>
+                    <a:p>
+                      <a:r>
+                        <a:rPr sz="900" b="1">
                           <a:solidFill>
                             <a:srgbClr val="FFFFFF"/>
                           </a:solidFill>
@@ -8770,14 +9013,18 @@
                     <a:lstStyle/>
                     <a:p>
                       <a:r>
-                        <a:rPr sz="700" b="0"/>
+                        <a:rPr sz="900" b="0">
+                          <a:solidFill>
+                            <a:srgbClr val="122017"/>
+                          </a:solidFill>
+                        </a:rPr>
                         <a:t>Десктоп</a:t>
                       </a:r>
                     </a:p>
                   </a:txBody>
                   <a:tcPr>
                     <a:solidFill>
-                      <a:srgbClr val="F4FAF6"/>
+                      <a:srgbClr val="FFFFFF"/>
                     </a:solidFill>
                   </a:tcPr>
                 </a:tc>
@@ -8787,15 +9034,19 @@
                     <a:lstStyle/>
                     <a:p>
                       <a:r>
-                        <a:rPr sz="700" b="0"/>
+                        <a:rPr sz="900" b="0">
+                          <a:solidFill>
+                            <a:srgbClr val="122017"/>
+                          </a:solidFill>
+                        </a:rPr>
                         <a:t>Десктоп
-+Java</a:t>
++ Java</a:t>
                       </a:r>
                     </a:p>
                   </a:txBody>
                   <a:tcPr>
                     <a:solidFill>
-                      <a:srgbClr val="F4FAF6"/>
+                      <a:srgbClr val="FFFFFF"/>
                     </a:solidFill>
                   </a:tcPr>
                 </a:tc>
@@ -8805,14 +9056,18 @@
                     <a:lstStyle/>
                     <a:p>
                       <a:r>
-                        <a:rPr sz="700" b="0"/>
+                        <a:rPr sz="900" b="0">
+                          <a:solidFill>
+                            <a:srgbClr val="122017"/>
+                          </a:solidFill>
+                        </a:rPr>
                         <a:t>Веб</a:t>
                       </a:r>
                     </a:p>
                   </a:txBody>
                   <a:tcPr>
                     <a:solidFill>
-                      <a:srgbClr val="F4FAF6"/>
+                      <a:srgbClr val="FFFFFF"/>
                     </a:solidFill>
                   </a:tcPr>
                 </a:tc>
@@ -8822,14 +9077,18 @@
                     <a:lstStyle/>
                     <a:p>
                       <a:r>
-                        <a:rPr sz="700" b="0"/>
+                        <a:rPr sz="900" b="0">
+                          <a:solidFill>
+                            <a:srgbClr val="122017"/>
+                          </a:solidFill>
+                        </a:rPr>
                         <a:t>R-пакет</a:t>
                       </a:r>
                     </a:p>
                   </a:txBody>
                   <a:tcPr>
                     <a:solidFill>
-                      <a:srgbClr val="F4FAF6"/>
+                      <a:srgbClr val="FFFFFF"/>
                     </a:solidFill>
                   </a:tcPr>
                 </a:tc>
@@ -8839,14 +9098,18 @@
                     <a:lstStyle/>
                     <a:p>
                       <a:r>
-                        <a:rPr sz="700" b="0"/>
+                        <a:rPr sz="900" b="0">
+                          <a:solidFill>
+                            <a:srgbClr val="122017"/>
+                          </a:solidFill>
+                        </a:rPr>
                         <a:t>Десктоп</a:t>
                       </a:r>
                     </a:p>
                   </a:txBody>
                   <a:tcPr>
                     <a:solidFill>
-                      <a:srgbClr val="F4FAF6"/>
+                      <a:srgbClr val="FFFFFF"/>
                     </a:solidFill>
                   </a:tcPr>
                 </a:tc>
@@ -8856,14 +9119,18 @@
                     <a:lstStyle/>
                     <a:p>
                       <a:r>
-                        <a:rPr sz="700" b="0"/>
+                        <a:rPr sz="900" b="0">
+                          <a:solidFill>
+                            <a:srgbClr val="122017"/>
+                          </a:solidFill>
+                        </a:rPr>
                         <a:t>Веб</a:t>
                       </a:r>
                     </a:p>
                   </a:txBody>
                   <a:tcPr>
                     <a:solidFill>
-                      <a:srgbClr val="F4FAF6"/>
+                      <a:srgbClr val="FFFFFF"/>
                     </a:solidFill>
                   </a:tcPr>
                 </a:tc>
@@ -8873,14 +9140,18 @@
                     <a:lstStyle/>
                     <a:p>
                       <a:r>
-                        <a:rPr sz="700" b="0"/>
+                        <a:rPr sz="900" b="0">
+                          <a:solidFill>
+                            <a:srgbClr val="122017"/>
+                          </a:solidFill>
+                        </a:rPr>
                         <a:t>Веб</a:t>
                       </a:r>
                     </a:p>
                   </a:txBody>
                   <a:tcPr>
                     <a:solidFill>
-                      <a:srgbClr val="F4FAF6"/>
+                      <a:srgbClr val="FFFFFF"/>
                     </a:solidFill>
                   </a:tcPr>
                 </a:tc>
@@ -8890,14 +9161,18 @@
                     <a:lstStyle/>
                     <a:p>
                       <a:r>
-                        <a:rPr sz="700" b="0"/>
+                        <a:rPr sz="900" b="0">
+                          <a:solidFill>
+                            <a:srgbClr val="122017"/>
+                          </a:solidFill>
+                        </a:rPr>
                         <a:t>Веб</a:t>
                       </a:r>
                     </a:p>
                   </a:txBody>
                   <a:tcPr>
                     <a:solidFill>
-                      <a:srgbClr val="F4FAF6"/>
+                      <a:srgbClr val="FFFFFF"/>
                     </a:solidFill>
                   </a:tcPr>
                 </a:tc>
@@ -8907,7 +9182,11 @@
                     <a:lstStyle/>
                     <a:p>
                       <a:r>
-                        <a:rPr sz="700" b="0"/>
+                        <a:rPr sz="900" b="0">
+                          <a:solidFill>
+                            <a:srgbClr val="122017"/>
+                          </a:solidFill>
+                        </a:rPr>
                         <a:t>Веб
 (freemium)</a:t>
                       </a:r>
@@ -8915,7 +9194,7 @@
                   </a:txBody>
                   <a:tcPr>
                     <a:solidFill>
-                      <a:srgbClr val="F4FAF6"/>
+                      <a:srgbClr val="FFFFFF"/>
                     </a:solidFill>
                   </a:tcPr>
                 </a:tc>
@@ -8925,7 +9204,7 @@
                     <a:lstStyle/>
                     <a:p>
                       <a:r>
-                        <a:rPr sz="700" b="1">
+                        <a:rPr sz="900" b="1">
                           <a:solidFill>
                             <a:srgbClr val="1F493D"/>
                           </a:solidFill>
@@ -8942,14 +9221,14 @@
                   </a:tcPr>
                 </a:tc>
               </a:tr>
-              <a:tr h="670888">
-                <a:tc>
-                  <a:txBody>
-                    <a:bodyPr wrap="square"/>
-                    <a:lstStyle/>
-                    <a:p>
-                      <a:r>
-                        <a:rPr sz="700" b="1">
+              <a:tr h="612800">
+                <a:tc>
+                  <a:txBody>
+                    <a:bodyPr wrap="square"/>
+                    <a:lstStyle/>
+                    <a:p>
+                      <a:r>
+                        <a:rPr sz="900" b="1">
                           <a:solidFill>
                             <a:srgbClr val="FFFFFF"/>
                           </a:solidFill>
@@ -8970,129 +9249,203 @@
                     <a:lstStyle/>
                     <a:p>
                       <a:r>
-                        <a:rPr sz="700" b="0"/>
-                        <a:t>✓</a:t>
-                      </a:r>
-                    </a:p>
-                  </a:txBody>
-                  <a:tcPr/>
-                </a:tc>
-                <a:tc>
-                  <a:txBody>
-                    <a:bodyPr wrap="square"/>
-                    <a:lstStyle/>
-                    <a:p>
-                      <a:r>
-                        <a:rPr sz="700" b="0"/>
-                        <a:t>✓</a:t>
-                      </a:r>
-                    </a:p>
-                  </a:txBody>
-                  <a:tcPr/>
-                </a:tc>
-                <a:tc>
-                  <a:txBody>
-                    <a:bodyPr wrap="square"/>
-                    <a:lstStyle/>
-                    <a:p>
-                      <a:r>
-                        <a:rPr sz="700" b="0"/>
-                        <a:t>5 гр./мес</a:t>
-                      </a:r>
-                    </a:p>
-                  </a:txBody>
-                  <a:tcPr/>
-                </a:tc>
-                <a:tc>
-                  <a:txBody>
-                    <a:bodyPr wrap="square"/>
-                    <a:lstStyle/>
-                    <a:p>
-                      <a:r>
-                        <a:rPr sz="700" b="0"/>
-                        <a:t>✓</a:t>
-                      </a:r>
-                    </a:p>
-                  </a:txBody>
-                  <a:tcPr/>
-                </a:tc>
-                <a:tc>
-                  <a:txBody>
-                    <a:bodyPr wrap="square"/>
-                    <a:lstStyle/>
-                    <a:p>
-                      <a:r>
-                        <a:rPr sz="700" b="0"/>
-                        <a:t>✓</a:t>
-                      </a:r>
-                    </a:p>
-                  </a:txBody>
-                  <a:tcPr/>
-                </a:tc>
-                <a:tc>
-                  <a:txBody>
-                    <a:bodyPr wrap="square"/>
-                    <a:lstStyle/>
-                    <a:p>
-                      <a:r>
-                        <a:rPr sz="700" b="0"/>
-                        <a:t>✓</a:t>
-                      </a:r>
-                    </a:p>
-                  </a:txBody>
-                  <a:tcPr/>
-                </a:tc>
-                <a:tc>
-                  <a:txBody>
-                    <a:bodyPr wrap="square"/>
-                    <a:lstStyle/>
-                    <a:p>
-                      <a:r>
-                        <a:rPr sz="700" b="0"/>
-                        <a:t>✓</a:t>
-                      </a:r>
-                    </a:p>
-                  </a:txBody>
-                  <a:tcPr/>
-                </a:tc>
-                <a:tc>
-                  <a:txBody>
-                    <a:bodyPr wrap="square"/>
-                    <a:lstStyle/>
-                    <a:p>
-                      <a:r>
-                        <a:rPr sz="700" b="0"/>
-                        <a:t>✓</a:t>
-                      </a:r>
-                    </a:p>
-                  </a:txBody>
-                  <a:tcPr/>
-                </a:tc>
-                <a:tc>
-                  <a:txBody>
-                    <a:bodyPr wrap="square"/>
-                    <a:lstStyle/>
-                    <a:p>
-                      <a:r>
-                        <a:rPr sz="700" b="0"/>
-                        <a:t>5 карт/мес</a:t>
-                      </a:r>
-                    </a:p>
-                  </a:txBody>
-                  <a:tcPr/>
-                </a:tc>
-                <a:tc>
-                  <a:txBody>
-                    <a:bodyPr wrap="square"/>
-                    <a:lstStyle/>
-                    <a:p>
-                      <a:r>
-                        <a:rPr sz="700" b="1">
+                        <a:rPr sz="900" b="0">
+                          <a:solidFill>
+                            <a:srgbClr val="122017"/>
+                          </a:solidFill>
+                        </a:rPr>
+                        <a:t>Да</a:t>
+                      </a:r>
+                    </a:p>
+                  </a:txBody>
+                  <a:tcPr>
+                    <a:solidFill>
+                      <a:srgbClr val="F4FAF6"/>
+                    </a:solidFill>
+                  </a:tcPr>
+                </a:tc>
+                <a:tc>
+                  <a:txBody>
+                    <a:bodyPr wrap="square"/>
+                    <a:lstStyle/>
+                    <a:p>
+                      <a:r>
+                        <a:rPr sz="900" b="0">
+                          <a:solidFill>
+                            <a:srgbClr val="122017"/>
+                          </a:solidFill>
+                        </a:rPr>
+                        <a:t>Да</a:t>
+                      </a:r>
+                    </a:p>
+                  </a:txBody>
+                  <a:tcPr>
+                    <a:solidFill>
+                      <a:srgbClr val="F4FAF6"/>
+                    </a:solidFill>
+                  </a:tcPr>
+                </a:tc>
+                <a:tc>
+                  <a:txBody>
+                    <a:bodyPr wrap="square"/>
+                    <a:lstStyle/>
+                    <a:p>
+                      <a:r>
+                        <a:rPr sz="900" b="0">
+                          <a:solidFill>
+                            <a:srgbClr val="122017"/>
+                          </a:solidFill>
+                        </a:rPr>
+                        <a:t>5 графов
+в месяц</a:t>
+                      </a:r>
+                    </a:p>
+                  </a:txBody>
+                  <a:tcPr>
+                    <a:solidFill>
+                      <a:srgbClr val="F4FAF6"/>
+                    </a:solidFill>
+                  </a:tcPr>
+                </a:tc>
+                <a:tc>
+                  <a:txBody>
+                    <a:bodyPr wrap="square"/>
+                    <a:lstStyle/>
+                    <a:p>
+                      <a:r>
+                        <a:rPr sz="900" b="0">
+                          <a:solidFill>
+                            <a:srgbClr val="122017"/>
+                          </a:solidFill>
+                        </a:rPr>
+                        <a:t>Да</a:t>
+                      </a:r>
+                    </a:p>
+                  </a:txBody>
+                  <a:tcPr>
+                    <a:solidFill>
+                      <a:srgbClr val="F4FAF6"/>
+                    </a:solidFill>
+                  </a:tcPr>
+                </a:tc>
+                <a:tc>
+                  <a:txBody>
+                    <a:bodyPr wrap="square"/>
+                    <a:lstStyle/>
+                    <a:p>
+                      <a:r>
+                        <a:rPr sz="900" b="0">
+                          <a:solidFill>
+                            <a:srgbClr val="122017"/>
+                          </a:solidFill>
+                        </a:rPr>
+                        <a:t>Да</a:t>
+                      </a:r>
+                    </a:p>
+                  </a:txBody>
+                  <a:tcPr>
+                    <a:solidFill>
+                      <a:srgbClr val="F4FAF6"/>
+                    </a:solidFill>
+                  </a:tcPr>
+                </a:tc>
+                <a:tc>
+                  <a:txBody>
+                    <a:bodyPr wrap="square"/>
+                    <a:lstStyle/>
+                    <a:p>
+                      <a:r>
+                        <a:rPr sz="900" b="0">
+                          <a:solidFill>
+                            <a:srgbClr val="122017"/>
+                          </a:solidFill>
+                        </a:rPr>
+                        <a:t>Да</a:t>
+                      </a:r>
+                    </a:p>
+                  </a:txBody>
+                  <a:tcPr>
+                    <a:solidFill>
+                      <a:srgbClr val="F4FAF6"/>
+                    </a:solidFill>
+                  </a:tcPr>
+                </a:tc>
+                <a:tc>
+                  <a:txBody>
+                    <a:bodyPr wrap="square"/>
+                    <a:lstStyle/>
+                    <a:p>
+                      <a:r>
+                        <a:rPr sz="900" b="0">
+                          <a:solidFill>
+                            <a:srgbClr val="122017"/>
+                          </a:solidFill>
+                        </a:rPr>
+                        <a:t>Да</a:t>
+                      </a:r>
+                    </a:p>
+                  </a:txBody>
+                  <a:tcPr>
+                    <a:solidFill>
+                      <a:srgbClr val="F4FAF6"/>
+                    </a:solidFill>
+                  </a:tcPr>
+                </a:tc>
+                <a:tc>
+                  <a:txBody>
+                    <a:bodyPr wrap="square"/>
+                    <a:lstStyle/>
+                    <a:p>
+                      <a:r>
+                        <a:rPr sz="900" b="0">
+                          <a:solidFill>
+                            <a:srgbClr val="122017"/>
+                          </a:solidFill>
+                        </a:rPr>
+                        <a:t>Да</a:t>
+                      </a:r>
+                    </a:p>
+                  </a:txBody>
+                  <a:tcPr>
+                    <a:solidFill>
+                      <a:srgbClr val="F4FAF6"/>
+                    </a:solidFill>
+                  </a:tcPr>
+                </a:tc>
+                <a:tc>
+                  <a:txBody>
+                    <a:bodyPr wrap="square"/>
+                    <a:lstStyle/>
+                    <a:p>
+                      <a:r>
+                        <a:rPr sz="900" b="0">
+                          <a:solidFill>
+                            <a:srgbClr val="122017"/>
+                          </a:solidFill>
+                        </a:rPr>
+                        <a:t>5 карт
+в месяц</a:t>
+                      </a:r>
+                    </a:p>
+                  </a:txBody>
+                  <a:tcPr>
+                    <a:solidFill>
+                      <a:srgbClr val="F4FAF6"/>
+                    </a:solidFill>
+                  </a:tcPr>
+                </a:tc>
+                <a:tc>
+                  <a:txBody>
+                    <a:bodyPr wrap="square"/>
+                    <a:lstStyle/>
+                    <a:p>
+                      <a:r>
+                        <a:rPr sz="900" b="1">
                           <a:solidFill>
                             <a:srgbClr val="1F493D"/>
                           </a:solidFill>
                         </a:rPr>
-                        <a:t>✓</a:t>
+                        <a:t>Да</a:t>
                       </a:r>
                     </a:p>
                   </a:txBody>
@@ -9103,19 +9456,20 @@
                   </a:tcPr>
                 </a:tc>
               </a:tr>
-              <a:tr h="670888">
-                <a:tc>
-                  <a:txBody>
-                    <a:bodyPr wrap="square"/>
-                    <a:lstStyle/>
-                    <a:p>
-                      <a:r>
-                        <a:rPr sz="700" b="1">
+              <a:tr h="612800">
+                <a:tc>
+                  <a:txBody>
+                    <a:bodyPr wrap="square"/>
+                    <a:lstStyle/>
+                    <a:p>
+                      <a:r>
+                        <a:rPr sz="900" b="1">
                           <a:solidFill>
                             <a:srgbClr val="FFFFFF"/>
                           </a:solidFill>
                         </a:rPr>
-                        <a:t>Установка не нужна</a:t>
+                        <a:t>Установка
+не нужна</a:t>
                       </a:r>
                     </a:p>
                   </a:txBody>
@@ -9131,8 +9485,247 @@
                     <a:lstStyle/>
                     <a:p>
                       <a:r>
-                        <a:rPr sz="700" b="0"/>
-                        <a:t>—</a:t>
+                        <a:rPr sz="900" b="0">
+                          <a:solidFill>
+                            <a:srgbClr val="122017"/>
+                          </a:solidFill>
+                        </a:rPr>
+                        <a:t>Нет</a:t>
+                      </a:r>
+                    </a:p>
+                  </a:txBody>
+                  <a:tcPr>
+                    <a:solidFill>
+                      <a:srgbClr val="FFFFFF"/>
+                    </a:solidFill>
+                  </a:tcPr>
+                </a:tc>
+                <a:tc>
+                  <a:txBody>
+                    <a:bodyPr wrap="square"/>
+                    <a:lstStyle/>
+                    <a:p>
+                      <a:r>
+                        <a:rPr sz="900" b="0">
+                          <a:solidFill>
+                            <a:srgbClr val="122017"/>
+                          </a:solidFill>
+                        </a:rPr>
+                        <a:t>Нет</a:t>
+                      </a:r>
+                    </a:p>
+                  </a:txBody>
+                  <a:tcPr>
+                    <a:solidFill>
+                      <a:srgbClr val="FFFFFF"/>
+                    </a:solidFill>
+                  </a:tcPr>
+                </a:tc>
+                <a:tc>
+                  <a:txBody>
+                    <a:bodyPr wrap="square"/>
+                    <a:lstStyle/>
+                    <a:p>
+                      <a:r>
+                        <a:rPr sz="900" b="0">
+                          <a:solidFill>
+                            <a:srgbClr val="122017"/>
+                          </a:solidFill>
+                        </a:rPr>
+                        <a:t>Да</a:t>
+                      </a:r>
+                    </a:p>
+                  </a:txBody>
+                  <a:tcPr>
+                    <a:solidFill>
+                      <a:srgbClr val="FFFFFF"/>
+                    </a:solidFill>
+                  </a:tcPr>
+                </a:tc>
+                <a:tc>
+                  <a:txBody>
+                    <a:bodyPr wrap="square"/>
+                    <a:lstStyle/>
+                    <a:p>
+                      <a:r>
+                        <a:rPr sz="900" b="0">
+                          <a:solidFill>
+                            <a:srgbClr val="122017"/>
+                          </a:solidFill>
+                        </a:rPr>
+                        <a:t>Нет</a:t>
+                      </a:r>
+                    </a:p>
+                  </a:txBody>
+                  <a:tcPr>
+                    <a:solidFill>
+                      <a:srgbClr val="FFFFFF"/>
+                    </a:solidFill>
+                  </a:tcPr>
+                </a:tc>
+                <a:tc>
+                  <a:txBody>
+                    <a:bodyPr wrap="square"/>
+                    <a:lstStyle/>
+                    <a:p>
+                      <a:r>
+                        <a:rPr sz="900" b="0">
+                          <a:solidFill>
+                            <a:srgbClr val="122017"/>
+                          </a:solidFill>
+                        </a:rPr>
+                        <a:t>Нет</a:t>
+                      </a:r>
+                    </a:p>
+                  </a:txBody>
+                  <a:tcPr>
+                    <a:solidFill>
+                      <a:srgbClr val="FFFFFF"/>
+                    </a:solidFill>
+                  </a:tcPr>
+                </a:tc>
+                <a:tc>
+                  <a:txBody>
+                    <a:bodyPr wrap="square"/>
+                    <a:lstStyle/>
+                    <a:p>
+                      <a:r>
+                        <a:rPr sz="900" b="0">
+                          <a:solidFill>
+                            <a:srgbClr val="122017"/>
+                          </a:solidFill>
+                        </a:rPr>
+                        <a:t>Да</a:t>
+                      </a:r>
+                    </a:p>
+                  </a:txBody>
+                  <a:tcPr>
+                    <a:solidFill>
+                      <a:srgbClr val="FFFFFF"/>
+                    </a:solidFill>
+                  </a:tcPr>
+                </a:tc>
+                <a:tc>
+                  <a:txBody>
+                    <a:bodyPr wrap="square"/>
+                    <a:lstStyle/>
+                    <a:p>
+                      <a:r>
+                        <a:rPr sz="900" b="0">
+                          <a:solidFill>
+                            <a:srgbClr val="122017"/>
+                          </a:solidFill>
+                        </a:rPr>
+                        <a:t>Да</a:t>
+                      </a:r>
+                    </a:p>
+                  </a:txBody>
+                  <a:tcPr>
+                    <a:solidFill>
+                      <a:srgbClr val="FFFFFF"/>
+                    </a:solidFill>
+                  </a:tcPr>
+                </a:tc>
+                <a:tc>
+                  <a:txBody>
+                    <a:bodyPr wrap="square"/>
+                    <a:lstStyle/>
+                    <a:p>
+                      <a:r>
+                        <a:rPr sz="900" b="0">
+                          <a:solidFill>
+                            <a:srgbClr val="122017"/>
+                          </a:solidFill>
+                        </a:rPr>
+                        <a:t>Да</a:t>
+                      </a:r>
+                    </a:p>
+                  </a:txBody>
+                  <a:tcPr>
+                    <a:solidFill>
+                      <a:srgbClr val="FFFFFF"/>
+                    </a:solidFill>
+                  </a:tcPr>
+                </a:tc>
+                <a:tc>
+                  <a:txBody>
+                    <a:bodyPr wrap="square"/>
+                    <a:lstStyle/>
+                    <a:p>
+                      <a:r>
+                        <a:rPr sz="900" b="0">
+                          <a:solidFill>
+                            <a:srgbClr val="122017"/>
+                          </a:solidFill>
+                        </a:rPr>
+                        <a:t>Да</a:t>
+                      </a:r>
+                    </a:p>
+                  </a:txBody>
+                  <a:tcPr>
+                    <a:solidFill>
+                      <a:srgbClr val="FFFFFF"/>
+                    </a:solidFill>
+                  </a:tcPr>
+                </a:tc>
+                <a:tc>
+                  <a:txBody>
+                    <a:bodyPr wrap="square"/>
+                    <a:lstStyle/>
+                    <a:p>
+                      <a:r>
+                        <a:rPr sz="900" b="1">
+                          <a:solidFill>
+                            <a:srgbClr val="1F493D"/>
+                          </a:solidFill>
+                        </a:rPr>
+                        <a:t>Да</a:t>
+                      </a:r>
+                    </a:p>
+                  </a:txBody>
+                  <a:tcPr>
+                    <a:solidFill>
+                      <a:srgbClr val="E8F5ED"/>
+                    </a:solidFill>
+                  </a:tcPr>
+                </a:tc>
+              </a:tr>
+              <a:tr h="612800">
+                <a:tc>
+                  <a:txBody>
+                    <a:bodyPr wrap="square"/>
+                    <a:lstStyle/>
+                    <a:p>
+                      <a:r>
+                        <a:rPr sz="900" b="1">
+                          <a:solidFill>
+                            <a:srgbClr val="FFFFFF"/>
+                          </a:solidFill>
+                        </a:rPr>
+                        <a:t>Источник
+данных</a:t>
+                      </a:r>
+                    </a:p>
+                  </a:txBody>
+                  <a:tcPr>
+                    <a:solidFill>
+                      <a:srgbClr val="2D5544"/>
+                    </a:solidFill>
+                  </a:tcPr>
+                </a:tc>
+                <a:tc>
+                  <a:txBody>
+                    <a:bodyPr wrap="square"/>
+                    <a:lstStyle/>
+                    <a:p>
+                      <a:r>
+                        <a:rPr sz="900" b="0">
+                          <a:solidFill>
+                            <a:srgbClr val="122017"/>
+                          </a:solidFill>
+                        </a:rPr>
+                        <a:t>WoS,
+Scopus</a:t>
                       </a:r>
                     </a:p>
                   </a:txBody>
@@ -9148,8 +9741,13 @@
                     <a:lstStyle/>
                     <a:p>
                       <a:r>
-                        <a:rPr sz="700" b="0"/>
-                        <a:t>—</a:t>
+                        <a:rPr sz="900" b="0">
+                          <a:solidFill>
+                            <a:srgbClr val="122017"/>
+                          </a:solidFill>
+                        </a:rPr>
+                        <a:t>WoS,
+Scopus</a:t>
                       </a:r>
                     </a:p>
                   </a:txBody>
@@ -9165,8 +9763,13 @@
                     <a:lstStyle/>
                     <a:p>
                       <a:r>
-                        <a:rPr sz="700" b="0"/>
-                        <a:t>✓</a:t>
+                        <a:rPr sz="900" b="0">
+                          <a:solidFill>
+                            <a:srgbClr val="122017"/>
+                          </a:solidFill>
+                        </a:rPr>
+                        <a:t>Semantic
+Scholar</a:t>
                       </a:r>
                     </a:p>
                   </a:txBody>
@@ -9182,8 +9785,13 @@
                     <a:lstStyle/>
                     <a:p>
                       <a:r>
-                        <a:rPr sz="700" b="0"/>
-                        <a:t>—</a:t>
+                        <a:rPr sz="900" b="0">
+                          <a:solidFill>
+                            <a:srgbClr val="122017"/>
+                          </a:solidFill>
+                        </a:rPr>
+                        <a:t>OpenAlex
+и другие</a:t>
                       </a:r>
                     </a:p>
                   </a:txBody>
@@ -9199,8 +9807,13 @@
                     <a:lstStyle/>
                     <a:p>
                       <a:r>
-                        <a:rPr sz="700" b="0"/>
-                        <a:t>—</a:t>
+                        <a:rPr sz="900" b="0">
+                          <a:solidFill>
+                            <a:srgbClr val="122017"/>
+                          </a:solidFill>
+                        </a:rPr>
+                        <a:t>Импорт
+файлов</a:t>
                       </a:r>
                     </a:p>
                   </a:txBody>
@@ -9216,8 +9829,13 @@
                     <a:lstStyle/>
                     <a:p>
                       <a:r>
-                        <a:rPr sz="700" b="0"/>
-                        <a:t>✓</a:t>
+                        <a:rPr sz="900" b="0">
+                          <a:solidFill>
+                            <a:srgbClr val="122017"/>
+                          </a:solidFill>
+                        </a:rPr>
+                        <a:t>225 млн
+статей</a:t>
                       </a:r>
                     </a:p>
                   </a:txBody>
@@ -9233,8 +9851,13 @@
                     <a:lstStyle/>
                     <a:p>
                       <a:r>
-                        <a:rPr sz="700" b="0"/>
-                        <a:t>✓</a:t>
+                        <a:rPr sz="900" b="0">
+                          <a:solidFill>
+                            <a:srgbClr val="122017"/>
+                          </a:solidFill>
+                        </a:rPr>
+                        <a:t>Semantic
+Scholar</a:t>
                       </a:r>
                     </a:p>
                   </a:txBody>
@@ -9250,8 +9873,12 @@
                     <a:lstStyle/>
                     <a:p>
                       <a:r>
-                        <a:rPr sz="700" b="0"/>
-                        <a:t>✓</a:t>
+                        <a:rPr sz="900" b="0">
+                          <a:solidFill>
+                            <a:srgbClr val="122017"/>
+                          </a:solidFill>
+                        </a:rPr>
+                        <a:t>OpenAlex</a:t>
                       </a:r>
                     </a:p>
                   </a:txBody>
@@ -9267,8 +9894,13 @@
                     <a:lstStyle/>
                     <a:p>
                       <a:r>
-                        <a:rPr sz="700" b="0"/>
-                        <a:t>✓</a:t>
+                        <a:rPr sz="900" b="0">
+                          <a:solidFill>
+                            <a:srgbClr val="122017"/>
+                          </a:solidFill>
+                        </a:rPr>
+                        <a:t>Semantic
+Scholar</a:t>
                       </a:r>
                     </a:p>
                   </a:txBody>
@@ -9284,12 +9916,12 @@
                     <a:lstStyle/>
                     <a:p>
                       <a:r>
-                        <a:rPr sz="700" b="1">
+                        <a:rPr sz="900" b="1">
                           <a:solidFill>
                             <a:srgbClr val="1F493D"/>
                           </a:solidFill>
                         </a:rPr>
-                        <a:t>✓</a:t>
+                        <a:t>OpenAlex</a:t>
                       </a:r>
                     </a:p>
                   </a:txBody>
@@ -9300,19 +9932,255 @@
                   </a:tcPr>
                 </a:tc>
               </a:tr>
-              <a:tr h="670888">
-                <a:tc>
-                  <a:txBody>
-                    <a:bodyPr wrap="square"/>
-                    <a:lstStyle/>
-                    <a:p>
-                      <a:r>
-                        <a:rPr sz="700" b="1">
+              <a:tr h="612800">
+                <a:tc>
+                  <a:txBody>
+                    <a:bodyPr wrap="square"/>
+                    <a:lstStyle/>
+                    <a:p>
+                      <a:r>
+                        <a:rPr sz="900" b="1">
                           <a:solidFill>
                             <a:srgbClr val="FFFFFF"/>
                           </a:solidFill>
                         </a:rPr>
-                        <a:t>Источник данных</a:t>
+                        <a:t>Карта
+аффилиаций</a:t>
+                      </a:r>
+                    </a:p>
+                  </a:txBody>
+                  <a:tcPr>
+                    <a:solidFill>
+                      <a:srgbClr val="3A6B55"/>
+                    </a:solidFill>
+                  </a:tcPr>
+                </a:tc>
+                <a:tc>
+                  <a:txBody>
+                    <a:bodyPr wrap="square"/>
+                    <a:lstStyle/>
+                    <a:p>
+                      <a:r>
+                        <a:rPr sz="900" b="0">
+                          <a:solidFill>
+                            <a:srgbClr val="122017"/>
+                          </a:solidFill>
+                        </a:rPr>
+                        <a:t>По странам</a:t>
+                      </a:r>
+                    </a:p>
+                  </a:txBody>
+                  <a:tcPr>
+                    <a:solidFill>
+                      <a:srgbClr val="FFFFFF"/>
+                    </a:solidFill>
+                  </a:tcPr>
+                </a:tc>
+                <a:tc>
+                  <a:txBody>
+                    <a:bodyPr wrap="square"/>
+                    <a:lstStyle/>
+                    <a:p>
+                      <a:r>
+                        <a:rPr sz="900" b="0">
+                          <a:solidFill>
+                            <a:srgbClr val="122017"/>
+                          </a:solidFill>
+                        </a:rPr>
+                        <a:t>По странам</a:t>
+                      </a:r>
+                    </a:p>
+                  </a:txBody>
+                  <a:tcPr>
+                    <a:solidFill>
+                      <a:srgbClr val="FFFFFF"/>
+                    </a:solidFill>
+                  </a:tcPr>
+                </a:tc>
+                <a:tc>
+                  <a:txBody>
+                    <a:bodyPr wrap="square"/>
+                    <a:lstStyle/>
+                    <a:p>
+                      <a:r>
+                        <a:rPr sz="900" b="0">
+                          <a:solidFill>
+                            <a:srgbClr val="122017"/>
+                          </a:solidFill>
+                        </a:rPr>
+                        <a:t>Нет</a:t>
+                      </a:r>
+                    </a:p>
+                  </a:txBody>
+                  <a:tcPr>
+                    <a:solidFill>
+                      <a:srgbClr val="FFFFFF"/>
+                    </a:solidFill>
+                  </a:tcPr>
+                </a:tc>
+                <a:tc>
+                  <a:txBody>
+                    <a:bodyPr wrap="square"/>
+                    <a:lstStyle/>
+                    <a:p>
+                      <a:r>
+                        <a:rPr sz="900" b="0">
+                          <a:solidFill>
+                            <a:srgbClr val="122017"/>
+                          </a:solidFill>
+                        </a:rPr>
+                        <a:t>По странам</a:t>
+                      </a:r>
+                    </a:p>
+                  </a:txBody>
+                  <a:tcPr>
+                    <a:solidFill>
+                      <a:srgbClr val="FFFFFF"/>
+                    </a:solidFill>
+                  </a:tcPr>
+                </a:tc>
+                <a:tc>
+                  <a:txBody>
+                    <a:bodyPr wrap="square"/>
+                    <a:lstStyle/>
+                    <a:p>
+                      <a:r>
+                        <a:rPr sz="900" b="0">
+                          <a:solidFill>
+                            <a:srgbClr val="122017"/>
+                          </a:solidFill>
+                        </a:rPr>
+                        <a:t>Нет</a:t>
+                      </a:r>
+                    </a:p>
+                  </a:txBody>
+                  <a:tcPr>
+                    <a:solidFill>
+                      <a:srgbClr val="FFFFFF"/>
+                    </a:solidFill>
+                  </a:tcPr>
+                </a:tc>
+                <a:tc>
+                  <a:txBody>
+                    <a:bodyPr wrap="square"/>
+                    <a:lstStyle/>
+                    <a:p>
+                      <a:r>
+                        <a:rPr sz="900" b="0">
+                          <a:solidFill>
+                            <a:srgbClr val="122017"/>
+                          </a:solidFill>
+                        </a:rPr>
+                        <a:t>По странам</a:t>
+                      </a:r>
+                    </a:p>
+                  </a:txBody>
+                  <a:tcPr>
+                    <a:solidFill>
+                      <a:srgbClr val="FFFFFF"/>
+                    </a:solidFill>
+                  </a:tcPr>
+                </a:tc>
+                <a:tc>
+                  <a:txBody>
+                    <a:bodyPr wrap="square"/>
+                    <a:lstStyle/>
+                    <a:p>
+                      <a:r>
+                        <a:rPr sz="900" b="0">
+                          <a:solidFill>
+                            <a:srgbClr val="122017"/>
+                          </a:solidFill>
+                        </a:rPr>
+                        <a:t>Нет</a:t>
+                      </a:r>
+                    </a:p>
+                  </a:txBody>
+                  <a:tcPr>
+                    <a:solidFill>
+                      <a:srgbClr val="FFFFFF"/>
+                    </a:solidFill>
+                  </a:tcPr>
+                </a:tc>
+                <a:tc>
+                  <a:txBody>
+                    <a:bodyPr wrap="square"/>
+                    <a:lstStyle/>
+                    <a:p>
+                      <a:r>
+                        <a:rPr sz="900" b="0">
+                          <a:solidFill>
+                            <a:srgbClr val="122017"/>
+                          </a:solidFill>
+                        </a:rPr>
+                        <a:t>Нет</a:t>
+                      </a:r>
+                    </a:p>
+                  </a:txBody>
+                  <a:tcPr>
+                    <a:solidFill>
+                      <a:srgbClr val="FFFFFF"/>
+                    </a:solidFill>
+                  </a:tcPr>
+                </a:tc>
+                <a:tc>
+                  <a:txBody>
+                    <a:bodyPr wrap="square"/>
+                    <a:lstStyle/>
+                    <a:p>
+                      <a:r>
+                        <a:rPr sz="900" b="0">
+                          <a:solidFill>
+                            <a:srgbClr val="122017"/>
+                          </a:solidFill>
+                        </a:rPr>
+                        <a:t>Нет</a:t>
+                      </a:r>
+                    </a:p>
+                  </a:txBody>
+                  <a:tcPr>
+                    <a:solidFill>
+                      <a:srgbClr val="FFFFFF"/>
+                    </a:solidFill>
+                  </a:tcPr>
+                </a:tc>
+                <a:tc>
+                  <a:txBody>
+                    <a:bodyPr wrap="square"/>
+                    <a:lstStyle/>
+                    <a:p>
+                      <a:r>
+                        <a:rPr sz="900" b="1">
+                          <a:solidFill>
+                            <a:srgbClr val="1F493D"/>
+                          </a:solidFill>
+                        </a:rPr>
+                        <a:t>Да,
+координаты</a:t>
+                      </a:r>
+                    </a:p>
+                  </a:txBody>
+                  <a:tcPr>
+                    <a:solidFill>
+                      <a:srgbClr val="E8F5ED"/>
+                    </a:solidFill>
+                  </a:tcPr>
+                </a:tc>
+              </a:tr>
+              <a:tr h="612800">
+                <a:tc>
+                  <a:txBody>
+                    <a:bodyPr wrap="square"/>
+                    <a:lstStyle/>
+                    <a:p>
+                      <a:r>
+                        <a:rPr sz="900" b="1">
+                          <a:solidFill>
+                            <a:srgbClr val="FFFFFF"/>
+                          </a:solidFill>
+                        </a:rPr>
+                        <a:t>Граф
+связей</a:t>
                       </a:r>
                     </a:p>
                   </a:txBody>
@@ -9328,135 +10196,202 @@
                     <a:lstStyle/>
                     <a:p>
                       <a:r>
-                        <a:rPr sz="700" b="0"/>
-                        <a:t>WoS/
-Scopus</a:t>
-                      </a:r>
-                    </a:p>
-                  </a:txBody>
-                  <a:tcPr/>
-                </a:tc>
-                <a:tc>
-                  <a:txBody>
-                    <a:bodyPr wrap="square"/>
-                    <a:lstStyle/>
-                    <a:p>
-                      <a:r>
-                        <a:rPr sz="700" b="0"/>
-                        <a:t>WoS/
-Scopus</a:t>
-                      </a:r>
-                    </a:p>
-                  </a:txBody>
-                  <a:tcPr/>
-                </a:tc>
-                <a:tc>
-                  <a:txBody>
-                    <a:bodyPr wrap="square"/>
-                    <a:lstStyle/>
-                    <a:p>
-                      <a:r>
-                        <a:rPr sz="700" b="0"/>
-                        <a:t>Semantic
-Scholar</a:t>
-                      </a:r>
-                    </a:p>
-                  </a:txBody>
-                  <a:tcPr/>
-                </a:tc>
-                <a:tc>
-                  <a:txBody>
-                    <a:bodyPr wrap="square"/>
-                    <a:lstStyle/>
-                    <a:p>
-                      <a:r>
-                        <a:rPr sz="700" b="0"/>
-                        <a:t>OpenAlex
-и др.</a:t>
-                      </a:r>
-                    </a:p>
-                  </a:txBody>
-                  <a:tcPr/>
-                </a:tc>
-                <a:tc>
-                  <a:txBody>
-                    <a:bodyPr wrap="square"/>
-                    <a:lstStyle/>
-                    <a:p>
-                      <a:r>
-                        <a:rPr sz="700" b="0"/>
-                        <a:t>Файлы</a:t>
-                      </a:r>
-                    </a:p>
-                  </a:txBody>
-                  <a:tcPr/>
-                </a:tc>
-                <a:tc>
-                  <a:txBody>
-                    <a:bodyPr wrap="square"/>
-                    <a:lstStyle/>
-                    <a:p>
-                      <a:r>
-                        <a:rPr sz="700" b="0"/>
-                        <a:t>225 млн</a:t>
-                      </a:r>
-                    </a:p>
-                  </a:txBody>
-                  <a:tcPr/>
-                </a:tc>
-                <a:tc>
-                  <a:txBody>
-                    <a:bodyPr wrap="square"/>
-                    <a:lstStyle/>
-                    <a:p>
-                      <a:r>
-                        <a:rPr sz="700" b="0"/>
-                        <a:t>Semantic
-Scholar</a:t>
-                      </a:r>
-                    </a:p>
-                  </a:txBody>
-                  <a:tcPr/>
-                </a:tc>
-                <a:tc>
-                  <a:txBody>
-                    <a:bodyPr wrap="square"/>
-                    <a:lstStyle/>
-                    <a:p>
-                      <a:r>
-                        <a:rPr sz="700" b="0"/>
-                        <a:t>OpenAlex</a:t>
-                      </a:r>
-                    </a:p>
-                  </a:txBody>
-                  <a:tcPr/>
-                </a:tc>
-                <a:tc>
-                  <a:txBody>
-                    <a:bodyPr wrap="square"/>
-                    <a:lstStyle/>
-                    <a:p>
-                      <a:r>
-                        <a:rPr sz="700" b="0"/>
-                        <a:t>Semantic
-Scholar</a:t>
-                      </a:r>
-                    </a:p>
-                  </a:txBody>
-                  <a:tcPr/>
-                </a:tc>
-                <a:tc>
-                  <a:txBody>
-                    <a:bodyPr wrap="square"/>
-                    <a:lstStyle/>
-                    <a:p>
-                      <a:r>
-                        <a:rPr sz="700" b="1">
+                        <a:rPr sz="900" b="0">
+                          <a:solidFill>
+                            <a:srgbClr val="122017"/>
+                          </a:solidFill>
+                        </a:rPr>
+                        <a:t>Да</a:t>
+                      </a:r>
+                    </a:p>
+                  </a:txBody>
+                  <a:tcPr>
+                    <a:solidFill>
+                      <a:srgbClr val="F4FAF6"/>
+                    </a:solidFill>
+                  </a:tcPr>
+                </a:tc>
+                <a:tc>
+                  <a:txBody>
+                    <a:bodyPr wrap="square"/>
+                    <a:lstStyle/>
+                    <a:p>
+                      <a:r>
+                        <a:rPr sz="900" b="0">
+                          <a:solidFill>
+                            <a:srgbClr val="122017"/>
+                          </a:solidFill>
+                        </a:rPr>
+                        <a:t>Да</a:t>
+                      </a:r>
+                    </a:p>
+                  </a:txBody>
+                  <a:tcPr>
+                    <a:solidFill>
+                      <a:srgbClr val="F4FAF6"/>
+                    </a:solidFill>
+                  </a:tcPr>
+                </a:tc>
+                <a:tc>
+                  <a:txBody>
+                    <a:bodyPr wrap="square"/>
+                    <a:lstStyle/>
+                    <a:p>
+                      <a:r>
+                        <a:rPr sz="900" b="0">
+                          <a:solidFill>
+                            <a:srgbClr val="122017"/>
+                          </a:solidFill>
+                        </a:rPr>
+                        <a:t>Да</a:t>
+                      </a:r>
+                    </a:p>
+                  </a:txBody>
+                  <a:tcPr>
+                    <a:solidFill>
+                      <a:srgbClr val="F4FAF6"/>
+                    </a:solidFill>
+                  </a:tcPr>
+                </a:tc>
+                <a:tc>
+                  <a:txBody>
+                    <a:bodyPr wrap="square"/>
+                    <a:lstStyle/>
+                    <a:p>
+                      <a:r>
+                        <a:rPr sz="900" b="0">
+                          <a:solidFill>
+                            <a:srgbClr val="122017"/>
+                          </a:solidFill>
+                        </a:rPr>
+                        <a:t>Да</a:t>
+                      </a:r>
+                    </a:p>
+                  </a:txBody>
+                  <a:tcPr>
+                    <a:solidFill>
+                      <a:srgbClr val="F4FAF6"/>
+                    </a:solidFill>
+                  </a:tcPr>
+                </a:tc>
+                <a:tc>
+                  <a:txBody>
+                    <a:bodyPr wrap="square"/>
+                    <a:lstStyle/>
+                    <a:p>
+                      <a:r>
+                        <a:rPr sz="900" b="0">
+                          <a:solidFill>
+                            <a:srgbClr val="122017"/>
+                          </a:solidFill>
+                        </a:rPr>
+                        <a:t>Да</a:t>
+                      </a:r>
+                    </a:p>
+                  </a:txBody>
+                  <a:tcPr>
+                    <a:solidFill>
+                      <a:srgbClr val="F4FAF6"/>
+                    </a:solidFill>
+                  </a:tcPr>
+                </a:tc>
+                <a:tc>
+                  <a:txBody>
+                    <a:bodyPr wrap="square"/>
+                    <a:lstStyle/>
+                    <a:p>
+                      <a:r>
+                        <a:rPr sz="900" b="0">
+                          <a:solidFill>
+                            <a:srgbClr val="122017"/>
+                          </a:solidFill>
+                        </a:rPr>
+                        <a:t>Нет</a:t>
+                      </a:r>
+                    </a:p>
+                  </a:txBody>
+                  <a:tcPr>
+                    <a:solidFill>
+                      <a:srgbClr val="F4FAF6"/>
+                    </a:solidFill>
+                  </a:tcPr>
+                </a:tc>
+                <a:tc>
+                  <a:txBody>
+                    <a:bodyPr wrap="square"/>
+                    <a:lstStyle/>
+                    <a:p>
+                      <a:r>
+                        <a:rPr sz="900" b="0">
+                          <a:solidFill>
+                            <a:srgbClr val="122017"/>
+                          </a:solidFill>
+                        </a:rPr>
+                        <a:t>Да</a:t>
+                      </a:r>
+                    </a:p>
+                  </a:txBody>
+                  <a:tcPr>
+                    <a:solidFill>
+                      <a:srgbClr val="F4FAF6"/>
+                    </a:solidFill>
+                  </a:tcPr>
+                </a:tc>
+                <a:tc>
+                  <a:txBody>
+                    <a:bodyPr wrap="square"/>
+                    <a:lstStyle/>
+                    <a:p>
+                      <a:r>
+                        <a:rPr sz="900" b="0">
+                          <a:solidFill>
+                            <a:srgbClr val="122017"/>
+                          </a:solidFill>
+                        </a:rPr>
+                        <a:t>Да</a:t>
+                      </a:r>
+                    </a:p>
+                  </a:txBody>
+                  <a:tcPr>
+                    <a:solidFill>
+                      <a:srgbClr val="F4FAF6"/>
+                    </a:solidFill>
+                  </a:tcPr>
+                </a:tc>
+                <a:tc>
+                  <a:txBody>
+                    <a:bodyPr wrap="square"/>
+                    <a:lstStyle/>
+                    <a:p>
+                      <a:r>
+                        <a:rPr sz="900" b="0">
+                          <a:solidFill>
+                            <a:srgbClr val="122017"/>
+                          </a:solidFill>
+                        </a:rPr>
+                        <a:t>Да</a:t>
+                      </a:r>
+                    </a:p>
+                  </a:txBody>
+                  <a:tcPr>
+                    <a:solidFill>
+                      <a:srgbClr val="F4FAF6"/>
+                    </a:solidFill>
+                  </a:tcPr>
+                </a:tc>
+                <a:tc>
+                  <a:txBody>
+                    <a:bodyPr wrap="square"/>
+                    <a:lstStyle/>
+                    <a:p>
+                      <a:r>
+                        <a:rPr sz="900" b="1">
                           <a:solidFill>
                             <a:srgbClr val="1F493D"/>
                           </a:solidFill>
                         </a:rPr>
-                        <a:t>OpenAlex</a:t>
+                        <a:t>Да,
+5 режимов</a:t>
                       </a:r>
                     </a:p>
                   </a:txBody>
@@ -9467,19 +10402,20 @@
                   </a:tcPr>
                 </a:tc>
               </a:tr>
-              <a:tr h="670888">
-                <a:tc>
-                  <a:txBody>
-                    <a:bodyPr wrap="square"/>
-                    <a:lstStyle/>
-                    <a:p>
-                      <a:r>
-                        <a:rPr sz="700" b="1">
+              <a:tr h="612800">
+                <a:tc>
+                  <a:txBody>
+                    <a:bodyPr wrap="square"/>
+                    <a:lstStyle/>
+                    <a:p>
+                      <a:r>
+                        <a:rPr sz="900" b="1">
                           <a:solidFill>
                             <a:srgbClr val="FFFFFF"/>
                           </a:solidFill>
                         </a:rPr>
-                        <a:t>Карта аффилиаций</a:t>
+                        <a:t>Фасетные
+фильтры</a:t>
                       </a:r>
                     </a:p>
                   </a:txBody>
@@ -9495,8 +10431,246 @@
                     <a:lstStyle/>
                     <a:p>
                       <a:r>
-                        <a:rPr sz="700" b="0"/>
-                        <a:t>Страны</a:t>
+                        <a:rPr sz="900" b="0">
+                          <a:solidFill>
+                            <a:srgbClr val="122017"/>
+                          </a:solidFill>
+                        </a:rPr>
+                        <a:t>Частично</a:t>
+                      </a:r>
+                    </a:p>
+                  </a:txBody>
+                  <a:tcPr>
+                    <a:solidFill>
+                      <a:srgbClr val="FFFFFF"/>
+                    </a:solidFill>
+                  </a:tcPr>
+                </a:tc>
+                <a:tc>
+                  <a:txBody>
+                    <a:bodyPr wrap="square"/>
+                    <a:lstStyle/>
+                    <a:p>
+                      <a:r>
+                        <a:rPr sz="900" b="0">
+                          <a:solidFill>
+                            <a:srgbClr val="122017"/>
+                          </a:solidFill>
+                        </a:rPr>
+                        <a:t>Нет</a:t>
+                      </a:r>
+                    </a:p>
+                  </a:txBody>
+                  <a:tcPr>
+                    <a:solidFill>
+                      <a:srgbClr val="FFFFFF"/>
+                    </a:solidFill>
+                  </a:tcPr>
+                </a:tc>
+                <a:tc>
+                  <a:txBody>
+                    <a:bodyPr wrap="square"/>
+                    <a:lstStyle/>
+                    <a:p>
+                      <a:r>
+                        <a:rPr sz="900" b="0">
+                          <a:solidFill>
+                            <a:srgbClr val="122017"/>
+                          </a:solidFill>
+                        </a:rPr>
+                        <a:t>Нет</a:t>
+                      </a:r>
+                    </a:p>
+                  </a:txBody>
+                  <a:tcPr>
+                    <a:solidFill>
+                      <a:srgbClr val="FFFFFF"/>
+                    </a:solidFill>
+                  </a:tcPr>
+                </a:tc>
+                <a:tc>
+                  <a:txBody>
+                    <a:bodyPr wrap="square"/>
+                    <a:lstStyle/>
+                    <a:p>
+                      <a:r>
+                        <a:rPr sz="900" b="0">
+                          <a:solidFill>
+                            <a:srgbClr val="122017"/>
+                          </a:solidFill>
+                        </a:rPr>
+                        <a:t>Да</a:t>
+                      </a:r>
+                    </a:p>
+                  </a:txBody>
+                  <a:tcPr>
+                    <a:solidFill>
+                      <a:srgbClr val="FFFFFF"/>
+                    </a:solidFill>
+                  </a:tcPr>
+                </a:tc>
+                <a:tc>
+                  <a:txBody>
+                    <a:bodyPr wrap="square"/>
+                    <a:lstStyle/>
+                    <a:p>
+                      <a:r>
+                        <a:rPr sz="900" b="0">
+                          <a:solidFill>
+                            <a:srgbClr val="122017"/>
+                          </a:solidFill>
+                        </a:rPr>
+                        <a:t>Да</a:t>
+                      </a:r>
+                    </a:p>
+                  </a:txBody>
+                  <a:tcPr>
+                    <a:solidFill>
+                      <a:srgbClr val="FFFFFF"/>
+                    </a:solidFill>
+                  </a:tcPr>
+                </a:tc>
+                <a:tc>
+                  <a:txBody>
+                    <a:bodyPr wrap="square"/>
+                    <a:lstStyle/>
+                    <a:p>
+                      <a:r>
+                        <a:rPr sz="900" b="0">
+                          <a:solidFill>
+                            <a:srgbClr val="122017"/>
+                          </a:solidFill>
+                        </a:rPr>
+                        <a:t>Да</a:t>
+                      </a:r>
+                    </a:p>
+                  </a:txBody>
+                  <a:tcPr>
+                    <a:solidFill>
+                      <a:srgbClr val="FFFFFF"/>
+                    </a:solidFill>
+                  </a:tcPr>
+                </a:tc>
+                <a:tc>
+                  <a:txBody>
+                    <a:bodyPr wrap="square"/>
+                    <a:lstStyle/>
+                    <a:p>
+                      <a:r>
+                        <a:rPr sz="900" b="0">
+                          <a:solidFill>
+                            <a:srgbClr val="122017"/>
+                          </a:solidFill>
+                        </a:rPr>
+                        <a:t>Нет</a:t>
+                      </a:r>
+                    </a:p>
+                  </a:txBody>
+                  <a:tcPr>
+                    <a:solidFill>
+                      <a:srgbClr val="FFFFFF"/>
+                    </a:solidFill>
+                  </a:tcPr>
+                </a:tc>
+                <a:tc>
+                  <a:txBody>
+                    <a:bodyPr wrap="square"/>
+                    <a:lstStyle/>
+                    <a:p>
+                      <a:r>
+                        <a:rPr sz="900" b="0">
+                          <a:solidFill>
+                            <a:srgbClr val="122017"/>
+                          </a:solidFill>
+                        </a:rPr>
+                        <a:t>Нет</a:t>
+                      </a:r>
+                    </a:p>
+                  </a:txBody>
+                  <a:tcPr>
+                    <a:solidFill>
+                      <a:srgbClr val="FFFFFF"/>
+                    </a:solidFill>
+                  </a:tcPr>
+                </a:tc>
+                <a:tc>
+                  <a:txBody>
+                    <a:bodyPr wrap="square"/>
+                    <a:lstStyle/>
+                    <a:p>
+                      <a:r>
+                        <a:rPr sz="900" b="0">
+                          <a:solidFill>
+                            <a:srgbClr val="122017"/>
+                          </a:solidFill>
+                        </a:rPr>
+                        <a:t>Нет</a:t>
+                      </a:r>
+                    </a:p>
+                  </a:txBody>
+                  <a:tcPr>
+                    <a:solidFill>
+                      <a:srgbClr val="FFFFFF"/>
+                    </a:solidFill>
+                  </a:tcPr>
+                </a:tc>
+                <a:tc>
+                  <a:txBody>
+                    <a:bodyPr wrap="square"/>
+                    <a:lstStyle/>
+                    <a:p>
+                      <a:r>
+                        <a:rPr sz="900" b="1">
+                          <a:solidFill>
+                            <a:srgbClr val="1F493D"/>
+                          </a:solidFill>
+                        </a:rPr>
+                        <a:t>Да</a:t>
+                      </a:r>
+                    </a:p>
+                  </a:txBody>
+                  <a:tcPr>
+                    <a:solidFill>
+                      <a:srgbClr val="E8F5ED"/>
+                    </a:solidFill>
+                  </a:tcPr>
+                </a:tc>
+              </a:tr>
+              <a:tr h="612800">
+                <a:tc>
+                  <a:txBody>
+                    <a:bodyPr wrap="square"/>
+                    <a:lstStyle/>
+                    <a:p>
+                      <a:r>
+                        <a:rPr sz="900" b="1">
+                          <a:solidFill>
+                            <a:srgbClr val="FFFFFF"/>
+                          </a:solidFill>
+                        </a:rPr>
+                        <a:t>Поиск
+похожих</a:t>
+                      </a:r>
+                    </a:p>
+                  </a:txBody>
+                  <a:tcPr>
+                    <a:solidFill>
+                      <a:srgbClr val="2D5544"/>
+                    </a:solidFill>
+                  </a:tcPr>
+                </a:tc>
+                <a:tc>
+                  <a:txBody>
+                    <a:bodyPr wrap="square"/>
+                    <a:lstStyle/>
+                    <a:p>
+                      <a:r>
+                        <a:rPr sz="900" b="0">
+                          <a:solidFill>
+                            <a:srgbClr val="122017"/>
+                          </a:solidFill>
+                        </a:rPr>
+                        <a:t>Нет</a:t>
                       </a:r>
                     </a:p>
                   </a:txBody>
@@ -9512,8 +10686,12 @@
                     <a:lstStyle/>
                     <a:p>
                       <a:r>
-                        <a:rPr sz="700" b="0"/>
-                        <a:t>Страны</a:t>
+                        <a:rPr sz="900" b="0">
+                          <a:solidFill>
+                            <a:srgbClr val="122017"/>
+                          </a:solidFill>
+                        </a:rPr>
+                        <a:t>Нет</a:t>
                       </a:r>
                     </a:p>
                   </a:txBody>
@@ -9529,8 +10707,12 @@
                     <a:lstStyle/>
                     <a:p>
                       <a:r>
-                        <a:rPr sz="700" b="0"/>
-                        <a:t>—</a:t>
+                        <a:rPr sz="900" b="0">
+                          <a:solidFill>
+                            <a:srgbClr val="122017"/>
+                          </a:solidFill>
+                        </a:rPr>
+                        <a:t>По цитир.</a:t>
                       </a:r>
                     </a:p>
                   </a:txBody>
@@ -9546,8 +10728,12 @@
                     <a:lstStyle/>
                     <a:p>
                       <a:r>
-                        <a:rPr sz="700" b="0"/>
-                        <a:t>Страны</a:t>
+                        <a:rPr sz="900" b="0">
+                          <a:solidFill>
+                            <a:srgbClr val="122017"/>
+                          </a:solidFill>
+                        </a:rPr>
+                        <a:t>Нет</a:t>
                       </a:r>
                     </a:p>
                   </a:txBody>
@@ -9563,8 +10749,12 @@
                     <a:lstStyle/>
                     <a:p>
                       <a:r>
-                        <a:rPr sz="700" b="0"/>
-                        <a:t>—</a:t>
+                        <a:rPr sz="900" b="0">
+                          <a:solidFill>
+                            <a:srgbClr val="122017"/>
+                          </a:solidFill>
+                        </a:rPr>
+                        <a:t>Нет</a:t>
                       </a:r>
                     </a:p>
                   </a:txBody>
@@ -9580,8 +10770,12 @@
                     <a:lstStyle/>
                     <a:p>
                       <a:r>
-                        <a:rPr sz="700" b="0"/>
-                        <a:t>Страны</a:t>
+                        <a:rPr sz="900" b="0">
+                          <a:solidFill>
+                            <a:srgbClr val="122017"/>
+                          </a:solidFill>
+                        </a:rPr>
+                        <a:t>Нет</a:t>
                       </a:r>
                     </a:p>
                   </a:txBody>
@@ -9597,8 +10791,12 @@
                     <a:lstStyle/>
                     <a:p>
                       <a:r>
-                        <a:rPr sz="700" b="0"/>
-                        <a:t>—</a:t>
+                        <a:rPr sz="900" b="0">
+                          <a:solidFill>
+                            <a:srgbClr val="122017"/>
+                          </a:solidFill>
+                        </a:rPr>
+                        <a:t>По цитир.</a:t>
                       </a:r>
                     </a:p>
                   </a:txBody>
@@ -9614,8 +10812,12 @@
                     <a:lstStyle/>
                     <a:p>
                       <a:r>
-                        <a:rPr sz="700" b="0"/>
-                        <a:t>—</a:t>
+                        <a:rPr sz="900" b="0">
+                          <a:solidFill>
+                            <a:srgbClr val="122017"/>
+                          </a:solidFill>
+                        </a:rPr>
+                        <a:t>По цитир.</a:t>
                       </a:r>
                     </a:p>
                   </a:txBody>
@@ -9631,8 +10833,12 @@
                     <a:lstStyle/>
                     <a:p>
                       <a:r>
-                        <a:rPr sz="700" b="0"/>
-                        <a:t>—</a:t>
+                        <a:rPr sz="900" b="0">
+                          <a:solidFill>
+                            <a:srgbClr val="122017"/>
+                          </a:solidFill>
+                        </a:rPr>
+                        <a:t>По цитир.</a:t>
                       </a:r>
                     </a:p>
                   </a:txBody>
@@ -9648,531 +10854,13 @@
                     <a:lstStyle/>
                     <a:p>
                       <a:r>
-                        <a:rPr sz="700" b="1">
+                        <a:rPr sz="900" b="1">
                           <a:solidFill>
                             <a:srgbClr val="1F493D"/>
                           </a:solidFill>
                         </a:rPr>
-                        <a:t>✓ Координаты</a:t>
-                      </a:r>
-                    </a:p>
-                  </a:txBody>
-                  <a:tcPr>
-                    <a:solidFill>
-                      <a:srgbClr val="E8F5ED"/>
-                    </a:solidFill>
-                  </a:tcPr>
-                </a:tc>
-              </a:tr>
-              <a:tr h="670888">
-                <a:tc>
-                  <a:txBody>
-                    <a:bodyPr wrap="square"/>
-                    <a:lstStyle/>
-                    <a:p>
-                      <a:r>
-                        <a:rPr sz="700" b="1">
-                          <a:solidFill>
-                            <a:srgbClr val="FFFFFF"/>
-                          </a:solidFill>
-                        </a:rPr>
-                        <a:t>Граф связей</a:t>
-                      </a:r>
-                    </a:p>
-                  </a:txBody>
-                  <a:tcPr>
-                    <a:solidFill>
-                      <a:srgbClr val="2D5544"/>
-                    </a:solidFill>
-                  </a:tcPr>
-                </a:tc>
-                <a:tc>
-                  <a:txBody>
-                    <a:bodyPr wrap="square"/>
-                    <a:lstStyle/>
-                    <a:p>
-                      <a:r>
-                        <a:rPr sz="700" b="0"/>
-                        <a:t>✓</a:t>
-                      </a:r>
-                    </a:p>
-                  </a:txBody>
-                  <a:tcPr/>
-                </a:tc>
-                <a:tc>
-                  <a:txBody>
-                    <a:bodyPr wrap="square"/>
-                    <a:lstStyle/>
-                    <a:p>
-                      <a:r>
-                        <a:rPr sz="700" b="0"/>
-                        <a:t>✓</a:t>
-                      </a:r>
-                    </a:p>
-                  </a:txBody>
-                  <a:tcPr/>
-                </a:tc>
-                <a:tc>
-                  <a:txBody>
-                    <a:bodyPr wrap="square"/>
-                    <a:lstStyle/>
-                    <a:p>
-                      <a:r>
-                        <a:rPr sz="700" b="0"/>
-                        <a:t>✓</a:t>
-                      </a:r>
-                    </a:p>
-                  </a:txBody>
-                  <a:tcPr/>
-                </a:tc>
-                <a:tc>
-                  <a:txBody>
-                    <a:bodyPr wrap="square"/>
-                    <a:lstStyle/>
-                    <a:p>
-                      <a:r>
-                        <a:rPr sz="700" b="0"/>
-                        <a:t>✓</a:t>
-                      </a:r>
-                    </a:p>
-                  </a:txBody>
-                  <a:tcPr/>
-                </a:tc>
-                <a:tc>
-                  <a:txBody>
-                    <a:bodyPr wrap="square"/>
-                    <a:lstStyle/>
-                    <a:p>
-                      <a:r>
-                        <a:rPr sz="700" b="0"/>
-                        <a:t>✓</a:t>
-                      </a:r>
-                    </a:p>
-                  </a:txBody>
-                  <a:tcPr/>
-                </a:tc>
-                <a:tc>
-                  <a:txBody>
-                    <a:bodyPr wrap="square"/>
-                    <a:lstStyle/>
-                    <a:p>
-                      <a:r>
-                        <a:rPr sz="700" b="0"/>
-                        <a:t>—</a:t>
-                      </a:r>
-                    </a:p>
-                  </a:txBody>
-                  <a:tcPr/>
-                </a:tc>
-                <a:tc>
-                  <a:txBody>
-                    <a:bodyPr wrap="square"/>
-                    <a:lstStyle/>
-                    <a:p>
-                      <a:r>
-                        <a:rPr sz="700" b="0"/>
-                        <a:t>✓</a:t>
-                      </a:r>
-                    </a:p>
-                  </a:txBody>
-                  <a:tcPr/>
-                </a:tc>
-                <a:tc>
-                  <a:txBody>
-                    <a:bodyPr wrap="square"/>
-                    <a:lstStyle/>
-                    <a:p>
-                      <a:r>
-                        <a:rPr sz="700" b="0"/>
-                        <a:t>✓</a:t>
-                      </a:r>
-                    </a:p>
-                  </a:txBody>
-                  <a:tcPr/>
-                </a:tc>
-                <a:tc>
-                  <a:txBody>
-                    <a:bodyPr wrap="square"/>
-                    <a:lstStyle/>
-                    <a:p>
-                      <a:r>
-                        <a:rPr sz="700" b="0"/>
-                        <a:t>✓</a:t>
-                      </a:r>
-                    </a:p>
-                  </a:txBody>
-                  <a:tcPr/>
-                </a:tc>
-                <a:tc>
-                  <a:txBody>
-                    <a:bodyPr wrap="square"/>
-                    <a:lstStyle/>
-                    <a:p>
-                      <a:r>
-                        <a:rPr sz="700" b="1">
-                          <a:solidFill>
-                            <a:srgbClr val="1F493D"/>
-                          </a:solidFill>
-                        </a:rPr>
-                        <a:t>✓ 5 режимов</a:t>
-                      </a:r>
-                    </a:p>
-                  </a:txBody>
-                  <a:tcPr>
-                    <a:solidFill>
-                      <a:srgbClr val="E8F5ED"/>
-                    </a:solidFill>
-                  </a:tcPr>
-                </a:tc>
-              </a:tr>
-              <a:tr h="670888">
-                <a:tc>
-                  <a:txBody>
-                    <a:bodyPr wrap="square"/>
-                    <a:lstStyle/>
-                    <a:p>
-                      <a:r>
-                        <a:rPr sz="700" b="1">
-                          <a:solidFill>
-                            <a:srgbClr val="FFFFFF"/>
-                          </a:solidFill>
-                        </a:rPr>
-                        <a:t>Фасет. фильтры</a:t>
-                      </a:r>
-                    </a:p>
-                  </a:txBody>
-                  <a:tcPr>
-                    <a:solidFill>
-                      <a:srgbClr val="3A6B55"/>
-                    </a:solidFill>
-                  </a:tcPr>
-                </a:tc>
-                <a:tc>
-                  <a:txBody>
-                    <a:bodyPr wrap="square"/>
-                    <a:lstStyle/>
-                    <a:p>
-                      <a:r>
-                        <a:rPr sz="700" b="0"/>
-                        <a:t>Частично</a:t>
-                      </a:r>
-                    </a:p>
-                  </a:txBody>
-                  <a:tcPr>
-                    <a:solidFill>
-                      <a:srgbClr val="F4FAF6"/>
-                    </a:solidFill>
-                  </a:tcPr>
-                </a:tc>
-                <a:tc>
-                  <a:txBody>
-                    <a:bodyPr wrap="square"/>
-                    <a:lstStyle/>
-                    <a:p>
-                      <a:r>
-                        <a:rPr sz="700" b="0"/>
-                        <a:t>—</a:t>
-                      </a:r>
-                    </a:p>
-                  </a:txBody>
-                  <a:tcPr>
-                    <a:solidFill>
-                      <a:srgbClr val="F4FAF6"/>
-                    </a:solidFill>
-                  </a:tcPr>
-                </a:tc>
-                <a:tc>
-                  <a:txBody>
-                    <a:bodyPr wrap="square"/>
-                    <a:lstStyle/>
-                    <a:p>
-                      <a:r>
-                        <a:rPr sz="700" b="0"/>
-                        <a:t>—</a:t>
-                      </a:r>
-                    </a:p>
-                  </a:txBody>
-                  <a:tcPr>
-                    <a:solidFill>
-                      <a:srgbClr val="F4FAF6"/>
-                    </a:solidFill>
-                  </a:tcPr>
-                </a:tc>
-                <a:tc>
-                  <a:txBody>
-                    <a:bodyPr wrap="square"/>
-                    <a:lstStyle/>
-                    <a:p>
-                      <a:r>
-                        <a:rPr sz="700" b="0"/>
-                        <a:t>✓</a:t>
-                      </a:r>
-                    </a:p>
-                  </a:txBody>
-                  <a:tcPr>
-                    <a:solidFill>
-                      <a:srgbClr val="F4FAF6"/>
-                    </a:solidFill>
-                  </a:tcPr>
-                </a:tc>
-                <a:tc>
-                  <a:txBody>
-                    <a:bodyPr wrap="square"/>
-                    <a:lstStyle/>
-                    <a:p>
-                      <a:r>
-                        <a:rPr sz="700" b="0"/>
-                        <a:t>✓</a:t>
-                      </a:r>
-                    </a:p>
-                  </a:txBody>
-                  <a:tcPr>
-                    <a:solidFill>
-                      <a:srgbClr val="F4FAF6"/>
-                    </a:solidFill>
-                  </a:tcPr>
-                </a:tc>
-                <a:tc>
-                  <a:txBody>
-                    <a:bodyPr wrap="square"/>
-                    <a:lstStyle/>
-                    <a:p>
-                      <a:r>
-                        <a:rPr sz="700" b="0"/>
-                        <a:t>✓</a:t>
-                      </a:r>
-                    </a:p>
-                  </a:txBody>
-                  <a:tcPr>
-                    <a:solidFill>
-                      <a:srgbClr val="F4FAF6"/>
-                    </a:solidFill>
-                  </a:tcPr>
-                </a:tc>
-                <a:tc>
-                  <a:txBody>
-                    <a:bodyPr wrap="square"/>
-                    <a:lstStyle/>
-                    <a:p>
-                      <a:r>
-                        <a:rPr sz="700" b="0"/>
-                        <a:t>—</a:t>
-                      </a:r>
-                    </a:p>
-                  </a:txBody>
-                  <a:tcPr>
-                    <a:solidFill>
-                      <a:srgbClr val="F4FAF6"/>
-                    </a:solidFill>
-                  </a:tcPr>
-                </a:tc>
-                <a:tc>
-                  <a:txBody>
-                    <a:bodyPr wrap="square"/>
-                    <a:lstStyle/>
-                    <a:p>
-                      <a:r>
-                        <a:rPr sz="700" b="0"/>
-                        <a:t>—</a:t>
-                      </a:r>
-                    </a:p>
-                  </a:txBody>
-                  <a:tcPr>
-                    <a:solidFill>
-                      <a:srgbClr val="F4FAF6"/>
-                    </a:solidFill>
-                  </a:tcPr>
-                </a:tc>
-                <a:tc>
-                  <a:txBody>
-                    <a:bodyPr wrap="square"/>
-                    <a:lstStyle/>
-                    <a:p>
-                      <a:r>
-                        <a:rPr sz="700" b="0"/>
-                        <a:t>—</a:t>
-                      </a:r>
-                    </a:p>
-                  </a:txBody>
-                  <a:tcPr>
-                    <a:solidFill>
-                      <a:srgbClr val="F4FAF6"/>
-                    </a:solidFill>
-                  </a:tcPr>
-                </a:tc>
-                <a:tc>
-                  <a:txBody>
-                    <a:bodyPr wrap="square"/>
-                    <a:lstStyle/>
-                    <a:p>
-                      <a:r>
-                        <a:rPr sz="700" b="1">
-                          <a:solidFill>
-                            <a:srgbClr val="1F493D"/>
-                          </a:solidFill>
-                        </a:rPr>
-                        <a:t>✓</a:t>
-                      </a:r>
-                    </a:p>
-                  </a:txBody>
-                  <a:tcPr>
-                    <a:solidFill>
-                      <a:srgbClr val="E8F5ED"/>
-                    </a:solidFill>
-                  </a:tcPr>
-                </a:tc>
-              </a:tr>
-              <a:tr h="670896">
-                <a:tc>
-                  <a:txBody>
-                    <a:bodyPr wrap="square"/>
-                    <a:lstStyle/>
-                    <a:p>
-                      <a:r>
-                        <a:rPr sz="700" b="1">
-                          <a:solidFill>
-                            <a:srgbClr val="FFFFFF"/>
-                          </a:solidFill>
-                        </a:rPr>
-                        <a:t>Похожие статьи</a:t>
-                      </a:r>
-                    </a:p>
-                  </a:txBody>
-                  <a:tcPr>
-                    <a:solidFill>
-                      <a:srgbClr val="2D5544"/>
-                    </a:solidFill>
-                  </a:tcPr>
-                </a:tc>
-                <a:tc>
-                  <a:txBody>
-                    <a:bodyPr wrap="square"/>
-                    <a:lstStyle/>
-                    <a:p>
-                      <a:r>
-                        <a:rPr sz="700" b="0"/>
-                        <a:t>—</a:t>
-                      </a:r>
-                    </a:p>
-                  </a:txBody>
-                  <a:tcPr/>
-                </a:tc>
-                <a:tc>
-                  <a:txBody>
-                    <a:bodyPr wrap="square"/>
-                    <a:lstStyle/>
-                    <a:p>
-                      <a:r>
-                        <a:rPr sz="700" b="0"/>
-                        <a:t>—</a:t>
-                      </a:r>
-                    </a:p>
-                  </a:txBody>
-                  <a:tcPr/>
-                </a:tc>
-                <a:tc>
-                  <a:txBody>
-                    <a:bodyPr wrap="square"/>
-                    <a:lstStyle/>
-                    <a:p>
-                      <a:r>
-                        <a:rPr sz="700" b="0"/>
-                        <a:t>Цит.</a:t>
-                      </a:r>
-                    </a:p>
-                  </a:txBody>
-                  <a:tcPr/>
-                </a:tc>
-                <a:tc>
-                  <a:txBody>
-                    <a:bodyPr wrap="square"/>
-                    <a:lstStyle/>
-                    <a:p>
-                      <a:r>
-                        <a:rPr sz="700" b="0"/>
-                        <a:t>—</a:t>
-                      </a:r>
-                    </a:p>
-                  </a:txBody>
-                  <a:tcPr/>
-                </a:tc>
-                <a:tc>
-                  <a:txBody>
-                    <a:bodyPr wrap="square"/>
-                    <a:lstStyle/>
-                    <a:p>
-                      <a:r>
-                        <a:rPr sz="700" b="0"/>
-                        <a:t>—</a:t>
-                      </a:r>
-                    </a:p>
-                  </a:txBody>
-                  <a:tcPr/>
-                </a:tc>
-                <a:tc>
-                  <a:txBody>
-                    <a:bodyPr wrap="square"/>
-                    <a:lstStyle/>
-                    <a:p>
-                      <a:r>
-                        <a:rPr sz="700" b="0"/>
-                        <a:t>—</a:t>
-                      </a:r>
-                    </a:p>
-                  </a:txBody>
-                  <a:tcPr/>
-                </a:tc>
-                <a:tc>
-                  <a:txBody>
-                    <a:bodyPr wrap="square"/>
-                    <a:lstStyle/>
-                    <a:p>
-                      <a:r>
-                        <a:rPr sz="700" b="0"/>
-                        <a:t>Цит.</a:t>
-                      </a:r>
-                    </a:p>
-                  </a:txBody>
-                  <a:tcPr/>
-                </a:tc>
-                <a:tc>
-                  <a:txBody>
-                    <a:bodyPr wrap="square"/>
-                    <a:lstStyle/>
-                    <a:p>
-                      <a:r>
-                        <a:rPr sz="700" b="0"/>
-                        <a:t>Цит.</a:t>
-                      </a:r>
-                    </a:p>
-                  </a:txBody>
-                  <a:tcPr/>
-                </a:tc>
-                <a:tc>
-                  <a:txBody>
-                    <a:bodyPr wrap="square"/>
-                    <a:lstStyle/>
-                    <a:p>
-                      <a:r>
-                        <a:rPr sz="700" b="0"/>
-                        <a:t>Цит.</a:t>
-                      </a:r>
-                    </a:p>
-                  </a:txBody>
-                  <a:tcPr/>
-                </a:tc>
-                <a:tc>
-                  <a:txBody>
-                    <a:bodyPr wrap="square"/>
-                    <a:lstStyle/>
-                    <a:p>
-                      <a:r>
-                        <a:rPr sz="700" b="1">
-                          <a:solidFill>
-                            <a:srgbClr val="1F493D"/>
-                          </a:solidFill>
-                        </a:rPr>
-                        <a:t>✓ 5 признаков</a:t>
+                        <a:t>Да,
+5 признаков</a:t>
                       </a:r>
                     </a:p>
                   </a:txBody>

</xml_diff>

<commit_message>
Remove glossary slide, add justifications to key slides
- Removed glossary slide from beginning
- Architecture: added technology justification (why PostgreSQL, SVG, OpenAlex)
- Geocoding: added explanation why not 100% coverage
- Graph: added explanation why not D3/Cytoscape
</commit_message>
<xml_diff>
--- a/docs/Визуализация науки на основе метаданных публикаций и журналов.pptx
+++ b/docs/Визуализация науки на основе метаданных публикаций и журналов.pptx
@@ -6,7 +6,6 @@
   </p:sldMasterIdLst>
   <p:sldIdLst>
     <p:sldId id="256" r:id="rId7"/>
-    <p:sldId id="267" r:id="rId18"/>
     <p:sldId id="258" r:id="rId9"/>
     <p:sldId id="257" r:id="rId8"/>
     <p:sldId id="269" r:id="rId20"/>
@@ -3541,6 +3540,17 @@
 • Лимит: 70 статей одновременно</a:t>
             </a:r>
           </a:p>
+          <a:p>
+            <a:r>
+              <a:rPr sz="1000">
+                <a:solidFill>
+                  <a:srgbClr val="557766"/>
+                </a:solidFill>
+              </a:rPr>
+              <a:t>
+Почему не D3/Cytoscape: стандартный force-directed при 70+ узлах даёт хаотичное расположение. Колоночная раскладка предсказуема и читаема при любом числе узлов.</a:t>
+            </a:r>
+          </a:p>
         </p:txBody>
       </p:sp>
       <p:sp>
@@ -5743,6 +5753,17 @@
               <a:t>git операции падали  →  Очистка %temp%</a:t>
             </a:r>
           </a:p>
+          <a:p>
+            <a:r>
+              <a:rPr sz="1000">
+                <a:solidFill>
+                  <a:srgbClr val="557766"/>
+                </a:solidFill>
+              </a:rPr>
+              <a:t>
+Почему не 100%: часть аффилиаций — строки без топонима (напр. «Department of Physics»). Геокодер не может определить координаты без названия места.</a:t>
+            </a:r>
+          </a:p>
         </p:txBody>
       </p:sp>
     </p:spTree>
@@ -6600,696 +6621,6 @@
           </a:p>
         </p:txBody>
       </p:sp>
-    </p:spTree>
-  </p:cSld>
-  <p:clrMapOvr>
-    <a:masterClrMapping/>
-  </p:clrMapOvr>
-</p:sld>
-</file>
-
-<file path=ppt/slides/slide2.xml><?xml version="1.0" encoding="utf-8"?>
-<p:sld xmlns:a="http://schemas.openxmlformats.org/drawingml/2006/main" xmlns:p="http://schemas.openxmlformats.org/presentationml/2006/main" xmlns:r="http://schemas.openxmlformats.org/officeDocument/2006/relationships">
-  <p:cSld>
-    <p:spTree>
-      <p:nvGrpSpPr>
-        <p:cNvPr id="1" name=""/>
-        <p:cNvGrpSpPr/>
-        <p:nvPr/>
-      </p:nvGrpSpPr>
-      <p:grpSpPr/>
-      <p:sp>
-        <p:nvSpPr>
-          <p:cNvPr id="2" name="TextBox 1"/>
-          <p:cNvSpPr txBox="1"/>
-          <p:nvPr/>
-        </p:nvSpPr>
-        <p:spPr>
-          <a:xfrm>
-            <a:off x="360000" y="200000"/>
-            <a:ext cx="11468952" cy="500000"/>
-          </a:xfrm>
-          <a:prstGeom prst="rect">
-            <a:avLst/>
-          </a:prstGeom>
-          <a:noFill/>
-        </p:spPr>
-        <p:txBody>
-          <a:bodyPr wrap="none">
-            <a:spAutoFit/>
-          </a:bodyPr>
-          <a:lstStyle/>
-          <a:p>
-            <a:pPr algn="ctr"/>
-            <a:r>
-              <a:rPr sz="2400" b="1">
-                <a:solidFill>
-                  <a:srgbClr val="1F497D"/>
-                </a:solidFill>
-              </a:rPr>
-              <a:t>Глоссарий</a:t>
-            </a:r>
-          </a:p>
-        </p:txBody>
-      </p:sp>
-      <p:graphicFrame>
-        <p:nvGraphicFramePr>
-          <p:cNvPr id="3" name="Table 2"/>
-          <p:cNvGraphicFramePr>
-            <a:graphicFrameLocks noGrp="1"/>
-          </p:cNvGraphicFramePr>
-          <p:nvPr/>
-        </p:nvGraphicFramePr>
-        <p:xfrm>
-          <a:off x="360000" y="750000"/>
-          <a:ext cx="5634476" cy="5958000"/>
-        </p:xfrm>
-        <a:graphic>
-          <a:graphicData uri="http://schemas.openxmlformats.org/drawingml/2006/table">
-            <a:tbl>
-              <a:tblPr firstRow="1" bandRow="1">
-                <a:tableStyleId>{5C22544A-7EE6-4342-B048-85BDC9FD1C3A}</a:tableStyleId>
-              </a:tblPr>
-              <a:tblGrid>
-                <a:gridCol w="2817238"/>
-                <a:gridCol w="2817238"/>
-              </a:tblGrid>
-              <a:tr h="541636">
-                <a:tc>
-                  <a:txBody>
-                    <a:bodyPr/>
-                    <a:lstStyle/>
-                    <a:p>
-                      <a:r>
-                        <a:t>Термин</a:t>
-                      </a:r>
-                    </a:p>
-                  </a:txBody>
-                  <a:tcPr/>
-                </a:tc>
-                <a:tc>
-                  <a:txBody>
-                    <a:bodyPr/>
-                    <a:lstStyle/>
-                    <a:p>
-                      <a:r>
-                        <a:t>Определение</a:t>
-                      </a:r>
-                    </a:p>
-                  </a:txBody>
-                  <a:tcPr/>
-                </a:tc>
-              </a:tr>
-              <a:tr h="541636">
-                <a:tc>
-                  <a:txBody>
-                    <a:bodyPr wrap="square"/>
-                    <a:lstStyle/>
-                    <a:p>
-                      <a:r>
-                        <a:rPr sz="800" b="1"/>
-                        <a:t>Метаданные публикации</a:t>
-                      </a:r>
-                    </a:p>
-                  </a:txBody>
-                  <a:tcPr/>
-                </a:tc>
-                <a:tc>
-                  <a:txBody>
-                    <a:bodyPr wrap="square"/>
-                    <a:lstStyle/>
-                    <a:p>
-                      <a:r>
-                        <a:rPr sz="800" b="0"/>
-                        <a:t>Название, авторы, год, журнал, DOI, темы — без полного текста</a:t>
-                      </a:r>
-                    </a:p>
-                  </a:txBody>
-                  <a:tcPr/>
-                </a:tc>
-              </a:tr>
-              <a:tr h="541636">
-                <a:tc>
-                  <a:txBody>
-                    <a:bodyPr wrap="square"/>
-                    <a:lstStyle/>
-                    <a:p>
-                      <a:r>
-                        <a:rPr sz="800" b="1"/>
-                        <a:t>OpenAlex</a:t>
-                      </a:r>
-                    </a:p>
-                  </a:txBody>
-                  <a:tcPr/>
-                </a:tc>
-                <a:tc>
-                  <a:txBody>
-                    <a:bodyPr wrap="square"/>
-                    <a:lstStyle/>
-                    <a:p>
-                      <a:r>
-                        <a:rPr sz="800" b="0"/>
-                        <a:t>Открытый бесплатный каталог научных публикаций; более 250 млн работ</a:t>
-                      </a:r>
-                    </a:p>
-                  </a:txBody>
-                  <a:tcPr/>
-                </a:tc>
-              </a:tr>
-              <a:tr h="541636">
-                <a:tc>
-                  <a:txBody>
-                    <a:bodyPr wrap="square"/>
-                    <a:lstStyle/>
-                    <a:p>
-                      <a:r>
-                        <a:rPr sz="800" b="1"/>
-                        <a:t>API</a:t>
-                      </a:r>
-                    </a:p>
-                  </a:txBody>
-                  <a:tcPr/>
-                </a:tc>
-                <a:tc>
-                  <a:txBody>
-                    <a:bodyPr wrap="square"/>
-                    <a:lstStyle/>
-                    <a:p>
-                      <a:r>
-                        <a:rPr sz="800" b="0"/>
-                        <a:t>Набор HTTP-запросов для получения данных из внешнего сервиса</a:t>
-                      </a:r>
-                    </a:p>
-                  </a:txBody>
-                  <a:tcPr/>
-                </a:tc>
-              </a:tr>
-              <a:tr h="541636">
-                <a:tc>
-                  <a:txBody>
-                    <a:bodyPr wrap="square"/>
-                    <a:lstStyle/>
-                    <a:p>
-                      <a:r>
-                        <a:rPr sz="800" b="1"/>
-                        <a:t>DOI</a:t>
-                      </a:r>
-                    </a:p>
-                  </a:txBody>
-                  <a:tcPr/>
-                </a:tc>
-                <a:tc>
-                  <a:txBody>
-                    <a:bodyPr wrap="square"/>
-                    <a:lstStyle/>
-                    <a:p>
-                      <a:r>
-                        <a:rPr sz="800" b="0"/>
-                        <a:t>Уникальный цифровой идентификатор научной публикации (10.XXXX/...)</a:t>
-                      </a:r>
-                    </a:p>
-                  </a:txBody>
-                  <a:tcPr/>
-                </a:tc>
-              </a:tr>
-              <a:tr h="541636">
-                <a:tc>
-                  <a:txBody>
-                    <a:bodyPr wrap="square"/>
-                    <a:lstStyle/>
-                    <a:p>
-                      <a:r>
-                        <a:rPr sz="800" b="1"/>
-                        <a:t>Аффилиация</a:t>
-                      </a:r>
-                    </a:p>
-                  </a:txBody>
-                  <a:tcPr/>
-                </a:tc>
-                <a:tc>
-                  <a:txBody>
-                    <a:bodyPr wrap="square"/>
-                    <a:lstStyle/>
-                    <a:p>
-                      <a:r>
-                        <a:rPr sz="800" b="0"/>
-                        <a:t>Организация, с которой связан автор на момент публикации</a:t>
-                      </a:r>
-                    </a:p>
-                  </a:txBody>
-                  <a:tcPr/>
-                </a:tc>
-              </a:tr>
-              <a:tr h="541636">
-                <a:tc>
-                  <a:txBody>
-                    <a:bodyPr wrap="square"/>
-                    <a:lstStyle/>
-                    <a:p>
-                      <a:r>
-                        <a:rPr sz="800" b="1"/>
-                        <a:t>Геокодирование</a:t>
-                      </a:r>
-                    </a:p>
-                  </a:txBody>
-                  <a:tcPr/>
-                </a:tc>
-                <a:tc>
-                  <a:txBody>
-                    <a:bodyPr wrap="square"/>
-                    <a:lstStyle/>
-                    <a:p>
-                      <a:r>
-                        <a:rPr sz="800" b="0"/>
-                        <a:t>Определение географических координат по названию места</a:t>
-                      </a:r>
-                    </a:p>
-                  </a:txBody>
-                  <a:tcPr/>
-                </a:tc>
-              </a:tr>
-              <a:tr h="541636">
-                <a:tc>
-                  <a:txBody>
-                    <a:bodyPr wrap="square"/>
-                    <a:lstStyle/>
-                    <a:p>
-                      <a:r>
-                        <a:rPr sz="800" b="1"/>
-                        <a:t>Граф</a:t>
-                      </a:r>
-                    </a:p>
-                  </a:txBody>
-                  <a:tcPr/>
-                </a:tc>
-                <a:tc>
-                  <a:txBody>
-                    <a:bodyPr wrap="square"/>
-                    <a:lstStyle/>
-                    <a:p>
-                      <a:r>
-                        <a:rPr sz="800" b="0"/>
-                        <a:t>Структура из узлов и рёбер; для визуализации отношений между объектами</a:t>
-                      </a:r>
-                    </a:p>
-                  </a:txBody>
-                  <a:tcPr/>
-                </a:tc>
-              </a:tr>
-              <a:tr h="541636">
-                <a:tc>
-                  <a:txBody>
-                    <a:bodyPr wrap="square"/>
-                    <a:lstStyle/>
-                    <a:p>
-                      <a:r>
-                        <a:rPr sz="800" b="1"/>
-                        <a:t>REST API</a:t>
-                      </a:r>
-                    </a:p>
-                  </a:txBody>
-                  <a:tcPr/>
-                </a:tc>
-                <a:tc>
-                  <a:txBody>
-                    <a:bodyPr wrap="square"/>
-                    <a:lstStyle/>
-                    <a:p>
-                      <a:r>
-                        <a:rPr sz="800" b="0"/>
-                        <a:t>Веб-сервис, где каждый ресурс доступен по URL через GET/POST</a:t>
-                      </a:r>
-                    </a:p>
-                  </a:txBody>
-                  <a:tcPr/>
-                </a:tc>
-              </a:tr>
-              <a:tr h="541636">
-                <a:tc>
-                  <a:txBody>
-                    <a:bodyPr wrap="square"/>
-                    <a:lstStyle/>
-                    <a:p>
-                      <a:r>
-                        <a:rPr sz="800" b="1"/>
-                        <a:t>PostgreSQL</a:t>
-                      </a:r>
-                    </a:p>
-                  </a:txBody>
-                  <a:tcPr/>
-                </a:tc>
-                <a:tc>
-                  <a:txBody>
-                    <a:bodyPr wrap="square"/>
-                    <a:lstStyle/>
-                    <a:p>
-                      <a:r>
-                        <a:rPr sz="800" b="0"/>
-                        <a:t>Реляционная СУБД с открытым исходным кодом</a:t>
-                      </a:r>
-                    </a:p>
-                  </a:txBody>
-                  <a:tcPr/>
-                </a:tc>
-              </a:tr>
-              <a:tr h="541640">
-                <a:tc>
-                  <a:txBody>
-                    <a:bodyPr wrap="square"/>
-                    <a:lstStyle/>
-                    <a:p>
-                      <a:r>
-                        <a:rPr sz="800" b="1"/>
-                        <a:t>gzip</a:t>
-                      </a:r>
-                    </a:p>
-                  </a:txBody>
-                  <a:tcPr/>
-                </a:tc>
-                <a:tc>
-                  <a:txBody>
-                    <a:bodyPr wrap="square"/>
-                    <a:lstStyle/>
-                    <a:p>
-                      <a:r>
-                        <a:rPr sz="800" b="0"/>
-                        <a:t>Алгоритм сжатия данных; уменьшает объём HTTP-ответов в 5–10 раз</a:t>
-                      </a:r>
-                    </a:p>
-                  </a:txBody>
-                  <a:tcPr/>
-                </a:tc>
-              </a:tr>
-            </a:tbl>
-          </a:graphicData>
-        </a:graphic>
-      </p:graphicFrame>
-      <p:graphicFrame>
-        <p:nvGraphicFramePr>
-          <p:cNvPr id="4" name="Table 3"/>
-          <p:cNvGraphicFramePr>
-            <a:graphicFrameLocks noGrp="1"/>
-          </p:cNvGraphicFramePr>
-          <p:nvPr/>
-        </p:nvGraphicFramePr>
-        <p:xfrm>
-          <a:off x="6194476" y="750000"/>
-          <a:ext cx="5634476" cy="5958000"/>
-        </p:xfrm>
-        <a:graphic>
-          <a:graphicData uri="http://schemas.openxmlformats.org/drawingml/2006/table">
-            <a:tbl>
-              <a:tblPr firstRow="1" bandRow="1">
-                <a:tableStyleId>{5C22544A-7EE6-4342-B048-85BDC9FD1C3A}</a:tableStyleId>
-              </a:tblPr>
-              <a:tblGrid>
-                <a:gridCol w="2817238"/>
-                <a:gridCol w="2817238"/>
-              </a:tblGrid>
-              <a:tr h="595800">
-                <a:tc>
-                  <a:txBody>
-                    <a:bodyPr wrap="square"/>
-                    <a:lstStyle/>
-                    <a:p>
-                      <a:r>
-                        <a:rPr sz="800" b="1"/>
-                        <a:t>Фасетная фильтрация</a:t>
-                      </a:r>
-                    </a:p>
-                  </a:txBody>
-                  <a:tcPr/>
-                </a:tc>
-                <a:tc>
-                  <a:txBody>
-                    <a:bodyPr wrap="square"/>
-                    <a:lstStyle/>
-                    <a:p>
-                      <a:r>
-                        <a:rPr sz="800"/>
-                        <a:t>Выбор в одном фильтре ограничивает варианты в других</a:t>
-                      </a:r>
-                    </a:p>
-                  </a:txBody>
-                  <a:tcPr/>
-                </a:tc>
-              </a:tr>
-              <a:tr h="595800">
-                <a:tc>
-                  <a:txBody>
-                    <a:bodyPr wrap="square"/>
-                    <a:lstStyle/>
-                    <a:p>
-                      <a:r>
-                        <a:rPr sz="800" b="1"/>
-                        <a:t>SVG</a:t>
-                      </a:r>
-                    </a:p>
-                  </a:txBody>
-                  <a:tcPr/>
-                </a:tc>
-                <a:tc>
-                  <a:txBody>
-                    <a:bodyPr wrap="square"/>
-                    <a:lstStyle/>
-                    <a:p>
-                      <a:r>
-                        <a:rPr sz="800"/>
-                        <a:t>XML-формат векторной графики в браузере; используется для графа</a:t>
-                      </a:r>
-                    </a:p>
-                  </a:txBody>
-                  <a:tcPr/>
-                </a:tc>
-              </a:tr>
-              <a:tr h="595800">
-                <a:tc>
-                  <a:txBody>
-                    <a:bodyPr wrap="square"/>
-                    <a:lstStyle/>
-                    <a:p>
-                      <a:r>
-                        <a:rPr sz="800" b="1"/>
-                        <a:t>Cursor pagination</a:t>
-                      </a:r>
-                    </a:p>
-                  </a:txBody>
-                  <a:tcPr/>
-                </a:tc>
-                <a:tc>
-                  <a:txBody>
-                    <a:bodyPr wrap="square"/>
-                    <a:lstStyle/>
-                    <a:p>
-                      <a:r>
-                        <a:rPr sz="800"/>
-                        <a:t>Постраничный обход через токены-курсоры без пропусков</a:t>
-                      </a:r>
-                    </a:p>
-                  </a:txBody>
-                  <a:tcPr/>
-                </a:tc>
-              </a:tr>
-              <a:tr h="595800">
-                <a:tc>
-                  <a:txBody>
-                    <a:bodyPr wrap="square"/>
-                    <a:lstStyle/>
-                    <a:p>
-                      <a:r>
-                        <a:rPr sz="800" b="1"/>
-                        <a:t>Библиометрия</a:t>
-                      </a:r>
-                    </a:p>
-                  </a:txBody>
-                  <a:tcPr/>
-                </a:tc>
-                <a:tc>
-                  <a:txBody>
-                    <a:bodyPr wrap="square"/>
-                    <a:lstStyle/>
-                    <a:p>
-                      <a:r>
-                        <a:rPr sz="800"/>
-                        <a:t>Количественный анализ публикаций: цитирования, коавторства</a:t>
-                      </a:r>
-                    </a:p>
-                  </a:txBody>
-                  <a:tcPr/>
-                </a:tc>
-              </a:tr>
-              <a:tr h="595800">
-                <a:tc>
-                  <a:txBody>
-                    <a:bodyPr wrap="square"/>
-                    <a:lstStyle/>
-                    <a:p>
-                      <a:r>
-                        <a:rPr sz="800" b="1"/>
-                        <a:t>Балл сходства</a:t>
-                      </a:r>
-                    </a:p>
-                  </a:txBody>
-                  <a:tcPr/>
-                </a:tc>
-                <a:tc>
-                  <a:txBody>
-                    <a:bodyPr wrap="square"/>
-                    <a:lstStyle/>
-                    <a:p>
-                      <a:r>
-                        <a:rPr sz="800"/>
-                        <a:t>Числовая мера близости двух публикаций по взвешенным признакам</a:t>
-                      </a:r>
-                    </a:p>
-                  </a:txBody>
-                  <a:tcPr/>
-                </a:tc>
-              </a:tr>
-              <a:tr h="595800">
-                <a:tc>
-                  <a:txBody>
-                    <a:bodyPr wrap="square"/>
-                    <a:lstStyle/>
-                    <a:p>
-                      <a:r>
-                        <a:rPr sz="800" b="1"/>
-                        <a:t>requestAnimationFrame</a:t>
-                      </a:r>
-                    </a:p>
-                  </a:txBody>
-                  <a:tcPr/>
-                </a:tc>
-                <a:tc>
-                  <a:txBody>
-                    <a:bodyPr wrap="square"/>
-                    <a:lstStyle/>
-                    <a:p>
-                      <a:r>
-                        <a:rPr sz="800"/>
-                        <a:t>Браузерный API для тяжёлых операций между кадрами</a:t>
-                      </a:r>
-                    </a:p>
-                  </a:txBody>
-                  <a:tcPr/>
-                </a:tc>
-              </a:tr>
-              <a:tr h="595800">
-                <a:tc>
-                  <a:txBody>
-                    <a:bodyPr wrap="square"/>
-                    <a:lstStyle/>
-                    <a:p>
-                      <a:r>
-                        <a:rPr sz="800" b="1"/>
-                        <a:t>ijson</a:t>
-                      </a:r>
-                    </a:p>
-                  </a:txBody>
-                  <a:tcPr/>
-                </a:tc>
-                <a:tc>
-                  <a:txBody>
-                    <a:bodyPr wrap="square"/>
-                    <a:lstStyle/>
-                    <a:p>
-                      <a:r>
-                        <a:rPr sz="800"/>
-                        <a:t>Python-библиотека для потокового чтения JSON без загрузки в память</a:t>
-                      </a:r>
-                    </a:p>
-                  </a:txBody>
-                  <a:tcPr/>
-                </a:tc>
-              </a:tr>
-              <a:tr h="595800">
-                <a:tc>
-                  <a:txBody>
-                    <a:bodyPr wrap="square"/>
-                    <a:lstStyle/>
-                    <a:p>
-                      <a:r>
-                        <a:rPr sz="800" b="1"/>
-                        <a:t>Savepoint</a:t>
-                      </a:r>
-                    </a:p>
-                  </a:txBody>
-                  <a:tcPr/>
-                </a:tc>
-                <a:tc>
-                  <a:txBody>
-                    <a:bodyPr wrap="square"/>
-                    <a:lstStyle/>
-                    <a:p>
-                      <a:r>
-                        <a:rPr sz="800"/>
-                        <a:t>Частичный откат транзакции PostgreSQL без потери остальных данных</a:t>
-                      </a:r>
-                    </a:p>
-                  </a:txBody>
-                  <a:tcPr/>
-                </a:tc>
-              </a:tr>
-              <a:tr h="595800">
-                <a:tc>
-                  <a:txBody>
-                    <a:bodyPr wrap="square"/>
-                    <a:lstStyle/>
-                    <a:p>
-                      <a:r>
-                        <a:rPr sz="800" b="1"/>
-                        <a:t>Force-directed layout</a:t>
-                      </a:r>
-                    </a:p>
-                  </a:txBody>
-                  <a:tcPr/>
-                </a:tc>
-                <a:tc>
-                  <a:txBody>
-                    <a:bodyPr wrap="square"/>
-                    <a:lstStyle/>
-                    <a:p>
-                      <a:r>
-                        <a:rPr sz="800"/>
-                        <a:t>Физическая симуляция размещения узлов графа</a:t>
-                      </a:r>
-                    </a:p>
-                  </a:txBody>
-                  <a:tcPr/>
-                </a:tc>
-              </a:tr>
-              <a:tr h="595800">
-                <a:tc>
-                  <a:txBody>
-                    <a:bodyPr wrap="square"/>
-                    <a:lstStyle/>
-                    <a:p>
-                      <a:r>
-                        <a:rPr sz="800" b="1"/>
-                        <a:t>Колоночная раскладка</a:t>
-                      </a:r>
-                    </a:p>
-                  </a:txBody>
-                  <a:tcPr/>
-                </a:tc>
-                <a:tc>
-                  <a:txBody>
-                    <a:bodyPr wrap="square"/>
-                    <a:lstStyle/>
-                    <a:p>
-                      <a:r>
-                        <a:rPr sz="800"/>
-                        <a:t>Каждый тип узла занимает фиксированную вертикальную колонку</a:t>
-                      </a:r>
-                    </a:p>
-                  </a:txBody>
-                  <a:tcPr/>
-                </a:tc>
-              </a:tr>
-            </a:tbl>
-          </a:graphicData>
-        </a:graphic>
-      </p:graphicFrame>
     </p:spTree>
   </p:cSld>
   <p:clrMapOvr>
@@ -14007,15 +13338,13 @@
           <a:p>
             <a:pPr algn="l"/>
             <a:r>
-              <a:rPr sz="1400" b="0" i="0">
-                <a:solidFill>
-                  <a:srgbClr val="122017"/>
-                </a:solidFill>
-                <a:latin typeface="Calibri"/>
-              </a:rPr>
-              <a:t>• requestAnimationFrame — карта и граф не блокируют UI
-• ijson — потоковое чтение 200 МБ JSON без MemoryError
-• gzip-сжатие ответов API — объём меньше в 5–10 раз</a:t>
+              <a:rPr sz="1100"/>
+              <a:t>Обоснование технологий:
+• PostgreSQL — реляционные связи и JOIN-запросы для фасетной фильтрации
+• SVG без библиотек — нужна колоночная раскладка (force-directed даёт хаос при 70+ узлах)
+• OpenAlex — единственный бесплатный источник с аффилиациями и API учреждений
+• gzip — ответы API меньше в 5–10 раз; ijson — чтение 200 МБ без MemoryError
+• requestAnimationFrame — отрисовка не блокирует интерфейс</a:t>
             </a:r>
           </a:p>
         </p:txBody>
@@ -15182,6 +14511,17 @@
                 <a:latin typeface="Calibri"/>
               </a:rPr>
               <a:t>Примечание: Nominatim заблокировал IP (HTTP 403) после нескольких прогонов — переключились на Photon</a:t>
+            </a:r>
+          </a:p>
+          <a:p>
+            <a:r>
+              <a:rPr sz="1000">
+                <a:solidFill>
+                  <a:srgbClr val="557766"/>
+                </a:solidFill>
+              </a:rPr>
+              <a:t>
+Почему не 100%: часть аффилиаций — строки без топонима (напр. «Department of Physics»). Геокодер не может определить координаты без названия места.</a:t>
             </a:r>
           </a:p>
         </p:txBody>

</xml_diff>

<commit_message>
fix(presentation): replace text-based charts with real bar charts; add DB schema table
- Slide 5: removed 30 text/rectangle "chart card" shapes, added two
  BAR_CLUSTERED charts (growing topics green/blue, declining topics red)
- Slide 7: replaced plain text DB schema wall with a formatted 8×3 table
  showing table name, purpose, and key fields; alternating row colors
</commit_message>
<xml_diff>
--- a/docs/Визуализация науки на основе метаданных публикаций и журналов.pptx
+++ b/docs/Визуализация науки на основе метаданных публикаций и журналов.pptx
@@ -117,6 +117,372 @@
     </a:lvl9pPr>
   </p:defaultTextStyle>
 </p:presentation>
+</file>
+
+<file path=ppt/charts/chart1.xml><?xml version="1.0" encoding="utf-8"?>
+<c:chartSpace xmlns:c="http://schemas.openxmlformats.org/drawingml/2006/chart" xmlns:a="http://schemas.openxmlformats.org/drawingml/2006/main" xmlns:r="http://schemas.openxmlformats.org/officeDocument/2006/relationships">
+  <c:date1904 val="0"/>
+  <c:chart>
+    <c:autoTitleDeleted val="1"/>
+    <c:plotArea>
+      <c:barChart>
+        <c:barDir val="bar"/>
+        <c:grouping val="clustered"/>
+        <c:ser>
+          <c:idx val="0"/>
+          <c:order val="0"/>
+          <c:tx>
+            <c:strRef>
+              <c:f>Sheet1!$B$1</c:f>
+              <c:strCache>
+                <c:ptCount val="1"/>
+                <c:pt idx="0">
+                  <c:v>2000–2012</c:v>
+                </c:pt>
+              </c:strCache>
+            </c:strRef>
+          </c:tx>
+          <c:spPr>
+            <a:solidFill>
+              <a:srgbClr val="AED6F1"/>
+            </a:solidFill>
+          </c:spPr>
+          <c:cat>
+            <c:strRef>
+              <c:f>Sheet1!$A$2:$A$5</c:f>
+              <c:strCache>
+                <c:ptCount val="4"/>
+                <c:pt idx="0">
+                  <c:v>Neural Nets</c:v>
+                </c:pt>
+                <c:pt idx="1">
+                  <c:v>COVID-19</c:v>
+                </c:pt>
+                <c:pt idx="2">
+                  <c:v>Domain Adapt.</c:v>
+                </c:pt>
+                <c:pt idx="3">
+                  <c:v>Cancer Screen.</c:v>
+                </c:pt>
+              </c:strCache>
+            </c:strRef>
+          </c:cat>
+          <c:val>
+            <c:numRef>
+              <c:f>Sheet1!$B$2:$B$5</c:f>
+              <c:numCache>
+                <c:formatCode>General</c:formatCode>
+                <c:ptCount val="4"/>
+                <c:pt idx="0">
+                  <c:v>0</c:v>
+                </c:pt>
+                <c:pt idx="1">
+                  <c:v>0</c:v>
+                </c:pt>
+                <c:pt idx="2">
+                  <c:v>3</c:v>
+                </c:pt>
+                <c:pt idx="3">
+                  <c:v>3</c:v>
+                </c:pt>
+              </c:numCache>
+            </c:numRef>
+          </c:val>
+        </c:ser>
+        <c:ser>
+          <c:idx val="1"/>
+          <c:order val="1"/>
+          <c:tx>
+            <c:strRef>
+              <c:f>Sheet1!$C$1</c:f>
+              <c:strCache>
+                <c:ptCount val="1"/>
+                <c:pt idx="0">
+                  <c:v>2013–2024</c:v>
+                </c:pt>
+              </c:strCache>
+            </c:strRef>
+          </c:tx>
+          <c:spPr>
+            <a:solidFill>
+              <a:srgbClr val="27AE60"/>
+            </a:solidFill>
+          </c:spPr>
+          <c:cat>
+            <c:strRef>
+              <c:f>Sheet1!$A$2:$A$5</c:f>
+              <c:strCache>
+                <c:ptCount val="4"/>
+                <c:pt idx="0">
+                  <c:v>Neural Nets</c:v>
+                </c:pt>
+                <c:pt idx="1">
+                  <c:v>COVID-19</c:v>
+                </c:pt>
+                <c:pt idx="2">
+                  <c:v>Domain Adapt.</c:v>
+                </c:pt>
+                <c:pt idx="3">
+                  <c:v>Cancer Screen.</c:v>
+                </c:pt>
+              </c:strCache>
+            </c:strRef>
+          </c:cat>
+          <c:val>
+            <c:numRef>
+              <c:f>Sheet1!$C$2:$C$5</c:f>
+              <c:numCache>
+                <c:formatCode>General</c:formatCode>
+                <c:ptCount val="4"/>
+                <c:pt idx="0">
+                  <c:v>25</c:v>
+                </c:pt>
+                <c:pt idx="1">
+                  <c:v>10</c:v>
+                </c:pt>
+                <c:pt idx="2">
+                  <c:v>15</c:v>
+                </c:pt>
+                <c:pt idx="3">
+                  <c:v>13</c:v>
+                </c:pt>
+              </c:numCache>
+            </c:numRef>
+          </c:val>
+        </c:ser>
+        <c:axId val="-2068027336"/>
+        <c:axId val="-2113994440"/>
+      </c:barChart>
+      <c:catAx>
+        <c:axId val="-2068027336"/>
+        <c:scaling>
+          <c:orientation val="minMax"/>
+        </c:scaling>
+        <c:delete val="0"/>
+        <c:axPos val="l"/>
+        <c:majorTickMark val="out"/>
+        <c:minorTickMark val="none"/>
+        <c:tickLblPos val="nextTo"/>
+        <c:crossAx val="-2113994440"/>
+        <c:crosses val="autoZero"/>
+        <c:auto val="1"/>
+        <c:lblAlgn val="ctr"/>
+        <c:lblOffset val="100"/>
+        <c:noMultiLvlLbl val="0"/>
+      </c:catAx>
+      <c:valAx>
+        <c:axId val="-2113994440"/>
+        <c:scaling/>
+        <c:delete val="0"/>
+        <c:axPos val="b"/>
+        <c:majorGridlines/>
+        <c:majorTickMark val="out"/>
+        <c:minorTickMark val="none"/>
+        <c:tickLblPos val="nextTo"/>
+        <c:crossAx val="-2068027336"/>
+        <c:crosses val="autoZero"/>
+      </c:valAx>
+    </c:plotArea>
+    <c:legend/>
+    <c:dispBlanksAs val="gap"/>
+  </c:chart>
+  <c:txPr>
+    <a:bodyPr/>
+    <a:lstStyle/>
+    <a:p>
+      <a:pPr>
+        <a:defRPr sz="1800"/>
+      </a:pPr>
+      <a:endParaRPr lang="en-US"/>
+    </a:p>
+  </c:txPr>
+  <c:externalData r:id="rId1">
+    <c:autoUpdate val="0"/>
+  </c:externalData>
+</c:chartSpace>
+</file>
+
+<file path=ppt/charts/chart2.xml><?xml version="1.0" encoding="utf-8"?>
+<c:chartSpace xmlns:c="http://schemas.openxmlformats.org/drawingml/2006/chart" xmlns:a="http://schemas.openxmlformats.org/drawingml/2006/main" xmlns:r="http://schemas.openxmlformats.org/officeDocument/2006/relationships">
+  <c:date1904 val="0"/>
+  <c:chart>
+    <c:autoTitleDeleted val="1"/>
+    <c:plotArea>
+      <c:barChart>
+        <c:barDir val="bar"/>
+        <c:grouping val="clustered"/>
+        <c:ser>
+          <c:idx val="0"/>
+          <c:order val="0"/>
+          <c:tx>
+            <c:strRef>
+              <c:f>Sheet1!$B$1</c:f>
+              <c:strCache>
+                <c:ptCount val="1"/>
+                <c:pt idx="0">
+                  <c:v>2000–2012</c:v>
+                </c:pt>
+              </c:strCache>
+            </c:strRef>
+          </c:tx>
+          <c:spPr>
+            <a:solidFill>
+              <a:srgbClr val="F5B7B1"/>
+            </a:solidFill>
+          </c:spPr>
+          <c:cat>
+            <c:strRef>
+              <c:f>Sheet1!$A$2:$A$5</c:f>
+              <c:strCache>
+                <c:ptCount val="4"/>
+                <c:pt idx="0">
+                  <c:v>Chem. Physics</c:v>
+                </c:pt>
+                <c:pt idx="1">
+                  <c:v>Graphene</c:v>
+                </c:pt>
+                <c:pt idx="2">
+                  <c:v>Battery Mat.</c:v>
+                </c:pt>
+                <c:pt idx="3">
+                  <c:v>Genomics</c:v>
+                </c:pt>
+              </c:strCache>
+            </c:strRef>
+          </c:cat>
+          <c:val>
+            <c:numRef>
+              <c:f>Sheet1!$B$2:$B$5</c:f>
+              <c:numCache>
+                <c:formatCode>General</c:formatCode>
+                <c:ptCount val="4"/>
+                <c:pt idx="0">
+                  <c:v>10</c:v>
+                </c:pt>
+                <c:pt idx="1">
+                  <c:v>8</c:v>
+                </c:pt>
+                <c:pt idx="2">
+                  <c:v>4</c:v>
+                </c:pt>
+                <c:pt idx="3">
+                  <c:v>4</c:v>
+                </c:pt>
+              </c:numCache>
+            </c:numRef>
+          </c:val>
+        </c:ser>
+        <c:ser>
+          <c:idx val="1"/>
+          <c:order val="1"/>
+          <c:tx>
+            <c:strRef>
+              <c:f>Sheet1!$C$1</c:f>
+              <c:strCache>
+                <c:ptCount val="1"/>
+                <c:pt idx="0">
+                  <c:v>2013–2024</c:v>
+                </c:pt>
+              </c:strCache>
+            </c:strRef>
+          </c:tx>
+          <c:spPr>
+            <a:solidFill>
+              <a:srgbClr val="C0392B"/>
+            </a:solidFill>
+          </c:spPr>
+          <c:cat>
+            <c:strRef>
+              <c:f>Sheet1!$A$2:$A$5</c:f>
+              <c:strCache>
+                <c:ptCount val="4"/>
+                <c:pt idx="0">
+                  <c:v>Chem. Physics</c:v>
+                </c:pt>
+                <c:pt idx="1">
+                  <c:v>Graphene</c:v>
+                </c:pt>
+                <c:pt idx="2">
+                  <c:v>Battery Mat.</c:v>
+                </c:pt>
+                <c:pt idx="3">
+                  <c:v>Genomics</c:v>
+                </c:pt>
+              </c:strCache>
+            </c:strRef>
+          </c:cat>
+          <c:val>
+            <c:numRef>
+              <c:f>Sheet1!$C$2:$C$5</c:f>
+              <c:numCache>
+                <c:formatCode>General</c:formatCode>
+                <c:ptCount val="4"/>
+                <c:pt idx="0">
+                  <c:v>0</c:v>
+                </c:pt>
+                <c:pt idx="1">
+                  <c:v>0</c:v>
+                </c:pt>
+                <c:pt idx="2">
+                  <c:v>0</c:v>
+                </c:pt>
+                <c:pt idx="3">
+                  <c:v>0</c:v>
+                </c:pt>
+              </c:numCache>
+            </c:numRef>
+          </c:val>
+        </c:ser>
+        <c:axId val="-2068027336"/>
+        <c:axId val="-2113994440"/>
+      </c:barChart>
+      <c:catAx>
+        <c:axId val="-2068027336"/>
+        <c:scaling>
+          <c:orientation val="minMax"/>
+        </c:scaling>
+        <c:delete val="0"/>
+        <c:axPos val="l"/>
+        <c:majorTickMark val="out"/>
+        <c:minorTickMark val="none"/>
+        <c:tickLblPos val="nextTo"/>
+        <c:crossAx val="-2113994440"/>
+        <c:crosses val="autoZero"/>
+        <c:auto val="1"/>
+        <c:lblAlgn val="ctr"/>
+        <c:lblOffset val="100"/>
+        <c:noMultiLvlLbl val="0"/>
+      </c:catAx>
+      <c:valAx>
+        <c:axId val="-2113994440"/>
+        <c:scaling/>
+        <c:delete val="0"/>
+        <c:axPos val="b"/>
+        <c:majorGridlines/>
+        <c:majorTickMark val="out"/>
+        <c:minorTickMark val="none"/>
+        <c:tickLblPos val="nextTo"/>
+        <c:crossAx val="-2068027336"/>
+        <c:crosses val="autoZero"/>
+      </c:valAx>
+    </c:plotArea>
+    <c:legend/>
+    <c:dispBlanksAs val="gap"/>
+  </c:chart>
+  <c:txPr>
+    <a:bodyPr/>
+    <a:lstStyle/>
+    <a:p>
+      <a:pPr>
+        <a:defRPr sz="1800"/>
+      </a:pPr>
+      <a:endParaRPr lang="en-US"/>
+    </a:p>
+  </c:txPr>
+  <c:externalData r:id="rId1">
+    <c:autoUpdate val="0"/>
+  </c:externalData>
+</c:chartSpace>
 </file>
 
 <file path=ppt/slideLayouts/slideLayout1.xml><?xml version="1.0" encoding="utf-8"?>
@@ -10375,8 +10741,8 @@
         </p:nvSpPr>
         <p:spPr>
           <a:xfrm>
-            <a:off x="200000" y="4510000"/>
-            <a:ext cx="5794476" cy="240000"/>
+            <a:off x="180000" y="4392000"/>
+            <a:ext cx="5940000" cy="251999"/>
           </a:xfrm>
           <a:prstGeom prst="rect">
             <a:avLst/>
@@ -10384,76 +10750,32 @@
           <a:noFill/>
         </p:spPr>
         <p:txBody>
-          <a:bodyPr wrap="square">
+          <a:bodyPr wrap="none">
             <a:spAutoFit/>
           </a:bodyPr>
           <a:lstStyle/>
           <a:p>
-            <a:pPr algn="l"/>
-            <a:r>
-              <a:rPr sz="1000" b="1">
-                <a:solidFill>
-                  <a:srgbClr val="1F493D"/>
-                </a:solidFill>
-              </a:rPr>
-              <a:t>Растущие темы (2013–2024 vs 2000–2012)</a:t>
-            </a:r>
-          </a:p>
-        </p:txBody>
-      </p:sp>
-      <p:sp>
-        <p:nvSpPr>
-          <p:cNvPr id="15" name="Rectangle 14"/>
-          <p:cNvSpPr/>
-          <p:nvPr/>
-        </p:nvSpPr>
-        <p:spPr>
-          <a:xfrm>
-            <a:off x="200000" y="4780000"/>
-            <a:ext cx="5794476" cy="390000"/>
-          </a:xfrm>
-          <a:prstGeom prst="rect">
-            <a:avLst/>
-          </a:prstGeom>
-          <a:solidFill>
-            <a:srgbClr val="EEF7F1"/>
-          </a:solidFill>
-          <a:ln>
-            <a:noFill/>
-          </a:ln>
-        </p:spPr>
-        <p:style>
-          <a:lnRef idx="1">
-            <a:schemeClr val="accent1"/>
-          </a:lnRef>
-          <a:fillRef idx="3">
-            <a:schemeClr val="accent1"/>
-          </a:fillRef>
-          <a:effectRef idx="2">
-            <a:schemeClr val="accent1"/>
-          </a:effectRef>
-          <a:fontRef idx="minor">
-            <a:schemeClr val="lt1"/>
-          </a:fontRef>
-        </p:style>
-        <p:txBody>
-          <a:bodyPr rtlCol="0" anchor="ctr"/>
-          <a:lstStyle/>
-          <a:p>
-            <a:pPr algn="ctr"/>
-          </a:p>
-        </p:txBody>
-      </p:sp>
-      <p:sp>
-        <p:nvSpPr>
-          <p:cNvPr id="16" name="TextBox 15"/>
+            <a:r>
+              <a:rPr sz="1200" b="1">
+                <a:solidFill>
+                  <a:srgbClr val="27AE60"/>
+                </a:solidFill>
+              </a:rPr>
+              <a:t>Растущие темы (2000–2012 vs 2013–2024)</a:t>
+            </a:r>
+          </a:p>
+        </p:txBody>
+      </p:sp>
+      <p:sp>
+        <p:nvSpPr>
+          <p:cNvPr id="15" name="TextBox 14"/>
           <p:cNvSpPr txBox="1"/>
           <p:nvPr/>
         </p:nvSpPr>
         <p:spPr>
           <a:xfrm>
-            <a:off x="260000" y="4810000"/>
-            <a:ext cx="5494476" cy="170000"/>
+            <a:off x="6192000" y="4392000"/>
+            <a:ext cx="5760000" cy="251999"/>
           </a:xfrm>
           <a:prstGeom prst="rect">
             <a:avLst/>
@@ -10461,1004 +10783,58 @@
           <a:noFill/>
         </p:spPr>
         <p:txBody>
-          <a:bodyPr wrap="square">
+          <a:bodyPr wrap="none">
             <a:spAutoFit/>
           </a:bodyPr>
           <a:lstStyle/>
           <a:p>
-            <a:pPr algn="l"/>
-            <a:r>
-              <a:rPr sz="900" b="0">
-                <a:solidFill>
-                  <a:srgbClr val="1F493D"/>
-                </a:solidFill>
-              </a:rPr>
-              <a:t>Neural Network Applications</a:t>
-            </a:r>
-          </a:p>
-        </p:txBody>
-      </p:sp>
-      <p:sp>
-        <p:nvSpPr>
-          <p:cNvPr id="17" name="TextBox 16"/>
-          <p:cNvSpPr txBox="1"/>
-          <p:nvPr/>
-        </p:nvSpPr>
-        <p:spPr>
-          <a:xfrm>
-            <a:off x="260000" y="4990000"/>
-            <a:ext cx="700000" cy="150000"/>
-          </a:xfrm>
-          <a:prstGeom prst="rect">
-            <a:avLst/>
-          </a:prstGeom>
-          <a:noFill/>
-        </p:spPr>
-        <p:txBody>
-          <a:bodyPr wrap="square">
-            <a:spAutoFit/>
-          </a:bodyPr>
-          <a:lstStyle/>
-          <a:p>
-            <a:pPr algn="l"/>
-            <a:r>
-              <a:rPr sz="900" b="1">
-                <a:solidFill>
-                  <a:srgbClr val="23613F"/>
-                </a:solidFill>
-              </a:rPr>
-              <a:t>0 → 25</a:t>
-            </a:r>
-          </a:p>
-        </p:txBody>
-      </p:sp>
-      <p:sp>
-        <p:nvSpPr>
-          <p:cNvPr id="18" name="TextBox 17"/>
-          <p:cNvSpPr txBox="1"/>
-          <p:nvPr/>
-        </p:nvSpPr>
-        <p:spPr>
-          <a:xfrm>
-            <a:off x="1000000" y="4990000"/>
-            <a:ext cx="700000" cy="150000"/>
-          </a:xfrm>
-          <a:prstGeom prst="rect">
-            <a:avLst/>
-          </a:prstGeom>
-          <a:noFill/>
-        </p:spPr>
-        <p:txBody>
-          <a:bodyPr wrap="square">
-            <a:spAutoFit/>
-          </a:bodyPr>
-          <a:lstStyle/>
-          <a:p>
-            <a:pPr algn="l"/>
-            <a:r>
-              <a:rPr sz="900" b="1">
-                <a:solidFill>
-                  <a:srgbClr val="6AAD8A"/>
-                </a:solidFill>
-              </a:rPr>
-              <a:t>новая</a:t>
-            </a:r>
-          </a:p>
-        </p:txBody>
-      </p:sp>
-      <p:sp>
-        <p:nvSpPr>
-          <p:cNvPr id="19" name="Rectangle 18"/>
-          <p:cNvSpPr/>
-          <p:nvPr/>
-        </p:nvSpPr>
-        <p:spPr>
-          <a:xfrm>
-            <a:off x="200000" y="5200000"/>
-            <a:ext cx="5794476" cy="390000"/>
-          </a:xfrm>
-          <a:prstGeom prst="rect">
-            <a:avLst/>
-          </a:prstGeom>
-          <a:solidFill>
-            <a:srgbClr val="EEF7F1"/>
-          </a:solidFill>
-          <a:ln>
-            <a:noFill/>
-          </a:ln>
-        </p:spPr>
-        <p:style>
-          <a:lnRef idx="1">
-            <a:schemeClr val="accent1"/>
-          </a:lnRef>
-          <a:fillRef idx="3">
-            <a:schemeClr val="accent1"/>
-          </a:fillRef>
-          <a:effectRef idx="2">
-            <a:schemeClr val="accent1"/>
-          </a:effectRef>
-          <a:fontRef idx="minor">
-            <a:schemeClr val="lt1"/>
-          </a:fontRef>
-        </p:style>
-        <p:txBody>
-          <a:bodyPr rtlCol="0" anchor="ctr"/>
-          <a:lstStyle/>
-          <a:p>
-            <a:pPr algn="ctr"/>
-          </a:p>
-        </p:txBody>
-      </p:sp>
-      <p:sp>
-        <p:nvSpPr>
-          <p:cNvPr id="20" name="TextBox 19"/>
-          <p:cNvSpPr txBox="1"/>
-          <p:nvPr/>
-        </p:nvSpPr>
-        <p:spPr>
-          <a:xfrm>
-            <a:off x="260000" y="5230000"/>
-            <a:ext cx="5494476" cy="170000"/>
-          </a:xfrm>
-          <a:prstGeom prst="rect">
-            <a:avLst/>
-          </a:prstGeom>
-          <a:noFill/>
-        </p:spPr>
-        <p:txBody>
-          <a:bodyPr wrap="square">
-            <a:spAutoFit/>
-          </a:bodyPr>
-          <a:lstStyle/>
-          <a:p>
-            <a:pPr algn="l"/>
-            <a:r>
-              <a:rPr sz="900" b="0">
-                <a:solidFill>
-                  <a:srgbClr val="1F493D"/>
-                </a:solidFill>
-              </a:rPr>
-              <a:t>COVID-19 Research</a:t>
-            </a:r>
-          </a:p>
-        </p:txBody>
-      </p:sp>
-      <p:sp>
-        <p:nvSpPr>
-          <p:cNvPr id="21" name="TextBox 20"/>
-          <p:cNvSpPr txBox="1"/>
-          <p:nvPr/>
-        </p:nvSpPr>
-        <p:spPr>
-          <a:xfrm>
-            <a:off x="260000" y="5410000"/>
-            <a:ext cx="700000" cy="150000"/>
-          </a:xfrm>
-          <a:prstGeom prst="rect">
-            <a:avLst/>
-          </a:prstGeom>
-          <a:noFill/>
-        </p:spPr>
-        <p:txBody>
-          <a:bodyPr wrap="square">
-            <a:spAutoFit/>
-          </a:bodyPr>
-          <a:lstStyle/>
-          <a:p>
-            <a:pPr algn="l"/>
-            <a:r>
-              <a:rPr sz="900" b="1">
-                <a:solidFill>
-                  <a:srgbClr val="23613F"/>
-                </a:solidFill>
-              </a:rPr>
-              <a:t>0 → 10</a:t>
-            </a:r>
-          </a:p>
-        </p:txBody>
-      </p:sp>
-      <p:sp>
-        <p:nvSpPr>
-          <p:cNvPr id="22" name="TextBox 21"/>
-          <p:cNvSpPr txBox="1"/>
-          <p:nvPr/>
-        </p:nvSpPr>
-        <p:spPr>
-          <a:xfrm>
-            <a:off x="1000000" y="5410000"/>
-            <a:ext cx="700000" cy="150000"/>
-          </a:xfrm>
-          <a:prstGeom prst="rect">
-            <a:avLst/>
-          </a:prstGeom>
-          <a:noFill/>
-        </p:spPr>
-        <p:txBody>
-          <a:bodyPr wrap="square">
-            <a:spAutoFit/>
-          </a:bodyPr>
-          <a:lstStyle/>
-          <a:p>
-            <a:pPr algn="l"/>
-            <a:r>
-              <a:rPr sz="900" b="1">
-                <a:solidFill>
-                  <a:srgbClr val="6AAD8A"/>
-                </a:solidFill>
-              </a:rPr>
-              <a:t>новая</a:t>
-            </a:r>
-          </a:p>
-        </p:txBody>
-      </p:sp>
-      <p:sp>
-        <p:nvSpPr>
-          <p:cNvPr id="23" name="Rectangle 22"/>
-          <p:cNvSpPr/>
-          <p:nvPr/>
-        </p:nvSpPr>
-        <p:spPr>
-          <a:xfrm>
-            <a:off x="200000" y="5620000"/>
-            <a:ext cx="5794476" cy="390000"/>
-          </a:xfrm>
-          <a:prstGeom prst="rect">
-            <a:avLst/>
-          </a:prstGeom>
-          <a:solidFill>
-            <a:srgbClr val="EEF7F1"/>
-          </a:solidFill>
-          <a:ln>
-            <a:noFill/>
-          </a:ln>
-        </p:spPr>
-        <p:style>
-          <a:lnRef idx="1">
-            <a:schemeClr val="accent1"/>
-          </a:lnRef>
-          <a:fillRef idx="3">
-            <a:schemeClr val="accent1"/>
-          </a:fillRef>
-          <a:effectRef idx="2">
-            <a:schemeClr val="accent1"/>
-          </a:effectRef>
-          <a:fontRef idx="minor">
-            <a:schemeClr val="lt1"/>
-          </a:fontRef>
-        </p:style>
-        <p:txBody>
-          <a:bodyPr rtlCol="0" anchor="ctr"/>
-          <a:lstStyle/>
-          <a:p>
-            <a:pPr algn="ctr"/>
-          </a:p>
-        </p:txBody>
-      </p:sp>
-      <p:sp>
-        <p:nvSpPr>
-          <p:cNvPr id="24" name="TextBox 23"/>
-          <p:cNvSpPr txBox="1"/>
-          <p:nvPr/>
-        </p:nvSpPr>
-        <p:spPr>
-          <a:xfrm>
-            <a:off x="260000" y="5650000"/>
-            <a:ext cx="5494476" cy="170000"/>
-          </a:xfrm>
-          <a:prstGeom prst="rect">
-            <a:avLst/>
-          </a:prstGeom>
-          <a:noFill/>
-        </p:spPr>
-        <p:txBody>
-          <a:bodyPr wrap="square">
-            <a:spAutoFit/>
-          </a:bodyPr>
-          <a:lstStyle/>
-          <a:p>
-            <a:pPr algn="l"/>
-            <a:r>
-              <a:rPr sz="900" b="0">
-                <a:solidFill>
-                  <a:srgbClr val="1F493D"/>
-                </a:solidFill>
-              </a:rPr>
-              <a:t>Domain Adaptation &amp; Few-Shot Learning</a:t>
-            </a:r>
-          </a:p>
-        </p:txBody>
-      </p:sp>
-      <p:sp>
-        <p:nvSpPr>
-          <p:cNvPr id="25" name="TextBox 24"/>
-          <p:cNvSpPr txBox="1"/>
-          <p:nvPr/>
-        </p:nvSpPr>
-        <p:spPr>
-          <a:xfrm>
-            <a:off x="260000" y="5830000"/>
-            <a:ext cx="700000" cy="150000"/>
-          </a:xfrm>
-          <a:prstGeom prst="rect">
-            <a:avLst/>
-          </a:prstGeom>
-          <a:noFill/>
-        </p:spPr>
-        <p:txBody>
-          <a:bodyPr wrap="square">
-            <a:spAutoFit/>
-          </a:bodyPr>
-          <a:lstStyle/>
-          <a:p>
-            <a:pPr algn="l"/>
-            <a:r>
-              <a:rPr sz="900" b="1">
-                <a:solidFill>
-                  <a:srgbClr val="23613F"/>
-                </a:solidFill>
-              </a:rPr>
-              <a:t>3 → 15</a:t>
-            </a:r>
-          </a:p>
-        </p:txBody>
-      </p:sp>
-      <p:sp>
-        <p:nvSpPr>
-          <p:cNvPr id="26" name="TextBox 25"/>
-          <p:cNvSpPr txBox="1"/>
-          <p:nvPr/>
-        </p:nvSpPr>
-        <p:spPr>
-          <a:xfrm>
-            <a:off x="1000000" y="5830000"/>
-            <a:ext cx="700000" cy="150000"/>
-          </a:xfrm>
-          <a:prstGeom prst="rect">
-            <a:avLst/>
-          </a:prstGeom>
-          <a:noFill/>
-        </p:spPr>
-        <p:txBody>
-          <a:bodyPr wrap="square">
-            <a:spAutoFit/>
-          </a:bodyPr>
-          <a:lstStyle/>
-          <a:p>
-            <a:pPr algn="l"/>
-            <a:r>
-              <a:rPr sz="900" b="1">
-                <a:solidFill>
-                  <a:srgbClr val="6AAD8A"/>
-                </a:solidFill>
-              </a:rPr>
-              <a:t>×4.8</a:t>
-            </a:r>
-          </a:p>
-        </p:txBody>
-      </p:sp>
-      <p:sp>
-        <p:nvSpPr>
-          <p:cNvPr id="27" name="Rectangle 26"/>
-          <p:cNvSpPr/>
-          <p:nvPr/>
-        </p:nvSpPr>
-        <p:spPr>
-          <a:xfrm>
-            <a:off x="200000" y="6040000"/>
-            <a:ext cx="5794476" cy="390000"/>
-          </a:xfrm>
-          <a:prstGeom prst="rect">
-            <a:avLst/>
-          </a:prstGeom>
-          <a:solidFill>
-            <a:srgbClr val="EEF7F1"/>
-          </a:solidFill>
-          <a:ln>
-            <a:noFill/>
-          </a:ln>
-        </p:spPr>
-        <p:style>
-          <a:lnRef idx="1">
-            <a:schemeClr val="accent1"/>
-          </a:lnRef>
-          <a:fillRef idx="3">
-            <a:schemeClr val="accent1"/>
-          </a:fillRef>
-          <a:effectRef idx="2">
-            <a:schemeClr val="accent1"/>
-          </a:effectRef>
-          <a:fontRef idx="minor">
-            <a:schemeClr val="lt1"/>
-          </a:fontRef>
-        </p:style>
-        <p:txBody>
-          <a:bodyPr rtlCol="0" anchor="ctr"/>
-          <a:lstStyle/>
-          <a:p>
-            <a:pPr algn="ctr"/>
-          </a:p>
-        </p:txBody>
-      </p:sp>
-      <p:sp>
-        <p:nvSpPr>
-          <p:cNvPr id="28" name="TextBox 27"/>
-          <p:cNvSpPr txBox="1"/>
-          <p:nvPr/>
-        </p:nvSpPr>
-        <p:spPr>
-          <a:xfrm>
-            <a:off x="260000" y="6070000"/>
-            <a:ext cx="5494476" cy="170000"/>
-          </a:xfrm>
-          <a:prstGeom prst="rect">
-            <a:avLst/>
-          </a:prstGeom>
-          <a:noFill/>
-        </p:spPr>
-        <p:txBody>
-          <a:bodyPr wrap="square">
-            <a:spAutoFit/>
-          </a:bodyPr>
-          <a:lstStyle/>
-          <a:p>
-            <a:pPr algn="l"/>
-            <a:r>
-              <a:rPr sz="900" b="0">
-                <a:solidFill>
-                  <a:srgbClr val="1F493D"/>
-                </a:solidFill>
-              </a:rPr>
-              <a:t>Cancer Incidence &amp; Screening</a:t>
-            </a:r>
-          </a:p>
-        </p:txBody>
-      </p:sp>
-      <p:sp>
-        <p:nvSpPr>
-          <p:cNvPr id="29" name="TextBox 28"/>
-          <p:cNvSpPr txBox="1"/>
-          <p:nvPr/>
-        </p:nvSpPr>
-        <p:spPr>
-          <a:xfrm>
-            <a:off x="260000" y="6250000"/>
-            <a:ext cx="700000" cy="150000"/>
-          </a:xfrm>
-          <a:prstGeom prst="rect">
-            <a:avLst/>
-          </a:prstGeom>
-          <a:noFill/>
-        </p:spPr>
-        <p:txBody>
-          <a:bodyPr wrap="square">
-            <a:spAutoFit/>
-          </a:bodyPr>
-          <a:lstStyle/>
-          <a:p>
-            <a:pPr algn="l"/>
-            <a:r>
-              <a:rPr sz="900" b="1">
-                <a:solidFill>
-                  <a:srgbClr val="23613F"/>
-                </a:solidFill>
-              </a:rPr>
-              <a:t>3 → 13</a:t>
-            </a:r>
-          </a:p>
-        </p:txBody>
-      </p:sp>
-      <p:sp>
-        <p:nvSpPr>
-          <p:cNvPr id="30" name="TextBox 29"/>
-          <p:cNvSpPr txBox="1"/>
-          <p:nvPr/>
-        </p:nvSpPr>
-        <p:spPr>
-          <a:xfrm>
-            <a:off x="1000000" y="6250000"/>
-            <a:ext cx="700000" cy="150000"/>
-          </a:xfrm>
-          <a:prstGeom prst="rect">
-            <a:avLst/>
-          </a:prstGeom>
-          <a:noFill/>
-        </p:spPr>
-        <p:txBody>
-          <a:bodyPr wrap="square">
-            <a:spAutoFit/>
-          </a:bodyPr>
-          <a:lstStyle/>
-          <a:p>
-            <a:pPr algn="l"/>
-            <a:r>
-              <a:rPr sz="900" b="1">
-                <a:solidFill>
-                  <a:srgbClr val="6AAD8A"/>
-                </a:solidFill>
-              </a:rPr>
-              <a:t>×4.2</a:t>
-            </a:r>
-          </a:p>
-        </p:txBody>
-      </p:sp>
-      <p:sp>
-        <p:nvSpPr>
-          <p:cNvPr id="31" name="TextBox 30"/>
-          <p:cNvSpPr txBox="1"/>
-          <p:nvPr/>
-        </p:nvSpPr>
-        <p:spPr>
-          <a:xfrm>
-            <a:off x="6194476" y="4510000"/>
-            <a:ext cx="5794476" cy="240000"/>
-          </a:xfrm>
-          <a:prstGeom prst="rect">
-            <a:avLst/>
-          </a:prstGeom>
-          <a:noFill/>
-        </p:spPr>
-        <p:txBody>
-          <a:bodyPr wrap="square">
-            <a:spAutoFit/>
-          </a:bodyPr>
-          <a:lstStyle/>
-          <a:p>
-            <a:pPr algn="l"/>
-            <a:r>
-              <a:rPr sz="1000" b="1">
-                <a:solidFill>
-                  <a:srgbClr val="883333"/>
-                </a:solidFill>
-              </a:rPr>
-              <a:t>Угасающие темы (исчезли после 2012)</a:t>
-            </a:r>
-          </a:p>
-        </p:txBody>
-      </p:sp>
-      <p:sp>
-        <p:nvSpPr>
-          <p:cNvPr id="32" name="Rectangle 31"/>
-          <p:cNvSpPr/>
-          <p:nvPr/>
-        </p:nvSpPr>
-        <p:spPr>
-          <a:xfrm>
-            <a:off x="6194476" y="4780000"/>
-            <a:ext cx="5794476" cy="390000"/>
-          </a:xfrm>
-          <a:prstGeom prst="rect">
-            <a:avLst/>
-          </a:prstGeom>
-          <a:solidFill>
-            <a:srgbClr val="FBF0F0"/>
-          </a:solidFill>
-          <a:ln>
-            <a:noFill/>
-          </a:ln>
-        </p:spPr>
-        <p:style>
-          <a:lnRef idx="1">
-            <a:schemeClr val="accent1"/>
-          </a:lnRef>
-          <a:fillRef idx="3">
-            <a:schemeClr val="accent1"/>
-          </a:fillRef>
-          <a:effectRef idx="2">
-            <a:schemeClr val="accent1"/>
-          </a:effectRef>
-          <a:fontRef idx="minor">
-            <a:schemeClr val="lt1"/>
-          </a:fontRef>
-        </p:style>
-        <p:txBody>
-          <a:bodyPr rtlCol="0" anchor="ctr"/>
-          <a:lstStyle/>
-          <a:p>
-            <a:pPr algn="ctr"/>
-          </a:p>
-        </p:txBody>
-      </p:sp>
-      <p:sp>
-        <p:nvSpPr>
-          <p:cNvPr id="33" name="TextBox 32"/>
-          <p:cNvSpPr txBox="1"/>
-          <p:nvPr/>
-        </p:nvSpPr>
-        <p:spPr>
-          <a:xfrm>
-            <a:off x="6254476" y="4810000"/>
-            <a:ext cx="5594476" cy="170000"/>
-          </a:xfrm>
-          <a:prstGeom prst="rect">
-            <a:avLst/>
-          </a:prstGeom>
-          <a:noFill/>
-        </p:spPr>
-        <p:txBody>
-          <a:bodyPr wrap="square">
-            <a:spAutoFit/>
-          </a:bodyPr>
-          <a:lstStyle/>
-          <a:p>
-            <a:pPr algn="l"/>
-            <a:r>
-              <a:rPr sz="900" b="0">
-                <a:solidFill>
-                  <a:srgbClr val="662222"/>
-                </a:solidFill>
-              </a:rPr>
-              <a:t>Advanced Chemical Physics Studies</a:t>
-            </a:r>
-          </a:p>
-        </p:txBody>
-      </p:sp>
-      <p:sp>
-        <p:nvSpPr>
-          <p:cNvPr id="34" name="TextBox 33"/>
-          <p:cNvSpPr txBox="1"/>
-          <p:nvPr/>
-        </p:nvSpPr>
-        <p:spPr>
-          <a:xfrm>
-            <a:off x="6254476" y="4990000"/>
-            <a:ext cx="700000" cy="150000"/>
-          </a:xfrm>
-          <a:prstGeom prst="rect">
-            <a:avLst/>
-          </a:prstGeom>
-          <a:noFill/>
-        </p:spPr>
-        <p:txBody>
-          <a:bodyPr wrap="square">
-            <a:spAutoFit/>
-          </a:bodyPr>
-          <a:lstStyle/>
-          <a:p>
-            <a:pPr algn="l"/>
-            <a:r>
-              <a:rPr sz="900" b="1">
-                <a:solidFill>
-                  <a:srgbClr val="AA4444"/>
-                </a:solidFill>
-              </a:rPr>
-              <a:t>10 → 0</a:t>
-            </a:r>
-          </a:p>
-        </p:txBody>
-      </p:sp>
-      <p:sp>
-        <p:nvSpPr>
-          <p:cNvPr id="35" name="Rectangle 34"/>
-          <p:cNvSpPr/>
-          <p:nvPr/>
-        </p:nvSpPr>
-        <p:spPr>
-          <a:xfrm>
-            <a:off x="6194476" y="5200000"/>
-            <a:ext cx="5794476" cy="390000"/>
-          </a:xfrm>
-          <a:prstGeom prst="rect">
-            <a:avLst/>
-          </a:prstGeom>
-          <a:solidFill>
-            <a:srgbClr val="FBF0F0"/>
-          </a:solidFill>
-          <a:ln>
-            <a:noFill/>
-          </a:ln>
-        </p:spPr>
-        <p:style>
-          <a:lnRef idx="1">
-            <a:schemeClr val="accent1"/>
-          </a:lnRef>
-          <a:fillRef idx="3">
-            <a:schemeClr val="accent1"/>
-          </a:fillRef>
-          <a:effectRef idx="2">
-            <a:schemeClr val="accent1"/>
-          </a:effectRef>
-          <a:fontRef idx="minor">
-            <a:schemeClr val="lt1"/>
-          </a:fontRef>
-        </p:style>
-        <p:txBody>
-          <a:bodyPr rtlCol="0" anchor="ctr"/>
-          <a:lstStyle/>
-          <a:p>
-            <a:pPr algn="ctr"/>
-          </a:p>
-        </p:txBody>
-      </p:sp>
-      <p:sp>
-        <p:nvSpPr>
-          <p:cNvPr id="36" name="TextBox 35"/>
-          <p:cNvSpPr txBox="1"/>
-          <p:nvPr/>
-        </p:nvSpPr>
-        <p:spPr>
-          <a:xfrm>
-            <a:off x="6254476" y="5230000"/>
-            <a:ext cx="5594476" cy="170000"/>
-          </a:xfrm>
-          <a:prstGeom prst="rect">
-            <a:avLst/>
-          </a:prstGeom>
-          <a:noFill/>
-        </p:spPr>
-        <p:txBody>
-          <a:bodyPr wrap="square">
-            <a:spAutoFit/>
-          </a:bodyPr>
-          <a:lstStyle/>
-          <a:p>
-            <a:pPr algn="l"/>
-            <a:r>
-              <a:rPr sz="900" b="0">
-                <a:solidFill>
-                  <a:srgbClr val="662222"/>
-                </a:solidFill>
-              </a:rPr>
-              <a:t>Graphene research and applications</a:t>
-            </a:r>
-          </a:p>
-        </p:txBody>
-      </p:sp>
-      <p:sp>
-        <p:nvSpPr>
-          <p:cNvPr id="37" name="TextBox 36"/>
-          <p:cNvSpPr txBox="1"/>
-          <p:nvPr/>
-        </p:nvSpPr>
-        <p:spPr>
-          <a:xfrm>
-            <a:off x="6254476" y="5410000"/>
-            <a:ext cx="700000" cy="150000"/>
-          </a:xfrm>
-          <a:prstGeom prst="rect">
-            <a:avLst/>
-          </a:prstGeom>
-          <a:noFill/>
-        </p:spPr>
-        <p:txBody>
-          <a:bodyPr wrap="square">
-            <a:spAutoFit/>
-          </a:bodyPr>
-          <a:lstStyle/>
-          <a:p>
-            <a:pPr algn="l"/>
-            <a:r>
-              <a:rPr sz="900" b="1">
-                <a:solidFill>
-                  <a:srgbClr val="AA4444"/>
-                </a:solidFill>
-              </a:rPr>
-              <a:t>8 → 0</a:t>
-            </a:r>
-          </a:p>
-        </p:txBody>
-      </p:sp>
-      <p:sp>
-        <p:nvSpPr>
-          <p:cNvPr id="38" name="Rectangle 37"/>
-          <p:cNvSpPr/>
-          <p:nvPr/>
-        </p:nvSpPr>
-        <p:spPr>
-          <a:xfrm>
-            <a:off x="6194476" y="5620000"/>
-            <a:ext cx="5794476" cy="390000"/>
-          </a:xfrm>
-          <a:prstGeom prst="rect">
-            <a:avLst/>
-          </a:prstGeom>
-          <a:solidFill>
-            <a:srgbClr val="FBF0F0"/>
-          </a:solidFill>
-          <a:ln>
-            <a:noFill/>
-          </a:ln>
-        </p:spPr>
-        <p:style>
-          <a:lnRef idx="1">
-            <a:schemeClr val="accent1"/>
-          </a:lnRef>
-          <a:fillRef idx="3">
-            <a:schemeClr val="accent1"/>
-          </a:fillRef>
-          <a:effectRef idx="2">
-            <a:schemeClr val="accent1"/>
-          </a:effectRef>
-          <a:fontRef idx="minor">
-            <a:schemeClr val="lt1"/>
-          </a:fontRef>
-        </p:style>
-        <p:txBody>
-          <a:bodyPr rtlCol="0" anchor="ctr"/>
-          <a:lstStyle/>
-          <a:p>
-            <a:pPr algn="ctr"/>
-          </a:p>
-        </p:txBody>
-      </p:sp>
-      <p:sp>
-        <p:nvSpPr>
-          <p:cNvPr id="39" name="TextBox 38"/>
-          <p:cNvSpPr txBox="1"/>
-          <p:nvPr/>
-        </p:nvSpPr>
-        <p:spPr>
-          <a:xfrm>
-            <a:off x="6254476" y="5650000"/>
-            <a:ext cx="5594476" cy="170000"/>
-          </a:xfrm>
-          <a:prstGeom prst="rect">
-            <a:avLst/>
-          </a:prstGeom>
-          <a:noFill/>
-        </p:spPr>
-        <p:txBody>
-          <a:bodyPr wrap="square">
-            <a:spAutoFit/>
-          </a:bodyPr>
-          <a:lstStyle/>
-          <a:p>
-            <a:pPr algn="l"/>
-            <a:r>
-              <a:rPr sz="900" b="0">
-                <a:solidFill>
-                  <a:srgbClr val="662222"/>
-                </a:solidFill>
-              </a:rPr>
-              <a:t>Advancements in Battery Materials</a:t>
-            </a:r>
-          </a:p>
-        </p:txBody>
-      </p:sp>
-      <p:sp>
-        <p:nvSpPr>
-          <p:cNvPr id="40" name="TextBox 39"/>
-          <p:cNvSpPr txBox="1"/>
-          <p:nvPr/>
-        </p:nvSpPr>
-        <p:spPr>
-          <a:xfrm>
-            <a:off x="6254476" y="5830000"/>
-            <a:ext cx="700000" cy="150000"/>
-          </a:xfrm>
-          <a:prstGeom prst="rect">
-            <a:avLst/>
-          </a:prstGeom>
-          <a:noFill/>
-        </p:spPr>
-        <p:txBody>
-          <a:bodyPr wrap="square">
-            <a:spAutoFit/>
-          </a:bodyPr>
-          <a:lstStyle/>
-          <a:p>
-            <a:pPr algn="l"/>
-            <a:r>
-              <a:rPr sz="900" b="1">
-                <a:solidFill>
-                  <a:srgbClr val="AA4444"/>
-                </a:solidFill>
-              </a:rPr>
-              <a:t>4 → 0</a:t>
-            </a:r>
-          </a:p>
-        </p:txBody>
-      </p:sp>
-      <p:sp>
-        <p:nvSpPr>
-          <p:cNvPr id="41" name="Rectangle 40"/>
-          <p:cNvSpPr/>
-          <p:nvPr/>
-        </p:nvSpPr>
-        <p:spPr>
-          <a:xfrm>
-            <a:off x="6194476" y="6040000"/>
-            <a:ext cx="5794476" cy="390000"/>
-          </a:xfrm>
-          <a:prstGeom prst="rect">
-            <a:avLst/>
-          </a:prstGeom>
-          <a:solidFill>
-            <a:srgbClr val="FBF0F0"/>
-          </a:solidFill>
-          <a:ln>
-            <a:noFill/>
-          </a:ln>
-        </p:spPr>
-        <p:style>
-          <a:lnRef idx="1">
-            <a:schemeClr val="accent1"/>
-          </a:lnRef>
-          <a:fillRef idx="3">
-            <a:schemeClr val="accent1"/>
-          </a:fillRef>
-          <a:effectRef idx="2">
-            <a:schemeClr val="accent1"/>
-          </a:effectRef>
-          <a:fontRef idx="minor">
-            <a:schemeClr val="lt1"/>
-          </a:fontRef>
-        </p:style>
-        <p:txBody>
-          <a:bodyPr rtlCol="0" anchor="ctr"/>
-          <a:lstStyle/>
-          <a:p>
-            <a:pPr algn="ctr"/>
-          </a:p>
-        </p:txBody>
-      </p:sp>
-      <p:sp>
-        <p:nvSpPr>
-          <p:cNvPr id="42" name="TextBox 41"/>
-          <p:cNvSpPr txBox="1"/>
-          <p:nvPr/>
-        </p:nvSpPr>
-        <p:spPr>
-          <a:xfrm>
-            <a:off x="6254476" y="6070000"/>
-            <a:ext cx="5594476" cy="170000"/>
-          </a:xfrm>
-          <a:prstGeom prst="rect">
-            <a:avLst/>
-          </a:prstGeom>
-          <a:noFill/>
-        </p:spPr>
-        <p:txBody>
-          <a:bodyPr wrap="square">
-            <a:spAutoFit/>
-          </a:bodyPr>
-          <a:lstStyle/>
-          <a:p>
-            <a:pPr algn="l"/>
-            <a:r>
-              <a:rPr sz="900" b="0">
-                <a:solidFill>
-                  <a:srgbClr val="662222"/>
-                </a:solidFill>
-              </a:rPr>
-              <a:t>Genomics and Chromatin Dynamics</a:t>
-            </a:r>
-          </a:p>
-        </p:txBody>
-      </p:sp>
-      <p:sp>
-        <p:nvSpPr>
-          <p:cNvPr id="43" name="TextBox 42"/>
-          <p:cNvSpPr txBox="1"/>
-          <p:nvPr/>
-        </p:nvSpPr>
-        <p:spPr>
-          <a:xfrm>
-            <a:off x="6254476" y="6250000"/>
-            <a:ext cx="700000" cy="150000"/>
-          </a:xfrm>
-          <a:prstGeom prst="rect">
-            <a:avLst/>
-          </a:prstGeom>
-          <a:noFill/>
-        </p:spPr>
-        <p:txBody>
-          <a:bodyPr wrap="square">
-            <a:spAutoFit/>
-          </a:bodyPr>
-          <a:lstStyle/>
-          <a:p>
-            <a:pPr algn="l"/>
-            <a:r>
-              <a:rPr sz="900" b="1">
-                <a:solidFill>
-                  <a:srgbClr val="AA4444"/>
-                </a:solidFill>
-              </a:rPr>
-              <a:t>4 → 0</a:t>
-            </a:r>
-          </a:p>
-        </p:txBody>
-      </p:sp>
+            <a:r>
+              <a:rPr sz="1200" b="1">
+                <a:solidFill>
+                  <a:srgbClr val="E74C3C"/>
+                </a:solidFill>
+              </a:rPr>
+              <a:t>Угасающие темы (2000–2012 vs 2013–2024)</a:t>
+            </a:r>
+          </a:p>
+        </p:txBody>
+      </p:sp>
+      <p:graphicFrame>
+        <p:nvGraphicFramePr>
+          <p:cNvPr id="16" name="Chart 15"/>
+          <p:cNvGraphicFramePr>
+            <a:graphicFrameLocks noGrp="1"/>
+          </p:cNvGraphicFramePr>
+          <p:nvPr/>
+        </p:nvGraphicFramePr>
+        <p:xfrm>
+          <a:off x="108000" y="4644000"/>
+          <a:ext cx="6012000" cy="2088000"/>
+        </p:xfrm>
+        <a:graphic>
+          <a:graphicData uri="http://schemas.openxmlformats.org/drawingml/2006/chart">
+            <c:chart xmlns:c="http://schemas.openxmlformats.org/drawingml/2006/chart" r:id="rId2"/>
+          </a:graphicData>
+        </a:graphic>
+      </p:graphicFrame>
+      <p:graphicFrame>
+        <p:nvGraphicFramePr>
+          <p:cNvPr id="17" name="Chart 16"/>
+          <p:cNvGraphicFramePr>
+            <a:graphicFrameLocks noGrp="1"/>
+          </p:cNvGraphicFramePr>
+          <p:nvPr/>
+        </p:nvGraphicFramePr>
+        <p:xfrm>
+          <a:off x="6120000" y="4644000"/>
+          <a:ext cx="5940000" cy="2088000"/>
+        </p:xfrm>
+        <a:graphic>
+          <a:graphicData uri="http://schemas.openxmlformats.org/drawingml/2006/chart">
+            <c:chart xmlns:c="http://schemas.openxmlformats.org/drawingml/2006/chart" r:id="rId3"/>
+          </a:graphicData>
+        </a:graphic>
+      </p:graphicFrame>
     </p:spTree>
   </p:cSld>
   <p:clrMapOvr>
@@ -12613,316 +11989,6 @@
       </p:sp>
       <p:sp>
         <p:nvSpPr>
-          <p:cNvPr id="5" name="TextBox 4"/>
-          <p:cNvSpPr txBox="1"/>
-          <p:nvPr/>
-        </p:nvSpPr>
-        <p:spPr>
-          <a:xfrm>
-            <a:off x="365760" y="1143000"/>
-            <a:ext cx="7772400" cy="5303520"/>
-          </a:xfrm>
-          <a:prstGeom prst="rect">
-            <a:avLst/>
-          </a:prstGeom>
-          <a:noFill/>
-        </p:spPr>
-        <p:txBody>
-          <a:bodyPr wrap="square">
-            <a:spAutoFit/>
-          </a:bodyPr>
-          <a:lstStyle/>
-          <a:p>
-            <a:pPr>
-              <a:spcBef>
-                <a:spcPts val="300"/>
-              </a:spcBef>
-            </a:pPr>
-            <a:r>
-              <a:rPr b="1" sz="1400">
-                <a:solidFill>
-                  <a:srgbClr val="23613F"/>
-                </a:solidFill>
-                <a:latin typeface="Calibri"/>
-              </a:rPr>
-              <a:t>journals  </a:t>
-            </a:r>
-            <a:r>
-              <a:rPr sz="1400">
-                <a:solidFill>
-                  <a:srgbClr val="122017"/>
-                </a:solidFill>
-                <a:latin typeface="Calibri"/>
-              </a:rPr>
-              <a:t>— Научные журналы</a:t>
-            </a:r>
-          </a:p>
-          <a:p>
-            <a:pPr>
-              <a:spcBef>
-                <a:spcPts val="0"/>
-              </a:spcBef>
-            </a:pPr>
-            <a:r>
-              <a:rPr sz="1200" i="1">
-                <a:solidFill>
-                  <a:srgbClr val="577166"/>
-                </a:solidFill>
-                <a:latin typeface="Calibri"/>
-              </a:rPr>
-              <a:t>    openalex_id, name, issn</a:t>
-            </a:r>
-          </a:p>
-          <a:p>
-            <a:pPr>
-              <a:spcBef>
-                <a:spcPts val="300"/>
-              </a:spcBef>
-            </a:pPr>
-            <a:r>
-              <a:rPr b="1" sz="1400">
-                <a:solidFill>
-                  <a:srgbClr val="23613F"/>
-                </a:solidFill>
-                <a:latin typeface="Calibri"/>
-              </a:rPr>
-              <a:t>publications  </a:t>
-            </a:r>
-            <a:r>
-              <a:rPr sz="1400">
-                <a:solidFill>
-                  <a:srgbClr val="122017"/>
-                </a:solidFill>
-                <a:latin typeface="Calibri"/>
-              </a:rPr>
-              <a:t>— Публикации</a:t>
-            </a:r>
-          </a:p>
-          <a:p>
-            <a:pPr>
-              <a:spcBef>
-                <a:spcPts val="0"/>
-              </a:spcBef>
-            </a:pPr>
-            <a:r>
-              <a:rPr sz="1200" i="1">
-                <a:solidFill>
-                  <a:srgbClr val="577166"/>
-                </a:solidFill>
-                <a:latin typeface="Calibri"/>
-              </a:rPr>
-              <a:t>    title, doi, year, abstract, journal_id</a:t>
-            </a:r>
-          </a:p>
-          <a:p>
-            <a:pPr>
-              <a:spcBef>
-                <a:spcPts val="300"/>
-              </a:spcBef>
-            </a:pPr>
-            <a:r>
-              <a:rPr b="1" sz="1400">
-                <a:solidFill>
-                  <a:srgbClr val="23613F"/>
-                </a:solidFill>
-                <a:latin typeface="Calibri"/>
-              </a:rPr>
-              <a:t>persons  </a:t>
-            </a:r>
-            <a:r>
-              <a:rPr sz="1400">
-                <a:solidFill>
-                  <a:srgbClr val="122017"/>
-                </a:solidFill>
-                <a:latin typeface="Calibri"/>
-              </a:rPr>
-              <a:t>— Авторы</a:t>
-            </a:r>
-          </a:p>
-          <a:p>
-            <a:pPr>
-              <a:spcBef>
-                <a:spcPts val="0"/>
-              </a:spcBef>
-            </a:pPr>
-            <a:r>
-              <a:rPr sz="1200" i="1">
-                <a:solidFill>
-                  <a:srgbClr val="577166"/>
-                </a:solidFill>
-                <a:latin typeface="Calibri"/>
-              </a:rPr>
-              <a:t>    openalex_id, full_name, orcid</a:t>
-            </a:r>
-          </a:p>
-          <a:p>
-            <a:pPr>
-              <a:spcBef>
-                <a:spcPts val="300"/>
-              </a:spcBef>
-            </a:pPr>
-            <a:r>
-              <a:rPr b="1" sz="1400">
-                <a:solidFill>
-                  <a:srgbClr val="23613F"/>
-                </a:solidFill>
-                <a:latin typeface="Calibri"/>
-              </a:rPr>
-              <a:t>affiliations  </a:t>
-            </a:r>
-            <a:r>
-              <a:rPr sz="1400">
-                <a:solidFill>
-                  <a:srgbClr val="122017"/>
-                </a:solidFill>
-                <a:latin typeface="Calibri"/>
-              </a:rPr>
-              <a:t>— Организации + координаты</a:t>
-            </a:r>
-          </a:p>
-          <a:p>
-            <a:pPr>
-              <a:spcBef>
-                <a:spcPts val="0"/>
-              </a:spcBef>
-            </a:pPr>
-            <a:r>
-              <a:rPr sz="1200" i="1">
-                <a:solidFill>
-                  <a:srgbClr val="577166"/>
-                </a:solidFill>
-                <a:latin typeface="Calibri"/>
-              </a:rPr>
-              <a:t>    institution, latitude, longitude</a:t>
-            </a:r>
-          </a:p>
-          <a:p>
-            <a:pPr>
-              <a:spcBef>
-                <a:spcPts val="300"/>
-              </a:spcBef>
-            </a:pPr>
-            <a:r>
-              <a:rPr b="1" sz="1400">
-                <a:solidFill>
-                  <a:srgbClr val="23613F"/>
-                </a:solidFill>
-                <a:latin typeface="Calibri"/>
-              </a:rPr>
-              <a:t>publication_authors  </a:t>
-            </a:r>
-            <a:r>
-              <a:rPr sz="1400">
-                <a:solidFill>
-                  <a:srgbClr val="122017"/>
-                </a:solidFill>
-                <a:latin typeface="Calibri"/>
-              </a:rPr>
-              <a:t>— Публикация ↔ Автор (N:M)</a:t>
-            </a:r>
-          </a:p>
-          <a:p>
-            <a:pPr>
-              <a:spcBef>
-                <a:spcPts val="0"/>
-              </a:spcBef>
-            </a:pPr>
-            <a:r>
-              <a:rPr sz="1200" i="1">
-                <a:solidFill>
-                  <a:srgbClr val="577166"/>
-                </a:solidFill>
-                <a:latin typeface="Calibri"/>
-              </a:rPr>
-              <a:t>    publication_id, person_id</a:t>
-            </a:r>
-          </a:p>
-          <a:p>
-            <a:pPr>
-              <a:spcBef>
-                <a:spcPts val="300"/>
-              </a:spcBef>
-            </a:pPr>
-            <a:r>
-              <a:rPr b="1" sz="1400">
-                <a:solidFill>
-                  <a:srgbClr val="23613F"/>
-                </a:solidFill>
-                <a:latin typeface="Calibri"/>
-              </a:rPr>
-              <a:t>publication_topics  </a:t>
-            </a:r>
-            <a:r>
-              <a:rPr sz="1400">
-                <a:solidFill>
-                  <a:srgbClr val="122017"/>
-                </a:solidFill>
-                <a:latin typeface="Calibri"/>
-              </a:rPr>
-              <a:t>— Тематические классификаторы</a:t>
-            </a:r>
-          </a:p>
-          <a:p>
-            <a:pPr>
-              <a:spcBef>
-                <a:spcPts val="0"/>
-              </a:spcBef>
-            </a:pPr>
-            <a:r>
-              <a:rPr sz="1200" i="1">
-                <a:solidFill>
-                  <a:srgbClr val="577166"/>
-                </a:solidFill>
-                <a:latin typeface="Calibri"/>
-              </a:rPr>
-              <a:t>    topic_name, score</a:t>
-            </a:r>
-          </a:p>
-          <a:p>
-            <a:pPr>
-              <a:spcBef>
-                <a:spcPts val="300"/>
-              </a:spcBef>
-            </a:pPr>
-            <a:r>
-              <a:rPr b="1" sz="1400">
-                <a:solidFill>
-                  <a:srgbClr val="23613F"/>
-                </a:solidFill>
-                <a:latin typeface="Calibri"/>
-              </a:rPr>
-              <a:t>publication_keywords  </a:t>
-            </a:r>
-            <a:r>
-              <a:rPr sz="1400">
-                <a:solidFill>
-                  <a:srgbClr val="122017"/>
-                </a:solidFill>
-                <a:latin typeface="Calibri"/>
-              </a:rPr>
-              <a:t>— Ключевые слова</a:t>
-            </a:r>
-          </a:p>
-          <a:p>
-            <a:pPr>
-              <a:spcBef>
-                <a:spcPts val="0"/>
-              </a:spcBef>
-            </a:pPr>
-            <a:r>
-              <a:rPr sz="1200" i="1">
-                <a:solidFill>
-                  <a:srgbClr val="577166"/>
-                </a:solidFill>
-                <a:latin typeface="Calibri"/>
-              </a:rPr>
-              <a:t>    keyword_name, score</a:t>
-            </a:r>
-          </a:p>
-        </p:txBody>
-      </p:sp>
-      <p:sp>
-        <p:nvSpPr>
           <p:cNvPr id="6" name="TextBox 5"/>
           <p:cNvSpPr txBox="1"/>
           <p:nvPr/>
@@ -13110,6 +12176,449 @@
           </a:p>
         </p:txBody>
       </p:sp>
+      <p:graphicFrame>
+        <p:nvGraphicFramePr>
+          <p:cNvPr id="11" name="Table 10"/>
+          <p:cNvGraphicFramePr>
+            <a:graphicFrameLocks noGrp="1"/>
+          </p:cNvGraphicFramePr>
+          <p:nvPr/>
+        </p:nvGraphicFramePr>
+        <p:xfrm>
+          <a:off x="288000" y="1080000"/>
+          <a:ext cx="7920000" cy="4860000"/>
+        </p:xfrm>
+        <a:graphic>
+          <a:graphicData uri="http://schemas.openxmlformats.org/drawingml/2006/table">
+            <a:tbl>
+              <a:tblPr firstRow="1" bandRow="1">
+                <a:tableStyleId>{5C22544A-7EE6-4342-B048-85BDC9FD1C3A}</a:tableStyleId>
+              </a:tblPr>
+              <a:tblGrid>
+                <a:gridCol w="1980000"/>
+                <a:gridCol w="3240000"/>
+                <a:gridCol w="2700000"/>
+              </a:tblGrid>
+              <a:tr h="607500">
+                <a:tc>
+                  <a:txBody>
+                    <a:bodyPr wrap="square"/>
+                    <a:lstStyle/>
+                    <a:p>
+                      <a:r>
+                        <a:rPr b="1" sz="1100">
+                          <a:solidFill>
+                            <a:srgbClr val="FFFFFF"/>
+                          </a:solidFill>
+                        </a:rPr>
+                        <a:t>Таблица</a:t>
+                      </a:r>
+                    </a:p>
+                  </a:txBody>
+                  <a:tcPr>
+                    <a:solidFill>
+                      <a:srgbClr val="2C3E50"/>
+                    </a:solidFill>
+                  </a:tcPr>
+                </a:tc>
+                <a:tc>
+                  <a:txBody>
+                    <a:bodyPr wrap="square"/>
+                    <a:lstStyle/>
+                    <a:p>
+                      <a:r>
+                        <a:rPr b="1" sz="1100">
+                          <a:solidFill>
+                            <a:srgbClr val="FFFFFF"/>
+                          </a:solidFill>
+                        </a:rPr>
+                        <a:t>Назначение</a:t>
+                      </a:r>
+                    </a:p>
+                  </a:txBody>
+                  <a:tcPr>
+                    <a:solidFill>
+                      <a:srgbClr val="2C3E50"/>
+                    </a:solidFill>
+                  </a:tcPr>
+                </a:tc>
+                <a:tc>
+                  <a:txBody>
+                    <a:bodyPr wrap="square"/>
+                    <a:lstStyle/>
+                    <a:p>
+                      <a:r>
+                        <a:rPr b="1" sz="1100">
+                          <a:solidFill>
+                            <a:srgbClr val="FFFFFF"/>
+                          </a:solidFill>
+                        </a:rPr>
+                        <a:t>Ключевые поля</a:t>
+                      </a:r>
+                    </a:p>
+                  </a:txBody>
+                  <a:tcPr>
+                    <a:solidFill>
+                      <a:srgbClr val="2C3E50"/>
+                    </a:solidFill>
+                  </a:tcPr>
+                </a:tc>
+              </a:tr>
+              <a:tr h="607500">
+                <a:tc>
+                  <a:txBody>
+                    <a:bodyPr wrap="square"/>
+                    <a:lstStyle/>
+                    <a:p>
+                      <a:r>
+                        <a:rPr sz="1000" b="1">
+                          <a:solidFill>
+                            <a:srgbClr val="1A5C94"/>
+                          </a:solidFill>
+                        </a:rPr>
+                        <a:t>journals</a:t>
+                      </a:r>
+                    </a:p>
+                  </a:txBody>
+                  <a:tcPr/>
+                </a:tc>
+                <a:tc>
+                  <a:txBody>
+                    <a:bodyPr wrap="square"/>
+                    <a:lstStyle/>
+                    <a:p>
+                      <a:r>
+                        <a:rPr sz="1000" b="0"/>
+                        <a:t>Научные журналы</a:t>
+                      </a:r>
+                    </a:p>
+                  </a:txBody>
+                  <a:tcPr/>
+                </a:tc>
+                <a:tc>
+                  <a:txBody>
+                    <a:bodyPr wrap="square"/>
+                    <a:lstStyle/>
+                    <a:p>
+                      <a:r>
+                        <a:rPr sz="1000" b="0"/>
+                        <a:t>openalex_id, name, issn</a:t>
+                      </a:r>
+                    </a:p>
+                  </a:txBody>
+                  <a:tcPr/>
+                </a:tc>
+              </a:tr>
+              <a:tr h="607500">
+                <a:tc>
+                  <a:txBody>
+                    <a:bodyPr wrap="square"/>
+                    <a:lstStyle/>
+                    <a:p>
+                      <a:r>
+                        <a:rPr sz="1000" b="1">
+                          <a:solidFill>
+                            <a:srgbClr val="1A5C94"/>
+                          </a:solidFill>
+                        </a:rPr>
+                        <a:t>publications</a:t>
+                      </a:r>
+                    </a:p>
+                  </a:txBody>
+                  <a:tcPr>
+                    <a:solidFill>
+                      <a:srgbClr val="EAF2F8"/>
+                    </a:solidFill>
+                  </a:tcPr>
+                </a:tc>
+                <a:tc>
+                  <a:txBody>
+                    <a:bodyPr wrap="square"/>
+                    <a:lstStyle/>
+                    <a:p>
+                      <a:r>
+                        <a:rPr sz="1000" b="0"/>
+                        <a:t>Статьи и метаданные</a:t>
+                      </a:r>
+                    </a:p>
+                  </a:txBody>
+                  <a:tcPr>
+                    <a:solidFill>
+                      <a:srgbClr val="EAF2F8"/>
+                    </a:solidFill>
+                  </a:tcPr>
+                </a:tc>
+                <a:tc>
+                  <a:txBody>
+                    <a:bodyPr wrap="square"/>
+                    <a:lstStyle/>
+                    <a:p>
+                      <a:r>
+                        <a:rPr sz="1000" b="0"/>
+                        <a:t>title, doi, year, journal_id</a:t>
+                      </a:r>
+                    </a:p>
+                  </a:txBody>
+                  <a:tcPr>
+                    <a:solidFill>
+                      <a:srgbClr val="EAF2F8"/>
+                    </a:solidFill>
+                  </a:tcPr>
+                </a:tc>
+              </a:tr>
+              <a:tr h="607500">
+                <a:tc>
+                  <a:txBody>
+                    <a:bodyPr wrap="square"/>
+                    <a:lstStyle/>
+                    <a:p>
+                      <a:r>
+                        <a:rPr sz="1000" b="1">
+                          <a:solidFill>
+                            <a:srgbClr val="1A5C94"/>
+                          </a:solidFill>
+                        </a:rPr>
+                        <a:t>persons</a:t>
+                      </a:r>
+                    </a:p>
+                  </a:txBody>
+                  <a:tcPr/>
+                </a:tc>
+                <a:tc>
+                  <a:txBody>
+                    <a:bodyPr wrap="square"/>
+                    <a:lstStyle/>
+                    <a:p>
+                      <a:r>
+                        <a:rPr sz="1000" b="0"/>
+                        <a:t>Авторы</a:t>
+                      </a:r>
+                    </a:p>
+                  </a:txBody>
+                  <a:tcPr/>
+                </a:tc>
+                <a:tc>
+                  <a:txBody>
+                    <a:bodyPr wrap="square"/>
+                    <a:lstStyle/>
+                    <a:p>
+                      <a:r>
+                        <a:rPr sz="1000" b="0"/>
+                        <a:t>openalex_id, full_name, orcid</a:t>
+                      </a:r>
+                    </a:p>
+                  </a:txBody>
+                  <a:tcPr/>
+                </a:tc>
+              </a:tr>
+              <a:tr h="607500">
+                <a:tc>
+                  <a:txBody>
+                    <a:bodyPr wrap="square"/>
+                    <a:lstStyle/>
+                    <a:p>
+                      <a:r>
+                        <a:rPr sz="1000" b="1">
+                          <a:solidFill>
+                            <a:srgbClr val="1A5C94"/>
+                          </a:solidFill>
+                        </a:rPr>
+                        <a:t>affiliations</a:t>
+                      </a:r>
+                    </a:p>
+                  </a:txBody>
+                  <a:tcPr>
+                    <a:solidFill>
+                      <a:srgbClr val="EAF2F8"/>
+                    </a:solidFill>
+                  </a:tcPr>
+                </a:tc>
+                <a:tc>
+                  <a:txBody>
+                    <a:bodyPr wrap="square"/>
+                    <a:lstStyle/>
+                    <a:p>
+                      <a:r>
+                        <a:rPr sz="1000" b="0"/>
+                        <a:t>Организации + координаты</a:t>
+                      </a:r>
+                    </a:p>
+                  </a:txBody>
+                  <a:tcPr>
+                    <a:solidFill>
+                      <a:srgbClr val="EAF2F8"/>
+                    </a:solidFill>
+                  </a:tcPr>
+                </a:tc>
+                <a:tc>
+                  <a:txBody>
+                    <a:bodyPr wrap="square"/>
+                    <a:lstStyle/>
+                    <a:p>
+                      <a:r>
+                        <a:rPr sz="1000" b="0"/>
+                        <a:t>institution, latitude, longitude</a:t>
+                      </a:r>
+                    </a:p>
+                  </a:txBody>
+                  <a:tcPr>
+                    <a:solidFill>
+                      <a:srgbClr val="EAF2F8"/>
+                    </a:solidFill>
+                  </a:tcPr>
+                </a:tc>
+              </a:tr>
+              <a:tr h="607500">
+                <a:tc>
+                  <a:txBody>
+                    <a:bodyPr wrap="square"/>
+                    <a:lstStyle/>
+                    <a:p>
+                      <a:r>
+                        <a:rPr sz="1000" b="1">
+                          <a:solidFill>
+                            <a:srgbClr val="1A5C94"/>
+                          </a:solidFill>
+                        </a:rPr>
+                        <a:t>publication_authors</a:t>
+                      </a:r>
+                    </a:p>
+                  </a:txBody>
+                  <a:tcPr/>
+                </a:tc>
+                <a:tc>
+                  <a:txBody>
+                    <a:bodyPr wrap="square"/>
+                    <a:lstStyle/>
+                    <a:p>
+                      <a:r>
+                        <a:rPr sz="1000" b="0"/>
+                        <a:t>Публикация ↔ Автор</a:t>
+                      </a:r>
+                    </a:p>
+                  </a:txBody>
+                  <a:tcPr/>
+                </a:tc>
+                <a:tc>
+                  <a:txBody>
+                    <a:bodyPr wrap="square"/>
+                    <a:lstStyle/>
+                    <a:p>
+                      <a:r>
+                        <a:rPr sz="1000" b="0"/>
+                        <a:t>publication_id, person_id</a:t>
+                      </a:r>
+                    </a:p>
+                  </a:txBody>
+                  <a:tcPr/>
+                </a:tc>
+              </a:tr>
+              <a:tr h="607500">
+                <a:tc>
+                  <a:txBody>
+                    <a:bodyPr wrap="square"/>
+                    <a:lstStyle/>
+                    <a:p>
+                      <a:r>
+                        <a:rPr sz="1000" b="1">
+                          <a:solidFill>
+                            <a:srgbClr val="1A5C94"/>
+                          </a:solidFill>
+                        </a:rPr>
+                        <a:t>publication_topics</a:t>
+                      </a:r>
+                    </a:p>
+                  </a:txBody>
+                  <a:tcPr>
+                    <a:solidFill>
+                      <a:srgbClr val="EAF2F8"/>
+                    </a:solidFill>
+                  </a:tcPr>
+                </a:tc>
+                <a:tc>
+                  <a:txBody>
+                    <a:bodyPr wrap="square"/>
+                    <a:lstStyle/>
+                    <a:p>
+                      <a:r>
+                        <a:rPr sz="1000" b="0"/>
+                        <a:t>Тематические классификаторы</a:t>
+                      </a:r>
+                    </a:p>
+                  </a:txBody>
+                  <a:tcPr>
+                    <a:solidFill>
+                      <a:srgbClr val="EAF2F8"/>
+                    </a:solidFill>
+                  </a:tcPr>
+                </a:tc>
+                <a:tc>
+                  <a:txBody>
+                    <a:bodyPr wrap="square"/>
+                    <a:lstStyle/>
+                    <a:p>
+                      <a:r>
+                        <a:rPr sz="1000" b="0"/>
+                        <a:t>topic_name, score</a:t>
+                      </a:r>
+                    </a:p>
+                  </a:txBody>
+                  <a:tcPr>
+                    <a:solidFill>
+                      <a:srgbClr val="EAF2F8"/>
+                    </a:solidFill>
+                  </a:tcPr>
+                </a:tc>
+              </a:tr>
+              <a:tr h="607500">
+                <a:tc>
+                  <a:txBody>
+                    <a:bodyPr wrap="square"/>
+                    <a:lstStyle/>
+                    <a:p>
+                      <a:r>
+                        <a:rPr sz="1000" b="1">
+                          <a:solidFill>
+                            <a:srgbClr val="1A5C94"/>
+                          </a:solidFill>
+                        </a:rPr>
+                        <a:t>publication_keywords</a:t>
+                      </a:r>
+                    </a:p>
+                  </a:txBody>
+                  <a:tcPr/>
+                </a:tc>
+                <a:tc>
+                  <a:txBody>
+                    <a:bodyPr wrap="square"/>
+                    <a:lstStyle/>
+                    <a:p>
+                      <a:r>
+                        <a:rPr sz="1000" b="0"/>
+                        <a:t>Ключевые слова</a:t>
+                      </a:r>
+                    </a:p>
+                  </a:txBody>
+                  <a:tcPr/>
+                </a:tc>
+                <a:tc>
+                  <a:txBody>
+                    <a:bodyPr wrap="square"/>
+                    <a:lstStyle/>
+                    <a:p>
+                      <a:r>
+                        <a:rPr sz="1000" b="0"/>
+                        <a:t>keyword_name, score</a:t>
+                      </a:r>
+                    </a:p>
+                  </a:txBody>
+                  <a:tcPr/>
+                </a:tc>
+              </a:tr>
+            </a:tbl>
+          </a:graphicData>
+        </a:graphic>
+      </p:graphicFrame>
     </p:spTree>
   </p:cSld>
   <p:clrMapOvr>

</xml_diff>

<commit_message>
fix(presentation): translate chart labels to Russian on slide 5
- Growing topics: Neural Nets→Нейронные сети, Domain Adapt.→Доменная адаптация, Cancer Screen.→Онко-скрининг
- Declining topics: Chem. Physics→Хим. физика, Graphene→Графен, Battery Mat.→Материалы АКБ, Genomics→Геномика

https://claude.ai/code/session_01JXZNXE9oVEv7rsUiTvXR5D
</commit_message>
<xml_diff>
--- a/docs/Визуализация науки на основе метаданных публикаций и журналов.pptx
+++ b/docs/Визуализация науки на основе метаданных публикаций и журналов.pptx
@@ -485,6 +485,372 @@
 </c:chartSpace>
 </file>
 
+<file path=ppt/charts/chart3.xml><?xml version="1.0" encoding="utf-8"?>
+<c:chartSpace xmlns:c="http://schemas.openxmlformats.org/drawingml/2006/chart" xmlns:a="http://schemas.openxmlformats.org/drawingml/2006/main" xmlns:r="http://schemas.openxmlformats.org/officeDocument/2006/relationships">
+  <c:date1904 val="0"/>
+  <c:chart>
+    <c:autoTitleDeleted val="1"/>
+    <c:plotArea>
+      <c:barChart>
+        <c:barDir val="bar"/>
+        <c:grouping val="clustered"/>
+        <c:ser>
+          <c:idx val="0"/>
+          <c:order val="0"/>
+          <c:tx>
+            <c:strRef>
+              <c:f>Sheet1!$B$1</c:f>
+              <c:strCache>
+                <c:ptCount val="1"/>
+                <c:pt idx="0">
+                  <c:v>2000–2012</c:v>
+                </c:pt>
+              </c:strCache>
+            </c:strRef>
+          </c:tx>
+          <c:spPr>
+            <a:solidFill>
+              <a:srgbClr val="AED6F1"/>
+            </a:solidFill>
+          </c:spPr>
+          <c:cat>
+            <c:strRef>
+              <c:f>Sheet1!$A$2:$A$5</c:f>
+              <c:strCache>
+                <c:ptCount val="4"/>
+                <c:pt idx="0">
+                  <c:v>Нейронные сети</c:v>
+                </c:pt>
+                <c:pt idx="1">
+                  <c:v>COVID-19</c:v>
+                </c:pt>
+                <c:pt idx="2">
+                  <c:v>Доменная адаптация</c:v>
+                </c:pt>
+                <c:pt idx="3">
+                  <c:v>Онко-скрининг</c:v>
+                </c:pt>
+              </c:strCache>
+            </c:strRef>
+          </c:cat>
+          <c:val>
+            <c:numRef>
+              <c:f>Sheet1!$B$2:$B$5</c:f>
+              <c:numCache>
+                <c:formatCode>General</c:formatCode>
+                <c:ptCount val="4"/>
+                <c:pt idx="0">
+                  <c:v>0</c:v>
+                </c:pt>
+                <c:pt idx="1">
+                  <c:v>0</c:v>
+                </c:pt>
+                <c:pt idx="2">
+                  <c:v>3</c:v>
+                </c:pt>
+                <c:pt idx="3">
+                  <c:v>3</c:v>
+                </c:pt>
+              </c:numCache>
+            </c:numRef>
+          </c:val>
+        </c:ser>
+        <c:ser>
+          <c:idx val="1"/>
+          <c:order val="1"/>
+          <c:tx>
+            <c:strRef>
+              <c:f>Sheet1!$C$1</c:f>
+              <c:strCache>
+                <c:ptCount val="1"/>
+                <c:pt idx="0">
+                  <c:v>2013–2024</c:v>
+                </c:pt>
+              </c:strCache>
+            </c:strRef>
+          </c:tx>
+          <c:spPr>
+            <a:solidFill>
+              <a:srgbClr val="27AE60"/>
+            </a:solidFill>
+          </c:spPr>
+          <c:cat>
+            <c:strRef>
+              <c:f>Sheet1!$A$2:$A$5</c:f>
+              <c:strCache>
+                <c:ptCount val="4"/>
+                <c:pt idx="0">
+                  <c:v>Нейронные сети</c:v>
+                </c:pt>
+                <c:pt idx="1">
+                  <c:v>COVID-19</c:v>
+                </c:pt>
+                <c:pt idx="2">
+                  <c:v>Доменная адаптация</c:v>
+                </c:pt>
+                <c:pt idx="3">
+                  <c:v>Онко-скрининг</c:v>
+                </c:pt>
+              </c:strCache>
+            </c:strRef>
+          </c:cat>
+          <c:val>
+            <c:numRef>
+              <c:f>Sheet1!$C$2:$C$5</c:f>
+              <c:numCache>
+                <c:formatCode>General</c:formatCode>
+                <c:ptCount val="4"/>
+                <c:pt idx="0">
+                  <c:v>25</c:v>
+                </c:pt>
+                <c:pt idx="1">
+                  <c:v>10</c:v>
+                </c:pt>
+                <c:pt idx="2">
+                  <c:v>15</c:v>
+                </c:pt>
+                <c:pt idx="3">
+                  <c:v>13</c:v>
+                </c:pt>
+              </c:numCache>
+            </c:numRef>
+          </c:val>
+        </c:ser>
+        <c:axId val="-2068027336"/>
+        <c:axId val="-2113994440"/>
+      </c:barChart>
+      <c:catAx>
+        <c:axId val="-2068027336"/>
+        <c:scaling>
+          <c:orientation val="minMax"/>
+        </c:scaling>
+        <c:delete val="0"/>
+        <c:axPos val="l"/>
+        <c:majorTickMark val="out"/>
+        <c:minorTickMark val="none"/>
+        <c:tickLblPos val="nextTo"/>
+        <c:crossAx val="-2113994440"/>
+        <c:crosses val="autoZero"/>
+        <c:auto val="1"/>
+        <c:lblAlgn val="ctr"/>
+        <c:lblOffset val="100"/>
+        <c:noMultiLvlLbl val="0"/>
+      </c:catAx>
+      <c:valAx>
+        <c:axId val="-2113994440"/>
+        <c:scaling/>
+        <c:delete val="0"/>
+        <c:axPos val="b"/>
+        <c:majorGridlines/>
+        <c:majorTickMark val="out"/>
+        <c:minorTickMark val="none"/>
+        <c:tickLblPos val="nextTo"/>
+        <c:crossAx val="-2068027336"/>
+        <c:crosses val="autoZero"/>
+      </c:valAx>
+    </c:plotArea>
+    <c:legend/>
+    <c:dispBlanksAs val="gap"/>
+  </c:chart>
+  <c:txPr>
+    <a:bodyPr/>
+    <a:lstStyle/>
+    <a:p>
+      <a:pPr>
+        <a:defRPr sz="1800"/>
+      </a:pPr>
+      <a:endParaRPr lang="en-US"/>
+    </a:p>
+  </c:txPr>
+  <c:externalData r:id="rId1">
+    <c:autoUpdate val="0"/>
+  </c:externalData>
+</c:chartSpace>
+</file>
+
+<file path=ppt/charts/chart4.xml><?xml version="1.0" encoding="utf-8"?>
+<c:chartSpace xmlns:c="http://schemas.openxmlformats.org/drawingml/2006/chart" xmlns:a="http://schemas.openxmlformats.org/drawingml/2006/main" xmlns:r="http://schemas.openxmlformats.org/officeDocument/2006/relationships">
+  <c:date1904 val="0"/>
+  <c:chart>
+    <c:autoTitleDeleted val="1"/>
+    <c:plotArea>
+      <c:barChart>
+        <c:barDir val="bar"/>
+        <c:grouping val="clustered"/>
+        <c:ser>
+          <c:idx val="0"/>
+          <c:order val="0"/>
+          <c:tx>
+            <c:strRef>
+              <c:f>Sheet1!$B$1</c:f>
+              <c:strCache>
+                <c:ptCount val="1"/>
+                <c:pt idx="0">
+                  <c:v>2000–2012</c:v>
+                </c:pt>
+              </c:strCache>
+            </c:strRef>
+          </c:tx>
+          <c:spPr>
+            <a:solidFill>
+              <a:srgbClr val="F5B7B1"/>
+            </a:solidFill>
+          </c:spPr>
+          <c:cat>
+            <c:strRef>
+              <c:f>Sheet1!$A$2:$A$5</c:f>
+              <c:strCache>
+                <c:ptCount val="4"/>
+                <c:pt idx="0">
+                  <c:v>Хим. физика</c:v>
+                </c:pt>
+                <c:pt idx="1">
+                  <c:v>Графен</c:v>
+                </c:pt>
+                <c:pt idx="2">
+                  <c:v>Материалы АКБ</c:v>
+                </c:pt>
+                <c:pt idx="3">
+                  <c:v>Геномика</c:v>
+                </c:pt>
+              </c:strCache>
+            </c:strRef>
+          </c:cat>
+          <c:val>
+            <c:numRef>
+              <c:f>Sheet1!$B$2:$B$5</c:f>
+              <c:numCache>
+                <c:formatCode>General</c:formatCode>
+                <c:ptCount val="4"/>
+                <c:pt idx="0">
+                  <c:v>10</c:v>
+                </c:pt>
+                <c:pt idx="1">
+                  <c:v>8</c:v>
+                </c:pt>
+                <c:pt idx="2">
+                  <c:v>4</c:v>
+                </c:pt>
+                <c:pt idx="3">
+                  <c:v>4</c:v>
+                </c:pt>
+              </c:numCache>
+            </c:numRef>
+          </c:val>
+        </c:ser>
+        <c:ser>
+          <c:idx val="1"/>
+          <c:order val="1"/>
+          <c:tx>
+            <c:strRef>
+              <c:f>Sheet1!$C$1</c:f>
+              <c:strCache>
+                <c:ptCount val="1"/>
+                <c:pt idx="0">
+                  <c:v>2013–2024</c:v>
+                </c:pt>
+              </c:strCache>
+            </c:strRef>
+          </c:tx>
+          <c:spPr>
+            <a:solidFill>
+              <a:srgbClr val="C0392B"/>
+            </a:solidFill>
+          </c:spPr>
+          <c:cat>
+            <c:strRef>
+              <c:f>Sheet1!$A$2:$A$5</c:f>
+              <c:strCache>
+                <c:ptCount val="4"/>
+                <c:pt idx="0">
+                  <c:v>Хим. физика</c:v>
+                </c:pt>
+                <c:pt idx="1">
+                  <c:v>Графен</c:v>
+                </c:pt>
+                <c:pt idx="2">
+                  <c:v>Материалы АКБ</c:v>
+                </c:pt>
+                <c:pt idx="3">
+                  <c:v>Геномика</c:v>
+                </c:pt>
+              </c:strCache>
+            </c:strRef>
+          </c:cat>
+          <c:val>
+            <c:numRef>
+              <c:f>Sheet1!$C$2:$C$5</c:f>
+              <c:numCache>
+                <c:formatCode>General</c:formatCode>
+                <c:ptCount val="4"/>
+                <c:pt idx="0">
+                  <c:v>0</c:v>
+                </c:pt>
+                <c:pt idx="1">
+                  <c:v>0</c:v>
+                </c:pt>
+                <c:pt idx="2">
+                  <c:v>0</c:v>
+                </c:pt>
+                <c:pt idx="3">
+                  <c:v>0</c:v>
+                </c:pt>
+              </c:numCache>
+            </c:numRef>
+          </c:val>
+        </c:ser>
+        <c:axId val="-2068027336"/>
+        <c:axId val="-2113994440"/>
+      </c:barChart>
+      <c:catAx>
+        <c:axId val="-2068027336"/>
+        <c:scaling>
+          <c:orientation val="minMax"/>
+        </c:scaling>
+        <c:delete val="0"/>
+        <c:axPos val="l"/>
+        <c:majorTickMark val="out"/>
+        <c:minorTickMark val="none"/>
+        <c:tickLblPos val="nextTo"/>
+        <c:crossAx val="-2113994440"/>
+        <c:crosses val="autoZero"/>
+        <c:auto val="1"/>
+        <c:lblAlgn val="ctr"/>
+        <c:lblOffset val="100"/>
+        <c:noMultiLvlLbl val="0"/>
+      </c:catAx>
+      <c:valAx>
+        <c:axId val="-2113994440"/>
+        <c:scaling/>
+        <c:delete val="0"/>
+        <c:axPos val="b"/>
+        <c:majorGridlines/>
+        <c:majorTickMark val="out"/>
+        <c:minorTickMark val="none"/>
+        <c:tickLblPos val="nextTo"/>
+        <c:crossAx val="-2068027336"/>
+        <c:crosses val="autoZero"/>
+      </c:valAx>
+    </c:plotArea>
+    <c:legend/>
+    <c:dispBlanksAs val="gap"/>
+  </c:chart>
+  <c:txPr>
+    <a:bodyPr/>
+    <a:lstStyle/>
+    <a:p>
+      <a:pPr>
+        <a:defRPr sz="1800"/>
+      </a:pPr>
+      <a:endParaRPr lang="en-US"/>
+    </a:p>
+  </c:txPr>
+  <c:externalData r:id="rId1">
+    <c:autoUpdate val="0"/>
+  </c:externalData>
+</c:chartSpace>
+</file>
+
 <file path=ppt/slideLayouts/slideLayout1.xml><?xml version="1.0" encoding="utf-8"?>
 <p:sldLayout xmlns:a="http://schemas.openxmlformats.org/drawingml/2006/main" xmlns:r="http://schemas.openxmlformats.org/officeDocument/2006/relationships" xmlns:p="http://schemas.openxmlformats.org/presentationml/2006/main" type="title" preserve="1">
   <p:cSld name="Title Slide">
@@ -10813,7 +11179,7 @@
         </p:xfrm>
         <a:graphic>
           <a:graphicData uri="http://schemas.openxmlformats.org/drawingml/2006/chart">
-            <c:chart xmlns:c="http://schemas.openxmlformats.org/drawingml/2006/chart" r:id="rId2"/>
+            <c:chart xmlns:c="http://schemas.openxmlformats.org/drawingml/2006/chart" r:id="rId4"/>
           </a:graphicData>
         </a:graphic>
       </p:graphicFrame>
@@ -10831,7 +11197,7 @@
         </p:xfrm>
         <a:graphic>
           <a:graphicData uri="http://schemas.openxmlformats.org/drawingml/2006/chart">
-            <c:chart xmlns:c="http://schemas.openxmlformats.org/drawingml/2006/chart" r:id="rId3"/>
+            <c:chart xmlns:c="http://schemas.openxmlformats.org/drawingml/2006/chart" r:id="rId5"/>
           </a:graphicData>
         </a:graphic>
       </p:graphicFrame>

</xml_diff>

<commit_message>
feat(presentation): add charts to slides 2 and 8
- Slide 2 (Актуальность): столбчатый график роста числа публикаций
  по годам 2000–2024 на реальных данных из БД
- Slide 8 (Геокодирование): круговая диаграмма охвата —
  Этап 1 OpenAlex 78% / Этап 2 Photon 2.8% / без координат 19.2%

https://claude.ai/code/session_01JXZNXE9oVEv7rsUiTvXR5D
</commit_message>
<xml_diff>
--- a/docs/Визуализация науки на основе метаданных публикаций и журналов.pptx
+++ b/docs/Визуализация науки на основе метаданных публикаций и журналов.pptx
@@ -4,22 +4,25 @@
   <p:sldMasterIdLst>
     <p:sldMasterId id="2147483648" r:id="rId1"/>
   </p:sldMasterIdLst>
+  <p:notesMasterIdLst>
+    <p:notesMasterId r:id="rId15"/>
+  </p:notesMasterIdLst>
   <p:sldIdLst>
-    <p:sldId id="256" r:id="rId7"/>
-    <p:sldId id="258" r:id="rId9"/>
-    <p:sldId id="257" r:id="rId8"/>
-    <p:sldId id="269" r:id="rId20"/>
-    <p:sldId id="268" r:id="rId19"/>
-    <p:sldId id="259" r:id="rId10"/>
-    <p:sldId id="260" r:id="rId11"/>
-    <p:sldId id="261" r:id="rId12"/>
-    <p:sldId id="262" r:id="rId13"/>
-    <p:sldId id="263" r:id="rId14"/>
-    <p:sldId id="264" r:id="rId15"/>
-    <p:sldId id="265" r:id="rId16"/>
-    <p:sldId id="266" r:id="rId17"/>
+    <p:sldId id="256" r:id="rId2"/>
+    <p:sldId id="258" r:id="rId3"/>
+    <p:sldId id="257" r:id="rId4"/>
+    <p:sldId id="269" r:id="rId5"/>
+    <p:sldId id="268" r:id="rId6"/>
+    <p:sldId id="259" r:id="rId7"/>
+    <p:sldId id="260" r:id="rId8"/>
+    <p:sldId id="261" r:id="rId9"/>
+    <p:sldId id="262" r:id="rId10"/>
+    <p:sldId id="263" r:id="rId11"/>
+    <p:sldId id="264" r:id="rId12"/>
+    <p:sldId id="265" r:id="rId13"/>
+    <p:sldId id="266" r:id="rId14"/>
   </p:sldIdLst>
-  <p:sldSz cx="12188952" cy="6858000" type="screen4x3"/>
+  <p:sldSz cx="12188825" cy="6858000"/>
   <p:notesSz cx="6858000" cy="9144000"/>
   <p:defaultTextStyle>
     <a:defPPr>
@@ -116,18 +119,39 @@
       </a:defRPr>
     </a:lvl9pPr>
   </p:defaultTextStyle>
+  <p:extLst>
+    <p:ext uri="{EFAFB233-063F-42B5-8137-9DF3F51BA10A}">
+      <p15:sldGuideLst xmlns:p15="http://schemas.microsoft.com/office/powerpoint/2012/main">
+        <p15:guide id="1" orient="horz" pos="2160">
+          <p15:clr>
+            <a:srgbClr val="A4A3A4"/>
+          </p15:clr>
+        </p15:guide>
+        <p15:guide id="2" pos="2880">
+          <p15:clr>
+            <a:srgbClr val="A4A3A4"/>
+          </p15:clr>
+        </p15:guide>
+      </p15:sldGuideLst>
+    </p:ext>
+  </p:extLst>
 </p:presentation>
 </file>
 
 <file path=ppt/charts/chart1.xml><?xml version="1.0" encoding="utf-8"?>
-<c:chartSpace xmlns:c="http://schemas.openxmlformats.org/drawingml/2006/chart" xmlns:a="http://schemas.openxmlformats.org/drawingml/2006/main" xmlns:r="http://schemas.openxmlformats.org/officeDocument/2006/relationships">
+<c:chartSpace xmlns:c="http://schemas.openxmlformats.org/drawingml/2006/chart" xmlns:a="http://schemas.openxmlformats.org/drawingml/2006/main" xmlns:r="http://schemas.openxmlformats.org/officeDocument/2006/relationships" xmlns:c16r2="http://schemas.microsoft.com/office/drawing/2015/06/chart">
   <c:date1904 val="0"/>
+  <c:lang val="ru-RU"/>
+  <c:roundedCorners val="1"/>
+  <c:style val="2"/>
   <c:chart>
     <c:autoTitleDeleted val="1"/>
     <c:plotArea>
+      <c:layout/>
       <c:barChart>
         <c:barDir val="bar"/>
         <c:grouping val="clustered"/>
+        <c:varyColors val="1"/>
         <c:ser>
           <c:idx val="0"/>
           <c:order val="0"/>
@@ -147,372 +171,7 @@
               <a:srgbClr val="AED6F1"/>
             </a:solidFill>
           </c:spPr>
-          <c:cat>
-            <c:strRef>
-              <c:f>Sheet1!$A$2:$A$5</c:f>
-              <c:strCache>
-                <c:ptCount val="4"/>
-                <c:pt idx="0">
-                  <c:v>Neural Nets</c:v>
-                </c:pt>
-                <c:pt idx="1">
-                  <c:v>COVID-19</c:v>
-                </c:pt>
-                <c:pt idx="2">
-                  <c:v>Domain Adapt.</c:v>
-                </c:pt>
-                <c:pt idx="3">
-                  <c:v>Cancer Screen.</c:v>
-                </c:pt>
-              </c:strCache>
-            </c:strRef>
-          </c:cat>
-          <c:val>
-            <c:numRef>
-              <c:f>Sheet1!$B$2:$B$5</c:f>
-              <c:numCache>
-                <c:formatCode>General</c:formatCode>
-                <c:ptCount val="4"/>
-                <c:pt idx="0">
-                  <c:v>0</c:v>
-                </c:pt>
-                <c:pt idx="1">
-                  <c:v>0</c:v>
-                </c:pt>
-                <c:pt idx="2">
-                  <c:v>3</c:v>
-                </c:pt>
-                <c:pt idx="3">
-                  <c:v>3</c:v>
-                </c:pt>
-              </c:numCache>
-            </c:numRef>
-          </c:val>
-        </c:ser>
-        <c:ser>
-          <c:idx val="1"/>
-          <c:order val="1"/>
-          <c:tx>
-            <c:strRef>
-              <c:f>Sheet1!$C$1</c:f>
-              <c:strCache>
-                <c:ptCount val="1"/>
-                <c:pt idx="0">
-                  <c:v>2013–2024</c:v>
-                </c:pt>
-              </c:strCache>
-            </c:strRef>
-          </c:tx>
-          <c:spPr>
-            <a:solidFill>
-              <a:srgbClr val="27AE60"/>
-            </a:solidFill>
-          </c:spPr>
-          <c:cat>
-            <c:strRef>
-              <c:f>Sheet1!$A$2:$A$5</c:f>
-              <c:strCache>
-                <c:ptCount val="4"/>
-                <c:pt idx="0">
-                  <c:v>Neural Nets</c:v>
-                </c:pt>
-                <c:pt idx="1">
-                  <c:v>COVID-19</c:v>
-                </c:pt>
-                <c:pt idx="2">
-                  <c:v>Domain Adapt.</c:v>
-                </c:pt>
-                <c:pt idx="3">
-                  <c:v>Cancer Screen.</c:v>
-                </c:pt>
-              </c:strCache>
-            </c:strRef>
-          </c:cat>
-          <c:val>
-            <c:numRef>
-              <c:f>Sheet1!$C$2:$C$5</c:f>
-              <c:numCache>
-                <c:formatCode>General</c:formatCode>
-                <c:ptCount val="4"/>
-                <c:pt idx="0">
-                  <c:v>25</c:v>
-                </c:pt>
-                <c:pt idx="1">
-                  <c:v>10</c:v>
-                </c:pt>
-                <c:pt idx="2">
-                  <c:v>15</c:v>
-                </c:pt>
-                <c:pt idx="3">
-                  <c:v>13</c:v>
-                </c:pt>
-              </c:numCache>
-            </c:numRef>
-          </c:val>
-        </c:ser>
-        <c:axId val="-2068027336"/>
-        <c:axId val="-2113994440"/>
-      </c:barChart>
-      <c:catAx>
-        <c:axId val="-2068027336"/>
-        <c:scaling>
-          <c:orientation val="minMax"/>
-        </c:scaling>
-        <c:delete val="0"/>
-        <c:axPos val="l"/>
-        <c:majorTickMark val="out"/>
-        <c:minorTickMark val="none"/>
-        <c:tickLblPos val="nextTo"/>
-        <c:crossAx val="-2113994440"/>
-        <c:crosses val="autoZero"/>
-        <c:auto val="1"/>
-        <c:lblAlgn val="ctr"/>
-        <c:lblOffset val="100"/>
-        <c:noMultiLvlLbl val="0"/>
-      </c:catAx>
-      <c:valAx>
-        <c:axId val="-2113994440"/>
-        <c:scaling/>
-        <c:delete val="0"/>
-        <c:axPos val="b"/>
-        <c:majorGridlines/>
-        <c:majorTickMark val="out"/>
-        <c:minorTickMark val="none"/>
-        <c:tickLblPos val="nextTo"/>
-        <c:crossAx val="-2068027336"/>
-        <c:crosses val="autoZero"/>
-      </c:valAx>
-    </c:plotArea>
-    <c:legend/>
-    <c:dispBlanksAs val="gap"/>
-  </c:chart>
-  <c:txPr>
-    <a:bodyPr/>
-    <a:lstStyle/>
-    <a:p>
-      <a:pPr>
-        <a:defRPr sz="1800"/>
-      </a:pPr>
-      <a:endParaRPr lang="en-US"/>
-    </a:p>
-  </c:txPr>
-  <c:externalData r:id="rId1">
-    <c:autoUpdate val="0"/>
-  </c:externalData>
-</c:chartSpace>
-</file>
-
-<file path=ppt/charts/chart2.xml><?xml version="1.0" encoding="utf-8"?>
-<c:chartSpace xmlns:c="http://schemas.openxmlformats.org/drawingml/2006/chart" xmlns:a="http://schemas.openxmlformats.org/drawingml/2006/main" xmlns:r="http://schemas.openxmlformats.org/officeDocument/2006/relationships">
-  <c:date1904 val="0"/>
-  <c:chart>
-    <c:autoTitleDeleted val="1"/>
-    <c:plotArea>
-      <c:barChart>
-        <c:barDir val="bar"/>
-        <c:grouping val="clustered"/>
-        <c:ser>
-          <c:idx val="0"/>
-          <c:order val="0"/>
-          <c:tx>
-            <c:strRef>
-              <c:f>Sheet1!$B$1</c:f>
-              <c:strCache>
-                <c:ptCount val="1"/>
-                <c:pt idx="0">
-                  <c:v>2000–2012</c:v>
-                </c:pt>
-              </c:strCache>
-            </c:strRef>
-          </c:tx>
-          <c:spPr>
-            <a:solidFill>
-              <a:srgbClr val="F5B7B1"/>
-            </a:solidFill>
-          </c:spPr>
-          <c:cat>
-            <c:strRef>
-              <c:f>Sheet1!$A$2:$A$5</c:f>
-              <c:strCache>
-                <c:ptCount val="4"/>
-                <c:pt idx="0">
-                  <c:v>Chem. Physics</c:v>
-                </c:pt>
-                <c:pt idx="1">
-                  <c:v>Graphene</c:v>
-                </c:pt>
-                <c:pt idx="2">
-                  <c:v>Battery Mat.</c:v>
-                </c:pt>
-                <c:pt idx="3">
-                  <c:v>Genomics</c:v>
-                </c:pt>
-              </c:strCache>
-            </c:strRef>
-          </c:cat>
-          <c:val>
-            <c:numRef>
-              <c:f>Sheet1!$B$2:$B$5</c:f>
-              <c:numCache>
-                <c:formatCode>General</c:formatCode>
-                <c:ptCount val="4"/>
-                <c:pt idx="0">
-                  <c:v>10</c:v>
-                </c:pt>
-                <c:pt idx="1">
-                  <c:v>8</c:v>
-                </c:pt>
-                <c:pt idx="2">
-                  <c:v>4</c:v>
-                </c:pt>
-                <c:pt idx="3">
-                  <c:v>4</c:v>
-                </c:pt>
-              </c:numCache>
-            </c:numRef>
-          </c:val>
-        </c:ser>
-        <c:ser>
-          <c:idx val="1"/>
-          <c:order val="1"/>
-          <c:tx>
-            <c:strRef>
-              <c:f>Sheet1!$C$1</c:f>
-              <c:strCache>
-                <c:ptCount val="1"/>
-                <c:pt idx="0">
-                  <c:v>2013–2024</c:v>
-                </c:pt>
-              </c:strCache>
-            </c:strRef>
-          </c:tx>
-          <c:spPr>
-            <a:solidFill>
-              <a:srgbClr val="C0392B"/>
-            </a:solidFill>
-          </c:spPr>
-          <c:cat>
-            <c:strRef>
-              <c:f>Sheet1!$A$2:$A$5</c:f>
-              <c:strCache>
-                <c:ptCount val="4"/>
-                <c:pt idx="0">
-                  <c:v>Chem. Physics</c:v>
-                </c:pt>
-                <c:pt idx="1">
-                  <c:v>Graphene</c:v>
-                </c:pt>
-                <c:pt idx="2">
-                  <c:v>Battery Mat.</c:v>
-                </c:pt>
-                <c:pt idx="3">
-                  <c:v>Genomics</c:v>
-                </c:pt>
-              </c:strCache>
-            </c:strRef>
-          </c:cat>
-          <c:val>
-            <c:numRef>
-              <c:f>Sheet1!$C$2:$C$5</c:f>
-              <c:numCache>
-                <c:formatCode>General</c:formatCode>
-                <c:ptCount val="4"/>
-                <c:pt idx="0">
-                  <c:v>0</c:v>
-                </c:pt>
-                <c:pt idx="1">
-                  <c:v>0</c:v>
-                </c:pt>
-                <c:pt idx="2">
-                  <c:v>0</c:v>
-                </c:pt>
-                <c:pt idx="3">
-                  <c:v>0</c:v>
-                </c:pt>
-              </c:numCache>
-            </c:numRef>
-          </c:val>
-        </c:ser>
-        <c:axId val="-2068027336"/>
-        <c:axId val="-2113994440"/>
-      </c:barChart>
-      <c:catAx>
-        <c:axId val="-2068027336"/>
-        <c:scaling>
-          <c:orientation val="minMax"/>
-        </c:scaling>
-        <c:delete val="0"/>
-        <c:axPos val="l"/>
-        <c:majorTickMark val="out"/>
-        <c:minorTickMark val="none"/>
-        <c:tickLblPos val="nextTo"/>
-        <c:crossAx val="-2113994440"/>
-        <c:crosses val="autoZero"/>
-        <c:auto val="1"/>
-        <c:lblAlgn val="ctr"/>
-        <c:lblOffset val="100"/>
-        <c:noMultiLvlLbl val="0"/>
-      </c:catAx>
-      <c:valAx>
-        <c:axId val="-2113994440"/>
-        <c:scaling/>
-        <c:delete val="0"/>
-        <c:axPos val="b"/>
-        <c:majorGridlines/>
-        <c:majorTickMark val="out"/>
-        <c:minorTickMark val="none"/>
-        <c:tickLblPos val="nextTo"/>
-        <c:crossAx val="-2068027336"/>
-        <c:crosses val="autoZero"/>
-      </c:valAx>
-    </c:plotArea>
-    <c:legend/>
-    <c:dispBlanksAs val="gap"/>
-  </c:chart>
-  <c:txPr>
-    <a:bodyPr/>
-    <a:lstStyle/>
-    <a:p>
-      <a:pPr>
-        <a:defRPr sz="1800"/>
-      </a:pPr>
-      <a:endParaRPr lang="en-US"/>
-    </a:p>
-  </c:txPr>
-  <c:externalData r:id="rId1">
-    <c:autoUpdate val="0"/>
-  </c:externalData>
-</c:chartSpace>
-</file>
-
-<file path=ppt/charts/chart3.xml><?xml version="1.0" encoding="utf-8"?>
-<c:chartSpace xmlns:c="http://schemas.openxmlformats.org/drawingml/2006/chart" xmlns:a="http://schemas.openxmlformats.org/drawingml/2006/main" xmlns:r="http://schemas.openxmlformats.org/officeDocument/2006/relationships">
-  <c:date1904 val="0"/>
-  <c:chart>
-    <c:autoTitleDeleted val="1"/>
-    <c:plotArea>
-      <c:barChart>
-        <c:barDir val="bar"/>
-        <c:grouping val="clustered"/>
-        <c:ser>
-          <c:idx val="0"/>
-          <c:order val="0"/>
-          <c:tx>
-            <c:strRef>
-              <c:f>Sheet1!$B$1</c:f>
-              <c:strCache>
-                <c:ptCount val="1"/>
-                <c:pt idx="0">
-                  <c:v>2000–2012</c:v>
-                </c:pt>
-              </c:strCache>
-            </c:strRef>
-          </c:tx>
-          <c:spPr>
-            <a:solidFill>
-              <a:srgbClr val="AED6F1"/>
-            </a:solidFill>
-          </c:spPr>
+          <c:invertIfNegative val="1"/>
           <c:cat>
             <c:strRef>
               <c:f>Sheet1!$A$2:$A$5</c:f>
@@ -554,6 +213,20 @@
               </c:numCache>
             </c:numRef>
           </c:val>
+          <c:extLst>
+            <c:ext xmlns:c14="http://schemas.microsoft.com/office/drawing/2007/8/2/chart" uri="{6F2FDCE9-48DA-4B69-8628-5D25D57E5C99}">
+              <c14:invertSolidFillFmt>
+                <c14:spPr xmlns:c14="http://schemas.microsoft.com/office/drawing/2007/8/2/chart">
+                  <a:solidFill>
+                    <a:srgbClr val="FFFFFF"/>
+                  </a:solidFill>
+                </c14:spPr>
+              </c14:invertSolidFillFmt>
+            </c:ext>
+            <c:ext xmlns:c16="http://schemas.microsoft.com/office/drawing/2014/chart" uri="{C3380CC4-5D6E-409C-BE32-E72D297353CC}">
+              <c16:uniqueId val="{00000000-61EB-4DE0-AB85-FA15581D5D95}"/>
+            </c:ext>
+          </c:extLst>
         </c:ser>
         <c:ser>
           <c:idx val="1"/>
@@ -574,6 +247,7 @@
               <a:srgbClr val="27AE60"/>
             </a:solidFill>
           </c:spPr>
+          <c:invertIfNegative val="1"/>
           <c:cat>
             <c:strRef>
               <c:f>Sheet1!$A$2:$A$5</c:f>
@@ -615,7 +289,30 @@
               </c:numCache>
             </c:numRef>
           </c:val>
+          <c:extLst>
+            <c:ext xmlns:c14="http://schemas.microsoft.com/office/drawing/2007/8/2/chart" uri="{6F2FDCE9-48DA-4B69-8628-5D25D57E5C99}">
+              <c14:invertSolidFillFmt>
+                <c14:spPr xmlns:c14="http://schemas.microsoft.com/office/drawing/2007/8/2/chart">
+                  <a:solidFill>
+                    <a:srgbClr val="FFFFFF"/>
+                  </a:solidFill>
+                </c14:spPr>
+              </c14:invertSolidFillFmt>
+            </c:ext>
+            <c:ext xmlns:c16="http://schemas.microsoft.com/office/drawing/2014/chart" uri="{C3380CC4-5D6E-409C-BE32-E72D297353CC}">
+              <c16:uniqueId val="{00000001-61EB-4DE0-AB85-FA15581D5D95}"/>
+            </c:ext>
+          </c:extLst>
         </c:ser>
+        <c:dLbls>
+          <c:showLegendKey val="0"/>
+          <c:showVal val="0"/>
+          <c:showCatName val="0"/>
+          <c:showSerName val="0"/>
+          <c:showPercent val="0"/>
+          <c:showBubbleSize val="0"/>
+        </c:dLbls>
+        <c:gapWidth val="150"/>
         <c:axId val="-2068027336"/>
         <c:axId val="-2113994440"/>
       </c:barChart>
@@ -626,6 +323,7 @@
         </c:scaling>
         <c:delete val="0"/>
         <c:axPos val="l"/>
+        <c:numFmt formatCode="General" sourceLinked="0"/>
         <c:majorTickMark val="out"/>
         <c:minorTickMark val="none"/>
         <c:tickLblPos val="nextTo"/>
@@ -638,19 +336,38 @@
       </c:catAx>
       <c:valAx>
         <c:axId val="-2113994440"/>
-        <c:scaling/>
+        <c:scaling>
+          <c:orientation val="minMax"/>
+        </c:scaling>
         <c:delete val="0"/>
         <c:axPos val="b"/>
         <c:majorGridlines/>
+        <c:numFmt formatCode="General" sourceLinked="1"/>
         <c:majorTickMark val="out"/>
         <c:minorTickMark val="none"/>
         <c:tickLblPos val="nextTo"/>
         <c:crossAx val="-2068027336"/>
         <c:crosses val="autoZero"/>
+        <c:crossBetween val="between"/>
       </c:valAx>
     </c:plotArea>
-    <c:legend/>
+    <c:legend>
+      <c:legendPos val="r"/>
+      <c:layout>
+        <c:manualLayout>
+          <c:xMode val="edge"/>
+          <c:yMode val="edge"/>
+          <c:x val="7.9519294743845684E-2"/>
+          <c:y val="0.7265368773946359"/>
+          <c:w val="0.22337491683300068"/>
+          <c:h val="0.27072892720306518"/>
+        </c:manualLayout>
+      </c:layout>
+      <c:overlay val="1"/>
+    </c:legend>
+    <c:plotVisOnly val="1"/>
     <c:dispBlanksAs val="gap"/>
+    <c:showDLblsOverMax val="1"/>
   </c:chart>
   <c:txPr>
     <a:bodyPr/>
@@ -659,7 +376,7 @@
       <a:pPr>
         <a:defRPr sz="1800"/>
       </a:pPr>
-      <a:endParaRPr lang="en-US"/>
+      <a:endParaRPr lang="ru-RU"/>
     </a:p>
   </c:txPr>
   <c:externalData r:id="rId1">
@@ -668,15 +385,20 @@
 </c:chartSpace>
 </file>
 
-<file path=ppt/charts/chart4.xml><?xml version="1.0" encoding="utf-8"?>
-<c:chartSpace xmlns:c="http://schemas.openxmlformats.org/drawingml/2006/chart" xmlns:a="http://schemas.openxmlformats.org/drawingml/2006/main" xmlns:r="http://schemas.openxmlformats.org/officeDocument/2006/relationships">
+<file path=ppt/charts/chart2.xml><?xml version="1.0" encoding="utf-8"?>
+<c:chartSpace xmlns:c="http://schemas.openxmlformats.org/drawingml/2006/chart" xmlns:a="http://schemas.openxmlformats.org/drawingml/2006/main" xmlns:r="http://schemas.openxmlformats.org/officeDocument/2006/relationships" xmlns:c16r2="http://schemas.microsoft.com/office/drawing/2015/06/chart">
   <c:date1904 val="0"/>
+  <c:lang val="ru-RU"/>
+  <c:roundedCorners val="1"/>
+  <c:style val="2"/>
   <c:chart>
     <c:autoTitleDeleted val="1"/>
     <c:plotArea>
+      <c:layout/>
       <c:barChart>
         <c:barDir val="bar"/>
         <c:grouping val="clustered"/>
+        <c:varyColors val="1"/>
         <c:ser>
           <c:idx val="0"/>
           <c:order val="0"/>
@@ -696,6 +418,7 @@
               <a:srgbClr val="F5B7B1"/>
             </a:solidFill>
           </c:spPr>
+          <c:invertIfNegative val="1"/>
           <c:cat>
             <c:strRef>
               <c:f>Sheet1!$A$2:$A$5</c:f>
@@ -737,6 +460,20 @@
               </c:numCache>
             </c:numRef>
           </c:val>
+          <c:extLst>
+            <c:ext xmlns:c14="http://schemas.microsoft.com/office/drawing/2007/8/2/chart" uri="{6F2FDCE9-48DA-4B69-8628-5D25D57E5C99}">
+              <c14:invertSolidFillFmt>
+                <c14:spPr xmlns:c14="http://schemas.microsoft.com/office/drawing/2007/8/2/chart">
+                  <a:solidFill>
+                    <a:srgbClr val="FFFFFF"/>
+                  </a:solidFill>
+                </c14:spPr>
+              </c14:invertSolidFillFmt>
+            </c:ext>
+            <c:ext xmlns:c16="http://schemas.microsoft.com/office/drawing/2014/chart" uri="{C3380CC4-5D6E-409C-BE32-E72D297353CC}">
+              <c16:uniqueId val="{00000000-A758-4BAE-A51F-AA4B05D7D456}"/>
+            </c:ext>
+          </c:extLst>
         </c:ser>
         <c:ser>
           <c:idx val="1"/>
@@ -757,6 +494,7 @@
               <a:srgbClr val="C0392B"/>
             </a:solidFill>
           </c:spPr>
+          <c:invertIfNegative val="1"/>
           <c:cat>
             <c:strRef>
               <c:f>Sheet1!$A$2:$A$5</c:f>
@@ -798,7 +536,30 @@
               </c:numCache>
             </c:numRef>
           </c:val>
+          <c:extLst>
+            <c:ext xmlns:c14="http://schemas.microsoft.com/office/drawing/2007/8/2/chart" uri="{6F2FDCE9-48DA-4B69-8628-5D25D57E5C99}">
+              <c14:invertSolidFillFmt>
+                <c14:spPr xmlns:c14="http://schemas.microsoft.com/office/drawing/2007/8/2/chart">
+                  <a:solidFill>
+                    <a:srgbClr val="FFFFFF"/>
+                  </a:solidFill>
+                </c14:spPr>
+              </c14:invertSolidFillFmt>
+            </c:ext>
+            <c:ext xmlns:c16="http://schemas.microsoft.com/office/drawing/2014/chart" uri="{C3380CC4-5D6E-409C-BE32-E72D297353CC}">
+              <c16:uniqueId val="{00000001-A758-4BAE-A51F-AA4B05D7D456}"/>
+            </c:ext>
+          </c:extLst>
         </c:ser>
+        <c:dLbls>
+          <c:showLegendKey val="0"/>
+          <c:showVal val="0"/>
+          <c:showCatName val="0"/>
+          <c:showSerName val="0"/>
+          <c:showPercent val="0"/>
+          <c:showBubbleSize val="0"/>
+        </c:dLbls>
+        <c:gapWidth val="150"/>
         <c:axId val="-2068027336"/>
         <c:axId val="-2113994440"/>
       </c:barChart>
@@ -809,6 +570,7 @@
         </c:scaling>
         <c:delete val="0"/>
         <c:axPos val="l"/>
+        <c:numFmt formatCode="General" sourceLinked="0"/>
         <c:majorTickMark val="out"/>
         <c:minorTickMark val="none"/>
         <c:tickLblPos val="nextTo"/>
@@ -821,16 +583,153 @@
       </c:catAx>
       <c:valAx>
         <c:axId val="-2113994440"/>
-        <c:scaling/>
+        <c:scaling>
+          <c:orientation val="minMax"/>
+        </c:scaling>
         <c:delete val="0"/>
         <c:axPos val="b"/>
         <c:majorGridlines/>
+        <c:numFmt formatCode="General" sourceLinked="1"/>
         <c:majorTickMark val="out"/>
         <c:minorTickMark val="none"/>
         <c:tickLblPos val="nextTo"/>
         <c:crossAx val="-2068027336"/>
         <c:crosses val="autoZero"/>
+        <c:crossBetween val="between"/>
       </c:valAx>
+    </c:plotArea>
+    <c:legend>
+      <c:legendPos val="r"/>
+      <c:layout>
+        <c:manualLayout>
+          <c:xMode val="edge"/>
+          <c:yMode val="edge"/>
+          <c:x val="2.773905723905724E-2"/>
+          <c:y val="0.7022073754789272"/>
+          <c:w val="0.23891077441077441"/>
+          <c:h val="0.29505842911877395"/>
+        </c:manualLayout>
+      </c:layout>
+      <c:overlay val="1"/>
+    </c:legend>
+    <c:plotVisOnly val="1"/>
+    <c:dispBlanksAs val="gap"/>
+    <c:showDLblsOverMax val="1"/>
+  </c:chart>
+  <c:txPr>
+    <a:bodyPr/>
+    <a:lstStyle/>
+    <a:p>
+      <a:pPr>
+        <a:defRPr sz="1800"/>
+      </a:pPr>
+      <a:endParaRPr lang="ru-RU"/>
+    </a:p>
+  </c:txPr>
+  <c:externalData r:id="rId1">
+    <c:autoUpdate val="0"/>
+  </c:externalData>
+</c:chartSpace>
+</file>
+
+<file path=ppt/charts/chart3.xml><?xml version="1.0" encoding="utf-8"?>
+<c:chartSpace xmlns:c="http://schemas.openxmlformats.org/drawingml/2006/chart" xmlns:a="http://schemas.openxmlformats.org/drawingml/2006/main" xmlns:r="http://schemas.openxmlformats.org/officeDocument/2006/relationships">
+  <c:chart>
+    <c:title>
+      <c:tx>
+        <c:rich>
+          <a:bodyPr/>
+          <a:lstStyle/>
+          <a:p>
+            <a:r>
+              <a:rPr sz="1200" b="1"/>
+              <a:t>Охват геокодирования</a:t>
+            </a:r>
+          </a:p>
+        </c:rich>
+      </c:tx>
+      <c:layout/>
+      <c:overlay val="0"/>
+    </c:title>
+    <c:autoTitleDeleted val="0"/>
+    <c:plotArea>
+      <c:pieChart>
+        <c:varyColors val="1"/>
+        <c:ser>
+          <c:idx val="0"/>
+          <c:order val="0"/>
+          <c:tx>
+            <c:strRef>
+              <c:f>Sheet1!$B$1</c:f>
+              <c:strCache>
+                <c:ptCount val="1"/>
+                <c:pt idx="0">
+                  <c:v>Публикации (%)</c:v>
+                </c:pt>
+              </c:strCache>
+            </c:strRef>
+          </c:tx>
+          <c:dPt>
+            <c:idx val="0"/>
+            <c:spPr>
+              <a:solidFill>
+                <a:srgbClr val="276FBF"/>
+              </a:solidFill>
+            </c:spPr>
+          </c:dPt>
+          <c:dPt>
+            <c:idx val="1"/>
+            <c:spPr>
+              <a:solidFill>
+                <a:srgbClr val="27AE60"/>
+              </a:solidFill>
+            </c:spPr>
+          </c:dPt>
+          <c:dPt>
+            <c:idx val="2"/>
+            <c:spPr>
+              <a:solidFill>
+                <a:srgbClr val="BDC3C7"/>
+              </a:solidFill>
+            </c:spPr>
+          </c:dPt>
+          <c:cat>
+            <c:strRef>
+              <c:f>Sheet1!$A$2:$A$4</c:f>
+              <c:strCache>
+                <c:ptCount val="3"/>
+                <c:pt idx="0">
+                  <c:v>Этап 1: OpenAlex API</c:v>
+                </c:pt>
+                <c:pt idx="1">
+                  <c:v>Этап 2: Photon (OSM)</c:v>
+                </c:pt>
+                <c:pt idx="2">
+                  <c:v>Без координат</c:v>
+                </c:pt>
+              </c:strCache>
+            </c:strRef>
+          </c:cat>
+          <c:val>
+            <c:numRef>
+              <c:f>Sheet1!$B$2:$B$4</c:f>
+              <c:numCache>
+                <c:formatCode>General</c:formatCode>
+                <c:ptCount val="3"/>
+                <c:pt idx="0">
+                  <c:v>78.0</c:v>
+                </c:pt>
+                <c:pt idx="1">
+                  <c:v>2.8</c:v>
+                </c:pt>
+                <c:pt idx="2">
+                  <c:v>19.2</c:v>
+                </c:pt>
+              </c:numCache>
+            </c:numRef>
+          </c:val>
+        </c:ser>
+      </c:pieChart>
     </c:plotArea>
     <c:legend/>
     <c:dispBlanksAs val="gap"/>
@@ -851,6 +750,703 @@
 </c:chartSpace>
 </file>
 
+<file path=ppt/charts/chart4.xml><?xml version="1.0" encoding="utf-8"?>
+<c:chartSpace xmlns:c="http://schemas.openxmlformats.org/drawingml/2006/chart" xmlns:a="http://schemas.openxmlformats.org/drawingml/2006/main" xmlns:r="http://schemas.openxmlformats.org/officeDocument/2006/relationships">
+  <c:date1904 val="0"/>
+  <c:chart>
+    <c:title>
+      <c:tx>
+        <c:rich>
+          <a:bodyPr/>
+          <a:lstStyle/>
+          <a:p>
+            <a:r>
+              <a:rPr sz="1100"/>
+              <a:t>Динамика публикационной активности (из базы данных)</a:t>
+            </a:r>
+          </a:p>
+        </c:rich>
+      </c:tx>
+      <c:layout/>
+      <c:overlay val="0"/>
+    </c:title>
+    <c:autoTitleDeleted val="0"/>
+    <c:plotArea>
+      <c:barChart>
+        <c:barDir val="col"/>
+        <c:grouping val="clustered"/>
+        <c:ser>
+          <c:idx val="0"/>
+          <c:order val="0"/>
+          <c:tx>
+            <c:strRef>
+              <c:f>Sheet1!$B$1</c:f>
+              <c:strCache>
+                <c:ptCount val="1"/>
+                <c:pt idx="0">
+                  <c:v>Публикаций</c:v>
+                </c:pt>
+              </c:strCache>
+            </c:strRef>
+          </c:tx>
+          <c:spPr>
+            <a:solidFill>
+              <a:srgbClr val="276FBF"/>
+            </a:solidFill>
+          </c:spPr>
+          <c:cat>
+            <c:strRef>
+              <c:f>Sheet1!$A$2:$A$26</c:f>
+              <c:strCache>
+                <c:ptCount val="25"/>
+                <c:pt idx="0">
+                  <c:v>2000</c:v>
+                </c:pt>
+                <c:pt idx="1">
+                  <c:v>2001</c:v>
+                </c:pt>
+                <c:pt idx="2">
+                  <c:v>2002</c:v>
+                </c:pt>
+                <c:pt idx="3">
+                  <c:v>2003</c:v>
+                </c:pt>
+                <c:pt idx="4">
+                  <c:v>2004</c:v>
+                </c:pt>
+                <c:pt idx="5">
+                  <c:v>2005</c:v>
+                </c:pt>
+                <c:pt idx="6">
+                  <c:v>2006</c:v>
+                </c:pt>
+                <c:pt idx="7">
+                  <c:v>2007</c:v>
+                </c:pt>
+                <c:pt idx="8">
+                  <c:v>2008</c:v>
+                </c:pt>
+                <c:pt idx="9">
+                  <c:v>2009</c:v>
+                </c:pt>
+                <c:pt idx="10">
+                  <c:v>2010</c:v>
+                </c:pt>
+                <c:pt idx="11">
+                  <c:v>2011</c:v>
+                </c:pt>
+                <c:pt idx="12">
+                  <c:v>2012</c:v>
+                </c:pt>
+                <c:pt idx="13">
+                  <c:v>2013</c:v>
+                </c:pt>
+                <c:pt idx="14">
+                  <c:v>2014</c:v>
+                </c:pt>
+                <c:pt idx="15">
+                  <c:v>2015</c:v>
+                </c:pt>
+                <c:pt idx="16">
+                  <c:v>2016</c:v>
+                </c:pt>
+                <c:pt idx="17">
+                  <c:v>2017</c:v>
+                </c:pt>
+                <c:pt idx="18">
+                  <c:v>2018</c:v>
+                </c:pt>
+                <c:pt idx="19">
+                  <c:v>2019</c:v>
+                </c:pt>
+                <c:pt idx="20">
+                  <c:v>2020</c:v>
+                </c:pt>
+                <c:pt idx="21">
+                  <c:v>2021</c:v>
+                </c:pt>
+                <c:pt idx="22">
+                  <c:v>2022</c:v>
+                </c:pt>
+                <c:pt idx="23">
+                  <c:v>2023</c:v>
+                </c:pt>
+                <c:pt idx="24">
+                  <c:v>2024</c:v>
+                </c:pt>
+              </c:strCache>
+            </c:strRef>
+          </c:cat>
+          <c:val>
+            <c:numRef>
+              <c:f>Sheet1!$B$2:$B$26</c:f>
+              <c:numCache>
+                <c:formatCode>General</c:formatCode>
+                <c:ptCount val="25"/>
+                <c:pt idx="0">
+                  <c:v>25</c:v>
+                </c:pt>
+                <c:pt idx="1">
+                  <c:v>21</c:v>
+                </c:pt>
+                <c:pt idx="2">
+                  <c:v>18</c:v>
+                </c:pt>
+                <c:pt idx="3">
+                  <c:v>16</c:v>
+                </c:pt>
+                <c:pt idx="4">
+                  <c:v>16</c:v>
+                </c:pt>
+                <c:pt idx="5">
+                  <c:v>28</c:v>
+                </c:pt>
+                <c:pt idx="6">
+                  <c:v>13</c:v>
+                </c:pt>
+                <c:pt idx="7">
+                  <c:v>30</c:v>
+                </c:pt>
+                <c:pt idx="8">
+                  <c:v>21</c:v>
+                </c:pt>
+                <c:pt idx="9">
+                  <c:v>39</c:v>
+                </c:pt>
+                <c:pt idx="10">
+                  <c:v>19</c:v>
+                </c:pt>
+                <c:pt idx="11">
+                  <c:v>23</c:v>
+                </c:pt>
+                <c:pt idx="12">
+                  <c:v>23</c:v>
+                </c:pt>
+                <c:pt idx="13">
+                  <c:v>17</c:v>
+                </c:pt>
+                <c:pt idx="14">
+                  <c:v>23</c:v>
+                </c:pt>
+                <c:pt idx="15">
+                  <c:v>25</c:v>
+                </c:pt>
+                <c:pt idx="16">
+                  <c:v>22</c:v>
+                </c:pt>
+                <c:pt idx="17">
+                  <c:v>25</c:v>
+                </c:pt>
+                <c:pt idx="18">
+                  <c:v>16</c:v>
+                </c:pt>
+                <c:pt idx="19">
+                  <c:v>11</c:v>
+                </c:pt>
+                <c:pt idx="20">
+                  <c:v>21</c:v>
+                </c:pt>
+                <c:pt idx="21">
+                  <c:v>7</c:v>
+                </c:pt>
+                <c:pt idx="22">
+                  <c:v>3</c:v>
+                </c:pt>
+                <c:pt idx="23">
+                  <c:v>4</c:v>
+                </c:pt>
+                <c:pt idx="24">
+                  <c:v>2</c:v>
+                </c:pt>
+              </c:numCache>
+            </c:numRef>
+          </c:val>
+        </c:ser>
+        <c:axId val="-2068027336"/>
+        <c:axId val="-2113994440"/>
+      </c:barChart>
+      <c:catAx>
+        <c:axId val="-2068027336"/>
+        <c:scaling>
+          <c:orientation val="minMax"/>
+        </c:scaling>
+        <c:delete val="0"/>
+        <c:axPos val="b"/>
+        <c:majorTickMark val="out"/>
+        <c:minorTickMark val="none"/>
+        <c:tickLblPos val="nextTo"/>
+        <c:crossAx val="-2113994440"/>
+        <c:crosses val="autoZero"/>
+        <c:auto val="1"/>
+        <c:lblAlgn val="ctr"/>
+        <c:lblOffset val="100"/>
+        <c:noMultiLvlLbl val="0"/>
+      </c:catAx>
+      <c:valAx>
+        <c:axId val="-2113994440"/>
+        <c:scaling/>
+        <c:delete val="0"/>
+        <c:axPos val="l"/>
+        <c:majorGridlines/>
+        <c:majorTickMark val="out"/>
+        <c:minorTickMark val="none"/>
+        <c:tickLblPos val="nextTo"/>
+        <c:crossAx val="-2068027336"/>
+        <c:crosses val="autoZero"/>
+      </c:valAx>
+    </c:plotArea>
+    <c:dispBlanksAs val="gap"/>
+  </c:chart>
+  <c:txPr>
+    <a:bodyPr/>
+    <a:lstStyle/>
+    <a:p>
+      <a:pPr>
+        <a:defRPr sz="1800"/>
+      </a:pPr>
+      <a:endParaRPr lang="en-US"/>
+    </a:p>
+  </c:txPr>
+  <c:externalData r:id="rId1">
+    <c:autoUpdate val="0"/>
+  </c:externalData>
+</c:chartSpace>
+</file>
+
+<file path=ppt/notesMasters/notesMaster1.xml><?xml version="1.0" encoding="utf-8"?>
+<p:notesMaster xmlns:a="http://schemas.openxmlformats.org/drawingml/2006/main" xmlns:r="http://schemas.openxmlformats.org/officeDocument/2006/relationships" xmlns:p="http://schemas.openxmlformats.org/presentationml/2006/main">
+  <p:cSld>
+    <p:bg>
+      <p:bgRef idx="1001">
+        <a:schemeClr val="bg1"/>
+      </p:bgRef>
+    </p:bg>
+    <p:spTree>
+      <p:nvGrpSpPr>
+        <p:cNvPr id="1" name=""/>
+        <p:cNvGrpSpPr/>
+        <p:nvPr/>
+      </p:nvGrpSpPr>
+      <p:grpSpPr>
+        <a:xfrm>
+          <a:off x="0" y="0"/>
+          <a:ext cx="0" cy="0"/>
+          <a:chOff x="0" y="0"/>
+          <a:chExt cx="0" cy="0"/>
+        </a:xfrm>
+      </p:grpSpPr>
+      <p:sp>
+        <p:nvSpPr>
+          <p:cNvPr id="2" name="Верхний колонтитул 1"/>
+          <p:cNvSpPr>
+            <a:spLocks noGrp="1"/>
+          </p:cNvSpPr>
+          <p:nvPr>
+            <p:ph type="hdr" sz="quarter"/>
+          </p:nvPr>
+        </p:nvSpPr>
+        <p:spPr>
+          <a:xfrm>
+            <a:off x="0" y="0"/>
+            <a:ext cx="2971800" cy="458788"/>
+          </a:xfrm>
+          <a:prstGeom prst="rect">
+            <a:avLst/>
+          </a:prstGeom>
+        </p:spPr>
+        <p:txBody>
+          <a:bodyPr vert="horz" lIns="91440" tIns="45720" rIns="91440" bIns="45720" rtlCol="0"/>
+          <a:lstStyle>
+            <a:lvl1pPr algn="l">
+              <a:defRPr sz="1200"/>
+            </a:lvl1pPr>
+          </a:lstStyle>
+          <a:p>
+            <a:endParaRPr lang="ru-RU"/>
+          </a:p>
+        </p:txBody>
+      </p:sp>
+      <p:sp>
+        <p:nvSpPr>
+          <p:cNvPr id="3" name="Дата 2"/>
+          <p:cNvSpPr>
+            <a:spLocks noGrp="1"/>
+          </p:cNvSpPr>
+          <p:nvPr>
+            <p:ph type="dt" idx="1"/>
+          </p:nvPr>
+        </p:nvSpPr>
+        <p:spPr>
+          <a:xfrm>
+            <a:off x="3884613" y="0"/>
+            <a:ext cx="2971800" cy="458788"/>
+          </a:xfrm>
+          <a:prstGeom prst="rect">
+            <a:avLst/>
+          </a:prstGeom>
+        </p:spPr>
+        <p:txBody>
+          <a:bodyPr vert="horz" lIns="91440" tIns="45720" rIns="91440" bIns="45720" rtlCol="0"/>
+          <a:lstStyle>
+            <a:lvl1pPr algn="r">
+              <a:defRPr sz="1200"/>
+            </a:lvl1pPr>
+          </a:lstStyle>
+          <a:p>
+            <a:fld id="{77E86250-218A-4567-829C-67771F89BC3F}" type="datetimeFigureOut">
+              <a:rPr lang="ru-RU" smtClean="0"/>
+              <a:t>21.05.2026</a:t>
+            </a:fld>
+            <a:endParaRPr lang="ru-RU"/>
+          </a:p>
+        </p:txBody>
+      </p:sp>
+      <p:sp>
+        <p:nvSpPr>
+          <p:cNvPr id="4" name="Образ слайда 3"/>
+          <p:cNvSpPr>
+            <a:spLocks noGrp="1" noRot="1" noChangeAspect="1"/>
+          </p:cNvSpPr>
+          <p:nvPr>
+            <p:ph type="sldImg" idx="2"/>
+          </p:nvPr>
+        </p:nvSpPr>
+        <p:spPr>
+          <a:xfrm>
+            <a:off x="685800" y="1143000"/>
+            <a:ext cx="5486400" cy="3086100"/>
+          </a:xfrm>
+          <a:prstGeom prst="rect">
+            <a:avLst/>
+          </a:prstGeom>
+          <a:noFill/>
+          <a:ln w="12700">
+            <a:solidFill>
+              <a:prstClr val="black"/>
+            </a:solidFill>
+          </a:ln>
+        </p:spPr>
+        <p:txBody>
+          <a:bodyPr vert="horz" lIns="91440" tIns="45720" rIns="91440" bIns="45720" rtlCol="0" anchor="ctr"/>
+          <a:lstStyle/>
+          <a:p>
+            <a:endParaRPr lang="ru-RU"/>
+          </a:p>
+        </p:txBody>
+      </p:sp>
+      <p:sp>
+        <p:nvSpPr>
+          <p:cNvPr id="5" name="Заметки 4"/>
+          <p:cNvSpPr>
+            <a:spLocks noGrp="1"/>
+          </p:cNvSpPr>
+          <p:nvPr>
+            <p:ph type="body" sz="quarter" idx="3"/>
+          </p:nvPr>
+        </p:nvSpPr>
+        <p:spPr>
+          <a:xfrm>
+            <a:off x="685800" y="4400550"/>
+            <a:ext cx="5486400" cy="3600450"/>
+          </a:xfrm>
+          <a:prstGeom prst="rect">
+            <a:avLst/>
+          </a:prstGeom>
+        </p:spPr>
+        <p:txBody>
+          <a:bodyPr vert="horz" lIns="91440" tIns="45720" rIns="91440" bIns="45720" rtlCol="0"/>
+          <a:lstStyle/>
+          <a:p>
+            <a:pPr lvl="0"/>
+            <a:r>
+              <a:rPr lang="ru-RU" smtClean="0"/>
+              <a:t>Образец текста</a:t>
+            </a:r>
+          </a:p>
+          <a:p>
+            <a:pPr lvl="1"/>
+            <a:r>
+              <a:rPr lang="ru-RU" smtClean="0"/>
+              <a:t>Второй уровень</a:t>
+            </a:r>
+          </a:p>
+          <a:p>
+            <a:pPr lvl="2"/>
+            <a:r>
+              <a:rPr lang="ru-RU" smtClean="0"/>
+              <a:t>Третий уровень</a:t>
+            </a:r>
+          </a:p>
+          <a:p>
+            <a:pPr lvl="3"/>
+            <a:r>
+              <a:rPr lang="ru-RU" smtClean="0"/>
+              <a:t>Четвертый уровень</a:t>
+            </a:r>
+          </a:p>
+          <a:p>
+            <a:pPr lvl="4"/>
+            <a:r>
+              <a:rPr lang="ru-RU" smtClean="0"/>
+              <a:t>Пятый уровень</a:t>
+            </a:r>
+            <a:endParaRPr lang="ru-RU"/>
+          </a:p>
+        </p:txBody>
+      </p:sp>
+      <p:sp>
+        <p:nvSpPr>
+          <p:cNvPr id="6" name="Нижний колонтитул 5"/>
+          <p:cNvSpPr>
+            <a:spLocks noGrp="1"/>
+          </p:cNvSpPr>
+          <p:nvPr>
+            <p:ph type="ftr" sz="quarter" idx="4"/>
+          </p:nvPr>
+        </p:nvSpPr>
+        <p:spPr>
+          <a:xfrm>
+            <a:off x="0" y="8685213"/>
+            <a:ext cx="2971800" cy="458787"/>
+          </a:xfrm>
+          <a:prstGeom prst="rect">
+            <a:avLst/>
+          </a:prstGeom>
+        </p:spPr>
+        <p:txBody>
+          <a:bodyPr vert="horz" lIns="91440" tIns="45720" rIns="91440" bIns="45720" rtlCol="0" anchor="b"/>
+          <a:lstStyle>
+            <a:lvl1pPr algn="l">
+              <a:defRPr sz="1200"/>
+            </a:lvl1pPr>
+          </a:lstStyle>
+          <a:p>
+            <a:endParaRPr lang="ru-RU"/>
+          </a:p>
+        </p:txBody>
+      </p:sp>
+      <p:sp>
+        <p:nvSpPr>
+          <p:cNvPr id="7" name="Номер слайда 6"/>
+          <p:cNvSpPr>
+            <a:spLocks noGrp="1"/>
+          </p:cNvSpPr>
+          <p:nvPr>
+            <p:ph type="sldNum" sz="quarter" idx="5"/>
+          </p:nvPr>
+        </p:nvSpPr>
+        <p:spPr>
+          <a:xfrm>
+            <a:off x="3884613" y="8685213"/>
+            <a:ext cx="2971800" cy="458787"/>
+          </a:xfrm>
+          <a:prstGeom prst="rect">
+            <a:avLst/>
+          </a:prstGeom>
+        </p:spPr>
+        <p:txBody>
+          <a:bodyPr vert="horz" lIns="91440" tIns="45720" rIns="91440" bIns="45720" rtlCol="0" anchor="b"/>
+          <a:lstStyle>
+            <a:lvl1pPr algn="r">
+              <a:defRPr sz="1200"/>
+            </a:lvl1pPr>
+          </a:lstStyle>
+          <a:p>
+            <a:fld id="{D8447653-886A-468A-A7B0-2EF8A3D8AF15}" type="slidenum">
+              <a:rPr lang="ru-RU" smtClean="0"/>
+              <a:t>‹#›</a:t>
+            </a:fld>
+            <a:endParaRPr lang="ru-RU"/>
+          </a:p>
+        </p:txBody>
+      </p:sp>
+    </p:spTree>
+    <p:extLst>
+      <p:ext uri="{BB962C8B-B14F-4D97-AF65-F5344CB8AC3E}">
+        <p14:creationId xmlns:p14="http://schemas.microsoft.com/office/powerpoint/2010/main" val="3518742681"/>
+      </p:ext>
+    </p:extLst>
+  </p:cSld>
+  <p:clrMap bg1="lt1" tx1="dk1" bg2="lt2" tx2="dk2" accent1="accent1" accent2="accent2" accent3="accent3" accent4="accent4" accent5="accent5" accent6="accent6" hlink="hlink" folHlink="folHlink"/>
+  <p:notesStyle>
+    <a:lvl1pPr marL="0" algn="l" defTabSz="914400" rtl="0" eaLnBrk="1" latinLnBrk="0" hangingPunct="1">
+      <a:defRPr sz="1200" kern="1200">
+        <a:solidFill>
+          <a:schemeClr val="tx1"/>
+        </a:solidFill>
+        <a:latin typeface="+mn-lt"/>
+        <a:ea typeface="+mn-ea"/>
+        <a:cs typeface="+mn-cs"/>
+      </a:defRPr>
+    </a:lvl1pPr>
+    <a:lvl2pPr marL="457200" algn="l" defTabSz="914400" rtl="0" eaLnBrk="1" latinLnBrk="0" hangingPunct="1">
+      <a:defRPr sz="1200" kern="1200">
+        <a:solidFill>
+          <a:schemeClr val="tx1"/>
+        </a:solidFill>
+        <a:latin typeface="+mn-lt"/>
+        <a:ea typeface="+mn-ea"/>
+        <a:cs typeface="+mn-cs"/>
+      </a:defRPr>
+    </a:lvl2pPr>
+    <a:lvl3pPr marL="914400" algn="l" defTabSz="914400" rtl="0" eaLnBrk="1" latinLnBrk="0" hangingPunct="1">
+      <a:defRPr sz="1200" kern="1200">
+        <a:solidFill>
+          <a:schemeClr val="tx1"/>
+        </a:solidFill>
+        <a:latin typeface="+mn-lt"/>
+        <a:ea typeface="+mn-ea"/>
+        <a:cs typeface="+mn-cs"/>
+      </a:defRPr>
+    </a:lvl3pPr>
+    <a:lvl4pPr marL="1371600" algn="l" defTabSz="914400" rtl="0" eaLnBrk="1" latinLnBrk="0" hangingPunct="1">
+      <a:defRPr sz="1200" kern="1200">
+        <a:solidFill>
+          <a:schemeClr val="tx1"/>
+        </a:solidFill>
+        <a:latin typeface="+mn-lt"/>
+        <a:ea typeface="+mn-ea"/>
+        <a:cs typeface="+mn-cs"/>
+      </a:defRPr>
+    </a:lvl4pPr>
+    <a:lvl5pPr marL="1828800" algn="l" defTabSz="914400" rtl="0" eaLnBrk="1" latinLnBrk="0" hangingPunct="1">
+      <a:defRPr sz="1200" kern="1200">
+        <a:solidFill>
+          <a:schemeClr val="tx1"/>
+        </a:solidFill>
+        <a:latin typeface="+mn-lt"/>
+        <a:ea typeface="+mn-ea"/>
+        <a:cs typeface="+mn-cs"/>
+      </a:defRPr>
+    </a:lvl5pPr>
+    <a:lvl6pPr marL="2286000" algn="l" defTabSz="914400" rtl="0" eaLnBrk="1" latinLnBrk="0" hangingPunct="1">
+      <a:defRPr sz="1200" kern="1200">
+        <a:solidFill>
+          <a:schemeClr val="tx1"/>
+        </a:solidFill>
+        <a:latin typeface="+mn-lt"/>
+        <a:ea typeface="+mn-ea"/>
+        <a:cs typeface="+mn-cs"/>
+      </a:defRPr>
+    </a:lvl6pPr>
+    <a:lvl7pPr marL="2743200" algn="l" defTabSz="914400" rtl="0" eaLnBrk="1" latinLnBrk="0" hangingPunct="1">
+      <a:defRPr sz="1200" kern="1200">
+        <a:solidFill>
+          <a:schemeClr val="tx1"/>
+        </a:solidFill>
+        <a:latin typeface="+mn-lt"/>
+        <a:ea typeface="+mn-ea"/>
+        <a:cs typeface="+mn-cs"/>
+      </a:defRPr>
+    </a:lvl7pPr>
+    <a:lvl8pPr marL="3200400" algn="l" defTabSz="914400" rtl="0" eaLnBrk="1" latinLnBrk="0" hangingPunct="1">
+      <a:defRPr sz="1200" kern="1200">
+        <a:solidFill>
+          <a:schemeClr val="tx1"/>
+        </a:solidFill>
+        <a:latin typeface="+mn-lt"/>
+        <a:ea typeface="+mn-ea"/>
+        <a:cs typeface="+mn-cs"/>
+      </a:defRPr>
+    </a:lvl8pPr>
+    <a:lvl9pPr marL="3657600" algn="l" defTabSz="914400" rtl="0" eaLnBrk="1" latinLnBrk="0" hangingPunct="1">
+      <a:defRPr sz="1200" kern="1200">
+        <a:solidFill>
+          <a:schemeClr val="tx1"/>
+        </a:solidFill>
+        <a:latin typeface="+mn-lt"/>
+        <a:ea typeface="+mn-ea"/>
+        <a:cs typeface="+mn-cs"/>
+      </a:defRPr>
+    </a:lvl9pPr>
+  </p:notesStyle>
+</p:notesMaster>
+</file>
+
+<file path=ppt/notesSlides/notesSlide1.xml><?xml version="1.0" encoding="utf-8"?>
+<p:notes xmlns:a="http://schemas.openxmlformats.org/drawingml/2006/main" xmlns:r="http://schemas.openxmlformats.org/officeDocument/2006/relationships" xmlns:p="http://schemas.openxmlformats.org/presentationml/2006/main">
+  <p:cSld>
+    <p:spTree>
+      <p:nvGrpSpPr>
+        <p:cNvPr id="1" name=""/>
+        <p:cNvGrpSpPr/>
+        <p:nvPr/>
+      </p:nvGrpSpPr>
+      <p:grpSpPr>
+        <a:xfrm>
+          <a:off x="0" y="0"/>
+          <a:ext cx="0" cy="0"/>
+          <a:chOff x="0" y="0"/>
+          <a:chExt cx="0" cy="0"/>
+        </a:xfrm>
+      </p:grpSpPr>
+      <p:sp>
+        <p:nvSpPr>
+          <p:cNvPr id="2" name="Образ слайда 1"/>
+          <p:cNvSpPr>
+            <a:spLocks noGrp="1" noRot="1" noChangeAspect="1"/>
+          </p:cNvSpPr>
+          <p:nvPr>
+            <p:ph type="sldImg"/>
+          </p:nvPr>
+        </p:nvSpPr>
+        <p:spPr/>
+      </p:sp>
+      <p:sp>
+        <p:nvSpPr>
+          <p:cNvPr id="3" name="Заметки 2"/>
+          <p:cNvSpPr>
+            <a:spLocks noGrp="1"/>
+          </p:cNvSpPr>
+          <p:nvPr>
+            <p:ph type="body" idx="1"/>
+          </p:nvPr>
+        </p:nvSpPr>
+        <p:spPr/>
+        <p:txBody>
+          <a:bodyPr/>
+          <a:lstStyle/>
+          <a:p>
+            <a:endParaRPr lang="ru-RU" dirty="0"/>
+          </a:p>
+        </p:txBody>
+      </p:sp>
+      <p:sp>
+        <p:nvSpPr>
+          <p:cNvPr id="4" name="Номер слайда 3"/>
+          <p:cNvSpPr>
+            <a:spLocks noGrp="1"/>
+          </p:cNvSpPr>
+          <p:nvPr>
+            <p:ph type="sldNum" sz="quarter" idx="10"/>
+          </p:nvPr>
+        </p:nvSpPr>
+        <p:spPr/>
+        <p:txBody>
+          <a:bodyPr/>
+          <a:lstStyle/>
+          <a:p>
+            <a:fld id="{D8447653-886A-468A-A7B0-2EF8A3D8AF15}" type="slidenum">
+              <a:rPr lang="ru-RU" smtClean="0"/>
+              <a:t>5</a:t>
+            </a:fld>
+            <a:endParaRPr lang="ru-RU"/>
+          </a:p>
+        </p:txBody>
+      </p:sp>
+    </p:spTree>
+    <p:extLst>
+      <p:ext uri="{BB962C8B-B14F-4D97-AF65-F5344CB8AC3E}">
+        <p14:creationId xmlns:p14="http://schemas.microsoft.com/office/powerpoint/2010/main" val="3240830658"/>
+      </p:ext>
+    </p:extLst>
+  </p:cSld>
+  <p:clrMapOvr>
+    <a:masterClrMapping/>
+  </p:clrMapOvr>
+</p:notes>
+</file>
+
 <file path=ppt/slideLayouts/slideLayout1.xml><?xml version="1.0" encoding="utf-8"?>
 <p:sldLayout xmlns:a="http://schemas.openxmlformats.org/drawingml/2006/main" xmlns:r="http://schemas.openxmlformats.org/officeDocument/2006/relationships" xmlns:p="http://schemas.openxmlformats.org/presentationml/2006/main" type="title" preserve="1">
   <p:cSld name="Title Slide">
@@ -1032,7 +1628,7 @@
           <a:p>
             <a:fld id="{5BCAD085-E8A6-8845-BD4E-CB4CCA059FC4}" type="datetimeFigureOut">
               <a:rPr lang="en-US" smtClean="0"/>
-              <a:t>1/27/13</a:t>
+              <a:t>5/21/2026</a:t>
             </a:fld>
             <a:endParaRPr lang="en-US"/>
           </a:p>
@@ -1202,7 +1798,7 @@
           <a:p>
             <a:fld id="{5BCAD085-E8A6-8845-BD4E-CB4CCA059FC4}" type="datetimeFigureOut">
               <a:rPr lang="en-US" smtClean="0"/>
-              <a:t>1/27/13</a:t>
+              <a:t>5/21/2026</a:t>
             </a:fld>
             <a:endParaRPr lang="en-US"/>
           </a:p>
@@ -1382,7 +1978,7 @@
           <a:p>
             <a:fld id="{5BCAD085-E8A6-8845-BD4E-CB4CCA059FC4}" type="datetimeFigureOut">
               <a:rPr lang="en-US" smtClean="0"/>
-              <a:t>1/27/13</a:t>
+              <a:t>5/21/2026</a:t>
             </a:fld>
             <a:endParaRPr lang="en-US"/>
           </a:p>
@@ -1552,7 +2148,7 @@
           <a:p>
             <a:fld id="{5BCAD085-E8A6-8845-BD4E-CB4CCA059FC4}" type="datetimeFigureOut">
               <a:rPr lang="en-US" smtClean="0"/>
-              <a:t>1/27/13</a:t>
+              <a:t>5/21/2026</a:t>
             </a:fld>
             <a:endParaRPr lang="en-US"/>
           </a:p>
@@ -1798,7 +2394,7 @@
           <a:p>
             <a:fld id="{5BCAD085-E8A6-8845-BD4E-CB4CCA059FC4}" type="datetimeFigureOut">
               <a:rPr lang="en-US" smtClean="0"/>
-              <a:t>1/27/13</a:t>
+              <a:t>5/21/2026</a:t>
             </a:fld>
             <a:endParaRPr lang="en-US"/>
           </a:p>
@@ -2086,7 +2682,7 @@
           <a:p>
             <a:fld id="{5BCAD085-E8A6-8845-BD4E-CB4CCA059FC4}" type="datetimeFigureOut">
               <a:rPr lang="en-US" smtClean="0"/>
-              <a:t>1/27/13</a:t>
+              <a:t>5/21/2026</a:t>
             </a:fld>
             <a:endParaRPr lang="en-US"/>
           </a:p>
@@ -2508,7 +3104,7 @@
           <a:p>
             <a:fld id="{5BCAD085-E8A6-8845-BD4E-CB4CCA059FC4}" type="datetimeFigureOut">
               <a:rPr lang="en-US" smtClean="0"/>
-              <a:t>1/27/13</a:t>
+              <a:t>5/21/2026</a:t>
             </a:fld>
             <a:endParaRPr lang="en-US"/>
           </a:p>
@@ -2626,7 +3222,7 @@
           <a:p>
             <a:fld id="{5BCAD085-E8A6-8845-BD4E-CB4CCA059FC4}" type="datetimeFigureOut">
               <a:rPr lang="en-US" smtClean="0"/>
-              <a:t>1/27/13</a:t>
+              <a:t>5/21/2026</a:t>
             </a:fld>
             <a:endParaRPr lang="en-US"/>
           </a:p>
@@ -2721,7 +3317,7 @@
           <a:p>
             <a:fld id="{5BCAD085-E8A6-8845-BD4E-CB4CCA059FC4}" type="datetimeFigureOut">
               <a:rPr lang="en-US" smtClean="0"/>
-              <a:t>1/27/13</a:t>
+              <a:t>5/21/2026</a:t>
             </a:fld>
             <a:endParaRPr lang="en-US"/>
           </a:p>
@@ -2998,7 +3594,7 @@
           <a:p>
             <a:fld id="{5BCAD085-E8A6-8845-BD4E-CB4CCA059FC4}" type="datetimeFigureOut">
               <a:rPr lang="en-US" smtClean="0"/>
-              <a:t>1/27/13</a:t>
+              <a:t>5/21/2026</a:t>
             </a:fld>
             <a:endParaRPr lang="en-US"/>
           </a:p>
@@ -3251,7 +3847,7 @@
           <a:p>
             <a:fld id="{5BCAD085-E8A6-8845-BD4E-CB4CCA059FC4}" type="datetimeFigureOut">
               <a:rPr lang="en-US" smtClean="0"/>
-              <a:t>1/27/13</a:t>
+              <a:t>5/21/2026</a:t>
             </a:fld>
             <a:endParaRPr lang="en-US"/>
           </a:p>
@@ -3464,7 +4060,7 @@
           <a:p>
             <a:fld id="{5BCAD085-E8A6-8845-BD4E-CB4CCA059FC4}" type="datetimeFigureOut">
               <a:rPr lang="en-US" smtClean="0"/>
-              <a:t>1/27/13</a:t>
+              <a:t>5/21/2026</a:t>
             </a:fld>
             <a:endParaRPr lang="en-US"/>
           </a:p>
@@ -3823,7 +4419,7 @@
 </file>
 
 <file path=ppt/slides/slide1.xml><?xml version="1.0" encoding="utf-8"?>
-<p:sld xmlns:a="http://schemas.openxmlformats.org/drawingml/2006/main" xmlns:p="http://schemas.openxmlformats.org/presentationml/2006/main" xmlns:r="http://schemas.openxmlformats.org/officeDocument/2006/relationships">
+<p:sld xmlns:a="http://schemas.openxmlformats.org/drawingml/2006/main" xmlns:r="http://schemas.openxmlformats.org/officeDocument/2006/relationships" xmlns:p="http://schemas.openxmlformats.org/presentationml/2006/main">
   <p:cSld>
     <p:spTree>
       <p:nvGrpSpPr>
@@ -3831,7 +4427,14 @@
         <p:cNvGrpSpPr/>
         <p:nvPr/>
       </p:nvGrpSpPr>
-      <p:grpSpPr/>
+      <p:grpSpPr>
+        <a:xfrm>
+          <a:off x="0" y="0"/>
+          <a:ext cx="0" cy="0"/>
+          <a:chOff x="0" y="0"/>
+          <a:chExt cx="0" cy="0"/>
+        </a:xfrm>
+      </p:grpSpPr>
       <p:sp>
         <p:nvSpPr>
           <p:cNvPr id="2" name="Rectangle 1"/>
@@ -3872,6 +4475,7 @@
           <a:lstStyle/>
           <a:p>
             <a:pPr algn="ctr"/>
+            <a:endParaRPr/>
           </a:p>
         </p:txBody>
       </p:sp>
@@ -3915,6 +4519,7 @@
           <a:lstStyle/>
           <a:p>
             <a:pPr algn="ctr"/>
+            <a:endParaRPr/>
           </a:p>
         </p:txBody>
       </p:sp>
@@ -4068,7 +4673,7 @@
 </file>
 
 <file path=ppt/slides/slide10.xml><?xml version="1.0" encoding="utf-8"?>
-<p:sld xmlns:a="http://schemas.openxmlformats.org/drawingml/2006/main" xmlns:p="http://schemas.openxmlformats.org/presentationml/2006/main" xmlns:r="http://schemas.openxmlformats.org/officeDocument/2006/relationships">
+<p:sld xmlns:a="http://schemas.openxmlformats.org/drawingml/2006/main" xmlns:r="http://schemas.openxmlformats.org/officeDocument/2006/relationships" xmlns:p="http://schemas.openxmlformats.org/presentationml/2006/main">
   <p:cSld>
     <p:spTree>
       <p:nvGrpSpPr>
@@ -4076,7 +4681,14 @@
         <p:cNvGrpSpPr/>
         <p:nvPr/>
       </p:nvGrpSpPr>
-      <p:grpSpPr/>
+      <p:grpSpPr>
+        <a:xfrm>
+          <a:off x="0" y="0"/>
+          <a:ext cx="0" cy="0"/>
+          <a:chOff x="0" y="0"/>
+          <a:chExt cx="0" cy="0"/>
+        </a:xfrm>
+      </p:grpSpPr>
       <p:sp>
         <p:nvSpPr>
           <p:cNvPr id="2" name="Rectangle 1"/>
@@ -4117,6 +4729,7 @@
           <a:lstStyle/>
           <a:p>
             <a:pPr algn="ctr"/>
+            <a:endParaRPr/>
           </a:p>
         </p:txBody>
       </p:sp>
@@ -4160,6 +4773,7 @@
           <a:lstStyle/>
           <a:p>
             <a:pPr algn="ctr"/>
+            <a:endParaRPr/>
           </a:p>
         </p:txBody>
       </p:sp>
@@ -4303,7 +4917,7 @@
               </a:spcBef>
             </a:pPr>
             <a:r>
-              <a:rPr b="1" sz="1800">
+              <a:rPr sz="1800" b="1">
                 <a:solidFill>
                   <a:srgbClr val="23613F"/>
                 </a:solidFill>
@@ -4328,7 +4942,7 @@
               </a:spcBef>
             </a:pPr>
             <a:r>
-              <a:rPr b="1" sz="1800">
+              <a:rPr sz="1800" b="1">
                 <a:solidFill>
                   <a:srgbClr val="23613F"/>
                 </a:solidFill>
@@ -4353,7 +4967,7 @@
               </a:spcBef>
             </a:pPr>
             <a:r>
-              <a:rPr b="1" sz="1800">
+              <a:rPr sz="1800" b="1">
                 <a:solidFill>
                   <a:srgbClr val="23613F"/>
                 </a:solidFill>
@@ -4378,7 +4992,7 @@
               </a:spcBef>
             </a:pPr>
             <a:r>
-              <a:rPr b="1" sz="1800">
+              <a:rPr sz="1800" b="1">
                 <a:solidFill>
                   <a:srgbClr val="23613F"/>
                 </a:solidFill>
@@ -4403,7 +5017,7 @@
               </a:spcBef>
             </a:pPr>
             <a:r>
-              <a:rPr b="1" sz="1800">
+              <a:rPr sz="1800" b="1">
                 <a:solidFill>
                   <a:srgbClr val="23613F"/>
                 </a:solidFill>
@@ -4465,6 +5079,7 @@
           <a:lstStyle/>
           <a:p>
             <a:pPr algn="ctr"/>
+            <a:endParaRPr/>
           </a:p>
         </p:txBody>
       </p:sp>
@@ -4584,7 +5199,7 @@
 </file>
 
 <file path=ppt/slides/slide11.xml><?xml version="1.0" encoding="utf-8"?>
-<p:sld xmlns:a="http://schemas.openxmlformats.org/drawingml/2006/main" xmlns:p="http://schemas.openxmlformats.org/presentationml/2006/main" xmlns:r="http://schemas.openxmlformats.org/officeDocument/2006/relationships">
+<p:sld xmlns:a="http://schemas.openxmlformats.org/drawingml/2006/main" xmlns:r="http://schemas.openxmlformats.org/officeDocument/2006/relationships" xmlns:p="http://schemas.openxmlformats.org/presentationml/2006/main">
   <p:cSld>
     <p:spTree>
       <p:nvGrpSpPr>
@@ -4592,7 +5207,14 @@
         <p:cNvGrpSpPr/>
         <p:nvPr/>
       </p:nvGrpSpPr>
-      <p:grpSpPr/>
+      <p:grpSpPr>
+        <a:xfrm>
+          <a:off x="0" y="0"/>
+          <a:ext cx="0" cy="0"/>
+          <a:chOff x="0" y="0"/>
+          <a:chExt cx="0" cy="0"/>
+        </a:xfrm>
+      </p:grpSpPr>
       <p:sp>
         <p:nvSpPr>
           <p:cNvPr id="2" name="Rectangle 1"/>
@@ -4633,6 +5255,7 @@
           <a:lstStyle/>
           <a:p>
             <a:pPr algn="ctr"/>
+            <a:endParaRPr/>
           </a:p>
         </p:txBody>
       </p:sp>
@@ -4676,6 +5299,7 @@
           <a:lstStyle/>
           <a:p>
             <a:pPr algn="ctr"/>
+            <a:endParaRPr/>
           </a:p>
         </p:txBody>
       </p:sp>
@@ -4756,6 +5380,7 @@
           <a:lstStyle/>
           <a:p>
             <a:pPr algn="ctr"/>
+            <a:endParaRPr/>
           </a:p>
         </p:txBody>
       </p:sp>
@@ -4924,6 +5549,7 @@
           <a:lstStyle/>
           <a:p>
             <a:pPr algn="ctr"/>
+            <a:endParaRPr/>
           </a:p>
         </p:txBody>
       </p:sp>
@@ -5075,6 +5701,7 @@
           <a:lstStyle/>
           <a:p>
             <a:pPr algn="ctr"/>
+            <a:endParaRPr/>
           </a:p>
         </p:txBody>
       </p:sp>
@@ -5280,7 +5907,7 @@
 </file>
 
 <file path=ppt/slides/slide12.xml><?xml version="1.0" encoding="utf-8"?>
-<p:sld xmlns:a="http://schemas.openxmlformats.org/drawingml/2006/main" xmlns:p="http://schemas.openxmlformats.org/presentationml/2006/main" xmlns:r="http://schemas.openxmlformats.org/officeDocument/2006/relationships">
+<p:sld xmlns:a="http://schemas.openxmlformats.org/drawingml/2006/main" xmlns:r="http://schemas.openxmlformats.org/officeDocument/2006/relationships" xmlns:p="http://schemas.openxmlformats.org/presentationml/2006/main">
   <p:cSld>
     <p:spTree>
       <p:nvGrpSpPr>
@@ -5288,7 +5915,14 @@
         <p:cNvGrpSpPr/>
         <p:nvPr/>
       </p:nvGrpSpPr>
-      <p:grpSpPr/>
+      <p:grpSpPr>
+        <a:xfrm>
+          <a:off x="0" y="0"/>
+          <a:ext cx="0" cy="0"/>
+          <a:chOff x="0" y="0"/>
+          <a:chExt cx="0" cy="0"/>
+        </a:xfrm>
+      </p:grpSpPr>
       <p:sp>
         <p:nvSpPr>
           <p:cNvPr id="2" name="Rectangle 1"/>
@@ -5329,6 +5963,7 @@
           <a:lstStyle/>
           <a:p>
             <a:pPr algn="ctr"/>
+            <a:endParaRPr/>
           </a:p>
         </p:txBody>
       </p:sp>
@@ -5372,6 +6007,7 @@
           <a:lstStyle/>
           <a:p>
             <a:pPr algn="ctr"/>
+            <a:endParaRPr/>
           </a:p>
         </p:txBody>
       </p:sp>
@@ -5438,7 +6074,7 @@
               </a:spcBef>
             </a:pPr>
             <a:r>
-              <a:rPr b="1" sz="1500">
+              <a:rPr sz="1500" b="1">
                 <a:solidFill>
                   <a:srgbClr val="23613F"/>
                 </a:solidFill>
@@ -5463,7 +6099,7 @@
               </a:spcBef>
             </a:pPr>
             <a:r>
-              <a:rPr b="1" sz="1500">
+              <a:rPr sz="1500" b="1">
                 <a:solidFill>
                   <a:srgbClr val="23613F"/>
                 </a:solidFill>
@@ -5488,7 +6124,7 @@
               </a:spcBef>
             </a:pPr>
             <a:r>
-              <a:rPr b="1" sz="1500">
+              <a:rPr sz="1500" b="1">
                 <a:solidFill>
                   <a:srgbClr val="23613F"/>
                 </a:solidFill>
@@ -5513,7 +6149,7 @@
               </a:spcBef>
             </a:pPr>
             <a:r>
-              <a:rPr b="1" sz="1500">
+              <a:rPr sz="1500" b="1">
                 <a:solidFill>
                   <a:srgbClr val="23613F"/>
                 </a:solidFill>
@@ -5538,7 +6174,7 @@
               </a:spcBef>
             </a:pPr>
             <a:r>
-              <a:rPr b="1" sz="1500">
+              <a:rPr sz="1500" b="1">
                 <a:solidFill>
                   <a:srgbClr val="23613F"/>
                 </a:solidFill>
@@ -5563,7 +6199,7 @@
               </a:spcBef>
             </a:pPr>
             <a:r>
-              <a:rPr b="1" sz="1500">
+              <a:rPr sz="1500" b="1">
                 <a:solidFill>
                   <a:srgbClr val="23613F"/>
                 </a:solidFill>
@@ -5588,7 +6224,7 @@
               </a:spcBef>
             </a:pPr>
             <a:r>
-              <a:rPr b="1" sz="1500">
+              <a:rPr sz="1500" b="1">
                 <a:solidFill>
                   <a:srgbClr val="23613F"/>
                 </a:solidFill>
@@ -5628,7 +6264,7 @@
 </file>
 
 <file path=ppt/slides/slide13.xml><?xml version="1.0" encoding="utf-8"?>
-<p:sld xmlns:a="http://schemas.openxmlformats.org/drawingml/2006/main" xmlns:p="http://schemas.openxmlformats.org/presentationml/2006/main" xmlns:r="http://schemas.openxmlformats.org/officeDocument/2006/relationships">
+<p:sld xmlns:a="http://schemas.openxmlformats.org/drawingml/2006/main" xmlns:r="http://schemas.openxmlformats.org/officeDocument/2006/relationships" xmlns:p="http://schemas.openxmlformats.org/presentationml/2006/main">
   <p:cSld>
     <p:spTree>
       <p:nvGrpSpPr>
@@ -5636,7 +6272,14 @@
         <p:cNvGrpSpPr/>
         <p:nvPr/>
       </p:nvGrpSpPr>
-      <p:grpSpPr/>
+      <p:grpSpPr>
+        <a:xfrm>
+          <a:off x="0" y="0"/>
+          <a:ext cx="0" cy="0"/>
+          <a:chOff x="0" y="0"/>
+          <a:chExt cx="0" cy="0"/>
+        </a:xfrm>
+      </p:grpSpPr>
       <p:sp>
         <p:nvSpPr>
           <p:cNvPr id="2" name="Rectangle 1"/>
@@ -5677,6 +6320,7 @@
           <a:lstStyle/>
           <a:p>
             <a:pPr algn="ctr"/>
+            <a:endParaRPr/>
           </a:p>
         </p:txBody>
       </p:sp>
@@ -5720,6 +6364,7 @@
           <a:lstStyle/>
           <a:p>
             <a:pPr algn="ctr"/>
+            <a:endParaRPr/>
           </a:p>
         </p:txBody>
       </p:sp>
@@ -5798,6 +6443,7 @@
           <a:lstStyle/>
           <a:p>
             <a:pPr algn="ctr"/>
+            <a:endParaRPr/>
           </a:p>
         </p:txBody>
       </p:sp>
@@ -5912,6 +6558,7 @@
           <a:lstStyle/>
           <a:p>
             <a:pPr algn="ctr"/>
+            <a:endParaRPr/>
           </a:p>
         </p:txBody>
       </p:sp>
@@ -6026,6 +6673,7 @@
           <a:lstStyle/>
           <a:p>
             <a:pPr algn="ctr"/>
+            <a:endParaRPr/>
           </a:p>
         </p:txBody>
       </p:sp>
@@ -6140,6 +6788,7 @@
           <a:lstStyle/>
           <a:p>
             <a:pPr algn="ctr"/>
+            <a:endParaRPr/>
           </a:p>
         </p:txBody>
       </p:sp>
@@ -6254,6 +6903,7 @@
           <a:lstStyle/>
           <a:p>
             <a:pPr algn="ctr"/>
+            <a:endParaRPr/>
           </a:p>
         </p:txBody>
       </p:sp>
@@ -6438,6 +7088,7 @@
           <a:lstStyle/>
           <a:p>
             <a:pPr algn="ctr"/>
+            <a:endParaRPr/>
           </a:p>
         </p:txBody>
       </p:sp>
@@ -6485,7 +7136,7 @@
 </file>
 
 <file path=ppt/slides/slide2.xml><?xml version="1.0" encoding="utf-8"?>
-<p:sld xmlns:a="http://schemas.openxmlformats.org/drawingml/2006/main" xmlns:p="http://schemas.openxmlformats.org/presentationml/2006/main" xmlns:r="http://schemas.openxmlformats.org/officeDocument/2006/relationships">
+<p:sld xmlns:a="http://schemas.openxmlformats.org/drawingml/2006/main" xmlns:r="http://schemas.openxmlformats.org/officeDocument/2006/relationships" xmlns:p="http://schemas.openxmlformats.org/presentationml/2006/main">
   <p:cSld>
     <p:spTree>
       <p:nvGrpSpPr>
@@ -6493,7 +7144,14 @@
         <p:cNvGrpSpPr/>
         <p:nvPr/>
       </p:nvGrpSpPr>
-      <p:grpSpPr/>
+      <p:grpSpPr>
+        <a:xfrm>
+          <a:off x="0" y="0"/>
+          <a:ext cx="0" cy="0"/>
+          <a:chOff x="0" y="0"/>
+          <a:chExt cx="0" cy="0"/>
+        </a:xfrm>
+      </p:grpSpPr>
       <p:sp>
         <p:nvSpPr>
           <p:cNvPr id="2" name="Rectangle 1"/>
@@ -6534,6 +7192,7 @@
           <a:lstStyle/>
           <a:p>
             <a:pPr algn="ctr"/>
+            <a:endParaRPr/>
           </a:p>
         </p:txBody>
       </p:sp>
@@ -6577,6 +7236,7 @@
           <a:lstStyle/>
           <a:p>
             <a:pPr algn="ctr"/>
+            <a:endParaRPr/>
           </a:p>
         </p:txBody>
       </p:sp>
@@ -6657,6 +7317,7 @@
           <a:lstStyle/>
           <a:p>
             <a:pPr algn="ctr"/>
+            <a:endParaRPr/>
           </a:p>
         </p:txBody>
       </p:sp>
@@ -6773,6 +7434,7 @@
           <a:lstStyle/>
           <a:p>
             <a:pPr algn="ctr"/>
+            <a:endParaRPr/>
           </a:p>
         </p:txBody>
       </p:sp>
@@ -6889,6 +7551,7 @@
           <a:lstStyle/>
           <a:p>
             <a:pPr algn="ctr"/>
+            <a:endParaRPr/>
           </a:p>
         </p:txBody>
       </p:sp>
@@ -7005,6 +7668,7 @@
           <a:lstStyle/>
           <a:p>
             <a:pPr algn="ctr"/>
+            <a:endParaRPr/>
           </a:p>
         </p:txBody>
       </p:sp>
@@ -7151,6 +7815,24 @@
           </a:p>
         </p:txBody>
       </p:sp>
+      <p:graphicFrame>
+        <p:nvGraphicFramePr>
+          <p:cNvPr id="19" name="Chart 18"/>
+          <p:cNvGraphicFramePr>
+            <a:graphicFrameLocks noGrp="1"/>
+          </p:cNvGraphicFramePr>
+          <p:nvPr/>
+        </p:nvGraphicFramePr>
+        <p:xfrm>
+          <a:off x="180000" y="2700000"/>
+          <a:ext cx="11880000" cy="3960000"/>
+        </p:xfrm>
+        <a:graphic>
+          <a:graphicData uri="http://schemas.openxmlformats.org/drawingml/2006/chart">
+            <c:chart xmlns:c="http://schemas.openxmlformats.org/drawingml/2006/chart" r:id="rId2"/>
+          </a:graphicData>
+        </a:graphic>
+      </p:graphicFrame>
     </p:spTree>
   </p:cSld>
   <p:clrMapOvr>
@@ -7160,7 +7842,7 @@
 </file>
 
 <file path=ppt/slides/slide3.xml><?xml version="1.0" encoding="utf-8"?>
-<p:sld xmlns:a="http://schemas.openxmlformats.org/drawingml/2006/main" xmlns:p="http://schemas.openxmlformats.org/presentationml/2006/main" xmlns:r="http://schemas.openxmlformats.org/officeDocument/2006/relationships">
+<p:sld xmlns:a="http://schemas.openxmlformats.org/drawingml/2006/main" xmlns:r="http://schemas.openxmlformats.org/officeDocument/2006/relationships" xmlns:p="http://schemas.openxmlformats.org/presentationml/2006/main">
   <p:cSld>
     <p:spTree>
       <p:nvGrpSpPr>
@@ -7168,7 +7850,14 @@
         <p:cNvGrpSpPr/>
         <p:nvPr/>
       </p:nvGrpSpPr>
-      <p:grpSpPr/>
+      <p:grpSpPr>
+        <a:xfrm>
+          <a:off x="0" y="0"/>
+          <a:ext cx="0" cy="0"/>
+          <a:chOff x="0" y="0"/>
+          <a:chExt cx="0" cy="0"/>
+        </a:xfrm>
+      </p:grpSpPr>
       <p:sp>
         <p:nvSpPr>
           <p:cNvPr id="2" name="Rectangle 1"/>
@@ -7209,6 +7898,7 @@
           <a:lstStyle/>
           <a:p>
             <a:pPr algn="ctr"/>
+            <a:endParaRPr/>
           </a:p>
         </p:txBody>
       </p:sp>
@@ -7252,6 +7942,7 @@
           <a:lstStyle/>
           <a:p>
             <a:pPr algn="ctr"/>
+            <a:endParaRPr/>
           </a:p>
         </p:txBody>
       </p:sp>
@@ -7454,7 +8145,7 @@
           <a:p>
             <a:pPr algn="l"/>
             <a:r>
-              <a:rPr b="1" sz="1500">
+              <a:rPr sz="1500" b="1">
                 <a:solidFill>
                   <a:srgbClr val="183528"/>
                 </a:solidFill>
@@ -7488,7 +8179,7 @@
           <a:p>
             <a:pPr algn="l"/>
             <a:r>
-              <a:rPr b="0" sz="1400">
+              <a:rPr sz="1400" b="0">
                 <a:solidFill>
                   <a:srgbClr val="1A1A1A"/>
                 </a:solidFill>
@@ -7522,7 +8213,7 @@
           <a:p>
             <a:pPr algn="l"/>
             <a:r>
-              <a:rPr b="1" sz="1500">
+              <a:rPr sz="1500" b="1">
                 <a:solidFill>
                   <a:srgbClr val="183528"/>
                 </a:solidFill>
@@ -7556,7 +8247,7 @@
           <a:p>
             <a:pPr algn="l"/>
             <a:r>
-              <a:rPr b="0" sz="1400">
+              <a:rPr sz="1400" b="0">
                 <a:solidFill>
                   <a:srgbClr val="1A1A1A"/>
                 </a:solidFill>
@@ -7575,7 +8266,7 @@
 </file>
 
 <file path=ppt/slides/slide4.xml><?xml version="1.0" encoding="utf-8"?>
-<p:sld xmlns:a="http://schemas.openxmlformats.org/drawingml/2006/main" xmlns:p="http://schemas.openxmlformats.org/presentationml/2006/main" xmlns:r="http://schemas.openxmlformats.org/officeDocument/2006/relationships">
+<p:sld xmlns:a="http://schemas.openxmlformats.org/drawingml/2006/main" xmlns:r="http://schemas.openxmlformats.org/officeDocument/2006/relationships" xmlns:p="http://schemas.openxmlformats.org/presentationml/2006/main">
   <p:cSld>
     <p:spTree>
       <p:nvGrpSpPr>
@@ -7583,7 +8274,14 @@
         <p:cNvGrpSpPr/>
         <p:nvPr/>
       </p:nvGrpSpPr>
-      <p:grpSpPr/>
+      <p:grpSpPr>
+        <a:xfrm>
+          <a:off x="0" y="0"/>
+          <a:ext cx="0" cy="0"/>
+          <a:chOff x="0" y="0"/>
+          <a:chExt cx="0" cy="0"/>
+        </a:xfrm>
+      </p:grpSpPr>
       <p:sp>
         <p:nvSpPr>
           <p:cNvPr id="2" name="Rectangle 1"/>
@@ -7624,6 +8322,7 @@
           <a:lstStyle/>
           <a:p>
             <a:pPr algn="ctr"/>
+            <a:endParaRPr/>
           </a:p>
         </p:txBody>
       </p:sp>
@@ -7680,22 +8379,88 @@
                 <a:tableStyleId>{5C22544A-7EE6-4342-B048-85BDC9FD1C3A}</a:tableStyleId>
               </a:tblPr>
               <a:tblGrid>
-                <a:gridCol w="1350000"/>
-                <a:gridCol w="1063895"/>
-                <a:gridCol w="1063895"/>
-                <a:gridCol w="1063895"/>
-                <a:gridCol w="1063895"/>
-                <a:gridCol w="1063895"/>
-                <a:gridCol w="1063895"/>
-                <a:gridCol w="1063895"/>
-                <a:gridCol w="1063895"/>
-                <a:gridCol w="1063895"/>
-                <a:gridCol w="1063895"/>
+                <a:gridCol w="1350000">
+                  <a:extLst>
+                    <a:ext uri="{9D8B030D-6E8A-4147-A177-3AD203B41FA5}">
+                      <a16:colId xmlns:a16="http://schemas.microsoft.com/office/drawing/2014/main" val="20000"/>
+                    </a:ext>
+                  </a:extLst>
+                </a:gridCol>
+                <a:gridCol w="1063895">
+                  <a:extLst>
+                    <a:ext uri="{9D8B030D-6E8A-4147-A177-3AD203B41FA5}">
+                      <a16:colId xmlns:a16="http://schemas.microsoft.com/office/drawing/2014/main" val="20001"/>
+                    </a:ext>
+                  </a:extLst>
+                </a:gridCol>
+                <a:gridCol w="1063895">
+                  <a:extLst>
+                    <a:ext uri="{9D8B030D-6E8A-4147-A177-3AD203B41FA5}">
+                      <a16:colId xmlns:a16="http://schemas.microsoft.com/office/drawing/2014/main" val="20002"/>
+                    </a:ext>
+                  </a:extLst>
+                </a:gridCol>
+                <a:gridCol w="1063895">
+                  <a:extLst>
+                    <a:ext uri="{9D8B030D-6E8A-4147-A177-3AD203B41FA5}">
+                      <a16:colId xmlns:a16="http://schemas.microsoft.com/office/drawing/2014/main" val="20003"/>
+                    </a:ext>
+                  </a:extLst>
+                </a:gridCol>
+                <a:gridCol w="1063895">
+                  <a:extLst>
+                    <a:ext uri="{9D8B030D-6E8A-4147-A177-3AD203B41FA5}">
+                      <a16:colId xmlns:a16="http://schemas.microsoft.com/office/drawing/2014/main" val="20004"/>
+                    </a:ext>
+                  </a:extLst>
+                </a:gridCol>
+                <a:gridCol w="1063895">
+                  <a:extLst>
+                    <a:ext uri="{9D8B030D-6E8A-4147-A177-3AD203B41FA5}">
+                      <a16:colId xmlns:a16="http://schemas.microsoft.com/office/drawing/2014/main" val="20005"/>
+                    </a:ext>
+                  </a:extLst>
+                </a:gridCol>
+                <a:gridCol w="1063895">
+                  <a:extLst>
+                    <a:ext uri="{9D8B030D-6E8A-4147-A177-3AD203B41FA5}">
+                      <a16:colId xmlns:a16="http://schemas.microsoft.com/office/drawing/2014/main" val="20006"/>
+                    </a:ext>
+                  </a:extLst>
+                </a:gridCol>
+                <a:gridCol w="1063895">
+                  <a:extLst>
+                    <a:ext uri="{9D8B030D-6E8A-4147-A177-3AD203B41FA5}">
+                      <a16:colId xmlns:a16="http://schemas.microsoft.com/office/drawing/2014/main" val="20007"/>
+                    </a:ext>
+                  </a:extLst>
+                </a:gridCol>
+                <a:gridCol w="1063895">
+                  <a:extLst>
+                    <a:ext uri="{9D8B030D-6E8A-4147-A177-3AD203B41FA5}">
+                      <a16:colId xmlns:a16="http://schemas.microsoft.com/office/drawing/2014/main" val="20008"/>
+                    </a:ext>
+                  </a:extLst>
+                </a:gridCol>
+                <a:gridCol w="1063895">
+                  <a:extLst>
+                    <a:ext uri="{9D8B030D-6E8A-4147-A177-3AD203B41FA5}">
+                      <a16:colId xmlns:a16="http://schemas.microsoft.com/office/drawing/2014/main" val="20009"/>
+                    </a:ext>
+                  </a:extLst>
+                </a:gridCol>
+                <a:gridCol w="1063895">
+                  <a:extLst>
+                    <a:ext uri="{9D8B030D-6E8A-4147-A177-3AD203B41FA5}">
+                      <a16:colId xmlns:a16="http://schemas.microsoft.com/office/drawing/2014/main" val="20010"/>
+                    </a:ext>
+                  </a:extLst>
+                </a:gridCol>
               </a:tblGrid>
               <a:tr h="612800">
                 <a:tc>
                   <a:txBody>
-                    <a:bodyPr wrap="square"/>
+                    <a:bodyPr/>
                     <a:lstStyle/>
                     <a:p>
                       <a:r>
@@ -7716,7 +8481,7 @@
                 </a:tc>
                 <a:tc>
                   <a:txBody>
-                    <a:bodyPr wrap="square"/>
+                    <a:bodyPr/>
                     <a:lstStyle/>
                     <a:p>
                       <a:r>
@@ -7737,7 +8502,7 @@
                 </a:tc>
                 <a:tc>
                   <a:txBody>
-                    <a:bodyPr wrap="square"/>
+                    <a:bodyPr/>
                     <a:lstStyle/>
                     <a:p>
                       <a:r>
@@ -7758,7 +8523,7 @@
                 </a:tc>
                 <a:tc>
                   <a:txBody>
-                    <a:bodyPr wrap="square"/>
+                    <a:bodyPr/>
                     <a:lstStyle/>
                     <a:p>
                       <a:r>
@@ -7780,7 +8545,7 @@
                 </a:tc>
                 <a:tc>
                   <a:txBody>
-                    <a:bodyPr wrap="square"/>
+                    <a:bodyPr/>
                     <a:lstStyle/>
                     <a:p>
                       <a:r>
@@ -7801,7 +8566,7 @@
                 </a:tc>
                 <a:tc>
                   <a:txBody>
-                    <a:bodyPr wrap="square"/>
+                    <a:bodyPr/>
                     <a:lstStyle/>
                     <a:p>
                       <a:r>
@@ -7822,7 +8587,7 @@
                 </a:tc>
                 <a:tc>
                   <a:txBody>
-                    <a:bodyPr wrap="square"/>
+                    <a:bodyPr/>
                     <a:lstStyle/>
                     <a:p>
                       <a:r>
@@ -7843,7 +8608,7 @@
                 </a:tc>
                 <a:tc>
                   <a:txBody>
-                    <a:bodyPr wrap="square"/>
+                    <a:bodyPr/>
                     <a:lstStyle/>
                     <a:p>
                       <a:r>
@@ -7865,7 +8630,7 @@
                 </a:tc>
                 <a:tc>
                   <a:txBody>
-                    <a:bodyPr wrap="square"/>
+                    <a:bodyPr/>
                     <a:lstStyle/>
                     <a:p>
                       <a:r>
@@ -7886,7 +8651,7 @@
                 </a:tc>
                 <a:tc>
                   <a:txBody>
-                    <a:bodyPr wrap="square"/>
+                    <a:bodyPr/>
                     <a:lstStyle/>
                     <a:p>
                       <a:r>
@@ -7907,7 +8672,7 @@
                 </a:tc>
                 <a:tc>
                   <a:txBody>
-                    <a:bodyPr wrap="square"/>
+                    <a:bodyPr/>
                     <a:lstStyle/>
                     <a:p>
                       <a:r>
@@ -7927,11 +8692,16 @@
                     </a:solidFill>
                   </a:tcPr>
                 </a:tc>
+                <a:extLst>
+                  <a:ext uri="{0D108BD9-81ED-4DB2-BD59-A6C34878D82A}">
+                    <a16:rowId xmlns:a16="http://schemas.microsoft.com/office/drawing/2014/main" val="10000"/>
+                  </a:ext>
+                </a:extLst>
               </a:tr>
               <a:tr h="612800">
                 <a:tc>
                   <a:txBody>
-                    <a:bodyPr wrap="square"/>
+                    <a:bodyPr/>
                     <a:lstStyle/>
                     <a:p>
                       <a:r>
@@ -7953,7 +8723,7 @@
                 </a:tc>
                 <a:tc>
                   <a:txBody>
-                    <a:bodyPr wrap="square"/>
+                    <a:bodyPr/>
                     <a:lstStyle/>
                     <a:p>
                       <a:r>
@@ -7975,7 +8745,7 @@
                 </a:tc>
                 <a:tc>
                   <a:txBody>
-                    <a:bodyPr wrap="square"/>
+                    <a:bodyPr/>
                     <a:lstStyle/>
                     <a:p>
                       <a:r>
@@ -7997,7 +8767,7 @@
                 </a:tc>
                 <a:tc>
                   <a:txBody>
-                    <a:bodyPr wrap="square"/>
+                    <a:bodyPr/>
                     <a:lstStyle/>
                     <a:p>
                       <a:r>
@@ -8019,7 +8789,7 @@
                 </a:tc>
                 <a:tc>
                   <a:txBody>
-                    <a:bodyPr wrap="square"/>
+                    <a:bodyPr/>
                     <a:lstStyle/>
                     <a:p>
                       <a:r>
@@ -8041,7 +8811,7 @@
                 </a:tc>
                 <a:tc>
                   <a:txBody>
-                    <a:bodyPr wrap="square"/>
+                    <a:bodyPr/>
                     <a:lstStyle/>
                     <a:p>
                       <a:r>
@@ -8063,7 +8833,7 @@
                 </a:tc>
                 <a:tc>
                   <a:txBody>
-                    <a:bodyPr wrap="square"/>
+                    <a:bodyPr/>
                     <a:lstStyle/>
                     <a:p>
                       <a:r>
@@ -8085,7 +8855,7 @@
                 </a:tc>
                 <a:tc>
                   <a:txBody>
-                    <a:bodyPr wrap="square"/>
+                    <a:bodyPr/>
                     <a:lstStyle/>
                     <a:p>
                       <a:r>
@@ -8107,7 +8877,7 @@
                 </a:tc>
                 <a:tc>
                   <a:txBody>
-                    <a:bodyPr wrap="square"/>
+                    <a:bodyPr/>
                     <a:lstStyle/>
                     <a:p>
                       <a:r>
@@ -8129,7 +8899,7 @@
                 </a:tc>
                 <a:tc>
                   <a:txBody>
-                    <a:bodyPr wrap="square"/>
+                    <a:bodyPr/>
                     <a:lstStyle/>
                     <a:p>
                       <a:r>
@@ -8151,7 +8921,7 @@
                 </a:tc>
                 <a:tc>
                   <a:txBody>
-                    <a:bodyPr wrap="square"/>
+                    <a:bodyPr/>
                     <a:lstStyle/>
                     <a:p>
                       <a:r>
@@ -8170,11 +8940,16 @@
                     </a:solidFill>
                   </a:tcPr>
                 </a:tc>
+                <a:extLst>
+                  <a:ext uri="{0D108BD9-81ED-4DB2-BD59-A6C34878D82A}">
+                    <a16:rowId xmlns:a16="http://schemas.microsoft.com/office/drawing/2014/main" val="10001"/>
+                  </a:ext>
+                </a:extLst>
               </a:tr>
               <a:tr h="612800">
                 <a:tc>
                   <a:txBody>
-                    <a:bodyPr wrap="square"/>
+                    <a:bodyPr/>
                     <a:lstStyle/>
                     <a:p>
                       <a:r>
@@ -8195,7 +8970,7 @@
                 </a:tc>
                 <a:tc>
                   <a:txBody>
-                    <a:bodyPr wrap="square"/>
+                    <a:bodyPr/>
                     <a:lstStyle/>
                     <a:p>
                       <a:r>
@@ -8216,7 +8991,7 @@
                 </a:tc>
                 <a:tc>
                   <a:txBody>
-                    <a:bodyPr wrap="square"/>
+                    <a:bodyPr/>
                     <a:lstStyle/>
                     <a:p>
                       <a:r>
@@ -8238,7 +9013,7 @@
                 </a:tc>
                 <a:tc>
                   <a:txBody>
-                    <a:bodyPr wrap="square"/>
+                    <a:bodyPr/>
                     <a:lstStyle/>
                     <a:p>
                       <a:r>
@@ -8259,7 +9034,7 @@
                 </a:tc>
                 <a:tc>
                   <a:txBody>
-                    <a:bodyPr wrap="square"/>
+                    <a:bodyPr/>
                     <a:lstStyle/>
                     <a:p>
                       <a:r>
@@ -8280,7 +9055,7 @@
                 </a:tc>
                 <a:tc>
                   <a:txBody>
-                    <a:bodyPr wrap="square"/>
+                    <a:bodyPr/>
                     <a:lstStyle/>
                     <a:p>
                       <a:r>
@@ -8301,7 +9076,7 @@
                 </a:tc>
                 <a:tc>
                   <a:txBody>
-                    <a:bodyPr wrap="square"/>
+                    <a:bodyPr/>
                     <a:lstStyle/>
                     <a:p>
                       <a:r>
@@ -8322,7 +9097,7 @@
                 </a:tc>
                 <a:tc>
                   <a:txBody>
-                    <a:bodyPr wrap="square"/>
+                    <a:bodyPr/>
                     <a:lstStyle/>
                     <a:p>
                       <a:r>
@@ -8343,7 +9118,7 @@
                 </a:tc>
                 <a:tc>
                   <a:txBody>
-                    <a:bodyPr wrap="square"/>
+                    <a:bodyPr/>
                     <a:lstStyle/>
                     <a:p>
                       <a:r>
@@ -8364,7 +9139,7 @@
                 </a:tc>
                 <a:tc>
                   <a:txBody>
-                    <a:bodyPr wrap="square"/>
+                    <a:bodyPr/>
                     <a:lstStyle/>
                     <a:p>
                       <a:r>
@@ -8386,7 +9161,7 @@
                 </a:tc>
                 <a:tc>
                   <a:txBody>
-                    <a:bodyPr wrap="square"/>
+                    <a:bodyPr/>
                     <a:lstStyle/>
                     <a:p>
                       <a:r>
@@ -8406,11 +9181,16 @@
                     </a:solidFill>
                   </a:tcPr>
                 </a:tc>
+                <a:extLst>
+                  <a:ext uri="{0D108BD9-81ED-4DB2-BD59-A6C34878D82A}">
+                    <a16:rowId xmlns:a16="http://schemas.microsoft.com/office/drawing/2014/main" val="10002"/>
+                  </a:ext>
+                </a:extLst>
               </a:tr>
               <a:tr h="612800">
                 <a:tc>
                   <a:txBody>
-                    <a:bodyPr wrap="square"/>
+                    <a:bodyPr/>
                     <a:lstStyle/>
                     <a:p>
                       <a:r>
@@ -8431,7 +9211,7 @@
                 </a:tc>
                 <a:tc>
                   <a:txBody>
-                    <a:bodyPr wrap="square"/>
+                    <a:bodyPr/>
                     <a:lstStyle/>
                     <a:p>
                       <a:r>
@@ -8452,7 +9232,7 @@
                 </a:tc>
                 <a:tc>
                   <a:txBody>
-                    <a:bodyPr wrap="square"/>
+                    <a:bodyPr/>
                     <a:lstStyle/>
                     <a:p>
                       <a:r>
@@ -8473,7 +9253,7 @@
                 </a:tc>
                 <a:tc>
                   <a:txBody>
-                    <a:bodyPr wrap="square"/>
+                    <a:bodyPr/>
                     <a:lstStyle/>
                     <a:p>
                       <a:r>
@@ -8495,7 +9275,7 @@
                 </a:tc>
                 <a:tc>
                   <a:txBody>
-                    <a:bodyPr wrap="square"/>
+                    <a:bodyPr/>
                     <a:lstStyle/>
                     <a:p>
                       <a:r>
@@ -8516,7 +9296,7 @@
                 </a:tc>
                 <a:tc>
                   <a:txBody>
-                    <a:bodyPr wrap="square"/>
+                    <a:bodyPr/>
                     <a:lstStyle/>
                     <a:p>
                       <a:r>
@@ -8537,7 +9317,7 @@
                 </a:tc>
                 <a:tc>
                   <a:txBody>
-                    <a:bodyPr wrap="square"/>
+                    <a:bodyPr/>
                     <a:lstStyle/>
                     <a:p>
                       <a:r>
@@ -8558,7 +9338,7 @@
                 </a:tc>
                 <a:tc>
                   <a:txBody>
-                    <a:bodyPr wrap="square"/>
+                    <a:bodyPr/>
                     <a:lstStyle/>
                     <a:p>
                       <a:r>
@@ -8579,7 +9359,7 @@
                 </a:tc>
                 <a:tc>
                   <a:txBody>
-                    <a:bodyPr wrap="square"/>
+                    <a:bodyPr/>
                     <a:lstStyle/>
                     <a:p>
                       <a:r>
@@ -8600,7 +9380,7 @@
                 </a:tc>
                 <a:tc>
                   <a:txBody>
-                    <a:bodyPr wrap="square"/>
+                    <a:bodyPr/>
                     <a:lstStyle/>
                     <a:p>
                       <a:r>
@@ -8622,7 +9402,7 @@
                 </a:tc>
                 <a:tc>
                   <a:txBody>
-                    <a:bodyPr wrap="square"/>
+                    <a:bodyPr/>
                     <a:lstStyle/>
                     <a:p>
                       <a:r>
@@ -8641,11 +9421,16 @@
                     </a:solidFill>
                   </a:tcPr>
                 </a:tc>
+                <a:extLst>
+                  <a:ext uri="{0D108BD9-81ED-4DB2-BD59-A6C34878D82A}">
+                    <a16:rowId xmlns:a16="http://schemas.microsoft.com/office/drawing/2014/main" val="10003"/>
+                  </a:ext>
+                </a:extLst>
               </a:tr>
               <a:tr h="612800">
                 <a:tc>
                   <a:txBody>
-                    <a:bodyPr wrap="square"/>
+                    <a:bodyPr/>
                     <a:lstStyle/>
                     <a:p>
                       <a:r>
@@ -8667,7 +9452,7 @@
                 </a:tc>
                 <a:tc>
                   <a:txBody>
-                    <a:bodyPr wrap="square"/>
+                    <a:bodyPr/>
                     <a:lstStyle/>
                     <a:p>
                       <a:r>
@@ -8688,7 +9473,7 @@
                 </a:tc>
                 <a:tc>
                   <a:txBody>
-                    <a:bodyPr wrap="square"/>
+                    <a:bodyPr/>
                     <a:lstStyle/>
                     <a:p>
                       <a:r>
@@ -8709,7 +9494,7 @@
                 </a:tc>
                 <a:tc>
                   <a:txBody>
-                    <a:bodyPr wrap="square"/>
+                    <a:bodyPr/>
                     <a:lstStyle/>
                     <a:p>
                       <a:r>
@@ -8730,7 +9515,7 @@
                 </a:tc>
                 <a:tc>
                   <a:txBody>
-                    <a:bodyPr wrap="square"/>
+                    <a:bodyPr/>
                     <a:lstStyle/>
                     <a:p>
                       <a:r>
@@ -8751,7 +9536,7 @@
                 </a:tc>
                 <a:tc>
                   <a:txBody>
-                    <a:bodyPr wrap="square"/>
+                    <a:bodyPr/>
                     <a:lstStyle/>
                     <a:p>
                       <a:r>
@@ -8772,7 +9557,7 @@
                 </a:tc>
                 <a:tc>
                   <a:txBody>
-                    <a:bodyPr wrap="square"/>
+                    <a:bodyPr/>
                     <a:lstStyle/>
                     <a:p>
                       <a:r>
@@ -8793,7 +9578,7 @@
                 </a:tc>
                 <a:tc>
                   <a:txBody>
-                    <a:bodyPr wrap="square"/>
+                    <a:bodyPr/>
                     <a:lstStyle/>
                     <a:p>
                       <a:r>
@@ -8814,7 +9599,7 @@
                 </a:tc>
                 <a:tc>
                   <a:txBody>
-                    <a:bodyPr wrap="square"/>
+                    <a:bodyPr/>
                     <a:lstStyle/>
                     <a:p>
                       <a:r>
@@ -8835,7 +9620,7 @@
                 </a:tc>
                 <a:tc>
                   <a:txBody>
-                    <a:bodyPr wrap="square"/>
+                    <a:bodyPr/>
                     <a:lstStyle/>
                     <a:p>
                       <a:r>
@@ -8856,7 +9641,7 @@
                 </a:tc>
                 <a:tc>
                   <a:txBody>
-                    <a:bodyPr wrap="square"/>
+                    <a:bodyPr/>
                     <a:lstStyle/>
                     <a:p>
                       <a:r>
@@ -8875,11 +9660,16 @@
                     </a:solidFill>
                   </a:tcPr>
                 </a:tc>
+                <a:extLst>
+                  <a:ext uri="{0D108BD9-81ED-4DB2-BD59-A6C34878D82A}">
+                    <a16:rowId xmlns:a16="http://schemas.microsoft.com/office/drawing/2014/main" val="10004"/>
+                  </a:ext>
+                </a:extLst>
               </a:tr>
               <a:tr h="612800">
                 <a:tc>
                   <a:txBody>
-                    <a:bodyPr wrap="square"/>
+                    <a:bodyPr/>
                     <a:lstStyle/>
                     <a:p>
                       <a:r>
@@ -8901,7 +9691,7 @@
                 </a:tc>
                 <a:tc>
                   <a:txBody>
-                    <a:bodyPr wrap="square"/>
+                    <a:bodyPr/>
                     <a:lstStyle/>
                     <a:p>
                       <a:r>
@@ -8923,7 +9713,7 @@
                 </a:tc>
                 <a:tc>
                   <a:txBody>
-                    <a:bodyPr wrap="square"/>
+                    <a:bodyPr/>
                     <a:lstStyle/>
                     <a:p>
                       <a:r>
@@ -8945,7 +9735,7 @@
                 </a:tc>
                 <a:tc>
                   <a:txBody>
-                    <a:bodyPr wrap="square"/>
+                    <a:bodyPr/>
                     <a:lstStyle/>
                     <a:p>
                       <a:r>
@@ -8967,7 +9757,7 @@
                 </a:tc>
                 <a:tc>
                   <a:txBody>
-                    <a:bodyPr wrap="square"/>
+                    <a:bodyPr/>
                     <a:lstStyle/>
                     <a:p>
                       <a:r>
@@ -8989,7 +9779,7 @@
                 </a:tc>
                 <a:tc>
                   <a:txBody>
-                    <a:bodyPr wrap="square"/>
+                    <a:bodyPr/>
                     <a:lstStyle/>
                     <a:p>
                       <a:r>
@@ -9011,7 +9801,7 @@
                 </a:tc>
                 <a:tc>
                   <a:txBody>
-                    <a:bodyPr wrap="square"/>
+                    <a:bodyPr/>
                     <a:lstStyle/>
                     <a:p>
                       <a:r>
@@ -9033,7 +9823,7 @@
                 </a:tc>
                 <a:tc>
                   <a:txBody>
-                    <a:bodyPr wrap="square"/>
+                    <a:bodyPr/>
                     <a:lstStyle/>
                     <a:p>
                       <a:r>
@@ -9055,7 +9845,7 @@
                 </a:tc>
                 <a:tc>
                   <a:txBody>
-                    <a:bodyPr wrap="square"/>
+                    <a:bodyPr/>
                     <a:lstStyle/>
                     <a:p>
                       <a:r>
@@ -9076,7 +9866,7 @@
                 </a:tc>
                 <a:tc>
                   <a:txBody>
-                    <a:bodyPr wrap="square"/>
+                    <a:bodyPr/>
                     <a:lstStyle/>
                     <a:p>
                       <a:r>
@@ -9098,7 +9888,7 @@
                 </a:tc>
                 <a:tc>
                   <a:txBody>
-                    <a:bodyPr wrap="square"/>
+                    <a:bodyPr/>
                     <a:lstStyle/>
                     <a:p>
                       <a:r>
@@ -9117,11 +9907,16 @@
                     </a:solidFill>
                   </a:tcPr>
                 </a:tc>
+                <a:extLst>
+                  <a:ext uri="{0D108BD9-81ED-4DB2-BD59-A6C34878D82A}">
+                    <a16:rowId xmlns:a16="http://schemas.microsoft.com/office/drawing/2014/main" val="10005"/>
+                  </a:ext>
+                </a:extLst>
               </a:tr>
               <a:tr h="612800">
                 <a:tc>
                   <a:txBody>
-                    <a:bodyPr wrap="square"/>
+                    <a:bodyPr/>
                     <a:lstStyle/>
                     <a:p>
                       <a:r>
@@ -9143,7 +9938,7 @@
                 </a:tc>
                 <a:tc>
                   <a:txBody>
-                    <a:bodyPr wrap="square"/>
+                    <a:bodyPr/>
                     <a:lstStyle/>
                     <a:p>
                       <a:r>
@@ -9164,7 +9959,7 @@
                 </a:tc>
                 <a:tc>
                   <a:txBody>
-                    <a:bodyPr wrap="square"/>
+                    <a:bodyPr/>
                     <a:lstStyle/>
                     <a:p>
                       <a:r>
@@ -9185,7 +9980,7 @@
                 </a:tc>
                 <a:tc>
                   <a:txBody>
-                    <a:bodyPr wrap="square"/>
+                    <a:bodyPr/>
                     <a:lstStyle/>
                     <a:p>
                       <a:r>
@@ -9206,7 +10001,7 @@
                 </a:tc>
                 <a:tc>
                   <a:txBody>
-                    <a:bodyPr wrap="square"/>
+                    <a:bodyPr/>
                     <a:lstStyle/>
                     <a:p>
                       <a:r>
@@ -9227,7 +10022,7 @@
                 </a:tc>
                 <a:tc>
                   <a:txBody>
-                    <a:bodyPr wrap="square"/>
+                    <a:bodyPr/>
                     <a:lstStyle/>
                     <a:p>
                       <a:r>
@@ -9248,7 +10043,7 @@
                 </a:tc>
                 <a:tc>
                   <a:txBody>
-                    <a:bodyPr wrap="square"/>
+                    <a:bodyPr/>
                     <a:lstStyle/>
                     <a:p>
                       <a:r>
@@ -9269,7 +10064,7 @@
                 </a:tc>
                 <a:tc>
                   <a:txBody>
-                    <a:bodyPr wrap="square"/>
+                    <a:bodyPr/>
                     <a:lstStyle/>
                     <a:p>
                       <a:r>
@@ -9290,7 +10085,7 @@
                 </a:tc>
                 <a:tc>
                   <a:txBody>
-                    <a:bodyPr wrap="square"/>
+                    <a:bodyPr/>
                     <a:lstStyle/>
                     <a:p>
                       <a:r>
@@ -9311,7 +10106,7 @@
                 </a:tc>
                 <a:tc>
                   <a:txBody>
-                    <a:bodyPr wrap="square"/>
+                    <a:bodyPr/>
                     <a:lstStyle/>
                     <a:p>
                       <a:r>
@@ -9332,7 +10127,7 @@
                 </a:tc>
                 <a:tc>
                   <a:txBody>
-                    <a:bodyPr wrap="square"/>
+                    <a:bodyPr/>
                     <a:lstStyle/>
                     <a:p>
                       <a:r>
@@ -9352,11 +10147,16 @@
                     </a:solidFill>
                   </a:tcPr>
                 </a:tc>
+                <a:extLst>
+                  <a:ext uri="{0D108BD9-81ED-4DB2-BD59-A6C34878D82A}">
+                    <a16:rowId xmlns:a16="http://schemas.microsoft.com/office/drawing/2014/main" val="10006"/>
+                  </a:ext>
+                </a:extLst>
               </a:tr>
               <a:tr h="612800">
                 <a:tc>
                   <a:txBody>
-                    <a:bodyPr wrap="square"/>
+                    <a:bodyPr/>
                     <a:lstStyle/>
                     <a:p>
                       <a:r>
@@ -9378,7 +10178,7 @@
                 </a:tc>
                 <a:tc>
                   <a:txBody>
-                    <a:bodyPr wrap="square"/>
+                    <a:bodyPr/>
                     <a:lstStyle/>
                     <a:p>
                       <a:r>
@@ -9399,7 +10199,7 @@
                 </a:tc>
                 <a:tc>
                   <a:txBody>
-                    <a:bodyPr wrap="square"/>
+                    <a:bodyPr/>
                     <a:lstStyle/>
                     <a:p>
                       <a:r>
@@ -9420,7 +10220,7 @@
                 </a:tc>
                 <a:tc>
                   <a:txBody>
-                    <a:bodyPr wrap="square"/>
+                    <a:bodyPr/>
                     <a:lstStyle/>
                     <a:p>
                       <a:r>
@@ -9441,7 +10241,7 @@
                 </a:tc>
                 <a:tc>
                   <a:txBody>
-                    <a:bodyPr wrap="square"/>
+                    <a:bodyPr/>
                     <a:lstStyle/>
                     <a:p>
                       <a:r>
@@ -9462,7 +10262,7 @@
                 </a:tc>
                 <a:tc>
                   <a:txBody>
-                    <a:bodyPr wrap="square"/>
+                    <a:bodyPr/>
                     <a:lstStyle/>
                     <a:p>
                       <a:r>
@@ -9483,7 +10283,7 @@
                 </a:tc>
                 <a:tc>
                   <a:txBody>
-                    <a:bodyPr wrap="square"/>
+                    <a:bodyPr/>
                     <a:lstStyle/>
                     <a:p>
                       <a:r>
@@ -9504,7 +10304,7 @@
                 </a:tc>
                 <a:tc>
                   <a:txBody>
-                    <a:bodyPr wrap="square"/>
+                    <a:bodyPr/>
                     <a:lstStyle/>
                     <a:p>
                       <a:r>
@@ -9525,7 +10325,7 @@
                 </a:tc>
                 <a:tc>
                   <a:txBody>
-                    <a:bodyPr wrap="square"/>
+                    <a:bodyPr/>
                     <a:lstStyle/>
                     <a:p>
                       <a:r>
@@ -9546,7 +10346,7 @@
                 </a:tc>
                 <a:tc>
                   <a:txBody>
-                    <a:bodyPr wrap="square"/>
+                    <a:bodyPr/>
                     <a:lstStyle/>
                     <a:p>
                       <a:r>
@@ -9567,7 +10367,7 @@
                 </a:tc>
                 <a:tc>
                   <a:txBody>
-                    <a:bodyPr wrap="square"/>
+                    <a:bodyPr/>
                     <a:lstStyle/>
                     <a:p>
                       <a:r>
@@ -9587,11 +10387,16 @@
                     </a:solidFill>
                   </a:tcPr>
                 </a:tc>
+                <a:extLst>
+                  <a:ext uri="{0D108BD9-81ED-4DB2-BD59-A6C34878D82A}">
+                    <a16:rowId xmlns:a16="http://schemas.microsoft.com/office/drawing/2014/main" val="10007"/>
+                  </a:ext>
+                </a:extLst>
               </a:tr>
               <a:tr h="612800">
                 <a:tc>
                   <a:txBody>
-                    <a:bodyPr wrap="square"/>
+                    <a:bodyPr/>
                     <a:lstStyle/>
                     <a:p>
                       <a:r>
@@ -9613,7 +10418,7 @@
                 </a:tc>
                 <a:tc>
                   <a:txBody>
-                    <a:bodyPr wrap="square"/>
+                    <a:bodyPr/>
                     <a:lstStyle/>
                     <a:p>
                       <a:r>
@@ -9634,7 +10439,7 @@
                 </a:tc>
                 <a:tc>
                   <a:txBody>
-                    <a:bodyPr wrap="square"/>
+                    <a:bodyPr/>
                     <a:lstStyle/>
                     <a:p>
                       <a:r>
@@ -9655,7 +10460,7 @@
                 </a:tc>
                 <a:tc>
                   <a:txBody>
-                    <a:bodyPr wrap="square"/>
+                    <a:bodyPr/>
                     <a:lstStyle/>
                     <a:p>
                       <a:r>
@@ -9676,7 +10481,7 @@
                 </a:tc>
                 <a:tc>
                   <a:txBody>
-                    <a:bodyPr wrap="square"/>
+                    <a:bodyPr/>
                     <a:lstStyle/>
                     <a:p>
                       <a:r>
@@ -9697,7 +10502,7 @@
                 </a:tc>
                 <a:tc>
                   <a:txBody>
-                    <a:bodyPr wrap="square"/>
+                    <a:bodyPr/>
                     <a:lstStyle/>
                     <a:p>
                       <a:r>
@@ -9718,7 +10523,7 @@
                 </a:tc>
                 <a:tc>
                   <a:txBody>
-                    <a:bodyPr wrap="square"/>
+                    <a:bodyPr/>
                     <a:lstStyle/>
                     <a:p>
                       <a:r>
@@ -9739,7 +10544,7 @@
                 </a:tc>
                 <a:tc>
                   <a:txBody>
-                    <a:bodyPr wrap="square"/>
+                    <a:bodyPr/>
                     <a:lstStyle/>
                     <a:p>
                       <a:r>
@@ -9760,7 +10565,7 @@
                 </a:tc>
                 <a:tc>
                   <a:txBody>
-                    <a:bodyPr wrap="square"/>
+                    <a:bodyPr/>
                     <a:lstStyle/>
                     <a:p>
                       <a:r>
@@ -9781,7 +10586,7 @@
                 </a:tc>
                 <a:tc>
                   <a:txBody>
-                    <a:bodyPr wrap="square"/>
+                    <a:bodyPr/>
                     <a:lstStyle/>
                     <a:p>
                       <a:r>
@@ -9802,7 +10607,7 @@
                 </a:tc>
                 <a:tc>
                   <a:txBody>
-                    <a:bodyPr wrap="square"/>
+                    <a:bodyPr/>
                     <a:lstStyle/>
                     <a:p>
                       <a:r>
@@ -9821,11 +10626,16 @@
                     </a:solidFill>
                   </a:tcPr>
                 </a:tc>
+                <a:extLst>
+                  <a:ext uri="{0D108BD9-81ED-4DB2-BD59-A6C34878D82A}">
+                    <a16:rowId xmlns:a16="http://schemas.microsoft.com/office/drawing/2014/main" val="10008"/>
+                  </a:ext>
+                </a:extLst>
               </a:tr>
               <a:tr h="612800">
                 <a:tc>
                   <a:txBody>
-                    <a:bodyPr wrap="square"/>
+                    <a:bodyPr/>
                     <a:lstStyle/>
                     <a:p>
                       <a:r>
@@ -9847,7 +10657,7 @@
                 </a:tc>
                 <a:tc>
                   <a:txBody>
-                    <a:bodyPr wrap="square"/>
+                    <a:bodyPr/>
                     <a:lstStyle/>
                     <a:p>
                       <a:r>
@@ -9868,7 +10678,7 @@
                 </a:tc>
                 <a:tc>
                   <a:txBody>
-                    <a:bodyPr wrap="square"/>
+                    <a:bodyPr/>
                     <a:lstStyle/>
                     <a:p>
                       <a:r>
@@ -9889,7 +10699,7 @@
                 </a:tc>
                 <a:tc>
                   <a:txBody>
-                    <a:bodyPr wrap="square"/>
+                    <a:bodyPr/>
                     <a:lstStyle/>
                     <a:p>
                       <a:r>
@@ -9910,7 +10720,7 @@
                 </a:tc>
                 <a:tc>
                   <a:txBody>
-                    <a:bodyPr wrap="square"/>
+                    <a:bodyPr/>
                     <a:lstStyle/>
                     <a:p>
                       <a:r>
@@ -9931,7 +10741,7 @@
                 </a:tc>
                 <a:tc>
                   <a:txBody>
-                    <a:bodyPr wrap="square"/>
+                    <a:bodyPr/>
                     <a:lstStyle/>
                     <a:p>
                       <a:r>
@@ -9952,7 +10762,7 @@
                 </a:tc>
                 <a:tc>
                   <a:txBody>
-                    <a:bodyPr wrap="square"/>
+                    <a:bodyPr/>
                     <a:lstStyle/>
                     <a:p>
                       <a:r>
@@ -9973,7 +10783,7 @@
                 </a:tc>
                 <a:tc>
                   <a:txBody>
-                    <a:bodyPr wrap="square"/>
+                    <a:bodyPr/>
                     <a:lstStyle/>
                     <a:p>
                       <a:r>
@@ -9994,7 +10804,7 @@
                 </a:tc>
                 <a:tc>
                   <a:txBody>
-                    <a:bodyPr wrap="square"/>
+                    <a:bodyPr/>
                     <a:lstStyle/>
                     <a:p>
                       <a:r>
@@ -10015,7 +10825,7 @@
                 </a:tc>
                 <a:tc>
                   <a:txBody>
-                    <a:bodyPr wrap="square"/>
+                    <a:bodyPr/>
                     <a:lstStyle/>
                     <a:p>
                       <a:r>
@@ -10036,7 +10846,7 @@
                 </a:tc>
                 <a:tc>
                   <a:txBody>
-                    <a:bodyPr wrap="square"/>
+                    <a:bodyPr/>
                     <a:lstStyle/>
                     <a:p>
                       <a:r>
@@ -10056,6 +10866,11 @@
                     </a:solidFill>
                   </a:tcPr>
                 </a:tc>
+                <a:extLst>
+                  <a:ext uri="{0D108BD9-81ED-4DB2-BD59-A6C34878D82A}">
+                    <a16:rowId xmlns:a16="http://schemas.microsoft.com/office/drawing/2014/main" val="10009"/>
+                  </a:ext>
+                </a:extLst>
               </a:tr>
             </a:tbl>
           </a:graphicData>
@@ -10070,7 +10885,7 @@
 </file>
 
 <file path=ppt/slides/slide5.xml><?xml version="1.0" encoding="utf-8"?>
-<p:sld xmlns:a="http://schemas.openxmlformats.org/drawingml/2006/main" xmlns:p="http://schemas.openxmlformats.org/presentationml/2006/main" xmlns:r="http://schemas.openxmlformats.org/officeDocument/2006/relationships">
+<p:sld xmlns:a="http://schemas.openxmlformats.org/drawingml/2006/main" xmlns:r="http://schemas.openxmlformats.org/officeDocument/2006/relationships" xmlns:p="http://schemas.openxmlformats.org/presentationml/2006/main">
   <p:cSld>
     <p:spTree>
       <p:nvGrpSpPr>
@@ -10078,7 +10893,14 @@
         <p:cNvGrpSpPr/>
         <p:nvPr/>
       </p:nvGrpSpPr>
-      <p:grpSpPr/>
+      <p:grpSpPr>
+        <a:xfrm>
+          <a:off x="0" y="0"/>
+          <a:ext cx="0" cy="0"/>
+          <a:chOff x="0" y="0"/>
+          <a:chExt cx="0" cy="0"/>
+        </a:xfrm>
+      </p:grpSpPr>
       <p:sp>
         <p:nvSpPr>
           <p:cNvPr id="2" name="Rectangle 1"/>
@@ -10119,6 +10941,7 @@
           <a:lstStyle/>
           <a:p>
             <a:pPr algn="ctr"/>
+            <a:endParaRPr/>
           </a:p>
         </p:txBody>
       </p:sp>
@@ -10196,6 +11019,7 @@
           <a:lstStyle/>
           <a:p>
             <a:pPr algn="ctr"/>
+            <a:endParaRPr/>
           </a:p>
         </p:txBody>
       </p:sp>
@@ -10307,6 +11131,7 @@
           <a:lstStyle/>
           <a:p>
             <a:pPr algn="ctr"/>
+            <a:endParaRPr/>
           </a:p>
         </p:txBody>
       </p:sp>
@@ -10418,6 +11243,7 @@
           <a:lstStyle/>
           <a:p>
             <a:pPr algn="ctr"/>
+            <a:endParaRPr/>
           </a:p>
         </p:txBody>
       </p:sp>
@@ -10508,15 +11334,39 @@
                 <a:tableStyleId>{5C22544A-7EE6-4342-B048-85BDC9FD1C3A}</a:tableStyleId>
               </a:tblPr>
               <a:tblGrid>
-                <a:gridCol w="2500000"/>
-                <a:gridCol w="650000"/>
-                <a:gridCol w="6600000"/>
-                <a:gridCol w="800000"/>
+                <a:gridCol w="2500000">
+                  <a:extLst>
+                    <a:ext uri="{9D8B030D-6E8A-4147-A177-3AD203B41FA5}">
+                      <a16:colId xmlns:a16="http://schemas.microsoft.com/office/drawing/2014/main" val="20000"/>
+                    </a:ext>
+                  </a:extLst>
+                </a:gridCol>
+                <a:gridCol w="650000">
+                  <a:extLst>
+                    <a:ext uri="{9D8B030D-6E8A-4147-A177-3AD203B41FA5}">
+                      <a16:colId xmlns:a16="http://schemas.microsoft.com/office/drawing/2014/main" val="20001"/>
+                    </a:ext>
+                  </a:extLst>
+                </a:gridCol>
+                <a:gridCol w="6600000">
+                  <a:extLst>
+                    <a:ext uri="{9D8B030D-6E8A-4147-A177-3AD203B41FA5}">
+                      <a16:colId xmlns:a16="http://schemas.microsoft.com/office/drawing/2014/main" val="20002"/>
+                    </a:ext>
+                  </a:extLst>
+                </a:gridCol>
+                <a:gridCol w="800000">
+                  <a:extLst>
+                    <a:ext uri="{9D8B030D-6E8A-4147-A177-3AD203B41FA5}">
+                      <a16:colId xmlns:a16="http://schemas.microsoft.com/office/drawing/2014/main" val="20003"/>
+                    </a:ext>
+                  </a:extLst>
+                </a:gridCol>
               </a:tblGrid>
               <a:tr h="338888">
                 <a:tc>
                   <a:txBody>
-                    <a:bodyPr wrap="square"/>
+                    <a:bodyPr/>
                     <a:lstStyle/>
                     <a:p>
                       <a:r>
@@ -10537,7 +11387,7 @@
                 </a:tc>
                 <a:tc>
                   <a:txBody>
-                    <a:bodyPr wrap="square"/>
+                    <a:bodyPr/>
                     <a:lstStyle/>
                     <a:p>
                       <a:r>
@@ -10558,7 +11408,7 @@
                 </a:tc>
                 <a:tc>
                   <a:txBody>
-                    <a:bodyPr wrap="square"/>
+                    <a:bodyPr/>
                     <a:lstStyle/>
                     <a:p>
                       <a:r>
@@ -10579,7 +11429,7 @@
                 </a:tc>
                 <a:tc>
                   <a:txBody>
-                    <a:bodyPr wrap="square"/>
+                    <a:bodyPr/>
                     <a:lstStyle/>
                     <a:p>
                       <a:r>
@@ -10598,11 +11448,16 @@
                     </a:solidFill>
                   </a:tcPr>
                 </a:tc>
+                <a:extLst>
+                  <a:ext uri="{0D108BD9-81ED-4DB2-BD59-A6C34878D82A}">
+                    <a16:rowId xmlns:a16="http://schemas.microsoft.com/office/drawing/2014/main" val="10000"/>
+                  </a:ext>
+                </a:extLst>
               </a:tr>
               <a:tr h="338888">
                 <a:tc>
                   <a:txBody>
-                    <a:bodyPr wrap="square"/>
+                    <a:bodyPr/>
                     <a:lstStyle/>
                     <a:p>
                       <a:r>
@@ -10615,7 +11470,7 @@
                 </a:tc>
                 <a:tc>
                   <a:txBody>
-                    <a:bodyPr wrap="square"/>
+                    <a:bodyPr/>
                     <a:lstStyle/>
                     <a:p>
                       <a:r>
@@ -10628,7 +11483,7 @@
                 </a:tc>
                 <a:tc>
                   <a:txBody>
-                    <a:bodyPr wrap="square"/>
+                    <a:bodyPr/>
                     <a:lstStyle/>
                     <a:p>
                       <a:r>
@@ -10641,7 +11496,7 @@
                 </a:tc>
                 <a:tc>
                   <a:txBody>
-                    <a:bodyPr wrap="square"/>
+                    <a:bodyPr/>
                     <a:lstStyle/>
                     <a:p>
                       <a:r>
@@ -10652,11 +11507,16 @@
                   </a:txBody>
                   <a:tcPr/>
                 </a:tc>
+                <a:extLst>
+                  <a:ext uri="{0D108BD9-81ED-4DB2-BD59-A6C34878D82A}">
+                    <a16:rowId xmlns:a16="http://schemas.microsoft.com/office/drawing/2014/main" val="10001"/>
+                  </a:ext>
+                </a:extLst>
               </a:tr>
               <a:tr h="338888">
                 <a:tc>
                   <a:txBody>
-                    <a:bodyPr wrap="square"/>
+                    <a:bodyPr/>
                     <a:lstStyle/>
                     <a:p>
                       <a:r>
@@ -10673,7 +11533,7 @@
                 </a:tc>
                 <a:tc>
                   <a:txBody>
-                    <a:bodyPr wrap="square"/>
+                    <a:bodyPr/>
                     <a:lstStyle/>
                     <a:p>
                       <a:r>
@@ -10690,7 +11550,7 @@
                 </a:tc>
                 <a:tc>
                   <a:txBody>
-                    <a:bodyPr wrap="square"/>
+                    <a:bodyPr/>
                     <a:lstStyle/>
                     <a:p>
                       <a:r>
@@ -10707,7 +11567,7 @@
                 </a:tc>
                 <a:tc>
                   <a:txBody>
-                    <a:bodyPr wrap="square"/>
+                    <a:bodyPr/>
                     <a:lstStyle/>
                     <a:p>
                       <a:r>
@@ -10722,11 +11582,16 @@
                     </a:solidFill>
                   </a:tcPr>
                 </a:tc>
+                <a:extLst>
+                  <a:ext uri="{0D108BD9-81ED-4DB2-BD59-A6C34878D82A}">
+                    <a16:rowId xmlns:a16="http://schemas.microsoft.com/office/drawing/2014/main" val="10002"/>
+                  </a:ext>
+                </a:extLst>
               </a:tr>
               <a:tr h="338888">
                 <a:tc>
                   <a:txBody>
-                    <a:bodyPr wrap="square"/>
+                    <a:bodyPr/>
                     <a:lstStyle/>
                     <a:p>
                       <a:r>
@@ -10739,7 +11604,7 @@
                 </a:tc>
                 <a:tc>
                   <a:txBody>
-                    <a:bodyPr wrap="square"/>
+                    <a:bodyPr/>
                     <a:lstStyle/>
                     <a:p>
                       <a:r>
@@ -10752,7 +11617,7 @@
                 </a:tc>
                 <a:tc>
                   <a:txBody>
-                    <a:bodyPr wrap="square"/>
+                    <a:bodyPr/>
                     <a:lstStyle/>
                     <a:p>
                       <a:r>
@@ -10765,7 +11630,7 @@
                 </a:tc>
                 <a:tc>
                   <a:txBody>
-                    <a:bodyPr wrap="square"/>
+                    <a:bodyPr/>
                     <a:lstStyle/>
                     <a:p>
                       <a:r>
@@ -10776,11 +11641,16 @@
                   </a:txBody>
                   <a:tcPr/>
                 </a:tc>
+                <a:extLst>
+                  <a:ext uri="{0D108BD9-81ED-4DB2-BD59-A6C34878D82A}">
+                    <a16:rowId xmlns:a16="http://schemas.microsoft.com/office/drawing/2014/main" val="10003"/>
+                  </a:ext>
+                </a:extLst>
               </a:tr>
               <a:tr h="338888">
                 <a:tc>
                   <a:txBody>
-                    <a:bodyPr wrap="square"/>
+                    <a:bodyPr/>
                     <a:lstStyle/>
                     <a:p>
                       <a:r>
@@ -10797,7 +11667,7 @@
                 </a:tc>
                 <a:tc>
                   <a:txBody>
-                    <a:bodyPr wrap="square"/>
+                    <a:bodyPr/>
                     <a:lstStyle/>
                     <a:p>
                       <a:r>
@@ -10814,7 +11684,7 @@
                 </a:tc>
                 <a:tc>
                   <a:txBody>
-                    <a:bodyPr wrap="square"/>
+                    <a:bodyPr/>
                     <a:lstStyle/>
                     <a:p>
                       <a:r>
@@ -10831,7 +11701,7 @@
                 </a:tc>
                 <a:tc>
                   <a:txBody>
-                    <a:bodyPr wrap="square"/>
+                    <a:bodyPr/>
                     <a:lstStyle/>
                     <a:p>
                       <a:r>
@@ -10846,11 +11716,16 @@
                     </a:solidFill>
                   </a:tcPr>
                 </a:tc>
+                <a:extLst>
+                  <a:ext uri="{0D108BD9-81ED-4DB2-BD59-A6C34878D82A}">
+                    <a16:rowId xmlns:a16="http://schemas.microsoft.com/office/drawing/2014/main" val="10004"/>
+                  </a:ext>
+                </a:extLst>
               </a:tr>
               <a:tr h="338888">
                 <a:tc>
                   <a:txBody>
-                    <a:bodyPr wrap="square"/>
+                    <a:bodyPr/>
                     <a:lstStyle/>
                     <a:p>
                       <a:r>
@@ -10863,7 +11738,7 @@
                 </a:tc>
                 <a:tc>
                   <a:txBody>
-                    <a:bodyPr wrap="square"/>
+                    <a:bodyPr/>
                     <a:lstStyle/>
                     <a:p>
                       <a:r>
@@ -10876,7 +11751,7 @@
                 </a:tc>
                 <a:tc>
                   <a:txBody>
-                    <a:bodyPr wrap="square"/>
+                    <a:bodyPr/>
                     <a:lstStyle/>
                     <a:p>
                       <a:r>
@@ -10889,7 +11764,7 @@
                 </a:tc>
                 <a:tc>
                   <a:txBody>
-                    <a:bodyPr wrap="square"/>
+                    <a:bodyPr/>
                     <a:lstStyle/>
                     <a:p>
                       <a:r>
@@ -10900,11 +11775,16 @@
                   </a:txBody>
                   <a:tcPr/>
                 </a:tc>
+                <a:extLst>
+                  <a:ext uri="{0D108BD9-81ED-4DB2-BD59-A6C34878D82A}">
+                    <a16:rowId xmlns:a16="http://schemas.microsoft.com/office/drawing/2014/main" val="10005"/>
+                  </a:ext>
+                </a:extLst>
               </a:tr>
               <a:tr h="338888">
                 <a:tc>
                   <a:txBody>
-                    <a:bodyPr wrap="square"/>
+                    <a:bodyPr/>
                     <a:lstStyle/>
                     <a:p>
                       <a:r>
@@ -10921,7 +11801,7 @@
                 </a:tc>
                 <a:tc>
                   <a:txBody>
-                    <a:bodyPr wrap="square"/>
+                    <a:bodyPr/>
                     <a:lstStyle/>
                     <a:p>
                       <a:r>
@@ -10938,7 +11818,7 @@
                 </a:tc>
                 <a:tc>
                   <a:txBody>
-                    <a:bodyPr wrap="square"/>
+                    <a:bodyPr/>
                     <a:lstStyle/>
                     <a:p>
                       <a:r>
@@ -10955,7 +11835,7 @@
                 </a:tc>
                 <a:tc>
                   <a:txBody>
-                    <a:bodyPr wrap="square"/>
+                    <a:bodyPr/>
                     <a:lstStyle/>
                     <a:p>
                       <a:r>
@@ -10970,11 +11850,16 @@
                     </a:solidFill>
                   </a:tcPr>
                 </a:tc>
+                <a:extLst>
+                  <a:ext uri="{0D108BD9-81ED-4DB2-BD59-A6C34878D82A}">
+                    <a16:rowId xmlns:a16="http://schemas.microsoft.com/office/drawing/2014/main" val="10006"/>
+                  </a:ext>
+                </a:extLst>
               </a:tr>
               <a:tr h="338888">
                 <a:tc>
                   <a:txBody>
-                    <a:bodyPr wrap="square"/>
+                    <a:bodyPr/>
                     <a:lstStyle/>
                     <a:p>
                       <a:r>
@@ -10987,7 +11872,7 @@
                 </a:tc>
                 <a:tc>
                   <a:txBody>
-                    <a:bodyPr wrap="square"/>
+                    <a:bodyPr/>
                     <a:lstStyle/>
                     <a:p>
                       <a:r>
@@ -11000,7 +11885,7 @@
                 </a:tc>
                 <a:tc>
                   <a:txBody>
-                    <a:bodyPr wrap="square"/>
+                    <a:bodyPr/>
                     <a:lstStyle/>
                     <a:p>
                       <a:r>
@@ -11013,7 +11898,7 @@
                 </a:tc>
                 <a:tc>
                   <a:txBody>
-                    <a:bodyPr wrap="square"/>
+                    <a:bodyPr/>
                     <a:lstStyle/>
                     <a:p>
                       <a:r>
@@ -11024,11 +11909,16 @@
                   </a:txBody>
                   <a:tcPr/>
                 </a:tc>
+                <a:extLst>
+                  <a:ext uri="{0D108BD9-81ED-4DB2-BD59-A6C34878D82A}">
+                    <a16:rowId xmlns:a16="http://schemas.microsoft.com/office/drawing/2014/main" val="10007"/>
+                  </a:ext>
+                </a:extLst>
               </a:tr>
               <a:tr h="338896">
                 <a:tc>
                   <a:txBody>
-                    <a:bodyPr wrap="square"/>
+                    <a:bodyPr/>
                     <a:lstStyle/>
                     <a:p>
                       <a:r>
@@ -11045,7 +11935,7 @@
                 </a:tc>
                 <a:tc>
                   <a:txBody>
-                    <a:bodyPr wrap="square"/>
+                    <a:bodyPr/>
                     <a:lstStyle/>
                     <a:p>
                       <a:r>
@@ -11062,7 +11952,7 @@
                 </a:tc>
                 <a:tc>
                   <a:txBody>
-                    <a:bodyPr wrap="square"/>
+                    <a:bodyPr/>
                     <a:lstStyle/>
                     <a:p>
                       <a:r>
@@ -11079,7 +11969,7 @@
                 </a:tc>
                 <a:tc>
                   <a:txBody>
-                    <a:bodyPr wrap="square"/>
+                    <a:bodyPr/>
                     <a:lstStyle/>
                     <a:p>
                       <a:r>
@@ -11094,6 +11984,11 @@
                     </a:solidFill>
                   </a:tcPr>
                 </a:tc>
+                <a:extLst>
+                  <a:ext uri="{0D108BD9-81ED-4DB2-BD59-A6C34878D82A}">
+                    <a16:rowId xmlns:a16="http://schemas.microsoft.com/office/drawing/2014/main" val="10008"/>
+                  </a:ext>
+                </a:extLst>
               </a:tr>
             </a:tbl>
           </a:graphicData>
@@ -11171,7 +12066,13 @@
           <p:cNvGraphicFramePr>
             <a:graphicFrameLocks noGrp="1"/>
           </p:cNvGraphicFramePr>
-          <p:nvPr/>
+          <p:nvPr>
+            <p:extLst>
+              <p:ext uri="{D42A27DB-BD31-4B8C-83A1-F6EECF244321}">
+                <p14:modId xmlns:p14="http://schemas.microsoft.com/office/powerpoint/2010/main" val="1250342993"/>
+              </p:ext>
+            </p:extLst>
+          </p:nvPr>
         </p:nvGraphicFramePr>
         <p:xfrm>
           <a:off x="108000" y="4644000"/>
@@ -11179,7 +12080,7 @@
         </p:xfrm>
         <a:graphic>
           <a:graphicData uri="http://schemas.openxmlformats.org/drawingml/2006/chart">
-            <c:chart xmlns:c="http://schemas.openxmlformats.org/drawingml/2006/chart" r:id="rId4"/>
+            <c:chart xmlns:c="http://schemas.openxmlformats.org/drawingml/2006/chart" xmlns:r="http://schemas.openxmlformats.org/officeDocument/2006/relationships" r:id="rId3"/>
           </a:graphicData>
         </a:graphic>
       </p:graphicFrame>
@@ -11189,7 +12090,13 @@
           <p:cNvGraphicFramePr>
             <a:graphicFrameLocks noGrp="1"/>
           </p:cNvGraphicFramePr>
-          <p:nvPr/>
+          <p:nvPr>
+            <p:extLst>
+              <p:ext uri="{D42A27DB-BD31-4B8C-83A1-F6EECF244321}">
+                <p14:modId xmlns:p14="http://schemas.microsoft.com/office/powerpoint/2010/main" val="3066411286"/>
+              </p:ext>
+            </p:extLst>
+          </p:nvPr>
         </p:nvGraphicFramePr>
         <p:xfrm>
           <a:off x="6120000" y="4644000"/>
@@ -11197,7 +12104,7 @@
         </p:xfrm>
         <a:graphic>
           <a:graphicData uri="http://schemas.openxmlformats.org/drawingml/2006/chart">
-            <c:chart xmlns:c="http://schemas.openxmlformats.org/drawingml/2006/chart" r:id="rId5"/>
+            <c:chart xmlns:c="http://schemas.openxmlformats.org/drawingml/2006/chart" xmlns:r="http://schemas.openxmlformats.org/officeDocument/2006/relationships" r:id="rId4"/>
           </a:graphicData>
         </a:graphic>
       </p:graphicFrame>
@@ -11210,7 +12117,7 @@
 </file>
 
 <file path=ppt/slides/slide6.xml><?xml version="1.0" encoding="utf-8"?>
-<p:sld xmlns:a="http://schemas.openxmlformats.org/drawingml/2006/main" xmlns:p="http://schemas.openxmlformats.org/presentationml/2006/main" xmlns:r="http://schemas.openxmlformats.org/officeDocument/2006/relationships">
+<p:sld xmlns:a="http://schemas.openxmlformats.org/drawingml/2006/main" xmlns:r="http://schemas.openxmlformats.org/officeDocument/2006/relationships" xmlns:p="http://schemas.openxmlformats.org/presentationml/2006/main">
   <p:cSld>
     <p:spTree>
       <p:nvGrpSpPr>
@@ -11218,7 +12125,14 @@
         <p:cNvGrpSpPr/>
         <p:nvPr/>
       </p:nvGrpSpPr>
-      <p:grpSpPr/>
+      <p:grpSpPr>
+        <a:xfrm>
+          <a:off x="0" y="0"/>
+          <a:ext cx="0" cy="0"/>
+          <a:chOff x="0" y="0"/>
+          <a:chExt cx="0" cy="0"/>
+        </a:xfrm>
+      </p:grpSpPr>
       <p:sp>
         <p:nvSpPr>
           <p:cNvPr id="2" name="Rectangle 1"/>
@@ -11259,6 +12173,7 @@
           <a:lstStyle/>
           <a:p>
             <a:pPr algn="ctr"/>
+            <a:endParaRPr/>
           </a:p>
         </p:txBody>
       </p:sp>
@@ -11302,6 +12217,7 @@
           <a:lstStyle/>
           <a:p>
             <a:pPr algn="ctr"/>
+            <a:endParaRPr/>
           </a:p>
         </p:txBody>
       </p:sp>
@@ -11380,6 +12296,7 @@
           <a:lstStyle/>
           <a:p>
             <a:pPr algn="ctr"/>
+            <a:endParaRPr/>
           </a:p>
         </p:txBody>
       </p:sp>
@@ -11458,6 +12375,7 @@
           <a:lstStyle/>
           <a:p>
             <a:pPr algn="ctr"/>
+            <a:endParaRPr/>
           </a:p>
         </p:txBody>
       </p:sp>
@@ -11572,6 +12490,7 @@
           <a:lstStyle/>
           <a:p>
             <a:pPr algn="ctr"/>
+            <a:endParaRPr/>
           </a:p>
         </p:txBody>
       </p:sp>
@@ -11650,6 +12569,7 @@
           <a:lstStyle/>
           <a:p>
             <a:pPr algn="ctr"/>
+            <a:endParaRPr/>
           </a:p>
         </p:txBody>
       </p:sp>
@@ -11764,6 +12684,7 @@
           <a:lstStyle/>
           <a:p>
             <a:pPr algn="ctr"/>
+            <a:endParaRPr/>
           </a:p>
         </p:txBody>
       </p:sp>
@@ -11842,6 +12763,7 @@
           <a:lstStyle/>
           <a:p>
             <a:pPr algn="ctr"/>
+            <a:endParaRPr/>
           </a:p>
         </p:txBody>
       </p:sp>
@@ -11956,6 +12878,7 @@
           <a:lstStyle/>
           <a:p>
             <a:pPr algn="ctr"/>
+            <a:endParaRPr/>
           </a:p>
         </p:txBody>
       </p:sp>
@@ -12034,6 +12957,7 @@
           <a:lstStyle/>
           <a:p>
             <a:pPr algn="ctr"/>
+            <a:endParaRPr/>
           </a:p>
         </p:txBody>
       </p:sp>
@@ -12223,7 +13147,7 @@
 </file>
 
 <file path=ppt/slides/slide7.xml><?xml version="1.0" encoding="utf-8"?>
-<p:sld xmlns:a="http://schemas.openxmlformats.org/drawingml/2006/main" xmlns:p="http://schemas.openxmlformats.org/presentationml/2006/main" xmlns:r="http://schemas.openxmlformats.org/officeDocument/2006/relationships">
+<p:sld xmlns:a="http://schemas.openxmlformats.org/drawingml/2006/main" xmlns:r="http://schemas.openxmlformats.org/officeDocument/2006/relationships" xmlns:p="http://schemas.openxmlformats.org/presentationml/2006/main">
   <p:cSld>
     <p:spTree>
       <p:nvGrpSpPr>
@@ -12231,7 +13155,14 @@
         <p:cNvGrpSpPr/>
         <p:nvPr/>
       </p:nvGrpSpPr>
-      <p:grpSpPr/>
+      <p:grpSpPr>
+        <a:xfrm>
+          <a:off x="0" y="0"/>
+          <a:ext cx="0" cy="0"/>
+          <a:chOff x="0" y="0"/>
+          <a:chExt cx="0" cy="0"/>
+        </a:xfrm>
+      </p:grpSpPr>
       <p:sp>
         <p:nvSpPr>
           <p:cNvPr id="2" name="Rectangle 1"/>
@@ -12272,6 +13203,7 @@
           <a:lstStyle/>
           <a:p>
             <a:pPr algn="ctr"/>
+            <a:endParaRPr/>
           </a:p>
         </p:txBody>
       </p:sp>
@@ -12315,6 +13247,7 @@
           <a:lstStyle/>
           <a:p>
             <a:pPr algn="ctr"/>
+            <a:endParaRPr/>
           </a:p>
         </p:txBody>
       </p:sp>
@@ -12504,6 +13437,7 @@
           <a:lstStyle/>
           <a:p>
             <a:pPr algn="ctr"/>
+            <a:endParaRPr/>
           </a:p>
         </p:txBody>
       </p:sp>
@@ -12561,18 +13495,36 @@
                 <a:tableStyleId>{5C22544A-7EE6-4342-B048-85BDC9FD1C3A}</a:tableStyleId>
               </a:tblPr>
               <a:tblGrid>
-                <a:gridCol w="1980000"/>
-                <a:gridCol w="3240000"/>
-                <a:gridCol w="2700000"/>
+                <a:gridCol w="1980000">
+                  <a:extLst>
+                    <a:ext uri="{9D8B030D-6E8A-4147-A177-3AD203B41FA5}">
+                      <a16:colId xmlns:a16="http://schemas.microsoft.com/office/drawing/2014/main" val="20000"/>
+                    </a:ext>
+                  </a:extLst>
+                </a:gridCol>
+                <a:gridCol w="3240000">
+                  <a:extLst>
+                    <a:ext uri="{9D8B030D-6E8A-4147-A177-3AD203B41FA5}">
+                      <a16:colId xmlns:a16="http://schemas.microsoft.com/office/drawing/2014/main" val="20001"/>
+                    </a:ext>
+                  </a:extLst>
+                </a:gridCol>
+                <a:gridCol w="2700000">
+                  <a:extLst>
+                    <a:ext uri="{9D8B030D-6E8A-4147-A177-3AD203B41FA5}">
+                      <a16:colId xmlns:a16="http://schemas.microsoft.com/office/drawing/2014/main" val="20002"/>
+                    </a:ext>
+                  </a:extLst>
+                </a:gridCol>
               </a:tblGrid>
               <a:tr h="607500">
                 <a:tc>
                   <a:txBody>
-                    <a:bodyPr wrap="square"/>
-                    <a:lstStyle/>
-                    <a:p>
-                      <a:r>
-                        <a:rPr b="1" sz="1100">
+                    <a:bodyPr/>
+                    <a:lstStyle/>
+                    <a:p>
+                      <a:r>
+                        <a:rPr sz="1100" b="1">
                           <a:solidFill>
                             <a:srgbClr val="FFFFFF"/>
                           </a:solidFill>
@@ -12589,11 +13541,11 @@
                 </a:tc>
                 <a:tc>
                   <a:txBody>
-                    <a:bodyPr wrap="square"/>
-                    <a:lstStyle/>
-                    <a:p>
-                      <a:r>
-                        <a:rPr b="1" sz="1100">
+                    <a:bodyPr/>
+                    <a:lstStyle/>
+                    <a:p>
+                      <a:r>
+                        <a:rPr sz="1100" b="1">
                           <a:solidFill>
                             <a:srgbClr val="FFFFFF"/>
                           </a:solidFill>
@@ -12610,11 +13562,11 @@
                 </a:tc>
                 <a:tc>
                   <a:txBody>
-                    <a:bodyPr wrap="square"/>
-                    <a:lstStyle/>
-                    <a:p>
-                      <a:r>
-                        <a:rPr b="1" sz="1100">
+                    <a:bodyPr/>
+                    <a:lstStyle/>
+                    <a:p>
+                      <a:r>
+                        <a:rPr sz="1100" b="1">
                           <a:solidFill>
                             <a:srgbClr val="FFFFFF"/>
                           </a:solidFill>
@@ -12629,11 +13581,16 @@
                     </a:solidFill>
                   </a:tcPr>
                 </a:tc>
+                <a:extLst>
+                  <a:ext uri="{0D108BD9-81ED-4DB2-BD59-A6C34878D82A}">
+                    <a16:rowId xmlns:a16="http://schemas.microsoft.com/office/drawing/2014/main" val="10000"/>
+                  </a:ext>
+                </a:extLst>
               </a:tr>
               <a:tr h="607500">
                 <a:tc>
                   <a:txBody>
-                    <a:bodyPr wrap="square"/>
+                    <a:bodyPr/>
                     <a:lstStyle/>
                     <a:p>
                       <a:r>
@@ -12650,7 +13607,7 @@
                 </a:tc>
                 <a:tc>
                   <a:txBody>
-                    <a:bodyPr wrap="square"/>
+                    <a:bodyPr/>
                     <a:lstStyle/>
                     <a:p>
                       <a:r>
@@ -12663,7 +13620,7 @@
                 </a:tc>
                 <a:tc>
                   <a:txBody>
-                    <a:bodyPr wrap="square"/>
+                    <a:bodyPr/>
                     <a:lstStyle/>
                     <a:p>
                       <a:r>
@@ -12674,11 +13631,16 @@
                   </a:txBody>
                   <a:tcPr/>
                 </a:tc>
+                <a:extLst>
+                  <a:ext uri="{0D108BD9-81ED-4DB2-BD59-A6C34878D82A}">
+                    <a16:rowId xmlns:a16="http://schemas.microsoft.com/office/drawing/2014/main" val="10001"/>
+                  </a:ext>
+                </a:extLst>
               </a:tr>
               <a:tr h="607500">
                 <a:tc>
                   <a:txBody>
-                    <a:bodyPr wrap="square"/>
+                    <a:bodyPr/>
                     <a:lstStyle/>
                     <a:p>
                       <a:r>
@@ -12699,7 +13661,7 @@
                 </a:tc>
                 <a:tc>
                   <a:txBody>
-                    <a:bodyPr wrap="square"/>
+                    <a:bodyPr/>
                     <a:lstStyle/>
                     <a:p>
                       <a:r>
@@ -12716,7 +13678,7 @@
                 </a:tc>
                 <a:tc>
                   <a:txBody>
-                    <a:bodyPr wrap="square"/>
+                    <a:bodyPr/>
                     <a:lstStyle/>
                     <a:p>
                       <a:r>
@@ -12731,11 +13693,16 @@
                     </a:solidFill>
                   </a:tcPr>
                 </a:tc>
+                <a:extLst>
+                  <a:ext uri="{0D108BD9-81ED-4DB2-BD59-A6C34878D82A}">
+                    <a16:rowId xmlns:a16="http://schemas.microsoft.com/office/drawing/2014/main" val="10002"/>
+                  </a:ext>
+                </a:extLst>
               </a:tr>
               <a:tr h="607500">
                 <a:tc>
                   <a:txBody>
-                    <a:bodyPr wrap="square"/>
+                    <a:bodyPr/>
                     <a:lstStyle/>
                     <a:p>
                       <a:r>
@@ -12752,7 +13719,7 @@
                 </a:tc>
                 <a:tc>
                   <a:txBody>
-                    <a:bodyPr wrap="square"/>
+                    <a:bodyPr/>
                     <a:lstStyle/>
                     <a:p>
                       <a:r>
@@ -12765,7 +13732,7 @@
                 </a:tc>
                 <a:tc>
                   <a:txBody>
-                    <a:bodyPr wrap="square"/>
+                    <a:bodyPr/>
                     <a:lstStyle/>
                     <a:p>
                       <a:r>
@@ -12776,11 +13743,16 @@
                   </a:txBody>
                   <a:tcPr/>
                 </a:tc>
+                <a:extLst>
+                  <a:ext uri="{0D108BD9-81ED-4DB2-BD59-A6C34878D82A}">
+                    <a16:rowId xmlns:a16="http://schemas.microsoft.com/office/drawing/2014/main" val="10003"/>
+                  </a:ext>
+                </a:extLst>
               </a:tr>
               <a:tr h="607500">
                 <a:tc>
                   <a:txBody>
-                    <a:bodyPr wrap="square"/>
+                    <a:bodyPr/>
                     <a:lstStyle/>
                     <a:p>
                       <a:r>
@@ -12801,7 +13773,7 @@
                 </a:tc>
                 <a:tc>
                   <a:txBody>
-                    <a:bodyPr wrap="square"/>
+                    <a:bodyPr/>
                     <a:lstStyle/>
                     <a:p>
                       <a:r>
@@ -12818,7 +13790,7 @@
                 </a:tc>
                 <a:tc>
                   <a:txBody>
-                    <a:bodyPr wrap="square"/>
+                    <a:bodyPr/>
                     <a:lstStyle/>
                     <a:p>
                       <a:r>
@@ -12833,11 +13805,16 @@
                     </a:solidFill>
                   </a:tcPr>
                 </a:tc>
+                <a:extLst>
+                  <a:ext uri="{0D108BD9-81ED-4DB2-BD59-A6C34878D82A}">
+                    <a16:rowId xmlns:a16="http://schemas.microsoft.com/office/drawing/2014/main" val="10004"/>
+                  </a:ext>
+                </a:extLst>
               </a:tr>
               <a:tr h="607500">
                 <a:tc>
                   <a:txBody>
-                    <a:bodyPr wrap="square"/>
+                    <a:bodyPr/>
                     <a:lstStyle/>
                     <a:p>
                       <a:r>
@@ -12854,7 +13831,7 @@
                 </a:tc>
                 <a:tc>
                   <a:txBody>
-                    <a:bodyPr wrap="square"/>
+                    <a:bodyPr/>
                     <a:lstStyle/>
                     <a:p>
                       <a:r>
@@ -12867,7 +13844,7 @@
                 </a:tc>
                 <a:tc>
                   <a:txBody>
-                    <a:bodyPr wrap="square"/>
+                    <a:bodyPr/>
                     <a:lstStyle/>
                     <a:p>
                       <a:r>
@@ -12878,11 +13855,16 @@
                   </a:txBody>
                   <a:tcPr/>
                 </a:tc>
+                <a:extLst>
+                  <a:ext uri="{0D108BD9-81ED-4DB2-BD59-A6C34878D82A}">
+                    <a16:rowId xmlns:a16="http://schemas.microsoft.com/office/drawing/2014/main" val="10005"/>
+                  </a:ext>
+                </a:extLst>
               </a:tr>
               <a:tr h="607500">
                 <a:tc>
                   <a:txBody>
-                    <a:bodyPr wrap="square"/>
+                    <a:bodyPr/>
                     <a:lstStyle/>
                     <a:p>
                       <a:r>
@@ -12903,7 +13885,7 @@
                 </a:tc>
                 <a:tc>
                   <a:txBody>
-                    <a:bodyPr wrap="square"/>
+                    <a:bodyPr/>
                     <a:lstStyle/>
                     <a:p>
                       <a:r>
@@ -12920,7 +13902,7 @@
                 </a:tc>
                 <a:tc>
                   <a:txBody>
-                    <a:bodyPr wrap="square"/>
+                    <a:bodyPr/>
                     <a:lstStyle/>
                     <a:p>
                       <a:r>
@@ -12935,11 +13917,16 @@
                     </a:solidFill>
                   </a:tcPr>
                 </a:tc>
+                <a:extLst>
+                  <a:ext uri="{0D108BD9-81ED-4DB2-BD59-A6C34878D82A}">
+                    <a16:rowId xmlns:a16="http://schemas.microsoft.com/office/drawing/2014/main" val="10006"/>
+                  </a:ext>
+                </a:extLst>
               </a:tr>
               <a:tr h="607500">
                 <a:tc>
                   <a:txBody>
-                    <a:bodyPr wrap="square"/>
+                    <a:bodyPr/>
                     <a:lstStyle/>
                     <a:p>
                       <a:r>
@@ -12956,7 +13943,7 @@
                 </a:tc>
                 <a:tc>
                   <a:txBody>
-                    <a:bodyPr wrap="square"/>
+                    <a:bodyPr/>
                     <a:lstStyle/>
                     <a:p>
                       <a:r>
@@ -12969,7 +13956,7 @@
                 </a:tc>
                 <a:tc>
                   <a:txBody>
-                    <a:bodyPr wrap="square"/>
+                    <a:bodyPr/>
                     <a:lstStyle/>
                     <a:p>
                       <a:r>
@@ -12980,6 +13967,11 @@
                   </a:txBody>
                   <a:tcPr/>
                 </a:tc>
+                <a:extLst>
+                  <a:ext uri="{0D108BD9-81ED-4DB2-BD59-A6C34878D82A}">
+                    <a16:rowId xmlns:a16="http://schemas.microsoft.com/office/drawing/2014/main" val="10007"/>
+                  </a:ext>
+                </a:extLst>
               </a:tr>
             </a:tbl>
           </a:graphicData>
@@ -12994,7 +13986,7 @@
 </file>
 
 <file path=ppt/slides/slide8.xml><?xml version="1.0" encoding="utf-8"?>
-<p:sld xmlns:a="http://schemas.openxmlformats.org/drawingml/2006/main" xmlns:p="http://schemas.openxmlformats.org/presentationml/2006/main" xmlns:r="http://schemas.openxmlformats.org/officeDocument/2006/relationships">
+<p:sld xmlns:a="http://schemas.openxmlformats.org/drawingml/2006/main" xmlns:r="http://schemas.openxmlformats.org/officeDocument/2006/relationships" xmlns:p="http://schemas.openxmlformats.org/presentationml/2006/main">
   <p:cSld>
     <p:spTree>
       <p:nvGrpSpPr>
@@ -13002,7 +13994,14 @@
         <p:cNvGrpSpPr/>
         <p:nvPr/>
       </p:nvGrpSpPr>
-      <p:grpSpPr/>
+      <p:grpSpPr>
+        <a:xfrm>
+          <a:off x="0" y="0"/>
+          <a:ext cx="0" cy="0"/>
+          <a:chOff x="0" y="0"/>
+          <a:chExt cx="0" cy="0"/>
+        </a:xfrm>
+      </p:grpSpPr>
       <p:sp>
         <p:nvSpPr>
           <p:cNvPr id="2" name="Rectangle 1"/>
@@ -13043,6 +14042,7 @@
           <a:lstStyle/>
           <a:p>
             <a:pPr algn="ctr"/>
+            <a:endParaRPr/>
           </a:p>
         </p:txBody>
       </p:sp>
@@ -13086,6 +14086,7 @@
           <a:lstStyle/>
           <a:p>
             <a:pPr algn="ctr"/>
+            <a:endParaRPr/>
           </a:p>
         </p:txBody>
       </p:sp>
@@ -13166,6 +14167,7 @@
           <a:lstStyle/>
           <a:p>
             <a:pPr algn="ctr"/>
+            <a:endParaRPr/>
           </a:p>
         </p:txBody>
       </p:sp>
@@ -13322,6 +14324,7 @@
           <a:lstStyle/>
           <a:p>
             <a:pPr algn="ctr"/>
+            <a:endParaRPr/>
           </a:p>
         </p:txBody>
       </p:sp>
@@ -13440,6 +14443,7 @@
           <a:lstStyle/>
           <a:p>
             <a:pPr algn="ctr"/>
+            <a:endParaRPr/>
           </a:p>
         </p:txBody>
       </p:sp>
@@ -13559,6 +14563,24 @@
           </a:p>
         </p:txBody>
       </p:sp>
+      <p:graphicFrame>
+        <p:nvGraphicFramePr>
+          <p:cNvPr id="16" name="Chart 15"/>
+          <p:cNvGraphicFramePr>
+            <a:graphicFrameLocks noGrp="1"/>
+          </p:cNvGraphicFramePr>
+          <p:nvPr/>
+        </p:nvGraphicFramePr>
+        <p:xfrm>
+          <a:off x="8100000" y="1080000"/>
+          <a:ext cx="3960000" cy="3600000"/>
+        </p:xfrm>
+        <a:graphic>
+          <a:graphicData uri="http://schemas.openxmlformats.org/drawingml/2006/chart">
+            <c:chart xmlns:c="http://schemas.openxmlformats.org/drawingml/2006/chart" r:id="rId2"/>
+          </a:graphicData>
+        </a:graphic>
+      </p:graphicFrame>
     </p:spTree>
   </p:cSld>
   <p:clrMapOvr>
@@ -13568,7 +14590,7 @@
 </file>
 
 <file path=ppt/slides/slide9.xml><?xml version="1.0" encoding="utf-8"?>
-<p:sld xmlns:a="http://schemas.openxmlformats.org/drawingml/2006/main" xmlns:p="http://schemas.openxmlformats.org/presentationml/2006/main" xmlns:r="http://schemas.openxmlformats.org/officeDocument/2006/relationships">
+<p:sld xmlns:a="http://schemas.openxmlformats.org/drawingml/2006/main" xmlns:r="http://schemas.openxmlformats.org/officeDocument/2006/relationships" xmlns:p="http://schemas.openxmlformats.org/presentationml/2006/main">
   <p:cSld>
     <p:spTree>
       <p:nvGrpSpPr>
@@ -13576,7 +14598,14 @@
         <p:cNvGrpSpPr/>
         <p:nvPr/>
       </p:nvGrpSpPr>
-      <p:grpSpPr/>
+      <p:grpSpPr>
+        <a:xfrm>
+          <a:off x="0" y="0"/>
+          <a:ext cx="0" cy="0"/>
+          <a:chOff x="0" y="0"/>
+          <a:chExt cx="0" cy="0"/>
+        </a:xfrm>
+      </p:grpSpPr>
       <p:sp>
         <p:nvSpPr>
           <p:cNvPr id="2" name="Rectangle 1"/>
@@ -13617,6 +14646,7 @@
           <a:lstStyle/>
           <a:p>
             <a:pPr algn="ctr"/>
+            <a:endParaRPr/>
           </a:p>
         </p:txBody>
       </p:sp>
@@ -13660,6 +14690,7 @@
           <a:lstStyle/>
           <a:p>
             <a:pPr algn="ctr"/>
+            <a:endParaRPr/>
           </a:p>
         </p:txBody>
       </p:sp>
@@ -13848,7 +14879,7 @@
               </a:spcBef>
             </a:pPr>
             <a:r>
-              <a:rPr b="1" sz="1400">
+              <a:rPr sz="1400" b="1">
                 <a:solidFill>
                   <a:srgbClr val="23613F"/>
                 </a:solidFill>
@@ -13873,7 +14904,7 @@
               </a:spcBef>
             </a:pPr>
             <a:r>
-              <a:rPr b="1" sz="1400">
+              <a:rPr sz="1400" b="1">
                 <a:solidFill>
                   <a:srgbClr val="23613F"/>
                 </a:solidFill>
@@ -13898,7 +14929,7 @@
               </a:spcBef>
             </a:pPr>
             <a:r>
-              <a:rPr b="1" sz="1400">
+              <a:rPr sz="1400" b="1">
                 <a:solidFill>
                   <a:srgbClr val="23613F"/>
                 </a:solidFill>
@@ -13923,7 +14954,7 @@
               </a:spcBef>
             </a:pPr>
             <a:r>
-              <a:rPr b="1" sz="1400">
+              <a:rPr sz="1400" b="1">
                 <a:solidFill>
                   <a:srgbClr val="23613F"/>
                 </a:solidFill>
@@ -13948,7 +14979,7 @@
               </a:spcBef>
             </a:pPr>
             <a:r>
-              <a:rPr b="1" sz="1400">
+              <a:rPr sz="1400" b="1">
                 <a:solidFill>
                   <a:srgbClr val="23613F"/>
                 </a:solidFill>
@@ -14010,6 +15041,7 @@
           <a:lstStyle/>
           <a:p>
             <a:pPr algn="ctr"/>
+            <a:endParaRPr/>
           </a:p>
         </p:txBody>
       </p:sp>
@@ -14088,6 +15120,7 @@
           <a:lstStyle/>
           <a:p>
             <a:pPr algn="ctr"/>
+            <a:endParaRPr/>
           </a:p>
         </p:txBody>
       </p:sp>
@@ -14166,6 +15199,7 @@
           <a:lstStyle/>
           <a:p>
             <a:pPr algn="ctr"/>
+            <a:endParaRPr/>
           </a:p>
         </p:txBody>
       </p:sp>
@@ -14244,6 +15278,7 @@
           <a:lstStyle/>
           <a:p>
             <a:pPr algn="ctr"/>
+            <a:endParaRPr/>
           </a:p>
         </p:txBody>
       </p:sp>
@@ -14322,6 +15357,7 @@
           <a:lstStyle/>
           <a:p>
             <a:pPr algn="ctr"/>
+            <a:endParaRPr/>
           </a:p>
         </p:txBody>
       </p:sp>
@@ -14400,6 +15436,7 @@
           <a:lstStyle/>
           <a:p>
             <a:pPr algn="ctr"/>
+            <a:endParaRPr/>
           </a:p>
         </p:txBody>
       </p:sp>
@@ -14764,4 +15801,265 @@
   </a:objectDefaults>
   <a:extraClrSchemeLst/>
 </a:theme>
+</file>
+
+<file path=ppt/theme/theme2.xml><?xml version="1.0" encoding="utf-8"?>
+<a:theme xmlns:a="http://schemas.openxmlformats.org/drawingml/2006/main" name="Тема Office">
+  <a:themeElements>
+    <a:clrScheme name="Стандартная">
+      <a:dk1>
+        <a:sysClr val="windowText" lastClr="000000"/>
+      </a:dk1>
+      <a:lt1>
+        <a:sysClr val="window" lastClr="FFFFFF"/>
+      </a:lt1>
+      <a:dk2>
+        <a:srgbClr val="44546A"/>
+      </a:dk2>
+      <a:lt2>
+        <a:srgbClr val="E7E6E6"/>
+      </a:lt2>
+      <a:accent1>
+        <a:srgbClr val="5B9BD5"/>
+      </a:accent1>
+      <a:accent2>
+        <a:srgbClr val="ED7D31"/>
+      </a:accent2>
+      <a:accent3>
+        <a:srgbClr val="A5A5A5"/>
+      </a:accent3>
+      <a:accent4>
+        <a:srgbClr val="FFC000"/>
+      </a:accent4>
+      <a:accent5>
+        <a:srgbClr val="4472C4"/>
+      </a:accent5>
+      <a:accent6>
+        <a:srgbClr val="70AD47"/>
+      </a:accent6>
+      <a:hlink>
+        <a:srgbClr val="0563C1"/>
+      </a:hlink>
+      <a:folHlink>
+        <a:srgbClr val="954F72"/>
+      </a:folHlink>
+    </a:clrScheme>
+    <a:fontScheme name="Стандартная">
+      <a:majorFont>
+        <a:latin typeface="Calibri Light" panose="020F0302020204030204"/>
+        <a:ea typeface=""/>
+        <a:cs typeface=""/>
+        <a:font script="Jpan" typeface="游ゴシック Light"/>
+        <a:font script="Hang" typeface="맑은 고딕"/>
+        <a:font script="Hans" typeface="等线 Light"/>
+        <a:font script="Hant" typeface="新細明體"/>
+        <a:font script="Arab" typeface="Times New Roman"/>
+        <a:font script="Hebr" typeface="Times New Roman"/>
+        <a:font script="Thai" typeface="Angsana New"/>
+        <a:font script="Ethi" typeface="Nyala"/>
+        <a:font script="Beng" typeface="Vrinda"/>
+        <a:font script="Gujr" typeface="Shruti"/>
+        <a:font script="Khmr" typeface="MoolBoran"/>
+        <a:font script="Knda" typeface="Tunga"/>
+        <a:font script="Guru" typeface="Raavi"/>
+        <a:font script="Cans" typeface="Euphemia"/>
+        <a:font script="Cher" typeface="Plantagenet Cherokee"/>
+        <a:font script="Yiii" typeface="Microsoft Yi Baiti"/>
+        <a:font script="Tibt" typeface="Microsoft Himalaya"/>
+        <a:font script="Thaa" typeface="MV Boli"/>
+        <a:font script="Deva" typeface="Mangal"/>
+        <a:font script="Telu" typeface="Gautami"/>
+        <a:font script="Taml" typeface="Latha"/>
+        <a:font script="Syrc" typeface="Estrangelo Edessa"/>
+        <a:font script="Orya" typeface="Kalinga"/>
+        <a:font script="Mlym" typeface="Kartika"/>
+        <a:font script="Laoo" typeface="DokChampa"/>
+        <a:font script="Sinh" typeface="Iskoola Pota"/>
+        <a:font script="Mong" typeface="Mongolian Baiti"/>
+        <a:font script="Viet" typeface="Times New Roman"/>
+        <a:font script="Uigh" typeface="Microsoft Uighur"/>
+        <a:font script="Geor" typeface="Sylfaen"/>
+      </a:majorFont>
+      <a:minorFont>
+        <a:latin typeface="Calibri" panose="020F0502020204030204"/>
+        <a:ea typeface=""/>
+        <a:cs typeface=""/>
+        <a:font script="Jpan" typeface="游ゴシック"/>
+        <a:font script="Hang" typeface="맑은 고딕"/>
+        <a:font script="Hans" typeface="等线"/>
+        <a:font script="Hant" typeface="新細明體"/>
+        <a:font script="Arab" typeface="Arial"/>
+        <a:font script="Hebr" typeface="Arial"/>
+        <a:font script="Thai" typeface="Cordia New"/>
+        <a:font script="Ethi" typeface="Nyala"/>
+        <a:font script="Beng" typeface="Vrinda"/>
+        <a:font script="Gujr" typeface="Shruti"/>
+        <a:font script="Khmr" typeface="DaunPenh"/>
+        <a:font script="Knda" typeface="Tunga"/>
+        <a:font script="Guru" typeface="Raavi"/>
+        <a:font script="Cans" typeface="Euphemia"/>
+        <a:font script="Cher" typeface="Plantagenet Cherokee"/>
+        <a:font script="Yiii" typeface="Microsoft Yi Baiti"/>
+        <a:font script="Tibt" typeface="Microsoft Himalaya"/>
+        <a:font script="Thaa" typeface="MV Boli"/>
+        <a:font script="Deva" typeface="Mangal"/>
+        <a:font script="Telu" typeface="Gautami"/>
+        <a:font script="Taml" typeface="Latha"/>
+        <a:font script="Syrc" typeface="Estrangelo Edessa"/>
+        <a:font script="Orya" typeface="Kalinga"/>
+        <a:font script="Mlym" typeface="Kartika"/>
+        <a:font script="Laoo" typeface="DokChampa"/>
+        <a:font script="Sinh" typeface="Iskoola Pota"/>
+        <a:font script="Mong" typeface="Mongolian Baiti"/>
+        <a:font script="Viet" typeface="Arial"/>
+        <a:font script="Uigh" typeface="Microsoft Uighur"/>
+        <a:font script="Geor" typeface="Sylfaen"/>
+      </a:minorFont>
+    </a:fontScheme>
+    <a:fmtScheme name="Стандартная">
+      <a:fillStyleLst>
+        <a:solidFill>
+          <a:schemeClr val="phClr"/>
+        </a:solidFill>
+        <a:gradFill rotWithShape="1">
+          <a:gsLst>
+            <a:gs pos="0">
+              <a:schemeClr val="phClr">
+                <a:lumMod val="110000"/>
+                <a:satMod val="105000"/>
+                <a:tint val="67000"/>
+              </a:schemeClr>
+            </a:gs>
+            <a:gs pos="50000">
+              <a:schemeClr val="phClr">
+                <a:lumMod val="105000"/>
+                <a:satMod val="103000"/>
+                <a:tint val="73000"/>
+              </a:schemeClr>
+            </a:gs>
+            <a:gs pos="100000">
+              <a:schemeClr val="phClr">
+                <a:lumMod val="105000"/>
+                <a:satMod val="109000"/>
+                <a:tint val="81000"/>
+              </a:schemeClr>
+            </a:gs>
+          </a:gsLst>
+          <a:lin ang="5400000" scaled="0"/>
+        </a:gradFill>
+        <a:gradFill rotWithShape="1">
+          <a:gsLst>
+            <a:gs pos="0">
+              <a:schemeClr val="phClr">
+                <a:satMod val="103000"/>
+                <a:lumMod val="102000"/>
+                <a:tint val="94000"/>
+              </a:schemeClr>
+            </a:gs>
+            <a:gs pos="50000">
+              <a:schemeClr val="phClr">
+                <a:satMod val="110000"/>
+                <a:lumMod val="100000"/>
+                <a:shade val="100000"/>
+              </a:schemeClr>
+            </a:gs>
+            <a:gs pos="100000">
+              <a:schemeClr val="phClr">
+                <a:lumMod val="99000"/>
+                <a:satMod val="120000"/>
+                <a:shade val="78000"/>
+              </a:schemeClr>
+            </a:gs>
+          </a:gsLst>
+          <a:lin ang="5400000" scaled="0"/>
+        </a:gradFill>
+      </a:fillStyleLst>
+      <a:lnStyleLst>
+        <a:ln w="6350" cap="flat" cmpd="sng" algn="ctr">
+          <a:solidFill>
+            <a:schemeClr val="phClr"/>
+          </a:solidFill>
+          <a:prstDash val="solid"/>
+          <a:miter lim="800000"/>
+        </a:ln>
+        <a:ln w="12700" cap="flat" cmpd="sng" algn="ctr">
+          <a:solidFill>
+            <a:schemeClr val="phClr"/>
+          </a:solidFill>
+          <a:prstDash val="solid"/>
+          <a:miter lim="800000"/>
+        </a:ln>
+        <a:ln w="19050" cap="flat" cmpd="sng" algn="ctr">
+          <a:solidFill>
+            <a:schemeClr val="phClr"/>
+          </a:solidFill>
+          <a:prstDash val="solid"/>
+          <a:miter lim="800000"/>
+        </a:ln>
+      </a:lnStyleLst>
+      <a:effectStyleLst>
+        <a:effectStyle>
+          <a:effectLst/>
+        </a:effectStyle>
+        <a:effectStyle>
+          <a:effectLst/>
+        </a:effectStyle>
+        <a:effectStyle>
+          <a:effectLst>
+            <a:outerShdw blurRad="57150" dist="19050" dir="5400000" algn="ctr" rotWithShape="0">
+              <a:srgbClr val="000000">
+                <a:alpha val="63000"/>
+              </a:srgbClr>
+            </a:outerShdw>
+          </a:effectLst>
+        </a:effectStyle>
+      </a:effectStyleLst>
+      <a:bgFillStyleLst>
+        <a:solidFill>
+          <a:schemeClr val="phClr"/>
+        </a:solidFill>
+        <a:solidFill>
+          <a:schemeClr val="phClr">
+            <a:tint val="95000"/>
+            <a:satMod val="170000"/>
+          </a:schemeClr>
+        </a:solidFill>
+        <a:gradFill rotWithShape="1">
+          <a:gsLst>
+            <a:gs pos="0">
+              <a:schemeClr val="phClr">
+                <a:tint val="93000"/>
+                <a:satMod val="150000"/>
+                <a:shade val="98000"/>
+                <a:lumMod val="102000"/>
+              </a:schemeClr>
+            </a:gs>
+            <a:gs pos="50000">
+              <a:schemeClr val="phClr">
+                <a:tint val="98000"/>
+                <a:satMod val="130000"/>
+                <a:shade val="90000"/>
+                <a:lumMod val="103000"/>
+              </a:schemeClr>
+            </a:gs>
+            <a:gs pos="100000">
+              <a:schemeClr val="phClr">
+                <a:shade val="63000"/>
+                <a:satMod val="120000"/>
+              </a:schemeClr>
+            </a:gs>
+          </a:gsLst>
+          <a:lin ang="5400000" scaled="0"/>
+        </a:gradFill>
+      </a:bgFillStyleLst>
+    </a:fmtScheme>
+  </a:themeElements>
+  <a:objectDefaults/>
+  <a:extraClrSchemeLst/>
+  <a:extLst>
+    <a:ext uri="{05A4C25C-085E-4340-85A3-A5531E510DB2}">
+      <thm15:themeFamily xmlns:thm15="http://schemas.microsoft.com/office/thememl/2012/main" name="Office Theme" id="{62F939B6-93AF-4DB8-9C6B-D6C7DFDC589F}" vid="{4A3C46E8-61CC-4603-A589-7422A47A8E4A}"/>
+    </a:ext>
+  </a:extLst>
+</a:theme>
 </file>
</xml_diff>

<commit_message>
fix(presentation): remove charts from slides 2 and 8 — no free space, overlapped text
</commit_message>
<xml_diff>
--- a/docs/Визуализация науки на основе метаданных публикаций и журналов.pptx
+++ b/docs/Визуализация науки на основе метаданных публикаций и журналов.pptx
@@ -7815,24 +7815,6 @@
           </a:p>
         </p:txBody>
       </p:sp>
-      <p:graphicFrame>
-        <p:nvGraphicFramePr>
-          <p:cNvPr id="19" name="Chart 18"/>
-          <p:cNvGraphicFramePr>
-            <a:graphicFrameLocks noGrp="1"/>
-          </p:cNvGraphicFramePr>
-          <p:nvPr/>
-        </p:nvGraphicFramePr>
-        <p:xfrm>
-          <a:off x="180000" y="2700000"/>
-          <a:ext cx="11880000" cy="3960000"/>
-        </p:xfrm>
-        <a:graphic>
-          <a:graphicData uri="http://schemas.openxmlformats.org/drawingml/2006/chart">
-            <c:chart xmlns:c="http://schemas.openxmlformats.org/drawingml/2006/chart" r:id="rId2"/>
-          </a:graphicData>
-        </a:graphic>
-      </p:graphicFrame>
     </p:spTree>
   </p:cSld>
   <p:clrMapOvr>
@@ -14563,24 +14545,6 @@
           </a:p>
         </p:txBody>
       </p:sp>
-      <p:graphicFrame>
-        <p:nvGraphicFramePr>
-          <p:cNvPr id="16" name="Chart 15"/>
-          <p:cNvGraphicFramePr>
-            <a:graphicFrameLocks noGrp="1"/>
-          </p:cNvGraphicFramePr>
-          <p:nvPr/>
-        </p:nvGraphicFramePr>
-        <p:xfrm>
-          <a:off x="8100000" y="1080000"/>
-          <a:ext cx="3960000" cy="3600000"/>
-        </p:xfrm>
-        <a:graphic>
-          <a:graphicData uri="http://schemas.openxmlformats.org/drawingml/2006/chart">
-            <c:chart xmlns:c="http://schemas.openxmlformats.org/drawingml/2006/chart" r:id="rId2"/>
-          </a:graphicData>
-        </a:graphic>
-      </p:graphicFrame>
     </p:spTree>
   </p:cSld>
   <p:clrMapOvr>

</xml_diff>

<commit_message>
feat(presentation): add slide 3 with publication dynamics chart
New slide inserted after Актуальность: столбчатый график
публикационной активности по годам 2000–2024 (реальные данные,
n=488 публикаций с годом). Занимает весь слайд без перекрытия текста.

https://claude.ai/code/session_01JXZNXE9oVEv7rsUiTvXR5D
</commit_message>
<xml_diff>
--- a/docs/Визуализация науки на основе метаданных публикаций и журналов.pptx
+++ b/docs/Визуализация науки на основе метаданных публикаций и журналов.pptx
@@ -10,6 +10,7 @@
   <p:sldIdLst>
     <p:sldId id="256" r:id="rId2"/>
     <p:sldId id="258" r:id="rId3"/>
+    <p:sldId id="270" r:id="rId20"/>
     <p:sldId id="257" r:id="rId4"/>
     <p:sldId id="269" r:id="rId5"/>
     <p:sldId id="268" r:id="rId6"/>
@@ -1013,6 +1014,253 @@
 </c:chartSpace>
 </file>
 
+<file path=ppt/charts/chart5.xml><?xml version="1.0" encoding="utf-8"?>
+<c:chartSpace xmlns:c="http://schemas.openxmlformats.org/drawingml/2006/chart" xmlns:a="http://schemas.openxmlformats.org/drawingml/2006/main" xmlns:r="http://schemas.openxmlformats.org/officeDocument/2006/relationships">
+  <c:date1904 val="0"/>
+  <c:chart>
+    <c:autoTitleDeleted val="1"/>
+    <c:plotArea>
+      <c:barChart>
+        <c:barDir val="col"/>
+        <c:grouping val="clustered"/>
+        <c:ser>
+          <c:idx val="0"/>
+          <c:order val="0"/>
+          <c:tx>
+            <c:strRef>
+              <c:f>Sheet1!$B$1</c:f>
+              <c:strCache>
+                <c:ptCount val="1"/>
+                <c:pt idx="0">
+                  <c:v>Публикаций</c:v>
+                </c:pt>
+              </c:strCache>
+            </c:strRef>
+          </c:tx>
+          <c:spPr>
+            <a:solidFill>
+              <a:srgbClr val="276FBF"/>
+            </a:solidFill>
+          </c:spPr>
+          <c:cat>
+            <c:strRef>
+              <c:f>Sheet1!$A$2:$A$26</c:f>
+              <c:strCache>
+                <c:ptCount val="25"/>
+                <c:pt idx="0">
+                  <c:v>2000</c:v>
+                </c:pt>
+                <c:pt idx="1">
+                  <c:v>2001</c:v>
+                </c:pt>
+                <c:pt idx="2">
+                  <c:v>2002</c:v>
+                </c:pt>
+                <c:pt idx="3">
+                  <c:v>2003</c:v>
+                </c:pt>
+                <c:pt idx="4">
+                  <c:v>2004</c:v>
+                </c:pt>
+                <c:pt idx="5">
+                  <c:v>2005</c:v>
+                </c:pt>
+                <c:pt idx="6">
+                  <c:v>2006</c:v>
+                </c:pt>
+                <c:pt idx="7">
+                  <c:v>2007</c:v>
+                </c:pt>
+                <c:pt idx="8">
+                  <c:v>2008</c:v>
+                </c:pt>
+                <c:pt idx="9">
+                  <c:v>2009</c:v>
+                </c:pt>
+                <c:pt idx="10">
+                  <c:v>2010</c:v>
+                </c:pt>
+                <c:pt idx="11">
+                  <c:v>2011</c:v>
+                </c:pt>
+                <c:pt idx="12">
+                  <c:v>2012</c:v>
+                </c:pt>
+                <c:pt idx="13">
+                  <c:v>2013</c:v>
+                </c:pt>
+                <c:pt idx="14">
+                  <c:v>2014</c:v>
+                </c:pt>
+                <c:pt idx="15">
+                  <c:v>2015</c:v>
+                </c:pt>
+                <c:pt idx="16">
+                  <c:v>2016</c:v>
+                </c:pt>
+                <c:pt idx="17">
+                  <c:v>2017</c:v>
+                </c:pt>
+                <c:pt idx="18">
+                  <c:v>2018</c:v>
+                </c:pt>
+                <c:pt idx="19">
+                  <c:v>2019</c:v>
+                </c:pt>
+                <c:pt idx="20">
+                  <c:v>2020</c:v>
+                </c:pt>
+                <c:pt idx="21">
+                  <c:v>2021</c:v>
+                </c:pt>
+                <c:pt idx="22">
+                  <c:v>2022</c:v>
+                </c:pt>
+                <c:pt idx="23">
+                  <c:v>2023</c:v>
+                </c:pt>
+                <c:pt idx="24">
+                  <c:v>2024</c:v>
+                </c:pt>
+              </c:strCache>
+            </c:strRef>
+          </c:cat>
+          <c:val>
+            <c:numRef>
+              <c:f>Sheet1!$B$2:$B$26</c:f>
+              <c:numCache>
+                <c:formatCode>General</c:formatCode>
+                <c:ptCount val="25"/>
+                <c:pt idx="0">
+                  <c:v>25</c:v>
+                </c:pt>
+                <c:pt idx="1">
+                  <c:v>21</c:v>
+                </c:pt>
+                <c:pt idx="2">
+                  <c:v>18</c:v>
+                </c:pt>
+                <c:pt idx="3">
+                  <c:v>16</c:v>
+                </c:pt>
+                <c:pt idx="4">
+                  <c:v>16</c:v>
+                </c:pt>
+                <c:pt idx="5">
+                  <c:v>28</c:v>
+                </c:pt>
+                <c:pt idx="6">
+                  <c:v>13</c:v>
+                </c:pt>
+                <c:pt idx="7">
+                  <c:v>30</c:v>
+                </c:pt>
+                <c:pt idx="8">
+                  <c:v>21</c:v>
+                </c:pt>
+                <c:pt idx="9">
+                  <c:v>39</c:v>
+                </c:pt>
+                <c:pt idx="10">
+                  <c:v>19</c:v>
+                </c:pt>
+                <c:pt idx="11">
+                  <c:v>23</c:v>
+                </c:pt>
+                <c:pt idx="12">
+                  <c:v>23</c:v>
+                </c:pt>
+                <c:pt idx="13">
+                  <c:v>17</c:v>
+                </c:pt>
+                <c:pt idx="14">
+                  <c:v>23</c:v>
+                </c:pt>
+                <c:pt idx="15">
+                  <c:v>25</c:v>
+                </c:pt>
+                <c:pt idx="16">
+                  <c:v>22</c:v>
+                </c:pt>
+                <c:pt idx="17">
+                  <c:v>25</c:v>
+                </c:pt>
+                <c:pt idx="18">
+                  <c:v>16</c:v>
+                </c:pt>
+                <c:pt idx="19">
+                  <c:v>11</c:v>
+                </c:pt>
+                <c:pt idx="20">
+                  <c:v>21</c:v>
+                </c:pt>
+                <c:pt idx="21">
+                  <c:v>7</c:v>
+                </c:pt>
+                <c:pt idx="22">
+                  <c:v>3</c:v>
+                </c:pt>
+                <c:pt idx="23">
+                  <c:v>4</c:v>
+                </c:pt>
+                <c:pt idx="24">
+                  <c:v>2</c:v>
+                </c:pt>
+              </c:numCache>
+            </c:numRef>
+          </c:val>
+        </c:ser>
+        <c:axId val="-2068027336"/>
+        <c:axId val="-2113994440"/>
+      </c:barChart>
+      <c:catAx>
+        <c:axId val="-2068027336"/>
+        <c:scaling>
+          <c:orientation val="minMax"/>
+        </c:scaling>
+        <c:delete val="0"/>
+        <c:axPos val="b"/>
+        <c:majorTickMark val="out"/>
+        <c:minorTickMark val="none"/>
+        <c:tickLblPos val="nextTo"/>
+        <c:crossAx val="-2113994440"/>
+        <c:crosses val="autoZero"/>
+        <c:auto val="1"/>
+        <c:lblAlgn val="ctr"/>
+        <c:lblOffset val="100"/>
+        <c:noMultiLvlLbl val="0"/>
+      </c:catAx>
+      <c:valAx>
+        <c:axId val="-2113994440"/>
+        <c:scaling/>
+        <c:delete val="0"/>
+        <c:axPos val="l"/>
+        <c:majorGridlines/>
+        <c:majorTickMark val="out"/>
+        <c:minorTickMark val="none"/>
+        <c:tickLblPos val="nextTo"/>
+        <c:crossAx val="-2068027336"/>
+        <c:crosses val="autoZero"/>
+      </c:valAx>
+    </c:plotArea>
+    <c:dispBlanksAs val="gap"/>
+  </c:chart>
+  <c:txPr>
+    <a:bodyPr/>
+    <a:lstStyle/>
+    <a:p>
+      <a:pPr>
+        <a:defRPr sz="1800"/>
+      </a:pPr>
+      <a:endParaRPr lang="en-US"/>
+    </a:p>
+  </c:txPr>
+  <c:externalData r:id="rId1">
+    <c:autoUpdate val="0"/>
+  </c:externalData>
+</c:chartSpace>
+</file>
+
 <file path=ppt/notesMasters/notesMaster1.xml><?xml version="1.0" encoding="utf-8"?>
 <p:notesMaster xmlns:a="http://schemas.openxmlformats.org/drawingml/2006/main" xmlns:r="http://schemas.openxmlformats.org/officeDocument/2006/relationships" xmlns:p="http://schemas.openxmlformats.org/presentationml/2006/main">
   <p:cSld>
@@ -7127,6 +7375,163 @@
           </a:p>
         </p:txBody>
       </p:sp>
+    </p:spTree>
+  </p:cSld>
+  <p:clrMapOvr>
+    <a:masterClrMapping/>
+  </p:clrMapOvr>
+</p:sld>
+</file>
+
+<file path=ppt/slides/slide14.xml><?xml version="1.0" encoding="utf-8"?>
+<p:sld xmlns:a="http://schemas.openxmlformats.org/drawingml/2006/main" xmlns:p="http://schemas.openxmlformats.org/presentationml/2006/main" xmlns:r="http://schemas.openxmlformats.org/officeDocument/2006/relationships">
+  <p:cSld>
+    <p:spTree>
+      <p:nvGrpSpPr>
+        <p:cNvPr id="1" name=""/>
+        <p:cNvGrpSpPr/>
+        <p:nvPr/>
+      </p:nvGrpSpPr>
+      <p:grpSpPr/>
+      <p:sp>
+        <p:nvSpPr>
+          <p:cNvPr id="2" name="Rectangle 1"/>
+          <p:cNvSpPr/>
+          <p:nvPr/>
+        </p:nvSpPr>
+        <p:spPr>
+          <a:xfrm>
+            <a:off x="0" y="0"/>
+            <a:ext cx="12188952" cy="6858000"/>
+          </a:xfrm>
+          <a:prstGeom prst="rect">
+            <a:avLst/>
+          </a:prstGeom>
+          <a:solidFill>
+            <a:srgbClr val="F7FBF8"/>
+          </a:solidFill>
+          <a:ln>
+            <a:noFill/>
+          </a:ln>
+        </p:spPr>
+        <p:style>
+          <a:lnRef idx="1">
+            <a:schemeClr val="accent1"/>
+          </a:lnRef>
+          <a:fillRef idx="3">
+            <a:schemeClr val="accent1"/>
+          </a:fillRef>
+          <a:effectRef idx="2">
+            <a:schemeClr val="accent1"/>
+          </a:effectRef>
+          <a:fontRef idx="minor">
+            <a:schemeClr val="lt1"/>
+          </a:fontRef>
+        </p:style>
+        <p:txBody>
+          <a:bodyPr rtlCol="0" anchor="ctr"/>
+          <a:lstStyle/>
+          <a:p>
+            <a:pPr algn="ctr"/>
+            <a:endParaRPr/>
+          </a:p>
+        </p:txBody>
+      </p:sp>
+      <p:sp>
+        <p:nvSpPr>
+          <p:cNvPr id="3" name="Rectangle 2"/>
+          <p:cNvSpPr/>
+          <p:nvPr/>
+        </p:nvSpPr>
+        <p:spPr>
+          <a:xfrm>
+            <a:off x="0" y="0"/>
+            <a:ext cx="12188952" cy="1005840"/>
+          </a:xfrm>
+          <a:prstGeom prst="rect">
+            <a:avLst/>
+          </a:prstGeom>
+          <a:solidFill>
+            <a:srgbClr val="163126"/>
+          </a:solidFill>
+          <a:ln>
+            <a:noFill/>
+          </a:ln>
+        </p:spPr>
+        <p:style>
+          <a:lnRef idx="1">
+            <a:schemeClr val="accent1"/>
+          </a:lnRef>
+          <a:fillRef idx="3">
+            <a:schemeClr val="accent1"/>
+          </a:fillRef>
+          <a:effectRef idx="2">
+            <a:schemeClr val="accent1"/>
+          </a:effectRef>
+          <a:fontRef idx="minor">
+            <a:schemeClr val="lt1"/>
+          </a:fontRef>
+        </p:style>
+        <p:txBody>
+          <a:bodyPr rtlCol="0" anchor="ctr"/>
+          <a:lstStyle/>
+          <a:p>
+            <a:pPr algn="ctr"/>
+            <a:endParaRPr/>
+          </a:p>
+        </p:txBody>
+      </p:sp>
+      <p:sp>
+        <p:nvSpPr>
+          <p:cNvPr id="4" name="TextBox 3"/>
+          <p:cNvSpPr txBox="1"/>
+          <p:nvPr/>
+        </p:nvSpPr>
+        <p:spPr>
+          <a:xfrm>
+            <a:off x="360000" y="180000"/>
+            <a:ext cx="11448000" cy="684000"/>
+          </a:xfrm>
+          <a:prstGeom prst="rect">
+            <a:avLst/>
+          </a:prstGeom>
+          <a:noFill/>
+        </p:spPr>
+        <p:txBody>
+          <a:bodyPr wrap="none">
+            <a:spAutoFit/>
+          </a:bodyPr>
+          <a:lstStyle/>
+          <a:p>
+            <a:r>
+              <a:rPr sz="2200" b="1">
+                <a:solidFill>
+                  <a:srgbClr val="FFFFFF"/>
+                </a:solidFill>
+              </a:rPr>
+              <a:t>Динамика публикационной активности (данные OpenAlex)</a:t>
+            </a:r>
+          </a:p>
+        </p:txBody>
+      </p:sp>
+      <p:graphicFrame>
+        <p:nvGraphicFramePr>
+          <p:cNvPr id="5" name="Chart 4"/>
+          <p:cNvGraphicFramePr>
+            <a:graphicFrameLocks noGrp="1"/>
+          </p:cNvGraphicFramePr>
+          <p:nvPr/>
+        </p:nvGraphicFramePr>
+        <p:xfrm>
+          <a:off x="180000" y="1007999"/>
+          <a:ext cx="11880000" cy="5688000"/>
+        </p:xfrm>
+        <a:graphic>
+          <a:graphicData uri="http://schemas.openxmlformats.org/drawingml/2006/chart">
+            <c:chart xmlns:c="http://schemas.openxmlformats.org/drawingml/2006/chart" r:id="rId2"/>
+          </a:graphicData>
+        </a:graphic>
+      </p:graphicFrame>
     </p:spTree>
   </p:cSld>
   <p:clrMapOvr>

</xml_diff>

<commit_message>
style(presentation): replace plain slide numbers with visual badge
Dark green rounded rectangle with white bold current number
and light green "/ N" total — matches the presentation's color palette.

https://claude.ai/code/session_01JXZNXE9oVEv7rsUiTvXR5D
</commit_message>
<xml_diff>
--- a/docs/Визуализация науки на основе метаданных публикаций и журналов.pptx
+++ b/docs/Визуализация науки на основе метаданных публикаций и журналов.pptx
@@ -4342,28 +4342,46 @@
         </p:nvSpPr>
         <p:spPr>
           <a:xfrm>
-            <a:off x="11288825" y="6498000"/>
-            <a:ext cx="792000" cy="288000"/>
-          </a:xfrm>
-          <a:prstGeom prst="rect">
-            <a:avLst/>
-          </a:prstGeom>
+            <a:off x="11144825" y="6408000"/>
+            <a:ext cx="864000" cy="270000"/>
+          </a:xfrm>
           <a:noFill/>
-        </p:spPr>
-        <p:txBody>
-          <a:bodyPr wrap="none">
+          <a:ln>
+            <a:noFill/>
+          </a:ln>
+          <a:solidFill>
+            <a:srgbClr val="23613F"/>
+          </a:solidFill>
+          <a:prstGeom prst="roundRect">
+            <a:avLst>
+              <a:gd name="adj" fmla="val 30000"/>
+            </a:avLst>
+          </a:prstGeom>
+        </p:spPr>
+        <p:txBody>
+          <a:bodyPr wrap="none" anchor="ctr">
             <a:spAutoFit/>
           </a:bodyPr>
           <a:lstStyle/>
           <a:p>
-            <a:pPr algn="r"/>
-            <a:r>
-              <a:rPr sz="1000">
-                <a:solidFill>
-                  <a:srgbClr val="BBBBBB"/>
-                </a:solidFill>
-              </a:rPr>
-              <a:t>1 / 13</a:t>
+            <a:pPr algn="ctr"/>
+            <a:r>
+              <a:rPr sz="1100" b="1">
+                <a:solidFill>
+                  <a:srgbClr val="FFFFFF"/>
+                </a:solidFill>
+                <a:latin typeface="Arial"/>
+              </a:rPr>
+              <a:t>1</a:t>
+            </a:r>
+            <a:r>
+              <a:rPr sz="1000" b="0">
+                <a:solidFill>
+                  <a:srgbClr val="CFE0D6"/>
+                </a:solidFill>
+                <a:latin typeface="Arial"/>
+              </a:rPr>
+              <a:t> / 14</a:t>
             </a:r>
           </a:p>
         </p:txBody>
@@ -5264,40 +5282,6 @@
       </p:sp>
       <p:sp>
         <p:nvSpPr>
-          <p:cNvPr id="21" name="TextBox 20"/>
-          <p:cNvSpPr txBox="1"/>
-          <p:nvPr/>
-        </p:nvSpPr>
-        <p:spPr>
-          <a:xfrm>
-            <a:off x="11288825" y="6498000"/>
-            <a:ext cx="792000" cy="288000"/>
-          </a:xfrm>
-          <a:prstGeom prst="rect">
-            <a:avLst/>
-          </a:prstGeom>
-          <a:noFill/>
-        </p:spPr>
-        <p:txBody>
-          <a:bodyPr wrap="none">
-            <a:spAutoFit/>
-          </a:bodyPr>
-          <a:lstStyle/>
-          <a:p>
-            <a:pPr algn="r"/>
-            <a:r>
-              <a:rPr sz="1000">
-                <a:solidFill>
-                  <a:srgbClr val="BBBBBB"/>
-                </a:solidFill>
-              </a:rPr>
-              <a:t>9 / 13</a:t>
-            </a:r>
-          </a:p>
-        </p:txBody>
-      </p:sp>
-      <p:sp>
-        <p:nvSpPr>
           <p:cNvPr id="22" name="TextBox 21"/>
           <p:cNvSpPr txBox="1"/>
           <p:nvPr/>
@@ -5325,6 +5309,58 @@
                 </a:solidFill>
               </a:rPr>
               <a:t>Режим отображения — настройка типов узлов и связей, видимых на графе одновременно. Каждый режим показывает разный «срез» данных: например, режим «Авторы» скрывает годы и журналы и оставляет только связи статья → автор.</a:t>
+            </a:r>
+          </a:p>
+        </p:txBody>
+      </p:sp>
+      <p:sp>
+        <p:nvSpPr>
+          <p:cNvPr id="23" name="TextBox 22"/>
+          <p:cNvSpPr txBox="1"/>
+          <p:nvPr/>
+        </p:nvSpPr>
+        <p:spPr>
+          <a:xfrm>
+            <a:off x="11144825" y="6408000"/>
+            <a:ext cx="864000" cy="270000"/>
+          </a:xfrm>
+          <a:noFill/>
+          <a:ln>
+            <a:noFill/>
+          </a:ln>
+          <a:solidFill>
+            <a:srgbClr val="23613F"/>
+          </a:solidFill>
+          <a:prstGeom prst="roundRect">
+            <a:avLst>
+              <a:gd name="adj" fmla="val 30000"/>
+            </a:avLst>
+          </a:prstGeom>
+        </p:spPr>
+        <p:txBody>
+          <a:bodyPr wrap="none" anchor="ctr">
+            <a:spAutoFit/>
+          </a:bodyPr>
+          <a:lstStyle/>
+          <a:p>
+            <a:pPr algn="ctr"/>
+            <a:r>
+              <a:rPr sz="1100" b="1">
+                <a:solidFill>
+                  <a:srgbClr val="FFFFFF"/>
+                </a:solidFill>
+                <a:latin typeface="Arial"/>
+              </a:rPr>
+              <a:t>10</a:t>
+            </a:r>
+            <a:r>
+              <a:rPr sz="1000" b="0">
+                <a:solidFill>
+                  <a:srgbClr val="CFE0D6"/>
+                </a:solidFill>
+                <a:latin typeface="Arial"/>
+              </a:rPr>
+              <a:t> / 14</a:t>
             </a:r>
           </a:p>
         </p:txBody>
@@ -5863,28 +5899,46 @@
         </p:nvSpPr>
         <p:spPr>
           <a:xfrm>
-            <a:off x="11288825" y="6498000"/>
-            <a:ext cx="792000" cy="288000"/>
-          </a:xfrm>
-          <a:prstGeom prst="rect">
-            <a:avLst/>
-          </a:prstGeom>
+            <a:off x="11144825" y="6408000"/>
+            <a:ext cx="864000" cy="270000"/>
+          </a:xfrm>
           <a:noFill/>
-        </p:spPr>
-        <p:txBody>
-          <a:bodyPr wrap="none">
+          <a:ln>
+            <a:noFill/>
+          </a:ln>
+          <a:solidFill>
+            <a:srgbClr val="23613F"/>
+          </a:solidFill>
+          <a:prstGeom prst="roundRect">
+            <a:avLst>
+              <a:gd name="adj" fmla="val 30000"/>
+            </a:avLst>
+          </a:prstGeom>
+        </p:spPr>
+        <p:txBody>
+          <a:bodyPr wrap="none" anchor="ctr">
             <a:spAutoFit/>
           </a:bodyPr>
           <a:lstStyle/>
           <a:p>
-            <a:pPr algn="r"/>
-            <a:r>
-              <a:rPr sz="1000">
-                <a:solidFill>
-                  <a:srgbClr val="BBBBBB"/>
-                </a:solidFill>
-              </a:rPr>
-              <a:t>10 / 13</a:t>
+            <a:pPr algn="ctr"/>
+            <a:r>
+              <a:rPr sz="1100" b="1">
+                <a:solidFill>
+                  <a:srgbClr val="FFFFFF"/>
+                </a:solidFill>
+                <a:latin typeface="Arial"/>
+              </a:rPr>
+              <a:t>11</a:t>
+            </a:r>
+            <a:r>
+              <a:rPr sz="1000" b="0">
+                <a:solidFill>
+                  <a:srgbClr val="CFE0D6"/>
+                </a:solidFill>
+                <a:latin typeface="Arial"/>
+              </a:rPr>
+              <a:t> / 14</a:t>
             </a:r>
           </a:p>
         </p:txBody>
@@ -6605,28 +6659,46 @@
         </p:nvSpPr>
         <p:spPr>
           <a:xfrm>
-            <a:off x="11288825" y="6498000"/>
-            <a:ext cx="792000" cy="288000"/>
-          </a:xfrm>
-          <a:prstGeom prst="rect">
-            <a:avLst/>
-          </a:prstGeom>
+            <a:off x="11144825" y="6408000"/>
+            <a:ext cx="864000" cy="270000"/>
+          </a:xfrm>
           <a:noFill/>
-        </p:spPr>
-        <p:txBody>
-          <a:bodyPr wrap="none">
+          <a:ln>
+            <a:noFill/>
+          </a:ln>
+          <a:solidFill>
+            <a:srgbClr val="23613F"/>
+          </a:solidFill>
+          <a:prstGeom prst="roundRect">
+            <a:avLst>
+              <a:gd name="adj" fmla="val 30000"/>
+            </a:avLst>
+          </a:prstGeom>
+        </p:spPr>
+        <p:txBody>
+          <a:bodyPr wrap="none" anchor="ctr">
             <a:spAutoFit/>
           </a:bodyPr>
           <a:lstStyle/>
           <a:p>
-            <a:pPr algn="r"/>
-            <a:r>
-              <a:rPr sz="1000">
-                <a:solidFill>
-                  <a:srgbClr val="BBBBBB"/>
-                </a:solidFill>
-              </a:rPr>
-              <a:t>11 / 13</a:t>
+            <a:pPr algn="ctr"/>
+            <a:r>
+              <a:rPr sz="1100" b="1">
+                <a:solidFill>
+                  <a:srgbClr val="FFFFFF"/>
+                </a:solidFill>
+                <a:latin typeface="Arial"/>
+              </a:rPr>
+              <a:t>12</a:t>
+            </a:r>
+            <a:r>
+              <a:rPr sz="1000" b="0">
+                <a:solidFill>
+                  <a:srgbClr val="CFE0D6"/>
+                </a:solidFill>
+                <a:latin typeface="Arial"/>
+              </a:rPr>
+              <a:t> / 14</a:t>
             </a:r>
           </a:p>
         </p:txBody>
@@ -6996,28 +7068,46 @@
         </p:nvSpPr>
         <p:spPr>
           <a:xfrm>
-            <a:off x="11288825" y="6498000"/>
-            <a:ext cx="792000" cy="288000"/>
-          </a:xfrm>
-          <a:prstGeom prst="rect">
-            <a:avLst/>
-          </a:prstGeom>
+            <a:off x="11144825" y="6408000"/>
+            <a:ext cx="864000" cy="270000"/>
+          </a:xfrm>
           <a:noFill/>
-        </p:spPr>
-        <p:txBody>
-          <a:bodyPr wrap="none">
+          <a:ln>
+            <a:noFill/>
+          </a:ln>
+          <a:solidFill>
+            <a:srgbClr val="23613F"/>
+          </a:solidFill>
+          <a:prstGeom prst="roundRect">
+            <a:avLst>
+              <a:gd name="adj" fmla="val 30000"/>
+            </a:avLst>
+          </a:prstGeom>
+        </p:spPr>
+        <p:txBody>
+          <a:bodyPr wrap="none" anchor="ctr">
             <a:spAutoFit/>
           </a:bodyPr>
           <a:lstStyle/>
           <a:p>
-            <a:pPr algn="r"/>
-            <a:r>
-              <a:rPr sz="1000">
-                <a:solidFill>
-                  <a:srgbClr val="BBBBBB"/>
-                </a:solidFill>
-              </a:rPr>
-              <a:t>12 / 13</a:t>
+            <a:pPr algn="ctr"/>
+            <a:r>
+              <a:rPr sz="1100" b="1">
+                <a:solidFill>
+                  <a:srgbClr val="FFFFFF"/>
+                </a:solidFill>
+                <a:latin typeface="Arial"/>
+              </a:rPr>
+              <a:t>13</a:t>
+            </a:r>
+            <a:r>
+              <a:rPr sz="1000" b="0">
+                <a:solidFill>
+                  <a:srgbClr val="CFE0D6"/>
+                </a:solidFill>
+                <a:latin typeface="Arial"/>
+              </a:rPr>
+              <a:t> / 14</a:t>
             </a:r>
           </a:p>
         </p:txBody>
@@ -8204,1184 +8294,54 @@
           </a:p>
         </p:txBody>
       </p:sp>
-    </p:spTree>
-  </p:cSld>
-  <p:clrMapOvr>
-    <a:masterClrMapping/>
-  </p:clrMapOvr>
-</p:sld>
-</file>
-
-<file path=ppt/slides/slide14.xml><?xml version="1.0" encoding="utf-8"?>
-<p:sld xmlns:a="http://schemas.openxmlformats.org/drawingml/2006/main" xmlns:p="http://schemas.openxmlformats.org/presentationml/2006/main" xmlns:r="http://schemas.openxmlformats.org/officeDocument/2006/relationships">
-  <p:cSld>
-    <p:spTree>
-      <p:nvGrpSpPr>
-        <p:cNvPr id="1" name=""/>
-        <p:cNvGrpSpPr/>
-        <p:nvPr/>
-      </p:nvGrpSpPr>
-      <p:grpSpPr/>
-      <p:sp>
-        <p:nvSpPr>
-          <p:cNvPr id="2" name="Rectangle 1"/>
-          <p:cNvSpPr/>
-          <p:nvPr/>
-        </p:nvSpPr>
-        <p:spPr>
-          <a:xfrm>
-            <a:off x="0" y="0"/>
-            <a:ext cx="12188952" cy="6858000"/>
-          </a:xfrm>
-          <a:prstGeom prst="rect">
-            <a:avLst/>
-          </a:prstGeom>
-          <a:solidFill>
-            <a:srgbClr val="F7FBF8"/>
-          </a:solidFill>
+      <p:sp>
+        <p:nvSpPr>
+          <p:cNvPr id="30" name="TextBox 29"/>
+          <p:cNvSpPr txBox="1"/>
+          <p:nvPr/>
+        </p:nvSpPr>
+        <p:spPr>
+          <a:xfrm>
+            <a:off x="11144825" y="6408000"/>
+            <a:ext cx="864000" cy="270000"/>
+          </a:xfrm>
+          <a:noFill/>
           <a:ln>
             <a:noFill/>
           </a:ln>
-        </p:spPr>
-        <p:style>
-          <a:lnRef idx="1">
-            <a:schemeClr val="accent1"/>
-          </a:lnRef>
-          <a:fillRef idx="3">
-            <a:schemeClr val="accent1"/>
-          </a:fillRef>
-          <a:effectRef idx="2">
-            <a:schemeClr val="accent1"/>
-          </a:effectRef>
-          <a:fontRef idx="minor">
-            <a:schemeClr val="lt1"/>
-          </a:fontRef>
-        </p:style>
-        <p:txBody>
-          <a:bodyPr rtlCol="0" anchor="ctr"/>
-          <a:lstStyle/>
-          <a:p>
-            <a:pPr algn="ctr"/>
-            <a:endParaRPr/>
-          </a:p>
-        </p:txBody>
-      </p:sp>
-      <p:sp>
-        <p:nvSpPr>
-          <p:cNvPr id="3" name="Rectangle 2"/>
-          <p:cNvSpPr/>
-          <p:nvPr/>
-        </p:nvSpPr>
-        <p:spPr>
-          <a:xfrm>
-            <a:off x="0" y="0"/>
-            <a:ext cx="12188952" cy="1005840"/>
-          </a:xfrm>
-          <a:prstGeom prst="rect">
-            <a:avLst/>
-          </a:prstGeom>
           <a:solidFill>
-            <a:srgbClr val="163126"/>
+            <a:srgbClr val="23613F"/>
           </a:solidFill>
-          <a:ln>
-            <a:noFill/>
-          </a:ln>
-        </p:spPr>
-        <p:style>
-          <a:lnRef idx="1">
-            <a:schemeClr val="accent1"/>
-          </a:lnRef>
-          <a:fillRef idx="3">
-            <a:schemeClr val="accent1"/>
-          </a:fillRef>
-          <a:effectRef idx="2">
-            <a:schemeClr val="accent1"/>
-          </a:effectRef>
-          <a:fontRef idx="minor">
-            <a:schemeClr val="lt1"/>
-          </a:fontRef>
-        </p:style>
-        <p:txBody>
-          <a:bodyPr rtlCol="0" anchor="ctr"/>
-          <a:lstStyle/>
-          <a:p>
-            <a:pPr algn="ctr"/>
-            <a:endParaRPr/>
-          </a:p>
-        </p:txBody>
-      </p:sp>
-      <p:sp>
-        <p:nvSpPr>
-          <p:cNvPr id="4" name="TextBox 3"/>
-          <p:cNvSpPr txBox="1"/>
-          <p:nvPr/>
-        </p:nvSpPr>
-        <p:spPr>
-          <a:xfrm>
-            <a:off x="360000" y="180000"/>
-            <a:ext cx="11448000" cy="684000"/>
-          </a:xfrm>
-          <a:prstGeom prst="rect">
-            <a:avLst/>
-          </a:prstGeom>
-          <a:noFill/>
-        </p:spPr>
-        <p:txBody>
-          <a:bodyPr wrap="none">
+          <a:prstGeom prst="roundRect">
+            <a:avLst>
+              <a:gd name="adj" fmla="val 30000"/>
+            </a:avLst>
+          </a:prstGeom>
+        </p:spPr>
+        <p:txBody>
+          <a:bodyPr wrap="none" anchor="ctr">
             <a:spAutoFit/>
           </a:bodyPr>
           <a:lstStyle/>
           <a:p>
-            <a:r>
-              <a:rPr sz="2200" b="1">
+            <a:pPr algn="ctr"/>
+            <a:r>
+              <a:rPr sz="1100" b="1">
                 <a:solidFill>
                   <a:srgbClr val="FFFFFF"/>
                 </a:solidFill>
-              </a:rPr>
-              <a:t>База данных — схема связей (ER-диаграмма)</a:t>
-            </a:r>
-          </a:p>
-        </p:txBody>
-      </p:sp>
-      <p:sp>
-        <p:nvSpPr>
-          <p:cNvPr id="5" name="TextBox 4"/>
-          <p:cNvSpPr txBox="1"/>
-          <p:nvPr/>
-        </p:nvSpPr>
-        <p:spPr>
-          <a:xfrm>
-            <a:off x="4860000" y="1080000"/>
-            <a:ext cx="2232000" cy="288000"/>
-          </a:xfrm>
-          <a:prstGeom prst="rect">
-            <a:avLst/>
-          </a:prstGeom>
-          <a:noFill/>
-          <a:solidFill>
-            <a:srgbClr val="1A5276"/>
-          </a:solidFill>
-        </p:spPr>
-        <p:txBody>
-          <a:bodyPr wrap="none">
-            <a:spAutoFit/>
-          </a:bodyPr>
-          <a:lstStyle/>
-          <a:p>
-            <a:pPr algn="ctr"/>
-            <a:r>
-              <a:rPr sz="1100" b="1">
-                <a:solidFill>
-                  <a:srgbClr val="FFFFFF"/>
-                </a:solidFill>
-              </a:rPr>
-              <a:t>journals</a:t>
-            </a:r>
-          </a:p>
-        </p:txBody>
-      </p:sp>
-      <p:sp>
-        <p:nvSpPr>
-          <p:cNvPr id="6" name="TextBox 5"/>
-          <p:cNvSpPr txBox="1"/>
-          <p:nvPr/>
-        </p:nvSpPr>
-        <p:spPr>
-          <a:xfrm>
-            <a:off x="4860000" y="1386000"/>
-            <a:ext cx="2232000" cy="846000"/>
-          </a:xfrm>
-          <a:prstGeom prst="rect">
-            <a:avLst/>
-          </a:prstGeom>
-          <a:noFill/>
-          <a:ln w="12700">
-            <a:solidFill>
-              <a:srgbClr val="1A5276"/>
-            </a:solidFill>
-          </a:ln>
-          <a:solidFill>
-            <a:srgbClr val="F0F4F8"/>
-          </a:solidFill>
-        </p:spPr>
-        <p:txBody>
-          <a:bodyPr wrap="square">
-            <a:spAutoFit/>
-          </a:bodyPr>
-          <a:lstStyle/>
-          <a:p>
-            <a:pPr algn="l"/>
-            <a:r>
-              <a:rPr sz="900">
-                <a:solidFill>
-                  <a:srgbClr val="222222"/>
-                </a:solidFill>
-              </a:rPr>
-              <a:t>openalex_id</a:t>
-            </a:r>
-          </a:p>
-          <a:p>
-            <a:pPr algn="l"/>
-            <a:r>
-              <a:rPr sz="900">
-                <a:solidFill>
-                  <a:srgbClr val="222222"/>
-                </a:solidFill>
-              </a:rPr>
-              <a:t>name</a:t>
-            </a:r>
-          </a:p>
-          <a:p>
-            <a:pPr algn="l"/>
-            <a:r>
-              <a:rPr sz="900">
-                <a:solidFill>
-                  <a:srgbClr val="222222"/>
-                </a:solidFill>
-              </a:rPr>
-              <a:t>issn</a:t>
-            </a:r>
-          </a:p>
-        </p:txBody>
-      </p:sp>
-      <p:sp>
-        <p:nvSpPr>
-          <p:cNvPr id="7" name="TextBox 6"/>
-          <p:cNvSpPr txBox="1"/>
-          <p:nvPr/>
-        </p:nvSpPr>
-        <p:spPr>
-          <a:xfrm>
-            <a:off x="4860000" y="2700000"/>
-            <a:ext cx="2232000" cy="288000"/>
-          </a:xfrm>
-          <a:prstGeom prst="rect">
-            <a:avLst/>
-          </a:prstGeom>
-          <a:noFill/>
-          <a:solidFill>
-            <a:srgbClr val="154360"/>
-          </a:solidFill>
-        </p:spPr>
-        <p:txBody>
-          <a:bodyPr wrap="none">
-            <a:spAutoFit/>
-          </a:bodyPr>
-          <a:lstStyle/>
-          <a:p>
-            <a:pPr algn="ctr"/>
-            <a:r>
-              <a:rPr sz="1100" b="1">
-                <a:solidFill>
-                  <a:srgbClr val="FFFFFF"/>
-                </a:solidFill>
-              </a:rPr>
-              <a:t>publications</a:t>
-            </a:r>
-          </a:p>
-        </p:txBody>
-      </p:sp>
-      <p:sp>
-        <p:nvSpPr>
-          <p:cNvPr id="8" name="TextBox 7"/>
-          <p:cNvSpPr txBox="1"/>
-          <p:nvPr/>
-        </p:nvSpPr>
-        <p:spPr>
-          <a:xfrm>
-            <a:off x="4860000" y="3006000"/>
-            <a:ext cx="2232000" cy="846000"/>
-          </a:xfrm>
-          <a:prstGeom prst="rect">
-            <a:avLst/>
-          </a:prstGeom>
-          <a:noFill/>
-          <a:ln w="12700">
-            <a:solidFill>
-              <a:srgbClr val="154360"/>
-            </a:solidFill>
-          </a:ln>
-          <a:solidFill>
-            <a:srgbClr val="F0F4F8"/>
-          </a:solidFill>
-        </p:spPr>
-        <p:txBody>
-          <a:bodyPr wrap="square">
-            <a:spAutoFit/>
-          </a:bodyPr>
-          <a:lstStyle/>
-          <a:p>
-            <a:pPr algn="l"/>
-            <a:r>
-              <a:rPr sz="900">
-                <a:solidFill>
-                  <a:srgbClr val="222222"/>
-                </a:solidFill>
-              </a:rPr>
-              <a:t>id  title  doi</a:t>
-            </a:r>
-          </a:p>
-          <a:p>
-            <a:pPr algn="l"/>
-            <a:r>
-              <a:rPr sz="900">
-                <a:solidFill>
-                  <a:srgbClr val="222222"/>
-                </a:solidFill>
-              </a:rPr>
-              <a:t>year  abstract</a:t>
-            </a:r>
-          </a:p>
-          <a:p>
-            <a:pPr algn="l"/>
-            <a:r>
-              <a:rPr sz="900">
-                <a:solidFill>
-                  <a:srgbClr val="222222"/>
-                </a:solidFill>
-              </a:rPr>
-              <a:t>journal_id →</a:t>
-            </a:r>
-          </a:p>
-        </p:txBody>
-      </p:sp>
-      <p:sp>
-        <p:nvSpPr>
-          <p:cNvPr id="9" name="TextBox 8"/>
-          <p:cNvSpPr txBox="1"/>
-          <p:nvPr/>
-        </p:nvSpPr>
-        <p:spPr>
-          <a:xfrm>
-            <a:off x="7920000" y="2700000"/>
-            <a:ext cx="2232000" cy="288000"/>
-          </a:xfrm>
-          <a:prstGeom prst="rect">
-            <a:avLst/>
-          </a:prstGeom>
-          <a:noFill/>
-          <a:solidFill>
-            <a:srgbClr val="1A5C3A"/>
-          </a:solidFill>
-        </p:spPr>
-        <p:txBody>
-          <a:bodyPr wrap="none">
-            <a:spAutoFit/>
-          </a:bodyPr>
-          <a:lstStyle/>
-          <a:p>
-            <a:pPr algn="ctr"/>
-            <a:r>
-              <a:rPr sz="1100" b="1">
-                <a:solidFill>
-                  <a:srgbClr val="FFFFFF"/>
-                </a:solidFill>
-              </a:rPr>
-              <a:t>publication_authors</a:t>
-            </a:r>
-          </a:p>
-        </p:txBody>
-      </p:sp>
-      <p:sp>
-        <p:nvSpPr>
-          <p:cNvPr id="10" name="TextBox 9"/>
-          <p:cNvSpPr txBox="1"/>
-          <p:nvPr/>
-        </p:nvSpPr>
-        <p:spPr>
-          <a:xfrm>
-            <a:off x="7920000" y="3006000"/>
-            <a:ext cx="2232000" cy="486000"/>
-          </a:xfrm>
-          <a:prstGeom prst="rect">
-            <a:avLst/>
-          </a:prstGeom>
-          <a:noFill/>
-          <a:ln w="12700">
-            <a:solidFill>
-              <a:srgbClr val="1A5C3A"/>
-            </a:solidFill>
-          </a:ln>
-          <a:solidFill>
-            <a:srgbClr val="F0F4F8"/>
-          </a:solidFill>
-        </p:spPr>
-        <p:txBody>
-          <a:bodyPr wrap="square">
-            <a:spAutoFit/>
-          </a:bodyPr>
-          <a:lstStyle/>
-          <a:p>
-            <a:pPr algn="l"/>
-            <a:r>
-              <a:rPr sz="900">
-                <a:solidFill>
-                  <a:srgbClr val="222222"/>
-                </a:solidFill>
-              </a:rPr>
-              <a:t>publication_id →</a:t>
-            </a:r>
-          </a:p>
-          <a:p>
-            <a:pPr algn="l"/>
-            <a:r>
-              <a:rPr sz="900">
-                <a:solidFill>
-                  <a:srgbClr val="222222"/>
-                </a:solidFill>
-              </a:rPr>
-              <a:t>person_id →</a:t>
-            </a:r>
-          </a:p>
-        </p:txBody>
-      </p:sp>
-      <p:sp>
-        <p:nvSpPr>
-          <p:cNvPr id="11" name="TextBox 10"/>
-          <p:cNvSpPr txBox="1"/>
-          <p:nvPr/>
-        </p:nvSpPr>
-        <p:spPr>
-          <a:xfrm>
-            <a:off x="7920000" y="4500000"/>
-            <a:ext cx="2232000" cy="288000"/>
-          </a:xfrm>
-          <a:prstGeom prst="rect">
-            <a:avLst/>
-          </a:prstGeom>
-          <a:noFill/>
-          <a:solidFill>
-            <a:srgbClr val="1A5C3A"/>
-          </a:solidFill>
-        </p:spPr>
-        <p:txBody>
-          <a:bodyPr wrap="none">
-            <a:spAutoFit/>
-          </a:bodyPr>
-          <a:lstStyle/>
-          <a:p>
-            <a:pPr algn="ctr"/>
-            <a:r>
-              <a:rPr sz="1100" b="1">
-                <a:solidFill>
-                  <a:srgbClr val="FFFFFF"/>
-                </a:solidFill>
-              </a:rPr>
-              <a:t>persons</a:t>
-            </a:r>
-          </a:p>
-        </p:txBody>
-      </p:sp>
-      <p:sp>
-        <p:nvSpPr>
-          <p:cNvPr id="12" name="TextBox 11"/>
-          <p:cNvSpPr txBox="1"/>
-          <p:nvPr/>
-        </p:nvSpPr>
-        <p:spPr>
-          <a:xfrm>
-            <a:off x="7920000" y="4806000"/>
-            <a:ext cx="2232000" cy="846000"/>
-          </a:xfrm>
-          <a:prstGeom prst="rect">
-            <a:avLst/>
-          </a:prstGeom>
-          <a:noFill/>
-          <a:ln w="12700">
-            <a:solidFill>
-              <a:srgbClr val="1A5C3A"/>
-            </a:solidFill>
-          </a:ln>
-          <a:solidFill>
-            <a:srgbClr val="F0F4F8"/>
-          </a:solidFill>
-        </p:spPr>
-        <p:txBody>
-          <a:bodyPr wrap="square">
-            <a:spAutoFit/>
-          </a:bodyPr>
-          <a:lstStyle/>
-          <a:p>
-            <a:pPr algn="l"/>
-            <a:r>
-              <a:rPr sz="900">
-                <a:solidFill>
-                  <a:srgbClr val="222222"/>
-                </a:solidFill>
-              </a:rPr>
-              <a:t>openalex_id</a:t>
-            </a:r>
-          </a:p>
-          <a:p>
-            <a:pPr algn="l"/>
-            <a:r>
-              <a:rPr sz="900">
-                <a:solidFill>
-                  <a:srgbClr val="222222"/>
-                </a:solidFill>
-              </a:rPr>
-              <a:t>full_name  orcid</a:t>
-            </a:r>
-          </a:p>
-        </p:txBody>
-      </p:sp>
-      <p:sp>
-        <p:nvSpPr>
-          <p:cNvPr id="13" name="TextBox 12"/>
-          <p:cNvSpPr txBox="1"/>
-          <p:nvPr/>
-        </p:nvSpPr>
-        <p:spPr>
-          <a:xfrm>
-            <a:off x="10260000" y="2700000"/>
-            <a:ext cx="2232000" cy="288000"/>
-          </a:xfrm>
-          <a:prstGeom prst="rect">
-            <a:avLst/>
-          </a:prstGeom>
-          <a:noFill/>
-          <a:solidFill>
-            <a:srgbClr val="7D3C98"/>
-          </a:solidFill>
-        </p:spPr>
-        <p:txBody>
-          <a:bodyPr wrap="none">
-            <a:spAutoFit/>
-          </a:bodyPr>
-          <a:lstStyle/>
-          <a:p>
-            <a:pPr algn="ctr"/>
-            <a:r>
-              <a:rPr sz="1100" b="1">
-                <a:solidFill>
-                  <a:srgbClr val="FFFFFF"/>
-                </a:solidFill>
-              </a:rPr>
-              <a:t>affiliations</a:t>
-            </a:r>
-          </a:p>
-        </p:txBody>
-      </p:sp>
-      <p:sp>
-        <p:nvSpPr>
-          <p:cNvPr id="14" name="TextBox 13"/>
-          <p:cNvSpPr txBox="1"/>
-          <p:nvPr/>
-        </p:nvSpPr>
-        <p:spPr>
-          <a:xfrm>
-            <a:off x="10260000" y="3006000"/>
-            <a:ext cx="2232000" cy="846000"/>
-          </a:xfrm>
-          <a:prstGeom prst="rect">
-            <a:avLst/>
-          </a:prstGeom>
-          <a:noFill/>
-          <a:ln w="12700">
-            <a:solidFill>
-              <a:srgbClr val="7D3C98"/>
-            </a:solidFill>
-          </a:ln>
-          <a:solidFill>
-            <a:srgbClr val="F0F4F8"/>
-          </a:solidFill>
-        </p:spPr>
-        <p:txBody>
-          <a:bodyPr wrap="square">
-            <a:spAutoFit/>
-          </a:bodyPr>
-          <a:lstStyle/>
-          <a:p>
-            <a:pPr algn="l"/>
-            <a:r>
-              <a:rPr sz="900">
-                <a:solidFill>
-                  <a:srgbClr val="222222"/>
-                </a:solidFill>
-              </a:rPr>
-              <a:t>institution</a:t>
-            </a:r>
-          </a:p>
-          <a:p>
-            <a:pPr algn="l"/>
-            <a:r>
-              <a:rPr sz="900">
-                <a:solidFill>
-                  <a:srgbClr val="222222"/>
-                </a:solidFill>
-              </a:rPr>
-              <a:t>latitude</a:t>
-            </a:r>
-          </a:p>
-          <a:p>
-            <a:pPr algn="l"/>
-            <a:r>
-              <a:rPr sz="900">
-                <a:solidFill>
-                  <a:srgbClr val="222222"/>
-                </a:solidFill>
-              </a:rPr>
-              <a:t>longitude</a:t>
-            </a:r>
-          </a:p>
-        </p:txBody>
-      </p:sp>
-      <p:sp>
-        <p:nvSpPr>
-          <p:cNvPr id="15" name="TextBox 14"/>
-          <p:cNvSpPr txBox="1"/>
-          <p:nvPr/>
-        </p:nvSpPr>
-        <p:spPr>
-          <a:xfrm>
-            <a:off x="1800000" y="4500000"/>
-            <a:ext cx="2232000" cy="288000"/>
-          </a:xfrm>
-          <a:prstGeom prst="rect">
-            <a:avLst/>
-          </a:prstGeom>
-          <a:noFill/>
-          <a:solidFill>
-            <a:srgbClr val="935116"/>
-          </a:solidFill>
-        </p:spPr>
-        <p:txBody>
-          <a:bodyPr wrap="none">
-            <a:spAutoFit/>
-          </a:bodyPr>
-          <a:lstStyle/>
-          <a:p>
-            <a:pPr algn="ctr"/>
-            <a:r>
-              <a:rPr sz="1100" b="1">
-                <a:solidFill>
-                  <a:srgbClr val="FFFFFF"/>
-                </a:solidFill>
-              </a:rPr>
-              <a:t>publication_topics</a:t>
-            </a:r>
-          </a:p>
-        </p:txBody>
-      </p:sp>
-      <p:sp>
-        <p:nvSpPr>
-          <p:cNvPr id="16" name="TextBox 15"/>
-          <p:cNvSpPr txBox="1"/>
-          <p:nvPr/>
-        </p:nvSpPr>
-        <p:spPr>
-          <a:xfrm>
-            <a:off x="1800000" y="4806000"/>
-            <a:ext cx="2232000" cy="846000"/>
-          </a:xfrm>
-          <a:prstGeom prst="rect">
-            <a:avLst/>
-          </a:prstGeom>
-          <a:noFill/>
-          <a:ln w="12700">
-            <a:solidFill>
-              <a:srgbClr val="935116"/>
-            </a:solidFill>
-          </a:ln>
-          <a:solidFill>
-            <a:srgbClr val="F0F4F8"/>
-          </a:solidFill>
-        </p:spPr>
-        <p:txBody>
-          <a:bodyPr wrap="square">
-            <a:spAutoFit/>
-          </a:bodyPr>
-          <a:lstStyle/>
-          <a:p>
-            <a:pPr algn="l"/>
-            <a:r>
-              <a:rPr sz="900">
-                <a:solidFill>
-                  <a:srgbClr val="222222"/>
-                </a:solidFill>
-              </a:rPr>
-              <a:t>publication_id →</a:t>
-            </a:r>
-          </a:p>
-          <a:p>
-            <a:pPr algn="l"/>
-            <a:r>
-              <a:rPr sz="900">
-                <a:solidFill>
-                  <a:srgbClr val="222222"/>
-                </a:solidFill>
-              </a:rPr>
-              <a:t>topic_name  score</a:t>
-            </a:r>
-          </a:p>
-        </p:txBody>
-      </p:sp>
-      <p:sp>
-        <p:nvSpPr>
-          <p:cNvPr id="17" name="TextBox 16"/>
-          <p:cNvSpPr txBox="1"/>
-          <p:nvPr/>
-        </p:nvSpPr>
-        <p:spPr>
-          <a:xfrm>
-            <a:off x="1800000" y="2700000"/>
-            <a:ext cx="2232000" cy="288000"/>
-          </a:xfrm>
-          <a:prstGeom prst="rect">
-            <a:avLst/>
-          </a:prstGeom>
-          <a:noFill/>
-          <a:solidFill>
-            <a:srgbClr val="935116"/>
-          </a:solidFill>
-        </p:spPr>
-        <p:txBody>
-          <a:bodyPr wrap="none">
-            <a:spAutoFit/>
-          </a:bodyPr>
-          <a:lstStyle/>
-          <a:p>
-            <a:pPr algn="ctr"/>
-            <a:r>
-              <a:rPr sz="1100" b="1">
-                <a:solidFill>
-                  <a:srgbClr val="FFFFFF"/>
-                </a:solidFill>
-              </a:rPr>
-              <a:t>publication_keywords</a:t>
-            </a:r>
-          </a:p>
-        </p:txBody>
-      </p:sp>
-      <p:sp>
-        <p:nvSpPr>
-          <p:cNvPr id="18" name="TextBox 17"/>
-          <p:cNvSpPr txBox="1"/>
-          <p:nvPr/>
-        </p:nvSpPr>
-        <p:spPr>
-          <a:xfrm>
-            <a:off x="1800000" y="3006000"/>
-            <a:ext cx="2232000" cy="846000"/>
-          </a:xfrm>
-          <a:prstGeom prst="rect">
-            <a:avLst/>
-          </a:prstGeom>
-          <a:noFill/>
-          <a:ln w="12700">
-            <a:solidFill>
-              <a:srgbClr val="935116"/>
-            </a:solidFill>
-          </a:ln>
-          <a:solidFill>
-            <a:srgbClr val="F0F4F8"/>
-          </a:solidFill>
-        </p:spPr>
-        <p:txBody>
-          <a:bodyPr wrap="square">
-            <a:spAutoFit/>
-          </a:bodyPr>
-          <a:lstStyle/>
-          <a:p>
-            <a:pPr algn="l"/>
-            <a:r>
-              <a:rPr sz="900">
-                <a:solidFill>
-                  <a:srgbClr val="222222"/>
-                </a:solidFill>
-              </a:rPr>
-              <a:t>publication_id →</a:t>
-            </a:r>
-          </a:p>
-          <a:p>
-            <a:pPr algn="l"/>
-            <a:r>
-              <a:rPr sz="900">
-                <a:solidFill>
-                  <a:srgbClr val="222222"/>
-                </a:solidFill>
-              </a:rPr>
-              <a:t>keyword_name  score</a:t>
-            </a:r>
-          </a:p>
-        </p:txBody>
-      </p:sp>
-      <p:cxnSp>
-        <p:nvCxnSpPr>
-          <p:cNvPr id="19" name="Connector 18"/>
-          <p:cNvCxnSpPr/>
-          <p:nvPr/>
-        </p:nvCxnSpPr>
-        <p:spPr>
-          <a:xfrm>
-            <a:off x="5976000" y="2232000"/>
-            <a:ext cx="0" cy="468000"/>
-          </a:xfrm>
-          <a:prstGeom prst="line">
-            <a:avLst/>
-          </a:prstGeom>
-          <a:ln w="19050">
-            <a:solidFill>
-              <a:srgbClr val="88AACC"/>
-            </a:solidFill>
-          </a:ln>
-        </p:spPr>
-        <p:style>
-          <a:lnRef idx="2">
-            <a:schemeClr val="accent1"/>
-          </a:lnRef>
-          <a:fillRef idx="0">
-            <a:schemeClr val="accent1"/>
-          </a:fillRef>
-          <a:effectRef idx="1">
-            <a:schemeClr val="accent1"/>
-          </a:effectRef>
-          <a:fontRef idx="minor">
-            <a:schemeClr val="tx1"/>
-          </a:fontRef>
-        </p:style>
-      </p:cxnSp>
-      <p:sp>
-        <p:nvSpPr>
-          <p:cNvPr id="20" name="TextBox 19"/>
-          <p:cNvSpPr txBox="1"/>
-          <p:nvPr/>
-        </p:nvSpPr>
-        <p:spPr>
-          <a:xfrm>
-            <a:off x="5688000" y="2322000"/>
-            <a:ext cx="576000" cy="180000"/>
-          </a:xfrm>
-          <a:prstGeom prst="rect">
-            <a:avLst/>
-          </a:prstGeom>
-          <a:noFill/>
-        </p:spPr>
-        <p:txBody>
-          <a:bodyPr wrap="none">
-            <a:spAutoFit/>
-          </a:bodyPr>
-          <a:lstStyle/>
-          <a:p>
-            <a:pPr algn="ctr"/>
-            <a:r>
-              <a:rPr sz="800">
-                <a:solidFill>
-                  <a:srgbClr val="88AACC"/>
-                </a:solidFill>
-              </a:rPr>
-              <a:t>1 : N</a:t>
-            </a:r>
-          </a:p>
-        </p:txBody>
-      </p:sp>
-      <p:cxnSp>
-        <p:nvCxnSpPr>
-          <p:cNvPr id="21" name="Connector 20"/>
-          <p:cNvCxnSpPr/>
-          <p:nvPr/>
-        </p:nvCxnSpPr>
-        <p:spPr>
-          <a:xfrm>
-            <a:off x="7092000" y="3096000"/>
-            <a:ext cx="828000" cy="0"/>
-          </a:xfrm>
-          <a:prstGeom prst="line">
-            <a:avLst/>
-          </a:prstGeom>
-          <a:ln w="19050">
-            <a:solidFill>
-              <a:srgbClr val="88AACC"/>
-            </a:solidFill>
-          </a:ln>
-        </p:spPr>
-        <p:style>
-          <a:lnRef idx="2">
-            <a:schemeClr val="accent1"/>
-          </a:lnRef>
-          <a:fillRef idx="0">
-            <a:schemeClr val="accent1"/>
-          </a:fillRef>
-          <a:effectRef idx="1">
-            <a:schemeClr val="accent1"/>
-          </a:effectRef>
-          <a:fontRef idx="minor">
-            <a:schemeClr val="tx1"/>
-          </a:fontRef>
-        </p:style>
-      </p:cxnSp>
-      <p:sp>
-        <p:nvSpPr>
-          <p:cNvPr id="22" name="TextBox 21"/>
-          <p:cNvSpPr txBox="1"/>
-          <p:nvPr/>
-        </p:nvSpPr>
-        <p:spPr>
-          <a:xfrm>
-            <a:off x="7218000" y="2952000"/>
-            <a:ext cx="576000" cy="180000"/>
-          </a:xfrm>
-          <a:prstGeom prst="rect">
-            <a:avLst/>
-          </a:prstGeom>
-          <a:noFill/>
-        </p:spPr>
-        <p:txBody>
-          <a:bodyPr wrap="none">
-            <a:spAutoFit/>
-          </a:bodyPr>
-          <a:lstStyle/>
-          <a:p>
-            <a:pPr algn="ctr"/>
-            <a:r>
-              <a:rPr sz="800">
-                <a:solidFill>
-                  <a:srgbClr val="88AACC"/>
-                </a:solidFill>
-              </a:rPr>
-              <a:t>1 : N</a:t>
-            </a:r>
-          </a:p>
-        </p:txBody>
-      </p:sp>
-      <p:cxnSp>
-        <p:nvCxnSpPr>
-          <p:cNvPr id="23" name="Connector 22"/>
-          <p:cNvCxnSpPr/>
-          <p:nvPr/>
-        </p:nvCxnSpPr>
-        <p:spPr>
-          <a:xfrm>
-            <a:off x="9036000" y="3492000"/>
-            <a:ext cx="0" cy="1008000"/>
-          </a:xfrm>
-          <a:prstGeom prst="line">
-            <a:avLst/>
-          </a:prstGeom>
-          <a:ln w="19050">
-            <a:solidFill>
-              <a:srgbClr val="88AACC"/>
-            </a:solidFill>
-          </a:ln>
-        </p:spPr>
-        <p:style>
-          <a:lnRef idx="2">
-            <a:schemeClr val="accent1"/>
-          </a:lnRef>
-          <a:fillRef idx="0">
-            <a:schemeClr val="accent1"/>
-          </a:fillRef>
-          <a:effectRef idx="1">
-            <a:schemeClr val="accent1"/>
-          </a:effectRef>
-          <a:fontRef idx="minor">
-            <a:schemeClr val="tx1"/>
-          </a:fontRef>
-        </p:style>
-      </p:cxnSp>
-      <p:sp>
-        <p:nvSpPr>
-          <p:cNvPr id="24" name="TextBox 23"/>
-          <p:cNvSpPr txBox="1"/>
-          <p:nvPr/>
-        </p:nvSpPr>
-        <p:spPr>
-          <a:xfrm>
-            <a:off x="8748000" y="3852000"/>
-            <a:ext cx="576000" cy="180000"/>
-          </a:xfrm>
-          <a:prstGeom prst="rect">
-            <a:avLst/>
-          </a:prstGeom>
-          <a:noFill/>
-        </p:spPr>
-        <p:txBody>
-          <a:bodyPr wrap="none">
-            <a:spAutoFit/>
-          </a:bodyPr>
-          <a:lstStyle/>
-          <a:p>
-            <a:pPr algn="ctr"/>
-            <a:r>
-              <a:rPr sz="800">
-                <a:solidFill>
-                  <a:srgbClr val="88AACC"/>
-                </a:solidFill>
-              </a:rPr>
-              <a:t>N : 1</a:t>
-            </a:r>
-          </a:p>
-        </p:txBody>
-      </p:sp>
-      <p:cxnSp>
-        <p:nvCxnSpPr>
-          <p:cNvPr id="25" name="Connector 24"/>
-          <p:cNvCxnSpPr/>
-          <p:nvPr/>
-        </p:nvCxnSpPr>
-        <p:spPr>
-          <a:xfrm flipV="1">
-            <a:off x="10152000" y="3600000"/>
-            <a:ext cx="108000" cy="1296000"/>
-          </a:xfrm>
-          <a:prstGeom prst="line">
-            <a:avLst/>
-          </a:prstGeom>
-          <a:ln w="19050">
-            <a:solidFill>
-              <a:srgbClr val="88AACC"/>
-            </a:solidFill>
-          </a:ln>
-        </p:spPr>
-        <p:style>
-          <a:lnRef idx="2">
-            <a:schemeClr val="accent1"/>
-          </a:lnRef>
-          <a:fillRef idx="0">
-            <a:schemeClr val="accent1"/>
-          </a:fillRef>
-          <a:effectRef idx="1">
-            <a:schemeClr val="accent1"/>
-          </a:effectRef>
-          <a:fontRef idx="minor">
-            <a:schemeClr val="tx1"/>
-          </a:fontRef>
-        </p:style>
-      </p:cxnSp>
-      <p:cxnSp>
-        <p:nvCxnSpPr>
-          <p:cNvPr id="26" name="Connector 25"/>
-          <p:cNvCxnSpPr/>
-          <p:nvPr/>
-        </p:nvCxnSpPr>
-        <p:spPr>
-          <a:xfrm flipH="1">
-            <a:off x="4032000" y="3240000"/>
-            <a:ext cx="828000" cy="1800000"/>
-          </a:xfrm>
-          <a:prstGeom prst="line">
-            <a:avLst/>
-          </a:prstGeom>
-          <a:ln w="19050">
-            <a:solidFill>
-              <a:srgbClr val="88AACC"/>
-            </a:solidFill>
-          </a:ln>
-        </p:spPr>
-        <p:style>
-          <a:lnRef idx="2">
-            <a:schemeClr val="accent1"/>
-          </a:lnRef>
-          <a:fillRef idx="0">
-            <a:schemeClr val="accent1"/>
-          </a:fillRef>
-          <a:effectRef idx="1">
-            <a:schemeClr val="accent1"/>
-          </a:effectRef>
-          <a:fontRef idx="minor">
-            <a:schemeClr val="tx1"/>
-          </a:fontRef>
-        </p:style>
-      </p:cxnSp>
-      <p:sp>
-        <p:nvSpPr>
-          <p:cNvPr id="27" name="TextBox 26"/>
-          <p:cNvSpPr txBox="1"/>
-          <p:nvPr/>
-        </p:nvSpPr>
-        <p:spPr>
-          <a:xfrm>
-            <a:off x="4158000" y="3996000"/>
-            <a:ext cx="576000" cy="180000"/>
-          </a:xfrm>
-          <a:prstGeom prst="rect">
-            <a:avLst/>
-          </a:prstGeom>
-          <a:noFill/>
-        </p:spPr>
-        <p:txBody>
-          <a:bodyPr wrap="none">
-            <a:spAutoFit/>
-          </a:bodyPr>
-          <a:lstStyle/>
-          <a:p>
-            <a:pPr algn="ctr"/>
-            <a:r>
-              <a:rPr sz="800">
-                <a:solidFill>
-                  <a:srgbClr val="88AACC"/>
-                </a:solidFill>
-              </a:rPr>
-              <a:t>1 : N</a:t>
-            </a:r>
-          </a:p>
-        </p:txBody>
-      </p:sp>
-      <p:cxnSp>
-        <p:nvCxnSpPr>
-          <p:cNvPr id="28" name="Connector 27"/>
-          <p:cNvCxnSpPr/>
-          <p:nvPr/>
-        </p:nvCxnSpPr>
-        <p:spPr>
-          <a:xfrm flipH="1">
-            <a:off x="4032000" y="3060000"/>
-            <a:ext cx="828000" cy="0"/>
-          </a:xfrm>
-          <a:prstGeom prst="line">
-            <a:avLst/>
-          </a:prstGeom>
-          <a:ln w="19050">
-            <a:solidFill>
-              <a:srgbClr val="88AACC"/>
-            </a:solidFill>
-          </a:ln>
-        </p:spPr>
-        <p:style>
-          <a:lnRef idx="2">
-            <a:schemeClr val="accent1"/>
-          </a:lnRef>
-          <a:fillRef idx="0">
-            <a:schemeClr val="accent1"/>
-          </a:fillRef>
-          <a:effectRef idx="1">
-            <a:schemeClr val="accent1"/>
-          </a:effectRef>
-          <a:fontRef idx="minor">
-            <a:schemeClr val="tx1"/>
-          </a:fontRef>
-        </p:style>
-      </p:cxnSp>
-      <p:sp>
-        <p:nvSpPr>
-          <p:cNvPr id="29" name="TextBox 28"/>
-          <p:cNvSpPr txBox="1"/>
-          <p:nvPr/>
-        </p:nvSpPr>
-        <p:spPr>
-          <a:xfrm>
-            <a:off x="4158000" y="2916000"/>
-            <a:ext cx="576000" cy="180000"/>
-          </a:xfrm>
-          <a:prstGeom prst="rect">
-            <a:avLst/>
-          </a:prstGeom>
-          <a:noFill/>
-        </p:spPr>
-        <p:txBody>
-          <a:bodyPr wrap="none">
-            <a:spAutoFit/>
-          </a:bodyPr>
-          <a:lstStyle/>
-          <a:p>
-            <a:pPr algn="ctr"/>
-            <a:r>
-              <a:rPr sz="800">
-                <a:solidFill>
-                  <a:srgbClr val="88AACC"/>
-                </a:solidFill>
-              </a:rPr>
-              <a:t>1 : N</a:t>
+                <a:latin typeface="Arial"/>
+              </a:rPr>
+              <a:t>14</a:t>
+            </a:r>
+            <a:r>
+              <a:rPr sz="1000" b="0">
+                <a:solidFill>
+                  <a:srgbClr val="CFE0D6"/>
+                </a:solidFill>
+                <a:latin typeface="Arial"/>
+              </a:rPr>
+              <a:t> / 14</a:t>
             </a:r>
           </a:p>
         </p:txBody>
@@ -10082,28 +9042,46 @@
         </p:nvSpPr>
         <p:spPr>
           <a:xfrm>
-            <a:off x="11288825" y="6498000"/>
-            <a:ext cx="792000" cy="288000"/>
-          </a:xfrm>
-          <a:prstGeom prst="rect">
-            <a:avLst/>
-          </a:prstGeom>
+            <a:off x="11144825" y="6408000"/>
+            <a:ext cx="864000" cy="270000"/>
+          </a:xfrm>
           <a:noFill/>
-        </p:spPr>
-        <p:txBody>
-          <a:bodyPr wrap="none">
+          <a:ln>
+            <a:noFill/>
+          </a:ln>
+          <a:solidFill>
+            <a:srgbClr val="23613F"/>
+          </a:solidFill>
+          <a:prstGeom prst="roundRect">
+            <a:avLst>
+              <a:gd name="adj" fmla="val 30000"/>
+            </a:avLst>
+          </a:prstGeom>
+        </p:spPr>
+        <p:txBody>
+          <a:bodyPr wrap="none" anchor="ctr">
             <a:spAutoFit/>
           </a:bodyPr>
           <a:lstStyle/>
           <a:p>
-            <a:pPr algn="r"/>
-            <a:r>
-              <a:rPr sz="1000">
-                <a:solidFill>
-                  <a:srgbClr val="BBBBBB"/>
-                </a:solidFill>
-              </a:rPr>
-              <a:t>2 / 13</a:t>
+            <a:pPr algn="ctr"/>
+            <a:r>
+              <a:rPr sz="1100" b="1">
+                <a:solidFill>
+                  <a:srgbClr val="FFFFFF"/>
+                </a:solidFill>
+                <a:latin typeface="Arial"/>
+              </a:rPr>
+              <a:t>2</a:t>
+            </a:r>
+            <a:r>
+              <a:rPr sz="1000" b="0">
+                <a:solidFill>
+                  <a:srgbClr val="CFE0D6"/>
+                </a:solidFill>
+                <a:latin typeface="Arial"/>
+              </a:rPr>
+              <a:t> / 14</a:t>
             </a:r>
           </a:p>
         </p:txBody>
@@ -10273,28 +9251,46 @@
         </p:nvSpPr>
         <p:spPr>
           <a:xfrm>
-            <a:off x="11288825" y="6498000"/>
-            <a:ext cx="792000" cy="288000"/>
-          </a:xfrm>
-          <a:prstGeom prst="rect">
-            <a:avLst/>
-          </a:prstGeom>
+            <a:off x="11144825" y="6408000"/>
+            <a:ext cx="864000" cy="270000"/>
+          </a:xfrm>
           <a:noFill/>
-        </p:spPr>
-        <p:txBody>
-          <a:bodyPr wrap="none">
+          <a:ln>
+            <a:noFill/>
+          </a:ln>
+          <a:solidFill>
+            <a:srgbClr val="23613F"/>
+          </a:solidFill>
+          <a:prstGeom prst="roundRect">
+            <a:avLst>
+              <a:gd name="adj" fmla="val 30000"/>
+            </a:avLst>
+          </a:prstGeom>
+        </p:spPr>
+        <p:txBody>
+          <a:bodyPr wrap="none" anchor="ctr">
             <a:spAutoFit/>
           </a:bodyPr>
           <a:lstStyle/>
           <a:p>
-            <a:pPr algn="r"/>
-            <a:r>
-              <a:rPr sz="1000">
-                <a:solidFill>
-                  <a:srgbClr val="BBBBBB"/>
-                </a:solidFill>
-              </a:rPr>
-              <a:t>3 / 13</a:t>
+            <a:pPr algn="ctr"/>
+            <a:r>
+              <a:rPr sz="1100" b="1">
+                <a:solidFill>
+                  <a:srgbClr val="FFFFFF"/>
+                </a:solidFill>
+                <a:latin typeface="Arial"/>
+              </a:rPr>
+              <a:t>3</a:t>
+            </a:r>
+            <a:r>
+              <a:rPr sz="1000" b="0">
+                <a:solidFill>
+                  <a:srgbClr val="CFE0D6"/>
+                </a:solidFill>
+                <a:latin typeface="Arial"/>
+              </a:rPr>
+              <a:t> / 14</a:t>
             </a:r>
           </a:p>
         </p:txBody>
@@ -10756,28 +9752,46 @@
         </p:nvSpPr>
         <p:spPr>
           <a:xfrm>
-            <a:off x="11288825" y="6498000"/>
-            <a:ext cx="792000" cy="288000"/>
-          </a:xfrm>
-          <a:prstGeom prst="rect">
-            <a:avLst/>
-          </a:prstGeom>
+            <a:off x="11144825" y="6408000"/>
+            <a:ext cx="864000" cy="270000"/>
+          </a:xfrm>
           <a:noFill/>
-        </p:spPr>
-        <p:txBody>
-          <a:bodyPr wrap="none">
+          <a:ln>
+            <a:noFill/>
+          </a:ln>
+          <a:solidFill>
+            <a:srgbClr val="23613F"/>
+          </a:solidFill>
+          <a:prstGeom prst="roundRect">
+            <a:avLst>
+              <a:gd name="adj" fmla="val 30000"/>
+            </a:avLst>
+          </a:prstGeom>
+        </p:spPr>
+        <p:txBody>
+          <a:bodyPr wrap="none" anchor="ctr">
             <a:spAutoFit/>
           </a:bodyPr>
           <a:lstStyle/>
           <a:p>
-            <a:pPr algn="r"/>
-            <a:r>
-              <a:rPr sz="1000">
-                <a:solidFill>
-                  <a:srgbClr val="BBBBBB"/>
-                </a:solidFill>
-              </a:rPr>
-              <a:t>4 / 13</a:t>
+            <a:pPr algn="ctr"/>
+            <a:r>
+              <a:rPr sz="1100" b="1">
+                <a:solidFill>
+                  <a:srgbClr val="FFFFFF"/>
+                </a:solidFill>
+                <a:latin typeface="Arial"/>
+              </a:rPr>
+              <a:t>4</a:t>
+            </a:r>
+            <a:r>
+              <a:rPr sz="1000" b="0">
+                <a:solidFill>
+                  <a:srgbClr val="CFE0D6"/>
+                </a:solidFill>
+                <a:latin typeface="Arial"/>
+              </a:rPr>
+              <a:t> / 14</a:t>
             </a:r>
           </a:p>
         </p:txBody>
@@ -13409,28 +12423,46 @@
         </p:nvSpPr>
         <p:spPr>
           <a:xfrm>
-            <a:off x="11288825" y="6498000"/>
-            <a:ext cx="792000" cy="288000"/>
-          </a:xfrm>
-          <a:prstGeom prst="rect">
-            <a:avLst/>
-          </a:prstGeom>
+            <a:off x="11144825" y="6408000"/>
+            <a:ext cx="864000" cy="270000"/>
+          </a:xfrm>
           <a:noFill/>
-        </p:spPr>
-        <p:txBody>
-          <a:bodyPr wrap="none">
+          <a:ln>
+            <a:noFill/>
+          </a:ln>
+          <a:solidFill>
+            <a:srgbClr val="23613F"/>
+          </a:solidFill>
+          <a:prstGeom prst="roundRect">
+            <a:avLst>
+              <a:gd name="adj" fmla="val 30000"/>
+            </a:avLst>
+          </a:prstGeom>
+        </p:spPr>
+        <p:txBody>
+          <a:bodyPr wrap="none" anchor="ctr">
             <a:spAutoFit/>
           </a:bodyPr>
           <a:lstStyle/>
           <a:p>
-            <a:pPr algn="r"/>
-            <a:r>
-              <a:rPr sz="1000">
-                <a:solidFill>
-                  <a:srgbClr val="BBBBBB"/>
-                </a:solidFill>
-              </a:rPr>
-              <a:t>5 / 13</a:t>
+            <a:pPr algn="ctr"/>
+            <a:r>
+              <a:rPr sz="1100" b="1">
+                <a:solidFill>
+                  <a:srgbClr val="FFFFFF"/>
+                </a:solidFill>
+                <a:latin typeface="Arial"/>
+              </a:rPr>
+              <a:t>5</a:t>
+            </a:r>
+            <a:r>
+              <a:rPr sz="1000" b="0">
+                <a:solidFill>
+                  <a:srgbClr val="CFE0D6"/>
+                </a:solidFill>
+                <a:latin typeface="Arial"/>
+              </a:rPr>
+              <a:t> / 14</a:t>
             </a:r>
           </a:p>
         </p:txBody>
@@ -13443,7 +12475,7 @@
 </p:sld>
 </file>
 
-<file path=ppt/slides/slide7.xml><?xml version="1.0" encoding="utf-8"?>
+<file path=ppt/slides/slide6.xml><?xml version="1.0" encoding="utf-8"?>
 <p:sld xmlns:a="http://schemas.openxmlformats.org/drawingml/2006/main" xmlns:r="http://schemas.openxmlformats.org/officeDocument/2006/relationships" xmlns:p="http://schemas.openxmlformats.org/presentationml/2006/main">
   <p:cSld>
     <p:spTree>
@@ -14403,28 +13435,46 @@
         </p:nvSpPr>
         <p:spPr>
           <a:xfrm>
-            <a:off x="11288825" y="6498000"/>
-            <a:ext cx="792000" cy="288000"/>
-          </a:xfrm>
-          <a:prstGeom prst="rect">
-            <a:avLst/>
-          </a:prstGeom>
+            <a:off x="11144825" y="6408000"/>
+            <a:ext cx="864000" cy="270000"/>
+          </a:xfrm>
           <a:noFill/>
-        </p:spPr>
-        <p:txBody>
-          <a:bodyPr wrap="none">
+          <a:ln>
+            <a:noFill/>
+          </a:ln>
+          <a:solidFill>
+            <a:srgbClr val="23613F"/>
+          </a:solidFill>
+          <a:prstGeom prst="roundRect">
+            <a:avLst>
+              <a:gd name="adj" fmla="val 30000"/>
+            </a:avLst>
+          </a:prstGeom>
+        </p:spPr>
+        <p:txBody>
+          <a:bodyPr wrap="none" anchor="ctr">
             <a:spAutoFit/>
           </a:bodyPr>
           <a:lstStyle/>
           <a:p>
-            <a:pPr algn="r"/>
-            <a:r>
-              <a:rPr sz="1000">
-                <a:solidFill>
-                  <a:srgbClr val="BBBBBB"/>
-                </a:solidFill>
-              </a:rPr>
-              <a:t>6 / 13</a:t>
+            <a:pPr algn="ctr"/>
+            <a:r>
+              <a:rPr sz="1100" b="1">
+                <a:solidFill>
+                  <a:srgbClr val="FFFFFF"/>
+                </a:solidFill>
+                <a:latin typeface="Arial"/>
+              </a:rPr>
+              <a:t>6</a:t>
+            </a:r>
+            <a:r>
+              <a:rPr sz="1000" b="0">
+                <a:solidFill>
+                  <a:srgbClr val="CFE0D6"/>
+                </a:solidFill>
+                <a:latin typeface="Arial"/>
+              </a:rPr>
+              <a:t> / 14</a:t>
             </a:r>
           </a:p>
         </p:txBody>
@@ -14437,7 +13487,7 @@
 </p:sld>
 </file>
 
-<file path=ppt/slides/slide8.xml><?xml version="1.0" encoding="utf-8"?>
+<file path=ppt/slides/slide7.xml><?xml version="1.0" encoding="utf-8"?>
 <p:sld xmlns:a="http://schemas.openxmlformats.org/drawingml/2006/main" xmlns:r="http://schemas.openxmlformats.org/officeDocument/2006/relationships" xmlns:p="http://schemas.openxmlformats.org/presentationml/2006/main">
   <p:cSld>
     <p:spTree>
@@ -15276,28 +14326,46 @@
         </p:nvSpPr>
         <p:spPr>
           <a:xfrm>
-            <a:off x="11288825" y="6498000"/>
-            <a:ext cx="792000" cy="288000"/>
-          </a:xfrm>
-          <a:prstGeom prst="rect">
-            <a:avLst/>
-          </a:prstGeom>
+            <a:off x="11144825" y="6408000"/>
+            <a:ext cx="864000" cy="270000"/>
+          </a:xfrm>
           <a:noFill/>
-        </p:spPr>
-        <p:txBody>
-          <a:bodyPr wrap="none">
+          <a:ln>
+            <a:noFill/>
+          </a:ln>
+          <a:solidFill>
+            <a:srgbClr val="23613F"/>
+          </a:solidFill>
+          <a:prstGeom prst="roundRect">
+            <a:avLst>
+              <a:gd name="adj" fmla="val 30000"/>
+            </a:avLst>
+          </a:prstGeom>
+        </p:spPr>
+        <p:txBody>
+          <a:bodyPr wrap="none" anchor="ctr">
             <a:spAutoFit/>
           </a:bodyPr>
           <a:lstStyle/>
           <a:p>
-            <a:pPr algn="r"/>
-            <a:r>
-              <a:rPr sz="1000">
-                <a:solidFill>
-                  <a:srgbClr val="BBBBBB"/>
-                </a:solidFill>
-              </a:rPr>
-              <a:t>7 / 13</a:t>
+            <a:pPr algn="ctr"/>
+            <a:r>
+              <a:rPr sz="1100" b="1">
+                <a:solidFill>
+                  <a:srgbClr val="FFFFFF"/>
+                </a:solidFill>
+                <a:latin typeface="Arial"/>
+              </a:rPr>
+              <a:t>7</a:t>
+            </a:r>
+            <a:r>
+              <a:rPr sz="1000" b="0">
+                <a:solidFill>
+                  <a:srgbClr val="CFE0D6"/>
+                </a:solidFill>
+                <a:latin typeface="Arial"/>
+              </a:rPr>
+              <a:t> / 14</a:t>
             </a:r>
           </a:p>
         </p:txBody>
@@ -15896,28 +14964,46 @@
         </p:nvSpPr>
         <p:spPr>
           <a:xfrm>
-            <a:off x="11288825" y="6498000"/>
-            <a:ext cx="792000" cy="288000"/>
-          </a:xfrm>
-          <a:prstGeom prst="rect">
-            <a:avLst/>
-          </a:prstGeom>
+            <a:off x="11144825" y="6408000"/>
+            <a:ext cx="864000" cy="270000"/>
+          </a:xfrm>
           <a:noFill/>
-        </p:spPr>
-        <p:txBody>
-          <a:bodyPr wrap="none">
+          <a:ln>
+            <a:noFill/>
+          </a:ln>
+          <a:solidFill>
+            <a:srgbClr val="23613F"/>
+          </a:solidFill>
+          <a:prstGeom prst="roundRect">
+            <a:avLst>
+              <a:gd name="adj" fmla="val 30000"/>
+            </a:avLst>
+          </a:prstGeom>
+        </p:spPr>
+        <p:txBody>
+          <a:bodyPr wrap="none" anchor="ctr">
             <a:spAutoFit/>
           </a:bodyPr>
           <a:lstStyle/>
           <a:p>
-            <a:pPr algn="r"/>
-            <a:r>
-              <a:rPr sz="1000">
-                <a:solidFill>
-                  <a:srgbClr val="BBBBBB"/>
-                </a:solidFill>
-              </a:rPr>
-              <a:t>8 / 13</a:t>
+            <a:pPr algn="ctr"/>
+            <a:r>
+              <a:rPr sz="1100" b="1">
+                <a:solidFill>
+                  <a:srgbClr val="FFFFFF"/>
+                </a:solidFill>
+                <a:latin typeface="Arial"/>
+              </a:rPr>
+              <a:t>9</a:t>
+            </a:r>
+            <a:r>
+              <a:rPr sz="1000" b="0">
+                <a:solidFill>
+                  <a:srgbClr val="CFE0D6"/>
+                </a:solidFill>
+                <a:latin typeface="Arial"/>
+              </a:rPr>
+              <a:t> / 14</a:t>
             </a:r>
           </a:p>
         </p:txBody>

</xml_diff>

<commit_message>
style(presentation): progress bar slide numbering
Full-width track bar at bottom of each slide with proportional
fill and a circle marker showing current slide number — like a
media player progress bar.
</commit_message>
<xml_diff>
--- a/docs/Визуализация науки на основе метаданных публикаций и журналов.pptx
+++ b/docs/Визуализация науки на основе метаданных публикаций и журналов.pptx
@@ -4342,21 +4342,79 @@
         </p:nvSpPr>
         <p:spPr>
           <a:xfrm>
-            <a:off x="11144825" y="6408000"/>
-            <a:ext cx="864000" cy="270000"/>
+            <a:off x="0" y="6757200"/>
+            <a:ext cx="12188825" cy="100800"/>
           </a:xfrm>
           <a:noFill/>
+          <a:prstGeom prst="rect">
+            <a:avLst/>
+          </a:prstGeom>
+          <a:solidFill>
+            <a:srgbClr val="122017"/>
+          </a:solidFill>
           <a:ln>
             <a:noFill/>
           </a:ln>
+        </p:spPr>
+        <p:txBody>
+          <a:bodyPr wrap="none">
+            <a:spAutoFit/>
+          </a:bodyPr>
+          <a:lstStyle/>
+          <a:p/>
+        </p:txBody>
+      </p:sp>
+      <p:sp>
+        <p:nvSpPr>
+          <p:cNvPr id="9" name="TextBox 8"/>
+          <p:cNvSpPr txBox="1"/>
+          <p:nvPr/>
+        </p:nvSpPr>
+        <p:spPr>
+          <a:xfrm>
+            <a:off x="0" y="6757200"/>
+            <a:ext cx="870630" cy="100800"/>
+          </a:xfrm>
+          <a:noFill/>
+          <a:prstGeom prst="rect">
+            <a:avLst/>
+          </a:prstGeom>
           <a:solidFill>
-            <a:srgbClr val="23613F"/>
+            <a:srgbClr val="3A6B55"/>
           </a:solidFill>
-          <a:prstGeom prst="roundRect">
-            <a:avLst>
-              <a:gd name="adj" fmla="val 30000"/>
-            </a:avLst>
-          </a:prstGeom>
+          <a:ln>
+            <a:noFill/>
+          </a:ln>
+        </p:spPr>
+        <p:txBody>
+          <a:bodyPr wrap="none">
+            <a:spAutoFit/>
+          </a:bodyPr>
+          <a:lstStyle/>
+          <a:p/>
+        </p:txBody>
+      </p:sp>
+      <p:sp>
+        <p:nvSpPr>
+          <p:cNvPr id="10" name="TextBox 9"/>
+          <p:cNvSpPr txBox="1"/>
+          <p:nvPr/>
+        </p:nvSpPr>
+        <p:spPr>
+          <a:xfrm>
+            <a:off x="708630" y="6645600"/>
+            <a:ext cx="324000" cy="324000"/>
+          </a:xfrm>
+          <a:noFill/>
+          <a:prstGeom prst="ellipse">
+            <a:avLst/>
+          </a:prstGeom>
+          <a:solidFill>
+            <a:srgbClr val="8BB29A"/>
+          </a:solidFill>
+          <a:ln>
+            <a:noFill/>
+          </a:ln>
         </p:spPr>
         <p:txBody>
           <a:bodyPr wrap="none" anchor="ctr">
@@ -4366,22 +4424,13 @@
           <a:p>
             <a:pPr algn="ctr"/>
             <a:r>
-              <a:rPr sz="1100" b="1">
+              <a:rPr sz="900" b="1">
                 <a:solidFill>
                   <a:srgbClr val="FFFFFF"/>
                 </a:solidFill>
                 <a:latin typeface="Arial"/>
               </a:rPr>
               <a:t>1</a:t>
-            </a:r>
-            <a:r>
-              <a:rPr sz="1000" b="0">
-                <a:solidFill>
-                  <a:srgbClr val="CFE0D6"/>
-                </a:solidFill>
-                <a:latin typeface="Arial"/>
-              </a:rPr>
-              <a:t> / 14</a:t>
             </a:r>
           </a:p>
         </p:txBody>
@@ -5321,21 +5370,79 @@
         </p:nvSpPr>
         <p:spPr>
           <a:xfrm>
-            <a:off x="11144825" y="6408000"/>
-            <a:ext cx="864000" cy="270000"/>
+            <a:off x="0" y="6757200"/>
+            <a:ext cx="12188825" cy="100800"/>
           </a:xfrm>
           <a:noFill/>
+          <a:prstGeom prst="rect">
+            <a:avLst/>
+          </a:prstGeom>
+          <a:solidFill>
+            <a:srgbClr val="122017"/>
+          </a:solidFill>
           <a:ln>
             <a:noFill/>
           </a:ln>
+        </p:spPr>
+        <p:txBody>
+          <a:bodyPr wrap="none">
+            <a:spAutoFit/>
+          </a:bodyPr>
+          <a:lstStyle/>
+          <a:p/>
+        </p:txBody>
+      </p:sp>
+      <p:sp>
+        <p:nvSpPr>
+          <p:cNvPr id="24" name="TextBox 23"/>
+          <p:cNvSpPr txBox="1"/>
+          <p:nvPr/>
+        </p:nvSpPr>
+        <p:spPr>
+          <a:xfrm>
+            <a:off x="0" y="6757200"/>
+            <a:ext cx="8706303" cy="100800"/>
+          </a:xfrm>
+          <a:noFill/>
+          <a:prstGeom prst="rect">
+            <a:avLst/>
+          </a:prstGeom>
           <a:solidFill>
-            <a:srgbClr val="23613F"/>
+            <a:srgbClr val="3A6B55"/>
           </a:solidFill>
-          <a:prstGeom prst="roundRect">
-            <a:avLst>
-              <a:gd name="adj" fmla="val 30000"/>
-            </a:avLst>
-          </a:prstGeom>
+          <a:ln>
+            <a:noFill/>
+          </a:ln>
+        </p:spPr>
+        <p:txBody>
+          <a:bodyPr wrap="none">
+            <a:spAutoFit/>
+          </a:bodyPr>
+          <a:lstStyle/>
+          <a:p/>
+        </p:txBody>
+      </p:sp>
+      <p:sp>
+        <p:nvSpPr>
+          <p:cNvPr id="25" name="TextBox 24"/>
+          <p:cNvSpPr txBox="1"/>
+          <p:nvPr/>
+        </p:nvSpPr>
+        <p:spPr>
+          <a:xfrm>
+            <a:off x="8544303" y="6645600"/>
+            <a:ext cx="324000" cy="324000"/>
+          </a:xfrm>
+          <a:noFill/>
+          <a:prstGeom prst="ellipse">
+            <a:avLst/>
+          </a:prstGeom>
+          <a:solidFill>
+            <a:srgbClr val="8BB29A"/>
+          </a:solidFill>
+          <a:ln>
+            <a:noFill/>
+          </a:ln>
         </p:spPr>
         <p:txBody>
           <a:bodyPr wrap="none" anchor="ctr">
@@ -5345,22 +5452,13 @@
           <a:p>
             <a:pPr algn="ctr"/>
             <a:r>
-              <a:rPr sz="1100" b="1">
+              <a:rPr sz="900" b="1">
                 <a:solidFill>
                   <a:srgbClr val="FFFFFF"/>
                 </a:solidFill>
                 <a:latin typeface="Arial"/>
               </a:rPr>
               <a:t>10</a:t>
-            </a:r>
-            <a:r>
-              <a:rPr sz="1000" b="0">
-                <a:solidFill>
-                  <a:srgbClr val="CFE0D6"/>
-                </a:solidFill>
-                <a:latin typeface="Arial"/>
-              </a:rPr>
-              <a:t> / 14</a:t>
             </a:r>
           </a:p>
         </p:txBody>
@@ -5899,21 +5997,79 @@
         </p:nvSpPr>
         <p:spPr>
           <a:xfrm>
-            <a:off x="11144825" y="6408000"/>
-            <a:ext cx="864000" cy="270000"/>
+            <a:off x="0" y="6757200"/>
+            <a:ext cx="12188825" cy="100800"/>
           </a:xfrm>
           <a:noFill/>
+          <a:prstGeom prst="rect">
+            <a:avLst/>
+          </a:prstGeom>
+          <a:solidFill>
+            <a:srgbClr val="122017"/>
+          </a:solidFill>
           <a:ln>
             <a:noFill/>
           </a:ln>
+        </p:spPr>
+        <p:txBody>
+          <a:bodyPr wrap="none">
+            <a:spAutoFit/>
+          </a:bodyPr>
+          <a:lstStyle/>
+          <a:p/>
+        </p:txBody>
+      </p:sp>
+      <p:sp>
+        <p:nvSpPr>
+          <p:cNvPr id="13" name="TextBox 12"/>
+          <p:cNvSpPr txBox="1"/>
+          <p:nvPr/>
+        </p:nvSpPr>
+        <p:spPr>
+          <a:xfrm>
+            <a:off x="0" y="6757200"/>
+            <a:ext cx="9576933" cy="100800"/>
+          </a:xfrm>
+          <a:noFill/>
+          <a:prstGeom prst="rect">
+            <a:avLst/>
+          </a:prstGeom>
           <a:solidFill>
-            <a:srgbClr val="23613F"/>
+            <a:srgbClr val="3A6B55"/>
           </a:solidFill>
-          <a:prstGeom prst="roundRect">
-            <a:avLst>
-              <a:gd name="adj" fmla="val 30000"/>
-            </a:avLst>
-          </a:prstGeom>
+          <a:ln>
+            <a:noFill/>
+          </a:ln>
+        </p:spPr>
+        <p:txBody>
+          <a:bodyPr wrap="none">
+            <a:spAutoFit/>
+          </a:bodyPr>
+          <a:lstStyle/>
+          <a:p/>
+        </p:txBody>
+      </p:sp>
+      <p:sp>
+        <p:nvSpPr>
+          <p:cNvPr id="14" name="TextBox 13"/>
+          <p:cNvSpPr txBox="1"/>
+          <p:nvPr/>
+        </p:nvSpPr>
+        <p:spPr>
+          <a:xfrm>
+            <a:off x="9414933" y="6645600"/>
+            <a:ext cx="324000" cy="324000"/>
+          </a:xfrm>
+          <a:noFill/>
+          <a:prstGeom prst="ellipse">
+            <a:avLst/>
+          </a:prstGeom>
+          <a:solidFill>
+            <a:srgbClr val="8BB29A"/>
+          </a:solidFill>
+          <a:ln>
+            <a:noFill/>
+          </a:ln>
         </p:spPr>
         <p:txBody>
           <a:bodyPr wrap="none" anchor="ctr">
@@ -5923,22 +6079,13 @@
           <a:p>
             <a:pPr algn="ctr"/>
             <a:r>
-              <a:rPr sz="1100" b="1">
+              <a:rPr sz="900" b="1">
                 <a:solidFill>
                   <a:srgbClr val="FFFFFF"/>
                 </a:solidFill>
                 <a:latin typeface="Arial"/>
               </a:rPr>
               <a:t>11</a:t>
-            </a:r>
-            <a:r>
-              <a:rPr sz="1000" b="0">
-                <a:solidFill>
-                  <a:srgbClr val="CFE0D6"/>
-                </a:solidFill>
-                <a:latin typeface="Arial"/>
-              </a:rPr>
-              <a:t> / 14</a:t>
             </a:r>
           </a:p>
         </p:txBody>
@@ -6659,21 +6806,79 @@
         </p:nvSpPr>
         <p:spPr>
           <a:xfrm>
-            <a:off x="11144825" y="6408000"/>
-            <a:ext cx="864000" cy="270000"/>
+            <a:off x="0" y="6757200"/>
+            <a:ext cx="12188825" cy="100800"/>
           </a:xfrm>
           <a:noFill/>
+          <a:prstGeom prst="rect">
+            <a:avLst/>
+          </a:prstGeom>
+          <a:solidFill>
+            <a:srgbClr val="122017"/>
+          </a:solidFill>
           <a:ln>
             <a:noFill/>
           </a:ln>
+        </p:spPr>
+        <p:txBody>
+          <a:bodyPr wrap="none">
+            <a:spAutoFit/>
+          </a:bodyPr>
+          <a:lstStyle/>
+          <a:p/>
+        </p:txBody>
+      </p:sp>
+      <p:sp>
+        <p:nvSpPr>
+          <p:cNvPr id="17" name="TextBox 16"/>
+          <p:cNvSpPr txBox="1"/>
+          <p:nvPr/>
+        </p:nvSpPr>
+        <p:spPr>
+          <a:xfrm>
+            <a:off x="0" y="6757200"/>
+            <a:ext cx="10447564" cy="100800"/>
+          </a:xfrm>
+          <a:noFill/>
+          <a:prstGeom prst="rect">
+            <a:avLst/>
+          </a:prstGeom>
           <a:solidFill>
-            <a:srgbClr val="23613F"/>
+            <a:srgbClr val="3A6B55"/>
           </a:solidFill>
-          <a:prstGeom prst="roundRect">
-            <a:avLst>
-              <a:gd name="adj" fmla="val 30000"/>
-            </a:avLst>
-          </a:prstGeom>
+          <a:ln>
+            <a:noFill/>
+          </a:ln>
+        </p:spPr>
+        <p:txBody>
+          <a:bodyPr wrap="none">
+            <a:spAutoFit/>
+          </a:bodyPr>
+          <a:lstStyle/>
+          <a:p/>
+        </p:txBody>
+      </p:sp>
+      <p:sp>
+        <p:nvSpPr>
+          <p:cNvPr id="18" name="TextBox 17"/>
+          <p:cNvSpPr txBox="1"/>
+          <p:nvPr/>
+        </p:nvSpPr>
+        <p:spPr>
+          <a:xfrm>
+            <a:off x="10285564" y="6645600"/>
+            <a:ext cx="324000" cy="324000"/>
+          </a:xfrm>
+          <a:noFill/>
+          <a:prstGeom prst="ellipse">
+            <a:avLst/>
+          </a:prstGeom>
+          <a:solidFill>
+            <a:srgbClr val="8BB29A"/>
+          </a:solidFill>
+          <a:ln>
+            <a:noFill/>
+          </a:ln>
         </p:spPr>
         <p:txBody>
           <a:bodyPr wrap="none" anchor="ctr">
@@ -6683,22 +6888,13 @@
           <a:p>
             <a:pPr algn="ctr"/>
             <a:r>
-              <a:rPr sz="1100" b="1">
+              <a:rPr sz="900" b="1">
                 <a:solidFill>
                   <a:srgbClr val="FFFFFF"/>
                 </a:solidFill>
                 <a:latin typeface="Arial"/>
               </a:rPr>
               <a:t>12</a:t>
-            </a:r>
-            <a:r>
-              <a:rPr sz="1000" b="0">
-                <a:solidFill>
-                  <a:srgbClr val="CFE0D6"/>
-                </a:solidFill>
-                <a:latin typeface="Arial"/>
-              </a:rPr>
-              <a:t> / 14</a:t>
             </a:r>
           </a:p>
         </p:txBody>
@@ -7068,21 +7264,79 @@
         </p:nvSpPr>
         <p:spPr>
           <a:xfrm>
-            <a:off x="11144825" y="6408000"/>
-            <a:ext cx="864000" cy="270000"/>
+            <a:off x="0" y="6757200"/>
+            <a:ext cx="12188825" cy="100800"/>
           </a:xfrm>
           <a:noFill/>
+          <a:prstGeom prst="rect">
+            <a:avLst/>
+          </a:prstGeom>
+          <a:solidFill>
+            <a:srgbClr val="122017"/>
+          </a:solidFill>
           <a:ln>
             <a:noFill/>
           </a:ln>
+        </p:spPr>
+        <p:txBody>
+          <a:bodyPr wrap="none">
+            <a:spAutoFit/>
+          </a:bodyPr>
+          <a:lstStyle/>
+          <a:p/>
+        </p:txBody>
+      </p:sp>
+      <p:sp>
+        <p:nvSpPr>
+          <p:cNvPr id="7" name="TextBox 6"/>
+          <p:cNvSpPr txBox="1"/>
+          <p:nvPr/>
+        </p:nvSpPr>
+        <p:spPr>
+          <a:xfrm>
+            <a:off x="0" y="6757200"/>
+            <a:ext cx="11318194" cy="100800"/>
+          </a:xfrm>
+          <a:noFill/>
+          <a:prstGeom prst="rect">
+            <a:avLst/>
+          </a:prstGeom>
           <a:solidFill>
-            <a:srgbClr val="23613F"/>
+            <a:srgbClr val="3A6B55"/>
           </a:solidFill>
-          <a:prstGeom prst="roundRect">
-            <a:avLst>
-              <a:gd name="adj" fmla="val 30000"/>
-            </a:avLst>
-          </a:prstGeom>
+          <a:ln>
+            <a:noFill/>
+          </a:ln>
+        </p:spPr>
+        <p:txBody>
+          <a:bodyPr wrap="none">
+            <a:spAutoFit/>
+          </a:bodyPr>
+          <a:lstStyle/>
+          <a:p/>
+        </p:txBody>
+      </p:sp>
+      <p:sp>
+        <p:nvSpPr>
+          <p:cNvPr id="8" name="TextBox 7"/>
+          <p:cNvSpPr txBox="1"/>
+          <p:nvPr/>
+        </p:nvSpPr>
+        <p:spPr>
+          <a:xfrm>
+            <a:off x="11156194" y="6645600"/>
+            <a:ext cx="324000" cy="324000"/>
+          </a:xfrm>
+          <a:noFill/>
+          <a:prstGeom prst="ellipse">
+            <a:avLst/>
+          </a:prstGeom>
+          <a:solidFill>
+            <a:srgbClr val="8BB29A"/>
+          </a:solidFill>
+          <a:ln>
+            <a:noFill/>
+          </a:ln>
         </p:spPr>
         <p:txBody>
           <a:bodyPr wrap="none" anchor="ctr">
@@ -7092,22 +7346,13 @@
           <a:p>
             <a:pPr algn="ctr"/>
             <a:r>
-              <a:rPr sz="1100" b="1">
+              <a:rPr sz="900" b="1">
                 <a:solidFill>
                   <a:srgbClr val="FFFFFF"/>
                 </a:solidFill>
                 <a:latin typeface="Arial"/>
               </a:rPr>
               <a:t>13</a:t>
-            </a:r>
-            <a:r>
-              <a:rPr sz="1000" b="0">
-                <a:solidFill>
-                  <a:srgbClr val="CFE0D6"/>
-                </a:solidFill>
-                <a:latin typeface="Arial"/>
-              </a:rPr>
-              <a:t> / 14</a:t>
             </a:r>
           </a:p>
         </p:txBody>
@@ -8302,21 +8547,79 @@
         </p:nvSpPr>
         <p:spPr>
           <a:xfrm>
-            <a:off x="11144825" y="6408000"/>
-            <a:ext cx="864000" cy="270000"/>
+            <a:off x="0" y="6757200"/>
+            <a:ext cx="12188825" cy="100800"/>
           </a:xfrm>
           <a:noFill/>
+          <a:prstGeom prst="rect">
+            <a:avLst/>
+          </a:prstGeom>
+          <a:solidFill>
+            <a:srgbClr val="122017"/>
+          </a:solidFill>
           <a:ln>
             <a:noFill/>
           </a:ln>
+        </p:spPr>
+        <p:txBody>
+          <a:bodyPr wrap="none">
+            <a:spAutoFit/>
+          </a:bodyPr>
+          <a:lstStyle/>
+          <a:p/>
+        </p:txBody>
+      </p:sp>
+      <p:sp>
+        <p:nvSpPr>
+          <p:cNvPr id="31" name="TextBox 30"/>
+          <p:cNvSpPr txBox="1"/>
+          <p:nvPr/>
+        </p:nvSpPr>
+        <p:spPr>
+          <a:xfrm>
+            <a:off x="0" y="6757200"/>
+            <a:ext cx="6965042" cy="100800"/>
+          </a:xfrm>
+          <a:noFill/>
+          <a:prstGeom prst="rect">
+            <a:avLst/>
+          </a:prstGeom>
           <a:solidFill>
-            <a:srgbClr val="23613F"/>
+            <a:srgbClr val="3A6B55"/>
           </a:solidFill>
-          <a:prstGeom prst="roundRect">
-            <a:avLst>
-              <a:gd name="adj" fmla="val 30000"/>
-            </a:avLst>
-          </a:prstGeom>
+          <a:ln>
+            <a:noFill/>
+          </a:ln>
+        </p:spPr>
+        <p:txBody>
+          <a:bodyPr wrap="none">
+            <a:spAutoFit/>
+          </a:bodyPr>
+          <a:lstStyle/>
+          <a:p/>
+        </p:txBody>
+      </p:sp>
+      <p:sp>
+        <p:nvSpPr>
+          <p:cNvPr id="32" name="TextBox 31"/>
+          <p:cNvSpPr txBox="1"/>
+          <p:nvPr/>
+        </p:nvSpPr>
+        <p:spPr>
+          <a:xfrm>
+            <a:off x="6803042" y="6645600"/>
+            <a:ext cx="324000" cy="324000"/>
+          </a:xfrm>
+          <a:noFill/>
+          <a:prstGeom prst="ellipse">
+            <a:avLst/>
+          </a:prstGeom>
+          <a:solidFill>
+            <a:srgbClr val="8BB29A"/>
+          </a:solidFill>
+          <a:ln>
+            <a:noFill/>
+          </a:ln>
         </p:spPr>
         <p:txBody>
           <a:bodyPr wrap="none" anchor="ctr">
@@ -8326,22 +8629,114 @@
           <a:p>
             <a:pPr algn="ctr"/>
             <a:r>
-              <a:rPr sz="1100" b="1">
+              <a:rPr sz="900" b="1">
                 <a:solidFill>
                   <a:srgbClr val="FFFFFF"/>
                 </a:solidFill>
                 <a:latin typeface="Arial"/>
               </a:rPr>
+              <a:t>8</a:t>
+            </a:r>
+          </a:p>
+        </p:txBody>
+      </p:sp>
+      <p:sp>
+        <p:nvSpPr>
+          <p:cNvPr id="33" name="TextBox 32"/>
+          <p:cNvSpPr txBox="1"/>
+          <p:nvPr/>
+        </p:nvSpPr>
+        <p:spPr>
+          <a:xfrm>
+            <a:off x="0" y="6757200"/>
+            <a:ext cx="12188825" cy="100800"/>
+          </a:xfrm>
+          <a:noFill/>
+          <a:prstGeom prst="rect">
+            <a:avLst/>
+          </a:prstGeom>
+          <a:solidFill>
+            <a:srgbClr val="122017"/>
+          </a:solidFill>
+          <a:ln>
+            <a:noFill/>
+          </a:ln>
+        </p:spPr>
+        <p:txBody>
+          <a:bodyPr wrap="none">
+            <a:spAutoFit/>
+          </a:bodyPr>
+          <a:lstStyle/>
+          <a:p/>
+        </p:txBody>
+      </p:sp>
+      <p:sp>
+        <p:nvSpPr>
+          <p:cNvPr id="34" name="TextBox 33"/>
+          <p:cNvSpPr txBox="1"/>
+          <p:nvPr/>
+        </p:nvSpPr>
+        <p:spPr>
+          <a:xfrm>
+            <a:off x="0" y="6757200"/>
+            <a:ext cx="12188825" cy="100800"/>
+          </a:xfrm>
+          <a:noFill/>
+          <a:prstGeom prst="rect">
+            <a:avLst/>
+          </a:prstGeom>
+          <a:solidFill>
+            <a:srgbClr val="3A6B55"/>
+          </a:solidFill>
+          <a:ln>
+            <a:noFill/>
+          </a:ln>
+        </p:spPr>
+        <p:txBody>
+          <a:bodyPr wrap="none">
+            <a:spAutoFit/>
+          </a:bodyPr>
+          <a:lstStyle/>
+          <a:p/>
+        </p:txBody>
+      </p:sp>
+      <p:sp>
+        <p:nvSpPr>
+          <p:cNvPr id="35" name="TextBox 34"/>
+          <p:cNvSpPr txBox="1"/>
+          <p:nvPr/>
+        </p:nvSpPr>
+        <p:spPr>
+          <a:xfrm>
+            <a:off x="11864825" y="6645600"/>
+            <a:ext cx="324000" cy="324000"/>
+          </a:xfrm>
+          <a:noFill/>
+          <a:prstGeom prst="ellipse">
+            <a:avLst/>
+          </a:prstGeom>
+          <a:solidFill>
+            <a:srgbClr val="8BB29A"/>
+          </a:solidFill>
+          <a:ln>
+            <a:noFill/>
+          </a:ln>
+        </p:spPr>
+        <p:txBody>
+          <a:bodyPr wrap="none" anchor="ctr">
+            <a:spAutoFit/>
+          </a:bodyPr>
+          <a:lstStyle/>
+          <a:p>
+            <a:pPr algn="ctr"/>
+            <a:r>
+              <a:rPr sz="900" b="1">
+                <a:solidFill>
+                  <a:srgbClr val="FFFFFF"/>
+                </a:solidFill>
+                <a:latin typeface="Arial"/>
+              </a:rPr>
               <a:t>14</a:t>
-            </a:r>
-            <a:r>
-              <a:rPr sz="1000" b="0">
-                <a:solidFill>
-                  <a:srgbClr val="CFE0D6"/>
-                </a:solidFill>
-                <a:latin typeface="Arial"/>
-              </a:rPr>
-              <a:t> / 14</a:t>
             </a:r>
           </a:p>
         </p:txBody>
@@ -9042,21 +9437,79 @@
         </p:nvSpPr>
         <p:spPr>
           <a:xfrm>
-            <a:off x="11144825" y="6408000"/>
-            <a:ext cx="864000" cy="270000"/>
+            <a:off x="0" y="6757200"/>
+            <a:ext cx="12188825" cy="100800"/>
           </a:xfrm>
           <a:noFill/>
+          <a:prstGeom prst="rect">
+            <a:avLst/>
+          </a:prstGeom>
+          <a:solidFill>
+            <a:srgbClr val="122017"/>
+          </a:solidFill>
           <a:ln>
             <a:noFill/>
           </a:ln>
+        </p:spPr>
+        <p:txBody>
+          <a:bodyPr wrap="none">
+            <a:spAutoFit/>
+          </a:bodyPr>
+          <a:lstStyle/>
+          <a:p/>
+        </p:txBody>
+      </p:sp>
+      <p:sp>
+        <p:nvSpPr>
+          <p:cNvPr id="20" name="TextBox 19"/>
+          <p:cNvSpPr txBox="1"/>
+          <p:nvPr/>
+        </p:nvSpPr>
+        <p:spPr>
+          <a:xfrm>
+            <a:off x="0" y="6757200"/>
+            <a:ext cx="1741260" cy="100800"/>
+          </a:xfrm>
+          <a:noFill/>
+          <a:prstGeom prst="rect">
+            <a:avLst/>
+          </a:prstGeom>
           <a:solidFill>
-            <a:srgbClr val="23613F"/>
+            <a:srgbClr val="3A6B55"/>
           </a:solidFill>
-          <a:prstGeom prst="roundRect">
-            <a:avLst>
-              <a:gd name="adj" fmla="val 30000"/>
-            </a:avLst>
-          </a:prstGeom>
+          <a:ln>
+            <a:noFill/>
+          </a:ln>
+        </p:spPr>
+        <p:txBody>
+          <a:bodyPr wrap="none">
+            <a:spAutoFit/>
+          </a:bodyPr>
+          <a:lstStyle/>
+          <a:p/>
+        </p:txBody>
+      </p:sp>
+      <p:sp>
+        <p:nvSpPr>
+          <p:cNvPr id="21" name="TextBox 20"/>
+          <p:cNvSpPr txBox="1"/>
+          <p:nvPr/>
+        </p:nvSpPr>
+        <p:spPr>
+          <a:xfrm>
+            <a:off x="1579260" y="6645600"/>
+            <a:ext cx="324000" cy="324000"/>
+          </a:xfrm>
+          <a:noFill/>
+          <a:prstGeom prst="ellipse">
+            <a:avLst/>
+          </a:prstGeom>
+          <a:solidFill>
+            <a:srgbClr val="8BB29A"/>
+          </a:solidFill>
+          <a:ln>
+            <a:noFill/>
+          </a:ln>
         </p:spPr>
         <p:txBody>
           <a:bodyPr wrap="none" anchor="ctr">
@@ -9066,22 +9519,13 @@
           <a:p>
             <a:pPr algn="ctr"/>
             <a:r>
-              <a:rPr sz="1100" b="1">
+              <a:rPr sz="900" b="1">
                 <a:solidFill>
                   <a:srgbClr val="FFFFFF"/>
                 </a:solidFill>
                 <a:latin typeface="Arial"/>
               </a:rPr>
               <a:t>2</a:t>
-            </a:r>
-            <a:r>
-              <a:rPr sz="1000" b="0">
-                <a:solidFill>
-                  <a:srgbClr val="CFE0D6"/>
-                </a:solidFill>
-                <a:latin typeface="Arial"/>
-              </a:rPr>
-              <a:t> / 14</a:t>
             </a:r>
           </a:p>
         </p:txBody>
@@ -9251,21 +9695,79 @@
         </p:nvSpPr>
         <p:spPr>
           <a:xfrm>
-            <a:off x="11144825" y="6408000"/>
-            <a:ext cx="864000" cy="270000"/>
+            <a:off x="0" y="6757200"/>
+            <a:ext cx="12188825" cy="100800"/>
           </a:xfrm>
           <a:noFill/>
+          <a:prstGeom prst="rect">
+            <a:avLst/>
+          </a:prstGeom>
+          <a:solidFill>
+            <a:srgbClr val="122017"/>
+          </a:solidFill>
           <a:ln>
             <a:noFill/>
           </a:ln>
+        </p:spPr>
+        <p:txBody>
+          <a:bodyPr wrap="none">
+            <a:spAutoFit/>
+          </a:bodyPr>
+          <a:lstStyle/>
+          <a:p/>
+        </p:txBody>
+      </p:sp>
+      <p:sp>
+        <p:nvSpPr>
+          <p:cNvPr id="7" name="TextBox 6"/>
+          <p:cNvSpPr txBox="1"/>
+          <p:nvPr/>
+        </p:nvSpPr>
+        <p:spPr>
+          <a:xfrm>
+            <a:off x="0" y="6757200"/>
+            <a:ext cx="2611891" cy="100800"/>
+          </a:xfrm>
+          <a:noFill/>
+          <a:prstGeom prst="rect">
+            <a:avLst/>
+          </a:prstGeom>
           <a:solidFill>
-            <a:srgbClr val="23613F"/>
+            <a:srgbClr val="3A6B55"/>
           </a:solidFill>
-          <a:prstGeom prst="roundRect">
-            <a:avLst>
-              <a:gd name="adj" fmla="val 30000"/>
-            </a:avLst>
-          </a:prstGeom>
+          <a:ln>
+            <a:noFill/>
+          </a:ln>
+        </p:spPr>
+        <p:txBody>
+          <a:bodyPr wrap="none">
+            <a:spAutoFit/>
+          </a:bodyPr>
+          <a:lstStyle/>
+          <a:p/>
+        </p:txBody>
+      </p:sp>
+      <p:sp>
+        <p:nvSpPr>
+          <p:cNvPr id="8" name="TextBox 7"/>
+          <p:cNvSpPr txBox="1"/>
+          <p:nvPr/>
+        </p:nvSpPr>
+        <p:spPr>
+          <a:xfrm>
+            <a:off x="2449891" y="6645600"/>
+            <a:ext cx="324000" cy="324000"/>
+          </a:xfrm>
+          <a:noFill/>
+          <a:prstGeom prst="ellipse">
+            <a:avLst/>
+          </a:prstGeom>
+          <a:solidFill>
+            <a:srgbClr val="8BB29A"/>
+          </a:solidFill>
+          <a:ln>
+            <a:noFill/>
+          </a:ln>
         </p:spPr>
         <p:txBody>
           <a:bodyPr wrap="none" anchor="ctr">
@@ -9275,22 +9777,13 @@
           <a:p>
             <a:pPr algn="ctr"/>
             <a:r>
-              <a:rPr sz="1100" b="1">
+              <a:rPr sz="900" b="1">
                 <a:solidFill>
                   <a:srgbClr val="FFFFFF"/>
                 </a:solidFill>
                 <a:latin typeface="Arial"/>
               </a:rPr>
               <a:t>3</a:t>
-            </a:r>
-            <a:r>
-              <a:rPr sz="1000" b="0">
-                <a:solidFill>
-                  <a:srgbClr val="CFE0D6"/>
-                </a:solidFill>
-                <a:latin typeface="Arial"/>
-              </a:rPr>
-              <a:t> / 14</a:t>
             </a:r>
           </a:p>
         </p:txBody>
@@ -9752,21 +10245,79 @@
         </p:nvSpPr>
         <p:spPr>
           <a:xfrm>
-            <a:off x="11144825" y="6408000"/>
-            <a:ext cx="864000" cy="270000"/>
+            <a:off x="0" y="6757200"/>
+            <a:ext cx="12188825" cy="100800"/>
           </a:xfrm>
           <a:noFill/>
+          <a:prstGeom prst="rect">
+            <a:avLst/>
+          </a:prstGeom>
+          <a:solidFill>
+            <a:srgbClr val="122017"/>
+          </a:solidFill>
           <a:ln>
             <a:noFill/>
           </a:ln>
+        </p:spPr>
+        <p:txBody>
+          <a:bodyPr wrap="none">
+            <a:spAutoFit/>
+          </a:bodyPr>
+          <a:lstStyle/>
+          <a:p/>
+        </p:txBody>
+      </p:sp>
+      <p:sp>
+        <p:nvSpPr>
+          <p:cNvPr id="14" name="TextBox 13"/>
+          <p:cNvSpPr txBox="1"/>
+          <p:nvPr/>
+        </p:nvSpPr>
+        <p:spPr>
+          <a:xfrm>
+            <a:off x="0" y="6757200"/>
+            <a:ext cx="3482521" cy="100800"/>
+          </a:xfrm>
+          <a:noFill/>
+          <a:prstGeom prst="rect">
+            <a:avLst/>
+          </a:prstGeom>
           <a:solidFill>
-            <a:srgbClr val="23613F"/>
+            <a:srgbClr val="3A6B55"/>
           </a:solidFill>
-          <a:prstGeom prst="roundRect">
-            <a:avLst>
-              <a:gd name="adj" fmla="val 30000"/>
-            </a:avLst>
-          </a:prstGeom>
+          <a:ln>
+            <a:noFill/>
+          </a:ln>
+        </p:spPr>
+        <p:txBody>
+          <a:bodyPr wrap="none">
+            <a:spAutoFit/>
+          </a:bodyPr>
+          <a:lstStyle/>
+          <a:p/>
+        </p:txBody>
+      </p:sp>
+      <p:sp>
+        <p:nvSpPr>
+          <p:cNvPr id="15" name="TextBox 14"/>
+          <p:cNvSpPr txBox="1"/>
+          <p:nvPr/>
+        </p:nvSpPr>
+        <p:spPr>
+          <a:xfrm>
+            <a:off x="3320521" y="6645600"/>
+            <a:ext cx="324000" cy="324000"/>
+          </a:xfrm>
+          <a:noFill/>
+          <a:prstGeom prst="ellipse">
+            <a:avLst/>
+          </a:prstGeom>
+          <a:solidFill>
+            <a:srgbClr val="8BB29A"/>
+          </a:solidFill>
+          <a:ln>
+            <a:noFill/>
+          </a:ln>
         </p:spPr>
         <p:txBody>
           <a:bodyPr wrap="none" anchor="ctr">
@@ -9776,22 +10327,13 @@
           <a:p>
             <a:pPr algn="ctr"/>
             <a:r>
-              <a:rPr sz="1100" b="1">
+              <a:rPr sz="900" b="1">
                 <a:solidFill>
                   <a:srgbClr val="FFFFFF"/>
                 </a:solidFill>
                 <a:latin typeface="Arial"/>
               </a:rPr>
               <a:t>4</a:t>
-            </a:r>
-            <a:r>
-              <a:rPr sz="1000" b="0">
-                <a:solidFill>
-                  <a:srgbClr val="CFE0D6"/>
-                </a:solidFill>
-                <a:latin typeface="Arial"/>
-              </a:rPr>
-              <a:t> / 14</a:t>
             </a:r>
           </a:p>
         </p:txBody>
@@ -12423,21 +12965,79 @@
         </p:nvSpPr>
         <p:spPr>
           <a:xfrm>
-            <a:off x="11144825" y="6408000"/>
-            <a:ext cx="864000" cy="270000"/>
+            <a:off x="0" y="6757200"/>
+            <a:ext cx="12188825" cy="100800"/>
           </a:xfrm>
           <a:noFill/>
+          <a:prstGeom prst="rect">
+            <a:avLst/>
+          </a:prstGeom>
+          <a:solidFill>
+            <a:srgbClr val="122017"/>
+          </a:solidFill>
           <a:ln>
             <a:noFill/>
           </a:ln>
+        </p:spPr>
+        <p:txBody>
+          <a:bodyPr wrap="none">
+            <a:spAutoFit/>
+          </a:bodyPr>
+          <a:lstStyle/>
+          <a:p/>
+        </p:txBody>
+      </p:sp>
+      <p:sp>
+        <p:nvSpPr>
+          <p:cNvPr id="6" name="TextBox 5"/>
+          <p:cNvSpPr txBox="1"/>
+          <p:nvPr/>
+        </p:nvSpPr>
+        <p:spPr>
+          <a:xfrm>
+            <a:off x="0" y="6757200"/>
+            <a:ext cx="4353151" cy="100800"/>
+          </a:xfrm>
+          <a:noFill/>
+          <a:prstGeom prst="rect">
+            <a:avLst/>
+          </a:prstGeom>
           <a:solidFill>
-            <a:srgbClr val="23613F"/>
+            <a:srgbClr val="3A6B55"/>
           </a:solidFill>
-          <a:prstGeom prst="roundRect">
-            <a:avLst>
-              <a:gd name="adj" fmla="val 30000"/>
-            </a:avLst>
-          </a:prstGeom>
+          <a:ln>
+            <a:noFill/>
+          </a:ln>
+        </p:spPr>
+        <p:txBody>
+          <a:bodyPr wrap="none">
+            <a:spAutoFit/>
+          </a:bodyPr>
+          <a:lstStyle/>
+          <a:p/>
+        </p:txBody>
+      </p:sp>
+      <p:sp>
+        <p:nvSpPr>
+          <p:cNvPr id="7" name="TextBox 6"/>
+          <p:cNvSpPr txBox="1"/>
+          <p:nvPr/>
+        </p:nvSpPr>
+        <p:spPr>
+          <a:xfrm>
+            <a:off x="4191151" y="6645600"/>
+            <a:ext cx="324000" cy="324000"/>
+          </a:xfrm>
+          <a:noFill/>
+          <a:prstGeom prst="ellipse">
+            <a:avLst/>
+          </a:prstGeom>
+          <a:solidFill>
+            <a:srgbClr val="8BB29A"/>
+          </a:solidFill>
+          <a:ln>
+            <a:noFill/>
+          </a:ln>
         </p:spPr>
         <p:txBody>
           <a:bodyPr wrap="none" anchor="ctr">
@@ -12447,22 +13047,13 @@
           <a:p>
             <a:pPr algn="ctr"/>
             <a:r>
-              <a:rPr sz="1100" b="1">
+              <a:rPr sz="900" b="1">
                 <a:solidFill>
                   <a:srgbClr val="FFFFFF"/>
                 </a:solidFill>
                 <a:latin typeface="Arial"/>
               </a:rPr>
               <a:t>5</a:t>
-            </a:r>
-            <a:r>
-              <a:rPr sz="1000" b="0">
-                <a:solidFill>
-                  <a:srgbClr val="CFE0D6"/>
-                </a:solidFill>
-                <a:latin typeface="Arial"/>
-              </a:rPr>
-              <a:t> / 14</a:t>
             </a:r>
           </a:p>
         </p:txBody>
@@ -13435,21 +14026,79 @@
         </p:nvSpPr>
         <p:spPr>
           <a:xfrm>
-            <a:off x="11144825" y="6408000"/>
-            <a:ext cx="864000" cy="270000"/>
+            <a:off x="0" y="6757200"/>
+            <a:ext cx="12188825" cy="100800"/>
           </a:xfrm>
           <a:noFill/>
+          <a:prstGeom prst="rect">
+            <a:avLst/>
+          </a:prstGeom>
+          <a:solidFill>
+            <a:srgbClr val="122017"/>
+          </a:solidFill>
           <a:ln>
             <a:noFill/>
           </a:ln>
+        </p:spPr>
+        <p:txBody>
+          <a:bodyPr wrap="none">
+            <a:spAutoFit/>
+          </a:bodyPr>
+          <a:lstStyle/>
+          <a:p/>
+        </p:txBody>
+      </p:sp>
+      <p:sp>
+        <p:nvSpPr>
+          <p:cNvPr id="27" name="TextBox 26"/>
+          <p:cNvSpPr txBox="1"/>
+          <p:nvPr/>
+        </p:nvSpPr>
+        <p:spPr>
+          <a:xfrm>
+            <a:off x="0" y="6757200"/>
+            <a:ext cx="5223782" cy="100800"/>
+          </a:xfrm>
+          <a:noFill/>
+          <a:prstGeom prst="rect">
+            <a:avLst/>
+          </a:prstGeom>
           <a:solidFill>
-            <a:srgbClr val="23613F"/>
+            <a:srgbClr val="3A6B55"/>
           </a:solidFill>
-          <a:prstGeom prst="roundRect">
-            <a:avLst>
-              <a:gd name="adj" fmla="val 30000"/>
-            </a:avLst>
-          </a:prstGeom>
+          <a:ln>
+            <a:noFill/>
+          </a:ln>
+        </p:spPr>
+        <p:txBody>
+          <a:bodyPr wrap="none">
+            <a:spAutoFit/>
+          </a:bodyPr>
+          <a:lstStyle/>
+          <a:p/>
+        </p:txBody>
+      </p:sp>
+      <p:sp>
+        <p:nvSpPr>
+          <p:cNvPr id="28" name="TextBox 27"/>
+          <p:cNvSpPr txBox="1"/>
+          <p:nvPr/>
+        </p:nvSpPr>
+        <p:spPr>
+          <a:xfrm>
+            <a:off x="5061782" y="6645600"/>
+            <a:ext cx="324000" cy="324000"/>
+          </a:xfrm>
+          <a:noFill/>
+          <a:prstGeom prst="ellipse">
+            <a:avLst/>
+          </a:prstGeom>
+          <a:solidFill>
+            <a:srgbClr val="8BB29A"/>
+          </a:solidFill>
+          <a:ln>
+            <a:noFill/>
+          </a:ln>
         </p:spPr>
         <p:txBody>
           <a:bodyPr wrap="none" anchor="ctr">
@@ -13459,22 +14108,13 @@
           <a:p>
             <a:pPr algn="ctr"/>
             <a:r>
-              <a:rPr sz="1100" b="1">
+              <a:rPr sz="900" b="1">
                 <a:solidFill>
                   <a:srgbClr val="FFFFFF"/>
                 </a:solidFill>
                 <a:latin typeface="Arial"/>
               </a:rPr>
               <a:t>6</a:t>
-            </a:r>
-            <a:r>
-              <a:rPr sz="1000" b="0">
-                <a:solidFill>
-                  <a:srgbClr val="CFE0D6"/>
-                </a:solidFill>
-                <a:latin typeface="Arial"/>
-              </a:rPr>
-              <a:t> / 14</a:t>
             </a:r>
           </a:p>
         </p:txBody>
@@ -14326,21 +14966,79 @@
         </p:nvSpPr>
         <p:spPr>
           <a:xfrm>
-            <a:off x="11144825" y="6408000"/>
-            <a:ext cx="864000" cy="270000"/>
+            <a:off x="0" y="6757200"/>
+            <a:ext cx="12188825" cy="100800"/>
           </a:xfrm>
           <a:noFill/>
+          <a:prstGeom prst="rect">
+            <a:avLst/>
+          </a:prstGeom>
+          <a:solidFill>
+            <a:srgbClr val="122017"/>
+          </a:solidFill>
           <a:ln>
             <a:noFill/>
           </a:ln>
+        </p:spPr>
+        <p:txBody>
+          <a:bodyPr wrap="none">
+            <a:spAutoFit/>
+          </a:bodyPr>
+          <a:lstStyle/>
+          <a:p/>
+        </p:txBody>
+      </p:sp>
+      <p:sp>
+        <p:nvSpPr>
+          <p:cNvPr id="13" name="TextBox 12"/>
+          <p:cNvSpPr txBox="1"/>
+          <p:nvPr/>
+        </p:nvSpPr>
+        <p:spPr>
+          <a:xfrm>
+            <a:off x="0" y="6757200"/>
+            <a:ext cx="6094412" cy="100800"/>
+          </a:xfrm>
+          <a:noFill/>
+          <a:prstGeom prst="rect">
+            <a:avLst/>
+          </a:prstGeom>
           <a:solidFill>
-            <a:srgbClr val="23613F"/>
+            <a:srgbClr val="3A6B55"/>
           </a:solidFill>
-          <a:prstGeom prst="roundRect">
-            <a:avLst>
-              <a:gd name="adj" fmla="val 30000"/>
-            </a:avLst>
-          </a:prstGeom>
+          <a:ln>
+            <a:noFill/>
+          </a:ln>
+        </p:spPr>
+        <p:txBody>
+          <a:bodyPr wrap="none">
+            <a:spAutoFit/>
+          </a:bodyPr>
+          <a:lstStyle/>
+          <a:p/>
+        </p:txBody>
+      </p:sp>
+      <p:sp>
+        <p:nvSpPr>
+          <p:cNvPr id="14" name="TextBox 13"/>
+          <p:cNvSpPr txBox="1"/>
+          <p:nvPr/>
+        </p:nvSpPr>
+        <p:spPr>
+          <a:xfrm>
+            <a:off x="5932412" y="6645600"/>
+            <a:ext cx="324000" cy="324000"/>
+          </a:xfrm>
+          <a:noFill/>
+          <a:prstGeom prst="ellipse">
+            <a:avLst/>
+          </a:prstGeom>
+          <a:solidFill>
+            <a:srgbClr val="8BB29A"/>
+          </a:solidFill>
+          <a:ln>
+            <a:noFill/>
+          </a:ln>
         </p:spPr>
         <p:txBody>
           <a:bodyPr wrap="none" anchor="ctr">
@@ -14350,22 +15048,13 @@
           <a:p>
             <a:pPr algn="ctr"/>
             <a:r>
-              <a:rPr sz="1100" b="1">
+              <a:rPr sz="900" b="1">
                 <a:solidFill>
                   <a:srgbClr val="FFFFFF"/>
                 </a:solidFill>
                 <a:latin typeface="Arial"/>
               </a:rPr>
               <a:t>7</a:t>
-            </a:r>
-            <a:r>
-              <a:rPr sz="1000" b="0">
-                <a:solidFill>
-                  <a:srgbClr val="CFE0D6"/>
-                </a:solidFill>
-                <a:latin typeface="Arial"/>
-              </a:rPr>
-              <a:t> / 14</a:t>
             </a:r>
           </a:p>
         </p:txBody>
@@ -14964,21 +15653,79 @@
         </p:nvSpPr>
         <p:spPr>
           <a:xfrm>
-            <a:off x="11144825" y="6408000"/>
-            <a:ext cx="864000" cy="270000"/>
+            <a:off x="0" y="6757200"/>
+            <a:ext cx="12188825" cy="100800"/>
           </a:xfrm>
           <a:noFill/>
+          <a:prstGeom prst="rect">
+            <a:avLst/>
+          </a:prstGeom>
+          <a:solidFill>
+            <a:srgbClr val="122017"/>
+          </a:solidFill>
           <a:ln>
             <a:noFill/>
           </a:ln>
+        </p:spPr>
+        <p:txBody>
+          <a:bodyPr wrap="none">
+            <a:spAutoFit/>
+          </a:bodyPr>
+          <a:lstStyle/>
+          <a:p/>
+        </p:txBody>
+      </p:sp>
+      <p:sp>
+        <p:nvSpPr>
+          <p:cNvPr id="17" name="TextBox 16"/>
+          <p:cNvSpPr txBox="1"/>
+          <p:nvPr/>
+        </p:nvSpPr>
+        <p:spPr>
+          <a:xfrm>
+            <a:off x="0" y="6757200"/>
+            <a:ext cx="7835673" cy="100800"/>
+          </a:xfrm>
+          <a:noFill/>
+          <a:prstGeom prst="rect">
+            <a:avLst/>
+          </a:prstGeom>
           <a:solidFill>
-            <a:srgbClr val="23613F"/>
+            <a:srgbClr val="3A6B55"/>
           </a:solidFill>
-          <a:prstGeom prst="roundRect">
-            <a:avLst>
-              <a:gd name="adj" fmla="val 30000"/>
-            </a:avLst>
-          </a:prstGeom>
+          <a:ln>
+            <a:noFill/>
+          </a:ln>
+        </p:spPr>
+        <p:txBody>
+          <a:bodyPr wrap="none">
+            <a:spAutoFit/>
+          </a:bodyPr>
+          <a:lstStyle/>
+          <a:p/>
+        </p:txBody>
+      </p:sp>
+      <p:sp>
+        <p:nvSpPr>
+          <p:cNvPr id="18" name="TextBox 17"/>
+          <p:cNvSpPr txBox="1"/>
+          <p:nvPr/>
+        </p:nvSpPr>
+        <p:spPr>
+          <a:xfrm>
+            <a:off x="7673673" y="6645600"/>
+            <a:ext cx="324000" cy="324000"/>
+          </a:xfrm>
+          <a:noFill/>
+          <a:prstGeom prst="ellipse">
+            <a:avLst/>
+          </a:prstGeom>
+          <a:solidFill>
+            <a:srgbClr val="8BB29A"/>
+          </a:solidFill>
+          <a:ln>
+            <a:noFill/>
+          </a:ln>
         </p:spPr>
         <p:txBody>
           <a:bodyPr wrap="none" anchor="ctr">
@@ -14988,22 +15735,13 @@
           <a:p>
             <a:pPr algn="ctr"/>
             <a:r>
-              <a:rPr sz="1100" b="1">
+              <a:rPr sz="900" b="1">
                 <a:solidFill>
                   <a:srgbClr val="FFFFFF"/>
                 </a:solidFill>
                 <a:latin typeface="Arial"/>
               </a:rPr>
               <a:t>9</a:t>
-            </a:r>
-            <a:r>
-              <a:rPr sz="1000" b="0">
-                <a:solidFill>
-                  <a:srgbClr val="CFE0D6"/>
-                </a:solidFill>
-                <a:latin typeface="Arial"/>
-              </a:rPr>
-              <a:t> / 14</a:t>
             </a:r>
           </a:p>
         </p:txBody>

</xml_diff>

<commit_message>
fix(presentation): repair corrupted PPTX (duplicate slide14.xml)
Root cause: adding a new slide after delete caused python-pptx to assign
slide14.xml to the new part while the original slide14.xml was still in
use — creating a duplicate entry in sldIdLst and two ZIP entries with the
same name, which PowerPoint refused to open.

Fix (direct ZIP surgery):
- Moved Результаты to slide15.xml (new unique part)
- Updated presentation.xml.rels: rId14 → slides/slide15.xml
- Fixed sldIdLst: changed duplicate rId6 at position 14 → rId14
- Added [Content_Types].xml entry for slide15.xml
- Repacked ZIP without duplicates

Slide 8 (ER-diagram) stays at slide14.xml; Slide 14 (Результаты) at slide15.xml.

https://claude.ai/code/session_01JXZNXE9oVEv7rsUiTvXR5D
</commit_message>
<xml_diff>
--- a/docs/Визуализация науки на основе метаданных публикаций и журналов.pptx
+++ b/docs/Визуализация науки на основе метаданных публикаций и журналов.pptx
@@ -21,7 +21,7 @@
     <p:sldId id="263" r:id="rId11"/>
     <p:sldId id="264" r:id="rId12"/>
     <p:sldId id="265" r:id="rId13"/>
-    <p:sldId id="266" r:id="rId14"/>
+    <p:sldId id="272" r:id="rId14"/>
   </p:sldIdLst>
   <p:sldSz cx="12188825" cy="6858000"/>
   <p:notesSz cx="6858000" cy="9144000"/>
@@ -7465,7 +7465,7 @@
       </p:sp>
       <p:sp>
         <p:nvSpPr>
-          <p:cNvPr id="4" name="TextBox 3"/>
+          <p:cNvPr id="100" name="sp0"/>
           <p:cNvSpPr txBox="1"/>
           <p:nvPr/>
         </p:nvSpPr>
@@ -7478,15 +7478,17 @@
             <a:avLst/>
           </a:prstGeom>
           <a:noFill/>
-        </p:spPr>
-        <p:txBody>
-          <a:bodyPr wrap="none">
-            <a:spAutoFit/>
-          </a:bodyPr>
-          <a:lstStyle/>
-          <a:p>
-            <a:r>
-              <a:rPr sz="2200" b="1">
+          <a:ln>
+            <a:noFill/>
+          </a:ln>
+        </p:spPr>
+        <p:txBody>
+          <a:bodyPr wrap="square" anchor="ctr"/>
+          <a:lstStyle/>
+          <a:p>
+            <a:pPr algn="l"/>
+            <a:r>
+              <a:rPr lang="ru-RU" sz="2000" b="1">
                 <a:solidFill>
                   <a:srgbClr val="FFFFFF"/>
                 </a:solidFill>
@@ -7498,32 +7500,34 @@
       </p:sp>
       <p:sp>
         <p:nvSpPr>
-          <p:cNvPr id="5" name="TextBox 4"/>
+          <p:cNvPr id="101" name="sp1"/>
           <p:cNvSpPr txBox="1"/>
           <p:nvPr/>
         </p:nvSpPr>
         <p:spPr>
           <a:xfrm>
-            <a:off x="4860000" y="1080000"/>
-            <a:ext cx="2232000" cy="288000"/>
-          </a:xfrm>
-          <a:prstGeom prst="rect">
-            <a:avLst/>
-          </a:prstGeom>
-          <a:noFill/>
+            <a:off x="4968000" y="1080000"/>
+            <a:ext cx="2160000" cy="270000"/>
+          </a:xfrm>
+          <a:prstGeom prst="roundRect">
+            <a:avLst>
+              <a:gd name="adj" fmla="val 20000"/>
+            </a:avLst>
+          </a:prstGeom>
           <a:solidFill>
             <a:srgbClr val="1A5276"/>
           </a:solidFill>
-        </p:spPr>
-        <p:txBody>
-          <a:bodyPr wrap="none">
-            <a:spAutoFit/>
-          </a:bodyPr>
+          <a:ln>
+            <a:noFill/>
+          </a:ln>
+        </p:spPr>
+        <p:txBody>
+          <a:bodyPr wrap="square" anchor="ctr"/>
           <a:lstStyle/>
           <a:p>
             <a:pPr algn="ctr"/>
             <a:r>
-              <a:rPr sz="1100" b="1">
+              <a:rPr lang="ru-RU" sz="1000" b="1">
                 <a:solidFill>
                   <a:srgbClr val="FFFFFF"/>
                 </a:solidFill>
@@ -7535,610 +7539,568 @@
       </p:sp>
       <p:sp>
         <p:nvSpPr>
-          <p:cNvPr id="6" name="TextBox 5"/>
+          <p:cNvPr id="102" name="sp2"/>
           <p:cNvSpPr txBox="1"/>
           <p:nvPr/>
         </p:nvSpPr>
         <p:spPr>
           <a:xfrm>
-            <a:off x="4860000" y="1386000"/>
-            <a:ext cx="2232000" cy="846000"/>
-          </a:xfrm>
-          <a:prstGeom prst="rect">
-            <a:avLst/>
-          </a:prstGeom>
-          <a:noFill/>
+            <a:off x="4968000" y="1350000"/>
+            <a:ext cx="2160000" cy="810000"/>
+          </a:xfrm>
+          <a:prstGeom prst="rect">
+            <a:avLst/>
+          </a:prstGeom>
+          <a:solidFill>
+            <a:srgbClr val="F0F4F8"/>
+          </a:solidFill>
           <a:ln w="12700">
             <a:solidFill>
               <a:srgbClr val="1A5276"/>
             </a:solidFill>
           </a:ln>
+        </p:spPr>
+        <p:txBody>
+          <a:bodyPr wrap="square" anchor="ctr"/>
+          <a:lstStyle/>
+          <a:p>
+            <a:pPr algn="l"/>
+            <a:r>
+              <a:rPr lang="ru-RU" sz="900" b="0">
+                <a:solidFill>
+                  <a:srgbClr val="222222"/>
+                </a:solidFill>
+              </a:rPr>
+              <a:t>openalex_id</a:t>
+            </a:r>
+          </a:p>
+          <a:p>
+            <a:pPr algn="l"/>
+            <a:r>
+              <a:rPr lang="ru-RU" sz="900" b="0">
+                <a:solidFill>
+                  <a:srgbClr val="222222"/>
+                </a:solidFill>
+              </a:rPr>
+              <a:t>name · issn</a:t>
+            </a:r>
+          </a:p>
+        </p:txBody>
+      </p:sp>
+      <p:sp>
+        <p:nvSpPr>
+          <p:cNvPr id="103" name="sp3"/>
+          <p:cNvSpPr txBox="1"/>
+          <p:nvPr/>
+        </p:nvSpPr>
+        <p:spPr>
+          <a:xfrm>
+            <a:off x="4968000" y="2700000"/>
+            <a:ext cx="2160000" cy="270000"/>
+          </a:xfrm>
+          <a:prstGeom prst="roundRect">
+            <a:avLst>
+              <a:gd name="adj" fmla="val 20000"/>
+            </a:avLst>
+          </a:prstGeom>
+          <a:solidFill>
+            <a:srgbClr val="154360"/>
+          </a:solidFill>
+          <a:ln>
+            <a:noFill/>
+          </a:ln>
+        </p:spPr>
+        <p:txBody>
+          <a:bodyPr wrap="square" anchor="ctr"/>
+          <a:lstStyle/>
+          <a:p>
+            <a:pPr algn="ctr"/>
+            <a:r>
+              <a:rPr lang="ru-RU" sz="1000" b="1">
+                <a:solidFill>
+                  <a:srgbClr val="FFFFFF"/>
+                </a:solidFill>
+              </a:rPr>
+              <a:t>publications</a:t>
+            </a:r>
+          </a:p>
+        </p:txBody>
+      </p:sp>
+      <p:sp>
+        <p:nvSpPr>
+          <p:cNvPr id="104" name="sp4"/>
+          <p:cNvSpPr txBox="1"/>
+          <p:nvPr/>
+        </p:nvSpPr>
+        <p:spPr>
+          <a:xfrm>
+            <a:off x="4968000" y="2970000"/>
+            <a:ext cx="2160000" cy="810000"/>
+          </a:xfrm>
+          <a:prstGeom prst="rect">
+            <a:avLst/>
+          </a:prstGeom>
           <a:solidFill>
             <a:srgbClr val="F0F4F8"/>
           </a:solidFill>
-        </p:spPr>
-        <p:txBody>
-          <a:bodyPr wrap="square">
-            <a:spAutoFit/>
-          </a:bodyPr>
-          <a:lstStyle/>
-          <a:p>
-            <a:pPr algn="l"/>
-            <a:r>
-              <a:rPr sz="900">
-                <a:solidFill>
-                  <a:srgbClr val="222222"/>
-                </a:solidFill>
-              </a:rPr>
-              <a:t>openalex_id</a:t>
-            </a:r>
-          </a:p>
-          <a:p>
-            <a:pPr algn="l"/>
-            <a:r>
-              <a:rPr sz="900">
-                <a:solidFill>
-                  <a:srgbClr val="222222"/>
-                </a:solidFill>
-              </a:rPr>
-              <a:t>name</a:t>
-            </a:r>
-          </a:p>
-          <a:p>
-            <a:pPr algn="l"/>
-            <a:r>
-              <a:rPr sz="900">
-                <a:solidFill>
-                  <a:srgbClr val="222222"/>
-                </a:solidFill>
-              </a:rPr>
-              <a:t>issn</a:t>
-            </a:r>
-          </a:p>
-        </p:txBody>
-      </p:sp>
-      <p:sp>
-        <p:nvSpPr>
-          <p:cNvPr id="7" name="TextBox 6"/>
-          <p:cNvSpPr txBox="1"/>
-          <p:nvPr/>
-        </p:nvSpPr>
-        <p:spPr>
-          <a:xfrm>
-            <a:off x="4860000" y="2700000"/>
-            <a:ext cx="2232000" cy="288000"/>
-          </a:xfrm>
-          <a:prstGeom prst="rect">
-            <a:avLst/>
-          </a:prstGeom>
-          <a:noFill/>
-          <a:solidFill>
-            <a:srgbClr val="154360"/>
-          </a:solidFill>
-        </p:spPr>
-        <p:txBody>
-          <a:bodyPr wrap="none">
-            <a:spAutoFit/>
-          </a:bodyPr>
-          <a:lstStyle/>
-          <a:p>
-            <a:pPr algn="ctr"/>
-            <a:r>
-              <a:rPr sz="1100" b="1">
-                <a:solidFill>
-                  <a:srgbClr val="FFFFFF"/>
-                </a:solidFill>
-              </a:rPr>
-              <a:t>publications</a:t>
-            </a:r>
-          </a:p>
-        </p:txBody>
-      </p:sp>
-      <p:sp>
-        <p:nvSpPr>
-          <p:cNvPr id="8" name="TextBox 7"/>
-          <p:cNvSpPr txBox="1"/>
-          <p:nvPr/>
-        </p:nvSpPr>
-        <p:spPr>
-          <a:xfrm>
-            <a:off x="4860000" y="3006000"/>
-            <a:ext cx="2232000" cy="846000"/>
-          </a:xfrm>
-          <a:prstGeom prst="rect">
-            <a:avLst/>
-          </a:prstGeom>
-          <a:noFill/>
           <a:ln w="12700">
             <a:solidFill>
               <a:srgbClr val="154360"/>
             </a:solidFill>
           </a:ln>
+        </p:spPr>
+        <p:txBody>
+          <a:bodyPr wrap="square" anchor="ctr"/>
+          <a:lstStyle/>
+          <a:p>
+            <a:pPr algn="l"/>
+            <a:r>
+              <a:rPr lang="ru-RU" sz="900" b="0">
+                <a:solidFill>
+                  <a:srgbClr val="222222"/>
+                </a:solidFill>
+              </a:rPr>
+              <a:t>id · title · doi</a:t>
+            </a:r>
+          </a:p>
+          <a:p>
+            <a:pPr algn="l"/>
+            <a:r>
+              <a:rPr lang="ru-RU" sz="900" b="0">
+                <a:solidFill>
+                  <a:srgbClr val="222222"/>
+                </a:solidFill>
+              </a:rPr>
+              <a:t>year · journal_id →</a:t>
+            </a:r>
+          </a:p>
+        </p:txBody>
+      </p:sp>
+      <p:sp>
+        <p:nvSpPr>
+          <p:cNvPr id="105" name="sp5"/>
+          <p:cNvSpPr txBox="1"/>
+          <p:nvPr/>
+        </p:nvSpPr>
+        <p:spPr>
+          <a:xfrm>
+            <a:off x="8100000" y="2700000"/>
+            <a:ext cx="2160000" cy="270000"/>
+          </a:xfrm>
+          <a:prstGeom prst="roundRect">
+            <a:avLst>
+              <a:gd name="adj" fmla="val 20000"/>
+            </a:avLst>
+          </a:prstGeom>
+          <a:solidFill>
+            <a:srgbClr val="1A5C3A"/>
+          </a:solidFill>
+          <a:ln>
+            <a:noFill/>
+          </a:ln>
+        </p:spPr>
+        <p:txBody>
+          <a:bodyPr wrap="square" anchor="ctr"/>
+          <a:lstStyle/>
+          <a:p>
+            <a:pPr algn="ctr"/>
+            <a:r>
+              <a:rPr lang="ru-RU" sz="1000" b="1">
+                <a:solidFill>
+                  <a:srgbClr val="FFFFFF"/>
+                </a:solidFill>
+              </a:rPr>
+              <a:t>publication_authors</a:t>
+            </a:r>
+          </a:p>
+        </p:txBody>
+      </p:sp>
+      <p:sp>
+        <p:nvSpPr>
+          <p:cNvPr id="106" name="sp6"/>
+          <p:cNvSpPr txBox="1"/>
+          <p:nvPr/>
+        </p:nvSpPr>
+        <p:spPr>
+          <a:xfrm>
+            <a:off x="8100000" y="2970000"/>
+            <a:ext cx="2160000" cy="810000"/>
+          </a:xfrm>
+          <a:prstGeom prst="rect">
+            <a:avLst/>
+          </a:prstGeom>
           <a:solidFill>
             <a:srgbClr val="F0F4F8"/>
           </a:solidFill>
-        </p:spPr>
-        <p:txBody>
-          <a:bodyPr wrap="square">
-            <a:spAutoFit/>
-          </a:bodyPr>
-          <a:lstStyle/>
-          <a:p>
-            <a:pPr algn="l"/>
-            <a:r>
-              <a:rPr sz="900">
-                <a:solidFill>
-                  <a:srgbClr val="222222"/>
-                </a:solidFill>
-              </a:rPr>
-              <a:t>id  title  doi</a:t>
-            </a:r>
-          </a:p>
-          <a:p>
-            <a:pPr algn="l"/>
-            <a:r>
-              <a:rPr sz="900">
-                <a:solidFill>
-                  <a:srgbClr val="222222"/>
-                </a:solidFill>
-              </a:rPr>
-              <a:t>year  abstract</a:t>
-            </a:r>
-          </a:p>
-          <a:p>
-            <a:pPr algn="l"/>
-            <a:r>
-              <a:rPr sz="900">
-                <a:solidFill>
-                  <a:srgbClr val="222222"/>
-                </a:solidFill>
-              </a:rPr>
-              <a:t>journal_id →</a:t>
-            </a:r>
-          </a:p>
-        </p:txBody>
-      </p:sp>
-      <p:sp>
-        <p:nvSpPr>
-          <p:cNvPr id="9" name="TextBox 8"/>
-          <p:cNvSpPr txBox="1"/>
-          <p:nvPr/>
-        </p:nvSpPr>
-        <p:spPr>
-          <a:xfrm>
-            <a:off x="7920000" y="2700000"/>
-            <a:ext cx="2232000" cy="288000"/>
-          </a:xfrm>
-          <a:prstGeom prst="rect">
-            <a:avLst/>
-          </a:prstGeom>
-          <a:noFill/>
-          <a:solidFill>
-            <a:srgbClr val="1A5C3A"/>
-          </a:solidFill>
-        </p:spPr>
-        <p:txBody>
-          <a:bodyPr wrap="none">
-            <a:spAutoFit/>
-          </a:bodyPr>
-          <a:lstStyle/>
-          <a:p>
-            <a:pPr algn="ctr"/>
-            <a:r>
-              <a:rPr sz="1100" b="1">
-                <a:solidFill>
-                  <a:srgbClr val="FFFFFF"/>
-                </a:solidFill>
-              </a:rPr>
-              <a:t>publication_authors</a:t>
-            </a:r>
-          </a:p>
-        </p:txBody>
-      </p:sp>
-      <p:sp>
-        <p:nvSpPr>
-          <p:cNvPr id="10" name="TextBox 9"/>
-          <p:cNvSpPr txBox="1"/>
-          <p:nvPr/>
-        </p:nvSpPr>
-        <p:spPr>
-          <a:xfrm>
-            <a:off x="7920000" y="3006000"/>
-            <a:ext cx="2232000" cy="486000"/>
-          </a:xfrm>
-          <a:prstGeom prst="rect">
-            <a:avLst/>
-          </a:prstGeom>
-          <a:noFill/>
           <a:ln w="12700">
             <a:solidFill>
               <a:srgbClr val="1A5C3A"/>
             </a:solidFill>
           </a:ln>
+        </p:spPr>
+        <p:txBody>
+          <a:bodyPr wrap="square" anchor="ctr"/>
+          <a:lstStyle/>
+          <a:p>
+            <a:pPr algn="l"/>
+            <a:r>
+              <a:rPr lang="ru-RU" sz="900" b="0">
+                <a:solidFill>
+                  <a:srgbClr val="222222"/>
+                </a:solidFill>
+              </a:rPr>
+              <a:t>publication_id →</a:t>
+            </a:r>
+          </a:p>
+          <a:p>
+            <a:pPr algn="l"/>
+            <a:r>
+              <a:rPr lang="ru-RU" sz="900" b="0">
+                <a:solidFill>
+                  <a:srgbClr val="222222"/>
+                </a:solidFill>
+              </a:rPr>
+              <a:t>person_id →</a:t>
+            </a:r>
+          </a:p>
+        </p:txBody>
+      </p:sp>
+      <p:sp>
+        <p:nvSpPr>
+          <p:cNvPr id="107" name="sp7"/>
+          <p:cNvSpPr txBox="1"/>
+          <p:nvPr/>
+        </p:nvSpPr>
+        <p:spPr>
+          <a:xfrm>
+            <a:off x="8100000" y="4392000"/>
+            <a:ext cx="2160000" cy="270000"/>
+          </a:xfrm>
+          <a:prstGeom prst="roundRect">
+            <a:avLst>
+              <a:gd name="adj" fmla="val 20000"/>
+            </a:avLst>
+          </a:prstGeom>
+          <a:solidFill>
+            <a:srgbClr val="1A5C3A"/>
+          </a:solidFill>
+          <a:ln>
+            <a:noFill/>
+          </a:ln>
+        </p:spPr>
+        <p:txBody>
+          <a:bodyPr wrap="square" anchor="ctr"/>
+          <a:lstStyle/>
+          <a:p>
+            <a:pPr algn="ctr"/>
+            <a:r>
+              <a:rPr lang="ru-RU" sz="1000" b="1">
+                <a:solidFill>
+                  <a:srgbClr val="FFFFFF"/>
+                </a:solidFill>
+              </a:rPr>
+              <a:t>persons</a:t>
+            </a:r>
+          </a:p>
+        </p:txBody>
+      </p:sp>
+      <p:sp>
+        <p:nvSpPr>
+          <p:cNvPr id="108" name="sp8"/>
+          <p:cNvSpPr txBox="1"/>
+          <p:nvPr/>
+        </p:nvSpPr>
+        <p:spPr>
+          <a:xfrm>
+            <a:off x="8100000" y="4662000"/>
+            <a:ext cx="2160000" cy="810000"/>
+          </a:xfrm>
+          <a:prstGeom prst="rect">
+            <a:avLst/>
+          </a:prstGeom>
           <a:solidFill>
             <a:srgbClr val="F0F4F8"/>
           </a:solidFill>
-        </p:spPr>
-        <p:txBody>
-          <a:bodyPr wrap="square">
-            <a:spAutoFit/>
-          </a:bodyPr>
-          <a:lstStyle/>
-          <a:p>
-            <a:pPr algn="l"/>
-            <a:r>
-              <a:rPr sz="900">
-                <a:solidFill>
-                  <a:srgbClr val="222222"/>
-                </a:solidFill>
-              </a:rPr>
-              <a:t>publication_id →</a:t>
-            </a:r>
-          </a:p>
-          <a:p>
-            <a:pPr algn="l"/>
-            <a:r>
-              <a:rPr sz="900">
-                <a:solidFill>
-                  <a:srgbClr val="222222"/>
-                </a:solidFill>
-              </a:rPr>
-              <a:t>person_id →</a:t>
-            </a:r>
-          </a:p>
-        </p:txBody>
-      </p:sp>
-      <p:sp>
-        <p:nvSpPr>
-          <p:cNvPr id="11" name="TextBox 10"/>
-          <p:cNvSpPr txBox="1"/>
-          <p:nvPr/>
-        </p:nvSpPr>
-        <p:spPr>
-          <a:xfrm>
-            <a:off x="7920000" y="4500000"/>
-            <a:ext cx="2232000" cy="288000"/>
-          </a:xfrm>
-          <a:prstGeom prst="rect">
-            <a:avLst/>
-          </a:prstGeom>
-          <a:noFill/>
-          <a:solidFill>
-            <a:srgbClr val="1A5C3A"/>
-          </a:solidFill>
-        </p:spPr>
-        <p:txBody>
-          <a:bodyPr wrap="none">
-            <a:spAutoFit/>
-          </a:bodyPr>
-          <a:lstStyle/>
-          <a:p>
-            <a:pPr algn="ctr"/>
-            <a:r>
-              <a:rPr sz="1100" b="1">
-                <a:solidFill>
-                  <a:srgbClr val="FFFFFF"/>
-                </a:solidFill>
-              </a:rPr>
-              <a:t>persons</a:t>
-            </a:r>
-          </a:p>
-        </p:txBody>
-      </p:sp>
-      <p:sp>
-        <p:nvSpPr>
-          <p:cNvPr id="12" name="TextBox 11"/>
-          <p:cNvSpPr txBox="1"/>
-          <p:nvPr/>
-        </p:nvSpPr>
-        <p:spPr>
-          <a:xfrm>
-            <a:off x="7920000" y="4806000"/>
-            <a:ext cx="2232000" cy="846000"/>
-          </a:xfrm>
-          <a:prstGeom prst="rect">
-            <a:avLst/>
-          </a:prstGeom>
-          <a:noFill/>
           <a:ln w="12700">
             <a:solidFill>
               <a:srgbClr val="1A5C3A"/>
             </a:solidFill>
           </a:ln>
+        </p:spPr>
+        <p:txBody>
+          <a:bodyPr wrap="square" anchor="ctr"/>
+          <a:lstStyle/>
+          <a:p>
+            <a:pPr algn="l"/>
+            <a:r>
+              <a:rPr lang="ru-RU" sz="900" b="0">
+                <a:solidFill>
+                  <a:srgbClr val="222222"/>
+                </a:solidFill>
+              </a:rPr>
+              <a:t>openalex_id</a:t>
+            </a:r>
+          </a:p>
+          <a:p>
+            <a:pPr algn="l"/>
+            <a:r>
+              <a:rPr lang="ru-RU" sz="900" b="0">
+                <a:solidFill>
+                  <a:srgbClr val="222222"/>
+                </a:solidFill>
+              </a:rPr>
+              <a:t>full_name · orcid</a:t>
+            </a:r>
+          </a:p>
+        </p:txBody>
+      </p:sp>
+      <p:sp>
+        <p:nvSpPr>
+          <p:cNvPr id="109" name="sp9"/>
+          <p:cNvSpPr txBox="1"/>
+          <p:nvPr/>
+        </p:nvSpPr>
+        <p:spPr>
+          <a:xfrm>
+            <a:off x="10368000" y="4392000"/>
+            <a:ext cx="2160000" cy="270000"/>
+          </a:xfrm>
+          <a:prstGeom prst="roundRect">
+            <a:avLst>
+              <a:gd name="adj" fmla="val 20000"/>
+            </a:avLst>
+          </a:prstGeom>
+          <a:solidFill>
+            <a:srgbClr val="7D3C98"/>
+          </a:solidFill>
+          <a:ln>
+            <a:noFill/>
+          </a:ln>
+        </p:spPr>
+        <p:txBody>
+          <a:bodyPr wrap="square" anchor="ctr"/>
+          <a:lstStyle/>
+          <a:p>
+            <a:pPr algn="ctr"/>
+            <a:r>
+              <a:rPr lang="ru-RU" sz="1000" b="1">
+                <a:solidFill>
+                  <a:srgbClr val="FFFFFF"/>
+                </a:solidFill>
+              </a:rPr>
+              <a:t>affiliations</a:t>
+            </a:r>
+          </a:p>
+        </p:txBody>
+      </p:sp>
+      <p:sp>
+        <p:nvSpPr>
+          <p:cNvPr id="110" name="sp10"/>
+          <p:cNvSpPr txBox="1"/>
+          <p:nvPr/>
+        </p:nvSpPr>
+        <p:spPr>
+          <a:xfrm>
+            <a:off x="10368000" y="4662000"/>
+            <a:ext cx="2160000" cy="810000"/>
+          </a:xfrm>
+          <a:prstGeom prst="rect">
+            <a:avLst/>
+          </a:prstGeom>
           <a:solidFill>
             <a:srgbClr val="F0F4F8"/>
           </a:solidFill>
-        </p:spPr>
-        <p:txBody>
-          <a:bodyPr wrap="square">
-            <a:spAutoFit/>
-          </a:bodyPr>
-          <a:lstStyle/>
-          <a:p>
-            <a:pPr algn="l"/>
-            <a:r>
-              <a:rPr sz="900">
-                <a:solidFill>
-                  <a:srgbClr val="222222"/>
-                </a:solidFill>
-              </a:rPr>
-              <a:t>openalex_id</a:t>
-            </a:r>
-          </a:p>
-          <a:p>
-            <a:pPr algn="l"/>
-            <a:r>
-              <a:rPr sz="900">
-                <a:solidFill>
-                  <a:srgbClr val="222222"/>
-                </a:solidFill>
-              </a:rPr>
-              <a:t>full_name  orcid</a:t>
-            </a:r>
-          </a:p>
-        </p:txBody>
-      </p:sp>
-      <p:sp>
-        <p:nvSpPr>
-          <p:cNvPr id="13" name="TextBox 12"/>
-          <p:cNvSpPr txBox="1"/>
-          <p:nvPr/>
-        </p:nvSpPr>
-        <p:spPr>
-          <a:xfrm>
-            <a:off x="10260000" y="2700000"/>
-            <a:ext cx="2232000" cy="288000"/>
-          </a:xfrm>
-          <a:prstGeom prst="rect">
-            <a:avLst/>
-          </a:prstGeom>
-          <a:noFill/>
-          <a:solidFill>
-            <a:srgbClr val="7D3C98"/>
-          </a:solidFill>
-        </p:spPr>
-        <p:txBody>
-          <a:bodyPr wrap="none">
-            <a:spAutoFit/>
-          </a:bodyPr>
-          <a:lstStyle/>
-          <a:p>
-            <a:pPr algn="ctr"/>
-            <a:r>
-              <a:rPr sz="1100" b="1">
-                <a:solidFill>
-                  <a:srgbClr val="FFFFFF"/>
-                </a:solidFill>
-              </a:rPr>
-              <a:t>affiliations</a:t>
-            </a:r>
-          </a:p>
-        </p:txBody>
-      </p:sp>
-      <p:sp>
-        <p:nvSpPr>
-          <p:cNvPr id="14" name="TextBox 13"/>
-          <p:cNvSpPr txBox="1"/>
-          <p:nvPr/>
-        </p:nvSpPr>
-        <p:spPr>
-          <a:xfrm>
-            <a:off x="10260000" y="3006000"/>
-            <a:ext cx="2232000" cy="846000"/>
-          </a:xfrm>
-          <a:prstGeom prst="rect">
-            <a:avLst/>
-          </a:prstGeom>
-          <a:noFill/>
           <a:ln w="12700">
             <a:solidFill>
               <a:srgbClr val="7D3C98"/>
             </a:solidFill>
           </a:ln>
+        </p:spPr>
+        <p:txBody>
+          <a:bodyPr wrap="square" anchor="ctr"/>
+          <a:lstStyle/>
+          <a:p>
+            <a:pPr algn="l"/>
+            <a:r>
+              <a:rPr lang="ru-RU" sz="900" b="0">
+                <a:solidFill>
+                  <a:srgbClr val="222222"/>
+                </a:solidFill>
+              </a:rPr>
+              <a:t>institution</a:t>
+            </a:r>
+          </a:p>
+          <a:p>
+            <a:pPr algn="l"/>
+            <a:r>
+              <a:rPr lang="ru-RU" sz="900" b="0">
+                <a:solidFill>
+                  <a:srgbClr val="222222"/>
+                </a:solidFill>
+              </a:rPr>
+              <a:t>lat · lon</a:t>
+            </a:r>
+          </a:p>
+        </p:txBody>
+      </p:sp>
+      <p:sp>
+        <p:nvSpPr>
+          <p:cNvPr id="111" name="sp11"/>
+          <p:cNvSpPr txBox="1"/>
+          <p:nvPr/>
+        </p:nvSpPr>
+        <p:spPr>
+          <a:xfrm>
+            <a:off x="1800000" y="4392000"/>
+            <a:ext cx="2160000" cy="270000"/>
+          </a:xfrm>
+          <a:prstGeom prst="roundRect">
+            <a:avLst>
+              <a:gd name="adj" fmla="val 20000"/>
+            </a:avLst>
+          </a:prstGeom>
+          <a:solidFill>
+            <a:srgbClr val="935116"/>
+          </a:solidFill>
+          <a:ln>
+            <a:noFill/>
+          </a:ln>
+        </p:spPr>
+        <p:txBody>
+          <a:bodyPr wrap="square" anchor="ctr"/>
+          <a:lstStyle/>
+          <a:p>
+            <a:pPr algn="ctr"/>
+            <a:r>
+              <a:rPr lang="ru-RU" sz="1000" b="1">
+                <a:solidFill>
+                  <a:srgbClr val="FFFFFF"/>
+                </a:solidFill>
+              </a:rPr>
+              <a:t>publication_topics</a:t>
+            </a:r>
+          </a:p>
+        </p:txBody>
+      </p:sp>
+      <p:sp>
+        <p:nvSpPr>
+          <p:cNvPr id="112" name="sp12"/>
+          <p:cNvSpPr txBox="1"/>
+          <p:nvPr/>
+        </p:nvSpPr>
+        <p:spPr>
+          <a:xfrm>
+            <a:off x="1800000" y="4662000"/>
+            <a:ext cx="2160000" cy="810000"/>
+          </a:xfrm>
+          <a:prstGeom prst="rect">
+            <a:avLst/>
+          </a:prstGeom>
           <a:solidFill>
             <a:srgbClr val="F0F4F8"/>
           </a:solidFill>
-        </p:spPr>
-        <p:txBody>
-          <a:bodyPr wrap="square">
-            <a:spAutoFit/>
-          </a:bodyPr>
-          <a:lstStyle/>
-          <a:p>
-            <a:pPr algn="l"/>
-            <a:r>
-              <a:rPr sz="900">
-                <a:solidFill>
-                  <a:srgbClr val="222222"/>
-                </a:solidFill>
-              </a:rPr>
-              <a:t>institution</a:t>
-            </a:r>
-          </a:p>
-          <a:p>
-            <a:pPr algn="l"/>
-            <a:r>
-              <a:rPr sz="900">
-                <a:solidFill>
-                  <a:srgbClr val="222222"/>
-                </a:solidFill>
-              </a:rPr>
-              <a:t>latitude</a:t>
-            </a:r>
-          </a:p>
-          <a:p>
-            <a:pPr algn="l"/>
-            <a:r>
-              <a:rPr sz="900">
-                <a:solidFill>
-                  <a:srgbClr val="222222"/>
-                </a:solidFill>
-              </a:rPr>
-              <a:t>longitude</a:t>
-            </a:r>
-          </a:p>
-        </p:txBody>
-      </p:sp>
-      <p:sp>
-        <p:nvSpPr>
-          <p:cNvPr id="15" name="TextBox 14"/>
-          <p:cNvSpPr txBox="1"/>
-          <p:nvPr/>
-        </p:nvSpPr>
-        <p:spPr>
-          <a:xfrm>
-            <a:off x="1800000" y="4500000"/>
-            <a:ext cx="2232000" cy="288000"/>
-          </a:xfrm>
-          <a:prstGeom prst="rect">
-            <a:avLst/>
-          </a:prstGeom>
-          <a:noFill/>
-          <a:solidFill>
-            <a:srgbClr val="935116"/>
-          </a:solidFill>
-        </p:spPr>
-        <p:txBody>
-          <a:bodyPr wrap="none">
-            <a:spAutoFit/>
-          </a:bodyPr>
-          <a:lstStyle/>
-          <a:p>
-            <a:pPr algn="ctr"/>
-            <a:r>
-              <a:rPr sz="1100" b="1">
-                <a:solidFill>
-                  <a:srgbClr val="FFFFFF"/>
-                </a:solidFill>
-              </a:rPr>
-              <a:t>publication_topics</a:t>
-            </a:r>
-          </a:p>
-        </p:txBody>
-      </p:sp>
-      <p:sp>
-        <p:nvSpPr>
-          <p:cNvPr id="16" name="TextBox 15"/>
-          <p:cNvSpPr txBox="1"/>
-          <p:nvPr/>
-        </p:nvSpPr>
-        <p:spPr>
-          <a:xfrm>
-            <a:off x="1800000" y="4806000"/>
-            <a:ext cx="2232000" cy="846000"/>
-          </a:xfrm>
-          <a:prstGeom prst="rect">
-            <a:avLst/>
-          </a:prstGeom>
-          <a:noFill/>
           <a:ln w="12700">
             <a:solidFill>
               <a:srgbClr val="935116"/>
             </a:solidFill>
           </a:ln>
+        </p:spPr>
+        <p:txBody>
+          <a:bodyPr wrap="square" anchor="ctr"/>
+          <a:lstStyle/>
+          <a:p>
+            <a:pPr algn="l"/>
+            <a:r>
+              <a:rPr lang="ru-RU" sz="900" b="0">
+                <a:solidFill>
+                  <a:srgbClr val="222222"/>
+                </a:solidFill>
+              </a:rPr>
+              <a:t>publication_id →</a:t>
+            </a:r>
+          </a:p>
+          <a:p>
+            <a:pPr algn="l"/>
+            <a:r>
+              <a:rPr lang="ru-RU" sz="900" b="0">
+                <a:solidFill>
+                  <a:srgbClr val="222222"/>
+                </a:solidFill>
+              </a:rPr>
+              <a:t>topic · score</a:t>
+            </a:r>
+          </a:p>
+        </p:txBody>
+      </p:sp>
+      <p:sp>
+        <p:nvSpPr>
+          <p:cNvPr id="113" name="sp13"/>
+          <p:cNvSpPr txBox="1"/>
+          <p:nvPr/>
+        </p:nvSpPr>
+        <p:spPr>
+          <a:xfrm>
+            <a:off x="1800000" y="2700000"/>
+            <a:ext cx="2160000" cy="270000"/>
+          </a:xfrm>
+          <a:prstGeom prst="roundRect">
+            <a:avLst>
+              <a:gd name="adj" fmla="val 20000"/>
+            </a:avLst>
+          </a:prstGeom>
+          <a:solidFill>
+            <a:srgbClr val="935116"/>
+          </a:solidFill>
+          <a:ln>
+            <a:noFill/>
+          </a:ln>
+        </p:spPr>
+        <p:txBody>
+          <a:bodyPr wrap="square" anchor="ctr"/>
+          <a:lstStyle/>
+          <a:p>
+            <a:pPr algn="ctr"/>
+            <a:r>
+              <a:rPr lang="ru-RU" sz="1000" b="1">
+                <a:solidFill>
+                  <a:srgbClr val="FFFFFF"/>
+                </a:solidFill>
+              </a:rPr>
+              <a:t>publication_keywords</a:t>
+            </a:r>
+          </a:p>
+        </p:txBody>
+      </p:sp>
+      <p:sp>
+        <p:nvSpPr>
+          <p:cNvPr id="114" name="sp14"/>
+          <p:cNvSpPr txBox="1"/>
+          <p:nvPr/>
+        </p:nvSpPr>
+        <p:spPr>
+          <a:xfrm>
+            <a:off x="1800000" y="2970000"/>
+            <a:ext cx="2160000" cy="810000"/>
+          </a:xfrm>
+          <a:prstGeom prst="rect">
+            <a:avLst/>
+          </a:prstGeom>
           <a:solidFill>
             <a:srgbClr val="F0F4F8"/>
           </a:solidFill>
-        </p:spPr>
-        <p:txBody>
-          <a:bodyPr wrap="square">
-            <a:spAutoFit/>
-          </a:bodyPr>
-          <a:lstStyle/>
-          <a:p>
-            <a:pPr algn="l"/>
-            <a:r>
-              <a:rPr sz="900">
-                <a:solidFill>
-                  <a:srgbClr val="222222"/>
-                </a:solidFill>
-              </a:rPr>
-              <a:t>publication_id →</a:t>
-            </a:r>
-          </a:p>
-          <a:p>
-            <a:pPr algn="l"/>
-            <a:r>
-              <a:rPr sz="900">
-                <a:solidFill>
-                  <a:srgbClr val="222222"/>
-                </a:solidFill>
-              </a:rPr>
-              <a:t>topic_name  score</a:t>
-            </a:r>
-          </a:p>
-        </p:txBody>
-      </p:sp>
-      <p:sp>
-        <p:nvSpPr>
-          <p:cNvPr id="17" name="TextBox 16"/>
-          <p:cNvSpPr txBox="1"/>
-          <p:nvPr/>
-        </p:nvSpPr>
-        <p:spPr>
-          <a:xfrm>
-            <a:off x="1800000" y="2700000"/>
-            <a:ext cx="2232000" cy="288000"/>
-          </a:xfrm>
-          <a:prstGeom prst="rect">
-            <a:avLst/>
-          </a:prstGeom>
-          <a:noFill/>
-          <a:solidFill>
-            <a:srgbClr val="935116"/>
-          </a:solidFill>
-        </p:spPr>
-        <p:txBody>
-          <a:bodyPr wrap="none">
-            <a:spAutoFit/>
-          </a:bodyPr>
-          <a:lstStyle/>
-          <a:p>
-            <a:pPr algn="ctr"/>
-            <a:r>
-              <a:rPr sz="1100" b="1">
-                <a:solidFill>
-                  <a:srgbClr val="FFFFFF"/>
-                </a:solidFill>
-              </a:rPr>
-              <a:t>publication_keywords</a:t>
-            </a:r>
-          </a:p>
-        </p:txBody>
-      </p:sp>
-      <p:sp>
-        <p:nvSpPr>
-          <p:cNvPr id="18" name="TextBox 17"/>
-          <p:cNvSpPr txBox="1"/>
-          <p:nvPr/>
-        </p:nvSpPr>
-        <p:spPr>
-          <a:xfrm>
-            <a:off x="1800000" y="3006000"/>
-            <a:ext cx="2232000" cy="846000"/>
-          </a:xfrm>
-          <a:prstGeom prst="rect">
-            <a:avLst/>
-          </a:prstGeom>
-          <a:noFill/>
           <a:ln w="12700">
             <a:solidFill>
               <a:srgbClr val="935116"/>
             </a:solidFill>
           </a:ln>
-          <a:solidFill>
-            <a:srgbClr val="F0F4F8"/>
-          </a:solidFill>
-        </p:spPr>
-        <p:txBody>
-          <a:bodyPr wrap="square">
-            <a:spAutoFit/>
-          </a:bodyPr>
+        </p:spPr>
+        <p:txBody>
+          <a:bodyPr wrap="square" anchor="ctr"/>
           <a:lstStyle/>
           <a:p>
             <a:pPr algn="l"/>
             <a:r>
-              <a:rPr sz="900">
+              <a:rPr lang="ru-RU" sz="900" b="0">
                 <a:solidFill>
                   <a:srgbClr val="222222"/>
                 </a:solidFill>
@@ -8149,76 +8111,77 @@
           <a:p>
             <a:pPr algn="l"/>
             <a:r>
-              <a:rPr sz="900">
+              <a:rPr lang="ru-RU" sz="900" b="0">
                 <a:solidFill>
                   <a:srgbClr val="222222"/>
                 </a:solidFill>
               </a:rPr>
-              <a:t>keyword_name  score</a:t>
-            </a:r>
-          </a:p>
-        </p:txBody>
-      </p:sp>
-      <p:cxnSp>
-        <p:nvCxnSpPr>
-          <p:cNvPr id="19" name="Connector 18"/>
-          <p:cNvCxnSpPr/>
-          <p:nvPr/>
-        </p:nvCxnSpPr>
-        <p:spPr>
-          <a:xfrm>
-            <a:off x="5976000" y="2232000"/>
-            <a:ext cx="0" cy="468000"/>
-          </a:xfrm>
-          <a:prstGeom prst="line">
-            <a:avLst/>
-          </a:prstGeom>
-          <a:ln w="19050">
-            <a:solidFill>
-              <a:srgbClr val="88AACC"/>
-            </a:solidFill>
+              <a:t>keyword · score</a:t>
+            </a:r>
+          </a:p>
+        </p:txBody>
+      </p:sp>
+      <p:sp>
+        <p:nvSpPr>
+          <p:cNvPr id="115" name="sp15"/>
+          <p:cNvSpPr txBox="1"/>
+          <p:nvPr/>
+        </p:nvSpPr>
+        <p:spPr>
+          <a:xfrm>
+            <a:off x="6048000" y="2232000"/>
+            <a:ext cx="540000" cy="180000"/>
+          </a:xfrm>
+          <a:prstGeom prst="rect">
+            <a:avLst/>
+          </a:prstGeom>
+          <a:noFill/>
+          <a:ln>
+            <a:noFill/>
           </a:ln>
         </p:spPr>
-        <p:style>
-          <a:lnRef idx="2">
-            <a:schemeClr val="accent1"/>
-          </a:lnRef>
-          <a:fillRef idx="0">
-            <a:schemeClr val="accent1"/>
-          </a:fillRef>
-          <a:effectRef idx="1">
-            <a:schemeClr val="accent1"/>
-          </a:effectRef>
-          <a:fontRef idx="minor">
-            <a:schemeClr val="tx1"/>
-          </a:fontRef>
-        </p:style>
-      </p:cxnSp>
-      <p:sp>
-        <p:nvSpPr>
-          <p:cNvPr id="20" name="TextBox 19"/>
+        <p:txBody>
+          <a:bodyPr wrap="square" anchor="ctr"/>
+          <a:lstStyle/>
+          <a:p>
+            <a:pPr algn="ctr"/>
+            <a:r>
+              <a:rPr lang="ru-RU" sz="800" b="0">
+                <a:solidFill>
+                  <a:srgbClr val="88AACC"/>
+                </a:solidFill>
+              </a:rPr>
+              <a:t>1 : N</a:t>
+            </a:r>
+          </a:p>
+        </p:txBody>
+      </p:sp>
+      <p:sp>
+        <p:nvSpPr>
+          <p:cNvPr id="116" name="sp16"/>
           <p:cNvSpPr txBox="1"/>
           <p:nvPr/>
         </p:nvSpPr>
         <p:spPr>
           <a:xfrm>
-            <a:off x="5688000" y="2322000"/>
-            <a:ext cx="576000" cy="180000"/>
+            <a:off x="7380000" y="3240000"/>
+            <a:ext cx="540000" cy="180000"/>
           </a:xfrm>
           <a:prstGeom prst="rect">
             <a:avLst/>
           </a:prstGeom>
           <a:noFill/>
-        </p:spPr>
-        <p:txBody>
-          <a:bodyPr wrap="none">
-            <a:spAutoFit/>
-          </a:bodyPr>
+          <a:ln>
+            <a:noFill/>
+          </a:ln>
+        </p:spPr>
+        <p:txBody>
+          <a:bodyPr wrap="square" anchor="ctr"/>
           <a:lstStyle/>
           <a:p>
             <a:pPr algn="ctr"/>
             <a:r>
-              <a:rPr sz="800">
+              <a:rPr lang="ru-RU" sz="800" b="0">
                 <a:solidFill>
                   <a:srgbClr val="88AACC"/>
                 </a:solidFill>
@@ -8228,66 +8191,67 @@
           </a:p>
         </p:txBody>
       </p:sp>
-      <p:cxnSp>
-        <p:nvCxnSpPr>
-          <p:cNvPr id="21" name="Connector 20"/>
-          <p:cNvCxnSpPr/>
-          <p:nvPr/>
-        </p:nvCxnSpPr>
-        <p:spPr>
-          <a:xfrm>
-            <a:off x="7092000" y="3096000"/>
-            <a:ext cx="828000" cy="0"/>
-          </a:xfrm>
-          <a:prstGeom prst="line">
-            <a:avLst/>
-          </a:prstGeom>
-          <a:ln w="19050">
-            <a:solidFill>
-              <a:srgbClr val="88AACC"/>
-            </a:solidFill>
+      <p:sp>
+        <p:nvSpPr>
+          <p:cNvPr id="117" name="sp17"/>
+          <p:cNvSpPr txBox="1"/>
+          <p:nvPr/>
+        </p:nvSpPr>
+        <p:spPr>
+          <a:xfrm>
+            <a:off x="9180000" y="4031999"/>
+            <a:ext cx="540000" cy="180000"/>
+          </a:xfrm>
+          <a:prstGeom prst="rect">
+            <a:avLst/>
+          </a:prstGeom>
+          <a:noFill/>
+          <a:ln>
+            <a:noFill/>
           </a:ln>
         </p:spPr>
-        <p:style>
-          <a:lnRef idx="2">
-            <a:schemeClr val="accent1"/>
-          </a:lnRef>
-          <a:fillRef idx="0">
-            <a:schemeClr val="accent1"/>
-          </a:fillRef>
-          <a:effectRef idx="1">
-            <a:schemeClr val="accent1"/>
-          </a:effectRef>
-          <a:fontRef idx="minor">
-            <a:schemeClr val="tx1"/>
-          </a:fontRef>
-        </p:style>
-      </p:cxnSp>
-      <p:sp>
-        <p:nvSpPr>
-          <p:cNvPr id="22" name="TextBox 21"/>
+        <p:txBody>
+          <a:bodyPr wrap="square" anchor="ctr"/>
+          <a:lstStyle/>
+          <a:p>
+            <a:pPr algn="ctr"/>
+            <a:r>
+              <a:rPr lang="ru-RU" sz="800" b="0">
+                <a:solidFill>
+                  <a:srgbClr val="88AACC"/>
+                </a:solidFill>
+              </a:rPr>
+              <a:t>N : 1</a:t>
+            </a:r>
+          </a:p>
+        </p:txBody>
+      </p:sp>
+      <p:sp>
+        <p:nvSpPr>
+          <p:cNvPr id="118" name="sp18"/>
           <p:cNvSpPr txBox="1"/>
           <p:nvPr/>
         </p:nvSpPr>
         <p:spPr>
           <a:xfrm>
-            <a:off x="7218000" y="2952000"/>
-            <a:ext cx="576000" cy="180000"/>
+            <a:off x="4068000" y="3240000"/>
+            <a:ext cx="540000" cy="180000"/>
           </a:xfrm>
           <a:prstGeom prst="rect">
             <a:avLst/>
           </a:prstGeom>
           <a:noFill/>
-        </p:spPr>
-        <p:txBody>
-          <a:bodyPr wrap="none">
-            <a:spAutoFit/>
-          </a:bodyPr>
+          <a:ln>
+            <a:noFill/>
+          </a:ln>
+        </p:spPr>
+        <p:txBody>
+          <a:bodyPr wrap="square" anchor="ctr"/>
           <a:lstStyle/>
           <a:p>
             <a:pPr algn="ctr"/>
             <a:r>
-              <a:rPr sz="800">
+              <a:rPr lang="ru-RU" sz="800" b="0">
                 <a:solidFill>
                   <a:srgbClr val="88AACC"/>
                 </a:solidFill>
@@ -8297,260 +8261,52 @@
           </a:p>
         </p:txBody>
       </p:sp>
-      <p:cxnSp>
-        <p:nvCxnSpPr>
-          <p:cNvPr id="23" name="Connector 22"/>
-          <p:cNvCxnSpPr/>
-          <p:nvPr/>
-        </p:nvCxnSpPr>
-        <p:spPr>
-          <a:xfrm>
-            <a:off x="9036000" y="3492000"/>
-            <a:ext cx="0" cy="1008000"/>
-          </a:xfrm>
-          <a:prstGeom prst="line">
-            <a:avLst/>
-          </a:prstGeom>
-          <a:ln w="19050">
-            <a:solidFill>
-              <a:srgbClr val="88AACC"/>
-            </a:solidFill>
+      <p:sp>
+        <p:nvSpPr>
+          <p:cNvPr id="119" name="sp19"/>
+          <p:cNvSpPr txBox="1"/>
+          <p:nvPr/>
+        </p:nvSpPr>
+        <p:spPr>
+          <a:xfrm>
+            <a:off x="4068000" y="4031999"/>
+            <a:ext cx="540000" cy="180000"/>
+          </a:xfrm>
+          <a:prstGeom prst="rect">
+            <a:avLst/>
+          </a:prstGeom>
+          <a:noFill/>
+          <a:ln>
+            <a:noFill/>
           </a:ln>
         </p:spPr>
-        <p:style>
-          <a:lnRef idx="2">
-            <a:schemeClr val="accent1"/>
-          </a:lnRef>
-          <a:fillRef idx="0">
-            <a:schemeClr val="accent1"/>
-          </a:fillRef>
-          <a:effectRef idx="1">
-            <a:schemeClr val="accent1"/>
-          </a:effectRef>
-          <a:fontRef idx="minor">
-            <a:schemeClr val="tx1"/>
-          </a:fontRef>
-        </p:style>
-      </p:cxnSp>
-      <p:sp>
-        <p:nvSpPr>
-          <p:cNvPr id="24" name="TextBox 23"/>
+        <p:txBody>
+          <a:bodyPr wrap="square" anchor="ctr"/>
+          <a:lstStyle/>
+          <a:p>
+            <a:pPr algn="ctr"/>
+            <a:r>
+              <a:rPr lang="ru-RU" sz="800" b="0">
+                <a:solidFill>
+                  <a:srgbClr val="88AACC"/>
+                </a:solidFill>
+              </a:rPr>
+              <a:t>1 : N</a:t>
+            </a:r>
+          </a:p>
+        </p:txBody>
+      </p:sp>
+      <p:sp>
+        <p:nvSpPr>
+          <p:cNvPr id="120" name="sp20"/>
           <p:cNvSpPr txBox="1"/>
           <p:nvPr/>
         </p:nvSpPr>
         <p:spPr>
           <a:xfrm>
-            <a:off x="8748000" y="3852000"/>
-            <a:ext cx="576000" cy="180000"/>
-          </a:xfrm>
-          <a:prstGeom prst="rect">
-            <a:avLst/>
-          </a:prstGeom>
-          <a:noFill/>
-        </p:spPr>
-        <p:txBody>
-          <a:bodyPr wrap="none">
-            <a:spAutoFit/>
-          </a:bodyPr>
-          <a:lstStyle/>
-          <a:p>
-            <a:pPr algn="ctr"/>
-            <a:r>
-              <a:rPr sz="800">
-                <a:solidFill>
-                  <a:srgbClr val="88AACC"/>
-                </a:solidFill>
-              </a:rPr>
-              <a:t>N : 1</a:t>
-            </a:r>
-          </a:p>
-        </p:txBody>
-      </p:sp>
-      <p:cxnSp>
-        <p:nvCxnSpPr>
-          <p:cNvPr id="25" name="Connector 24"/>
-          <p:cNvCxnSpPr/>
-          <p:nvPr/>
-        </p:nvCxnSpPr>
-        <p:spPr>
-          <a:xfrm flipV="1">
-            <a:off x="10152000" y="3600000"/>
-            <a:ext cx="108000" cy="1296000"/>
-          </a:xfrm>
-          <a:prstGeom prst="line">
-            <a:avLst/>
-          </a:prstGeom>
-          <a:ln w="19050">
-            <a:solidFill>
-              <a:srgbClr val="88AACC"/>
-            </a:solidFill>
-          </a:ln>
-        </p:spPr>
-        <p:style>
-          <a:lnRef idx="2">
-            <a:schemeClr val="accent1"/>
-          </a:lnRef>
-          <a:fillRef idx="0">
-            <a:schemeClr val="accent1"/>
-          </a:fillRef>
-          <a:effectRef idx="1">
-            <a:schemeClr val="accent1"/>
-          </a:effectRef>
-          <a:fontRef idx="minor">
-            <a:schemeClr val="tx1"/>
-          </a:fontRef>
-        </p:style>
-      </p:cxnSp>
-      <p:cxnSp>
-        <p:nvCxnSpPr>
-          <p:cNvPr id="26" name="Connector 25"/>
-          <p:cNvCxnSpPr/>
-          <p:nvPr/>
-        </p:nvCxnSpPr>
-        <p:spPr>
-          <a:xfrm flipH="1">
-            <a:off x="4032000" y="3240000"/>
-            <a:ext cx="828000" cy="1800000"/>
-          </a:xfrm>
-          <a:prstGeom prst="line">
-            <a:avLst/>
-          </a:prstGeom>
-          <a:ln w="19050">
-            <a:solidFill>
-              <a:srgbClr val="88AACC"/>
-            </a:solidFill>
-          </a:ln>
-        </p:spPr>
-        <p:style>
-          <a:lnRef idx="2">
-            <a:schemeClr val="accent1"/>
-          </a:lnRef>
-          <a:fillRef idx="0">
-            <a:schemeClr val="accent1"/>
-          </a:fillRef>
-          <a:effectRef idx="1">
-            <a:schemeClr val="accent1"/>
-          </a:effectRef>
-          <a:fontRef idx="minor">
-            <a:schemeClr val="tx1"/>
-          </a:fontRef>
-        </p:style>
-      </p:cxnSp>
-      <p:sp>
-        <p:nvSpPr>
-          <p:cNvPr id="27" name="TextBox 26"/>
-          <p:cNvSpPr txBox="1"/>
-          <p:nvPr/>
-        </p:nvSpPr>
-        <p:spPr>
-          <a:xfrm>
-            <a:off x="4158000" y="3996000"/>
-            <a:ext cx="576000" cy="180000"/>
-          </a:xfrm>
-          <a:prstGeom prst="rect">
-            <a:avLst/>
-          </a:prstGeom>
-          <a:noFill/>
-        </p:spPr>
-        <p:txBody>
-          <a:bodyPr wrap="none">
-            <a:spAutoFit/>
-          </a:bodyPr>
-          <a:lstStyle/>
-          <a:p>
-            <a:pPr algn="ctr"/>
-            <a:r>
-              <a:rPr sz="800">
-                <a:solidFill>
-                  <a:srgbClr val="88AACC"/>
-                </a:solidFill>
-              </a:rPr>
-              <a:t>1 : N</a:t>
-            </a:r>
-          </a:p>
-        </p:txBody>
-      </p:sp>
-      <p:cxnSp>
-        <p:nvCxnSpPr>
-          <p:cNvPr id="28" name="Connector 27"/>
-          <p:cNvCxnSpPr/>
-          <p:nvPr/>
-        </p:nvCxnSpPr>
-        <p:spPr>
-          <a:xfrm flipH="1">
-            <a:off x="4032000" y="3060000"/>
-            <a:ext cx="828000" cy="0"/>
-          </a:xfrm>
-          <a:prstGeom prst="line">
-            <a:avLst/>
-          </a:prstGeom>
-          <a:ln w="19050">
-            <a:solidFill>
-              <a:srgbClr val="88AACC"/>
-            </a:solidFill>
-          </a:ln>
-        </p:spPr>
-        <p:style>
-          <a:lnRef idx="2">
-            <a:schemeClr val="accent1"/>
-          </a:lnRef>
-          <a:fillRef idx="0">
-            <a:schemeClr val="accent1"/>
-          </a:fillRef>
-          <a:effectRef idx="1">
-            <a:schemeClr val="accent1"/>
-          </a:effectRef>
-          <a:fontRef idx="minor">
-            <a:schemeClr val="tx1"/>
-          </a:fontRef>
-        </p:style>
-      </p:cxnSp>
-      <p:sp>
-        <p:nvSpPr>
-          <p:cNvPr id="29" name="TextBox 28"/>
-          <p:cNvSpPr txBox="1"/>
-          <p:nvPr/>
-        </p:nvSpPr>
-        <p:spPr>
-          <a:xfrm>
-            <a:off x="4158000" y="2916000"/>
-            <a:ext cx="576000" cy="180000"/>
-          </a:xfrm>
-          <a:prstGeom prst="rect">
-            <a:avLst/>
-          </a:prstGeom>
-          <a:noFill/>
-        </p:spPr>
-        <p:txBody>
-          <a:bodyPr wrap="none">
-            <a:spAutoFit/>
-          </a:bodyPr>
-          <a:lstStyle/>
-          <a:p>
-            <a:pPr algn="ctr"/>
-            <a:r>
-              <a:rPr sz="800">
-                <a:solidFill>
-                  <a:srgbClr val="88AACC"/>
-                </a:solidFill>
-              </a:rPr>
-              <a:t>1 : N</a:t>
-            </a:r>
-          </a:p>
-        </p:txBody>
-      </p:sp>
-      <p:sp>
-        <p:nvSpPr>
-          <p:cNvPr id="30" name="TextBox 29"/>
-          <p:cNvSpPr txBox="1"/>
-          <p:nvPr/>
-        </p:nvSpPr>
-        <p:spPr>
-          <a:xfrm>
             <a:off x="0" y="6757200"/>
-            <a:ext cx="12188825" cy="100800"/>
-          </a:xfrm>
-          <a:noFill/>
+            <a:ext cx="12192000" cy="100800"/>
+          </a:xfrm>
           <a:prstGeom prst="rect">
             <a:avLst/>
           </a:prstGeom>
@@ -8562,25 +8318,32 @@
           </a:ln>
         </p:spPr>
         <p:txBody>
-          <a:bodyPr wrap="none">
-            <a:spAutoFit/>
-          </a:bodyPr>
-          <a:lstStyle/>
-          <a:p/>
-        </p:txBody>
-      </p:sp>
-      <p:sp>
-        <p:nvSpPr>
-          <p:cNvPr id="31" name="TextBox 30"/>
+          <a:bodyPr wrap="square" anchor="ctr"/>
+          <a:lstStyle/>
+          <a:p>
+            <a:pPr algn="l"/>
+            <a:r>
+              <a:rPr lang="ru-RU" sz="1100" b="0">
+                <a:solidFill>
+                  <a:srgbClr val="FFFFFF"/>
+                </a:solidFill>
+              </a:rPr>
+              <a:t/>
+            </a:r>
+          </a:p>
+        </p:txBody>
+      </p:sp>
+      <p:sp>
+        <p:nvSpPr>
+          <p:cNvPr id="121" name="sp21"/>
           <p:cNvSpPr txBox="1"/>
           <p:nvPr/>
         </p:nvSpPr>
         <p:spPr>
           <a:xfrm>
             <a:off x="0" y="6757200"/>
-            <a:ext cx="6965042" cy="100800"/>
-          </a:xfrm>
-          <a:noFill/>
+            <a:ext cx="6966857" cy="100800"/>
+          </a:xfrm>
           <a:prstGeom prst="rect">
             <a:avLst/>
           </a:prstGeom>
@@ -8592,25 +8355,32 @@
           </a:ln>
         </p:spPr>
         <p:txBody>
-          <a:bodyPr wrap="none">
-            <a:spAutoFit/>
-          </a:bodyPr>
-          <a:lstStyle/>
-          <a:p/>
-        </p:txBody>
-      </p:sp>
-      <p:sp>
-        <p:nvSpPr>
-          <p:cNvPr id="32" name="TextBox 31"/>
+          <a:bodyPr wrap="square" anchor="ctr"/>
+          <a:lstStyle/>
+          <a:p>
+            <a:pPr algn="l"/>
+            <a:r>
+              <a:rPr lang="ru-RU" sz="1100" b="0">
+                <a:solidFill>
+                  <a:srgbClr val="FFFFFF"/>
+                </a:solidFill>
+              </a:rPr>
+              <a:t/>
+            </a:r>
+          </a:p>
+        </p:txBody>
+      </p:sp>
+      <p:sp>
+        <p:nvSpPr>
+          <p:cNvPr id="122" name="sp22"/>
           <p:cNvSpPr txBox="1"/>
           <p:nvPr/>
         </p:nvSpPr>
         <p:spPr>
           <a:xfrm>
-            <a:off x="6803042" y="6645600"/>
+            <a:off x="6804857" y="6645600"/>
             <a:ext cx="324000" cy="324000"/>
           </a:xfrm>
-          <a:noFill/>
           <a:prstGeom prst="ellipse">
             <a:avLst/>
           </a:prstGeom>
@@ -8622,36 +8392,787 @@
           </a:ln>
         </p:spPr>
         <p:txBody>
-          <a:bodyPr wrap="none" anchor="ctr">
-            <a:spAutoFit/>
-          </a:bodyPr>
+          <a:bodyPr wrap="square" anchor="ctr"/>
           <a:lstStyle/>
           <a:p>
             <a:pPr algn="ctr"/>
             <a:r>
-              <a:rPr sz="900" b="1">
+              <a:rPr lang="ru-RU" sz="900" b="1">
                 <a:solidFill>
                   <a:srgbClr val="FFFFFF"/>
                 </a:solidFill>
-                <a:latin typeface="Arial"/>
               </a:rPr>
               <a:t>8</a:t>
             </a:r>
           </a:p>
         </p:txBody>
       </p:sp>
-      <p:sp>
-        <p:nvSpPr>
-          <p:cNvPr id="33" name="TextBox 32"/>
+    </p:spTree>
+  </p:cSld>
+  <p:clrMapOvr>
+    <a:masterClrMapping/>
+  </p:clrMapOvr>
+</p:sld>
+</file>
+
+<file path=ppt/slides/slide15.xml><?xml version="1.0" encoding="utf-8"?>
+<p:sld xmlns:a="http://schemas.openxmlformats.org/drawingml/2006/main" xmlns:r="http://schemas.openxmlformats.org/officeDocument/2006/relationships" xmlns:p="http://schemas.openxmlformats.org/presentationml/2006/main">
+  <p:cSld>
+    <p:spTree>
+      <p:sp>
+        <p:nvSpPr>
+          <p:cNvPr id="2" name="Rectangle 1"/>
+          <p:cNvSpPr/>
+          <p:nvPr/>
+        </p:nvSpPr>
+        <p:spPr>
+          <a:xfrm>
+            <a:off x="0" y="0"/>
+            <a:ext cx="12188952" cy="6858000"/>
+          </a:xfrm>
+          <a:prstGeom prst="rect">
+            <a:avLst/>
+          </a:prstGeom>
+          <a:solidFill>
+            <a:srgbClr val="F7FBF8"/>
+          </a:solidFill>
+          <a:ln>
+            <a:noFill/>
+          </a:ln>
+        </p:spPr>
+        <p:style>
+          <a:lnRef idx="1">
+            <a:schemeClr val="accent1"/>
+          </a:lnRef>
+          <a:fillRef idx="3">
+            <a:schemeClr val="accent1"/>
+          </a:fillRef>
+          <a:effectRef idx="2">
+            <a:schemeClr val="accent1"/>
+          </a:effectRef>
+          <a:fontRef idx="minor">
+            <a:schemeClr val="lt1"/>
+          </a:fontRef>
+        </p:style>
+        <p:txBody>
+          <a:bodyPr rtlCol="0" anchor="ctr"/>
+          <a:lstStyle/>
+          <a:p>
+            <a:pPr algn="ctr"/>
+            <a:endParaRPr/>
+          </a:p>
+        </p:txBody>
+      </p:sp>
+      <p:sp>
+        <p:nvSpPr>
+          <p:cNvPr id="3" name="Rectangle 2"/>
+          <p:cNvSpPr/>
+          <p:nvPr/>
+        </p:nvSpPr>
+        <p:spPr>
+          <a:xfrm>
+            <a:off x="0" y="0"/>
+            <a:ext cx="12188952" cy="1005840"/>
+          </a:xfrm>
+          <a:prstGeom prst="rect">
+            <a:avLst/>
+          </a:prstGeom>
+          <a:solidFill>
+            <a:srgbClr val="163126"/>
+          </a:solidFill>
+          <a:ln>
+            <a:noFill/>
+          </a:ln>
+        </p:spPr>
+        <p:style>
+          <a:lnRef idx="1">
+            <a:schemeClr val="accent1"/>
+          </a:lnRef>
+          <a:fillRef idx="3">
+            <a:schemeClr val="accent1"/>
+          </a:fillRef>
+          <a:effectRef idx="2">
+            <a:schemeClr val="accent1"/>
+          </a:effectRef>
+          <a:fontRef idx="minor">
+            <a:schemeClr val="lt1"/>
+          </a:fontRef>
+        </p:style>
+        <p:txBody>
+          <a:bodyPr rtlCol="0" anchor="ctr"/>
+          <a:lstStyle/>
+          <a:p>
+            <a:pPr algn="ctr"/>
+            <a:endParaRPr/>
+          </a:p>
+        </p:txBody>
+      </p:sp>
+      <p:sp>
+        <p:nvSpPr>
+          <p:cNvPr id="99" name="TextBox"/>
           <p:cNvSpPr txBox="1"/>
           <p:nvPr/>
         </p:nvSpPr>
         <p:spPr>
           <a:xfrm>
+            <a:off x="360000" y="180000"/>
+            <a:ext cx="11448000" cy="684000"/>
+          </a:xfrm>
+          <a:prstGeom prst="rect">
+            <a:avLst/>
+          </a:prstGeom>
+          <a:noFill/>
+          <a:ln>
+            <a:noFill/>
+          </a:ln>
+        </p:spPr>
+        <p:txBody>
+          <a:bodyPr wrap="square" anchor="ctr"/>
+          <a:lstStyle/>
+          <a:p>
+            <a:pPr algn="l"/>
+            <a:r>
+              <a:rPr lang="ru-RU" sz="2200" b="1">
+                <a:solidFill>
+                  <a:srgbClr val="FFFFFF"/>
+                </a:solidFill>
+              </a:rPr>
+              <a:t>Результаты</a:t>
+            </a:r>
+            <a:br>
+              <a:rPr lang="ru-RU"/>
+            </a:br>
+          </a:p>
+        </p:txBody>
+      </p:sp>
+      <p:sp>
+        <p:nvSpPr>
+          <p:cNvPr id="99" name="TextBox"/>
+          <p:cNvSpPr txBox="1"/>
+          <p:nvPr/>
+        </p:nvSpPr>
+        <p:spPr>
+          <a:xfrm>
+            <a:off x="360000" y="1152000"/>
+            <a:ext cx="2808000" cy="2088000"/>
+          </a:xfrm>
+          <a:prstGeom prst="rect">
+            <a:avLst/>
+          </a:prstGeom>
+          <a:solidFill>
+            <a:srgbClr val="1A5276"/>
+          </a:solidFill>
+          <a:ln>
+            <a:noFill/>
+          </a:ln>
+        </p:spPr>
+        <p:txBody>
+          <a:bodyPr wrap="square" anchor="ctr"/>
+          <a:lstStyle/>
+          <a:p>
+            <a:pPr algn="l"/>
+            <a:r>
+              <a:rPr lang="ru-RU" sz="1400" b="0">
+                <a:solidFill>
+                  <a:srgbClr val="FFFFFF"/>
+                </a:solidFill>
+              </a:rPr>
+              <a:t/>
+            </a:r>
+            <a:br>
+              <a:rPr lang="ru-RU"/>
+            </a:br>
+          </a:p>
+        </p:txBody>
+      </p:sp>
+      <p:sp>
+        <p:nvSpPr>
+          <p:cNvPr id="99" name="TextBox"/>
+          <p:cNvSpPr txBox="1"/>
+          <p:nvPr/>
+        </p:nvSpPr>
+        <p:spPr>
+          <a:xfrm>
+            <a:off x="468000" y="1296000"/>
+            <a:ext cx="2592000" cy="864000"/>
+          </a:xfrm>
+          <a:prstGeom prst="rect">
+            <a:avLst/>
+          </a:prstGeom>
+          <a:noFill/>
+          <a:ln>
+            <a:noFill/>
+          </a:ln>
+        </p:spPr>
+        <p:txBody>
+          <a:bodyPr wrap="square" anchor="ctr"/>
+          <a:lstStyle/>
+          <a:p>
+            <a:pPr algn="ctr"/>
+            <a:r>
+              <a:rPr lang="ru-RU" sz="3600" b="1">
+                <a:solidFill>
+                  <a:srgbClr val="FFFFFF"/>
+                </a:solidFill>
+              </a:rPr>
+              <a:t>9 994</a:t>
+            </a:r>
+            <a:br>
+              <a:rPr lang="ru-RU"/>
+            </a:br>
+          </a:p>
+        </p:txBody>
+      </p:sp>
+      <p:sp>
+        <p:nvSpPr>
+          <p:cNvPr id="99" name="TextBox"/>
+          <p:cNvSpPr txBox="1"/>
+          <p:nvPr/>
+        </p:nvSpPr>
+        <p:spPr>
+          <a:xfrm>
+            <a:off x="468000" y="2160000"/>
+            <a:ext cx="2592000" cy="1007999"/>
+          </a:xfrm>
+          <a:prstGeom prst="rect">
+            <a:avLst/>
+          </a:prstGeom>
+          <a:noFill/>
+          <a:ln>
+            <a:noFill/>
+          </a:ln>
+        </p:spPr>
+        <p:txBody>
+          <a:bodyPr wrap="square" anchor="ctr"/>
+          <a:lstStyle/>
+          <a:p>
+            <a:pPr algn="ctr"/>
+            <a:r>
+              <a:rPr lang="ru-RU" sz="1200" b="0">
+                <a:solidFill>
+                  <a:srgbClr val="CFE0D6"/>
+                </a:solidFill>
+              </a:rPr>
+              <a:t>публикаций</a:t>
+            </a:r>
+            <a:br>
+              <a:rPr lang="ru-RU"/>
+            </a:br>
+            <a:r>
+              <a:rPr lang="ru-RU" sz="1200" b="0">
+                <a:solidFill>
+                  <a:srgbClr val="CFE0D6"/>
+                </a:solidFill>
+              </a:rPr>
+              <a:t>загружено из OpenAlex</a:t>
+            </a:r>
+            <a:br>
+              <a:rPr lang="ru-RU"/>
+            </a:br>
+          </a:p>
+        </p:txBody>
+      </p:sp>
+      <p:sp>
+        <p:nvSpPr>
+          <p:cNvPr id="99" name="TextBox"/>
+          <p:cNvSpPr txBox="1"/>
+          <p:nvPr/>
+        </p:nvSpPr>
+        <p:spPr>
+          <a:xfrm>
+            <a:off x="3311999" y="1152000"/>
+            <a:ext cx="2808000" cy="2088000"/>
+          </a:xfrm>
+          <a:prstGeom prst="rect">
+            <a:avLst/>
+          </a:prstGeom>
+          <a:solidFill>
+            <a:srgbClr val="1A5C3A"/>
+          </a:solidFill>
+          <a:ln>
+            <a:noFill/>
+          </a:ln>
+        </p:spPr>
+        <p:txBody>
+          <a:bodyPr wrap="square" anchor="ctr"/>
+          <a:lstStyle/>
+          <a:p>
+            <a:pPr algn="l"/>
+            <a:r>
+              <a:rPr lang="ru-RU" sz="1400" b="0">
+                <a:solidFill>
+                  <a:srgbClr val="FFFFFF"/>
+                </a:solidFill>
+              </a:rPr>
+              <a:t/>
+            </a:r>
+            <a:br>
+              <a:rPr lang="ru-RU"/>
+            </a:br>
+          </a:p>
+        </p:txBody>
+      </p:sp>
+      <p:sp>
+        <p:nvSpPr>
+          <p:cNvPr id="99" name="TextBox"/>
+          <p:cNvSpPr txBox="1"/>
+          <p:nvPr/>
+        </p:nvSpPr>
+        <p:spPr>
+          <a:xfrm>
+            <a:off x="3419999" y="1296000"/>
+            <a:ext cx="2592000" cy="864000"/>
+          </a:xfrm>
+          <a:prstGeom prst="rect">
+            <a:avLst/>
+          </a:prstGeom>
+          <a:noFill/>
+          <a:ln>
+            <a:noFill/>
+          </a:ln>
+        </p:spPr>
+        <p:txBody>
+          <a:bodyPr wrap="square" anchor="ctr"/>
+          <a:lstStyle/>
+          <a:p>
+            <a:pPr algn="ctr"/>
+            <a:r>
+              <a:rPr lang="ru-RU" sz="3600" b="1">
+                <a:solidFill>
+                  <a:srgbClr val="FFFFFF"/>
+                </a:solidFill>
+              </a:rPr>
+              <a:t>7</a:t>
+            </a:r>
+            <a:br>
+              <a:rPr lang="ru-RU"/>
+            </a:br>
+          </a:p>
+        </p:txBody>
+      </p:sp>
+      <p:sp>
+        <p:nvSpPr>
+          <p:cNvPr id="99" name="TextBox"/>
+          <p:cNvSpPr txBox="1"/>
+          <p:nvPr/>
+        </p:nvSpPr>
+        <p:spPr>
+          <a:xfrm>
+            <a:off x="3419999" y="2160000"/>
+            <a:ext cx="2592000" cy="1007999"/>
+          </a:xfrm>
+          <a:prstGeom prst="rect">
+            <a:avLst/>
+          </a:prstGeom>
+          <a:noFill/>
+          <a:ln>
+            <a:noFill/>
+          </a:ln>
+        </p:spPr>
+        <p:txBody>
+          <a:bodyPr wrap="square" anchor="ctr"/>
+          <a:lstStyle/>
+          <a:p>
+            <a:pPr algn="ctr"/>
+            <a:r>
+              <a:rPr lang="ru-RU" sz="1200" b="0">
+                <a:solidFill>
+                  <a:srgbClr val="CFE0D6"/>
+                </a:solidFill>
+              </a:rPr>
+              <a:t>таблиц</a:t>
+            </a:r>
+            <a:br>
+              <a:rPr lang="ru-RU"/>
+            </a:br>
+            <a:r>
+              <a:rPr lang="ru-RU" sz="1200" b="0">
+                <a:solidFill>
+                  <a:srgbClr val="CFE0D6"/>
+                </a:solidFill>
+              </a:rPr>
+              <a:t>в базе данных</a:t>
+            </a:r>
+            <a:br>
+              <a:rPr lang="ru-RU"/>
+            </a:br>
+          </a:p>
+        </p:txBody>
+      </p:sp>
+      <p:sp>
+        <p:nvSpPr>
+          <p:cNvPr id="99" name="TextBox"/>
+          <p:cNvSpPr txBox="1"/>
+          <p:nvPr/>
+        </p:nvSpPr>
+        <p:spPr>
+          <a:xfrm>
+            <a:off x="6263999" y="1152000"/>
+            <a:ext cx="2808000" cy="2088000"/>
+          </a:xfrm>
+          <a:prstGeom prst="rect">
+            <a:avLst/>
+          </a:prstGeom>
+          <a:solidFill>
+            <a:srgbClr val="163126"/>
+          </a:solidFill>
+          <a:ln>
+            <a:noFill/>
+          </a:ln>
+        </p:spPr>
+        <p:txBody>
+          <a:bodyPr wrap="square" anchor="ctr"/>
+          <a:lstStyle/>
+          <a:p>
+            <a:pPr algn="l"/>
+            <a:r>
+              <a:rPr lang="ru-RU" sz="1400" b="0">
+                <a:solidFill>
+                  <a:srgbClr val="FFFFFF"/>
+                </a:solidFill>
+              </a:rPr>
+              <a:t/>
+            </a:r>
+            <a:br>
+              <a:rPr lang="ru-RU"/>
+            </a:br>
+          </a:p>
+        </p:txBody>
+      </p:sp>
+      <p:sp>
+        <p:nvSpPr>
+          <p:cNvPr id="99" name="TextBox"/>
+          <p:cNvSpPr txBox="1"/>
+          <p:nvPr/>
+        </p:nvSpPr>
+        <p:spPr>
+          <a:xfrm>
+            <a:off x="6371999" y="1296000"/>
+            <a:ext cx="2592000" cy="864000"/>
+          </a:xfrm>
+          <a:prstGeom prst="rect">
+            <a:avLst/>
+          </a:prstGeom>
+          <a:noFill/>
+          <a:ln>
+            <a:noFill/>
+          </a:ln>
+        </p:spPr>
+        <p:txBody>
+          <a:bodyPr wrap="square" anchor="ctr"/>
+          <a:lstStyle/>
+          <a:p>
+            <a:pPr algn="ctr"/>
+            <a:r>
+              <a:rPr lang="ru-RU" sz="3600" b="1">
+                <a:solidFill>
+                  <a:srgbClr val="FFFFFF"/>
+                </a:solidFill>
+              </a:rPr>
+              <a:t>80,8%</a:t>
+            </a:r>
+            <a:br>
+              <a:rPr lang="ru-RU"/>
+            </a:br>
+          </a:p>
+        </p:txBody>
+      </p:sp>
+      <p:sp>
+        <p:nvSpPr>
+          <p:cNvPr id="99" name="TextBox"/>
+          <p:cNvSpPr txBox="1"/>
+          <p:nvPr/>
+        </p:nvSpPr>
+        <p:spPr>
+          <a:xfrm>
+            <a:off x="6371999" y="2160000"/>
+            <a:ext cx="2592000" cy="1007999"/>
+          </a:xfrm>
+          <a:prstGeom prst="rect">
+            <a:avLst/>
+          </a:prstGeom>
+          <a:noFill/>
+          <a:ln>
+            <a:noFill/>
+          </a:ln>
+        </p:spPr>
+        <p:txBody>
+          <a:bodyPr wrap="square" anchor="ctr"/>
+          <a:lstStyle/>
+          <a:p>
+            <a:pPr algn="ctr"/>
+            <a:r>
+              <a:rPr lang="ru-RU" sz="1200" b="0">
+                <a:solidFill>
+                  <a:srgbClr val="CFE0D6"/>
+                </a:solidFill>
+              </a:rPr>
+              <a:t>публикаций</a:t>
+            </a:r>
+            <a:br>
+              <a:rPr lang="ru-RU"/>
+            </a:br>
+            <a:r>
+              <a:rPr lang="ru-RU" sz="1200" b="0">
+                <a:solidFill>
+                  <a:srgbClr val="CFE0D6"/>
+                </a:solidFill>
+              </a:rPr>
+              <a:t>с геокоординатами</a:t>
+            </a:r>
+            <a:br>
+              <a:rPr lang="ru-RU"/>
+            </a:br>
+            <a:r>
+              <a:rPr lang="ru-RU" sz="1200" b="0">
+                <a:solidFill>
+                  <a:srgbClr val="CFE0D6"/>
+                </a:solidFill>
+              </a:rPr>
+              <a:t>(порог — 75%)</a:t>
+            </a:r>
+            <a:br>
+              <a:rPr lang="ru-RU"/>
+            </a:br>
+          </a:p>
+        </p:txBody>
+      </p:sp>
+      <p:sp>
+        <p:nvSpPr>
+          <p:cNvPr id="99" name="TextBox"/>
+          <p:cNvSpPr txBox="1"/>
+          <p:nvPr/>
+        </p:nvSpPr>
+        <p:spPr>
+          <a:xfrm>
+            <a:off x="9216000" y="1152000"/>
+            <a:ext cx="2808000" cy="2088000"/>
+          </a:xfrm>
+          <a:prstGeom prst="rect">
+            <a:avLst/>
+          </a:prstGeom>
+          <a:solidFill>
+            <a:srgbClr val="7D3C98"/>
+          </a:solidFill>
+          <a:ln>
+            <a:noFill/>
+          </a:ln>
+        </p:spPr>
+        <p:txBody>
+          <a:bodyPr wrap="square" anchor="ctr"/>
+          <a:lstStyle/>
+          <a:p>
+            <a:pPr algn="l"/>
+            <a:r>
+              <a:rPr lang="ru-RU" sz="1400" b="0">
+                <a:solidFill>
+                  <a:srgbClr val="FFFFFF"/>
+                </a:solidFill>
+              </a:rPr>
+              <a:t/>
+            </a:r>
+            <a:br>
+              <a:rPr lang="ru-RU"/>
+            </a:br>
+          </a:p>
+        </p:txBody>
+      </p:sp>
+      <p:sp>
+        <p:nvSpPr>
+          <p:cNvPr id="99" name="TextBox"/>
+          <p:cNvSpPr txBox="1"/>
+          <p:nvPr/>
+        </p:nvSpPr>
+        <p:spPr>
+          <a:xfrm>
+            <a:off x="9324000" y="1296000"/>
+            <a:ext cx="2592000" cy="864000"/>
+          </a:xfrm>
+          <a:prstGeom prst="rect">
+            <a:avLst/>
+          </a:prstGeom>
+          <a:noFill/>
+          <a:ln>
+            <a:noFill/>
+          </a:ln>
+        </p:spPr>
+        <p:txBody>
+          <a:bodyPr wrap="square" anchor="ctr"/>
+          <a:lstStyle/>
+          <a:p>
+            <a:pPr algn="ctr"/>
+            <a:r>
+              <a:rPr lang="ru-RU" sz="3600" b="1">
+                <a:solidFill>
+                  <a:srgbClr val="FFFFFF"/>
+                </a:solidFill>
+              </a:rPr>
+              <a:t>5</a:t>
+            </a:r>
+            <a:br>
+              <a:rPr lang="ru-RU"/>
+            </a:br>
+          </a:p>
+        </p:txBody>
+      </p:sp>
+      <p:sp>
+        <p:nvSpPr>
+          <p:cNvPr id="99" name="TextBox"/>
+          <p:cNvSpPr txBox="1"/>
+          <p:nvPr/>
+        </p:nvSpPr>
+        <p:spPr>
+          <a:xfrm>
+            <a:off x="9324000" y="2160000"/>
+            <a:ext cx="2592000" cy="1007999"/>
+          </a:xfrm>
+          <a:prstGeom prst="rect">
+            <a:avLst/>
+          </a:prstGeom>
+          <a:noFill/>
+          <a:ln>
+            <a:noFill/>
+          </a:ln>
+        </p:spPr>
+        <p:txBody>
+          <a:bodyPr wrap="square" anchor="ctr"/>
+          <a:lstStyle/>
+          <a:p>
+            <a:pPr algn="ctr"/>
+            <a:r>
+              <a:rPr lang="ru-RU" sz="1200" b="0">
+                <a:solidFill>
+                  <a:srgbClr val="CFE0D6"/>
+                </a:solidFill>
+              </a:rPr>
+              <a:t>режимов</a:t>
+            </a:r>
+            <a:br>
+              <a:rPr lang="ru-RU"/>
+            </a:br>
+            <a:r>
+              <a:rPr lang="ru-RU" sz="1200" b="0">
+                <a:solidFill>
+                  <a:srgbClr val="CFE0D6"/>
+                </a:solidFill>
+              </a:rPr>
+              <a:t>отображения</a:t>
+            </a:r>
+            <a:br>
+              <a:rPr lang="ru-RU"/>
+            </a:br>
+            <a:r>
+              <a:rPr lang="ru-RU" sz="1200" b="0">
+                <a:solidFill>
+                  <a:srgbClr val="CFE0D6"/>
+                </a:solidFill>
+              </a:rPr>
+              <a:t>в графе</a:t>
+            </a:r>
+            <a:br>
+              <a:rPr lang="ru-RU"/>
+            </a:br>
+          </a:p>
+        </p:txBody>
+      </p:sp>
+      <p:sp>
+        <p:nvSpPr>
+          <p:cNvPr id="99" name="TextBox"/>
+          <p:cNvSpPr txBox="1"/>
+          <p:nvPr/>
+        </p:nvSpPr>
+        <p:spPr>
+          <a:xfrm>
+            <a:off x="468000" y="3528000"/>
+            <a:ext cx="11232000" cy="1260000"/>
+          </a:xfrm>
+          <a:prstGeom prst="rect">
+            <a:avLst/>
+          </a:prstGeom>
+          <a:noFill/>
+          <a:ln>
+            <a:noFill/>
+          </a:ln>
+        </p:spPr>
+        <p:txBody>
+          <a:bodyPr wrap="square" anchor="ctr"/>
+          <a:lstStyle/>
+          <a:p>
+            <a:pPr algn="l"/>
+            <a:r>
+              <a:rPr lang="ru-RU" sz="1300" b="0">
+                <a:solidFill>
+                  <a:srgbClr val="E8F5ED"/>
+                </a:solidFill>
+              </a:rPr>
+              <a:t>Система переводит плоский список статей в два визуальных представления — карту с географией исследований и граф с авторскими связями.</a:t>
+            </a:r>
+            <a:br>
+              <a:rPr lang="ru-RU"/>
+            </a:br>
+            <a:r>
+              <a:rPr lang="ru-RU" sz="1300" b="0">
+                <a:solidFill>
+                  <a:srgbClr val="E8F5ED"/>
+                </a:solidFill>
+              </a:rPr>
+              <a:t>В отличие от рассмотренных аналогов (VOSviewer, Connected Papers, ResearchRabbit) сочетает карту, граф и поиск похожих в одной браузерной среде без установки ПО.</a:t>
+            </a:r>
+            <a:br>
+              <a:rPr lang="ru-RU"/>
+            </a:br>
+          </a:p>
+        </p:txBody>
+      </p:sp>
+      <p:sp>
+        <p:nvSpPr>
+          <p:cNvPr id="99" name="TextBox"/>
+          <p:cNvSpPr txBox="1"/>
+          <p:nvPr/>
+        </p:nvSpPr>
+        <p:spPr>
+          <a:xfrm>
+            <a:off x="468000" y="4896000"/>
+            <a:ext cx="11232000" cy="792000"/>
+          </a:xfrm>
+          <a:prstGeom prst="rect">
+            <a:avLst/>
+          </a:prstGeom>
+          <a:noFill/>
+          <a:ln>
+            <a:noFill/>
+          </a:ln>
+        </p:spPr>
+        <p:txBody>
+          <a:bodyPr wrap="square" anchor="ctr"/>
+          <a:lstStyle/>
+          <a:p>
+            <a:pPr algn="l"/>
+            <a:r>
+              <a:rPr lang="ru-RU" sz="1200" b="0">
+                <a:solidFill>
+                  <a:srgbClr val="8BB29A"/>
+                </a:solidFill>
+              </a:rPr>
+              <a:t>Алгоритм поиска похожих статей: авторы (×4) · темы (×3) · ключевые слова (×2) · аффилиации (×2) · журнал (×2)</a:t>
+            </a:r>
+            <a:br>
+              <a:rPr lang="ru-RU"/>
+            </a:br>
+          </a:p>
+        </p:txBody>
+      </p:sp>
+      <p:sp>
+        <p:nvSpPr>
+          <p:cNvPr id="99" name="TextBox"/>
+          <p:cNvSpPr txBox="1"/>
+          <p:nvPr/>
+        </p:nvSpPr>
+        <p:spPr>
+          <a:xfrm>
             <a:off x="0" y="6757200"/>
-            <a:ext cx="12188825" cy="100800"/>
-          </a:xfrm>
-          <a:noFill/>
+            <a:ext cx="12192000" cy="100800"/>
+          </a:xfrm>
           <a:prstGeom prst="rect">
             <a:avLst/>
           </a:prstGeom>
@@ -8663,25 +9184,35 @@
           </a:ln>
         </p:spPr>
         <p:txBody>
-          <a:bodyPr wrap="none">
-            <a:spAutoFit/>
-          </a:bodyPr>
-          <a:lstStyle/>
-          <a:p/>
-        </p:txBody>
-      </p:sp>
-      <p:sp>
-        <p:nvSpPr>
-          <p:cNvPr id="34" name="TextBox 33"/>
+          <a:bodyPr wrap="square" anchor="ctr"/>
+          <a:lstStyle/>
+          <a:p>
+            <a:pPr algn="l"/>
+            <a:r>
+              <a:rPr lang="ru-RU" sz="1400" b="0">
+                <a:solidFill>
+                  <a:srgbClr val="FFFFFF"/>
+                </a:solidFill>
+              </a:rPr>
+              <a:t/>
+            </a:r>
+            <a:br>
+              <a:rPr lang="ru-RU"/>
+            </a:br>
+          </a:p>
+        </p:txBody>
+      </p:sp>
+      <p:sp>
+        <p:nvSpPr>
+          <p:cNvPr id="99" name="TextBox"/>
           <p:cNvSpPr txBox="1"/>
           <p:nvPr/>
         </p:nvSpPr>
         <p:spPr>
           <a:xfrm>
             <a:off x="0" y="6757200"/>
-            <a:ext cx="12188825" cy="100800"/>
-          </a:xfrm>
-          <a:noFill/>
+            <a:ext cx="12192000" cy="100800"/>
+          </a:xfrm>
           <a:prstGeom prst="rect">
             <a:avLst/>
           </a:prstGeom>
@@ -8693,26 +9224,36 @@
           </a:ln>
         </p:spPr>
         <p:txBody>
-          <a:bodyPr wrap="none">
-            <a:spAutoFit/>
-          </a:bodyPr>
-          <a:lstStyle/>
-          <a:p/>
-        </p:txBody>
-      </p:sp>
-      <p:sp>
-        <p:nvSpPr>
-          <p:cNvPr id="35" name="TextBox 34"/>
+          <a:bodyPr wrap="square" anchor="ctr"/>
+          <a:lstStyle/>
+          <a:p>
+            <a:pPr algn="l"/>
+            <a:r>
+              <a:rPr lang="ru-RU" sz="1400" b="0">
+                <a:solidFill>
+                  <a:srgbClr val="FFFFFF"/>
+                </a:solidFill>
+              </a:rPr>
+              <a:t/>
+            </a:r>
+            <a:br>
+              <a:rPr lang="ru-RU"/>
+            </a:br>
+          </a:p>
+        </p:txBody>
+      </p:sp>
+      <p:sp>
+        <p:nvSpPr>
+          <p:cNvPr id="99" name="TextBox"/>
           <p:cNvSpPr txBox="1"/>
           <p:nvPr/>
         </p:nvSpPr>
         <p:spPr>
           <a:xfrm>
-            <a:off x="11864825" y="6645600"/>
+            <a:off x="11868000" y="6645600"/>
             <a:ext cx="324000" cy="324000"/>
           </a:xfrm>
-          <a:noFill/>
-          <a:prstGeom prst="ellipse">
+          <a:prstGeom prst="rect">
             <a:avLst/>
           </a:prstGeom>
           <a:solidFill>
@@ -8723,21 +9264,21 @@
           </a:ln>
         </p:spPr>
         <p:txBody>
-          <a:bodyPr wrap="none" anchor="ctr">
-            <a:spAutoFit/>
-          </a:bodyPr>
+          <a:bodyPr wrap="square" anchor="ctr"/>
           <a:lstStyle/>
           <a:p>
             <a:pPr algn="ctr"/>
             <a:r>
-              <a:rPr sz="900" b="1">
+              <a:rPr lang="ru-RU" sz="900" b="1">
                 <a:solidFill>
                   <a:srgbClr val="FFFFFF"/>
                 </a:solidFill>
-                <a:latin typeface="Arial"/>
               </a:rPr>
               <a:t>14</a:t>
             </a:r>
+            <a:br>
+              <a:rPr lang="ru-RU"/>
+            </a:br>
           </a:p>
         </p:txBody>
       </p:sp>

</xml_diff>

<commit_message>
style(presentation): progress bar as moving dark rectangle with number at tip
Full-width dark track + solid rectangle growing left→right per slide.
Lighter accent at the leading edge, slide number printed at the tip.

https://claude.ai/code/session_01JXZNXE9oVEv7rsUiTvXR5D
</commit_message>
<xml_diff>
--- a/docs/Визуализация науки на основе метаданных публикаций и журналов.pptx
+++ b/docs/Визуализация науки на основе метаданных публикаций и журналов.pptx
@@ -4336,46 +4336,69 @@
       </p:sp>
       <p:sp>
         <p:nvSpPr>
-          <p:cNvPr id="8" name="TextBox 7"/>
-          <p:cNvSpPr txBox="1"/>
-          <p:nvPr/>
-        </p:nvSpPr>
-        <p:spPr>
-          <a:xfrm>
-            <a:off x="0" y="6757200"/>
-            <a:ext cx="12188825" cy="100800"/>
-          </a:xfrm>
-          <a:noFill/>
+          <p:cNvPr id="2010" name="pb10"/>
+          <p:cNvSpPr txBox="1"/>
+          <p:nvPr/>
+        </p:nvSpPr>
+        <p:spPr>
+          <a:xfrm>
+            <a:off x="0" y="6660000"/>
+            <a:ext cx="12192000" cy="198000"/>
+          </a:xfrm>
           <a:prstGeom prst="rect">
             <a:avLst/>
           </a:prstGeom>
           <a:solidFill>
-            <a:srgbClr val="122017"/>
+            <a:srgbClr val="0D1F14"/>
           </a:solidFill>
           <a:ln>
             <a:noFill/>
           </a:ln>
         </p:spPr>
         <p:txBody>
-          <a:bodyPr wrap="none">
-            <a:spAutoFit/>
-          </a:bodyPr>
+          <a:bodyPr wrap="none" anchor="ctr"/>
           <a:lstStyle/>
           <a:p/>
         </p:txBody>
       </p:sp>
       <p:sp>
         <p:nvSpPr>
-          <p:cNvPr id="9" name="TextBox 8"/>
-          <p:cNvSpPr txBox="1"/>
-          <p:nvPr/>
-        </p:nvSpPr>
-        <p:spPr>
-          <a:xfrm>
-            <a:off x="0" y="6757200"/>
-            <a:ext cx="870630" cy="100800"/>
-          </a:xfrm>
-          <a:noFill/>
+          <p:cNvPr id="2011" name="pb11"/>
+          <p:cNvSpPr txBox="1"/>
+          <p:nvPr/>
+        </p:nvSpPr>
+        <p:spPr>
+          <a:xfrm>
+            <a:off x="0" y="6660000"/>
+            <a:ext cx="870857" cy="198000"/>
+          </a:xfrm>
+          <a:prstGeom prst="rect">
+            <a:avLst/>
+          </a:prstGeom>
+          <a:solidFill>
+            <a:srgbClr val="2D5544"/>
+          </a:solidFill>
+          <a:ln>
+            <a:noFill/>
+          </a:ln>
+        </p:spPr>
+        <p:txBody>
+          <a:bodyPr wrap="none" anchor="ctr"/>
+          <a:lstStyle/>
+          <a:p/>
+        </p:txBody>
+      </p:sp>
+      <p:sp>
+        <p:nvSpPr>
+          <p:cNvPr id="2012" name="pb12"/>
+          <p:cNvSpPr txBox="1"/>
+          <p:nvPr/>
+        </p:nvSpPr>
+        <p:spPr>
+          <a:xfrm>
+            <a:off x="330857" y="6660000"/>
+            <a:ext cx="540000" cy="198000"/>
+          </a:xfrm>
           <a:prstGeom prst="rect">
             <a:avLst/>
           </a:prstGeom>
@@ -4387,48 +4410,42 @@
           </a:ln>
         </p:spPr>
         <p:txBody>
-          <a:bodyPr wrap="none">
-            <a:spAutoFit/>
-          </a:bodyPr>
+          <a:bodyPr wrap="none" anchor="ctr"/>
           <a:lstStyle/>
           <a:p/>
         </p:txBody>
       </p:sp>
       <p:sp>
         <p:nvSpPr>
-          <p:cNvPr id="10" name="TextBox 9"/>
-          <p:cNvSpPr txBox="1"/>
-          <p:nvPr/>
-        </p:nvSpPr>
-        <p:spPr>
-          <a:xfrm>
-            <a:off x="708630" y="6645600"/>
-            <a:ext cx="324000" cy="324000"/>
-          </a:xfrm>
-          <a:noFill/>
-          <a:prstGeom prst="ellipse">
+          <p:cNvPr id="2113" name="pbn13"/>
+          <p:cNvSpPr txBox="1"/>
+          <p:nvPr/>
+        </p:nvSpPr>
+        <p:spPr>
+          <a:xfrm>
+            <a:off x="222857" y="6660000"/>
+            <a:ext cx="648000" cy="198000"/>
+          </a:xfrm>
+          <a:prstGeom prst="rect">
             <a:avLst/>
           </a:prstGeom>
           <a:solidFill>
-            <a:srgbClr val="8BB29A"/>
+            <a:srgbClr val="23613F"/>
           </a:solidFill>
           <a:ln>
             <a:noFill/>
           </a:ln>
         </p:spPr>
         <p:txBody>
-          <a:bodyPr wrap="none" anchor="ctr">
-            <a:spAutoFit/>
-          </a:bodyPr>
+          <a:bodyPr wrap="none" anchor="ctr"/>
           <a:lstStyle/>
           <a:p>
             <a:pPr algn="ctr"/>
             <a:r>
-              <a:rPr sz="900" b="1">
+              <a:rPr lang="ru-RU" sz="800" b="1">
                 <a:solidFill>
                   <a:srgbClr val="FFFFFF"/>
                 </a:solidFill>
-                <a:latin typeface="Arial"/>
               </a:rPr>
               <a:t>1</a:t>
             </a:r>
@@ -5364,46 +5381,69 @@
       </p:sp>
       <p:sp>
         <p:nvSpPr>
-          <p:cNvPr id="23" name="TextBox 22"/>
-          <p:cNvSpPr txBox="1"/>
-          <p:nvPr/>
-        </p:nvSpPr>
-        <p:spPr>
-          <a:xfrm>
-            <a:off x="0" y="6757200"/>
-            <a:ext cx="12188825" cy="100800"/>
-          </a:xfrm>
-          <a:noFill/>
+          <p:cNvPr id="2100" name="pb100"/>
+          <p:cNvSpPr txBox="1"/>
+          <p:nvPr/>
+        </p:nvSpPr>
+        <p:spPr>
+          <a:xfrm>
+            <a:off x="0" y="6660000"/>
+            <a:ext cx="12192000" cy="198000"/>
+          </a:xfrm>
           <a:prstGeom prst="rect">
             <a:avLst/>
           </a:prstGeom>
           <a:solidFill>
-            <a:srgbClr val="122017"/>
+            <a:srgbClr val="0D1F14"/>
           </a:solidFill>
           <a:ln>
             <a:noFill/>
           </a:ln>
         </p:spPr>
         <p:txBody>
-          <a:bodyPr wrap="none">
-            <a:spAutoFit/>
-          </a:bodyPr>
+          <a:bodyPr wrap="none" anchor="ctr"/>
           <a:lstStyle/>
           <a:p/>
         </p:txBody>
       </p:sp>
       <p:sp>
         <p:nvSpPr>
-          <p:cNvPr id="24" name="TextBox 23"/>
-          <p:cNvSpPr txBox="1"/>
-          <p:nvPr/>
-        </p:nvSpPr>
-        <p:spPr>
-          <a:xfrm>
-            <a:off x="0" y="6757200"/>
-            <a:ext cx="8706303" cy="100800"/>
-          </a:xfrm>
-          <a:noFill/>
+          <p:cNvPr id="2101" name="pb101"/>
+          <p:cNvSpPr txBox="1"/>
+          <p:nvPr/>
+        </p:nvSpPr>
+        <p:spPr>
+          <a:xfrm>
+            <a:off x="0" y="6660000"/>
+            <a:ext cx="8708571" cy="198000"/>
+          </a:xfrm>
+          <a:prstGeom prst="rect">
+            <a:avLst/>
+          </a:prstGeom>
+          <a:solidFill>
+            <a:srgbClr val="2D5544"/>
+          </a:solidFill>
+          <a:ln>
+            <a:noFill/>
+          </a:ln>
+        </p:spPr>
+        <p:txBody>
+          <a:bodyPr wrap="none" anchor="ctr"/>
+          <a:lstStyle/>
+          <a:p/>
+        </p:txBody>
+      </p:sp>
+      <p:sp>
+        <p:nvSpPr>
+          <p:cNvPr id="2102" name="pb102"/>
+          <p:cNvSpPr txBox="1"/>
+          <p:nvPr/>
+        </p:nvSpPr>
+        <p:spPr>
+          <a:xfrm>
+            <a:off x="8168571" y="6660000"/>
+            <a:ext cx="540000" cy="198000"/>
+          </a:xfrm>
           <a:prstGeom prst="rect">
             <a:avLst/>
           </a:prstGeom>
@@ -5415,48 +5455,42 @@
           </a:ln>
         </p:spPr>
         <p:txBody>
-          <a:bodyPr wrap="none">
-            <a:spAutoFit/>
-          </a:bodyPr>
+          <a:bodyPr wrap="none" anchor="ctr"/>
           <a:lstStyle/>
           <a:p/>
         </p:txBody>
       </p:sp>
       <p:sp>
         <p:nvSpPr>
-          <p:cNvPr id="25" name="TextBox 24"/>
-          <p:cNvSpPr txBox="1"/>
-          <p:nvPr/>
-        </p:nvSpPr>
-        <p:spPr>
-          <a:xfrm>
-            <a:off x="8544303" y="6645600"/>
-            <a:ext cx="324000" cy="324000"/>
-          </a:xfrm>
-          <a:noFill/>
-          <a:prstGeom prst="ellipse">
+          <p:cNvPr id="2203" name="pbn103"/>
+          <p:cNvSpPr txBox="1"/>
+          <p:nvPr/>
+        </p:nvSpPr>
+        <p:spPr>
+          <a:xfrm>
+            <a:off x="8060571" y="6660000"/>
+            <a:ext cx="648000" cy="198000"/>
+          </a:xfrm>
+          <a:prstGeom prst="rect">
             <a:avLst/>
           </a:prstGeom>
           <a:solidFill>
-            <a:srgbClr val="8BB29A"/>
+            <a:srgbClr val="23613F"/>
           </a:solidFill>
           <a:ln>
             <a:noFill/>
           </a:ln>
         </p:spPr>
         <p:txBody>
-          <a:bodyPr wrap="none" anchor="ctr">
-            <a:spAutoFit/>
-          </a:bodyPr>
+          <a:bodyPr wrap="none" anchor="ctr"/>
           <a:lstStyle/>
           <a:p>
             <a:pPr algn="ctr"/>
             <a:r>
-              <a:rPr sz="900" b="1">
+              <a:rPr lang="ru-RU" sz="800" b="1">
                 <a:solidFill>
                   <a:srgbClr val="FFFFFF"/>
                 </a:solidFill>
-                <a:latin typeface="Arial"/>
               </a:rPr>
               <a:t>10</a:t>
             </a:r>
@@ -5991,46 +6025,69 @@
       </p:sp>
       <p:sp>
         <p:nvSpPr>
-          <p:cNvPr id="12" name="TextBox 11"/>
-          <p:cNvSpPr txBox="1"/>
-          <p:nvPr/>
-        </p:nvSpPr>
-        <p:spPr>
-          <a:xfrm>
-            <a:off x="0" y="6757200"/>
-            <a:ext cx="12188825" cy="100800"/>
-          </a:xfrm>
-          <a:noFill/>
+          <p:cNvPr id="2110" name="pb110"/>
+          <p:cNvSpPr txBox="1"/>
+          <p:nvPr/>
+        </p:nvSpPr>
+        <p:spPr>
+          <a:xfrm>
+            <a:off x="0" y="6660000"/>
+            <a:ext cx="12192000" cy="198000"/>
+          </a:xfrm>
           <a:prstGeom prst="rect">
             <a:avLst/>
           </a:prstGeom>
           <a:solidFill>
-            <a:srgbClr val="122017"/>
+            <a:srgbClr val="0D1F14"/>
           </a:solidFill>
           <a:ln>
             <a:noFill/>
           </a:ln>
         </p:spPr>
         <p:txBody>
-          <a:bodyPr wrap="none">
-            <a:spAutoFit/>
-          </a:bodyPr>
+          <a:bodyPr wrap="none" anchor="ctr"/>
           <a:lstStyle/>
           <a:p/>
         </p:txBody>
       </p:sp>
       <p:sp>
         <p:nvSpPr>
-          <p:cNvPr id="13" name="TextBox 12"/>
-          <p:cNvSpPr txBox="1"/>
-          <p:nvPr/>
-        </p:nvSpPr>
-        <p:spPr>
-          <a:xfrm>
-            <a:off x="0" y="6757200"/>
-            <a:ext cx="9576933" cy="100800"/>
-          </a:xfrm>
-          <a:noFill/>
+          <p:cNvPr id="2111" name="pb111"/>
+          <p:cNvSpPr txBox="1"/>
+          <p:nvPr/>
+        </p:nvSpPr>
+        <p:spPr>
+          <a:xfrm>
+            <a:off x="0" y="6660000"/>
+            <a:ext cx="9579428" cy="198000"/>
+          </a:xfrm>
+          <a:prstGeom prst="rect">
+            <a:avLst/>
+          </a:prstGeom>
+          <a:solidFill>
+            <a:srgbClr val="2D5544"/>
+          </a:solidFill>
+          <a:ln>
+            <a:noFill/>
+          </a:ln>
+        </p:spPr>
+        <p:txBody>
+          <a:bodyPr wrap="none" anchor="ctr"/>
+          <a:lstStyle/>
+          <a:p/>
+        </p:txBody>
+      </p:sp>
+      <p:sp>
+        <p:nvSpPr>
+          <p:cNvPr id="2112" name="pb112"/>
+          <p:cNvSpPr txBox="1"/>
+          <p:nvPr/>
+        </p:nvSpPr>
+        <p:spPr>
+          <a:xfrm>
+            <a:off x="9039428" y="6660000"/>
+            <a:ext cx="540000" cy="198000"/>
+          </a:xfrm>
           <a:prstGeom prst="rect">
             <a:avLst/>
           </a:prstGeom>
@@ -6042,48 +6099,42 @@
           </a:ln>
         </p:spPr>
         <p:txBody>
-          <a:bodyPr wrap="none">
-            <a:spAutoFit/>
-          </a:bodyPr>
+          <a:bodyPr wrap="none" anchor="ctr"/>
           <a:lstStyle/>
           <a:p/>
         </p:txBody>
       </p:sp>
       <p:sp>
         <p:nvSpPr>
-          <p:cNvPr id="14" name="TextBox 13"/>
-          <p:cNvSpPr txBox="1"/>
-          <p:nvPr/>
-        </p:nvSpPr>
-        <p:spPr>
-          <a:xfrm>
-            <a:off x="9414933" y="6645600"/>
-            <a:ext cx="324000" cy="324000"/>
-          </a:xfrm>
-          <a:noFill/>
-          <a:prstGeom prst="ellipse">
+          <p:cNvPr id="2213" name="pbn113"/>
+          <p:cNvSpPr txBox="1"/>
+          <p:nvPr/>
+        </p:nvSpPr>
+        <p:spPr>
+          <a:xfrm>
+            <a:off x="8931428" y="6660000"/>
+            <a:ext cx="648000" cy="198000"/>
+          </a:xfrm>
+          <a:prstGeom prst="rect">
             <a:avLst/>
           </a:prstGeom>
           <a:solidFill>
-            <a:srgbClr val="8BB29A"/>
+            <a:srgbClr val="23613F"/>
           </a:solidFill>
           <a:ln>
             <a:noFill/>
           </a:ln>
         </p:spPr>
         <p:txBody>
-          <a:bodyPr wrap="none" anchor="ctr">
-            <a:spAutoFit/>
-          </a:bodyPr>
+          <a:bodyPr wrap="none" anchor="ctr"/>
           <a:lstStyle/>
           <a:p>
             <a:pPr algn="ctr"/>
             <a:r>
-              <a:rPr sz="900" b="1">
+              <a:rPr lang="ru-RU" sz="800" b="1">
                 <a:solidFill>
                   <a:srgbClr val="FFFFFF"/>
                 </a:solidFill>
-                <a:latin typeface="Arial"/>
               </a:rPr>
               <a:t>11</a:t>
             </a:r>
@@ -6800,46 +6851,69 @@
       </p:sp>
       <p:sp>
         <p:nvSpPr>
-          <p:cNvPr id="16" name="TextBox 15"/>
-          <p:cNvSpPr txBox="1"/>
-          <p:nvPr/>
-        </p:nvSpPr>
-        <p:spPr>
-          <a:xfrm>
-            <a:off x="0" y="6757200"/>
-            <a:ext cx="12188825" cy="100800"/>
-          </a:xfrm>
-          <a:noFill/>
+          <p:cNvPr id="2120" name="pb120"/>
+          <p:cNvSpPr txBox="1"/>
+          <p:nvPr/>
+        </p:nvSpPr>
+        <p:spPr>
+          <a:xfrm>
+            <a:off x="0" y="6660000"/>
+            <a:ext cx="12192000" cy="198000"/>
+          </a:xfrm>
           <a:prstGeom prst="rect">
             <a:avLst/>
           </a:prstGeom>
           <a:solidFill>
-            <a:srgbClr val="122017"/>
+            <a:srgbClr val="0D1F14"/>
           </a:solidFill>
           <a:ln>
             <a:noFill/>
           </a:ln>
         </p:spPr>
         <p:txBody>
-          <a:bodyPr wrap="none">
-            <a:spAutoFit/>
-          </a:bodyPr>
+          <a:bodyPr wrap="none" anchor="ctr"/>
           <a:lstStyle/>
           <a:p/>
         </p:txBody>
       </p:sp>
       <p:sp>
         <p:nvSpPr>
-          <p:cNvPr id="17" name="TextBox 16"/>
-          <p:cNvSpPr txBox="1"/>
-          <p:nvPr/>
-        </p:nvSpPr>
-        <p:spPr>
-          <a:xfrm>
-            <a:off x="0" y="6757200"/>
-            <a:ext cx="10447564" cy="100800"/>
-          </a:xfrm>
-          <a:noFill/>
+          <p:cNvPr id="2121" name="pb121"/>
+          <p:cNvSpPr txBox="1"/>
+          <p:nvPr/>
+        </p:nvSpPr>
+        <p:spPr>
+          <a:xfrm>
+            <a:off x="0" y="6660000"/>
+            <a:ext cx="10450285" cy="198000"/>
+          </a:xfrm>
+          <a:prstGeom prst="rect">
+            <a:avLst/>
+          </a:prstGeom>
+          <a:solidFill>
+            <a:srgbClr val="2D5544"/>
+          </a:solidFill>
+          <a:ln>
+            <a:noFill/>
+          </a:ln>
+        </p:spPr>
+        <p:txBody>
+          <a:bodyPr wrap="none" anchor="ctr"/>
+          <a:lstStyle/>
+          <a:p/>
+        </p:txBody>
+      </p:sp>
+      <p:sp>
+        <p:nvSpPr>
+          <p:cNvPr id="2122" name="pb122"/>
+          <p:cNvSpPr txBox="1"/>
+          <p:nvPr/>
+        </p:nvSpPr>
+        <p:spPr>
+          <a:xfrm>
+            <a:off x="9910285" y="6660000"/>
+            <a:ext cx="540000" cy="198000"/>
+          </a:xfrm>
           <a:prstGeom prst="rect">
             <a:avLst/>
           </a:prstGeom>
@@ -6851,48 +6925,42 @@
           </a:ln>
         </p:spPr>
         <p:txBody>
-          <a:bodyPr wrap="none">
-            <a:spAutoFit/>
-          </a:bodyPr>
+          <a:bodyPr wrap="none" anchor="ctr"/>
           <a:lstStyle/>
           <a:p/>
         </p:txBody>
       </p:sp>
       <p:sp>
         <p:nvSpPr>
-          <p:cNvPr id="18" name="TextBox 17"/>
-          <p:cNvSpPr txBox="1"/>
-          <p:nvPr/>
-        </p:nvSpPr>
-        <p:spPr>
-          <a:xfrm>
-            <a:off x="10285564" y="6645600"/>
-            <a:ext cx="324000" cy="324000"/>
-          </a:xfrm>
-          <a:noFill/>
-          <a:prstGeom prst="ellipse">
+          <p:cNvPr id="2223" name="pbn123"/>
+          <p:cNvSpPr txBox="1"/>
+          <p:nvPr/>
+        </p:nvSpPr>
+        <p:spPr>
+          <a:xfrm>
+            <a:off x="9802285" y="6660000"/>
+            <a:ext cx="648000" cy="198000"/>
+          </a:xfrm>
+          <a:prstGeom prst="rect">
             <a:avLst/>
           </a:prstGeom>
           <a:solidFill>
-            <a:srgbClr val="8BB29A"/>
+            <a:srgbClr val="23613F"/>
           </a:solidFill>
           <a:ln>
             <a:noFill/>
           </a:ln>
         </p:spPr>
         <p:txBody>
-          <a:bodyPr wrap="none" anchor="ctr">
-            <a:spAutoFit/>
-          </a:bodyPr>
+          <a:bodyPr wrap="none" anchor="ctr"/>
           <a:lstStyle/>
           <a:p>
             <a:pPr algn="ctr"/>
             <a:r>
-              <a:rPr sz="900" b="1">
+              <a:rPr lang="ru-RU" sz="800" b="1">
                 <a:solidFill>
                   <a:srgbClr val="FFFFFF"/>
                 </a:solidFill>
-                <a:latin typeface="Arial"/>
               </a:rPr>
               <a:t>12</a:t>
             </a:r>
@@ -7258,46 +7326,69 @@
       </p:sp>
       <p:sp>
         <p:nvSpPr>
-          <p:cNvPr id="6" name="TextBox 5"/>
-          <p:cNvSpPr txBox="1"/>
-          <p:nvPr/>
-        </p:nvSpPr>
-        <p:spPr>
-          <a:xfrm>
-            <a:off x="0" y="6757200"/>
-            <a:ext cx="12188825" cy="100800"/>
-          </a:xfrm>
-          <a:noFill/>
+          <p:cNvPr id="2130" name="pb130"/>
+          <p:cNvSpPr txBox="1"/>
+          <p:nvPr/>
+        </p:nvSpPr>
+        <p:spPr>
+          <a:xfrm>
+            <a:off x="0" y="6660000"/>
+            <a:ext cx="12192000" cy="198000"/>
+          </a:xfrm>
           <a:prstGeom prst="rect">
             <a:avLst/>
           </a:prstGeom>
           <a:solidFill>
-            <a:srgbClr val="122017"/>
+            <a:srgbClr val="0D1F14"/>
           </a:solidFill>
           <a:ln>
             <a:noFill/>
           </a:ln>
         </p:spPr>
         <p:txBody>
-          <a:bodyPr wrap="none">
-            <a:spAutoFit/>
-          </a:bodyPr>
+          <a:bodyPr wrap="none" anchor="ctr"/>
           <a:lstStyle/>
           <a:p/>
         </p:txBody>
       </p:sp>
       <p:sp>
         <p:nvSpPr>
-          <p:cNvPr id="7" name="TextBox 6"/>
-          <p:cNvSpPr txBox="1"/>
-          <p:nvPr/>
-        </p:nvSpPr>
-        <p:spPr>
-          <a:xfrm>
-            <a:off x="0" y="6757200"/>
-            <a:ext cx="11318194" cy="100800"/>
-          </a:xfrm>
-          <a:noFill/>
+          <p:cNvPr id="2131" name="pb131"/>
+          <p:cNvSpPr txBox="1"/>
+          <p:nvPr/>
+        </p:nvSpPr>
+        <p:spPr>
+          <a:xfrm>
+            <a:off x="0" y="6660000"/>
+            <a:ext cx="11321142" cy="198000"/>
+          </a:xfrm>
+          <a:prstGeom prst="rect">
+            <a:avLst/>
+          </a:prstGeom>
+          <a:solidFill>
+            <a:srgbClr val="2D5544"/>
+          </a:solidFill>
+          <a:ln>
+            <a:noFill/>
+          </a:ln>
+        </p:spPr>
+        <p:txBody>
+          <a:bodyPr wrap="none" anchor="ctr"/>
+          <a:lstStyle/>
+          <a:p/>
+        </p:txBody>
+      </p:sp>
+      <p:sp>
+        <p:nvSpPr>
+          <p:cNvPr id="2132" name="pb132"/>
+          <p:cNvSpPr txBox="1"/>
+          <p:nvPr/>
+        </p:nvSpPr>
+        <p:spPr>
+          <a:xfrm>
+            <a:off x="10781142" y="6660000"/>
+            <a:ext cx="540000" cy="198000"/>
+          </a:xfrm>
           <a:prstGeom prst="rect">
             <a:avLst/>
           </a:prstGeom>
@@ -7309,48 +7400,42 @@
           </a:ln>
         </p:spPr>
         <p:txBody>
-          <a:bodyPr wrap="none">
-            <a:spAutoFit/>
-          </a:bodyPr>
+          <a:bodyPr wrap="none" anchor="ctr"/>
           <a:lstStyle/>
           <a:p/>
         </p:txBody>
       </p:sp>
       <p:sp>
         <p:nvSpPr>
-          <p:cNvPr id="8" name="TextBox 7"/>
-          <p:cNvSpPr txBox="1"/>
-          <p:nvPr/>
-        </p:nvSpPr>
-        <p:spPr>
-          <a:xfrm>
-            <a:off x="11156194" y="6645600"/>
-            <a:ext cx="324000" cy="324000"/>
-          </a:xfrm>
-          <a:noFill/>
-          <a:prstGeom prst="ellipse">
+          <p:cNvPr id="2233" name="pbn133"/>
+          <p:cNvSpPr txBox="1"/>
+          <p:nvPr/>
+        </p:nvSpPr>
+        <p:spPr>
+          <a:xfrm>
+            <a:off x="10673142" y="6660000"/>
+            <a:ext cx="648000" cy="198000"/>
+          </a:xfrm>
+          <a:prstGeom prst="rect">
             <a:avLst/>
           </a:prstGeom>
           <a:solidFill>
-            <a:srgbClr val="8BB29A"/>
+            <a:srgbClr val="23613F"/>
           </a:solidFill>
           <a:ln>
             <a:noFill/>
           </a:ln>
         </p:spPr>
         <p:txBody>
-          <a:bodyPr wrap="none" anchor="ctr">
-            <a:spAutoFit/>
-          </a:bodyPr>
+          <a:bodyPr wrap="none" anchor="ctr"/>
           <a:lstStyle/>
           <a:p>
             <a:pPr algn="ctr"/>
             <a:r>
-              <a:rPr sz="900" b="1">
+              <a:rPr lang="ru-RU" sz="800" b="1">
                 <a:solidFill>
                   <a:srgbClr val="FFFFFF"/>
                 </a:solidFill>
-                <a:latin typeface="Arial"/>
               </a:rPr>
               <a:t>13</a:t>
             </a:r>
@@ -8298,51 +8383,68 @@
       </p:sp>
       <p:sp>
         <p:nvSpPr>
-          <p:cNvPr id="120" name="sp20"/>
-          <p:cNvSpPr txBox="1"/>
-          <p:nvPr/>
-        </p:nvSpPr>
-        <p:spPr>
-          <a:xfrm>
-            <a:off x="0" y="6757200"/>
-            <a:ext cx="12192000" cy="100800"/>
+          <p:cNvPr id="2080" name="pb80"/>
+          <p:cNvSpPr txBox="1"/>
+          <p:nvPr/>
+        </p:nvSpPr>
+        <p:spPr>
+          <a:xfrm>
+            <a:off x="0" y="6660000"/>
+            <a:ext cx="12192000" cy="198000"/>
           </a:xfrm>
           <a:prstGeom prst="rect">
             <a:avLst/>
           </a:prstGeom>
           <a:solidFill>
-            <a:srgbClr val="122017"/>
+            <a:srgbClr val="0D1F14"/>
           </a:solidFill>
           <a:ln>
             <a:noFill/>
           </a:ln>
         </p:spPr>
         <p:txBody>
-          <a:bodyPr wrap="square" anchor="ctr"/>
-          <a:lstStyle/>
-          <a:p>
-            <a:pPr algn="l"/>
-            <a:r>
-              <a:rPr lang="ru-RU" sz="1100" b="0">
-                <a:solidFill>
-                  <a:srgbClr val="FFFFFF"/>
-                </a:solidFill>
-              </a:rPr>
-              <a:t/>
-            </a:r>
-          </a:p>
-        </p:txBody>
-      </p:sp>
-      <p:sp>
-        <p:nvSpPr>
-          <p:cNvPr id="121" name="sp21"/>
-          <p:cNvSpPr txBox="1"/>
-          <p:nvPr/>
-        </p:nvSpPr>
-        <p:spPr>
-          <a:xfrm>
-            <a:off x="0" y="6757200"/>
-            <a:ext cx="6966857" cy="100800"/>
+          <a:bodyPr wrap="none" anchor="ctr"/>
+          <a:lstStyle/>
+          <a:p/>
+        </p:txBody>
+      </p:sp>
+      <p:sp>
+        <p:nvSpPr>
+          <p:cNvPr id="2081" name="pb81"/>
+          <p:cNvSpPr txBox="1"/>
+          <p:nvPr/>
+        </p:nvSpPr>
+        <p:spPr>
+          <a:xfrm>
+            <a:off x="0" y="6660000"/>
+            <a:ext cx="6966857" cy="198000"/>
+          </a:xfrm>
+          <a:prstGeom prst="rect">
+            <a:avLst/>
+          </a:prstGeom>
+          <a:solidFill>
+            <a:srgbClr val="2D5544"/>
+          </a:solidFill>
+          <a:ln>
+            <a:noFill/>
+          </a:ln>
+        </p:spPr>
+        <p:txBody>
+          <a:bodyPr wrap="none" anchor="ctr"/>
+          <a:lstStyle/>
+          <a:p/>
+        </p:txBody>
+      </p:sp>
+      <p:sp>
+        <p:nvSpPr>
+          <p:cNvPr id="2082" name="pb82"/>
+          <p:cNvSpPr txBox="1"/>
+          <p:nvPr/>
+        </p:nvSpPr>
+        <p:spPr>
+          <a:xfrm>
+            <a:off x="6426857" y="6660000"/>
+            <a:ext cx="540000" cy="198000"/>
           </a:xfrm>
           <a:prstGeom prst="rect">
             <a:avLst/>
@@ -8355,49 +8457,39 @@
           </a:ln>
         </p:spPr>
         <p:txBody>
-          <a:bodyPr wrap="square" anchor="ctr"/>
-          <a:lstStyle/>
-          <a:p>
-            <a:pPr algn="l"/>
-            <a:r>
-              <a:rPr lang="ru-RU" sz="1100" b="0">
-                <a:solidFill>
-                  <a:srgbClr val="FFFFFF"/>
-                </a:solidFill>
-              </a:rPr>
-              <a:t/>
-            </a:r>
-          </a:p>
-        </p:txBody>
-      </p:sp>
-      <p:sp>
-        <p:nvSpPr>
-          <p:cNvPr id="122" name="sp22"/>
-          <p:cNvSpPr txBox="1"/>
-          <p:nvPr/>
-        </p:nvSpPr>
-        <p:spPr>
-          <a:xfrm>
-            <a:off x="6804857" y="6645600"/>
-            <a:ext cx="324000" cy="324000"/>
-          </a:xfrm>
-          <a:prstGeom prst="ellipse">
+          <a:bodyPr wrap="none" anchor="ctr"/>
+          <a:lstStyle/>
+          <a:p/>
+        </p:txBody>
+      </p:sp>
+      <p:sp>
+        <p:nvSpPr>
+          <p:cNvPr id="2183" name="pbn83"/>
+          <p:cNvSpPr txBox="1"/>
+          <p:nvPr/>
+        </p:nvSpPr>
+        <p:spPr>
+          <a:xfrm>
+            <a:off x="6318857" y="6660000"/>
+            <a:ext cx="648000" cy="198000"/>
+          </a:xfrm>
+          <a:prstGeom prst="rect">
             <a:avLst/>
           </a:prstGeom>
           <a:solidFill>
-            <a:srgbClr val="8BB29A"/>
+            <a:srgbClr val="23613F"/>
           </a:solidFill>
           <a:ln>
             <a:noFill/>
           </a:ln>
         </p:spPr>
         <p:txBody>
-          <a:bodyPr wrap="square" anchor="ctr"/>
+          <a:bodyPr wrap="none" anchor="ctr"/>
           <a:lstStyle/>
           <a:p>
             <a:pPr algn="ctr"/>
             <a:r>
-              <a:rPr lang="ru-RU" sz="900" b="1">
+              <a:rPr lang="ru-RU" sz="800" b="1">
                 <a:solidFill>
                   <a:srgbClr val="FFFFFF"/>
                 </a:solidFill>
@@ -9164,54 +9256,68 @@
       </p:sp>
       <p:sp>
         <p:nvSpPr>
-          <p:cNvPr id="99" name="TextBox"/>
-          <p:cNvSpPr txBox="1"/>
-          <p:nvPr/>
-        </p:nvSpPr>
-        <p:spPr>
-          <a:xfrm>
-            <a:off x="0" y="6757200"/>
-            <a:ext cx="12192000" cy="100800"/>
+          <p:cNvPr id="2140" name="pb140"/>
+          <p:cNvSpPr txBox="1"/>
+          <p:nvPr/>
+        </p:nvSpPr>
+        <p:spPr>
+          <a:xfrm>
+            <a:off x="0" y="6660000"/>
+            <a:ext cx="12192000" cy="198000"/>
           </a:xfrm>
           <a:prstGeom prst="rect">
             <a:avLst/>
           </a:prstGeom>
           <a:solidFill>
-            <a:srgbClr val="122017"/>
+            <a:srgbClr val="0D1F14"/>
           </a:solidFill>
           <a:ln>
             <a:noFill/>
           </a:ln>
         </p:spPr>
         <p:txBody>
-          <a:bodyPr wrap="square" anchor="ctr"/>
-          <a:lstStyle/>
-          <a:p>
-            <a:pPr algn="l"/>
-            <a:r>
-              <a:rPr lang="ru-RU" sz="1400" b="0">
-                <a:solidFill>
-                  <a:srgbClr val="FFFFFF"/>
-                </a:solidFill>
-              </a:rPr>
-              <a:t/>
-            </a:r>
-            <a:br>
-              <a:rPr lang="ru-RU"/>
-            </a:br>
-          </a:p>
-        </p:txBody>
-      </p:sp>
-      <p:sp>
-        <p:nvSpPr>
-          <p:cNvPr id="99" name="TextBox"/>
-          <p:cNvSpPr txBox="1"/>
-          <p:nvPr/>
-        </p:nvSpPr>
-        <p:spPr>
-          <a:xfrm>
-            <a:off x="0" y="6757200"/>
-            <a:ext cx="12192000" cy="100800"/>
+          <a:bodyPr wrap="none" anchor="ctr"/>
+          <a:lstStyle/>
+          <a:p/>
+        </p:txBody>
+      </p:sp>
+      <p:sp>
+        <p:nvSpPr>
+          <p:cNvPr id="2141" name="pb141"/>
+          <p:cNvSpPr txBox="1"/>
+          <p:nvPr/>
+        </p:nvSpPr>
+        <p:spPr>
+          <a:xfrm>
+            <a:off x="0" y="6660000"/>
+            <a:ext cx="12192000" cy="198000"/>
+          </a:xfrm>
+          <a:prstGeom prst="rect">
+            <a:avLst/>
+          </a:prstGeom>
+          <a:solidFill>
+            <a:srgbClr val="2D5544"/>
+          </a:solidFill>
+          <a:ln>
+            <a:noFill/>
+          </a:ln>
+        </p:spPr>
+        <p:txBody>
+          <a:bodyPr wrap="none" anchor="ctr"/>
+          <a:lstStyle/>
+          <a:p/>
+        </p:txBody>
+      </p:sp>
+      <p:sp>
+        <p:nvSpPr>
+          <p:cNvPr id="2142" name="pb142"/>
+          <p:cNvSpPr txBox="1"/>
+          <p:nvPr/>
+        </p:nvSpPr>
+        <p:spPr>
+          <a:xfrm>
+            <a:off x="11652000" y="6660000"/>
+            <a:ext cx="540000" cy="198000"/>
           </a:xfrm>
           <a:prstGeom prst="rect">
             <a:avLst/>
@@ -9224,61 +9330,45 @@
           </a:ln>
         </p:spPr>
         <p:txBody>
-          <a:bodyPr wrap="square" anchor="ctr"/>
-          <a:lstStyle/>
-          <a:p>
-            <a:pPr algn="l"/>
-            <a:r>
-              <a:rPr lang="ru-RU" sz="1400" b="0">
-                <a:solidFill>
-                  <a:srgbClr val="FFFFFF"/>
-                </a:solidFill>
-              </a:rPr>
-              <a:t/>
-            </a:r>
-            <a:br>
-              <a:rPr lang="ru-RU"/>
-            </a:br>
-          </a:p>
-        </p:txBody>
-      </p:sp>
-      <p:sp>
-        <p:nvSpPr>
-          <p:cNvPr id="99" name="TextBox"/>
-          <p:cNvSpPr txBox="1"/>
-          <p:nvPr/>
-        </p:nvSpPr>
-        <p:spPr>
-          <a:xfrm>
-            <a:off x="11868000" y="6645600"/>
-            <a:ext cx="324000" cy="324000"/>
+          <a:bodyPr wrap="none" anchor="ctr"/>
+          <a:lstStyle/>
+          <a:p/>
+        </p:txBody>
+      </p:sp>
+      <p:sp>
+        <p:nvSpPr>
+          <p:cNvPr id="2243" name="pbn143"/>
+          <p:cNvSpPr txBox="1"/>
+          <p:nvPr/>
+        </p:nvSpPr>
+        <p:spPr>
+          <a:xfrm>
+            <a:off x="11544000" y="6660000"/>
+            <a:ext cx="648000" cy="198000"/>
           </a:xfrm>
           <a:prstGeom prst="rect">
             <a:avLst/>
           </a:prstGeom>
           <a:solidFill>
-            <a:srgbClr val="8BB29A"/>
+            <a:srgbClr val="23613F"/>
           </a:solidFill>
           <a:ln>
             <a:noFill/>
           </a:ln>
         </p:spPr>
         <p:txBody>
-          <a:bodyPr wrap="square" anchor="ctr"/>
+          <a:bodyPr wrap="none" anchor="ctr"/>
           <a:lstStyle/>
           <a:p>
             <a:pPr algn="ctr"/>
             <a:r>
-              <a:rPr lang="ru-RU" sz="900" b="1">
+              <a:rPr lang="ru-RU" sz="800" b="1">
                 <a:solidFill>
                   <a:srgbClr val="FFFFFF"/>
                 </a:solidFill>
               </a:rPr>
               <a:t>14</a:t>
             </a:r>
-            <a:br>
-              <a:rPr lang="ru-RU"/>
-            </a:br>
           </a:p>
         </p:txBody>
       </p:sp>
@@ -9972,46 +10062,69 @@
       </p:sp>
       <p:sp>
         <p:nvSpPr>
-          <p:cNvPr id="19" name="TextBox 18"/>
-          <p:cNvSpPr txBox="1"/>
-          <p:nvPr/>
-        </p:nvSpPr>
-        <p:spPr>
-          <a:xfrm>
-            <a:off x="0" y="6757200"/>
-            <a:ext cx="12188825" cy="100800"/>
-          </a:xfrm>
-          <a:noFill/>
+          <p:cNvPr id="2020" name="pb20"/>
+          <p:cNvSpPr txBox="1"/>
+          <p:nvPr/>
+        </p:nvSpPr>
+        <p:spPr>
+          <a:xfrm>
+            <a:off x="0" y="6660000"/>
+            <a:ext cx="12192000" cy="198000"/>
+          </a:xfrm>
           <a:prstGeom prst="rect">
             <a:avLst/>
           </a:prstGeom>
           <a:solidFill>
-            <a:srgbClr val="122017"/>
+            <a:srgbClr val="0D1F14"/>
           </a:solidFill>
           <a:ln>
             <a:noFill/>
           </a:ln>
         </p:spPr>
         <p:txBody>
-          <a:bodyPr wrap="none">
-            <a:spAutoFit/>
-          </a:bodyPr>
+          <a:bodyPr wrap="none" anchor="ctr"/>
           <a:lstStyle/>
           <a:p/>
         </p:txBody>
       </p:sp>
       <p:sp>
         <p:nvSpPr>
-          <p:cNvPr id="20" name="TextBox 19"/>
-          <p:cNvSpPr txBox="1"/>
-          <p:nvPr/>
-        </p:nvSpPr>
-        <p:spPr>
-          <a:xfrm>
-            <a:off x="0" y="6757200"/>
-            <a:ext cx="1741260" cy="100800"/>
-          </a:xfrm>
-          <a:noFill/>
+          <p:cNvPr id="2021" name="pb21"/>
+          <p:cNvSpPr txBox="1"/>
+          <p:nvPr/>
+        </p:nvSpPr>
+        <p:spPr>
+          <a:xfrm>
+            <a:off x="0" y="6660000"/>
+            <a:ext cx="1741714" cy="198000"/>
+          </a:xfrm>
+          <a:prstGeom prst="rect">
+            <a:avLst/>
+          </a:prstGeom>
+          <a:solidFill>
+            <a:srgbClr val="2D5544"/>
+          </a:solidFill>
+          <a:ln>
+            <a:noFill/>
+          </a:ln>
+        </p:spPr>
+        <p:txBody>
+          <a:bodyPr wrap="none" anchor="ctr"/>
+          <a:lstStyle/>
+          <a:p/>
+        </p:txBody>
+      </p:sp>
+      <p:sp>
+        <p:nvSpPr>
+          <p:cNvPr id="2022" name="pb22"/>
+          <p:cNvSpPr txBox="1"/>
+          <p:nvPr/>
+        </p:nvSpPr>
+        <p:spPr>
+          <a:xfrm>
+            <a:off x="1201714" y="6660000"/>
+            <a:ext cx="540000" cy="198000"/>
+          </a:xfrm>
           <a:prstGeom prst="rect">
             <a:avLst/>
           </a:prstGeom>
@@ -10023,48 +10136,42 @@
           </a:ln>
         </p:spPr>
         <p:txBody>
-          <a:bodyPr wrap="none">
-            <a:spAutoFit/>
-          </a:bodyPr>
+          <a:bodyPr wrap="none" anchor="ctr"/>
           <a:lstStyle/>
           <a:p/>
         </p:txBody>
       </p:sp>
       <p:sp>
         <p:nvSpPr>
-          <p:cNvPr id="21" name="TextBox 20"/>
-          <p:cNvSpPr txBox="1"/>
-          <p:nvPr/>
-        </p:nvSpPr>
-        <p:spPr>
-          <a:xfrm>
-            <a:off x="1579260" y="6645600"/>
-            <a:ext cx="324000" cy="324000"/>
-          </a:xfrm>
-          <a:noFill/>
-          <a:prstGeom prst="ellipse">
+          <p:cNvPr id="2123" name="pbn23"/>
+          <p:cNvSpPr txBox="1"/>
+          <p:nvPr/>
+        </p:nvSpPr>
+        <p:spPr>
+          <a:xfrm>
+            <a:off x="1093714" y="6660000"/>
+            <a:ext cx="648000" cy="198000"/>
+          </a:xfrm>
+          <a:prstGeom prst="rect">
             <a:avLst/>
           </a:prstGeom>
           <a:solidFill>
-            <a:srgbClr val="8BB29A"/>
+            <a:srgbClr val="23613F"/>
           </a:solidFill>
           <a:ln>
             <a:noFill/>
           </a:ln>
         </p:spPr>
         <p:txBody>
-          <a:bodyPr wrap="none" anchor="ctr">
-            <a:spAutoFit/>
-          </a:bodyPr>
+          <a:bodyPr wrap="none" anchor="ctr"/>
           <a:lstStyle/>
           <a:p>
             <a:pPr algn="ctr"/>
             <a:r>
-              <a:rPr sz="900" b="1">
+              <a:rPr lang="ru-RU" sz="800" b="1">
                 <a:solidFill>
                   <a:srgbClr val="FFFFFF"/>
                 </a:solidFill>
-                <a:latin typeface="Arial"/>
               </a:rPr>
               <a:t>2</a:t>
             </a:r>
@@ -10230,46 +10337,69 @@
       </p:graphicFrame>
       <p:sp>
         <p:nvSpPr>
-          <p:cNvPr id="6" name="TextBox 5"/>
-          <p:cNvSpPr txBox="1"/>
-          <p:nvPr/>
-        </p:nvSpPr>
-        <p:spPr>
-          <a:xfrm>
-            <a:off x="0" y="6757200"/>
-            <a:ext cx="12188825" cy="100800"/>
-          </a:xfrm>
-          <a:noFill/>
+          <p:cNvPr id="2030" name="pb30"/>
+          <p:cNvSpPr txBox="1"/>
+          <p:nvPr/>
+        </p:nvSpPr>
+        <p:spPr>
+          <a:xfrm>
+            <a:off x="0" y="6660000"/>
+            <a:ext cx="12192000" cy="198000"/>
+          </a:xfrm>
           <a:prstGeom prst="rect">
             <a:avLst/>
           </a:prstGeom>
           <a:solidFill>
-            <a:srgbClr val="122017"/>
+            <a:srgbClr val="0D1F14"/>
           </a:solidFill>
           <a:ln>
             <a:noFill/>
           </a:ln>
         </p:spPr>
         <p:txBody>
-          <a:bodyPr wrap="none">
-            <a:spAutoFit/>
-          </a:bodyPr>
+          <a:bodyPr wrap="none" anchor="ctr"/>
           <a:lstStyle/>
           <a:p/>
         </p:txBody>
       </p:sp>
       <p:sp>
         <p:nvSpPr>
-          <p:cNvPr id="7" name="TextBox 6"/>
-          <p:cNvSpPr txBox="1"/>
-          <p:nvPr/>
-        </p:nvSpPr>
-        <p:spPr>
-          <a:xfrm>
-            <a:off x="0" y="6757200"/>
-            <a:ext cx="2611891" cy="100800"/>
-          </a:xfrm>
-          <a:noFill/>
+          <p:cNvPr id="2031" name="pb31"/>
+          <p:cNvSpPr txBox="1"/>
+          <p:nvPr/>
+        </p:nvSpPr>
+        <p:spPr>
+          <a:xfrm>
+            <a:off x="0" y="6660000"/>
+            <a:ext cx="2612571" cy="198000"/>
+          </a:xfrm>
+          <a:prstGeom prst="rect">
+            <a:avLst/>
+          </a:prstGeom>
+          <a:solidFill>
+            <a:srgbClr val="2D5544"/>
+          </a:solidFill>
+          <a:ln>
+            <a:noFill/>
+          </a:ln>
+        </p:spPr>
+        <p:txBody>
+          <a:bodyPr wrap="none" anchor="ctr"/>
+          <a:lstStyle/>
+          <a:p/>
+        </p:txBody>
+      </p:sp>
+      <p:sp>
+        <p:nvSpPr>
+          <p:cNvPr id="2032" name="pb32"/>
+          <p:cNvSpPr txBox="1"/>
+          <p:nvPr/>
+        </p:nvSpPr>
+        <p:spPr>
+          <a:xfrm>
+            <a:off x="2072571" y="6660000"/>
+            <a:ext cx="540000" cy="198000"/>
+          </a:xfrm>
           <a:prstGeom prst="rect">
             <a:avLst/>
           </a:prstGeom>
@@ -10281,48 +10411,42 @@
           </a:ln>
         </p:spPr>
         <p:txBody>
-          <a:bodyPr wrap="none">
-            <a:spAutoFit/>
-          </a:bodyPr>
+          <a:bodyPr wrap="none" anchor="ctr"/>
           <a:lstStyle/>
           <a:p/>
         </p:txBody>
       </p:sp>
       <p:sp>
         <p:nvSpPr>
-          <p:cNvPr id="8" name="TextBox 7"/>
-          <p:cNvSpPr txBox="1"/>
-          <p:nvPr/>
-        </p:nvSpPr>
-        <p:spPr>
-          <a:xfrm>
-            <a:off x="2449891" y="6645600"/>
-            <a:ext cx="324000" cy="324000"/>
-          </a:xfrm>
-          <a:noFill/>
-          <a:prstGeom prst="ellipse">
+          <p:cNvPr id="2133" name="pbn33"/>
+          <p:cNvSpPr txBox="1"/>
+          <p:nvPr/>
+        </p:nvSpPr>
+        <p:spPr>
+          <a:xfrm>
+            <a:off x="1964571" y="6660000"/>
+            <a:ext cx="648000" cy="198000"/>
+          </a:xfrm>
+          <a:prstGeom prst="rect">
             <a:avLst/>
           </a:prstGeom>
           <a:solidFill>
-            <a:srgbClr val="8BB29A"/>
+            <a:srgbClr val="23613F"/>
           </a:solidFill>
           <a:ln>
             <a:noFill/>
           </a:ln>
         </p:spPr>
         <p:txBody>
-          <a:bodyPr wrap="none" anchor="ctr">
-            <a:spAutoFit/>
-          </a:bodyPr>
+          <a:bodyPr wrap="none" anchor="ctr"/>
           <a:lstStyle/>
           <a:p>
             <a:pPr algn="ctr"/>
             <a:r>
-              <a:rPr sz="900" b="1">
+              <a:rPr lang="ru-RU" sz="800" b="1">
                 <a:solidFill>
                   <a:srgbClr val="FFFFFF"/>
                 </a:solidFill>
-                <a:latin typeface="Arial"/>
               </a:rPr>
               <a:t>3</a:t>
             </a:r>
@@ -10780,46 +10904,69 @@
       </p:sp>
       <p:sp>
         <p:nvSpPr>
-          <p:cNvPr id="13" name="TextBox 12"/>
-          <p:cNvSpPr txBox="1"/>
-          <p:nvPr/>
-        </p:nvSpPr>
-        <p:spPr>
-          <a:xfrm>
-            <a:off x="0" y="6757200"/>
-            <a:ext cx="12188825" cy="100800"/>
-          </a:xfrm>
-          <a:noFill/>
+          <p:cNvPr id="2040" name="pb40"/>
+          <p:cNvSpPr txBox="1"/>
+          <p:nvPr/>
+        </p:nvSpPr>
+        <p:spPr>
+          <a:xfrm>
+            <a:off x="0" y="6660000"/>
+            <a:ext cx="12192000" cy="198000"/>
+          </a:xfrm>
           <a:prstGeom prst="rect">
             <a:avLst/>
           </a:prstGeom>
           <a:solidFill>
-            <a:srgbClr val="122017"/>
+            <a:srgbClr val="0D1F14"/>
           </a:solidFill>
           <a:ln>
             <a:noFill/>
           </a:ln>
         </p:spPr>
         <p:txBody>
-          <a:bodyPr wrap="none">
-            <a:spAutoFit/>
-          </a:bodyPr>
+          <a:bodyPr wrap="none" anchor="ctr"/>
           <a:lstStyle/>
           <a:p/>
         </p:txBody>
       </p:sp>
       <p:sp>
         <p:nvSpPr>
-          <p:cNvPr id="14" name="TextBox 13"/>
-          <p:cNvSpPr txBox="1"/>
-          <p:nvPr/>
-        </p:nvSpPr>
-        <p:spPr>
-          <a:xfrm>
-            <a:off x="0" y="6757200"/>
-            <a:ext cx="3482521" cy="100800"/>
-          </a:xfrm>
-          <a:noFill/>
+          <p:cNvPr id="2041" name="pb41"/>
+          <p:cNvSpPr txBox="1"/>
+          <p:nvPr/>
+        </p:nvSpPr>
+        <p:spPr>
+          <a:xfrm>
+            <a:off x="0" y="6660000"/>
+            <a:ext cx="3483428" cy="198000"/>
+          </a:xfrm>
+          <a:prstGeom prst="rect">
+            <a:avLst/>
+          </a:prstGeom>
+          <a:solidFill>
+            <a:srgbClr val="2D5544"/>
+          </a:solidFill>
+          <a:ln>
+            <a:noFill/>
+          </a:ln>
+        </p:spPr>
+        <p:txBody>
+          <a:bodyPr wrap="none" anchor="ctr"/>
+          <a:lstStyle/>
+          <a:p/>
+        </p:txBody>
+      </p:sp>
+      <p:sp>
+        <p:nvSpPr>
+          <p:cNvPr id="2042" name="pb42"/>
+          <p:cNvSpPr txBox="1"/>
+          <p:nvPr/>
+        </p:nvSpPr>
+        <p:spPr>
+          <a:xfrm>
+            <a:off x="2943428" y="6660000"/>
+            <a:ext cx="540000" cy="198000"/>
+          </a:xfrm>
           <a:prstGeom prst="rect">
             <a:avLst/>
           </a:prstGeom>
@@ -10831,48 +10978,42 @@
           </a:ln>
         </p:spPr>
         <p:txBody>
-          <a:bodyPr wrap="none">
-            <a:spAutoFit/>
-          </a:bodyPr>
+          <a:bodyPr wrap="none" anchor="ctr"/>
           <a:lstStyle/>
           <a:p/>
         </p:txBody>
       </p:sp>
       <p:sp>
         <p:nvSpPr>
-          <p:cNvPr id="15" name="TextBox 14"/>
-          <p:cNvSpPr txBox="1"/>
-          <p:nvPr/>
-        </p:nvSpPr>
-        <p:spPr>
-          <a:xfrm>
-            <a:off x="3320521" y="6645600"/>
-            <a:ext cx="324000" cy="324000"/>
-          </a:xfrm>
-          <a:noFill/>
-          <a:prstGeom prst="ellipse">
+          <p:cNvPr id="2143" name="pbn43"/>
+          <p:cNvSpPr txBox="1"/>
+          <p:nvPr/>
+        </p:nvSpPr>
+        <p:spPr>
+          <a:xfrm>
+            <a:off x="2835428" y="6660000"/>
+            <a:ext cx="648000" cy="198000"/>
+          </a:xfrm>
+          <a:prstGeom prst="rect">
             <a:avLst/>
           </a:prstGeom>
           <a:solidFill>
-            <a:srgbClr val="8BB29A"/>
+            <a:srgbClr val="23613F"/>
           </a:solidFill>
           <a:ln>
             <a:noFill/>
           </a:ln>
         </p:spPr>
         <p:txBody>
-          <a:bodyPr wrap="none" anchor="ctr">
-            <a:spAutoFit/>
-          </a:bodyPr>
+          <a:bodyPr wrap="none" anchor="ctr"/>
           <a:lstStyle/>
           <a:p>
             <a:pPr algn="ctr"/>
             <a:r>
-              <a:rPr sz="900" b="1">
+              <a:rPr lang="ru-RU" sz="800" b="1">
                 <a:solidFill>
                   <a:srgbClr val="FFFFFF"/>
                 </a:solidFill>
-                <a:latin typeface="Arial"/>
               </a:rPr>
               <a:t>4</a:t>
             </a:r>
@@ -13500,46 +13641,69 @@
       </p:graphicFrame>
       <p:sp>
         <p:nvSpPr>
-          <p:cNvPr id="5" name="TextBox 4"/>
-          <p:cNvSpPr txBox="1"/>
-          <p:nvPr/>
-        </p:nvSpPr>
-        <p:spPr>
-          <a:xfrm>
-            <a:off x="0" y="6757200"/>
-            <a:ext cx="12188825" cy="100800"/>
-          </a:xfrm>
-          <a:noFill/>
+          <p:cNvPr id="2050" name="pb50"/>
+          <p:cNvSpPr txBox="1"/>
+          <p:nvPr/>
+        </p:nvSpPr>
+        <p:spPr>
+          <a:xfrm>
+            <a:off x="0" y="6660000"/>
+            <a:ext cx="12192000" cy="198000"/>
+          </a:xfrm>
           <a:prstGeom prst="rect">
             <a:avLst/>
           </a:prstGeom>
           <a:solidFill>
-            <a:srgbClr val="122017"/>
+            <a:srgbClr val="0D1F14"/>
           </a:solidFill>
           <a:ln>
             <a:noFill/>
           </a:ln>
         </p:spPr>
         <p:txBody>
-          <a:bodyPr wrap="none">
-            <a:spAutoFit/>
-          </a:bodyPr>
+          <a:bodyPr wrap="none" anchor="ctr"/>
           <a:lstStyle/>
           <a:p/>
         </p:txBody>
       </p:sp>
       <p:sp>
         <p:nvSpPr>
-          <p:cNvPr id="6" name="TextBox 5"/>
-          <p:cNvSpPr txBox="1"/>
-          <p:nvPr/>
-        </p:nvSpPr>
-        <p:spPr>
-          <a:xfrm>
-            <a:off x="0" y="6757200"/>
-            <a:ext cx="4353151" cy="100800"/>
-          </a:xfrm>
-          <a:noFill/>
+          <p:cNvPr id="2051" name="pb51"/>
+          <p:cNvSpPr txBox="1"/>
+          <p:nvPr/>
+        </p:nvSpPr>
+        <p:spPr>
+          <a:xfrm>
+            <a:off x="0" y="6660000"/>
+            <a:ext cx="4354285" cy="198000"/>
+          </a:xfrm>
+          <a:prstGeom prst="rect">
+            <a:avLst/>
+          </a:prstGeom>
+          <a:solidFill>
+            <a:srgbClr val="2D5544"/>
+          </a:solidFill>
+          <a:ln>
+            <a:noFill/>
+          </a:ln>
+        </p:spPr>
+        <p:txBody>
+          <a:bodyPr wrap="none" anchor="ctr"/>
+          <a:lstStyle/>
+          <a:p/>
+        </p:txBody>
+      </p:sp>
+      <p:sp>
+        <p:nvSpPr>
+          <p:cNvPr id="2052" name="pb52"/>
+          <p:cNvSpPr txBox="1"/>
+          <p:nvPr/>
+        </p:nvSpPr>
+        <p:spPr>
+          <a:xfrm>
+            <a:off x="3814285" y="6660000"/>
+            <a:ext cx="540000" cy="198000"/>
+          </a:xfrm>
           <a:prstGeom prst="rect">
             <a:avLst/>
           </a:prstGeom>
@@ -13551,48 +13715,42 @@
           </a:ln>
         </p:spPr>
         <p:txBody>
-          <a:bodyPr wrap="none">
-            <a:spAutoFit/>
-          </a:bodyPr>
+          <a:bodyPr wrap="none" anchor="ctr"/>
           <a:lstStyle/>
           <a:p/>
         </p:txBody>
       </p:sp>
       <p:sp>
         <p:nvSpPr>
-          <p:cNvPr id="7" name="TextBox 6"/>
-          <p:cNvSpPr txBox="1"/>
-          <p:nvPr/>
-        </p:nvSpPr>
-        <p:spPr>
-          <a:xfrm>
-            <a:off x="4191151" y="6645600"/>
-            <a:ext cx="324000" cy="324000"/>
-          </a:xfrm>
-          <a:noFill/>
-          <a:prstGeom prst="ellipse">
+          <p:cNvPr id="2153" name="pbn53"/>
+          <p:cNvSpPr txBox="1"/>
+          <p:nvPr/>
+        </p:nvSpPr>
+        <p:spPr>
+          <a:xfrm>
+            <a:off x="3706285" y="6660000"/>
+            <a:ext cx="648000" cy="198000"/>
+          </a:xfrm>
+          <a:prstGeom prst="rect">
             <a:avLst/>
           </a:prstGeom>
           <a:solidFill>
-            <a:srgbClr val="8BB29A"/>
+            <a:srgbClr val="23613F"/>
           </a:solidFill>
           <a:ln>
             <a:noFill/>
           </a:ln>
         </p:spPr>
         <p:txBody>
-          <a:bodyPr wrap="none" anchor="ctr">
-            <a:spAutoFit/>
-          </a:bodyPr>
+          <a:bodyPr wrap="none" anchor="ctr"/>
           <a:lstStyle/>
           <a:p>
             <a:pPr algn="ctr"/>
             <a:r>
-              <a:rPr sz="900" b="1">
+              <a:rPr lang="ru-RU" sz="800" b="1">
                 <a:solidFill>
                   <a:srgbClr val="FFFFFF"/>
                 </a:solidFill>
-                <a:latin typeface="Arial"/>
               </a:rPr>
               <a:t>5</a:t>
             </a:r>
@@ -14561,46 +14719,69 @@
       </p:sp>
       <p:sp>
         <p:nvSpPr>
-          <p:cNvPr id="26" name="TextBox 25"/>
-          <p:cNvSpPr txBox="1"/>
-          <p:nvPr/>
-        </p:nvSpPr>
-        <p:spPr>
-          <a:xfrm>
-            <a:off x="0" y="6757200"/>
-            <a:ext cx="12188825" cy="100800"/>
-          </a:xfrm>
-          <a:noFill/>
+          <p:cNvPr id="2060" name="pb60"/>
+          <p:cNvSpPr txBox="1"/>
+          <p:nvPr/>
+        </p:nvSpPr>
+        <p:spPr>
+          <a:xfrm>
+            <a:off x="0" y="6660000"/>
+            <a:ext cx="12192000" cy="198000"/>
+          </a:xfrm>
           <a:prstGeom prst="rect">
             <a:avLst/>
           </a:prstGeom>
           <a:solidFill>
-            <a:srgbClr val="122017"/>
+            <a:srgbClr val="0D1F14"/>
           </a:solidFill>
           <a:ln>
             <a:noFill/>
           </a:ln>
         </p:spPr>
         <p:txBody>
-          <a:bodyPr wrap="none">
-            <a:spAutoFit/>
-          </a:bodyPr>
+          <a:bodyPr wrap="none" anchor="ctr"/>
           <a:lstStyle/>
           <a:p/>
         </p:txBody>
       </p:sp>
       <p:sp>
         <p:nvSpPr>
-          <p:cNvPr id="27" name="TextBox 26"/>
-          <p:cNvSpPr txBox="1"/>
-          <p:nvPr/>
-        </p:nvSpPr>
-        <p:spPr>
-          <a:xfrm>
-            <a:off x="0" y="6757200"/>
-            <a:ext cx="5223782" cy="100800"/>
-          </a:xfrm>
-          <a:noFill/>
+          <p:cNvPr id="2061" name="pb61"/>
+          <p:cNvSpPr txBox="1"/>
+          <p:nvPr/>
+        </p:nvSpPr>
+        <p:spPr>
+          <a:xfrm>
+            <a:off x="0" y="6660000"/>
+            <a:ext cx="5225142" cy="198000"/>
+          </a:xfrm>
+          <a:prstGeom prst="rect">
+            <a:avLst/>
+          </a:prstGeom>
+          <a:solidFill>
+            <a:srgbClr val="2D5544"/>
+          </a:solidFill>
+          <a:ln>
+            <a:noFill/>
+          </a:ln>
+        </p:spPr>
+        <p:txBody>
+          <a:bodyPr wrap="none" anchor="ctr"/>
+          <a:lstStyle/>
+          <a:p/>
+        </p:txBody>
+      </p:sp>
+      <p:sp>
+        <p:nvSpPr>
+          <p:cNvPr id="2062" name="pb62"/>
+          <p:cNvSpPr txBox="1"/>
+          <p:nvPr/>
+        </p:nvSpPr>
+        <p:spPr>
+          <a:xfrm>
+            <a:off x="4685142" y="6660000"/>
+            <a:ext cx="540000" cy="198000"/>
+          </a:xfrm>
           <a:prstGeom prst="rect">
             <a:avLst/>
           </a:prstGeom>
@@ -14612,48 +14793,42 @@
           </a:ln>
         </p:spPr>
         <p:txBody>
-          <a:bodyPr wrap="none">
-            <a:spAutoFit/>
-          </a:bodyPr>
+          <a:bodyPr wrap="none" anchor="ctr"/>
           <a:lstStyle/>
           <a:p/>
         </p:txBody>
       </p:sp>
       <p:sp>
         <p:nvSpPr>
-          <p:cNvPr id="28" name="TextBox 27"/>
-          <p:cNvSpPr txBox="1"/>
-          <p:nvPr/>
-        </p:nvSpPr>
-        <p:spPr>
-          <a:xfrm>
-            <a:off x="5061782" y="6645600"/>
-            <a:ext cx="324000" cy="324000"/>
-          </a:xfrm>
-          <a:noFill/>
-          <a:prstGeom prst="ellipse">
+          <p:cNvPr id="2163" name="pbn63"/>
+          <p:cNvSpPr txBox="1"/>
+          <p:nvPr/>
+        </p:nvSpPr>
+        <p:spPr>
+          <a:xfrm>
+            <a:off x="4577142" y="6660000"/>
+            <a:ext cx="648000" cy="198000"/>
+          </a:xfrm>
+          <a:prstGeom prst="rect">
             <a:avLst/>
           </a:prstGeom>
           <a:solidFill>
-            <a:srgbClr val="8BB29A"/>
+            <a:srgbClr val="23613F"/>
           </a:solidFill>
           <a:ln>
             <a:noFill/>
           </a:ln>
         </p:spPr>
         <p:txBody>
-          <a:bodyPr wrap="none" anchor="ctr">
-            <a:spAutoFit/>
-          </a:bodyPr>
+          <a:bodyPr wrap="none" anchor="ctr"/>
           <a:lstStyle/>
           <a:p>
             <a:pPr algn="ctr"/>
             <a:r>
-              <a:rPr sz="900" b="1">
+              <a:rPr lang="ru-RU" sz="800" b="1">
                 <a:solidFill>
                   <a:srgbClr val="FFFFFF"/>
                 </a:solidFill>
-                <a:latin typeface="Arial"/>
               </a:rPr>
               <a:t>6</a:t>
             </a:r>
@@ -15501,46 +15676,69 @@
       </p:graphicFrame>
       <p:sp>
         <p:nvSpPr>
-          <p:cNvPr id="12" name="TextBox 11"/>
-          <p:cNvSpPr txBox="1"/>
-          <p:nvPr/>
-        </p:nvSpPr>
-        <p:spPr>
-          <a:xfrm>
-            <a:off x="0" y="6757200"/>
-            <a:ext cx="12188825" cy="100800"/>
-          </a:xfrm>
-          <a:noFill/>
+          <p:cNvPr id="2070" name="pb70"/>
+          <p:cNvSpPr txBox="1"/>
+          <p:nvPr/>
+        </p:nvSpPr>
+        <p:spPr>
+          <a:xfrm>
+            <a:off x="0" y="6660000"/>
+            <a:ext cx="12192000" cy="198000"/>
+          </a:xfrm>
           <a:prstGeom prst="rect">
             <a:avLst/>
           </a:prstGeom>
           <a:solidFill>
-            <a:srgbClr val="122017"/>
+            <a:srgbClr val="0D1F14"/>
           </a:solidFill>
           <a:ln>
             <a:noFill/>
           </a:ln>
         </p:spPr>
         <p:txBody>
-          <a:bodyPr wrap="none">
-            <a:spAutoFit/>
-          </a:bodyPr>
+          <a:bodyPr wrap="none" anchor="ctr"/>
           <a:lstStyle/>
           <a:p/>
         </p:txBody>
       </p:sp>
       <p:sp>
         <p:nvSpPr>
-          <p:cNvPr id="13" name="TextBox 12"/>
-          <p:cNvSpPr txBox="1"/>
-          <p:nvPr/>
-        </p:nvSpPr>
-        <p:spPr>
-          <a:xfrm>
-            <a:off x="0" y="6757200"/>
-            <a:ext cx="6094412" cy="100800"/>
-          </a:xfrm>
-          <a:noFill/>
+          <p:cNvPr id="2071" name="pb71"/>
+          <p:cNvSpPr txBox="1"/>
+          <p:nvPr/>
+        </p:nvSpPr>
+        <p:spPr>
+          <a:xfrm>
+            <a:off x="0" y="6660000"/>
+            <a:ext cx="6096000" cy="198000"/>
+          </a:xfrm>
+          <a:prstGeom prst="rect">
+            <a:avLst/>
+          </a:prstGeom>
+          <a:solidFill>
+            <a:srgbClr val="2D5544"/>
+          </a:solidFill>
+          <a:ln>
+            <a:noFill/>
+          </a:ln>
+        </p:spPr>
+        <p:txBody>
+          <a:bodyPr wrap="none" anchor="ctr"/>
+          <a:lstStyle/>
+          <a:p/>
+        </p:txBody>
+      </p:sp>
+      <p:sp>
+        <p:nvSpPr>
+          <p:cNvPr id="2072" name="pb72"/>
+          <p:cNvSpPr txBox="1"/>
+          <p:nvPr/>
+        </p:nvSpPr>
+        <p:spPr>
+          <a:xfrm>
+            <a:off x="5556000" y="6660000"/>
+            <a:ext cx="540000" cy="198000"/>
+          </a:xfrm>
           <a:prstGeom prst="rect">
             <a:avLst/>
           </a:prstGeom>
@@ -15552,48 +15750,42 @@
           </a:ln>
         </p:spPr>
         <p:txBody>
-          <a:bodyPr wrap="none">
-            <a:spAutoFit/>
-          </a:bodyPr>
+          <a:bodyPr wrap="none" anchor="ctr"/>
           <a:lstStyle/>
           <a:p/>
         </p:txBody>
       </p:sp>
       <p:sp>
         <p:nvSpPr>
-          <p:cNvPr id="14" name="TextBox 13"/>
-          <p:cNvSpPr txBox="1"/>
-          <p:nvPr/>
-        </p:nvSpPr>
-        <p:spPr>
-          <a:xfrm>
-            <a:off x="5932412" y="6645600"/>
-            <a:ext cx="324000" cy="324000"/>
-          </a:xfrm>
-          <a:noFill/>
-          <a:prstGeom prst="ellipse">
+          <p:cNvPr id="2173" name="pbn73"/>
+          <p:cNvSpPr txBox="1"/>
+          <p:nvPr/>
+        </p:nvSpPr>
+        <p:spPr>
+          <a:xfrm>
+            <a:off x="5448000" y="6660000"/>
+            <a:ext cx="648000" cy="198000"/>
+          </a:xfrm>
+          <a:prstGeom prst="rect">
             <a:avLst/>
           </a:prstGeom>
           <a:solidFill>
-            <a:srgbClr val="8BB29A"/>
+            <a:srgbClr val="23613F"/>
           </a:solidFill>
           <a:ln>
             <a:noFill/>
           </a:ln>
         </p:spPr>
         <p:txBody>
-          <a:bodyPr wrap="none" anchor="ctr">
-            <a:spAutoFit/>
-          </a:bodyPr>
+          <a:bodyPr wrap="none" anchor="ctr"/>
           <a:lstStyle/>
           <a:p>
             <a:pPr algn="ctr"/>
             <a:r>
-              <a:rPr sz="900" b="1">
+              <a:rPr lang="ru-RU" sz="800" b="1">
                 <a:solidFill>
                   <a:srgbClr val="FFFFFF"/>
                 </a:solidFill>
-                <a:latin typeface="Arial"/>
               </a:rPr>
               <a:t>7</a:t>
             </a:r>
@@ -16188,46 +16380,69 @@
       </p:sp>
       <p:sp>
         <p:nvSpPr>
-          <p:cNvPr id="16" name="TextBox 15"/>
-          <p:cNvSpPr txBox="1"/>
-          <p:nvPr/>
-        </p:nvSpPr>
-        <p:spPr>
-          <a:xfrm>
-            <a:off x="0" y="6757200"/>
-            <a:ext cx="12188825" cy="100800"/>
-          </a:xfrm>
-          <a:noFill/>
+          <p:cNvPr id="2090" name="pb90"/>
+          <p:cNvSpPr txBox="1"/>
+          <p:nvPr/>
+        </p:nvSpPr>
+        <p:spPr>
+          <a:xfrm>
+            <a:off x="0" y="6660000"/>
+            <a:ext cx="12192000" cy="198000"/>
+          </a:xfrm>
           <a:prstGeom prst="rect">
             <a:avLst/>
           </a:prstGeom>
           <a:solidFill>
-            <a:srgbClr val="122017"/>
+            <a:srgbClr val="0D1F14"/>
           </a:solidFill>
           <a:ln>
             <a:noFill/>
           </a:ln>
         </p:spPr>
         <p:txBody>
-          <a:bodyPr wrap="none">
-            <a:spAutoFit/>
-          </a:bodyPr>
+          <a:bodyPr wrap="none" anchor="ctr"/>
           <a:lstStyle/>
           <a:p/>
         </p:txBody>
       </p:sp>
       <p:sp>
         <p:nvSpPr>
-          <p:cNvPr id="17" name="TextBox 16"/>
-          <p:cNvSpPr txBox="1"/>
-          <p:nvPr/>
-        </p:nvSpPr>
-        <p:spPr>
-          <a:xfrm>
-            <a:off x="0" y="6757200"/>
-            <a:ext cx="7835673" cy="100800"/>
-          </a:xfrm>
-          <a:noFill/>
+          <p:cNvPr id="2091" name="pb91"/>
+          <p:cNvSpPr txBox="1"/>
+          <p:nvPr/>
+        </p:nvSpPr>
+        <p:spPr>
+          <a:xfrm>
+            <a:off x="0" y="6660000"/>
+            <a:ext cx="7837714" cy="198000"/>
+          </a:xfrm>
+          <a:prstGeom prst="rect">
+            <a:avLst/>
+          </a:prstGeom>
+          <a:solidFill>
+            <a:srgbClr val="2D5544"/>
+          </a:solidFill>
+          <a:ln>
+            <a:noFill/>
+          </a:ln>
+        </p:spPr>
+        <p:txBody>
+          <a:bodyPr wrap="none" anchor="ctr"/>
+          <a:lstStyle/>
+          <a:p/>
+        </p:txBody>
+      </p:sp>
+      <p:sp>
+        <p:nvSpPr>
+          <p:cNvPr id="2092" name="pb92"/>
+          <p:cNvSpPr txBox="1"/>
+          <p:nvPr/>
+        </p:nvSpPr>
+        <p:spPr>
+          <a:xfrm>
+            <a:off x="7297714" y="6660000"/>
+            <a:ext cx="540000" cy="198000"/>
+          </a:xfrm>
           <a:prstGeom prst="rect">
             <a:avLst/>
           </a:prstGeom>
@@ -16239,48 +16454,42 @@
           </a:ln>
         </p:spPr>
         <p:txBody>
-          <a:bodyPr wrap="none">
-            <a:spAutoFit/>
-          </a:bodyPr>
+          <a:bodyPr wrap="none" anchor="ctr"/>
           <a:lstStyle/>
           <a:p/>
         </p:txBody>
       </p:sp>
       <p:sp>
         <p:nvSpPr>
-          <p:cNvPr id="18" name="TextBox 17"/>
-          <p:cNvSpPr txBox="1"/>
-          <p:nvPr/>
-        </p:nvSpPr>
-        <p:spPr>
-          <a:xfrm>
-            <a:off x="7673673" y="6645600"/>
-            <a:ext cx="324000" cy="324000"/>
-          </a:xfrm>
-          <a:noFill/>
-          <a:prstGeom prst="ellipse">
+          <p:cNvPr id="2193" name="pbn93"/>
+          <p:cNvSpPr txBox="1"/>
+          <p:nvPr/>
+        </p:nvSpPr>
+        <p:spPr>
+          <a:xfrm>
+            <a:off x="7189714" y="6660000"/>
+            <a:ext cx="648000" cy="198000"/>
+          </a:xfrm>
+          <a:prstGeom prst="rect">
             <a:avLst/>
           </a:prstGeom>
           <a:solidFill>
-            <a:srgbClr val="8BB29A"/>
+            <a:srgbClr val="23613F"/>
           </a:solidFill>
           <a:ln>
             <a:noFill/>
           </a:ln>
         </p:spPr>
         <p:txBody>
-          <a:bodyPr wrap="none" anchor="ctr">
-            <a:spAutoFit/>
-          </a:bodyPr>
+          <a:bodyPr wrap="none" anchor="ctr"/>
           <a:lstStyle/>
           <a:p>
             <a:pPr algn="ctr"/>
             <a:r>
-              <a:rPr sz="900" b="1">
+              <a:rPr lang="ru-RU" sz="800" b="1">
                 <a:solidFill>
                   <a:srgbClr val="FFFFFF"/>
                 </a:solidFill>
-                <a:latin typeface="Arial"/>
               </a:rPr>
               <a:t>9</a:t>
             </a:r>

</xml_diff>

<commit_message>
fix(presentation): restore original Результаты slide from git history
Replaced the placeholder Результаты slide with the original version
recovered from commit f10a632 — 5 metric cards + bullet summary + footer bar.

https://claude.ai/code/session_01JXZNXE9oVEv7rsUiTvXR5D
</commit_message>
<xml_diff>
--- a/docs/Визуализация науки на основе метаданных публикаций и журналов.pptx
+++ b/docs/Визуализация науки на основе метаданных публикаций и журналов.pptx
@@ -8511,6 +8511,19 @@
 <p:sld xmlns:a="http://schemas.openxmlformats.org/drawingml/2006/main" xmlns:r="http://schemas.openxmlformats.org/officeDocument/2006/relationships" xmlns:p="http://schemas.openxmlformats.org/presentationml/2006/main">
   <p:cSld>
     <p:spTree>
+      <p:nvGrpSpPr>
+        <p:cNvPr id="1" name=""/>
+        <p:cNvGrpSpPr/>
+        <p:nvPr/>
+      </p:nvGrpSpPr>
+      <p:grpSpPr>
+        <a:xfrm>
+          <a:off x="0" y="0"/>
+          <a:ext cx="0" cy="0"/>
+          <a:chOff x="0" y="0"/>
+          <a:chExt cx="0" cy="0"/>
+        </a:xfrm>
+      </p:grpSpPr>
       <p:sp>
         <p:nvSpPr>
           <p:cNvPr id="2" name="Rectangle 1"/>
@@ -8521,50 +8534,6 @@
           <a:xfrm>
             <a:off x="0" y="0"/>
             <a:ext cx="12188952" cy="6858000"/>
-          </a:xfrm>
-          <a:prstGeom prst="rect">
-            <a:avLst/>
-          </a:prstGeom>
-          <a:solidFill>
-            <a:srgbClr val="F7FBF8"/>
-          </a:solidFill>
-          <a:ln>
-            <a:noFill/>
-          </a:ln>
-        </p:spPr>
-        <p:style>
-          <a:lnRef idx="1">
-            <a:schemeClr val="accent1"/>
-          </a:lnRef>
-          <a:fillRef idx="3">
-            <a:schemeClr val="accent1"/>
-          </a:fillRef>
-          <a:effectRef idx="2">
-            <a:schemeClr val="accent1"/>
-          </a:effectRef>
-          <a:fontRef idx="minor">
-            <a:schemeClr val="lt1"/>
-          </a:fontRef>
-        </p:style>
-        <p:txBody>
-          <a:bodyPr rtlCol="0" anchor="ctr"/>
-          <a:lstStyle/>
-          <a:p>
-            <a:pPr algn="ctr"/>
-            <a:endParaRPr/>
-          </a:p>
-        </p:txBody>
-      </p:sp>
-      <p:sp>
-        <p:nvSpPr>
-          <p:cNvPr id="3" name="Rectangle 2"/>
-          <p:cNvSpPr/>
-          <p:nvPr/>
-        </p:nvSpPr>
-        <p:spPr>
-          <a:xfrm>
-            <a:off x="0" y="0"/>
-            <a:ext cx="12188952" cy="1005840"/>
           </a:xfrm>
           <a:prstGeom prst="rect">
             <a:avLst/>
@@ -8601,662 +8570,810 @@
       </p:sp>
       <p:sp>
         <p:nvSpPr>
-          <p:cNvPr id="99" name="TextBox"/>
-          <p:cNvSpPr txBox="1"/>
-          <p:nvPr/>
-        </p:nvSpPr>
-        <p:spPr>
-          <a:xfrm>
-            <a:off x="360000" y="180000"/>
-            <a:ext cx="11448000" cy="684000"/>
-          </a:xfrm>
-          <a:prstGeom prst="rect">
-            <a:avLst/>
-          </a:prstGeom>
-          <a:noFill/>
-          <a:ln>
-            <a:noFill/>
-          </a:ln>
-        </p:spPr>
-        <p:txBody>
-          <a:bodyPr wrap="square" anchor="ctr"/>
-          <a:lstStyle/>
-          <a:p>
-            <a:pPr algn="l"/>
-            <a:r>
-              <a:rPr lang="ru-RU" sz="2200" b="1">
-                <a:solidFill>
-                  <a:srgbClr val="FFFFFF"/>
-                </a:solidFill>
-              </a:rPr>
-              <a:t>Результаты</a:t>
-            </a:r>
-            <a:br>
-              <a:rPr lang="ru-RU"/>
-            </a:br>
-          </a:p>
-        </p:txBody>
-      </p:sp>
-      <p:sp>
-        <p:nvSpPr>
-          <p:cNvPr id="99" name="TextBox"/>
-          <p:cNvSpPr txBox="1"/>
-          <p:nvPr/>
-        </p:nvSpPr>
-        <p:spPr>
-          <a:xfrm>
-            <a:off x="360000" y="1152000"/>
-            <a:ext cx="2808000" cy="2088000"/>
+          <p:cNvPr id="3" name="Rectangle 2"/>
+          <p:cNvSpPr/>
+          <p:nvPr/>
+        </p:nvSpPr>
+        <p:spPr>
+          <a:xfrm>
+            <a:off x="0" y="0"/>
+            <a:ext cx="12188952" cy="1005840"/>
           </a:xfrm>
           <a:prstGeom prst="rect">
             <a:avLst/>
           </a:prstGeom>
           <a:solidFill>
-            <a:srgbClr val="1A5276"/>
+            <a:srgbClr val="23613F"/>
           </a:solidFill>
           <a:ln>
             <a:noFill/>
           </a:ln>
         </p:spPr>
-        <p:txBody>
-          <a:bodyPr wrap="square" anchor="ctr"/>
+        <p:style>
+          <a:lnRef idx="1">
+            <a:schemeClr val="accent1"/>
+          </a:lnRef>
+          <a:fillRef idx="3">
+            <a:schemeClr val="accent1"/>
+          </a:fillRef>
+          <a:effectRef idx="2">
+            <a:schemeClr val="accent1"/>
+          </a:effectRef>
+          <a:fontRef idx="minor">
+            <a:schemeClr val="lt1"/>
+          </a:fontRef>
+        </p:style>
+        <p:txBody>
+          <a:bodyPr rtlCol="0" anchor="ctr"/>
+          <a:lstStyle/>
+          <a:p>
+            <a:pPr algn="ctr"/>
+            <a:endParaRPr/>
+          </a:p>
+        </p:txBody>
+      </p:sp>
+      <p:sp>
+        <p:nvSpPr>
+          <p:cNvPr id="4" name="TextBox 3"/>
+          <p:cNvSpPr txBox="1"/>
+          <p:nvPr/>
+        </p:nvSpPr>
+        <p:spPr>
+          <a:xfrm>
+            <a:off x="365760" y="164592"/>
+            <a:ext cx="11430000" cy="685800"/>
+          </a:xfrm>
+          <a:prstGeom prst="rect">
+            <a:avLst/>
+          </a:prstGeom>
+          <a:noFill/>
+        </p:spPr>
+        <p:txBody>
+          <a:bodyPr wrap="square">
+            <a:spAutoFit/>
+          </a:bodyPr>
           <a:lstStyle/>
           <a:p>
             <a:pPr algn="l"/>
             <a:r>
-              <a:rPr lang="ru-RU" sz="1400" b="0">
+              <a:rPr sz="2600" b="1" i="0">
                 <a:solidFill>
                   <a:srgbClr val="FFFFFF"/>
                 </a:solidFill>
-              </a:rPr>
-              <a:t/>
-            </a:r>
-            <a:br>
-              <a:rPr lang="ru-RU"/>
-            </a:br>
-          </a:p>
-        </p:txBody>
-      </p:sp>
-      <p:sp>
-        <p:nvSpPr>
-          <p:cNvPr id="99" name="TextBox"/>
-          <p:cNvSpPr txBox="1"/>
-          <p:nvPr/>
-        </p:nvSpPr>
-        <p:spPr>
-          <a:xfrm>
-            <a:off x="468000" y="1296000"/>
-            <a:ext cx="2592000" cy="864000"/>
-          </a:xfrm>
-          <a:prstGeom prst="rect">
-            <a:avLst/>
-          </a:prstGeom>
-          <a:noFill/>
-          <a:ln>
-            <a:noFill/>
-          </a:ln>
-        </p:spPr>
-        <p:txBody>
-          <a:bodyPr wrap="square" anchor="ctr"/>
-          <a:lstStyle/>
-          <a:p>
-            <a:pPr algn="ctr"/>
-            <a:r>
-              <a:rPr lang="ru-RU" sz="3600" b="1">
-                <a:solidFill>
-                  <a:srgbClr val="FFFFFF"/>
-                </a:solidFill>
-              </a:rPr>
-              <a:t>9 994</a:t>
-            </a:r>
-            <a:br>
-              <a:rPr lang="ru-RU"/>
-            </a:br>
-          </a:p>
-        </p:txBody>
-      </p:sp>
-      <p:sp>
-        <p:nvSpPr>
-          <p:cNvPr id="99" name="TextBox"/>
-          <p:cNvSpPr txBox="1"/>
-          <p:nvPr/>
-        </p:nvSpPr>
-        <p:spPr>
-          <a:xfrm>
-            <a:off x="468000" y="2160000"/>
-            <a:ext cx="2592000" cy="1007999"/>
-          </a:xfrm>
-          <a:prstGeom prst="rect">
-            <a:avLst/>
-          </a:prstGeom>
-          <a:noFill/>
-          <a:ln>
-            <a:noFill/>
-          </a:ln>
-        </p:spPr>
-        <p:txBody>
-          <a:bodyPr wrap="square" anchor="ctr"/>
-          <a:lstStyle/>
-          <a:p>
-            <a:pPr algn="ctr"/>
-            <a:r>
-              <a:rPr lang="ru-RU" sz="1200" b="0">
-                <a:solidFill>
-                  <a:srgbClr val="CFE0D6"/>
-                </a:solidFill>
-              </a:rPr>
-              <a:t>публикаций</a:t>
-            </a:r>
-            <a:br>
-              <a:rPr lang="ru-RU"/>
-            </a:br>
-            <a:r>
-              <a:rPr lang="ru-RU" sz="1200" b="0">
-                <a:solidFill>
-                  <a:srgbClr val="CFE0D6"/>
-                </a:solidFill>
-              </a:rPr>
-              <a:t>загружено из OpenAlex</a:t>
-            </a:r>
-            <a:br>
-              <a:rPr lang="ru-RU"/>
-            </a:br>
-          </a:p>
-        </p:txBody>
-      </p:sp>
-      <p:sp>
-        <p:nvSpPr>
-          <p:cNvPr id="99" name="TextBox"/>
-          <p:cNvSpPr txBox="1"/>
-          <p:nvPr/>
-        </p:nvSpPr>
-        <p:spPr>
-          <a:xfrm>
-            <a:off x="3311999" y="1152000"/>
-            <a:ext cx="2808000" cy="2088000"/>
+                <a:latin typeface="Calibri"/>
+              </a:rPr>
+              <a:t>Результаты</a:t>
+            </a:r>
+          </a:p>
+        </p:txBody>
+      </p:sp>
+      <p:sp>
+        <p:nvSpPr>
+          <p:cNvPr id="5" name="Rectangle 4"/>
+          <p:cNvSpPr/>
+          <p:nvPr/>
+        </p:nvSpPr>
+        <p:spPr>
+          <a:xfrm>
+            <a:off x="365760" y="1188720"/>
+            <a:ext cx="2103120" cy="2011680"/>
           </a:xfrm>
           <a:prstGeom prst="rect">
             <a:avLst/>
           </a:prstGeom>
           <a:solidFill>
-            <a:srgbClr val="1A5C3A"/>
+            <a:srgbClr val="1E2E25"/>
           </a:solidFill>
           <a:ln>
             <a:noFill/>
           </a:ln>
         </p:spPr>
-        <p:txBody>
-          <a:bodyPr wrap="square" anchor="ctr"/>
-          <a:lstStyle/>
-          <a:p>
-            <a:pPr algn="l"/>
-            <a:r>
-              <a:rPr lang="ru-RU" sz="1400" b="0">
-                <a:solidFill>
-                  <a:srgbClr val="FFFFFF"/>
-                </a:solidFill>
-              </a:rPr>
-              <a:t/>
-            </a:r>
-            <a:br>
-              <a:rPr lang="ru-RU"/>
-            </a:br>
-          </a:p>
-        </p:txBody>
-      </p:sp>
-      <p:sp>
-        <p:nvSpPr>
-          <p:cNvPr id="99" name="TextBox"/>
-          <p:cNvSpPr txBox="1"/>
-          <p:nvPr/>
-        </p:nvSpPr>
-        <p:spPr>
-          <a:xfrm>
-            <a:off x="3419999" y="1296000"/>
-            <a:ext cx="2592000" cy="864000"/>
+        <p:style>
+          <a:lnRef idx="1">
+            <a:schemeClr val="accent1"/>
+          </a:lnRef>
+          <a:fillRef idx="3">
+            <a:schemeClr val="accent1"/>
+          </a:fillRef>
+          <a:effectRef idx="2">
+            <a:schemeClr val="accent1"/>
+          </a:effectRef>
+          <a:fontRef idx="minor">
+            <a:schemeClr val="lt1"/>
+          </a:fontRef>
+        </p:style>
+        <p:txBody>
+          <a:bodyPr rtlCol="0" anchor="ctr"/>
+          <a:lstStyle/>
+          <a:p>
+            <a:pPr algn="ctr"/>
+            <a:endParaRPr/>
+          </a:p>
+        </p:txBody>
+      </p:sp>
+      <p:sp>
+        <p:nvSpPr>
+          <p:cNvPr id="6" name="TextBox 5"/>
+          <p:cNvSpPr txBox="1"/>
+          <p:nvPr/>
+        </p:nvSpPr>
+        <p:spPr>
+          <a:xfrm>
+            <a:off x="411480" y="1280160"/>
+            <a:ext cx="2011680" cy="822960"/>
           </a:xfrm>
           <a:prstGeom prst="rect">
             <a:avLst/>
           </a:prstGeom>
           <a:noFill/>
-          <a:ln>
-            <a:noFill/>
-          </a:ln>
-        </p:spPr>
-        <p:txBody>
-          <a:bodyPr wrap="square" anchor="ctr"/>
+        </p:spPr>
+        <p:txBody>
+          <a:bodyPr wrap="square">
+            <a:spAutoFit/>
+          </a:bodyPr>
           <a:lstStyle/>
           <a:p>
             <a:pPr algn="ctr"/>
             <a:r>
-              <a:rPr lang="ru-RU" sz="3600" b="1">
-                <a:solidFill>
-                  <a:srgbClr val="FFFFFF"/>
-                </a:solidFill>
-              </a:rPr>
-              <a:t>7</a:t>
-            </a:r>
-            <a:br>
-              <a:rPr lang="ru-RU"/>
-            </a:br>
-          </a:p>
-        </p:txBody>
-      </p:sp>
-      <p:sp>
-        <p:nvSpPr>
-          <p:cNvPr id="99" name="TextBox"/>
-          <p:cNvSpPr txBox="1"/>
-          <p:nvPr/>
-        </p:nvSpPr>
-        <p:spPr>
-          <a:xfrm>
-            <a:off x="3419999" y="2160000"/>
-            <a:ext cx="2592000" cy="1007999"/>
+              <a:rPr sz="2200" b="1" i="0">
+                <a:solidFill>
+                  <a:srgbClr val="A8DDB8"/>
+                </a:solidFill>
+                <a:latin typeface="Calibri"/>
+              </a:rPr>
+              <a:t>9 994</a:t>
+            </a:r>
+          </a:p>
+        </p:txBody>
+      </p:sp>
+      <p:sp>
+        <p:nvSpPr>
+          <p:cNvPr id="7" name="TextBox 6"/>
+          <p:cNvSpPr txBox="1"/>
+          <p:nvPr/>
+        </p:nvSpPr>
+        <p:spPr>
+          <a:xfrm>
+            <a:off x="411480" y="2148840"/>
+            <a:ext cx="2011680" cy="914400"/>
           </a:xfrm>
           <a:prstGeom prst="rect">
             <a:avLst/>
           </a:prstGeom>
           <a:noFill/>
-          <a:ln>
-            <a:noFill/>
-          </a:ln>
-        </p:spPr>
-        <p:txBody>
-          <a:bodyPr wrap="square" anchor="ctr"/>
+        </p:spPr>
+        <p:txBody>
+          <a:bodyPr wrap="square">
+            <a:spAutoFit/>
+          </a:bodyPr>
           <a:lstStyle/>
           <a:p>
             <a:pPr algn="ctr"/>
             <a:r>
-              <a:rPr lang="ru-RU" sz="1200" b="0">
+              <a:rPr sz="1200" b="0" i="0">
                 <a:solidFill>
                   <a:srgbClr val="CFE0D6"/>
                 </a:solidFill>
-              </a:rPr>
-              <a:t>таблиц</a:t>
-            </a:r>
-            <a:br>
-              <a:rPr lang="ru-RU"/>
-            </a:br>
-            <a:r>
-              <a:rPr lang="ru-RU" sz="1200" b="0">
-                <a:solidFill>
-                  <a:srgbClr val="CFE0D6"/>
-                </a:solidFill>
-              </a:rPr>
-              <a:t>в базе данных</a:t>
-            </a:r>
-            <a:br>
-              <a:rPr lang="ru-RU"/>
-            </a:br>
-          </a:p>
-        </p:txBody>
-      </p:sp>
-      <p:sp>
-        <p:nvSpPr>
-          <p:cNvPr id="99" name="TextBox"/>
-          <p:cNvSpPr txBox="1"/>
-          <p:nvPr/>
-        </p:nvSpPr>
-        <p:spPr>
-          <a:xfrm>
-            <a:off x="6263999" y="1152000"/>
-            <a:ext cx="2808000" cy="2088000"/>
+                <a:latin typeface="Calibri"/>
+              </a:rPr>
+              <a:t>публикаций
+загружено из OpenAlex</a:t>
+            </a:r>
+          </a:p>
+        </p:txBody>
+      </p:sp>
+      <p:sp>
+        <p:nvSpPr>
+          <p:cNvPr id="8" name="Rectangle 7"/>
+          <p:cNvSpPr/>
+          <p:nvPr/>
+        </p:nvSpPr>
+        <p:spPr>
+          <a:xfrm>
+            <a:off x="2697479" y="1188720"/>
+            <a:ext cx="2103120" cy="2011680"/>
           </a:xfrm>
           <a:prstGeom prst="rect">
             <a:avLst/>
           </a:prstGeom>
           <a:solidFill>
-            <a:srgbClr val="163126"/>
+            <a:srgbClr val="1E2E25"/>
           </a:solidFill>
           <a:ln>
             <a:noFill/>
           </a:ln>
         </p:spPr>
-        <p:txBody>
-          <a:bodyPr wrap="square" anchor="ctr"/>
-          <a:lstStyle/>
-          <a:p>
-            <a:pPr algn="l"/>
-            <a:r>
-              <a:rPr lang="ru-RU" sz="1400" b="0">
-                <a:solidFill>
-                  <a:srgbClr val="FFFFFF"/>
-                </a:solidFill>
-              </a:rPr>
-              <a:t/>
-            </a:r>
-            <a:br>
-              <a:rPr lang="ru-RU"/>
-            </a:br>
-          </a:p>
-        </p:txBody>
-      </p:sp>
-      <p:sp>
-        <p:nvSpPr>
-          <p:cNvPr id="99" name="TextBox"/>
-          <p:cNvSpPr txBox="1"/>
-          <p:nvPr/>
-        </p:nvSpPr>
-        <p:spPr>
-          <a:xfrm>
-            <a:off x="6371999" y="1296000"/>
-            <a:ext cx="2592000" cy="864000"/>
+        <p:style>
+          <a:lnRef idx="1">
+            <a:schemeClr val="accent1"/>
+          </a:lnRef>
+          <a:fillRef idx="3">
+            <a:schemeClr val="accent1"/>
+          </a:fillRef>
+          <a:effectRef idx="2">
+            <a:schemeClr val="accent1"/>
+          </a:effectRef>
+          <a:fontRef idx="minor">
+            <a:schemeClr val="lt1"/>
+          </a:fontRef>
+        </p:style>
+        <p:txBody>
+          <a:bodyPr rtlCol="0" anchor="ctr"/>
+          <a:lstStyle/>
+          <a:p>
+            <a:pPr algn="ctr"/>
+            <a:endParaRPr/>
+          </a:p>
+        </p:txBody>
+      </p:sp>
+      <p:sp>
+        <p:nvSpPr>
+          <p:cNvPr id="9" name="TextBox 8"/>
+          <p:cNvSpPr txBox="1"/>
+          <p:nvPr/>
+        </p:nvSpPr>
+        <p:spPr>
+          <a:xfrm>
+            <a:off x="2743199" y="1280160"/>
+            <a:ext cx="2011680" cy="822960"/>
           </a:xfrm>
           <a:prstGeom prst="rect">
             <a:avLst/>
           </a:prstGeom>
           <a:noFill/>
-          <a:ln>
-            <a:noFill/>
-          </a:ln>
-        </p:spPr>
-        <p:txBody>
-          <a:bodyPr wrap="square" anchor="ctr"/>
+        </p:spPr>
+        <p:txBody>
+          <a:bodyPr wrap="square">
+            <a:spAutoFit/>
+          </a:bodyPr>
           <a:lstStyle/>
           <a:p>
             <a:pPr algn="ctr"/>
             <a:r>
-              <a:rPr lang="ru-RU" sz="3600" b="1">
-                <a:solidFill>
-                  <a:srgbClr val="FFFFFF"/>
-                </a:solidFill>
-              </a:rPr>
-              <a:t>80,8%</a:t>
-            </a:r>
-            <a:br>
-              <a:rPr lang="ru-RU"/>
-            </a:br>
-          </a:p>
-        </p:txBody>
-      </p:sp>
-      <p:sp>
-        <p:nvSpPr>
-          <p:cNvPr id="99" name="TextBox"/>
-          <p:cNvSpPr txBox="1"/>
-          <p:nvPr/>
-        </p:nvSpPr>
-        <p:spPr>
-          <a:xfrm>
-            <a:off x="6371999" y="2160000"/>
-            <a:ext cx="2592000" cy="1007999"/>
+              <a:rPr sz="2200" b="1" i="0">
+                <a:solidFill>
+                  <a:srgbClr val="A8DDB8"/>
+                </a:solidFill>
+                <a:latin typeface="Calibri"/>
+              </a:rPr>
+              <a:t>7 таблиц</a:t>
+            </a:r>
+          </a:p>
+        </p:txBody>
+      </p:sp>
+      <p:sp>
+        <p:nvSpPr>
+          <p:cNvPr id="10" name="TextBox 9"/>
+          <p:cNvSpPr txBox="1"/>
+          <p:nvPr/>
+        </p:nvSpPr>
+        <p:spPr>
+          <a:xfrm>
+            <a:off x="2743199" y="2148840"/>
+            <a:ext cx="2011680" cy="914400"/>
           </a:xfrm>
           <a:prstGeom prst="rect">
             <a:avLst/>
           </a:prstGeom>
           <a:noFill/>
-          <a:ln>
-            <a:noFill/>
-          </a:ln>
-        </p:spPr>
-        <p:txBody>
-          <a:bodyPr wrap="square" anchor="ctr"/>
+        </p:spPr>
+        <p:txBody>
+          <a:bodyPr wrap="square">
+            <a:spAutoFit/>
+          </a:bodyPr>
           <a:lstStyle/>
           <a:p>
             <a:pPr algn="ctr"/>
             <a:r>
-              <a:rPr lang="ru-RU" sz="1200" b="0">
+              <a:rPr sz="1200" b="0" i="0">
                 <a:solidFill>
                   <a:srgbClr val="CFE0D6"/>
                 </a:solidFill>
-              </a:rPr>
-              <a:t>публикаций</a:t>
-            </a:r>
-            <a:br>
-              <a:rPr lang="ru-RU"/>
-            </a:br>
-            <a:r>
-              <a:rPr lang="ru-RU" sz="1200" b="0">
-                <a:solidFill>
-                  <a:srgbClr val="CFE0D6"/>
-                </a:solidFill>
-              </a:rPr>
-              <a:t>с геокоординатами</a:t>
-            </a:r>
-            <a:br>
-              <a:rPr lang="ru-RU"/>
-            </a:br>
-            <a:r>
-              <a:rPr lang="ru-RU" sz="1200" b="0">
-                <a:solidFill>
-                  <a:srgbClr val="CFE0D6"/>
-                </a:solidFill>
-              </a:rPr>
-              <a:t>(порог — 75%)</a:t>
-            </a:r>
-            <a:br>
-              <a:rPr lang="ru-RU"/>
-            </a:br>
-          </a:p>
-        </p:txBody>
-      </p:sp>
-      <p:sp>
-        <p:nvSpPr>
-          <p:cNvPr id="99" name="TextBox"/>
-          <p:cNvSpPr txBox="1"/>
-          <p:nvPr/>
-        </p:nvSpPr>
-        <p:spPr>
-          <a:xfrm>
-            <a:off x="9216000" y="1152000"/>
-            <a:ext cx="2808000" cy="2088000"/>
+                <a:latin typeface="Calibri"/>
+              </a:rPr>
+              <a:t>реляционная БД
+PostgreSQL</a:t>
+            </a:r>
+          </a:p>
+        </p:txBody>
+      </p:sp>
+      <p:sp>
+        <p:nvSpPr>
+          <p:cNvPr id="11" name="Rectangle 10"/>
+          <p:cNvSpPr/>
+          <p:nvPr/>
+        </p:nvSpPr>
+        <p:spPr>
+          <a:xfrm>
+            <a:off x="5029200" y="1188720"/>
+            <a:ext cx="2103120" cy="2011680"/>
           </a:xfrm>
           <a:prstGeom prst="rect">
             <a:avLst/>
           </a:prstGeom>
           <a:solidFill>
-            <a:srgbClr val="7D3C98"/>
+            <a:srgbClr val="1E2E25"/>
           </a:solidFill>
           <a:ln>
             <a:noFill/>
           </a:ln>
         </p:spPr>
-        <p:txBody>
-          <a:bodyPr wrap="square" anchor="ctr"/>
-          <a:lstStyle/>
-          <a:p>
-            <a:pPr algn="l"/>
-            <a:r>
-              <a:rPr lang="ru-RU" sz="1400" b="0">
-                <a:solidFill>
-                  <a:srgbClr val="FFFFFF"/>
-                </a:solidFill>
-              </a:rPr>
-              <a:t/>
-            </a:r>
-            <a:br>
-              <a:rPr lang="ru-RU"/>
-            </a:br>
-          </a:p>
-        </p:txBody>
-      </p:sp>
-      <p:sp>
-        <p:nvSpPr>
-          <p:cNvPr id="99" name="TextBox"/>
-          <p:cNvSpPr txBox="1"/>
-          <p:nvPr/>
-        </p:nvSpPr>
-        <p:spPr>
-          <a:xfrm>
-            <a:off x="9324000" y="1296000"/>
-            <a:ext cx="2592000" cy="864000"/>
+        <p:style>
+          <a:lnRef idx="1">
+            <a:schemeClr val="accent1"/>
+          </a:lnRef>
+          <a:fillRef idx="3">
+            <a:schemeClr val="accent1"/>
+          </a:fillRef>
+          <a:effectRef idx="2">
+            <a:schemeClr val="accent1"/>
+          </a:effectRef>
+          <a:fontRef idx="minor">
+            <a:schemeClr val="lt1"/>
+          </a:fontRef>
+        </p:style>
+        <p:txBody>
+          <a:bodyPr rtlCol="0" anchor="ctr"/>
+          <a:lstStyle/>
+          <a:p>
+            <a:pPr algn="ctr"/>
+            <a:endParaRPr/>
+          </a:p>
+        </p:txBody>
+      </p:sp>
+      <p:sp>
+        <p:nvSpPr>
+          <p:cNvPr id="12" name="TextBox 11"/>
+          <p:cNvSpPr txBox="1"/>
+          <p:nvPr/>
+        </p:nvSpPr>
+        <p:spPr>
+          <a:xfrm>
+            <a:off x="5074920" y="1280160"/>
+            <a:ext cx="2011680" cy="822960"/>
           </a:xfrm>
           <a:prstGeom prst="rect">
             <a:avLst/>
           </a:prstGeom>
           <a:noFill/>
+        </p:spPr>
+        <p:txBody>
+          <a:bodyPr wrap="square">
+            <a:spAutoFit/>
+          </a:bodyPr>
+          <a:lstStyle/>
+          <a:p>
+            <a:pPr algn="ctr"/>
+            <a:r>
+              <a:rPr sz="2200" b="1" i="0">
+                <a:solidFill>
+                  <a:srgbClr val="A8DDB8"/>
+                </a:solidFill>
+                <a:latin typeface="Calibri"/>
+              </a:rPr>
+              <a:t>80,8%</a:t>
+            </a:r>
+          </a:p>
+        </p:txBody>
+      </p:sp>
+      <p:sp>
+        <p:nvSpPr>
+          <p:cNvPr id="13" name="TextBox 12"/>
+          <p:cNvSpPr txBox="1"/>
+          <p:nvPr/>
+        </p:nvSpPr>
+        <p:spPr>
+          <a:xfrm>
+            <a:off x="5074920" y="2148840"/>
+            <a:ext cx="2011680" cy="914400"/>
+          </a:xfrm>
+          <a:prstGeom prst="rect">
+            <a:avLst/>
+          </a:prstGeom>
+          <a:noFill/>
+        </p:spPr>
+        <p:txBody>
+          <a:bodyPr wrap="square">
+            <a:spAutoFit/>
+          </a:bodyPr>
+          <a:lstStyle/>
+          <a:p>
+            <a:pPr algn="ctr"/>
+            <a:r>
+              <a:rPr sz="1200" b="0" i="0">
+                <a:solidFill>
+                  <a:srgbClr val="CFE0D6"/>
+                </a:solidFill>
+                <a:latin typeface="Calibri"/>
+              </a:rPr>
+              <a:t>публикаций с
+геокоординатами</a:t>
+            </a:r>
+          </a:p>
+        </p:txBody>
+      </p:sp>
+      <p:sp>
+        <p:nvSpPr>
+          <p:cNvPr id="14" name="Rectangle 13"/>
+          <p:cNvSpPr/>
+          <p:nvPr/>
+        </p:nvSpPr>
+        <p:spPr>
+          <a:xfrm>
+            <a:off x="7360919" y="1188720"/>
+            <a:ext cx="2103120" cy="2011680"/>
+          </a:xfrm>
+          <a:prstGeom prst="rect">
+            <a:avLst/>
+          </a:prstGeom>
+          <a:solidFill>
+            <a:srgbClr val="1E2E25"/>
+          </a:solidFill>
           <a:ln>
             <a:noFill/>
           </a:ln>
         </p:spPr>
-        <p:txBody>
-          <a:bodyPr wrap="square" anchor="ctr"/>
+        <p:style>
+          <a:lnRef idx="1">
+            <a:schemeClr val="accent1"/>
+          </a:lnRef>
+          <a:fillRef idx="3">
+            <a:schemeClr val="accent1"/>
+          </a:fillRef>
+          <a:effectRef idx="2">
+            <a:schemeClr val="accent1"/>
+          </a:effectRef>
+          <a:fontRef idx="minor">
+            <a:schemeClr val="lt1"/>
+          </a:fontRef>
+        </p:style>
+        <p:txBody>
+          <a:bodyPr rtlCol="0" anchor="ctr"/>
           <a:lstStyle/>
           <a:p>
             <a:pPr algn="ctr"/>
-            <a:r>
-              <a:rPr lang="ru-RU" sz="3600" b="1">
-                <a:solidFill>
-                  <a:srgbClr val="FFFFFF"/>
-                </a:solidFill>
-              </a:rPr>
-              <a:t>5</a:t>
-            </a:r>
-            <a:br>
-              <a:rPr lang="ru-RU"/>
-            </a:br>
-          </a:p>
-        </p:txBody>
-      </p:sp>
-      <p:sp>
-        <p:nvSpPr>
-          <p:cNvPr id="99" name="TextBox"/>
-          <p:cNvSpPr txBox="1"/>
-          <p:nvPr/>
-        </p:nvSpPr>
-        <p:spPr>
-          <a:xfrm>
-            <a:off x="9324000" y="2160000"/>
-            <a:ext cx="2592000" cy="1007999"/>
+            <a:endParaRPr/>
+          </a:p>
+        </p:txBody>
+      </p:sp>
+      <p:sp>
+        <p:nvSpPr>
+          <p:cNvPr id="15" name="TextBox 14"/>
+          <p:cNvSpPr txBox="1"/>
+          <p:nvPr/>
+        </p:nvSpPr>
+        <p:spPr>
+          <a:xfrm>
+            <a:off x="7406640" y="1280160"/>
+            <a:ext cx="2011680" cy="822960"/>
           </a:xfrm>
           <a:prstGeom prst="rect">
             <a:avLst/>
           </a:prstGeom>
           <a:noFill/>
+        </p:spPr>
+        <p:txBody>
+          <a:bodyPr wrap="square">
+            <a:spAutoFit/>
+          </a:bodyPr>
+          <a:lstStyle/>
+          <a:p>
+            <a:pPr algn="ctr"/>
+            <a:r>
+              <a:rPr sz="2200" b="1" i="0">
+                <a:solidFill>
+                  <a:srgbClr val="A8DDB8"/>
+                </a:solidFill>
+                <a:latin typeface="Calibri"/>
+              </a:rPr>
+              <a:t>5 режимов</a:t>
+            </a:r>
+          </a:p>
+        </p:txBody>
+      </p:sp>
+      <p:sp>
+        <p:nvSpPr>
+          <p:cNvPr id="16" name="TextBox 15"/>
+          <p:cNvSpPr txBox="1"/>
+          <p:nvPr/>
+        </p:nvSpPr>
+        <p:spPr>
+          <a:xfrm>
+            <a:off x="7406640" y="2148840"/>
+            <a:ext cx="2011680" cy="914400"/>
+          </a:xfrm>
+          <a:prstGeom prst="rect">
+            <a:avLst/>
+          </a:prstGeom>
+          <a:noFill/>
+        </p:spPr>
+        <p:txBody>
+          <a:bodyPr wrap="square">
+            <a:spAutoFit/>
+          </a:bodyPr>
+          <a:lstStyle/>
+          <a:p>
+            <a:pPr algn="ctr"/>
+            <a:r>
+              <a:rPr sz="1200" b="0" i="0">
+                <a:solidFill>
+                  <a:srgbClr val="CFE0D6"/>
+                </a:solidFill>
+                <a:latin typeface="Calibri"/>
+              </a:rPr>
+              <a:t>графа связей
+(SVG, без библиотек)</a:t>
+            </a:r>
+          </a:p>
+        </p:txBody>
+      </p:sp>
+      <p:sp>
+        <p:nvSpPr>
+          <p:cNvPr id="17" name="Rectangle 16"/>
+          <p:cNvSpPr/>
+          <p:nvPr/>
+        </p:nvSpPr>
+        <p:spPr>
+          <a:xfrm>
+            <a:off x="9692640" y="1188720"/>
+            <a:ext cx="2103120" cy="2011680"/>
+          </a:xfrm>
+          <a:prstGeom prst="rect">
+            <a:avLst/>
+          </a:prstGeom>
+          <a:solidFill>
+            <a:srgbClr val="1E2E25"/>
+          </a:solidFill>
           <a:ln>
             <a:noFill/>
           </a:ln>
         </p:spPr>
-        <p:txBody>
-          <a:bodyPr wrap="square" anchor="ctr"/>
+        <p:style>
+          <a:lnRef idx="1">
+            <a:schemeClr val="accent1"/>
+          </a:lnRef>
+          <a:fillRef idx="3">
+            <a:schemeClr val="accent1"/>
+          </a:fillRef>
+          <a:effectRef idx="2">
+            <a:schemeClr val="accent1"/>
+          </a:effectRef>
+          <a:fontRef idx="minor">
+            <a:schemeClr val="lt1"/>
+          </a:fontRef>
+        </p:style>
+        <p:txBody>
+          <a:bodyPr rtlCol="0" anchor="ctr"/>
           <a:lstStyle/>
           <a:p>
             <a:pPr algn="ctr"/>
-            <a:r>
-              <a:rPr lang="ru-RU" sz="1200" b="0">
+            <a:endParaRPr/>
+          </a:p>
+        </p:txBody>
+      </p:sp>
+      <p:sp>
+        <p:nvSpPr>
+          <p:cNvPr id="18" name="TextBox 17"/>
+          <p:cNvSpPr txBox="1"/>
+          <p:nvPr/>
+        </p:nvSpPr>
+        <p:spPr>
+          <a:xfrm>
+            <a:off x="9738360" y="1280160"/>
+            <a:ext cx="2011680" cy="822960"/>
+          </a:xfrm>
+          <a:prstGeom prst="rect">
+            <a:avLst/>
+          </a:prstGeom>
+          <a:noFill/>
+        </p:spPr>
+        <p:txBody>
+          <a:bodyPr wrap="square">
+            <a:spAutoFit/>
+          </a:bodyPr>
+          <a:lstStyle/>
+          <a:p>
+            <a:pPr algn="ctr"/>
+            <a:r>
+              <a:rPr sz="2200" b="1" i="0">
+                <a:solidFill>
+                  <a:srgbClr val="A8DDB8"/>
+                </a:solidFill>
+                <a:latin typeface="Calibri"/>
+              </a:rPr>
+              <a:t>5 признаков</a:t>
+            </a:r>
+          </a:p>
+        </p:txBody>
+      </p:sp>
+      <p:sp>
+        <p:nvSpPr>
+          <p:cNvPr id="19" name="TextBox 18"/>
+          <p:cNvSpPr txBox="1"/>
+          <p:nvPr/>
+        </p:nvSpPr>
+        <p:spPr>
+          <a:xfrm>
+            <a:off x="9738360" y="2148840"/>
+            <a:ext cx="2011680" cy="914400"/>
+          </a:xfrm>
+          <a:prstGeom prst="rect">
+            <a:avLst/>
+          </a:prstGeom>
+          <a:noFill/>
+        </p:spPr>
+        <p:txBody>
+          <a:bodyPr wrap="square">
+            <a:spAutoFit/>
+          </a:bodyPr>
+          <a:lstStyle/>
+          <a:p>
+            <a:pPr algn="ctr"/>
+            <a:r>
+              <a:rPr sz="1200" b="0" i="0">
                 <a:solidFill>
                   <a:srgbClr val="CFE0D6"/>
                 </a:solidFill>
-              </a:rPr>
-              <a:t>режимов</a:t>
-            </a:r>
-            <a:br>
-              <a:rPr lang="ru-RU"/>
-            </a:br>
-            <a:r>
-              <a:rPr lang="ru-RU" sz="1200" b="0">
+                <a:latin typeface="Calibri"/>
+              </a:rPr>
+              <a:t>алгоритм поиска
+похожих статей</a:t>
+            </a:r>
+          </a:p>
+        </p:txBody>
+      </p:sp>
+      <p:sp>
+        <p:nvSpPr>
+          <p:cNvPr id="20" name="TextBox 19"/>
+          <p:cNvSpPr txBox="1"/>
+          <p:nvPr/>
+        </p:nvSpPr>
+        <p:spPr>
+          <a:xfrm>
+            <a:off x="457200" y="3474720"/>
+            <a:ext cx="11247120" cy="1371600"/>
+          </a:xfrm>
+          <a:prstGeom prst="rect">
+            <a:avLst/>
+          </a:prstGeom>
+          <a:noFill/>
+        </p:spPr>
+        <p:txBody>
+          <a:bodyPr wrap="square">
+            <a:spAutoFit/>
+          </a:bodyPr>
+          <a:lstStyle/>
+          <a:p>
+            <a:pPr algn="ctr"/>
+            <a:r>
+              <a:rPr sz="1300"/>
+              <a:t>Загружено 9 994 публикаций из OpenAlex
+Создана реляционная БД из 7 таблиц PostgreSQL
+Геокодировано 80,8% публикаций (точные координаты организаций)
+Реализованы карта, граф с 5 режимами и фасетные фильтры
+Разработан алгоритм поиска похожих статей по 5 признакам
+Создан REST API с gzip-сжатием и веб-интерфейс с тёмной темой</a:t>
+            </a:r>
+          </a:p>
+        </p:txBody>
+      </p:sp>
+      <p:sp>
+        <p:nvSpPr>
+          <p:cNvPr id="21" name="TextBox 20"/>
+          <p:cNvSpPr txBox="1"/>
+          <p:nvPr/>
+        </p:nvSpPr>
+        <p:spPr>
+          <a:xfrm>
+            <a:off x="457200" y="5029200"/>
+            <a:ext cx="11247120" cy="548640"/>
+          </a:xfrm>
+          <a:prstGeom prst="rect">
+            <a:avLst/>
+          </a:prstGeom>
+          <a:noFill/>
+        </p:spPr>
+        <p:txBody>
+          <a:bodyPr wrap="square">
+            <a:spAutoFit/>
+          </a:bodyPr>
+          <a:lstStyle/>
+          <a:p>
+            <a:pPr algn="ctr"/>
+            <a:r>
+              <a:rPr sz="1600" b="0" i="0">
                 <a:solidFill>
                   <a:srgbClr val="CFE0D6"/>
                 </a:solidFill>
-              </a:rPr>
-              <a:t>отображения</a:t>
-            </a:r>
-            <a:br>
-              <a:rPr lang="ru-RU"/>
-            </a:br>
-            <a:r>
-              <a:rPr lang="ru-RU" sz="1200" b="0">
-                <a:solidFill>
-                  <a:srgbClr val="CFE0D6"/>
-                </a:solidFill>
-              </a:rPr>
-              <a:t>в графе</a:t>
-            </a:r>
-            <a:br>
-              <a:rPr lang="ru-RU"/>
-            </a:br>
-          </a:p>
-        </p:txBody>
-      </p:sp>
-      <p:sp>
-        <p:nvSpPr>
-          <p:cNvPr id="99" name="TextBox"/>
-          <p:cNvSpPr txBox="1"/>
-          <p:nvPr/>
-        </p:nvSpPr>
-        <p:spPr>
-          <a:xfrm>
-            <a:off x="468000" y="3528000"/>
-            <a:ext cx="11232000" cy="1260000"/>
-          </a:xfrm>
-          <a:prstGeom prst="rect">
-            <a:avLst/>
-          </a:prstGeom>
-          <a:noFill/>
+                <a:latin typeface="Calibri"/>
+              </a:rPr>
+              <a:t>REST API  ·  Фасетные фильтры  ·  Тёмная тема  ·  gzip-сжатие</a:t>
+            </a:r>
+          </a:p>
+        </p:txBody>
+      </p:sp>
+      <p:sp>
+        <p:nvSpPr>
+          <p:cNvPr id="22" name="Rectangle 21"/>
+          <p:cNvSpPr/>
+          <p:nvPr/>
+        </p:nvSpPr>
+        <p:spPr>
+          <a:xfrm>
+            <a:off x="0" y="5943600"/>
+            <a:ext cx="12188952" cy="914400"/>
+          </a:xfrm>
+          <a:prstGeom prst="rect">
+            <a:avLst/>
+          </a:prstGeom>
+          <a:solidFill>
+            <a:srgbClr val="23613F"/>
+          </a:solidFill>
           <a:ln>
             <a:noFill/>
           </a:ln>
         </p:spPr>
-        <p:txBody>
-          <a:bodyPr wrap="square" anchor="ctr"/>
-          <a:lstStyle/>
-          <a:p>
-            <a:pPr algn="l"/>
-            <a:r>
-              <a:rPr lang="ru-RU" sz="1300" b="0">
-                <a:solidFill>
-                  <a:srgbClr val="E8F5ED"/>
-                </a:solidFill>
-              </a:rPr>
-              <a:t>Система переводит плоский список статей в два визуальных представления — карту с географией исследований и граф с авторскими связями.</a:t>
-            </a:r>
-            <a:br>
-              <a:rPr lang="ru-RU"/>
-            </a:br>
-            <a:r>
-              <a:rPr lang="ru-RU" sz="1300" b="0">
-                <a:solidFill>
-                  <a:srgbClr val="E8F5ED"/>
-                </a:solidFill>
-              </a:rPr>
-              <a:t>В отличие от рассмотренных аналогов (VOSviewer, Connected Papers, ResearchRabbit) сочетает карту, граф и поиск похожих в одной браузерной среде без установки ПО.</a:t>
-            </a:r>
-            <a:br>
-              <a:rPr lang="ru-RU"/>
-            </a:br>
-          </a:p>
-        </p:txBody>
-      </p:sp>
-      <p:sp>
-        <p:nvSpPr>
-          <p:cNvPr id="99" name="TextBox"/>
-          <p:cNvSpPr txBox="1"/>
-          <p:nvPr/>
-        </p:nvSpPr>
-        <p:spPr>
-          <a:xfrm>
-            <a:off x="468000" y="4896000"/>
-            <a:ext cx="11232000" cy="792000"/>
+        <p:style>
+          <a:lnRef idx="1">
+            <a:schemeClr val="accent1"/>
+          </a:lnRef>
+          <a:fillRef idx="3">
+            <a:schemeClr val="accent1"/>
+          </a:fillRef>
+          <a:effectRef idx="2">
+            <a:schemeClr val="accent1"/>
+          </a:effectRef>
+          <a:fontRef idx="minor">
+            <a:schemeClr val="lt1"/>
+          </a:fontRef>
+        </p:style>
+        <p:txBody>
+          <a:bodyPr rtlCol="0" anchor="ctr"/>
+          <a:lstStyle/>
+          <a:p>
+            <a:pPr algn="ctr"/>
+            <a:endParaRPr/>
+          </a:p>
+        </p:txBody>
+      </p:sp>
+      <p:sp>
+        <p:nvSpPr>
+          <p:cNvPr id="23" name="TextBox 22"/>
+          <p:cNvSpPr txBox="1"/>
+          <p:nvPr/>
+        </p:nvSpPr>
+        <p:spPr>
+          <a:xfrm>
+            <a:off x="457200" y="6035040"/>
+            <a:ext cx="11247120" cy="594360"/>
           </a:xfrm>
           <a:prstGeom prst="rect">
             <a:avLst/>
           </a:prstGeom>
           <a:noFill/>
-          <a:ln>
-            <a:noFill/>
-          </a:ln>
-        </p:spPr>
-        <p:txBody>
-          <a:bodyPr wrap="square" anchor="ctr"/>
-          <a:lstStyle/>
-          <a:p>
-            <a:pPr algn="l"/>
-            <a:r>
-              <a:rPr lang="ru-RU" sz="1200" b="0">
-                <a:solidFill>
-                  <a:srgbClr val="8BB29A"/>
-                </a:solidFill>
-              </a:rPr>
-              <a:t>Алгоритм поиска похожих статей: авторы (×4) · темы (×3) · ключевые слова (×2) · аффилиации (×2) · журнал (×2)</a:t>
-            </a:r>
-            <a:br>
-              <a:rPr lang="ru-RU"/>
-            </a:br>
-          </a:p>
-        </p:txBody>
-      </p:sp>
-      <p:sp>
-        <p:nvSpPr>
-          <p:cNvPr id="2140" name="pb140"/>
+        </p:spPr>
+        <p:txBody>
+          <a:bodyPr wrap="square">
+            <a:spAutoFit/>
+          </a:bodyPr>
+          <a:lstStyle/>
+          <a:p>
+            <a:pPr algn="ctr"/>
+            <a:r>
+              <a:rPr sz="1500" b="0" i="0">
+                <a:solidFill>
+                  <a:srgbClr val="FFFFFF"/>
+                </a:solidFill>
+                <a:latin typeface="Calibri"/>
+              </a:rPr>
+              <a:t>Веб-приложение: http://127.0.0.1:8000  |  Запуск: python openalex_server.py</a:t>
+            </a:r>
+          </a:p>
+        </p:txBody>
+      </p:sp>
+      <p:sp>
+        <p:nvSpPr>
+          <p:cNvPr id="3000" name="pb0"/>
           <p:cNvSpPr txBox="1"/>
           <p:nvPr/>
         </p:nvSpPr>
@@ -9283,7 +9400,7 @@
       </p:sp>
       <p:sp>
         <p:nvSpPr>
-          <p:cNvPr id="2141" name="pb141"/>
+          <p:cNvPr id="3001" name="pb1"/>
           <p:cNvSpPr txBox="1"/>
           <p:nvPr/>
         </p:nvSpPr>
@@ -9310,7 +9427,7 @@
       </p:sp>
       <p:sp>
         <p:nvSpPr>
-          <p:cNvPr id="2142" name="pb142"/>
+          <p:cNvPr id="3002" name="pb2"/>
           <p:cNvSpPr txBox="1"/>
           <p:nvPr/>
         </p:nvSpPr>
@@ -9337,7 +9454,7 @@
       </p:sp>
       <p:sp>
         <p:nvSpPr>
-          <p:cNvPr id="2243" name="pbn143"/>
+          <p:cNvPr id="3103" name="pbn3"/>
           <p:cNvSpPr txBox="1"/>
           <p:nvPr/>
         </p:nvSpPr>

</xml_diff>

<commit_message>
feat(presentation): restructure geocoding slide into 3 stages
Stage 1: Prioritization (orgs sorted by number of dependent publications)
Stage 2: OpenAlex API (78% coverage)
Stage 3: Photon/OSM (+2.8%)
Removed all technical details (GET URLs, batch sizes, cache filenames).
</commit_message>
<xml_diff>
--- a/docs/Визуализация науки на основе метаданных публикаций и журналов.pptx
+++ b/docs/Визуализация науки на основе метаданных публикаций и журналов.pptx
@@ -16024,327 +16024,95 @@
       </p:sp>
       <p:sp>
         <p:nvSpPr>
-          <p:cNvPr id="4" name="TextBox 3"/>
-          <p:cNvSpPr txBox="1"/>
-          <p:nvPr/>
-        </p:nvSpPr>
-        <p:spPr>
-          <a:xfrm>
-            <a:off x="365760" y="164592"/>
-            <a:ext cx="11430000" cy="685800"/>
-          </a:xfrm>
-          <a:prstGeom prst="rect">
-            <a:avLst/>
-          </a:prstGeom>
-          <a:noFill/>
-        </p:spPr>
-        <p:txBody>
-          <a:bodyPr wrap="square">
-            <a:spAutoFit/>
-          </a:bodyPr>
-          <a:lstStyle/>
-          <a:p>
-            <a:pPr algn="l"/>
-            <a:r>
-              <a:rPr sz="2600" b="1" i="0">
-                <a:solidFill>
-                  <a:srgbClr val="FFFFFF"/>
-                </a:solidFill>
-                <a:latin typeface="Calibri"/>
-              </a:rPr>
-              <a:t>Географическая привязка</a:t>
-            </a:r>
-          </a:p>
-        </p:txBody>
-      </p:sp>
-      <p:sp>
-        <p:nvSpPr>
-          <p:cNvPr id="5" name="Rectangle 4"/>
-          <p:cNvSpPr/>
-          <p:nvPr/>
-        </p:nvSpPr>
-        <p:spPr>
-          <a:xfrm>
-            <a:off x="365760" y="1097280"/>
-            <a:ext cx="5394960" cy="2468880"/>
+          <p:cNvPr id="2090" name="pb90"/>
+          <p:cNvSpPr txBox="1"/>
+          <p:nvPr/>
+        </p:nvSpPr>
+        <p:spPr>
+          <a:xfrm>
+            <a:off x="0" y="6660000"/>
+            <a:ext cx="12192000" cy="198000"/>
           </a:xfrm>
           <a:prstGeom prst="rect">
             <a:avLst/>
           </a:prstGeom>
           <a:solidFill>
-            <a:srgbClr val="FFFFFF"/>
+            <a:srgbClr val="0D1F14"/>
           </a:solidFill>
-          <a:ln w="9525">
-            <a:solidFill>
-              <a:srgbClr val="CFE0D6"/>
-            </a:solidFill>
+          <a:ln>
+            <a:noFill/>
           </a:ln>
         </p:spPr>
-        <p:style>
-          <a:lnRef idx="1">
-            <a:schemeClr val="accent1"/>
-          </a:lnRef>
-          <a:fillRef idx="3">
-            <a:schemeClr val="accent1"/>
-          </a:fillRef>
-          <a:effectRef idx="2">
-            <a:schemeClr val="accent1"/>
-          </a:effectRef>
-          <a:fontRef idx="minor">
-            <a:schemeClr val="lt1"/>
-          </a:fontRef>
-        </p:style>
-        <p:txBody>
-          <a:bodyPr rtlCol="0" anchor="ctr"/>
-          <a:lstStyle/>
-          <a:p>
-            <a:pPr algn="ctr"/>
-            <a:endParaRPr/>
-          </a:p>
-        </p:txBody>
-      </p:sp>
-      <p:sp>
-        <p:nvSpPr>
-          <p:cNvPr id="6" name="TextBox 5"/>
-          <p:cNvSpPr txBox="1"/>
-          <p:nvPr/>
-        </p:nvSpPr>
-        <p:spPr>
-          <a:xfrm>
-            <a:off x="457200" y="1188720"/>
-            <a:ext cx="5212080" cy="457200"/>
-          </a:xfrm>
-          <a:prstGeom prst="rect">
-            <a:avLst/>
-          </a:prstGeom>
-          <a:noFill/>
-        </p:spPr>
-        <p:txBody>
-          <a:bodyPr wrap="square">
-            <a:spAutoFit/>
-          </a:bodyPr>
-          <a:lstStyle/>
-          <a:p>
-            <a:pPr algn="l"/>
-            <a:r>
-              <a:rPr sz="1600" b="1" i="0">
-                <a:solidFill>
-                  <a:srgbClr val="23613F"/>
-                </a:solidFill>
-                <a:latin typeface="Calibri"/>
-              </a:rPr>
-              <a:t>Этап 1 — OpenAlex API</a:t>
-            </a:r>
-          </a:p>
-        </p:txBody>
-      </p:sp>
-      <p:sp>
-        <p:nvSpPr>
-          <p:cNvPr id="7" name="TextBox 6"/>
-          <p:cNvSpPr txBox="1"/>
-          <p:nvPr/>
-        </p:nvSpPr>
-        <p:spPr>
-          <a:xfrm>
-            <a:off x="457200" y="1691640"/>
-            <a:ext cx="5212080" cy="1783080"/>
-          </a:xfrm>
-          <a:prstGeom prst="rect">
-            <a:avLst/>
-          </a:prstGeom>
-          <a:noFill/>
-        </p:spPr>
-        <p:txBody>
-          <a:bodyPr wrap="square">
-            <a:spAutoFit/>
-          </a:bodyPr>
-          <a:lstStyle/>
-          <a:p>
-            <a:pPr algn="l"/>
-            <a:r>
-              <a:rPr sz="1400" b="0" i="0">
-                <a:solidFill>
-                  <a:srgbClr val="122017"/>
-                </a:solidFill>
-                <a:latin typeface="Calibri"/>
-              </a:rPr>
-              <a:t>GET /institutions?filter=ids.openalex:I1|I2|...
-• Батчи по 100 institution_id
-• Пауза 0,5 сек между запросами
-• Кэш: geo_cache.json
-Результат: 7 822 / 9 994 публикаций (78%)</a:t>
-            </a:r>
-          </a:p>
-        </p:txBody>
-      </p:sp>
-      <p:sp>
-        <p:nvSpPr>
-          <p:cNvPr id="8" name="TextBox 7"/>
-          <p:cNvSpPr txBox="1"/>
-          <p:nvPr/>
-        </p:nvSpPr>
-        <p:spPr>
-          <a:xfrm>
-            <a:off x="5852160" y="1828800"/>
-            <a:ext cx="822960" cy="1371600"/>
-          </a:xfrm>
-          <a:prstGeom prst="rect">
-            <a:avLst/>
-          </a:prstGeom>
-          <a:noFill/>
-        </p:spPr>
-        <p:txBody>
-          <a:bodyPr wrap="square">
-            <a:spAutoFit/>
-          </a:bodyPr>
-          <a:lstStyle/>
-          <a:p>
-            <a:pPr algn="ctr"/>
-            <a:r>
-              <a:rPr sz="1300" b="0" i="0">
-                <a:solidFill>
-                  <a:srgbClr val="577166"/>
-                </a:solidFill>
-                <a:latin typeface="Calibri"/>
-              </a:rPr>
-              <a:t>→
-не хватает
-22%</a:t>
-            </a:r>
-          </a:p>
-        </p:txBody>
-      </p:sp>
-      <p:sp>
-        <p:nvSpPr>
-          <p:cNvPr id="9" name="Rectangle 8"/>
-          <p:cNvSpPr/>
-          <p:nvPr/>
-        </p:nvSpPr>
-        <p:spPr>
-          <a:xfrm>
-            <a:off x="6766560" y="1097280"/>
-            <a:ext cx="5029200" cy="2468880"/>
+        <p:txBody>
+          <a:bodyPr wrap="none" anchor="ctr"/>
+          <a:lstStyle/>
+          <a:p/>
+        </p:txBody>
+      </p:sp>
+      <p:sp>
+        <p:nvSpPr>
+          <p:cNvPr id="2091" name="pb91"/>
+          <p:cNvSpPr txBox="1"/>
+          <p:nvPr/>
+        </p:nvSpPr>
+        <p:spPr>
+          <a:xfrm>
+            <a:off x="0" y="6660000"/>
+            <a:ext cx="7837714" cy="198000"/>
           </a:xfrm>
           <a:prstGeom prst="rect">
             <a:avLst/>
           </a:prstGeom>
           <a:solidFill>
-            <a:srgbClr val="FFFFFF"/>
+            <a:srgbClr val="2D5544"/>
           </a:solidFill>
-          <a:ln w="9525">
-            <a:solidFill>
-              <a:srgbClr val="CFE0D6"/>
-            </a:solidFill>
+          <a:ln>
+            <a:noFill/>
           </a:ln>
         </p:spPr>
-        <p:style>
-          <a:lnRef idx="1">
-            <a:schemeClr val="accent1"/>
-          </a:lnRef>
-          <a:fillRef idx="3">
-            <a:schemeClr val="accent1"/>
-          </a:fillRef>
-          <a:effectRef idx="2">
-            <a:schemeClr val="accent1"/>
-          </a:effectRef>
-          <a:fontRef idx="minor">
-            <a:schemeClr val="lt1"/>
-          </a:fontRef>
-        </p:style>
-        <p:txBody>
-          <a:bodyPr rtlCol="0" anchor="ctr"/>
-          <a:lstStyle/>
-          <a:p>
-            <a:pPr algn="ctr"/>
-            <a:endParaRPr/>
-          </a:p>
-        </p:txBody>
-      </p:sp>
-      <p:sp>
-        <p:nvSpPr>
-          <p:cNvPr id="10" name="TextBox 9"/>
-          <p:cNvSpPr txBox="1"/>
-          <p:nvPr/>
-        </p:nvSpPr>
-        <p:spPr>
-          <a:xfrm>
-            <a:off x="6858000" y="1188720"/>
-            <a:ext cx="4846320" cy="457200"/>
-          </a:xfrm>
-          <a:prstGeom prst="rect">
-            <a:avLst/>
-          </a:prstGeom>
-          <a:noFill/>
-        </p:spPr>
-        <p:txBody>
-          <a:bodyPr wrap="square">
-            <a:spAutoFit/>
-          </a:bodyPr>
-          <a:lstStyle/>
-          <a:p>
-            <a:pPr algn="l"/>
-            <a:r>
-              <a:rPr sz="1600" b="1" i="0">
-                <a:solidFill>
-                  <a:srgbClr val="23613F"/>
-                </a:solidFill>
-                <a:latin typeface="Calibri"/>
-              </a:rPr>
-              <a:t>Этап 2 — Photon (OpenStreetMap)</a:t>
-            </a:r>
-          </a:p>
-        </p:txBody>
-      </p:sp>
-      <p:sp>
-        <p:nvSpPr>
-          <p:cNvPr id="11" name="TextBox 10"/>
-          <p:cNvSpPr txBox="1"/>
-          <p:nvPr/>
-        </p:nvSpPr>
-        <p:spPr>
-          <a:xfrm>
-            <a:off x="6858000" y="1691640"/>
-            <a:ext cx="4846320" cy="1783080"/>
-          </a:xfrm>
-          <a:prstGeom prst="rect">
-            <a:avLst/>
-          </a:prstGeom>
-          <a:noFill/>
-        </p:spPr>
-        <p:txBody>
-          <a:bodyPr wrap="square">
-            <a:spAutoFit/>
-          </a:bodyPr>
-          <a:lstStyle/>
-          <a:p>
-            <a:pPr algn="l"/>
-            <a:r>
-              <a:rPr sz="1400" b="0" i="0">
-                <a:solidFill>
-                  <a:srgbClr val="122017"/>
-                </a:solidFill>
-                <a:latin typeface="Calibri"/>
-              </a:rPr>
-              <a:t>Для строк без institution_id:
-GET photon.komoot.io/api/?q=&lt;название&gt;
-Стратегия сокращения строки:
-полная → последние 3 части → 2 части
-Координаты GeoJSON: [lon, lat] → переставить
-Результат: +255 публикаций</a:t>
-            </a:r>
-          </a:p>
-        </p:txBody>
-      </p:sp>
-      <p:sp>
-        <p:nvSpPr>
-          <p:cNvPr id="12" name="Rectangle 11"/>
-          <p:cNvSpPr/>
-          <p:nvPr/>
-        </p:nvSpPr>
-        <p:spPr>
-          <a:xfrm>
-            <a:off x="365760" y="3749039"/>
-            <a:ext cx="11430000" cy="640080"/>
+        <p:txBody>
+          <a:bodyPr wrap="none" anchor="ctr"/>
+          <a:lstStyle/>
+          <a:p/>
+        </p:txBody>
+      </p:sp>
+      <p:sp>
+        <p:nvSpPr>
+          <p:cNvPr id="2092" name="pb92"/>
+          <p:cNvSpPr txBox="1"/>
+          <p:nvPr/>
+        </p:nvSpPr>
+        <p:spPr>
+          <a:xfrm>
+            <a:off x="7297714" y="6660000"/>
+            <a:ext cx="540000" cy="198000"/>
+          </a:xfrm>
+          <a:prstGeom prst="rect">
+            <a:avLst/>
+          </a:prstGeom>
+          <a:solidFill>
+            <a:srgbClr val="3A6B55"/>
+          </a:solidFill>
+          <a:ln>
+            <a:noFill/>
+          </a:ln>
+        </p:spPr>
+        <p:txBody>
+          <a:bodyPr wrap="none" anchor="ctr"/>
+          <a:lstStyle/>
+          <a:p/>
+        </p:txBody>
+      </p:sp>
+      <p:sp>
+        <p:nvSpPr>
+          <p:cNvPr id="2193" name="pbn93"/>
+          <p:cNvSpPr txBox="1"/>
+          <p:nvPr/>
+        </p:nvSpPr>
+        <p:spPr>
+          <a:xfrm>
+            <a:off x="7189714" y="6660000"/>
+            <a:ext cx="648000" cy="198000"/>
           </a:xfrm>
           <a:prstGeom prst="rect">
             <a:avLst/>
@@ -16356,155 +16124,346 @@
             <a:noFill/>
           </a:ln>
         </p:spPr>
-        <p:style>
-          <a:lnRef idx="1">
-            <a:schemeClr val="accent1"/>
-          </a:lnRef>
-          <a:fillRef idx="3">
-            <a:schemeClr val="accent1"/>
-          </a:fillRef>
-          <a:effectRef idx="2">
-            <a:schemeClr val="accent1"/>
-          </a:effectRef>
-          <a:fontRef idx="minor">
-            <a:schemeClr val="lt1"/>
-          </a:fontRef>
-        </p:style>
-        <p:txBody>
-          <a:bodyPr rtlCol="0" anchor="ctr"/>
+        <p:txBody>
+          <a:bodyPr wrap="none" anchor="ctr"/>
           <a:lstStyle/>
           <a:p>
             <a:pPr algn="ctr"/>
-            <a:endParaRPr/>
-          </a:p>
-        </p:txBody>
-      </p:sp>
-      <p:sp>
-        <p:nvSpPr>
-          <p:cNvPr id="13" name="TextBox 12"/>
-          <p:cNvSpPr txBox="1"/>
-          <p:nvPr/>
-        </p:nvSpPr>
-        <p:spPr>
-          <a:xfrm>
-            <a:off x="457200" y="3822191"/>
-            <a:ext cx="11247120" cy="502920"/>
+            <a:r>
+              <a:rPr lang="ru-RU" sz="800" b="1">
+                <a:solidFill>
+                  <a:srgbClr val="FFFFFF"/>
+                </a:solidFill>
+              </a:rPr>
+              <a:t>9</a:t>
+            </a:r>
+          </a:p>
+        </p:txBody>
+      </p:sp>
+      <p:sp>
+        <p:nvSpPr>
+          <p:cNvPr id="200" name="s0"/>
+          <p:cNvSpPr txBox="1"/>
+          <p:nvPr/>
+        </p:nvSpPr>
+        <p:spPr>
+          <a:xfrm>
+            <a:off x="360000" y="180000"/>
+            <a:ext cx="11448000" cy="684000"/>
           </a:xfrm>
           <a:prstGeom prst="rect">
             <a:avLst/>
           </a:prstGeom>
           <a:noFill/>
-        </p:spPr>
-        <p:txBody>
-          <a:bodyPr wrap="square">
-            <a:spAutoFit/>
-          </a:bodyPr>
+          <a:ln>
+            <a:noFill/>
+          </a:ln>
+        </p:spPr>
+        <p:txBody>
+          <a:bodyPr wrap="square" anchor="ctr"/>
+          <a:lstStyle/>
+          <a:p>
+            <a:pPr algn="l"/>
+            <a:r>
+              <a:rPr lang="ru-RU" sz="2200" b="1">
+                <a:solidFill>
+                  <a:srgbClr val="FFFFFF"/>
+                </a:solidFill>
+              </a:rPr>
+              <a:t>Географическая привязка</a:t>
+            </a:r>
+          </a:p>
+        </p:txBody>
+      </p:sp>
+      <p:sp>
+        <p:nvSpPr>
+          <p:cNvPr id="201" name="s1"/>
+          <p:cNvSpPr txBox="1"/>
+          <p:nvPr/>
+        </p:nvSpPr>
+        <p:spPr>
+          <a:xfrm>
+            <a:off x="360000" y="1080000"/>
+            <a:ext cx="3311999" cy="576000"/>
+          </a:xfrm>
+          <a:prstGeom prst="rect">
+            <a:avLst/>
+          </a:prstGeom>
+          <a:solidFill>
+            <a:srgbClr val="1A5276"/>
+          </a:solidFill>
+          <a:ln>
+            <a:noFill/>
+          </a:ln>
+        </p:spPr>
+        <p:txBody>
+          <a:bodyPr wrap="square" anchor="ctr"/>
           <a:lstStyle/>
           <a:p>
             <a:pPr algn="ctr"/>
             <a:r>
-              <a:rPr sz="1700" b="1" i="0">
+              <a:rPr lang="ru-RU" sz="1300" b="1">
                 <a:solidFill>
                   <a:srgbClr val="FFFFFF"/>
                 </a:solidFill>
-                <a:latin typeface="Calibri"/>
-              </a:rPr>
-              <a:t>Итог: 8 077 из 9 994 публикаций с координатами — 80,8% покрытие карты</a:t>
-            </a:r>
-          </a:p>
-        </p:txBody>
-      </p:sp>
-      <p:sp>
-        <p:nvSpPr>
-          <p:cNvPr id="14" name="TextBox 13"/>
-          <p:cNvSpPr txBox="1"/>
-          <p:nvPr/>
-        </p:nvSpPr>
-        <p:spPr>
-          <a:xfrm>
-            <a:off x="365760" y="4526280"/>
-            <a:ext cx="11430000" cy="548640"/>
-          </a:xfrm>
-          <a:prstGeom prst="rect">
-            <a:avLst/>
-          </a:prstGeom>
-          <a:noFill/>
-        </p:spPr>
-        <p:txBody>
-          <a:bodyPr wrap="square">
-            <a:spAutoFit/>
-          </a:bodyPr>
+              </a:rPr>
+              <a:t>Этап 1 — Приоритизация</a:t>
+            </a:r>
+          </a:p>
+        </p:txBody>
+      </p:sp>
+      <p:sp>
+        <p:nvSpPr>
+          <p:cNvPr id="202" name="s2"/>
+          <p:cNvSpPr txBox="1"/>
+          <p:nvPr/>
+        </p:nvSpPr>
+        <p:spPr>
+          <a:xfrm>
+            <a:off x="360000" y="1656000"/>
+            <a:ext cx="3311999" cy="3204000"/>
+          </a:xfrm>
+          <a:prstGeom prst="rect">
+            <a:avLst/>
+          </a:prstGeom>
+          <a:solidFill>
+            <a:srgbClr val="1A3A56"/>
+          </a:solidFill>
+          <a:ln>
+            <a:noFill/>
+          </a:ln>
+        </p:spPr>
+        <p:txBody>
+          <a:bodyPr wrap="square" anchor="t"/>
           <a:lstStyle/>
           <a:p>
             <a:pPr algn="l"/>
             <a:r>
-              <a:rPr sz="1300" b="0" i="1">
-                <a:solidFill>
-                  <a:srgbClr val="577166"/>
-                </a:solidFill>
-                <a:latin typeface="Calibri"/>
-              </a:rPr>
-              <a:t>Примечание: Nominatim заблокировал IP (HTTP 403) после нескольких прогонов — переключились на Photon</a:t>
-            </a:r>
-          </a:p>
-          <a:p>
-            <a:r>
-              <a:rPr sz="1000">
-                <a:solidFill>
-                  <a:srgbClr val="557766"/>
-                </a:solidFill>
-              </a:rPr>
-              <a:t>
-Почему не 100%: часть аффилиаций — строки без топонима (напр. «Department of Physics»). Геокодер не может определить координаты без названия места.</a:t>
-            </a:r>
-          </a:p>
-        </p:txBody>
-      </p:sp>
-      <p:sp>
-        <p:nvSpPr>
-          <p:cNvPr id="15" name="TextBox 14"/>
-          <p:cNvSpPr txBox="1"/>
-          <p:nvPr/>
-        </p:nvSpPr>
-        <p:spPr>
-          <a:xfrm>
-            <a:off x="365760" y="5166360"/>
-            <a:ext cx="11430000" cy="640080"/>
-          </a:xfrm>
-          <a:prstGeom prst="rect">
-            <a:avLst/>
-          </a:prstGeom>
-          <a:noFill/>
-        </p:spPr>
-        <p:txBody>
-          <a:bodyPr wrap="square">
-            <a:spAutoFit/>
-          </a:bodyPr>
-          <a:lstStyle/>
+              <a:rPr lang="ru-RU" sz="1300" b="0">
+                <a:solidFill>
+                  <a:srgbClr val="CFE0D6"/>
+                </a:solidFill>
+              </a:rPr>
+              <a:t>Организации сортируются по числу</a:t>
+            </a:r>
+          </a:p>
           <a:p>
             <a:pPr algn="l"/>
             <a:r>
-              <a:rPr sz="1400" b="0" i="0">
-                <a:solidFill>
-                  <a:srgbClr val="122017"/>
-                </a:solidFill>
-                <a:latin typeface="Calibri"/>
-              </a:rPr>
-              <a:t>Приоритизация: первыми обрабатываются организации, которые «разблокируют» наибольшее число публикаций без координат</a:t>
-            </a:r>
-          </a:p>
-        </p:txBody>
-      </p:sp>
-      <p:sp>
-        <p:nvSpPr>
-          <p:cNvPr id="2090" name="pb90"/>
-          <p:cNvSpPr txBox="1"/>
-          <p:nvPr/>
-        </p:nvSpPr>
-        <p:spPr>
-          <a:xfrm>
-            <a:off x="0" y="6660000"/>
-            <a:ext cx="12192000" cy="198000"/>
+              <a:rPr lang="ru-RU" sz="1300" b="0">
+                <a:solidFill>
+                  <a:srgbClr val="CFE0D6"/>
+                </a:solidFill>
+              </a:rPr>
+              <a:t>зависимых публикаций.</a:t>
+            </a:r>
+          </a:p>
+          <a:p>
+            <a:pPr algn="l"/>
+          </a:p>
+          <a:p>
+            <a:pPr algn="l"/>
+            <a:r>
+              <a:rPr lang="ru-RU" sz="1300" b="0">
+                <a:solidFill>
+                  <a:srgbClr val="CFE0D6"/>
+                </a:solidFill>
+              </a:rPr>
+              <a:t>Первыми обрабатываются те,</a:t>
+            </a:r>
+          </a:p>
+          <a:p>
+            <a:pPr algn="l"/>
+            <a:r>
+              <a:rPr lang="ru-RU" sz="1300" b="0">
+                <a:solidFill>
+                  <a:srgbClr val="CFE0D6"/>
+                </a:solidFill>
+              </a:rPr>
+              <a:t>что «разблокируют» наибольшее</a:t>
+            </a:r>
+          </a:p>
+          <a:p>
+            <a:pPr algn="l"/>
+            <a:r>
+              <a:rPr lang="ru-RU" sz="1300" b="0">
+                <a:solidFill>
+                  <a:srgbClr val="CFE0D6"/>
+                </a:solidFill>
+              </a:rPr>
+              <a:t>количество записей без координат.</a:t>
+            </a:r>
+          </a:p>
+        </p:txBody>
+      </p:sp>
+      <p:sp>
+        <p:nvSpPr>
+          <p:cNvPr id="203" name="s3"/>
+          <p:cNvSpPr txBox="1"/>
+          <p:nvPr/>
+        </p:nvSpPr>
+        <p:spPr>
+          <a:xfrm>
+            <a:off x="4211999" y="1080000"/>
+            <a:ext cx="3311999" cy="576000"/>
+          </a:xfrm>
+          <a:prstGeom prst="rect">
+            <a:avLst/>
+          </a:prstGeom>
+          <a:solidFill>
+            <a:srgbClr val="1A5C3A"/>
+          </a:solidFill>
+          <a:ln>
+            <a:noFill/>
+          </a:ln>
+        </p:spPr>
+        <p:txBody>
+          <a:bodyPr wrap="square" anchor="ctr"/>
+          <a:lstStyle/>
+          <a:p>
+            <a:pPr algn="ctr"/>
+            <a:r>
+              <a:rPr lang="ru-RU" sz="1300" b="1">
+                <a:solidFill>
+                  <a:srgbClr val="FFFFFF"/>
+                </a:solidFill>
+              </a:rPr>
+              <a:t>Этап 2 — OpenAlex API</a:t>
+            </a:r>
+          </a:p>
+        </p:txBody>
+      </p:sp>
+      <p:sp>
+        <p:nvSpPr>
+          <p:cNvPr id="204" name="s4"/>
+          <p:cNvSpPr txBox="1"/>
+          <p:nvPr/>
+        </p:nvSpPr>
+        <p:spPr>
+          <a:xfrm>
+            <a:off x="4211999" y="1656000"/>
+            <a:ext cx="3311999" cy="3204000"/>
+          </a:xfrm>
+          <a:prstGeom prst="rect">
+            <a:avLst/>
+          </a:prstGeom>
+          <a:solidFill>
+            <a:srgbClr val="1A3A2A"/>
+          </a:solidFill>
+          <a:ln>
+            <a:noFill/>
+          </a:ln>
+        </p:spPr>
+        <p:txBody>
+          <a:bodyPr wrap="square" anchor="t"/>
+          <a:lstStyle/>
+          <a:p>
+            <a:pPr algn="l"/>
+            <a:r>
+              <a:rPr lang="ru-RU" sz="1300" b="0">
+                <a:solidFill>
+                  <a:srgbClr val="CFE0D6"/>
+                </a:solidFill>
+              </a:rPr>
+              <a:t>Запрос координат по</a:t>
+            </a:r>
+          </a:p>
+          <a:p>
+            <a:pPr algn="l"/>
+            <a:r>
+              <a:rPr lang="ru-RU" sz="1300" b="0">
+                <a:solidFill>
+                  <a:srgbClr val="CFE0D6"/>
+                </a:solidFill>
+              </a:rPr>
+              <a:t>идентификатору организации</a:t>
+            </a:r>
+          </a:p>
+          <a:p>
+            <a:pPr algn="l"/>
+            <a:r>
+              <a:rPr lang="ru-RU" sz="1300" b="0">
+                <a:solidFill>
+                  <a:srgbClr val="CFE0D6"/>
+                </a:solidFill>
+              </a:rPr>
+              <a:t>через API OpenAlex.</a:t>
+            </a:r>
+          </a:p>
+          <a:p>
+            <a:pPr algn="l"/>
+          </a:p>
+          <a:p>
+            <a:pPr algn="l"/>
+            <a:r>
+              <a:rPr lang="ru-RU" sz="1300" b="0">
+                <a:solidFill>
+                  <a:srgbClr val="CFE0D6"/>
+                </a:solidFill>
+              </a:rPr>
+              <a:t>Результат:</a:t>
+            </a:r>
+          </a:p>
+          <a:p>
+            <a:pPr algn="l"/>
+            <a:r>
+              <a:rPr lang="ru-RU" sz="1300" b="0">
+                <a:solidFill>
+                  <a:srgbClr val="CFE0D6"/>
+                </a:solidFill>
+              </a:rPr>
+              <a:t>78% публикаций с координатами.</a:t>
+            </a:r>
+          </a:p>
+        </p:txBody>
+      </p:sp>
+      <p:sp>
+        <p:nvSpPr>
+          <p:cNvPr id="205" name="s5"/>
+          <p:cNvSpPr txBox="1"/>
+          <p:nvPr/>
+        </p:nvSpPr>
+        <p:spPr>
+          <a:xfrm>
+            <a:off x="8063998" y="1080000"/>
+            <a:ext cx="3311999" cy="576000"/>
+          </a:xfrm>
+          <a:prstGeom prst="rect">
+            <a:avLst/>
+          </a:prstGeom>
+          <a:solidFill>
+            <a:srgbClr val="163126"/>
+          </a:solidFill>
+          <a:ln>
+            <a:noFill/>
+          </a:ln>
+        </p:spPr>
+        <p:txBody>
+          <a:bodyPr wrap="square" anchor="ctr"/>
+          <a:lstStyle/>
+          <a:p>
+            <a:pPr algn="ctr"/>
+            <a:r>
+              <a:rPr lang="ru-RU" sz="1300" b="1">
+                <a:solidFill>
+                  <a:srgbClr val="FFFFFF"/>
+                </a:solidFill>
+              </a:rPr>
+              <a:t>Этап 3 — Photon</a:t>
+            </a:r>
+          </a:p>
+        </p:txBody>
+      </p:sp>
+      <p:sp>
+        <p:nvSpPr>
+          <p:cNvPr id="206" name="s6"/>
+          <p:cNvSpPr txBox="1"/>
+          <p:nvPr/>
+        </p:nvSpPr>
+        <p:spPr>
+          <a:xfrm>
+            <a:off x="8063998" y="1656000"/>
+            <a:ext cx="3311999" cy="3204000"/>
           </a:xfrm>
           <a:prstGeom prst="rect">
             <a:avLst/>
@@ -16517,75 +16476,148 @@
           </a:ln>
         </p:spPr>
         <p:txBody>
-          <a:bodyPr wrap="none" anchor="ctr"/>
-          <a:lstStyle/>
-          <a:p/>
-        </p:txBody>
-      </p:sp>
-      <p:sp>
-        <p:nvSpPr>
-          <p:cNvPr id="2091" name="pb91"/>
-          <p:cNvSpPr txBox="1"/>
-          <p:nvPr/>
-        </p:nvSpPr>
-        <p:spPr>
-          <a:xfrm>
-            <a:off x="0" y="6660000"/>
-            <a:ext cx="7837714" cy="198000"/>
-          </a:xfrm>
-          <a:prstGeom prst="rect">
-            <a:avLst/>
-          </a:prstGeom>
-          <a:solidFill>
-            <a:srgbClr val="2D5544"/>
-          </a:solidFill>
+          <a:bodyPr wrap="square" anchor="t"/>
+          <a:lstStyle/>
+          <a:p>
+            <a:pPr algn="l"/>
+            <a:r>
+              <a:rPr lang="ru-RU" sz="1300" b="0">
+                <a:solidFill>
+                  <a:srgbClr val="CFE0D6"/>
+                </a:solidFill>
+              </a:rPr>
+              <a:t>Для аффилиаций без</a:t>
+            </a:r>
+          </a:p>
+          <a:p>
+            <a:pPr algn="l"/>
+            <a:r>
+              <a:rPr lang="ru-RU" sz="1300" b="0">
+                <a:solidFill>
+                  <a:srgbClr val="CFE0D6"/>
+                </a:solidFill>
+              </a:rPr>
+              <a:t>идентификатора — геокодирование</a:t>
+            </a:r>
+          </a:p>
+          <a:p>
+            <a:pPr algn="l"/>
+            <a:r>
+              <a:rPr lang="ru-RU" sz="1300" b="0">
+                <a:solidFill>
+                  <a:srgbClr val="CFE0D6"/>
+                </a:solidFill>
+              </a:rPr>
+              <a:t>по строке названия через Photon</a:t>
+            </a:r>
+          </a:p>
+          <a:p>
+            <a:pPr algn="l"/>
+            <a:r>
+              <a:rPr lang="ru-RU" sz="1300" b="0">
+                <a:solidFill>
+                  <a:srgbClr val="CFE0D6"/>
+                </a:solidFill>
+              </a:rPr>
+              <a:t>(OpenStreetMap).</a:t>
+            </a:r>
+          </a:p>
+          <a:p>
+            <a:pPr algn="l"/>
+          </a:p>
+          <a:p>
+            <a:pPr algn="l"/>
+            <a:r>
+              <a:rPr lang="ru-RU" sz="1300" b="0">
+                <a:solidFill>
+                  <a:srgbClr val="CFE0D6"/>
+                </a:solidFill>
+              </a:rPr>
+              <a:t>Результат: +2,8% публикаций.</a:t>
+            </a:r>
+          </a:p>
+        </p:txBody>
+      </p:sp>
+      <p:sp>
+        <p:nvSpPr>
+          <p:cNvPr id="207" name="s7"/>
+          <p:cNvSpPr txBox="1"/>
+          <p:nvPr/>
+        </p:nvSpPr>
+        <p:spPr>
+          <a:xfrm>
+            <a:off x="3743999" y="2826000"/>
+            <a:ext cx="396000" cy="288000"/>
+          </a:xfrm>
+          <a:prstGeom prst="rect">
+            <a:avLst/>
+          </a:prstGeom>
+          <a:noFill/>
           <a:ln>
             <a:noFill/>
           </a:ln>
         </p:spPr>
         <p:txBody>
-          <a:bodyPr wrap="none" anchor="ctr"/>
-          <a:lstStyle/>
-          <a:p/>
-        </p:txBody>
-      </p:sp>
-      <p:sp>
-        <p:nvSpPr>
-          <p:cNvPr id="2092" name="pb92"/>
-          <p:cNvSpPr txBox="1"/>
-          <p:nvPr/>
-        </p:nvSpPr>
-        <p:spPr>
-          <a:xfrm>
-            <a:off x="7297714" y="6660000"/>
-            <a:ext cx="540000" cy="198000"/>
-          </a:xfrm>
-          <a:prstGeom prst="rect">
-            <a:avLst/>
-          </a:prstGeom>
-          <a:solidFill>
-            <a:srgbClr val="3A6B55"/>
-          </a:solidFill>
+          <a:bodyPr wrap="square" anchor="ctr"/>
+          <a:lstStyle/>
+          <a:p>
+            <a:pPr algn="ctr"/>
+            <a:r>
+              <a:rPr lang="ru-RU" sz="2200" b="1">
+                <a:solidFill>
+                  <a:srgbClr val="557766"/>
+                </a:solidFill>
+              </a:rPr>
+              <a:t>→</a:t>
+            </a:r>
+          </a:p>
+        </p:txBody>
+      </p:sp>
+      <p:sp>
+        <p:nvSpPr>
+          <p:cNvPr id="208" name="s8"/>
+          <p:cNvSpPr txBox="1"/>
+          <p:nvPr/>
+        </p:nvSpPr>
+        <p:spPr>
+          <a:xfrm>
+            <a:off x="7595998" y="2826000"/>
+            <a:ext cx="396000" cy="288000"/>
+          </a:xfrm>
+          <a:prstGeom prst="rect">
+            <a:avLst/>
+          </a:prstGeom>
+          <a:noFill/>
           <a:ln>
             <a:noFill/>
           </a:ln>
         </p:spPr>
         <p:txBody>
-          <a:bodyPr wrap="none" anchor="ctr"/>
-          <a:lstStyle/>
-          <a:p/>
-        </p:txBody>
-      </p:sp>
-      <p:sp>
-        <p:nvSpPr>
-          <p:cNvPr id="2193" name="pbn93"/>
-          <p:cNvSpPr txBox="1"/>
-          <p:nvPr/>
-        </p:nvSpPr>
-        <p:spPr>
-          <a:xfrm>
-            <a:off x="7189714" y="6660000"/>
-            <a:ext cx="648000" cy="198000"/>
+          <a:bodyPr wrap="square" anchor="ctr"/>
+          <a:lstStyle/>
+          <a:p>
+            <a:pPr algn="ctr"/>
+            <a:r>
+              <a:rPr lang="ru-RU" sz="2200" b="1">
+                <a:solidFill>
+                  <a:srgbClr val="557766"/>
+                </a:solidFill>
+              </a:rPr>
+              <a:t>→</a:t>
+            </a:r>
+          </a:p>
+        </p:txBody>
+      </p:sp>
+      <p:sp>
+        <p:nvSpPr>
+          <p:cNvPr id="209" name="s9"/>
+          <p:cNvSpPr txBox="1"/>
+          <p:nvPr/>
+        </p:nvSpPr>
+        <p:spPr>
+          <a:xfrm>
+            <a:off x="360000" y="5040000"/>
+            <a:ext cx="11520000" cy="540000"/>
           </a:xfrm>
           <a:prstGeom prst="rect">
             <a:avLst/>
@@ -16598,17 +16630,17 @@
           </a:ln>
         </p:spPr>
         <p:txBody>
-          <a:bodyPr wrap="none" anchor="ctr"/>
+          <a:bodyPr wrap="square" anchor="ctr"/>
           <a:lstStyle/>
           <a:p>
             <a:pPr algn="ctr"/>
             <a:r>
-              <a:rPr lang="ru-RU" sz="800" b="1">
+              <a:rPr lang="ru-RU" sz="1400" b="1">
                 <a:solidFill>
                   <a:srgbClr val="FFFFFF"/>
                 </a:solidFill>
               </a:rPr>
-              <a:t>9</a:t>
+              <a:t>Итог: 80,8% публикаций с координатами (порог — 75%)</a:t>
             </a:r>
           </a:p>
         </p:txBody>

</xml_diff>

<commit_message>
fix(presentation): remove geocoding section from Architecture slide
Geocoding is now covered on its own dedicated slide.

https://claude.ai/code/session_01JXZNXE9oVEv7rsUiTvXR5D
</commit_message>
<xml_diff>
--- a/docs/Визуализация науки на основе метаданных публикаций и журналов.pptx
+++ b/docs/Визуализация науки на основе метаданных публикаций и журналов.pptx
@@ -14765,77 +14765,6 @@
       </p:sp>
       <p:sp>
         <p:nvSpPr>
-          <p:cNvPr id="24" name="TextBox 23"/>
-          <p:cNvSpPr txBox="1"/>
-          <p:nvPr/>
-        </p:nvSpPr>
-        <p:spPr>
-          <a:xfrm>
-            <a:off x="274320" y="3703320"/>
-            <a:ext cx="5486400" cy="457200"/>
-          </a:xfrm>
-          <a:prstGeom prst="rect">
-            <a:avLst/>
-          </a:prstGeom>
-          <a:noFill/>
-        </p:spPr>
-        <p:txBody>
-          <a:bodyPr wrap="square">
-            <a:spAutoFit/>
-          </a:bodyPr>
-          <a:lstStyle/>
-          <a:p>
-            <a:pPr algn="l"/>
-            <a:r>
-              <a:rPr sz="1500" b="1" i="0">
-                <a:solidFill>
-                  <a:srgbClr val="23613F"/>
-                </a:solidFill>
-                <a:latin typeface="Calibri"/>
-              </a:rPr>
-              <a:t>Геокодирование аффилиаций</a:t>
-            </a:r>
-          </a:p>
-        </p:txBody>
-      </p:sp>
-      <p:sp>
-        <p:nvSpPr>
-          <p:cNvPr id="25" name="TextBox 24"/>
-          <p:cNvSpPr txBox="1"/>
-          <p:nvPr/>
-        </p:nvSpPr>
-        <p:spPr>
-          <a:xfrm>
-            <a:off x="274320" y="4160520"/>
-            <a:ext cx="5486400" cy="1097280"/>
-          </a:xfrm>
-          <a:prstGeom prst="rect">
-            <a:avLst/>
-          </a:prstGeom>
-          <a:noFill/>
-        </p:spPr>
-        <p:txBody>
-          <a:bodyPr wrap="square">
-            <a:spAutoFit/>
-          </a:bodyPr>
-          <a:lstStyle/>
-          <a:p>
-            <a:pPr algn="l"/>
-            <a:r>
-              <a:rPr sz="1400" b="0" i="0">
-                <a:solidFill>
-                  <a:srgbClr val="122017"/>
-                </a:solidFill>
-                <a:latin typeface="Calibri"/>
-              </a:rPr>
-              <a:t>Этап 1: OpenAlex /institutions API — батчи по 100 ID → 78% покрытие
-Этап 2: Photon (OpenStreetMap) по строке названия → итого 80,8%</a:t>
-            </a:r>
-          </a:p>
-        </p:txBody>
-      </p:sp>
-      <p:sp>
-        <p:nvSpPr>
           <p:cNvPr id="2060" name="pb60"/>
           <p:cNvSpPr txBox="1"/>
           <p:nvPr/>

</xml_diff>

<commit_message>
feat(presentation): add slide 4 — why post-2020 publications are underrepresented
4 cards: 2022 sanctions (Scopus/WoS), OpenAlex indexing lag (6-18 months),
migration to РИНЦ/eLIBRARY, affiliation fragmentation.
Summary bar: decline ≠ fall of science, it's indexing constraints.
Updated progress bars for new total of 15 slides.

https://claude.ai/code/session_01JXZNXE9oVEv7rsUiTvXR5D
</commit_message>
<xml_diff>
--- a/docs/Визуализация науки на основе метаданных публикаций и журналов.pptx
+++ b/docs/Визуализация науки на основе метаданных публикаций и журналов.pptx
@@ -11,6 +11,7 @@
     <p:sldId id="256" r:id="rId2"/>
     <p:sldId id="258" r:id="rId3"/>
     <p:sldId id="270" r:id="rId20"/>
+    <p:sldId id="274" r:id="rId21"/>
     <p:sldId id="257" r:id="rId4"/>
     <p:sldId id="269" r:id="rId5"/>
     <p:sldId id="259" r:id="rId7"/>
@@ -4336,7 +4337,7 @@
       </p:sp>
       <p:sp>
         <p:nvSpPr>
-          <p:cNvPr id="2010" name="pb10"/>
+          <p:cNvPr id="9010" name="pb10"/>
           <p:cNvSpPr txBox="1"/>
           <p:nvPr/>
         </p:nvSpPr>
@@ -4363,14 +4364,14 @@
       </p:sp>
       <p:sp>
         <p:nvSpPr>
-          <p:cNvPr id="2011" name="pb11"/>
+          <p:cNvPr id="9011" name="pb11"/>
           <p:cNvSpPr txBox="1"/>
           <p:nvPr/>
         </p:nvSpPr>
         <p:spPr>
           <a:xfrm>
             <a:off x="0" y="6660000"/>
-            <a:ext cx="870857" cy="198000"/>
+            <a:ext cx="812800" cy="198000"/>
           </a:xfrm>
           <a:prstGeom prst="rect">
             <a:avLst/>
@@ -4390,13 +4391,13 @@
       </p:sp>
       <p:sp>
         <p:nvSpPr>
-          <p:cNvPr id="2012" name="pb12"/>
-          <p:cNvSpPr txBox="1"/>
-          <p:nvPr/>
-        </p:nvSpPr>
-        <p:spPr>
-          <a:xfrm>
-            <a:off x="330857" y="6660000"/>
+          <p:cNvPr id="9012" name="pb12"/>
+          <p:cNvSpPr txBox="1"/>
+          <p:nvPr/>
+        </p:nvSpPr>
+        <p:spPr>
+          <a:xfrm>
+            <a:off x="272800" y="6660000"/>
             <a:ext cx="540000" cy="198000"/>
           </a:xfrm>
           <a:prstGeom prst="rect">
@@ -4417,13 +4418,13 @@
       </p:sp>
       <p:sp>
         <p:nvSpPr>
-          <p:cNvPr id="2113" name="pbn13"/>
-          <p:cNvSpPr txBox="1"/>
-          <p:nvPr/>
-        </p:nvSpPr>
-        <p:spPr>
-          <a:xfrm>
-            <a:off x="222857" y="6660000"/>
+          <p:cNvPr id="9013" name="pb13"/>
+          <p:cNvSpPr txBox="1"/>
+          <p:nvPr/>
+        </p:nvSpPr>
+        <p:spPr>
+          <a:xfrm>
+            <a:off x="164800" y="6660000"/>
             <a:ext cx="648000" cy="198000"/>
           </a:xfrm>
           <a:prstGeom prst="rect">
@@ -5381,7 +5382,7 @@
       </p:sp>
       <p:sp>
         <p:nvSpPr>
-          <p:cNvPr id="2100" name="pb100"/>
+          <p:cNvPr id="9110" name="pb110"/>
           <p:cNvSpPr txBox="1"/>
           <p:nvPr/>
         </p:nvSpPr>
@@ -5408,14 +5409,14 @@
       </p:sp>
       <p:sp>
         <p:nvSpPr>
-          <p:cNvPr id="2101" name="pb101"/>
+          <p:cNvPr id="9111" name="pb111"/>
           <p:cNvSpPr txBox="1"/>
           <p:nvPr/>
         </p:nvSpPr>
         <p:spPr>
           <a:xfrm>
             <a:off x="0" y="6660000"/>
-            <a:ext cx="8708571" cy="198000"/>
+            <a:ext cx="8940800" cy="198000"/>
           </a:xfrm>
           <a:prstGeom prst="rect">
             <a:avLst/>
@@ -5435,13 +5436,13 @@
       </p:sp>
       <p:sp>
         <p:nvSpPr>
-          <p:cNvPr id="2102" name="pb102"/>
-          <p:cNvSpPr txBox="1"/>
-          <p:nvPr/>
-        </p:nvSpPr>
-        <p:spPr>
-          <a:xfrm>
-            <a:off x="8168571" y="6660000"/>
+          <p:cNvPr id="9112" name="pb112"/>
+          <p:cNvSpPr txBox="1"/>
+          <p:nvPr/>
+        </p:nvSpPr>
+        <p:spPr>
+          <a:xfrm>
+            <a:off x="8400800" y="6660000"/>
             <a:ext cx="540000" cy="198000"/>
           </a:xfrm>
           <a:prstGeom prst="rect">
@@ -5462,13 +5463,13 @@
       </p:sp>
       <p:sp>
         <p:nvSpPr>
-          <p:cNvPr id="2203" name="pbn103"/>
-          <p:cNvSpPr txBox="1"/>
-          <p:nvPr/>
-        </p:nvSpPr>
-        <p:spPr>
-          <a:xfrm>
-            <a:off x="8060571" y="6660000"/>
+          <p:cNvPr id="9113" name="pb113"/>
+          <p:cNvSpPr txBox="1"/>
+          <p:nvPr/>
+        </p:nvSpPr>
+        <p:spPr>
+          <a:xfrm>
+            <a:off x="8292800" y="6660000"/>
             <a:ext cx="648000" cy="198000"/>
           </a:xfrm>
           <a:prstGeom prst="rect">
@@ -5492,7 +5493,7 @@
                   <a:srgbClr val="FFFFFF"/>
                 </a:solidFill>
               </a:rPr>
-              <a:t>10</a:t>
+              <a:t>11</a:t>
             </a:r>
           </a:p>
         </p:txBody>
@@ -5943,7 +5944,7 @@
       </p:sp>
       <p:sp>
         <p:nvSpPr>
-          <p:cNvPr id="2110" name="pb110"/>
+          <p:cNvPr id="9120" name="pb120"/>
           <p:cNvSpPr txBox="1"/>
           <p:nvPr/>
         </p:nvSpPr>
@@ -5970,14 +5971,14 @@
       </p:sp>
       <p:sp>
         <p:nvSpPr>
-          <p:cNvPr id="2111" name="pb111"/>
+          <p:cNvPr id="9121" name="pb121"/>
           <p:cNvSpPr txBox="1"/>
           <p:nvPr/>
         </p:nvSpPr>
         <p:spPr>
           <a:xfrm>
             <a:off x="0" y="6660000"/>
-            <a:ext cx="9579428" cy="198000"/>
+            <a:ext cx="9753600" cy="198000"/>
           </a:xfrm>
           <a:prstGeom prst="rect">
             <a:avLst/>
@@ -5997,13 +5998,13 @@
       </p:sp>
       <p:sp>
         <p:nvSpPr>
-          <p:cNvPr id="2112" name="pb112"/>
-          <p:cNvSpPr txBox="1"/>
-          <p:nvPr/>
-        </p:nvSpPr>
-        <p:spPr>
-          <a:xfrm>
-            <a:off x="9039428" y="6660000"/>
+          <p:cNvPr id="9122" name="pb122"/>
+          <p:cNvSpPr txBox="1"/>
+          <p:nvPr/>
+        </p:nvSpPr>
+        <p:spPr>
+          <a:xfrm>
+            <a:off x="9213600" y="6660000"/>
             <a:ext cx="540000" cy="198000"/>
           </a:xfrm>
           <a:prstGeom prst="rect">
@@ -6024,13 +6025,13 @@
       </p:sp>
       <p:sp>
         <p:nvSpPr>
-          <p:cNvPr id="2213" name="pbn113"/>
-          <p:cNvSpPr txBox="1"/>
-          <p:nvPr/>
-        </p:nvSpPr>
-        <p:spPr>
-          <a:xfrm>
-            <a:off x="8931428" y="6660000"/>
+          <p:cNvPr id="9123" name="pb123"/>
+          <p:cNvSpPr txBox="1"/>
+          <p:nvPr/>
+        </p:nvSpPr>
+        <p:spPr>
+          <a:xfrm>
+            <a:off x="9105600" y="6660000"/>
             <a:ext cx="648000" cy="198000"/>
           </a:xfrm>
           <a:prstGeom prst="rect">
@@ -6054,7 +6055,7 @@
                   <a:srgbClr val="FFFFFF"/>
                 </a:solidFill>
               </a:rPr>
-              <a:t>11</a:t>
+              <a:t>12</a:t>
             </a:r>
           </a:p>
         </p:txBody>
@@ -6769,7 +6770,7 @@
       </p:sp>
       <p:sp>
         <p:nvSpPr>
-          <p:cNvPr id="2120" name="pb120"/>
+          <p:cNvPr id="9130" name="pb130"/>
           <p:cNvSpPr txBox="1"/>
           <p:nvPr/>
         </p:nvSpPr>
@@ -6796,14 +6797,14 @@
       </p:sp>
       <p:sp>
         <p:nvSpPr>
-          <p:cNvPr id="2121" name="pb121"/>
+          <p:cNvPr id="9131" name="pb131"/>
           <p:cNvSpPr txBox="1"/>
           <p:nvPr/>
         </p:nvSpPr>
         <p:spPr>
           <a:xfrm>
             <a:off x="0" y="6660000"/>
-            <a:ext cx="10450285" cy="198000"/>
+            <a:ext cx="10566400" cy="198000"/>
           </a:xfrm>
           <a:prstGeom prst="rect">
             <a:avLst/>
@@ -6823,13 +6824,13 @@
       </p:sp>
       <p:sp>
         <p:nvSpPr>
-          <p:cNvPr id="2122" name="pb122"/>
-          <p:cNvSpPr txBox="1"/>
-          <p:nvPr/>
-        </p:nvSpPr>
-        <p:spPr>
-          <a:xfrm>
-            <a:off x="9910285" y="6660000"/>
+          <p:cNvPr id="9132" name="pb132"/>
+          <p:cNvSpPr txBox="1"/>
+          <p:nvPr/>
+        </p:nvSpPr>
+        <p:spPr>
+          <a:xfrm>
+            <a:off x="10026400" y="6660000"/>
             <a:ext cx="540000" cy="198000"/>
           </a:xfrm>
           <a:prstGeom prst="rect">
@@ -6850,13 +6851,13 @@
       </p:sp>
       <p:sp>
         <p:nvSpPr>
-          <p:cNvPr id="2223" name="pbn123"/>
-          <p:cNvSpPr txBox="1"/>
-          <p:nvPr/>
-        </p:nvSpPr>
-        <p:spPr>
-          <a:xfrm>
-            <a:off x="9802285" y="6660000"/>
+          <p:cNvPr id="9133" name="pb133"/>
+          <p:cNvSpPr txBox="1"/>
+          <p:nvPr/>
+        </p:nvSpPr>
+        <p:spPr>
+          <a:xfrm>
+            <a:off x="9918400" y="6660000"/>
             <a:ext cx="648000" cy="198000"/>
           </a:xfrm>
           <a:prstGeom prst="rect">
@@ -6880,7 +6881,7 @@
                   <a:srgbClr val="FFFFFF"/>
                 </a:solidFill>
               </a:rPr>
-              <a:t>12</a:t>
+              <a:t>13</a:t>
             </a:r>
           </a:p>
         </p:txBody>
@@ -7244,7 +7245,7 @@
       </p:sp>
       <p:sp>
         <p:nvSpPr>
-          <p:cNvPr id="2130" name="pb130"/>
+          <p:cNvPr id="9140" name="pb140"/>
           <p:cNvSpPr txBox="1"/>
           <p:nvPr/>
         </p:nvSpPr>
@@ -7271,14 +7272,14 @@
       </p:sp>
       <p:sp>
         <p:nvSpPr>
-          <p:cNvPr id="2131" name="pb131"/>
+          <p:cNvPr id="9141" name="pb141"/>
           <p:cNvSpPr txBox="1"/>
           <p:nvPr/>
         </p:nvSpPr>
         <p:spPr>
           <a:xfrm>
             <a:off x="0" y="6660000"/>
-            <a:ext cx="11321142" cy="198000"/>
+            <a:ext cx="11379200" cy="198000"/>
           </a:xfrm>
           <a:prstGeom prst="rect">
             <a:avLst/>
@@ -7298,13 +7299,13 @@
       </p:sp>
       <p:sp>
         <p:nvSpPr>
-          <p:cNvPr id="2132" name="pb132"/>
-          <p:cNvSpPr txBox="1"/>
-          <p:nvPr/>
-        </p:nvSpPr>
-        <p:spPr>
-          <a:xfrm>
-            <a:off x="10781142" y="6660000"/>
+          <p:cNvPr id="9142" name="pb142"/>
+          <p:cNvSpPr txBox="1"/>
+          <p:nvPr/>
+        </p:nvSpPr>
+        <p:spPr>
+          <a:xfrm>
+            <a:off x="10839200" y="6660000"/>
             <a:ext cx="540000" cy="198000"/>
           </a:xfrm>
           <a:prstGeom prst="rect">
@@ -7325,13 +7326,13 @@
       </p:sp>
       <p:sp>
         <p:nvSpPr>
-          <p:cNvPr id="2233" name="pbn133"/>
-          <p:cNvSpPr txBox="1"/>
-          <p:nvPr/>
-        </p:nvSpPr>
-        <p:spPr>
-          <a:xfrm>
-            <a:off x="10673142" y="6660000"/>
+          <p:cNvPr id="9143" name="pb143"/>
+          <p:cNvSpPr txBox="1"/>
+          <p:nvPr/>
+        </p:nvSpPr>
+        <p:spPr>
+          <a:xfrm>
+            <a:off x="10731200" y="6660000"/>
             <a:ext cx="648000" cy="198000"/>
           </a:xfrm>
           <a:prstGeom prst="rect">
@@ -7355,7 +7356,7 @@
                   <a:srgbClr val="FFFFFF"/>
                 </a:solidFill>
               </a:rPr>
-              <a:t>13</a:t>
+              <a:t>14</a:t>
             </a:r>
           </a:p>
         </p:txBody>
@@ -8234,7 +8235,7 @@
       </p:sp>
       <p:sp>
         <p:nvSpPr>
-          <p:cNvPr id="3000" name="pb0"/>
+          <p:cNvPr id="9150" name="pb150"/>
           <p:cNvSpPr txBox="1"/>
           <p:nvPr/>
         </p:nvSpPr>
@@ -8261,7 +8262,7 @@
       </p:sp>
       <p:sp>
         <p:nvSpPr>
-          <p:cNvPr id="3001" name="pb1"/>
+          <p:cNvPr id="9151" name="pb151"/>
           <p:cNvSpPr txBox="1"/>
           <p:nvPr/>
         </p:nvSpPr>
@@ -8288,7 +8289,7 @@
       </p:sp>
       <p:sp>
         <p:nvSpPr>
-          <p:cNvPr id="3002" name="pb2"/>
+          <p:cNvPr id="9152" name="pb152"/>
           <p:cNvSpPr txBox="1"/>
           <p:nvPr/>
         </p:nvSpPr>
@@ -8315,7 +8316,7 @@
       </p:sp>
       <p:sp>
         <p:nvSpPr>
-          <p:cNvPr id="3103" name="pbn3"/>
+          <p:cNvPr id="9153" name="pb153"/>
           <p:cNvSpPr txBox="1"/>
           <p:nvPr/>
         </p:nvSpPr>
@@ -8345,7 +8346,922 @@
                   <a:srgbClr val="FFFFFF"/>
                 </a:solidFill>
               </a:rPr>
-              <a:t>14</a:t>
+              <a:t>15</a:t>
+            </a:r>
+          </a:p>
+        </p:txBody>
+      </p:sp>
+    </p:spTree>
+  </p:cSld>
+  <p:clrMapOvr>
+    <a:masterClrMapping/>
+  </p:clrMapOvr>
+</p:sld>
+</file>
+
+<file path=ppt/slides/slide16.xml><?xml version="1.0" encoding="utf-8"?>
+<p:sld xmlns:a="http://schemas.openxmlformats.org/drawingml/2006/main" xmlns:r="http://schemas.openxmlformats.org/officeDocument/2006/relationships" xmlns:p="http://schemas.openxmlformats.org/presentationml/2006/main">
+  <p:cSld>
+    <p:spTree>
+      <p:nvGrpSpPr>
+        <p:cNvPr id="1" name=""/>
+        <p:cNvGrpSpPr/>
+        <p:nvPr/>
+      </p:nvGrpSpPr>
+      <p:grpSpPr>
+        <a:xfrm>
+          <a:off x="0" y="0"/>
+          <a:ext cx="0" cy="0"/>
+          <a:chOff x="0" y="0"/>
+          <a:chExt cx="0" cy="0"/>
+        </a:xfrm>
+      </p:grpSpPr>
+      <p:sp>
+        <p:nvSpPr>
+          <p:cNvPr id="2" name="Rectangle 1"/>
+          <p:cNvSpPr/>
+          <p:nvPr/>
+        </p:nvSpPr>
+        <p:spPr>
+          <a:xfrm>
+            <a:off x="0" y="0"/>
+            <a:ext cx="12188952" cy="6858000"/>
+          </a:xfrm>
+          <a:prstGeom prst="rect">
+            <a:avLst/>
+          </a:prstGeom>
+          <a:solidFill>
+            <a:srgbClr val="F7FBF8"/>
+          </a:solidFill>
+          <a:ln>
+            <a:noFill/>
+          </a:ln>
+        </p:spPr>
+        <p:style>
+          <a:lnRef idx="1">
+            <a:schemeClr val="accent1"/>
+          </a:lnRef>
+          <a:fillRef idx="3">
+            <a:schemeClr val="accent1"/>
+          </a:fillRef>
+          <a:effectRef idx="2">
+            <a:schemeClr val="accent1"/>
+          </a:effectRef>
+          <a:fontRef idx="minor">
+            <a:schemeClr val="lt1"/>
+          </a:fontRef>
+        </p:style>
+        <p:txBody>
+          <a:bodyPr rtlCol="0" anchor="ctr"/>
+          <a:lstStyle/>
+          <a:p>
+            <a:pPr algn="ctr"/>
+            <a:endParaRPr/>
+          </a:p>
+        </p:txBody>
+      </p:sp>
+      <p:sp>
+        <p:nvSpPr>
+          <p:cNvPr id="3" name="Rectangle 2"/>
+          <p:cNvSpPr/>
+          <p:nvPr/>
+        </p:nvSpPr>
+        <p:spPr>
+          <a:xfrm>
+            <a:off x="0" y="0"/>
+            <a:ext cx="12188952" cy="1005840"/>
+          </a:xfrm>
+          <a:prstGeom prst="rect">
+            <a:avLst/>
+          </a:prstGeom>
+          <a:solidFill>
+            <a:srgbClr val="163126"/>
+          </a:solidFill>
+          <a:ln>
+            <a:noFill/>
+          </a:ln>
+        </p:spPr>
+        <p:style>
+          <a:lnRef idx="1">
+            <a:schemeClr val="accent1"/>
+          </a:lnRef>
+          <a:fillRef idx="3">
+            <a:schemeClr val="accent1"/>
+          </a:fillRef>
+          <a:effectRef idx="2">
+            <a:schemeClr val="accent1"/>
+          </a:effectRef>
+          <a:fontRef idx="minor">
+            <a:schemeClr val="lt1"/>
+          </a:fontRef>
+        </p:style>
+        <p:txBody>
+          <a:bodyPr rtlCol="0" anchor="ctr"/>
+          <a:lstStyle/>
+          <a:p>
+            <a:pPr algn="ctr"/>
+            <a:endParaRPr/>
+          </a:p>
+        </p:txBody>
+      </p:sp>
+      <p:sp>
+        <p:nvSpPr>
+          <p:cNvPr id="120" name="s20"/>
+          <p:cNvSpPr txBox="1"/>
+          <p:nvPr/>
+        </p:nvSpPr>
+        <p:spPr>
+          <a:xfrm>
+            <a:off x="360000" y="180000"/>
+            <a:ext cx="11448000" cy="684000"/>
+          </a:xfrm>
+          <a:prstGeom prst="rect">
+            <a:avLst/>
+          </a:prstGeom>
+          <a:noFill/>
+          <a:ln>
+            <a:noFill/>
+          </a:ln>
+        </p:spPr>
+        <p:txBody>
+          <a:bodyPr wrap="square" anchor="ctr"/>
+          <a:lstStyle/>
+          <a:p>
+            <a:pPr algn="l"/>
+            <a:r>
+              <a:rPr lang="ru-RU" sz="2000" b="1">
+                <a:solidFill>
+                  <a:srgbClr val="FFFFFF"/>
+                </a:solidFill>
+              </a:rPr>
+              <a:t>Почему публикации после 2020 хуже представлены в базах?</a:t>
+            </a:r>
+          </a:p>
+        </p:txBody>
+      </p:sp>
+      <p:sp>
+        <p:nvSpPr>
+          <p:cNvPr id="121" name="s21"/>
+          <p:cNvSpPr txBox="1"/>
+          <p:nvPr/>
+        </p:nvSpPr>
+        <p:spPr>
+          <a:xfrm>
+            <a:off x="360000" y="1080000"/>
+            <a:ext cx="2808000" cy="648000"/>
+          </a:xfrm>
+          <a:prstGeom prst="rect">
+            <a:avLst/>
+          </a:prstGeom>
+          <a:noFill/>
+          <a:ln>
+            <a:noFill/>
+          </a:ln>
+        </p:spPr>
+        <p:txBody>
+          <a:bodyPr wrap="square" anchor="ctr"/>
+          <a:lstStyle/>
+          <a:p>
+            <a:pPr algn="ctr"/>
+            <a:r>
+              <a:rPr lang="ru-RU" sz="2600" b="1">
+                <a:solidFill>
+                  <a:srgbClr val="1A3A2A"/>
+                </a:solidFill>
+              </a:rPr>
+              <a:t>2022</a:t>
+            </a:r>
+          </a:p>
+        </p:txBody>
+      </p:sp>
+      <p:sp>
+        <p:nvSpPr>
+          <p:cNvPr id="122" name="s22"/>
+          <p:cNvSpPr txBox="1"/>
+          <p:nvPr/>
+        </p:nvSpPr>
+        <p:spPr>
+          <a:xfrm>
+            <a:off x="360000" y="1692000"/>
+            <a:ext cx="2808000" cy="792000"/>
+          </a:xfrm>
+          <a:prstGeom prst="rect">
+            <a:avLst/>
+          </a:prstGeom>
+          <a:solidFill>
+            <a:srgbClr val="1A3A2A"/>
+          </a:solidFill>
+          <a:ln>
+            <a:noFill/>
+          </a:ln>
+        </p:spPr>
+        <p:txBody>
+          <a:bodyPr wrap="square" anchor="ctr"/>
+          <a:lstStyle/>
+          <a:p>
+            <a:pPr algn="ctr"/>
+            <a:r>
+              <a:rPr lang="ru-RU" sz="1200" b="1">
+                <a:solidFill>
+                  <a:srgbClr val="FFFFFF"/>
+                </a:solidFill>
+              </a:rPr>
+              <a:t>Санкции</a:t>
+            </a:r>
+          </a:p>
+          <a:p>
+            <a:pPr algn="ctr"/>
+            <a:r>
+              <a:rPr lang="ru-RU" sz="1200" b="1">
+                <a:solidFill>
+                  <a:srgbClr val="FFFFFF"/>
+                </a:solidFill>
+              </a:rPr>
+              <a:t>международных баз</a:t>
+            </a:r>
+          </a:p>
+        </p:txBody>
+      </p:sp>
+      <p:sp>
+        <p:nvSpPr>
+          <p:cNvPr id="123" name="s23"/>
+          <p:cNvSpPr txBox="1"/>
+          <p:nvPr/>
+        </p:nvSpPr>
+        <p:spPr>
+          <a:xfrm>
+            <a:off x="360000" y="2484000"/>
+            <a:ext cx="2808000" cy="2448000"/>
+          </a:xfrm>
+          <a:prstGeom prst="rect">
+            <a:avLst/>
+          </a:prstGeom>
+          <a:solidFill>
+            <a:srgbClr val="0D1F14"/>
+          </a:solidFill>
+          <a:ln>
+            <a:noFill/>
+          </a:ln>
+        </p:spPr>
+        <p:txBody>
+          <a:bodyPr wrap="square" anchor="t"/>
+          <a:lstStyle/>
+          <a:p>
+            <a:pPr algn="l"/>
+            <a:r>
+              <a:rPr lang="ru-RU" sz="1200" b="0">
+                <a:solidFill>
+                  <a:srgbClr val="CFE0D6"/>
+                </a:solidFill>
+              </a:rPr>
+              <a:t>Scopus и Web of Science</a:t>
+            </a:r>
+          </a:p>
+          <a:p>
+            <a:pPr algn="l"/>
+            <a:r>
+              <a:rPr lang="ru-RU" sz="1200" b="0">
+                <a:solidFill>
+                  <a:srgbClr val="CFE0D6"/>
+                </a:solidFill>
+              </a:rPr>
+              <a:t>приостановили индексацию</a:t>
+            </a:r>
+          </a:p>
+          <a:p>
+            <a:pPr algn="l"/>
+            <a:r>
+              <a:rPr lang="ru-RU" sz="1200" b="0">
+                <a:solidFill>
+                  <a:srgbClr val="CFE0D6"/>
+                </a:solidFill>
+              </a:rPr>
+              <a:t>российских журналов.</a:t>
+            </a:r>
+          </a:p>
+          <a:p>
+            <a:pPr algn="l"/>
+            <a:r>
+              <a:rPr lang="ru-RU" sz="1200" b="0">
+                <a:solidFill>
+                  <a:srgbClr val="CFE0D6"/>
+                </a:solidFill>
+              </a:rPr>
+              <a:t>~500 изданий удалено из Scopus.</a:t>
+            </a:r>
+          </a:p>
+        </p:txBody>
+      </p:sp>
+      <p:sp>
+        <p:nvSpPr>
+          <p:cNvPr id="124" name="s24"/>
+          <p:cNvSpPr txBox="1"/>
+          <p:nvPr/>
+        </p:nvSpPr>
+        <p:spPr>
+          <a:xfrm>
+            <a:off x="3311999" y="1080000"/>
+            <a:ext cx="2808000" cy="648000"/>
+          </a:xfrm>
+          <a:prstGeom prst="rect">
+            <a:avLst/>
+          </a:prstGeom>
+          <a:noFill/>
+          <a:ln>
+            <a:noFill/>
+          </a:ln>
+        </p:spPr>
+        <p:txBody>
+          <a:bodyPr wrap="square" anchor="ctr"/>
+          <a:lstStyle/>
+          <a:p>
+            <a:pPr algn="ctr"/>
+            <a:r>
+              <a:rPr lang="ru-RU" sz="2600" b="1">
+                <a:solidFill>
+                  <a:srgbClr val="1A5C3A"/>
+                </a:solidFill>
+              </a:rPr>
+              <a:t>6–18 мес</a:t>
+            </a:r>
+          </a:p>
+        </p:txBody>
+      </p:sp>
+      <p:sp>
+        <p:nvSpPr>
+          <p:cNvPr id="125" name="s25"/>
+          <p:cNvSpPr txBox="1"/>
+          <p:nvPr/>
+        </p:nvSpPr>
+        <p:spPr>
+          <a:xfrm>
+            <a:off x="3311999" y="1692000"/>
+            <a:ext cx="2808000" cy="792000"/>
+          </a:xfrm>
+          <a:prstGeom prst="rect">
+            <a:avLst/>
+          </a:prstGeom>
+          <a:solidFill>
+            <a:srgbClr val="1A5C3A"/>
+          </a:solidFill>
+          <a:ln>
+            <a:noFill/>
+          </a:ln>
+        </p:spPr>
+        <p:txBody>
+          <a:bodyPr wrap="square" anchor="ctr"/>
+          <a:lstStyle/>
+          <a:p>
+            <a:pPr algn="ctr"/>
+            <a:r>
+              <a:rPr lang="ru-RU" sz="1200" b="1">
+                <a:solidFill>
+                  <a:srgbClr val="FFFFFF"/>
+                </a:solidFill>
+              </a:rPr>
+              <a:t>Задержка</a:t>
+            </a:r>
+          </a:p>
+          <a:p>
+            <a:pPr algn="ctr"/>
+            <a:r>
+              <a:rPr lang="ru-RU" sz="1200" b="1">
+                <a:solidFill>
+                  <a:srgbClr val="FFFFFF"/>
+                </a:solidFill>
+              </a:rPr>
+              <a:t>индексации OpenAlex</a:t>
+            </a:r>
+          </a:p>
+        </p:txBody>
+      </p:sp>
+      <p:sp>
+        <p:nvSpPr>
+          <p:cNvPr id="126" name="s26"/>
+          <p:cNvSpPr txBox="1"/>
+          <p:nvPr/>
+        </p:nvSpPr>
+        <p:spPr>
+          <a:xfrm>
+            <a:off x="3311999" y="2484000"/>
+            <a:ext cx="2808000" cy="2448000"/>
+          </a:xfrm>
+          <a:prstGeom prst="rect">
+            <a:avLst/>
+          </a:prstGeom>
+          <a:solidFill>
+            <a:srgbClr val="1A3A2A"/>
+          </a:solidFill>
+          <a:ln>
+            <a:noFill/>
+          </a:ln>
+        </p:spPr>
+        <p:txBody>
+          <a:bodyPr wrap="square" anchor="t"/>
+          <a:lstStyle/>
+          <a:p>
+            <a:pPr algn="l"/>
+            <a:r>
+              <a:rPr lang="ru-RU" sz="1200" b="0">
+                <a:solidFill>
+                  <a:srgbClr val="CFE0D6"/>
+                </a:solidFill>
+              </a:rPr>
+              <a:t>Новые статьи появляются</a:t>
+            </a:r>
+          </a:p>
+          <a:p>
+            <a:pPr algn="l"/>
+            <a:r>
+              <a:rPr lang="ru-RU" sz="1200" b="0">
+                <a:solidFill>
+                  <a:srgbClr val="CFE0D6"/>
+                </a:solidFill>
+              </a:rPr>
+              <a:t>в OpenAlex через 6–18 месяцев.</a:t>
+            </a:r>
+          </a:p>
+          <a:p>
+            <a:pPr algn="l"/>
+            <a:r>
+              <a:rPr lang="ru-RU" sz="1200" b="0">
+                <a:solidFill>
+                  <a:srgbClr val="CFE0D6"/>
+                </a:solidFill>
+              </a:rPr>
+              <a:t>Данные за 2023–2024</a:t>
+            </a:r>
+          </a:p>
+          <a:p>
+            <a:pPr algn="l"/>
+            <a:r>
+              <a:rPr lang="ru-RU" sz="1200" b="0">
+                <a:solidFill>
+                  <a:srgbClr val="CFE0D6"/>
+                </a:solidFill>
+              </a:rPr>
+              <a:t>заведомо неполные.</a:t>
+            </a:r>
+          </a:p>
+        </p:txBody>
+      </p:sp>
+      <p:sp>
+        <p:nvSpPr>
+          <p:cNvPr id="127" name="s27"/>
+          <p:cNvSpPr txBox="1"/>
+          <p:nvPr/>
+        </p:nvSpPr>
+        <p:spPr>
+          <a:xfrm>
+            <a:off x="6263999" y="1080000"/>
+            <a:ext cx="2808000" cy="648000"/>
+          </a:xfrm>
+          <a:prstGeom prst="rect">
+            <a:avLst/>
+          </a:prstGeom>
+          <a:noFill/>
+          <a:ln>
+            <a:noFill/>
+          </a:ln>
+        </p:spPr>
+        <p:txBody>
+          <a:bodyPr wrap="square" anchor="ctr"/>
+          <a:lstStyle/>
+          <a:p>
+            <a:pPr algn="ctr"/>
+            <a:r>
+              <a:rPr lang="ru-RU" sz="2600" b="1">
+                <a:solidFill>
+                  <a:srgbClr val="2D5544"/>
+                </a:solidFill>
+              </a:rPr>
+              <a:t>РИНЦ</a:t>
+            </a:r>
+          </a:p>
+        </p:txBody>
+      </p:sp>
+      <p:sp>
+        <p:nvSpPr>
+          <p:cNvPr id="128" name="s28"/>
+          <p:cNvSpPr txBox="1"/>
+          <p:nvPr/>
+        </p:nvSpPr>
+        <p:spPr>
+          <a:xfrm>
+            <a:off x="6263999" y="1692000"/>
+            <a:ext cx="2808000" cy="792000"/>
+          </a:xfrm>
+          <a:prstGeom prst="rect">
+            <a:avLst/>
+          </a:prstGeom>
+          <a:solidFill>
+            <a:srgbClr val="2D5544"/>
+          </a:solidFill>
+          <a:ln>
+            <a:noFill/>
+          </a:ln>
+        </p:spPr>
+        <p:txBody>
+          <a:bodyPr wrap="square" anchor="ctr"/>
+          <a:lstStyle/>
+          <a:p>
+            <a:pPr algn="ctr"/>
+            <a:r>
+              <a:rPr lang="ru-RU" sz="1200" b="1">
+                <a:solidFill>
+                  <a:srgbClr val="FFFFFF"/>
+                </a:solidFill>
+              </a:rPr>
+              <a:t>Уход</a:t>
+            </a:r>
+          </a:p>
+          <a:p>
+            <a:pPr algn="ctr"/>
+            <a:r>
+              <a:rPr lang="ru-RU" sz="1200" b="1">
+                <a:solidFill>
+                  <a:srgbClr val="FFFFFF"/>
+                </a:solidFill>
+              </a:rPr>
+              <a:t>в отечественные базы</a:t>
+            </a:r>
+          </a:p>
+        </p:txBody>
+      </p:sp>
+      <p:sp>
+        <p:nvSpPr>
+          <p:cNvPr id="129" name="s29"/>
+          <p:cNvSpPr txBox="1"/>
+          <p:nvPr/>
+        </p:nvSpPr>
+        <p:spPr>
+          <a:xfrm>
+            <a:off x="6263999" y="2484000"/>
+            <a:ext cx="2808000" cy="2448000"/>
+          </a:xfrm>
+          <a:prstGeom prst="rect">
+            <a:avLst/>
+          </a:prstGeom>
+          <a:solidFill>
+            <a:srgbClr val="1A3A2A"/>
+          </a:solidFill>
+          <a:ln>
+            <a:noFill/>
+          </a:ln>
+        </p:spPr>
+        <p:txBody>
+          <a:bodyPr wrap="square" anchor="t"/>
+          <a:lstStyle/>
+          <a:p>
+            <a:pPr algn="l"/>
+            <a:r>
+              <a:rPr lang="ru-RU" sz="1200" b="0">
+                <a:solidFill>
+                  <a:srgbClr val="CFE0D6"/>
+                </a:solidFill>
+              </a:rPr>
+              <a:t>Часть российских журналов</a:t>
+            </a:r>
+          </a:p>
+          <a:p>
+            <a:pPr algn="l"/>
+            <a:r>
+              <a:rPr lang="ru-RU" sz="1200" b="0">
+                <a:solidFill>
+                  <a:srgbClr val="CFE0D6"/>
+                </a:solidFill>
+              </a:rPr>
+              <a:t>переориентировалась</a:t>
+            </a:r>
+          </a:p>
+          <a:p>
+            <a:pPr algn="l"/>
+            <a:r>
+              <a:rPr lang="ru-RU" sz="1200" b="0">
+                <a:solidFill>
+                  <a:srgbClr val="CFE0D6"/>
+                </a:solidFill>
+              </a:rPr>
+              <a:t>на eLIBRARY/РИНЦ,</a:t>
+            </a:r>
+          </a:p>
+          <a:p>
+            <a:pPr algn="l"/>
+            <a:r>
+              <a:rPr lang="ru-RU" sz="1200" b="0">
+                <a:solidFill>
+                  <a:srgbClr val="CFE0D6"/>
+                </a:solidFill>
+              </a:rPr>
+              <a:t>который не связан с OpenAlex.</a:t>
+            </a:r>
+          </a:p>
+        </p:txBody>
+      </p:sp>
+      <p:sp>
+        <p:nvSpPr>
+          <p:cNvPr id="130" name="s30"/>
+          <p:cNvSpPr txBox="1"/>
+          <p:nvPr/>
+        </p:nvSpPr>
+        <p:spPr>
+          <a:xfrm>
+            <a:off x="9216000" y="1080000"/>
+            <a:ext cx="2808000" cy="648000"/>
+          </a:xfrm>
+          <a:prstGeom prst="rect">
+            <a:avLst/>
+          </a:prstGeom>
+          <a:noFill/>
+          <a:ln>
+            <a:noFill/>
+          </a:ln>
+        </p:spPr>
+        <p:txBody>
+          <a:bodyPr wrap="square" anchor="ctr"/>
+          <a:lstStyle/>
+          <a:p>
+            <a:pPr algn="ctr"/>
+            <a:r>
+              <a:rPr lang="ru-RU" sz="2600" b="1">
+                <a:solidFill>
+                  <a:srgbClr val="3A6B55"/>
+                </a:solidFill>
+              </a:rPr>
+              <a:t>↓ ID</a:t>
+            </a:r>
+          </a:p>
+        </p:txBody>
+      </p:sp>
+      <p:sp>
+        <p:nvSpPr>
+          <p:cNvPr id="131" name="s31"/>
+          <p:cNvSpPr txBox="1"/>
+          <p:nvPr/>
+        </p:nvSpPr>
+        <p:spPr>
+          <a:xfrm>
+            <a:off x="9216000" y="1692000"/>
+            <a:ext cx="2808000" cy="792000"/>
+          </a:xfrm>
+          <a:prstGeom prst="rect">
+            <a:avLst/>
+          </a:prstGeom>
+          <a:solidFill>
+            <a:srgbClr val="3A6B55"/>
+          </a:solidFill>
+          <a:ln>
+            <a:noFill/>
+          </a:ln>
+        </p:spPr>
+        <p:txBody>
+          <a:bodyPr wrap="square" anchor="ctr"/>
+          <a:lstStyle/>
+          <a:p>
+            <a:pPr algn="ctr"/>
+            <a:r>
+              <a:rPr lang="ru-RU" sz="1200" b="1">
+                <a:solidFill>
+                  <a:srgbClr val="FFFFFF"/>
+                </a:solidFill>
+              </a:rPr>
+              <a:t>Фрагментация</a:t>
+            </a:r>
+          </a:p>
+          <a:p>
+            <a:pPr algn="ctr"/>
+            <a:r>
+              <a:rPr lang="ru-RU" sz="1200" b="1">
+                <a:solidFill>
+                  <a:srgbClr val="FFFFFF"/>
+                </a:solidFill>
+              </a:rPr>
+              <a:t>аффилиаций</a:t>
+            </a:r>
+          </a:p>
+        </p:txBody>
+      </p:sp>
+      <p:sp>
+        <p:nvSpPr>
+          <p:cNvPr id="132" name="s32"/>
+          <p:cNvSpPr txBox="1"/>
+          <p:nvPr/>
+        </p:nvSpPr>
+        <p:spPr>
+          <a:xfrm>
+            <a:off x="9216000" y="2484000"/>
+            <a:ext cx="2808000" cy="2448000"/>
+          </a:xfrm>
+          <a:prstGeom prst="rect">
+            <a:avLst/>
+          </a:prstGeom>
+          <a:solidFill>
+            <a:srgbClr val="1F493D"/>
+          </a:solidFill>
+          <a:ln>
+            <a:noFill/>
+          </a:ln>
+        </p:spPr>
+        <p:txBody>
+          <a:bodyPr wrap="square" anchor="t"/>
+          <a:lstStyle/>
+          <a:p>
+            <a:pPr algn="l"/>
+            <a:r>
+              <a:rPr lang="ru-RU" sz="1200" b="0">
+                <a:solidFill>
+                  <a:srgbClr val="CFE0D6"/>
+                </a:solidFill>
+              </a:rPr>
+              <a:t>Авторы меняют или не указывают</a:t>
+            </a:r>
+          </a:p>
+          <a:p>
+            <a:pPr algn="l"/>
+            <a:r>
+              <a:rPr lang="ru-RU" sz="1200" b="0">
+                <a:solidFill>
+                  <a:srgbClr val="CFE0D6"/>
+                </a:solidFill>
+              </a:rPr>
+              <a:t>российскую принадлежность.</a:t>
+            </a:r>
+          </a:p>
+          <a:p>
+            <a:pPr algn="l"/>
+            <a:r>
+              <a:rPr lang="ru-RU" sz="1200" b="0">
+                <a:solidFill>
+                  <a:srgbClr val="CFE0D6"/>
+                </a:solidFill>
+              </a:rPr>
+              <a:t>Идентификаторы организаций</a:t>
+            </a:r>
+          </a:p>
+          <a:p>
+            <a:pPr algn="l"/>
+            <a:r>
+              <a:rPr lang="ru-RU" sz="1200" b="0">
+                <a:solidFill>
+                  <a:srgbClr val="CFE0D6"/>
+                </a:solidFill>
+              </a:rPr>
+              <a:t>пропадают из метаданных.</a:t>
+            </a:r>
+          </a:p>
+        </p:txBody>
+      </p:sp>
+      <p:sp>
+        <p:nvSpPr>
+          <p:cNvPr id="133" name="s33"/>
+          <p:cNvSpPr txBox="1"/>
+          <p:nvPr/>
+        </p:nvSpPr>
+        <p:spPr>
+          <a:xfrm>
+            <a:off x="360000" y="4824000"/>
+            <a:ext cx="11520000" cy="540000"/>
+          </a:xfrm>
+          <a:prstGeom prst="rect">
+            <a:avLst/>
+          </a:prstGeom>
+          <a:solidFill>
+            <a:srgbClr val="23613F"/>
+          </a:solidFill>
+          <a:ln>
+            <a:noFill/>
+          </a:ln>
+        </p:spPr>
+        <p:txBody>
+          <a:bodyPr wrap="square" anchor="ctr"/>
+          <a:lstStyle/>
+          <a:p>
+            <a:pPr algn="ctr"/>
+            <a:r>
+              <a:rPr lang="ru-RU" sz="1300" b="0">
+                <a:solidFill>
+                  <a:srgbClr val="E8F5ED"/>
+                </a:solidFill>
+              </a:rPr>
+              <a:t>Спад после 2020 на графике — не падение науки, а ограничения индексации и санкционное давление.</a:t>
+            </a:r>
+          </a:p>
+        </p:txBody>
+      </p:sp>
+      <p:sp>
+        <p:nvSpPr>
+          <p:cNvPr id="9040" name="pb40"/>
+          <p:cNvSpPr txBox="1"/>
+          <p:nvPr/>
+        </p:nvSpPr>
+        <p:spPr>
+          <a:xfrm>
+            <a:off x="0" y="6660000"/>
+            <a:ext cx="12192000" cy="198000"/>
+          </a:xfrm>
+          <a:prstGeom prst="rect">
+            <a:avLst/>
+          </a:prstGeom>
+          <a:solidFill>
+            <a:srgbClr val="0D1F14"/>
+          </a:solidFill>
+          <a:ln>
+            <a:noFill/>
+          </a:ln>
+        </p:spPr>
+        <p:txBody>
+          <a:bodyPr wrap="none" anchor="ctr"/>
+          <a:lstStyle/>
+          <a:p/>
+        </p:txBody>
+      </p:sp>
+      <p:sp>
+        <p:nvSpPr>
+          <p:cNvPr id="9041" name="pb41"/>
+          <p:cNvSpPr txBox="1"/>
+          <p:nvPr/>
+        </p:nvSpPr>
+        <p:spPr>
+          <a:xfrm>
+            <a:off x="0" y="6660000"/>
+            <a:ext cx="3251200" cy="198000"/>
+          </a:xfrm>
+          <a:prstGeom prst="rect">
+            <a:avLst/>
+          </a:prstGeom>
+          <a:solidFill>
+            <a:srgbClr val="2D5544"/>
+          </a:solidFill>
+          <a:ln>
+            <a:noFill/>
+          </a:ln>
+        </p:spPr>
+        <p:txBody>
+          <a:bodyPr wrap="none" anchor="ctr"/>
+          <a:lstStyle/>
+          <a:p/>
+        </p:txBody>
+      </p:sp>
+      <p:sp>
+        <p:nvSpPr>
+          <p:cNvPr id="9042" name="pb42"/>
+          <p:cNvSpPr txBox="1"/>
+          <p:nvPr/>
+        </p:nvSpPr>
+        <p:spPr>
+          <a:xfrm>
+            <a:off x="2711200" y="6660000"/>
+            <a:ext cx="540000" cy="198000"/>
+          </a:xfrm>
+          <a:prstGeom prst="rect">
+            <a:avLst/>
+          </a:prstGeom>
+          <a:solidFill>
+            <a:srgbClr val="3A6B55"/>
+          </a:solidFill>
+          <a:ln>
+            <a:noFill/>
+          </a:ln>
+        </p:spPr>
+        <p:txBody>
+          <a:bodyPr wrap="none" anchor="ctr"/>
+          <a:lstStyle/>
+          <a:p/>
+        </p:txBody>
+      </p:sp>
+      <p:sp>
+        <p:nvSpPr>
+          <p:cNvPr id="9043" name="pb43"/>
+          <p:cNvSpPr txBox="1"/>
+          <p:nvPr/>
+        </p:nvSpPr>
+        <p:spPr>
+          <a:xfrm>
+            <a:off x="2603200" y="6660000"/>
+            <a:ext cx="648000" cy="198000"/>
+          </a:xfrm>
+          <a:prstGeom prst="rect">
+            <a:avLst/>
+          </a:prstGeom>
+          <a:solidFill>
+            <a:srgbClr val="23613F"/>
+          </a:solidFill>
+          <a:ln>
+            <a:noFill/>
+          </a:ln>
+        </p:spPr>
+        <p:txBody>
+          <a:bodyPr wrap="none" anchor="ctr"/>
+          <a:lstStyle/>
+          <a:p>
+            <a:pPr algn="ctr"/>
+            <a:r>
+              <a:rPr lang="ru-RU" sz="800" b="1">
+                <a:solidFill>
+                  <a:srgbClr val="FFFFFF"/>
+                </a:solidFill>
+              </a:rPr>
+              <a:t>4</a:t>
             </a:r>
           </a:p>
         </p:txBody>
@@ -9040,7 +9956,7 @@
       </p:sp>
       <p:sp>
         <p:nvSpPr>
-          <p:cNvPr id="2020" name="pb20"/>
+          <p:cNvPr id="9020" name="pb20"/>
           <p:cNvSpPr txBox="1"/>
           <p:nvPr/>
         </p:nvSpPr>
@@ -9067,14 +9983,14 @@
       </p:sp>
       <p:sp>
         <p:nvSpPr>
-          <p:cNvPr id="2021" name="pb21"/>
+          <p:cNvPr id="9021" name="pb21"/>
           <p:cNvSpPr txBox="1"/>
           <p:nvPr/>
         </p:nvSpPr>
         <p:spPr>
           <a:xfrm>
             <a:off x="0" y="6660000"/>
-            <a:ext cx="1741714" cy="198000"/>
+            <a:ext cx="1625600" cy="198000"/>
           </a:xfrm>
           <a:prstGeom prst="rect">
             <a:avLst/>
@@ -9094,13 +10010,13 @@
       </p:sp>
       <p:sp>
         <p:nvSpPr>
-          <p:cNvPr id="2022" name="pb22"/>
-          <p:cNvSpPr txBox="1"/>
-          <p:nvPr/>
-        </p:nvSpPr>
-        <p:spPr>
-          <a:xfrm>
-            <a:off x="1201714" y="6660000"/>
+          <p:cNvPr id="9022" name="pb22"/>
+          <p:cNvSpPr txBox="1"/>
+          <p:nvPr/>
+        </p:nvSpPr>
+        <p:spPr>
+          <a:xfrm>
+            <a:off x="1085600" y="6660000"/>
             <a:ext cx="540000" cy="198000"/>
           </a:xfrm>
           <a:prstGeom prst="rect">
@@ -9121,13 +10037,13 @@
       </p:sp>
       <p:sp>
         <p:nvSpPr>
-          <p:cNvPr id="2123" name="pbn23"/>
-          <p:cNvSpPr txBox="1"/>
-          <p:nvPr/>
-        </p:nvSpPr>
-        <p:spPr>
-          <a:xfrm>
-            <a:off x="1093714" y="6660000"/>
+          <p:cNvPr id="9023" name="pb23"/>
+          <p:cNvSpPr txBox="1"/>
+          <p:nvPr/>
+        </p:nvSpPr>
+        <p:spPr>
+          <a:xfrm>
+            <a:off x="977600" y="6660000"/>
             <a:ext cx="648000" cy="198000"/>
           </a:xfrm>
           <a:prstGeom prst="rect">
@@ -9315,7 +10231,7 @@
       </p:graphicFrame>
       <p:sp>
         <p:nvSpPr>
-          <p:cNvPr id="2030" name="pb30"/>
+          <p:cNvPr id="9030" name="pb30"/>
           <p:cNvSpPr txBox="1"/>
           <p:nvPr/>
         </p:nvSpPr>
@@ -9342,14 +10258,14 @@
       </p:sp>
       <p:sp>
         <p:nvSpPr>
-          <p:cNvPr id="2031" name="pb31"/>
+          <p:cNvPr id="9031" name="pb31"/>
           <p:cNvSpPr txBox="1"/>
           <p:nvPr/>
         </p:nvSpPr>
         <p:spPr>
           <a:xfrm>
             <a:off x="0" y="6660000"/>
-            <a:ext cx="2612571" cy="198000"/>
+            <a:ext cx="2438400" cy="198000"/>
           </a:xfrm>
           <a:prstGeom prst="rect">
             <a:avLst/>
@@ -9369,13 +10285,13 @@
       </p:sp>
       <p:sp>
         <p:nvSpPr>
-          <p:cNvPr id="2032" name="pb32"/>
-          <p:cNvSpPr txBox="1"/>
-          <p:nvPr/>
-        </p:nvSpPr>
-        <p:spPr>
-          <a:xfrm>
-            <a:off x="2072571" y="6660000"/>
+          <p:cNvPr id="9032" name="pb32"/>
+          <p:cNvSpPr txBox="1"/>
+          <p:nvPr/>
+        </p:nvSpPr>
+        <p:spPr>
+          <a:xfrm>
+            <a:off x="1898400" y="6660000"/>
             <a:ext cx="540000" cy="198000"/>
           </a:xfrm>
           <a:prstGeom prst="rect">
@@ -9396,13 +10312,13 @@
       </p:sp>
       <p:sp>
         <p:nvSpPr>
-          <p:cNvPr id="2133" name="pbn33"/>
-          <p:cNvSpPr txBox="1"/>
-          <p:nvPr/>
-        </p:nvSpPr>
-        <p:spPr>
-          <a:xfrm>
-            <a:off x="1964571" y="6660000"/>
+          <p:cNvPr id="9033" name="pb33"/>
+          <p:cNvSpPr txBox="1"/>
+          <p:nvPr/>
+        </p:nvSpPr>
+        <p:spPr>
+          <a:xfrm>
+            <a:off x="1790400" y="6660000"/>
             <a:ext cx="648000" cy="198000"/>
           </a:xfrm>
           <a:prstGeom prst="rect">
@@ -9882,7 +10798,7 @@
       </p:sp>
       <p:sp>
         <p:nvSpPr>
-          <p:cNvPr id="2040" name="pb40"/>
+          <p:cNvPr id="9050" name="pb50"/>
           <p:cNvSpPr txBox="1"/>
           <p:nvPr/>
         </p:nvSpPr>
@@ -9909,14 +10825,14 @@
       </p:sp>
       <p:sp>
         <p:nvSpPr>
-          <p:cNvPr id="2041" name="pb41"/>
+          <p:cNvPr id="9051" name="pb51"/>
           <p:cNvSpPr txBox="1"/>
           <p:nvPr/>
         </p:nvSpPr>
         <p:spPr>
           <a:xfrm>
             <a:off x="0" y="6660000"/>
-            <a:ext cx="3483428" cy="198000"/>
+            <a:ext cx="4064000" cy="198000"/>
           </a:xfrm>
           <a:prstGeom prst="rect">
             <a:avLst/>
@@ -9936,13 +10852,13 @@
       </p:sp>
       <p:sp>
         <p:nvSpPr>
-          <p:cNvPr id="2042" name="pb42"/>
-          <p:cNvSpPr txBox="1"/>
-          <p:nvPr/>
-        </p:nvSpPr>
-        <p:spPr>
-          <a:xfrm>
-            <a:off x="2943428" y="6660000"/>
+          <p:cNvPr id="9052" name="pb52"/>
+          <p:cNvSpPr txBox="1"/>
+          <p:nvPr/>
+        </p:nvSpPr>
+        <p:spPr>
+          <a:xfrm>
+            <a:off x="3524000" y="6660000"/>
             <a:ext cx="540000" cy="198000"/>
           </a:xfrm>
           <a:prstGeom prst="rect">
@@ -9963,13 +10879,13 @@
       </p:sp>
       <p:sp>
         <p:nvSpPr>
-          <p:cNvPr id="2143" name="pbn43"/>
-          <p:cNvSpPr txBox="1"/>
-          <p:nvPr/>
-        </p:nvSpPr>
-        <p:spPr>
-          <a:xfrm>
-            <a:off x="2835428" y="6660000"/>
+          <p:cNvPr id="9053" name="pb53"/>
+          <p:cNvSpPr txBox="1"/>
+          <p:nvPr/>
+        </p:nvSpPr>
+        <p:spPr>
+          <a:xfrm>
+            <a:off x="3416000" y="6660000"/>
             <a:ext cx="648000" cy="198000"/>
           </a:xfrm>
           <a:prstGeom prst="rect">
@@ -9993,7 +10909,7 @@
                   <a:srgbClr val="FFFFFF"/>
                 </a:solidFill>
               </a:rPr>
-              <a:t>4</a:t>
+              <a:t>5</a:t>
             </a:r>
           </a:p>
         </p:txBody>
@@ -13070,7 +13986,7 @@
       </p:graphicFrame>
       <p:sp>
         <p:nvSpPr>
-          <p:cNvPr id="2050" name="pb50"/>
+          <p:cNvPr id="9060" name="pb60"/>
           <p:cNvSpPr txBox="1"/>
           <p:nvPr/>
         </p:nvSpPr>
@@ -13097,14 +14013,14 @@
       </p:sp>
       <p:sp>
         <p:nvSpPr>
-          <p:cNvPr id="2051" name="pb51"/>
+          <p:cNvPr id="9061" name="pb61"/>
           <p:cNvSpPr txBox="1"/>
           <p:nvPr/>
         </p:nvSpPr>
         <p:spPr>
           <a:xfrm>
             <a:off x="0" y="6660000"/>
-            <a:ext cx="4354285" cy="198000"/>
+            <a:ext cx="4876800" cy="198000"/>
           </a:xfrm>
           <a:prstGeom prst="rect">
             <a:avLst/>
@@ -13124,13 +14040,13 @@
       </p:sp>
       <p:sp>
         <p:nvSpPr>
-          <p:cNvPr id="2052" name="pb52"/>
-          <p:cNvSpPr txBox="1"/>
-          <p:nvPr/>
-        </p:nvSpPr>
-        <p:spPr>
-          <a:xfrm>
-            <a:off x="3814285" y="6660000"/>
+          <p:cNvPr id="9062" name="pb62"/>
+          <p:cNvSpPr txBox="1"/>
+          <p:nvPr/>
+        </p:nvSpPr>
+        <p:spPr>
+          <a:xfrm>
+            <a:off x="4336800" y="6660000"/>
             <a:ext cx="540000" cy="198000"/>
           </a:xfrm>
           <a:prstGeom prst="rect">
@@ -13151,13 +14067,13 @@
       </p:sp>
       <p:sp>
         <p:nvSpPr>
-          <p:cNvPr id="2153" name="pbn53"/>
-          <p:cNvSpPr txBox="1"/>
-          <p:nvPr/>
-        </p:nvSpPr>
-        <p:spPr>
-          <a:xfrm>
-            <a:off x="3706285" y="6660000"/>
+          <p:cNvPr id="9063" name="pb63"/>
+          <p:cNvSpPr txBox="1"/>
+          <p:nvPr/>
+        </p:nvSpPr>
+        <p:spPr>
+          <a:xfrm>
+            <a:off x="4228800" y="6660000"/>
             <a:ext cx="648000" cy="198000"/>
           </a:xfrm>
           <a:prstGeom prst="rect">
@@ -13181,7 +14097,7 @@
                   <a:srgbClr val="FFFFFF"/>
                 </a:solidFill>
               </a:rPr>
-              <a:t>5</a:t>
+              <a:t>6</a:t>
             </a:r>
           </a:p>
         </p:txBody>
@@ -14077,7 +14993,7 @@
       </p:sp>
       <p:sp>
         <p:nvSpPr>
-          <p:cNvPr id="2060" name="pb60"/>
+          <p:cNvPr id="9070" name="pb70"/>
           <p:cNvSpPr txBox="1"/>
           <p:nvPr/>
         </p:nvSpPr>
@@ -14104,14 +15020,14 @@
       </p:sp>
       <p:sp>
         <p:nvSpPr>
-          <p:cNvPr id="2061" name="pb61"/>
+          <p:cNvPr id="9071" name="pb71"/>
           <p:cNvSpPr txBox="1"/>
           <p:nvPr/>
         </p:nvSpPr>
         <p:spPr>
           <a:xfrm>
             <a:off x="0" y="6660000"/>
-            <a:ext cx="5225142" cy="198000"/>
+            <a:ext cx="5689600" cy="198000"/>
           </a:xfrm>
           <a:prstGeom prst="rect">
             <a:avLst/>
@@ -14131,13 +15047,13 @@
       </p:sp>
       <p:sp>
         <p:nvSpPr>
-          <p:cNvPr id="2062" name="pb62"/>
-          <p:cNvSpPr txBox="1"/>
-          <p:nvPr/>
-        </p:nvSpPr>
-        <p:spPr>
-          <a:xfrm>
-            <a:off x="4685142" y="6660000"/>
+          <p:cNvPr id="9072" name="pb72"/>
+          <p:cNvSpPr txBox="1"/>
+          <p:nvPr/>
+        </p:nvSpPr>
+        <p:spPr>
+          <a:xfrm>
+            <a:off x="5149600" y="6660000"/>
             <a:ext cx="540000" cy="198000"/>
           </a:xfrm>
           <a:prstGeom prst="rect">
@@ -14158,13 +15074,13 @@
       </p:sp>
       <p:sp>
         <p:nvSpPr>
-          <p:cNvPr id="2163" name="pbn63"/>
-          <p:cNvSpPr txBox="1"/>
-          <p:nvPr/>
-        </p:nvSpPr>
-        <p:spPr>
-          <a:xfrm>
-            <a:off x="4577142" y="6660000"/>
+          <p:cNvPr id="9073" name="pb73"/>
+          <p:cNvSpPr txBox="1"/>
+          <p:nvPr/>
+        </p:nvSpPr>
+        <p:spPr>
+          <a:xfrm>
+            <a:off x="5041600" y="6660000"/>
             <a:ext cx="648000" cy="198000"/>
           </a:xfrm>
           <a:prstGeom prst="rect">
@@ -14188,7 +15104,7 @@
                   <a:srgbClr val="FFFFFF"/>
                 </a:solidFill>
               </a:rPr>
-              <a:t>6</a:t>
+              <a:t>7</a:t>
             </a:r>
           </a:p>
         </p:txBody>
@@ -15034,7 +15950,7 @@
       </p:graphicFrame>
       <p:sp>
         <p:nvSpPr>
-          <p:cNvPr id="2070" name="pb70"/>
+          <p:cNvPr id="9080" name="pb80"/>
           <p:cNvSpPr txBox="1"/>
           <p:nvPr/>
         </p:nvSpPr>
@@ -15061,14 +15977,14 @@
       </p:sp>
       <p:sp>
         <p:nvSpPr>
-          <p:cNvPr id="2071" name="pb71"/>
+          <p:cNvPr id="9081" name="pb81"/>
           <p:cNvSpPr txBox="1"/>
           <p:nvPr/>
         </p:nvSpPr>
         <p:spPr>
           <a:xfrm>
             <a:off x="0" y="6660000"/>
-            <a:ext cx="6096000" cy="198000"/>
+            <a:ext cx="6502400" cy="198000"/>
           </a:xfrm>
           <a:prstGeom prst="rect">
             <a:avLst/>
@@ -15088,13 +16004,13 @@
       </p:sp>
       <p:sp>
         <p:nvSpPr>
-          <p:cNvPr id="2072" name="pb72"/>
-          <p:cNvSpPr txBox="1"/>
-          <p:nvPr/>
-        </p:nvSpPr>
-        <p:spPr>
-          <a:xfrm>
-            <a:off x="5556000" y="6660000"/>
+          <p:cNvPr id="9082" name="pb82"/>
+          <p:cNvSpPr txBox="1"/>
+          <p:nvPr/>
+        </p:nvSpPr>
+        <p:spPr>
+          <a:xfrm>
+            <a:off x="5962400" y="6660000"/>
             <a:ext cx="540000" cy="198000"/>
           </a:xfrm>
           <a:prstGeom prst="rect">
@@ -15115,13 +16031,13 @@
       </p:sp>
       <p:sp>
         <p:nvSpPr>
-          <p:cNvPr id="2173" name="pbn73"/>
-          <p:cNvSpPr txBox="1"/>
-          <p:nvPr/>
-        </p:nvSpPr>
-        <p:spPr>
-          <a:xfrm>
-            <a:off x="5448000" y="6660000"/>
+          <p:cNvPr id="9083" name="pb83"/>
+          <p:cNvSpPr txBox="1"/>
+          <p:nvPr/>
+        </p:nvSpPr>
+        <p:spPr>
+          <a:xfrm>
+            <a:off x="5854400" y="6660000"/>
             <a:ext cx="648000" cy="198000"/>
           </a:xfrm>
           <a:prstGeom prst="rect">
@@ -15145,7 +16061,7 @@
                   <a:srgbClr val="FFFFFF"/>
                 </a:solidFill>
               </a:rPr>
-              <a:t>7</a:t>
+              <a:t>8</a:t>
             </a:r>
           </a:p>
         </p:txBody>
@@ -16091,7 +17007,7 @@
       </p:sp>
       <p:sp>
         <p:nvSpPr>
-          <p:cNvPr id="2080" name="pb80"/>
+          <p:cNvPr id="9090" name="pb90"/>
           <p:cNvSpPr txBox="1"/>
           <p:nvPr/>
         </p:nvSpPr>
@@ -16118,14 +17034,14 @@
       </p:sp>
       <p:sp>
         <p:nvSpPr>
-          <p:cNvPr id="2081" name="pb81"/>
+          <p:cNvPr id="9091" name="pb91"/>
           <p:cNvSpPr txBox="1"/>
           <p:nvPr/>
         </p:nvSpPr>
         <p:spPr>
           <a:xfrm>
             <a:off x="0" y="6660000"/>
-            <a:ext cx="6966857" cy="198000"/>
+            <a:ext cx="7315200" cy="198000"/>
           </a:xfrm>
           <a:prstGeom prst="rect">
             <a:avLst/>
@@ -16145,13 +17061,13 @@
       </p:sp>
       <p:sp>
         <p:nvSpPr>
-          <p:cNvPr id="2082" name="pb82"/>
-          <p:cNvSpPr txBox="1"/>
-          <p:nvPr/>
-        </p:nvSpPr>
-        <p:spPr>
-          <a:xfrm>
-            <a:off x="6426857" y="6660000"/>
+          <p:cNvPr id="9092" name="pb92"/>
+          <p:cNvSpPr txBox="1"/>
+          <p:nvPr/>
+        </p:nvSpPr>
+        <p:spPr>
+          <a:xfrm>
+            <a:off x="6775200" y="6660000"/>
             <a:ext cx="540000" cy="198000"/>
           </a:xfrm>
           <a:prstGeom prst="rect">
@@ -16172,13 +17088,13 @@
       </p:sp>
       <p:sp>
         <p:nvSpPr>
-          <p:cNvPr id="2183" name="pbn83"/>
-          <p:cNvSpPr txBox="1"/>
-          <p:nvPr/>
-        </p:nvSpPr>
-        <p:spPr>
-          <a:xfrm>
-            <a:off x="6318857" y="6660000"/>
+          <p:cNvPr id="9093" name="pb93"/>
+          <p:cNvSpPr txBox="1"/>
+          <p:nvPr/>
+        </p:nvSpPr>
+        <p:spPr>
+          <a:xfrm>
+            <a:off x="6667200" y="6660000"/>
             <a:ext cx="648000" cy="198000"/>
           </a:xfrm>
           <a:prstGeom prst="rect">
@@ -16202,7 +17118,7 @@
                   <a:srgbClr val="FFFFFF"/>
                 </a:solidFill>
               </a:rPr>
-              <a:t>8</a:t>
+              <a:t>9</a:t>
             </a:r>
           </a:p>
         </p:txBody>
@@ -16322,14 +17238,328 @@
       </p:sp>
       <p:sp>
         <p:nvSpPr>
-          <p:cNvPr id="2090" name="pb90"/>
-          <p:cNvSpPr txBox="1"/>
-          <p:nvPr/>
-        </p:nvSpPr>
-        <p:spPr>
-          <a:xfrm>
-            <a:off x="0" y="6660000"/>
-            <a:ext cx="12192000" cy="198000"/>
+          <p:cNvPr id="200" name="s0"/>
+          <p:cNvSpPr txBox="1"/>
+          <p:nvPr/>
+        </p:nvSpPr>
+        <p:spPr>
+          <a:xfrm>
+            <a:off x="360000" y="180000"/>
+            <a:ext cx="11448000" cy="684000"/>
+          </a:xfrm>
+          <a:prstGeom prst="rect">
+            <a:avLst/>
+          </a:prstGeom>
+          <a:noFill/>
+          <a:ln>
+            <a:noFill/>
+          </a:ln>
+        </p:spPr>
+        <p:txBody>
+          <a:bodyPr wrap="square" anchor="ctr"/>
+          <a:lstStyle/>
+          <a:p>
+            <a:pPr algn="l"/>
+            <a:r>
+              <a:rPr lang="ru-RU" sz="2200" b="1">
+                <a:solidFill>
+                  <a:srgbClr val="FFFFFF"/>
+                </a:solidFill>
+              </a:rPr>
+              <a:t>Географическая привязка</a:t>
+            </a:r>
+          </a:p>
+        </p:txBody>
+      </p:sp>
+      <p:sp>
+        <p:nvSpPr>
+          <p:cNvPr id="201" name="s1"/>
+          <p:cNvSpPr txBox="1"/>
+          <p:nvPr/>
+        </p:nvSpPr>
+        <p:spPr>
+          <a:xfrm>
+            <a:off x="360000" y="1080000"/>
+            <a:ext cx="3311999" cy="576000"/>
+          </a:xfrm>
+          <a:prstGeom prst="rect">
+            <a:avLst/>
+          </a:prstGeom>
+          <a:solidFill>
+            <a:srgbClr val="1A5C3A"/>
+          </a:solidFill>
+          <a:ln>
+            <a:noFill/>
+          </a:ln>
+        </p:spPr>
+        <p:txBody>
+          <a:bodyPr wrap="square" anchor="ctr"/>
+          <a:lstStyle/>
+          <a:p>
+            <a:pPr algn="ctr"/>
+            <a:r>
+              <a:rPr lang="ru-RU" sz="1300" b="1">
+                <a:solidFill>
+                  <a:srgbClr val="FFFFFF"/>
+                </a:solidFill>
+              </a:rPr>
+              <a:t>Этап 1 — Приоритизация</a:t>
+            </a:r>
+          </a:p>
+        </p:txBody>
+      </p:sp>
+      <p:sp>
+        <p:nvSpPr>
+          <p:cNvPr id="202" name="s2"/>
+          <p:cNvSpPr txBox="1"/>
+          <p:nvPr/>
+        </p:nvSpPr>
+        <p:spPr>
+          <a:xfrm>
+            <a:off x="360000" y="1656000"/>
+            <a:ext cx="3311999" cy="3204000"/>
+          </a:xfrm>
+          <a:prstGeom prst="rect">
+            <a:avLst/>
+          </a:prstGeom>
+          <a:solidFill>
+            <a:srgbClr val="1A3A2A"/>
+          </a:solidFill>
+          <a:ln>
+            <a:noFill/>
+          </a:ln>
+        </p:spPr>
+        <p:txBody>
+          <a:bodyPr wrap="square" anchor="t"/>
+          <a:lstStyle/>
+          <a:p>
+            <a:pPr algn="l"/>
+            <a:r>
+              <a:rPr lang="ru-RU" sz="1300" b="0">
+                <a:solidFill>
+                  <a:srgbClr val="CFE0D6"/>
+                </a:solidFill>
+              </a:rPr>
+              <a:t>Организации сортируются по числу</a:t>
+            </a:r>
+          </a:p>
+          <a:p>
+            <a:pPr algn="l"/>
+            <a:r>
+              <a:rPr lang="ru-RU" sz="1300" b="0">
+                <a:solidFill>
+                  <a:srgbClr val="CFE0D6"/>
+                </a:solidFill>
+              </a:rPr>
+              <a:t>зависимых публикаций.</a:t>
+            </a:r>
+          </a:p>
+          <a:p>
+            <a:pPr algn="l"/>
+          </a:p>
+          <a:p>
+            <a:pPr algn="l"/>
+            <a:r>
+              <a:rPr lang="ru-RU" sz="1300" b="0">
+                <a:solidFill>
+                  <a:srgbClr val="CFE0D6"/>
+                </a:solidFill>
+              </a:rPr>
+              <a:t>Первыми обрабатываются те,</a:t>
+            </a:r>
+          </a:p>
+          <a:p>
+            <a:pPr algn="l"/>
+            <a:r>
+              <a:rPr lang="ru-RU" sz="1300" b="0">
+                <a:solidFill>
+                  <a:srgbClr val="CFE0D6"/>
+                </a:solidFill>
+              </a:rPr>
+              <a:t>что «разблокируют» наибольшее</a:t>
+            </a:r>
+          </a:p>
+          <a:p>
+            <a:pPr algn="l"/>
+            <a:r>
+              <a:rPr lang="ru-RU" sz="1300" b="0">
+                <a:solidFill>
+                  <a:srgbClr val="CFE0D6"/>
+                </a:solidFill>
+              </a:rPr>
+              <a:t>количество записей без координат.</a:t>
+            </a:r>
+          </a:p>
+        </p:txBody>
+      </p:sp>
+      <p:sp>
+        <p:nvSpPr>
+          <p:cNvPr id="203" name="s3"/>
+          <p:cNvSpPr txBox="1"/>
+          <p:nvPr/>
+        </p:nvSpPr>
+        <p:spPr>
+          <a:xfrm>
+            <a:off x="4211999" y="1080000"/>
+            <a:ext cx="3311999" cy="576000"/>
+          </a:xfrm>
+          <a:prstGeom prst="rect">
+            <a:avLst/>
+          </a:prstGeom>
+          <a:solidFill>
+            <a:srgbClr val="1A5C3A"/>
+          </a:solidFill>
+          <a:ln>
+            <a:noFill/>
+          </a:ln>
+        </p:spPr>
+        <p:txBody>
+          <a:bodyPr wrap="square" anchor="ctr"/>
+          <a:lstStyle/>
+          <a:p>
+            <a:pPr algn="ctr"/>
+            <a:r>
+              <a:rPr lang="ru-RU" sz="1300" b="1">
+                <a:solidFill>
+                  <a:srgbClr val="FFFFFF"/>
+                </a:solidFill>
+              </a:rPr>
+              <a:t>Этап 2 — OpenAlex API</a:t>
+            </a:r>
+          </a:p>
+        </p:txBody>
+      </p:sp>
+      <p:sp>
+        <p:nvSpPr>
+          <p:cNvPr id="204" name="s4"/>
+          <p:cNvSpPr txBox="1"/>
+          <p:nvPr/>
+        </p:nvSpPr>
+        <p:spPr>
+          <a:xfrm>
+            <a:off x="4211999" y="1656000"/>
+            <a:ext cx="3311999" cy="3204000"/>
+          </a:xfrm>
+          <a:prstGeom prst="rect">
+            <a:avLst/>
+          </a:prstGeom>
+          <a:solidFill>
+            <a:srgbClr val="1A3A2A"/>
+          </a:solidFill>
+          <a:ln>
+            <a:noFill/>
+          </a:ln>
+        </p:spPr>
+        <p:txBody>
+          <a:bodyPr wrap="square" anchor="t"/>
+          <a:lstStyle/>
+          <a:p>
+            <a:pPr algn="l"/>
+            <a:r>
+              <a:rPr lang="ru-RU" sz="1300" b="0">
+                <a:solidFill>
+                  <a:srgbClr val="CFE0D6"/>
+                </a:solidFill>
+              </a:rPr>
+              <a:t>Запрос координат по</a:t>
+            </a:r>
+          </a:p>
+          <a:p>
+            <a:pPr algn="l"/>
+            <a:r>
+              <a:rPr lang="ru-RU" sz="1300" b="0">
+                <a:solidFill>
+                  <a:srgbClr val="CFE0D6"/>
+                </a:solidFill>
+              </a:rPr>
+              <a:t>идентификатору организации</a:t>
+            </a:r>
+          </a:p>
+          <a:p>
+            <a:pPr algn="l"/>
+            <a:r>
+              <a:rPr lang="ru-RU" sz="1300" b="0">
+                <a:solidFill>
+                  <a:srgbClr val="CFE0D6"/>
+                </a:solidFill>
+              </a:rPr>
+              <a:t>через API OpenAlex.</a:t>
+            </a:r>
+          </a:p>
+          <a:p>
+            <a:pPr algn="l"/>
+          </a:p>
+          <a:p>
+            <a:pPr algn="l"/>
+            <a:r>
+              <a:rPr lang="ru-RU" sz="1300" b="0">
+                <a:solidFill>
+                  <a:srgbClr val="CFE0D6"/>
+                </a:solidFill>
+              </a:rPr>
+              <a:t>Результат:</a:t>
+            </a:r>
+          </a:p>
+          <a:p>
+            <a:pPr algn="l"/>
+            <a:r>
+              <a:rPr lang="ru-RU" sz="1300" b="0">
+                <a:solidFill>
+                  <a:srgbClr val="CFE0D6"/>
+                </a:solidFill>
+              </a:rPr>
+              <a:t>78% публикаций с координатами.</a:t>
+            </a:r>
+          </a:p>
+        </p:txBody>
+      </p:sp>
+      <p:sp>
+        <p:nvSpPr>
+          <p:cNvPr id="205" name="s5"/>
+          <p:cNvSpPr txBox="1"/>
+          <p:nvPr/>
+        </p:nvSpPr>
+        <p:spPr>
+          <a:xfrm>
+            <a:off x="8063998" y="1080000"/>
+            <a:ext cx="3311999" cy="576000"/>
+          </a:xfrm>
+          <a:prstGeom prst="rect">
+            <a:avLst/>
+          </a:prstGeom>
+          <a:solidFill>
+            <a:srgbClr val="163126"/>
+          </a:solidFill>
+          <a:ln>
+            <a:noFill/>
+          </a:ln>
+        </p:spPr>
+        <p:txBody>
+          <a:bodyPr wrap="square" anchor="ctr"/>
+          <a:lstStyle/>
+          <a:p>
+            <a:pPr algn="ctr"/>
+            <a:r>
+              <a:rPr lang="ru-RU" sz="1300" b="1">
+                <a:solidFill>
+                  <a:srgbClr val="FFFFFF"/>
+                </a:solidFill>
+              </a:rPr>
+              <a:t>Этап 3 — Photon</a:t>
+            </a:r>
+          </a:p>
+        </p:txBody>
+      </p:sp>
+      <p:sp>
+        <p:nvSpPr>
+          <p:cNvPr id="206" name="s6"/>
+          <p:cNvSpPr txBox="1"/>
+          <p:nvPr/>
+        </p:nvSpPr>
+        <p:spPr>
+          <a:xfrm>
+            <a:off x="8063998" y="1656000"/>
+            <a:ext cx="3311999" cy="3204000"/>
           </a:xfrm>
           <a:prstGeom prst="rect">
             <a:avLst/>
@@ -16342,6 +17572,197 @@
           </a:ln>
         </p:spPr>
         <p:txBody>
+          <a:bodyPr wrap="square" anchor="t"/>
+          <a:lstStyle/>
+          <a:p>
+            <a:pPr algn="l"/>
+            <a:r>
+              <a:rPr lang="ru-RU" sz="1300" b="0">
+                <a:solidFill>
+                  <a:srgbClr val="CFE0D6"/>
+                </a:solidFill>
+              </a:rPr>
+              <a:t>Для аффилиаций без</a:t>
+            </a:r>
+          </a:p>
+          <a:p>
+            <a:pPr algn="l"/>
+            <a:r>
+              <a:rPr lang="ru-RU" sz="1300" b="0">
+                <a:solidFill>
+                  <a:srgbClr val="CFE0D6"/>
+                </a:solidFill>
+              </a:rPr>
+              <a:t>идентификатора — геокодирование</a:t>
+            </a:r>
+          </a:p>
+          <a:p>
+            <a:pPr algn="l"/>
+            <a:r>
+              <a:rPr lang="ru-RU" sz="1300" b="0">
+                <a:solidFill>
+                  <a:srgbClr val="CFE0D6"/>
+                </a:solidFill>
+              </a:rPr>
+              <a:t>по строке названия через Photon</a:t>
+            </a:r>
+          </a:p>
+          <a:p>
+            <a:pPr algn="l"/>
+            <a:r>
+              <a:rPr lang="ru-RU" sz="1300" b="0">
+                <a:solidFill>
+                  <a:srgbClr val="CFE0D6"/>
+                </a:solidFill>
+              </a:rPr>
+              <a:t>(OpenStreetMap).</a:t>
+            </a:r>
+          </a:p>
+          <a:p>
+            <a:pPr algn="l"/>
+          </a:p>
+          <a:p>
+            <a:pPr algn="l"/>
+            <a:r>
+              <a:rPr lang="ru-RU" sz="1300" b="0">
+                <a:solidFill>
+                  <a:srgbClr val="CFE0D6"/>
+                </a:solidFill>
+              </a:rPr>
+              <a:t>Результат: +2,8% публикаций.</a:t>
+            </a:r>
+          </a:p>
+        </p:txBody>
+      </p:sp>
+      <p:sp>
+        <p:nvSpPr>
+          <p:cNvPr id="207" name="s7"/>
+          <p:cNvSpPr txBox="1"/>
+          <p:nvPr/>
+        </p:nvSpPr>
+        <p:spPr>
+          <a:xfrm>
+            <a:off x="3743999" y="2826000"/>
+            <a:ext cx="396000" cy="288000"/>
+          </a:xfrm>
+          <a:prstGeom prst="rect">
+            <a:avLst/>
+          </a:prstGeom>
+          <a:noFill/>
+          <a:ln>
+            <a:noFill/>
+          </a:ln>
+        </p:spPr>
+        <p:txBody>
+          <a:bodyPr wrap="square" anchor="ctr"/>
+          <a:lstStyle/>
+          <a:p>
+            <a:pPr algn="ctr"/>
+            <a:r>
+              <a:rPr lang="ru-RU" sz="2200" b="1">
+                <a:solidFill>
+                  <a:srgbClr val="557766"/>
+                </a:solidFill>
+              </a:rPr>
+              <a:t>→</a:t>
+            </a:r>
+          </a:p>
+        </p:txBody>
+      </p:sp>
+      <p:sp>
+        <p:nvSpPr>
+          <p:cNvPr id="208" name="s8"/>
+          <p:cNvSpPr txBox="1"/>
+          <p:nvPr/>
+        </p:nvSpPr>
+        <p:spPr>
+          <a:xfrm>
+            <a:off x="7595998" y="2826000"/>
+            <a:ext cx="396000" cy="288000"/>
+          </a:xfrm>
+          <a:prstGeom prst="rect">
+            <a:avLst/>
+          </a:prstGeom>
+          <a:noFill/>
+          <a:ln>
+            <a:noFill/>
+          </a:ln>
+        </p:spPr>
+        <p:txBody>
+          <a:bodyPr wrap="square" anchor="ctr"/>
+          <a:lstStyle/>
+          <a:p>
+            <a:pPr algn="ctr"/>
+            <a:r>
+              <a:rPr lang="ru-RU" sz="2200" b="1">
+                <a:solidFill>
+                  <a:srgbClr val="557766"/>
+                </a:solidFill>
+              </a:rPr>
+              <a:t>→</a:t>
+            </a:r>
+          </a:p>
+        </p:txBody>
+      </p:sp>
+      <p:sp>
+        <p:nvSpPr>
+          <p:cNvPr id="209" name="s9"/>
+          <p:cNvSpPr txBox="1"/>
+          <p:nvPr/>
+        </p:nvSpPr>
+        <p:spPr>
+          <a:xfrm>
+            <a:off x="360000" y="5040000"/>
+            <a:ext cx="11520000" cy="540000"/>
+          </a:xfrm>
+          <a:prstGeom prst="rect">
+            <a:avLst/>
+          </a:prstGeom>
+          <a:solidFill>
+            <a:srgbClr val="23613F"/>
+          </a:solidFill>
+          <a:ln>
+            <a:noFill/>
+          </a:ln>
+        </p:spPr>
+        <p:txBody>
+          <a:bodyPr wrap="square" anchor="ctr"/>
+          <a:lstStyle/>
+          <a:p>
+            <a:pPr algn="ctr"/>
+            <a:r>
+              <a:rPr lang="ru-RU" sz="1400" b="1">
+                <a:solidFill>
+                  <a:srgbClr val="FFFFFF"/>
+                </a:solidFill>
+              </a:rPr>
+              <a:t>Итог: 80,8% публикаций с координатами (порог — 75%)</a:t>
+            </a:r>
+          </a:p>
+        </p:txBody>
+      </p:sp>
+      <p:sp>
+        <p:nvSpPr>
+          <p:cNvPr id="9100" name="pb100"/>
+          <p:cNvSpPr txBox="1"/>
+          <p:nvPr/>
+        </p:nvSpPr>
+        <p:spPr>
+          <a:xfrm>
+            <a:off x="0" y="6660000"/>
+            <a:ext cx="12192000" cy="198000"/>
+          </a:xfrm>
+          <a:prstGeom prst="rect">
+            <a:avLst/>
+          </a:prstGeom>
+          <a:solidFill>
+            <a:srgbClr val="0D1F14"/>
+          </a:solidFill>
+          <a:ln>
+            <a:noFill/>
+          </a:ln>
+        </p:spPr>
+        <p:txBody>
           <a:bodyPr wrap="none" anchor="ctr"/>
           <a:lstStyle/>
           <a:p/>
@@ -16349,14 +17770,14 @@
       </p:sp>
       <p:sp>
         <p:nvSpPr>
-          <p:cNvPr id="2091" name="pb91"/>
+          <p:cNvPr id="9101" name="pb101"/>
           <p:cNvSpPr txBox="1"/>
           <p:nvPr/>
         </p:nvSpPr>
         <p:spPr>
           <a:xfrm>
             <a:off x="0" y="6660000"/>
-            <a:ext cx="7837714" cy="198000"/>
+            <a:ext cx="8128000" cy="198000"/>
           </a:xfrm>
           <a:prstGeom prst="rect">
             <a:avLst/>
@@ -16376,13 +17797,13 @@
       </p:sp>
       <p:sp>
         <p:nvSpPr>
-          <p:cNvPr id="2092" name="pb92"/>
-          <p:cNvSpPr txBox="1"/>
-          <p:nvPr/>
-        </p:nvSpPr>
-        <p:spPr>
-          <a:xfrm>
-            <a:off x="7297714" y="6660000"/>
+          <p:cNvPr id="9102" name="pb102"/>
+          <p:cNvSpPr txBox="1"/>
+          <p:nvPr/>
+        </p:nvSpPr>
+        <p:spPr>
+          <a:xfrm>
+            <a:off x="7588000" y="6660000"/>
             <a:ext cx="540000" cy="198000"/>
           </a:xfrm>
           <a:prstGeom prst="rect">
@@ -16403,13 +17824,13 @@
       </p:sp>
       <p:sp>
         <p:nvSpPr>
-          <p:cNvPr id="2193" name="pbn93"/>
-          <p:cNvSpPr txBox="1"/>
-          <p:nvPr/>
-        </p:nvSpPr>
-        <p:spPr>
-          <a:xfrm>
-            <a:off x="7189714" y="6660000"/>
+          <p:cNvPr id="9103" name="pb103"/>
+          <p:cNvSpPr txBox="1"/>
+          <p:nvPr/>
+        </p:nvSpPr>
+        <p:spPr>
+          <a:xfrm>
+            <a:off x="7480000" y="6660000"/>
             <a:ext cx="648000" cy="198000"/>
           </a:xfrm>
           <a:prstGeom prst="rect">
@@ -16433,512 +17854,7 @@
                   <a:srgbClr val="FFFFFF"/>
                 </a:solidFill>
               </a:rPr>
-              <a:t>9</a:t>
-            </a:r>
-          </a:p>
-        </p:txBody>
-      </p:sp>
-      <p:sp>
-        <p:nvSpPr>
-          <p:cNvPr id="200" name="s0"/>
-          <p:cNvSpPr txBox="1"/>
-          <p:nvPr/>
-        </p:nvSpPr>
-        <p:spPr>
-          <a:xfrm>
-            <a:off x="360000" y="180000"/>
-            <a:ext cx="11448000" cy="684000"/>
-          </a:xfrm>
-          <a:prstGeom prst="rect">
-            <a:avLst/>
-          </a:prstGeom>
-          <a:noFill/>
-          <a:ln>
-            <a:noFill/>
-          </a:ln>
-        </p:spPr>
-        <p:txBody>
-          <a:bodyPr wrap="square" anchor="ctr"/>
-          <a:lstStyle/>
-          <a:p>
-            <a:pPr algn="l"/>
-            <a:r>
-              <a:rPr lang="ru-RU" sz="2200" b="1">
-                <a:solidFill>
-                  <a:srgbClr val="FFFFFF"/>
-                </a:solidFill>
-              </a:rPr>
-              <a:t>Географическая привязка</a:t>
-            </a:r>
-          </a:p>
-        </p:txBody>
-      </p:sp>
-      <p:sp>
-        <p:nvSpPr>
-          <p:cNvPr id="201" name="s1"/>
-          <p:cNvSpPr txBox="1"/>
-          <p:nvPr/>
-        </p:nvSpPr>
-        <p:spPr>
-          <a:xfrm>
-            <a:off x="360000" y="1080000"/>
-            <a:ext cx="3311999" cy="576000"/>
-          </a:xfrm>
-          <a:prstGeom prst="rect">
-            <a:avLst/>
-          </a:prstGeom>
-          <a:solidFill>
-            <a:srgbClr val="1A5C3A"/>
-          </a:solidFill>
-          <a:ln>
-            <a:noFill/>
-          </a:ln>
-        </p:spPr>
-        <p:txBody>
-          <a:bodyPr wrap="square" anchor="ctr"/>
-          <a:lstStyle/>
-          <a:p>
-            <a:pPr algn="ctr"/>
-            <a:r>
-              <a:rPr lang="ru-RU" sz="1300" b="1">
-                <a:solidFill>
-                  <a:srgbClr val="FFFFFF"/>
-                </a:solidFill>
-              </a:rPr>
-              <a:t>Этап 1 — Приоритизация</a:t>
-            </a:r>
-          </a:p>
-        </p:txBody>
-      </p:sp>
-      <p:sp>
-        <p:nvSpPr>
-          <p:cNvPr id="202" name="s2"/>
-          <p:cNvSpPr txBox="1"/>
-          <p:nvPr/>
-        </p:nvSpPr>
-        <p:spPr>
-          <a:xfrm>
-            <a:off x="360000" y="1656000"/>
-            <a:ext cx="3311999" cy="3204000"/>
-          </a:xfrm>
-          <a:prstGeom prst="rect">
-            <a:avLst/>
-          </a:prstGeom>
-          <a:solidFill>
-            <a:srgbClr val="1A3A2A"/>
-          </a:solidFill>
-          <a:ln>
-            <a:noFill/>
-          </a:ln>
-        </p:spPr>
-        <p:txBody>
-          <a:bodyPr wrap="square" anchor="t"/>
-          <a:lstStyle/>
-          <a:p>
-            <a:pPr algn="l"/>
-            <a:r>
-              <a:rPr lang="ru-RU" sz="1300" b="0">
-                <a:solidFill>
-                  <a:srgbClr val="CFE0D6"/>
-                </a:solidFill>
-              </a:rPr>
-              <a:t>Организации сортируются по числу</a:t>
-            </a:r>
-          </a:p>
-          <a:p>
-            <a:pPr algn="l"/>
-            <a:r>
-              <a:rPr lang="ru-RU" sz="1300" b="0">
-                <a:solidFill>
-                  <a:srgbClr val="CFE0D6"/>
-                </a:solidFill>
-              </a:rPr>
-              <a:t>зависимых публикаций.</a:t>
-            </a:r>
-          </a:p>
-          <a:p>
-            <a:pPr algn="l"/>
-          </a:p>
-          <a:p>
-            <a:pPr algn="l"/>
-            <a:r>
-              <a:rPr lang="ru-RU" sz="1300" b="0">
-                <a:solidFill>
-                  <a:srgbClr val="CFE0D6"/>
-                </a:solidFill>
-              </a:rPr>
-              <a:t>Первыми обрабатываются те,</a:t>
-            </a:r>
-          </a:p>
-          <a:p>
-            <a:pPr algn="l"/>
-            <a:r>
-              <a:rPr lang="ru-RU" sz="1300" b="0">
-                <a:solidFill>
-                  <a:srgbClr val="CFE0D6"/>
-                </a:solidFill>
-              </a:rPr>
-              <a:t>что «разблокируют» наибольшее</a:t>
-            </a:r>
-          </a:p>
-          <a:p>
-            <a:pPr algn="l"/>
-            <a:r>
-              <a:rPr lang="ru-RU" sz="1300" b="0">
-                <a:solidFill>
-                  <a:srgbClr val="CFE0D6"/>
-                </a:solidFill>
-              </a:rPr>
-              <a:t>количество записей без координат.</a:t>
-            </a:r>
-          </a:p>
-        </p:txBody>
-      </p:sp>
-      <p:sp>
-        <p:nvSpPr>
-          <p:cNvPr id="203" name="s3"/>
-          <p:cNvSpPr txBox="1"/>
-          <p:nvPr/>
-        </p:nvSpPr>
-        <p:spPr>
-          <a:xfrm>
-            <a:off x="4211999" y="1080000"/>
-            <a:ext cx="3311999" cy="576000"/>
-          </a:xfrm>
-          <a:prstGeom prst="rect">
-            <a:avLst/>
-          </a:prstGeom>
-          <a:solidFill>
-            <a:srgbClr val="1A5C3A"/>
-          </a:solidFill>
-          <a:ln>
-            <a:noFill/>
-          </a:ln>
-        </p:spPr>
-        <p:txBody>
-          <a:bodyPr wrap="square" anchor="ctr"/>
-          <a:lstStyle/>
-          <a:p>
-            <a:pPr algn="ctr"/>
-            <a:r>
-              <a:rPr lang="ru-RU" sz="1300" b="1">
-                <a:solidFill>
-                  <a:srgbClr val="FFFFFF"/>
-                </a:solidFill>
-              </a:rPr>
-              <a:t>Этап 2 — OpenAlex API</a:t>
-            </a:r>
-          </a:p>
-        </p:txBody>
-      </p:sp>
-      <p:sp>
-        <p:nvSpPr>
-          <p:cNvPr id="204" name="s4"/>
-          <p:cNvSpPr txBox="1"/>
-          <p:nvPr/>
-        </p:nvSpPr>
-        <p:spPr>
-          <a:xfrm>
-            <a:off x="4211999" y="1656000"/>
-            <a:ext cx="3311999" cy="3204000"/>
-          </a:xfrm>
-          <a:prstGeom prst="rect">
-            <a:avLst/>
-          </a:prstGeom>
-          <a:solidFill>
-            <a:srgbClr val="1A3A2A"/>
-          </a:solidFill>
-          <a:ln>
-            <a:noFill/>
-          </a:ln>
-        </p:spPr>
-        <p:txBody>
-          <a:bodyPr wrap="square" anchor="t"/>
-          <a:lstStyle/>
-          <a:p>
-            <a:pPr algn="l"/>
-            <a:r>
-              <a:rPr lang="ru-RU" sz="1300" b="0">
-                <a:solidFill>
-                  <a:srgbClr val="CFE0D6"/>
-                </a:solidFill>
-              </a:rPr>
-              <a:t>Запрос координат по</a:t>
-            </a:r>
-          </a:p>
-          <a:p>
-            <a:pPr algn="l"/>
-            <a:r>
-              <a:rPr lang="ru-RU" sz="1300" b="0">
-                <a:solidFill>
-                  <a:srgbClr val="CFE0D6"/>
-                </a:solidFill>
-              </a:rPr>
-              <a:t>идентификатору организации</a:t>
-            </a:r>
-          </a:p>
-          <a:p>
-            <a:pPr algn="l"/>
-            <a:r>
-              <a:rPr lang="ru-RU" sz="1300" b="0">
-                <a:solidFill>
-                  <a:srgbClr val="CFE0D6"/>
-                </a:solidFill>
-              </a:rPr>
-              <a:t>через API OpenAlex.</a:t>
-            </a:r>
-          </a:p>
-          <a:p>
-            <a:pPr algn="l"/>
-          </a:p>
-          <a:p>
-            <a:pPr algn="l"/>
-            <a:r>
-              <a:rPr lang="ru-RU" sz="1300" b="0">
-                <a:solidFill>
-                  <a:srgbClr val="CFE0D6"/>
-                </a:solidFill>
-              </a:rPr>
-              <a:t>Результат:</a:t>
-            </a:r>
-          </a:p>
-          <a:p>
-            <a:pPr algn="l"/>
-            <a:r>
-              <a:rPr lang="ru-RU" sz="1300" b="0">
-                <a:solidFill>
-                  <a:srgbClr val="CFE0D6"/>
-                </a:solidFill>
-              </a:rPr>
-              <a:t>78% публикаций с координатами.</a:t>
-            </a:r>
-          </a:p>
-        </p:txBody>
-      </p:sp>
-      <p:sp>
-        <p:nvSpPr>
-          <p:cNvPr id="205" name="s5"/>
-          <p:cNvSpPr txBox="1"/>
-          <p:nvPr/>
-        </p:nvSpPr>
-        <p:spPr>
-          <a:xfrm>
-            <a:off x="8063998" y="1080000"/>
-            <a:ext cx="3311999" cy="576000"/>
-          </a:xfrm>
-          <a:prstGeom prst="rect">
-            <a:avLst/>
-          </a:prstGeom>
-          <a:solidFill>
-            <a:srgbClr val="163126"/>
-          </a:solidFill>
-          <a:ln>
-            <a:noFill/>
-          </a:ln>
-        </p:spPr>
-        <p:txBody>
-          <a:bodyPr wrap="square" anchor="ctr"/>
-          <a:lstStyle/>
-          <a:p>
-            <a:pPr algn="ctr"/>
-            <a:r>
-              <a:rPr lang="ru-RU" sz="1300" b="1">
-                <a:solidFill>
-                  <a:srgbClr val="FFFFFF"/>
-                </a:solidFill>
-              </a:rPr>
-              <a:t>Этап 3 — Photon</a:t>
-            </a:r>
-          </a:p>
-        </p:txBody>
-      </p:sp>
-      <p:sp>
-        <p:nvSpPr>
-          <p:cNvPr id="206" name="s6"/>
-          <p:cNvSpPr txBox="1"/>
-          <p:nvPr/>
-        </p:nvSpPr>
-        <p:spPr>
-          <a:xfrm>
-            <a:off x="8063998" y="1656000"/>
-            <a:ext cx="3311999" cy="3204000"/>
-          </a:xfrm>
-          <a:prstGeom prst="rect">
-            <a:avLst/>
-          </a:prstGeom>
-          <a:solidFill>
-            <a:srgbClr val="0D1F14"/>
-          </a:solidFill>
-          <a:ln>
-            <a:noFill/>
-          </a:ln>
-        </p:spPr>
-        <p:txBody>
-          <a:bodyPr wrap="square" anchor="t"/>
-          <a:lstStyle/>
-          <a:p>
-            <a:pPr algn="l"/>
-            <a:r>
-              <a:rPr lang="ru-RU" sz="1300" b="0">
-                <a:solidFill>
-                  <a:srgbClr val="CFE0D6"/>
-                </a:solidFill>
-              </a:rPr>
-              <a:t>Для аффилиаций без</a:t>
-            </a:r>
-          </a:p>
-          <a:p>
-            <a:pPr algn="l"/>
-            <a:r>
-              <a:rPr lang="ru-RU" sz="1300" b="0">
-                <a:solidFill>
-                  <a:srgbClr val="CFE0D6"/>
-                </a:solidFill>
-              </a:rPr>
-              <a:t>идентификатора — геокодирование</a:t>
-            </a:r>
-          </a:p>
-          <a:p>
-            <a:pPr algn="l"/>
-            <a:r>
-              <a:rPr lang="ru-RU" sz="1300" b="0">
-                <a:solidFill>
-                  <a:srgbClr val="CFE0D6"/>
-                </a:solidFill>
-              </a:rPr>
-              <a:t>по строке названия через Photon</a:t>
-            </a:r>
-          </a:p>
-          <a:p>
-            <a:pPr algn="l"/>
-            <a:r>
-              <a:rPr lang="ru-RU" sz="1300" b="0">
-                <a:solidFill>
-                  <a:srgbClr val="CFE0D6"/>
-                </a:solidFill>
-              </a:rPr>
-              <a:t>(OpenStreetMap).</a:t>
-            </a:r>
-          </a:p>
-          <a:p>
-            <a:pPr algn="l"/>
-          </a:p>
-          <a:p>
-            <a:pPr algn="l"/>
-            <a:r>
-              <a:rPr lang="ru-RU" sz="1300" b="0">
-                <a:solidFill>
-                  <a:srgbClr val="CFE0D6"/>
-                </a:solidFill>
-              </a:rPr>
-              <a:t>Результат: +2,8% публикаций.</a:t>
-            </a:r>
-          </a:p>
-        </p:txBody>
-      </p:sp>
-      <p:sp>
-        <p:nvSpPr>
-          <p:cNvPr id="207" name="s7"/>
-          <p:cNvSpPr txBox="1"/>
-          <p:nvPr/>
-        </p:nvSpPr>
-        <p:spPr>
-          <a:xfrm>
-            <a:off x="3743999" y="2826000"/>
-            <a:ext cx="396000" cy="288000"/>
-          </a:xfrm>
-          <a:prstGeom prst="rect">
-            <a:avLst/>
-          </a:prstGeom>
-          <a:noFill/>
-          <a:ln>
-            <a:noFill/>
-          </a:ln>
-        </p:spPr>
-        <p:txBody>
-          <a:bodyPr wrap="square" anchor="ctr"/>
-          <a:lstStyle/>
-          <a:p>
-            <a:pPr algn="ctr"/>
-            <a:r>
-              <a:rPr lang="ru-RU" sz="2200" b="1">
-                <a:solidFill>
-                  <a:srgbClr val="557766"/>
-                </a:solidFill>
-              </a:rPr>
-              <a:t>→</a:t>
-            </a:r>
-          </a:p>
-        </p:txBody>
-      </p:sp>
-      <p:sp>
-        <p:nvSpPr>
-          <p:cNvPr id="208" name="s8"/>
-          <p:cNvSpPr txBox="1"/>
-          <p:nvPr/>
-        </p:nvSpPr>
-        <p:spPr>
-          <a:xfrm>
-            <a:off x="7595998" y="2826000"/>
-            <a:ext cx="396000" cy="288000"/>
-          </a:xfrm>
-          <a:prstGeom prst="rect">
-            <a:avLst/>
-          </a:prstGeom>
-          <a:noFill/>
-          <a:ln>
-            <a:noFill/>
-          </a:ln>
-        </p:spPr>
-        <p:txBody>
-          <a:bodyPr wrap="square" anchor="ctr"/>
-          <a:lstStyle/>
-          <a:p>
-            <a:pPr algn="ctr"/>
-            <a:r>
-              <a:rPr lang="ru-RU" sz="2200" b="1">
-                <a:solidFill>
-                  <a:srgbClr val="557766"/>
-                </a:solidFill>
-              </a:rPr>
-              <a:t>→</a:t>
-            </a:r>
-          </a:p>
-        </p:txBody>
-      </p:sp>
-      <p:sp>
-        <p:nvSpPr>
-          <p:cNvPr id="209" name="s9"/>
-          <p:cNvSpPr txBox="1"/>
-          <p:nvPr/>
-        </p:nvSpPr>
-        <p:spPr>
-          <a:xfrm>
-            <a:off x="360000" y="5040000"/>
-            <a:ext cx="11520000" cy="540000"/>
-          </a:xfrm>
-          <a:prstGeom prst="rect">
-            <a:avLst/>
-          </a:prstGeom>
-          <a:solidFill>
-            <a:srgbClr val="23613F"/>
-          </a:solidFill>
-          <a:ln>
-            <a:noFill/>
-          </a:ln>
-        </p:spPr>
-        <p:txBody>
-          <a:bodyPr wrap="square" anchor="ctr"/>
-          <a:lstStyle/>
-          <a:p>
-            <a:pPr algn="ctr"/>
-            <a:r>
-              <a:rPr lang="ru-RU" sz="1400" b="1">
-                <a:solidFill>
-                  <a:srgbClr val="FFFFFF"/>
-                </a:solidFill>
-              </a:rPr>
-              <a:t>Итог: 80,8% публикаций с координатами (порог — 75%)</a:t>
+              <a:t>10</a:t>
             </a:r>
           </a:p>
         </p:txBody>

</xml_diff>

<commit_message>
fix(presentation): replace 'Хороплет' with 'По странам' in comparison table
</commit_message>
<xml_diff>
--- a/docs/Визуализация науки на основе метаданных публикаций и журналов.pptx
+++ b/docs/Визуализация науки на основе метаданных публикаций и журналов.pptx
@@ -13342,7 +13342,7 @@
                             <a:srgbClr val="FFFFFF"/>
                           </a:solidFill>
                         </a:rPr>
-                        <a:t>Хороплет</a:t>
+                        <a:t>По странам</a:t>
                       </a:r>
                     </a:p>
                   </a:txBody>
@@ -13364,7 +13364,7 @@
                             <a:srgbClr val="FFFFFF"/>
                           </a:solidFill>
                         </a:rPr>
-                        <a:t>Хороплет</a:t>
+                        <a:t>По странам</a:t>
                       </a:r>
                     </a:p>
                   </a:txBody>
@@ -13408,7 +13408,7 @@
                             <a:srgbClr val="FFFFFF"/>
                           </a:solidFill>
                         </a:rPr>
-                        <a:t>Хороплет</a:t>
+                        <a:t>По странам</a:t>
                       </a:r>
                     </a:p>
                   </a:txBody>
@@ -13452,7 +13452,7 @@
                             <a:srgbClr val="FFFFFF"/>
                           </a:solidFill>
                         </a:rPr>
-                        <a:t>Хороплет</a:t>
+                        <a:t>По странам</a:t>
                       </a:r>
                     </a:p>
                   </a:txBody>

</xml_diff>

<commit_message>
Fix slide 6 comparison table: expand columns to fill slide width
Column widths summed to ~12cm vs 33.9cm slide — table appeared half-empty.
Now col0=3.5cm (labels), cols 1-10=3.0cm each, total ~33.6cm.
</commit_message>
<xml_diff>
--- a/docs/Визуализация науки на основе метаданных публикаций и журналов.pptx
+++ b/docs/Визуализация науки на основе метаданных публикаций и журналов.pptx
@@ -11762,8 +11762,8 @@
           <p:nvPr/>
         </p:nvGraphicFramePr>
         <p:xfrm>
-          <a:off x="100000" y="680000"/>
-          <a:ext cx="11988950" cy="6128000"/>
+          <a:off x="50000" y="680000"/>
+          <a:ext cx="12092000" cy="6128000"/>
         </p:xfrm>
         <a:graphic>
           <a:graphicData uri="http://schemas.openxmlformats.org/drawingml/2006/table">
@@ -11772,79 +11772,79 @@
                 <a:tableStyleId>{5C22544A-7EE6-4342-B048-85BDC9FD1C3A}</a:tableStyleId>
               </a:tblPr>
               <a:tblGrid>
-                <a:gridCol w="1350000">
+                <a:gridCol w="1260000">
                   <a:extLst>
-                    <a:ext uri="{9D8B030D-6E8A-4147-A177-3AD203B41FA5}">
+                    <a:ext uri="{9D8B030D-6E8A-4147-A177-3AD203B41FA5}" cx="12092000">
                       <a16:colId xmlns:a16="http://schemas.microsoft.com/office/drawing/2014/main" val="20000"/>
                     </a:ext>
                   </a:extLst>
                 </a:gridCol>
-                <a:gridCol w="1063895">
+                <a:gridCol w="1083200">
                   <a:extLst>
-                    <a:ext uri="{9D8B030D-6E8A-4147-A177-3AD203B41FA5}">
+                    <a:ext uri="{9D8B030D-6E8A-4147-A177-3AD203B41FA5}" cx="12092000">
                       <a16:colId xmlns:a16="http://schemas.microsoft.com/office/drawing/2014/main" val="20001"/>
                     </a:ext>
                   </a:extLst>
                 </a:gridCol>
-                <a:gridCol w="1063895">
+                <a:gridCol w="1083200">
                   <a:extLst>
-                    <a:ext uri="{9D8B030D-6E8A-4147-A177-3AD203B41FA5}">
+                    <a:ext uri="{9D8B030D-6E8A-4147-A177-3AD203B41FA5}" cx="12092000">
                       <a16:colId xmlns:a16="http://schemas.microsoft.com/office/drawing/2014/main" val="20002"/>
                     </a:ext>
                   </a:extLst>
                 </a:gridCol>
-                <a:gridCol w="1063895">
+                <a:gridCol w="1083200">
                   <a:extLst>
-                    <a:ext uri="{9D8B030D-6E8A-4147-A177-3AD203B41FA5}">
+                    <a:ext uri="{9D8B030D-6E8A-4147-A177-3AD203B41FA5}" cx="12092000">
                       <a16:colId xmlns:a16="http://schemas.microsoft.com/office/drawing/2014/main" val="20003"/>
                     </a:ext>
                   </a:extLst>
                 </a:gridCol>
-                <a:gridCol w="1063895">
+                <a:gridCol w="1083200">
                   <a:extLst>
-                    <a:ext uri="{9D8B030D-6E8A-4147-A177-3AD203B41FA5}">
+                    <a:ext uri="{9D8B030D-6E8A-4147-A177-3AD203B41FA5}" cx="12092000">
                       <a16:colId xmlns:a16="http://schemas.microsoft.com/office/drawing/2014/main" val="20004"/>
                     </a:ext>
                   </a:extLst>
                 </a:gridCol>
-                <a:gridCol w="1063895">
+                <a:gridCol w="1083200">
                   <a:extLst>
-                    <a:ext uri="{9D8B030D-6E8A-4147-A177-3AD203B41FA5}">
+                    <a:ext uri="{9D8B030D-6E8A-4147-A177-3AD203B41FA5}" cx="12092000">
                       <a16:colId xmlns:a16="http://schemas.microsoft.com/office/drawing/2014/main" val="20005"/>
                     </a:ext>
                   </a:extLst>
                 </a:gridCol>
-                <a:gridCol w="1063895">
+                <a:gridCol w="1083200">
                   <a:extLst>
-                    <a:ext uri="{9D8B030D-6E8A-4147-A177-3AD203B41FA5}">
+                    <a:ext uri="{9D8B030D-6E8A-4147-A177-3AD203B41FA5}" cx="12092000">
                       <a16:colId xmlns:a16="http://schemas.microsoft.com/office/drawing/2014/main" val="20006"/>
                     </a:ext>
                   </a:extLst>
                 </a:gridCol>
-                <a:gridCol w="1063895">
+                <a:gridCol w="1083200">
                   <a:extLst>
-                    <a:ext uri="{9D8B030D-6E8A-4147-A177-3AD203B41FA5}">
+                    <a:ext uri="{9D8B030D-6E8A-4147-A177-3AD203B41FA5}" cx="12092000">
                       <a16:colId xmlns:a16="http://schemas.microsoft.com/office/drawing/2014/main" val="20007"/>
                     </a:ext>
                   </a:extLst>
                 </a:gridCol>
-                <a:gridCol w="1063895">
+                <a:gridCol w="1083200">
                   <a:extLst>
-                    <a:ext uri="{9D8B030D-6E8A-4147-A177-3AD203B41FA5}">
+                    <a:ext uri="{9D8B030D-6E8A-4147-A177-3AD203B41FA5}" cx="12092000">
                       <a16:colId xmlns:a16="http://schemas.microsoft.com/office/drawing/2014/main" val="20008"/>
                     </a:ext>
                   </a:extLst>
                 </a:gridCol>
-                <a:gridCol w="1063895">
+                <a:gridCol w="1083200">
                   <a:extLst>
-                    <a:ext uri="{9D8B030D-6E8A-4147-A177-3AD203B41FA5}">
+                    <a:ext uri="{9D8B030D-6E8A-4147-A177-3AD203B41FA5}" cx="12092000">
                       <a16:colId xmlns:a16="http://schemas.microsoft.com/office/drawing/2014/main" val="20009"/>
                     </a:ext>
                   </a:extLst>
                 </a:gridCol>
-                <a:gridCol w="1063895">
+                <a:gridCol w="1083200">
                   <a:extLst>
-                    <a:ext uri="{9D8B030D-6E8A-4147-A177-3AD203B41FA5}">
+                    <a:ext uri="{9D8B030D-6E8A-4147-A177-3AD203B41FA5}" cx="12092000">
                       <a16:colId xmlns:a16="http://schemas.microsoft.com/office/drawing/2014/main" val="20010"/>
                     </a:ext>
                   </a:extLst>
@@ -12086,7 +12086,7 @@
                   </a:tcPr>
                 </a:tc>
                 <a:extLst>
-                  <a:ext uri="{0D108BD9-81ED-4DB2-BD59-A6C34878D82A}">
+                  <a:ext uri="{0D108BD9-81ED-4DB2-BD59-A6C34878D82A}" cx="12092000">
                     <a16:rowId xmlns:a16="http://schemas.microsoft.com/office/drawing/2014/main" val="10000"/>
                   </a:ext>
                 </a:extLst>
@@ -12334,7 +12334,7 @@
                   </a:tcPr>
                 </a:tc>
                 <a:extLst>
-                  <a:ext uri="{0D108BD9-81ED-4DB2-BD59-A6C34878D82A}">
+                  <a:ext uri="{0D108BD9-81ED-4DB2-BD59-A6C34878D82A}" cx="12092000">
                     <a16:rowId xmlns:a16="http://schemas.microsoft.com/office/drawing/2014/main" val="10001"/>
                   </a:ext>
                 </a:extLst>
@@ -12575,7 +12575,7 @@
                   </a:tcPr>
                 </a:tc>
                 <a:extLst>
-                  <a:ext uri="{0D108BD9-81ED-4DB2-BD59-A6C34878D82A}">
+                  <a:ext uri="{0D108BD9-81ED-4DB2-BD59-A6C34878D82A}" cx="12092000">
                     <a16:rowId xmlns:a16="http://schemas.microsoft.com/office/drawing/2014/main" val="10002"/>
                   </a:ext>
                 </a:extLst>
@@ -12816,7 +12816,7 @@
                   </a:tcPr>
                 </a:tc>
                 <a:extLst>
-                  <a:ext uri="{0D108BD9-81ED-4DB2-BD59-A6C34878D82A}">
+                  <a:ext uri="{0D108BD9-81ED-4DB2-BD59-A6C34878D82A}" cx="12092000">
                     <a16:rowId xmlns:a16="http://schemas.microsoft.com/office/drawing/2014/main" val="10003"/>
                   </a:ext>
                 </a:extLst>
@@ -13055,7 +13055,7 @@
                   </a:tcPr>
                 </a:tc>
                 <a:extLst>
-                  <a:ext uri="{0D108BD9-81ED-4DB2-BD59-A6C34878D82A}">
+                  <a:ext uri="{0D108BD9-81ED-4DB2-BD59-A6C34878D82A}" cx="12092000">
                     <a16:rowId xmlns:a16="http://schemas.microsoft.com/office/drawing/2014/main" val="10004"/>
                   </a:ext>
                 </a:extLst>
@@ -13302,7 +13302,7 @@
                   </a:tcPr>
                 </a:tc>
                 <a:extLst>
-                  <a:ext uri="{0D108BD9-81ED-4DB2-BD59-A6C34878D82A}">
+                  <a:ext uri="{0D108BD9-81ED-4DB2-BD59-A6C34878D82A}" cx="12092000">
                     <a16:rowId xmlns:a16="http://schemas.microsoft.com/office/drawing/2014/main" val="10005"/>
                   </a:ext>
                 </a:extLst>
@@ -13551,7 +13551,7 @@
                   </a:tcPr>
                 </a:tc>
                 <a:extLst>
-                  <a:ext uri="{0D108BD9-81ED-4DB2-BD59-A6C34878D82A}">
+                  <a:ext uri="{0D108BD9-81ED-4DB2-BD59-A6C34878D82A}" cx="12092000">
                     <a16:rowId xmlns:a16="http://schemas.microsoft.com/office/drawing/2014/main" val="10006"/>
                   </a:ext>
                 </a:extLst>
@@ -13800,7 +13800,7 @@
                   </a:tcPr>
                 </a:tc>
                 <a:extLst>
-                  <a:ext uri="{0D108BD9-81ED-4DB2-BD59-A6C34878D82A}">
+                  <a:ext uri="{0D108BD9-81ED-4DB2-BD59-A6C34878D82A}" cx="12092000">
                     <a16:rowId xmlns:a16="http://schemas.microsoft.com/office/drawing/2014/main" val="10007"/>
                   </a:ext>
                 </a:extLst>
@@ -14049,7 +14049,7 @@
                   </a:tcPr>
                 </a:tc>
                 <a:extLst>
-                  <a:ext uri="{0D108BD9-81ED-4DB2-BD59-A6C34878D82A}">
+                  <a:ext uri="{0D108BD9-81ED-4DB2-BD59-A6C34878D82A}" cx="12092000">
                     <a16:rowId xmlns:a16="http://schemas.microsoft.com/office/drawing/2014/main" val="10008"/>
                   </a:ext>
                 </a:extLst>
@@ -14298,7 +14298,7 @@
                   </a:tcPr>
                 </a:tc>
                 <a:extLst>
-                  <a:ext uri="{0D108BD9-81ED-4DB2-BD59-A6C34878D82A}">
+                  <a:ext uri="{0D108BD9-81ED-4DB2-BD59-A6C34878D82A}" cx="12092000">
                     <a16:rowId xmlns:a16="http://schemas.microsoft.com/office/drawing/2014/main" val="10009"/>
                   </a:ext>
                 </a:extLst>

</xml_diff>

<commit_message>
Add edge types row to slide 11 (Граф связей)
Same visual style as node types row.
5 edge labels: Год→Статья, Журнал→Статья, Статья→Автор, Статья→Аффил., Статья—Статья
</commit_message>
<xml_diff>
--- a/docs/Визуализация науки на основе метаданных публикаций и журналов.pptx
+++ b/docs/Визуализация науки на основе метаданных публикаций и журналов.pptx
@@ -6089,8 +6089,8 @@
         </p:nvSpPr>
         <p:spPr>
           <a:xfrm>
-            <a:off x="288000" y="5940000"/>
-            <a:ext cx="11520000" cy="648000"/>
+            <a:off x="288000" y="6083600"/>
+            <a:ext cx="11520000" cy="500000"/>
           </a:xfrm>
           <a:prstGeom prst="rect">
             <a:avLst/>
@@ -6228,6 +6228,216 @@
                 </a:solidFill>
               </a:rPr>
               <a:t>11</a:t>
+            </a:r>
+          </a:p>
+        </p:txBody>
+      </p:sp>
+      <p:sp>
+        <p:nvSpPr>
+          <p:cNvPr id="9114" name="TextBox 9114"/>
+          <p:cNvSpPr txBox="1"/>
+          <p:nvPr/>
+        </p:nvSpPr>
+        <p:spPr>
+          <a:xfrm>
+            <a:off x="548640" y="5566400"/>
+            <a:ext cx="1828800" cy="365760"/>
+          </a:xfrm>
+          <a:prstGeom prst="rect">
+            <a:avLst/>
+          </a:prstGeom>
+          <a:noFill/>
+        </p:spPr>
+        <p:txBody>
+          <a:bodyPr wrap="square">
+            <a:spAutoFit/>
+          </a:bodyPr>
+          <a:lstStyle/>
+          <a:p>
+            <a:pPr algn="l"/>
+            <a:r>
+              <a:rPr sz="1100" b="1" i="0">
+                <a:solidFill>
+                  <a:srgbClr val="23613F"/>
+                </a:solidFill>
+                <a:latin typeface="Calibri"/>
+              </a:rPr>
+              <a:t>Типы связей:</a:t>
+            </a:r>
+          </a:p>
+        </p:txBody>
+      </p:sp>
+      <p:sp>
+        <p:nvSpPr>
+          <p:cNvPr id="9115" name="TextBox 9115"/>
+          <p:cNvSpPr txBox="1"/>
+          <p:nvPr/>
+        </p:nvSpPr>
+        <p:spPr>
+          <a:xfrm>
+            <a:off x="2468880" y="5657840"/>
+            <a:ext cx="1645920" cy="365760"/>
+          </a:xfrm>
+          <a:prstGeom prst="rect">
+            <a:avLst/>
+          </a:prstGeom>
+          <a:noFill/>
+        </p:spPr>
+        <p:txBody>
+          <a:bodyPr wrap="square">
+            <a:spAutoFit/>
+          </a:bodyPr>
+          <a:lstStyle/>
+          <a:p>
+            <a:pPr algn="ctr"/>
+            <a:r>
+              <a:rPr sz="1000" b="1" i="0">
+                <a:solidFill>
+                  <a:srgbClr val="CFE0D6"/>
+                </a:solidFill>
+                <a:latin typeface="Calibri"/>
+              </a:rPr>
+              <a:t>Год → Статья</a:t>
+            </a:r>
+          </a:p>
+        </p:txBody>
+      </p:sp>
+      <p:sp>
+        <p:nvSpPr>
+          <p:cNvPr id="9116" name="TextBox 9116"/>
+          <p:cNvSpPr txBox="1"/>
+          <p:nvPr/>
+        </p:nvSpPr>
+        <p:spPr>
+          <a:xfrm>
+            <a:off x="4389120" y="5657840"/>
+            <a:ext cx="1645920" cy="365760"/>
+          </a:xfrm>
+          <a:prstGeom prst="rect">
+            <a:avLst/>
+          </a:prstGeom>
+          <a:noFill/>
+        </p:spPr>
+        <p:txBody>
+          <a:bodyPr wrap="square">
+            <a:spAutoFit/>
+          </a:bodyPr>
+          <a:lstStyle/>
+          <a:p>
+            <a:pPr algn="ctr"/>
+            <a:r>
+              <a:rPr sz="1000" b="1" i="0">
+                <a:solidFill>
+                  <a:srgbClr val="CFE0D6"/>
+                </a:solidFill>
+                <a:latin typeface="Calibri"/>
+              </a:rPr>
+              <a:t>Журнал → Статья</a:t>
+            </a:r>
+          </a:p>
+        </p:txBody>
+      </p:sp>
+      <p:sp>
+        <p:nvSpPr>
+          <p:cNvPr id="9117" name="TextBox 9117"/>
+          <p:cNvSpPr txBox="1"/>
+          <p:nvPr/>
+        </p:nvSpPr>
+        <p:spPr>
+          <a:xfrm>
+            <a:off x="6309360" y="5657840"/>
+            <a:ext cx="1645920" cy="365760"/>
+          </a:xfrm>
+          <a:prstGeom prst="rect">
+            <a:avLst/>
+          </a:prstGeom>
+          <a:noFill/>
+        </p:spPr>
+        <p:txBody>
+          <a:bodyPr wrap="square">
+            <a:spAutoFit/>
+          </a:bodyPr>
+          <a:lstStyle/>
+          <a:p>
+            <a:pPr algn="ctr"/>
+            <a:r>
+              <a:rPr sz="1000" b="1" i="0">
+                <a:solidFill>
+                  <a:srgbClr val="CFE0D6"/>
+                </a:solidFill>
+                <a:latin typeface="Calibri"/>
+              </a:rPr>
+              <a:t>Статья → Автор</a:t>
+            </a:r>
+          </a:p>
+        </p:txBody>
+      </p:sp>
+      <p:sp>
+        <p:nvSpPr>
+          <p:cNvPr id="9118" name="TextBox 9118"/>
+          <p:cNvSpPr txBox="1"/>
+          <p:nvPr/>
+        </p:nvSpPr>
+        <p:spPr>
+          <a:xfrm>
+            <a:off x="8229600" y="5657840"/>
+            <a:ext cx="1645920" cy="365760"/>
+          </a:xfrm>
+          <a:prstGeom prst="rect">
+            <a:avLst/>
+          </a:prstGeom>
+          <a:noFill/>
+        </p:spPr>
+        <p:txBody>
+          <a:bodyPr wrap="square">
+            <a:spAutoFit/>
+          </a:bodyPr>
+          <a:lstStyle/>
+          <a:p>
+            <a:pPr algn="ctr"/>
+            <a:r>
+              <a:rPr sz="1000" b="1" i="0">
+                <a:solidFill>
+                  <a:srgbClr val="CFE0D6"/>
+                </a:solidFill>
+                <a:latin typeface="Calibri"/>
+              </a:rPr>
+              <a:t>Статья → Аффил.</a:t>
+            </a:r>
+          </a:p>
+        </p:txBody>
+      </p:sp>
+      <p:sp>
+        <p:nvSpPr>
+          <p:cNvPr id="9119" name="TextBox 9119"/>
+          <p:cNvSpPr txBox="1"/>
+          <p:nvPr/>
+        </p:nvSpPr>
+        <p:spPr>
+          <a:xfrm>
+            <a:off x="10149840" y="5657840"/>
+            <a:ext cx="1645920" cy="365760"/>
+          </a:xfrm>
+          <a:prstGeom prst="rect">
+            <a:avLst/>
+          </a:prstGeom>
+          <a:noFill/>
+        </p:spPr>
+        <p:txBody>
+          <a:bodyPr wrap="square">
+            <a:spAutoFit/>
+          </a:bodyPr>
+          <a:lstStyle/>
+          <a:p>
+            <a:pPr algn="ctr"/>
+            <a:r>
+              <a:rPr sz="1000" b="1" i="0">
+                <a:solidFill>
+                  <a:srgbClr val="CFE0D6"/>
+                </a:solidFill>
+                <a:latin typeface="Calibri"/>
+              </a:rPr>
+              <a:t>Статья — Статья</a:t>
             </a:r>
           </a:p>
         </p:txBody>

</xml_diff>

<commit_message>
Add score definition to glossary and slide 12
</commit_message>
<xml_diff>
--- a/docs/Визуализация науки на основе метаданных публикаций и журналов.pptx
+++ b/docs/Визуализация науки на основе метаданных публикаций и журналов.pptx
@@ -7000,6 +7000,45 @@
                 </a:solidFill>
               </a:rPr>
               <a:t>12</a:t>
+            </a:r>
+          </a:p>
+        </p:txBody>
+      </p:sp>
+      <p:sp>
+        <p:nvSpPr>
+          <p:cNvPr id="9124" name="TextBox 9124"/>
+          <p:cNvSpPr txBox="1"/>
+          <p:nvPr/>
+        </p:nvSpPr>
+        <p:spPr>
+          <a:xfrm>
+            <a:off x="360000" y="5900000"/>
+            <a:ext cx="11448000" cy="420000"/>
+          </a:xfrm>
+          <a:prstGeom prst="roundRect">
+            <a:avLst>
+              <a:gd name="adj" fmla="val 20000"/>
+            </a:avLst>
+          </a:prstGeom>
+          <a:solidFill>
+            <a:srgbClr val="1A3A2A"/>
+          </a:solidFill>
+        </p:spPr>
+        <p:txBody>
+          <a:bodyPr wrap="square" lIns="91440" rIns="91440" tIns="45720" bIns="45720">
+            <a:spAutoFit/>
+          </a:bodyPr>
+          <a:lstStyle/>
+          <a:p>
+            <a:pPr algn="l"/>
+            <a:r>
+              <a:rPr sz="1000" b="0" i="1">
+                <a:solidFill>
+                  <a:srgbClr val="CFE0D6"/>
+                </a:solidFill>
+                <a:latin typeface="Calibri"/>
+              </a:rPr>
+              <a:t>Балл сходства (score) — целое число близости двух статей по 5 признакам; чем выше — тем ближе. score = 0: статья не показывается.</a:t>
             </a:r>
           </a:p>
         </p:txBody>

</xml_diff>

<commit_message>
Merge user edits: remove DB slide, add ER image, update slide 1, rebuild progress bar
- Removed 'База данных PostgreSQL' slide (now 12 slides total)
- Replaced text-based ER diagram with PNG image from user's version
- Slide 1: added student/supervisor names, removed tech stack line
- Rebuilt progress bar for all 12 slides (1/12 → 12/12)
</commit_message>
<xml_diff>
--- a/docs/Визуализация науки на основе метаданных публикаций и журналов.pptx
+++ b/docs/Визуализация науки на основе метаданных публикаций и журналов.pptx
@@ -15,7 +15,6 @@
     <p:sldId id="257" r:id="rId4"/>
     <p:sldId id="269" r:id="rId5"/>
     <p:sldId id="259" r:id="rId7"/>
-    <p:sldId id="260" r:id="rId8"/>
     <p:sldId id="271" r:id="rId6"/>
     <p:sldId id="261" r:id="rId9"/>
     <p:sldId id="262" r:id="rId10"/>
@@ -4265,14 +4264,14 @@
       </p:sp>
       <p:sp>
         <p:nvSpPr>
-          <p:cNvPr id="6" name="TextBox 5"/>
+          <p:cNvPr id="7" name="TextBox 6"/>
           <p:cNvSpPr txBox="1"/>
           <p:nvPr/>
         </p:nvSpPr>
         <p:spPr>
           <a:xfrm>
-            <a:off x="457200" y="3474720"/>
-            <a:ext cx="11247120" cy="548640"/>
+            <a:off x="457200" y="5486400"/>
+            <a:ext cx="11247120" cy="640080"/>
           </a:xfrm>
           <a:prstGeom prst="rect">
             <a:avLst/>
@@ -4287,48 +4286,13 @@
           <a:p>
             <a:pPr algn="ctr"/>
             <a:r>
-              <a:rPr sz="1700" b="0" i="0">
-                <a:solidFill>
-                  <a:srgbClr val="CFE0D6"/>
+              <a:rPr sz="1800" b="0" i="0">
+                <a:solidFill>
+                  <a:srgbClr val="FFFFFF"/>
                 </a:solidFill>
                 <a:latin typeface="Calibri"/>
               </a:rPr>
-              <a:t>OpenAlex  ·  PostgreSQL  ·  Python  ·  Plotly  ·  SVG</a:t>
-            </a:r>
-          </a:p>
-        </p:txBody>
-      </p:sp>
-      <p:sp>
-        <p:nvSpPr>
-          <p:cNvPr id="7" name="TextBox 6"/>
-          <p:cNvSpPr txBox="1"/>
-          <p:nvPr/>
-        </p:nvSpPr>
-        <p:spPr>
-          <a:xfrm>
-            <a:off x="457200" y="5486400"/>
-            <a:ext cx="11247120" cy="640080"/>
-          </a:xfrm>
-          <a:prstGeom prst="rect">
-            <a:avLst/>
-          </a:prstGeom>
-          <a:noFill/>
-        </p:spPr>
-        <p:txBody>
-          <a:bodyPr wrap="square">
-            <a:spAutoFit/>
-          </a:bodyPr>
-          <a:lstStyle/>
-          <a:p>
-            <a:pPr algn="ctr"/>
-            <a:r>
-              <a:rPr sz="1800" b="0" i="0">
-                <a:solidFill>
-                  <a:srgbClr val="FFFFFF"/>
-                </a:solidFill>
-                <a:latin typeface="Calibri"/>
-              </a:rPr>
-              <a:t>2026</a:t>
+              <a:t>1</a:t>
             </a:r>
           </a:p>
         </p:txBody>
@@ -4369,7 +4333,7 @@
         <p:spPr>
           <a:xfrm>
             <a:off x="0" y="6660000"/>
-            <a:ext cx="812800" cy="198000"/>
+            <a:ext cx="476000" cy="198000"/>
           </a:xfrm>
           <a:prstGeom prst="rect">
             <a:avLst/>
@@ -4395,7 +4359,7 @@
         </p:nvSpPr>
         <p:spPr>
           <a:xfrm>
-            <a:off x="272800" y="6660000"/>
+            <a:off x="476000" y="6660000"/>
             <a:ext cx="540000" cy="198000"/>
           </a:xfrm>
           <a:prstGeom prst="rect">
@@ -4422,7 +4386,7 @@
         </p:nvSpPr>
         <p:spPr>
           <a:xfrm>
-            <a:off x="164800" y="6660000"/>
+            <a:off x="368000" y="6660000"/>
             <a:ext cx="648000" cy="198000"/>
           </a:xfrm>
           <a:prstGeom prst="rect">
@@ -4448,6 +4412,77 @@
               </a:rPr>
               <a:t>1</a:t>
             </a:r>
+          </a:p>
+        </p:txBody>
+      </p:sp>
+      <p:sp>
+        <p:nvSpPr>
+          <p:cNvPr id="6" name="TextBox 5"/>
+          <p:cNvSpPr txBox="1"/>
+          <p:nvPr/>
+        </p:nvSpPr>
+        <p:spPr>
+          <a:xfrm>
+            <a:off x="457200" y="3474720"/>
+            <a:ext cx="11247120" cy="615553"/>
+          </a:xfrm>
+          <a:prstGeom prst="rect">
+            <a:avLst/>
+          </a:prstGeom>
+          <a:noFill/>
+        </p:spPr>
+        <p:txBody>
+          <a:bodyPr wrap="square">
+            <a:spAutoFit/>
+          </a:bodyPr>
+          <a:lstStyle/>
+          <a:p>
+            <a:pPr algn="ctr"/>
+            <a:r>
+              <a:rPr lang="ru-RU" sz="1700" dirty="0" smtClean="0">
+                <a:solidFill>
+                  <a:srgbClr val="CFE0D6"/>
+                </a:solidFill>
+                <a:latin typeface="Calibri"/>
+              </a:rPr>
+              <a:t>Студент: Сурнова Варвара Сергеевна</a:t>
+            </a:r>
+          </a:p>
+          <a:p>
+            <a:pPr algn="ctr"/>
+            <a:r>
+              <a:rPr lang="ru-RU" sz="1700" b="0" i="0" dirty="0" smtClean="0">
+                <a:solidFill>
+                  <a:srgbClr val="CFE0D6"/>
+                </a:solidFill>
+                <a:latin typeface="Calibri"/>
+              </a:rPr>
+              <a:t>Научный руководитель: </a:t>
+            </a:r>
+            <a:r>
+              <a:rPr lang="ru-RU" sz="1700" b="0" i="0" dirty="0" err="1" smtClean="0">
+                <a:solidFill>
+                  <a:srgbClr val="CFE0D6"/>
+                </a:solidFill>
+                <a:latin typeface="Calibri"/>
+              </a:rPr>
+              <a:t>Атаева</a:t>
+            </a:r>
+            <a:r>
+              <a:rPr lang="ru-RU" sz="1700" b="0" i="0" dirty="0" smtClean="0">
+                <a:solidFill>
+                  <a:srgbClr val="CFE0D6"/>
+                </a:solidFill>
+                <a:latin typeface="Calibri"/>
+              </a:rPr>
+              <a:t> Ольга Муратовна</a:t>
+            </a:r>
+            <a:endParaRPr sz="1700" b="0" i="0" dirty="0">
+              <a:solidFill>
+                <a:srgbClr val="CFE0D6"/>
+              </a:solidFill>
+              <a:latin typeface="Calibri"/>
+            </a:endParaRPr>
           </a:p>
         </p:txBody>
       </p:sp>
@@ -5105,7 +5140,7 @@
         <p:spPr>
           <a:xfrm>
             <a:off x="0" y="6660000"/>
-            <a:ext cx="8128000" cy="198000"/>
+            <a:ext cx="8604000" cy="198000"/>
           </a:xfrm>
           <a:prstGeom prst="rect">
             <a:avLst/>
@@ -5131,7 +5166,7 @@
         </p:nvSpPr>
         <p:spPr>
           <a:xfrm>
-            <a:off x="7588000" y="6660000"/>
+            <a:off x="8604000" y="6660000"/>
             <a:ext cx="540000" cy="198000"/>
           </a:xfrm>
           <a:prstGeom prst="rect">
@@ -5158,7 +5193,7 @@
         </p:nvSpPr>
         <p:spPr>
           <a:xfrm>
-            <a:off x="7480000" y="6660000"/>
+            <a:off x="8496000" y="6660000"/>
             <a:ext cx="648000" cy="198000"/>
           </a:xfrm>
           <a:prstGeom prst="rect">
@@ -5182,7 +5217,7 @@
                   <a:srgbClr val="FFFFFF"/>
                 </a:solidFill>
               </a:rPr>
-              <a:t>10</a:t>
+              <a:t>9</a:t>
             </a:r>
           </a:p>
         </p:txBody>
@@ -6150,7 +6185,7 @@
         <p:spPr>
           <a:xfrm>
             <a:off x="0" y="6660000"/>
-            <a:ext cx="8940800" cy="198000"/>
+            <a:ext cx="9620000" cy="198000"/>
           </a:xfrm>
           <a:prstGeom prst="rect">
             <a:avLst/>
@@ -6176,7 +6211,7 @@
         </p:nvSpPr>
         <p:spPr>
           <a:xfrm>
-            <a:off x="8400800" y="6660000"/>
+            <a:off x="9620000" y="6660000"/>
             <a:ext cx="540000" cy="198000"/>
           </a:xfrm>
           <a:prstGeom prst="rect">
@@ -6203,7 +6238,7 @@
         </p:nvSpPr>
         <p:spPr>
           <a:xfrm>
-            <a:off x="8292800" y="6660000"/>
+            <a:off x="9512000" y="6660000"/>
             <a:ext cx="648000" cy="198000"/>
           </a:xfrm>
           <a:prstGeom prst="rect">
@@ -6227,7 +6262,7 @@
                   <a:srgbClr val="FFFFFF"/>
                 </a:solidFill>
               </a:rPr>
-              <a:t>11</a:t>
+              <a:t>10</a:t>
             </a:r>
           </a:p>
         </p:txBody>
@@ -6922,7 +6957,7 @@
         <p:spPr>
           <a:xfrm>
             <a:off x="0" y="6660000"/>
-            <a:ext cx="9753600" cy="198000"/>
+            <a:ext cx="10636000" cy="198000"/>
           </a:xfrm>
           <a:prstGeom prst="rect">
             <a:avLst/>
@@ -6948,7 +6983,7 @@
         </p:nvSpPr>
         <p:spPr>
           <a:xfrm>
-            <a:off x="9213600" y="6660000"/>
+            <a:off x="10636000" y="6660000"/>
             <a:ext cx="540000" cy="198000"/>
           </a:xfrm>
           <a:prstGeom prst="rect">
@@ -6975,7 +7010,7 @@
         </p:nvSpPr>
         <p:spPr>
           <a:xfrm>
-            <a:off x="9105600" y="6660000"/>
+            <a:off x="10528000" y="6660000"/>
             <a:ext cx="648000" cy="198000"/>
           </a:xfrm>
           <a:prstGeom prst="rect">
@@ -6999,7 +7034,7 @@
                   <a:srgbClr val="FFFFFF"/>
                 </a:solidFill>
               </a:rPr>
-              <a:t>12</a:t>
+              <a:t>11</a:t>
             </a:r>
           </a:p>
         </p:txBody>
@@ -7844,7 +7879,7 @@
         </p:nvSpPr>
         <p:spPr>
           <a:xfrm>
-            <a:off x="0" y="5943600"/>
+            <a:off x="11544000" y="5943600"/>
             <a:ext cx="12188952" cy="914400"/>
           </a:xfrm>
           <a:prstGeom prst="rect">
@@ -7951,7 +7986,7 @@
         <p:spPr>
           <a:xfrm>
             <a:off x="0" y="6660000"/>
-            <a:ext cx="12192000" cy="198000"/>
+            <a:ext cx="11652000" cy="198000"/>
           </a:xfrm>
           <a:prstGeom prst="rect">
             <a:avLst/>
@@ -8028,7 +8063,7 @@
                   <a:srgbClr val="FFFFFF"/>
                 </a:solidFill>
               </a:rPr>
-              <a:t>15</a:t>
+              <a:t>12</a:t>
             </a:r>
           </a:p>
         </p:txBody>
@@ -8757,7 +8792,7 @@
         <p:spPr>
           <a:xfrm>
             <a:off x="0" y="6660000"/>
-            <a:ext cx="1625600" cy="198000"/>
+            <a:ext cx="1492000" cy="198000"/>
           </a:xfrm>
           <a:prstGeom prst="rect">
             <a:avLst/>
@@ -8783,7 +8818,7 @@
         </p:nvSpPr>
         <p:spPr>
           <a:xfrm>
-            <a:off x="1085600" y="6660000"/>
+            <a:off x="1492000" y="6660000"/>
             <a:ext cx="540000" cy="198000"/>
           </a:xfrm>
           <a:prstGeom prst="rect">
@@ -8810,7 +8845,7 @@
         </p:nvSpPr>
         <p:spPr>
           <a:xfrm>
-            <a:off x="977600" y="6660000"/>
+            <a:off x="1384000" y="6660000"/>
             <a:ext cx="648000" cy="198000"/>
           </a:xfrm>
           <a:prstGeom prst="rect">
@@ -9032,7 +9067,7 @@
         <p:spPr>
           <a:xfrm>
             <a:off x="0" y="6660000"/>
-            <a:ext cx="2438400" cy="198000"/>
+            <a:ext cx="2508000" cy="198000"/>
           </a:xfrm>
           <a:prstGeom prst="rect">
             <a:avLst/>
@@ -9058,7 +9093,7 @@
         </p:nvSpPr>
         <p:spPr>
           <a:xfrm>
-            <a:off x="1898400" y="6660000"/>
+            <a:off x="2508000" y="6660000"/>
             <a:ext cx="540000" cy="198000"/>
           </a:xfrm>
           <a:prstGeom prst="rect">
@@ -9085,7 +9120,7 @@
         </p:nvSpPr>
         <p:spPr>
           <a:xfrm>
-            <a:off x="1790400" y="6660000"/>
+            <a:off x="2400000" y="6660000"/>
             <a:ext cx="648000" cy="198000"/>
           </a:xfrm>
           <a:prstGeom prst="rect">
@@ -9292,7 +9327,7 @@
                   <a:srgbClr val="1A3A2A"/>
                 </a:solidFill>
               </a:rPr>
-              <a:t>2022</a:t>
+              <a:t>4</a:t>
             </a:r>
           </a:p>
         </p:txBody>
@@ -9947,7 +9982,7 @@
         <p:spPr>
           <a:xfrm>
             <a:off x="0" y="6660000"/>
-            <a:ext cx="3251200" cy="198000"/>
+            <a:ext cx="3524000" cy="198000"/>
           </a:xfrm>
           <a:prstGeom prst="rect">
             <a:avLst/>
@@ -9973,7 +10008,7 @@
         </p:nvSpPr>
         <p:spPr>
           <a:xfrm>
-            <a:off x="2711200" y="6660000"/>
+            <a:off x="3524000" y="6660000"/>
             <a:ext cx="540000" cy="198000"/>
           </a:xfrm>
           <a:prstGeom prst="rect">
@@ -10000,7 +10035,7 @@
         </p:nvSpPr>
         <p:spPr>
           <a:xfrm>
-            <a:off x="2603200" y="6660000"/>
+            <a:off x="3416000" y="6660000"/>
             <a:ext cx="648000" cy="198000"/>
           </a:xfrm>
           <a:prstGeom prst="rect">
@@ -10514,7 +10549,7 @@
         <p:spPr>
           <a:xfrm>
             <a:off x="0" y="6660000"/>
-            <a:ext cx="4064000" cy="198000"/>
+            <a:ext cx="4540000" cy="198000"/>
           </a:xfrm>
           <a:prstGeom prst="rect">
             <a:avLst/>
@@ -10540,7 +10575,7 @@
         </p:nvSpPr>
         <p:spPr>
           <a:xfrm>
-            <a:off x="3524000" y="6660000"/>
+            <a:off x="4540000" y="6660000"/>
             <a:ext cx="540000" cy="198000"/>
           </a:xfrm>
           <a:prstGeom prst="rect">
@@ -10567,7 +10602,7 @@
         </p:nvSpPr>
         <p:spPr>
           <a:xfrm>
-            <a:off x="3416000" y="6660000"/>
+            <a:off x="4432000" y="6660000"/>
             <a:ext cx="648000" cy="198000"/>
           </a:xfrm>
           <a:prstGeom prst="rect">
@@ -11269,7 +11304,7 @@
                             <a:srgbClr val="1F493D"/>
                           </a:solidFill>
                         </a:rPr>
-                        <a:t>2024</a:t>
+                        <a:t>6</a:t>
                       </a:r>
                     </a:p>
                   </a:txBody>
@@ -13289,7 +13324,7 @@
         <p:spPr>
           <a:xfrm>
             <a:off x="0" y="6660000"/>
-            <a:ext cx="4876800" cy="198000"/>
+            <a:ext cx="5556000" cy="198000"/>
           </a:xfrm>
           <a:prstGeom prst="rect">
             <a:avLst/>
@@ -13315,7 +13350,7 @@
         </p:nvSpPr>
         <p:spPr>
           <a:xfrm>
-            <a:off x="4336800" y="6660000"/>
+            <a:off x="5556000" y="6660000"/>
             <a:ext cx="540000" cy="198000"/>
           </a:xfrm>
           <a:prstGeom prst="rect">
@@ -13342,7 +13377,7 @@
         </p:nvSpPr>
         <p:spPr>
           <a:xfrm>
-            <a:off x="4228800" y="6660000"/>
+            <a:off x="5448000" y="6660000"/>
             <a:ext cx="648000" cy="198000"/>
           </a:xfrm>
           <a:prstGeom prst="rect">
@@ -14296,7 +14331,7 @@
         <p:spPr>
           <a:xfrm>
             <a:off x="0" y="6660000"/>
-            <a:ext cx="5689600" cy="198000"/>
+            <a:ext cx="6572000" cy="198000"/>
           </a:xfrm>
           <a:prstGeom prst="rect">
             <a:avLst/>
@@ -14322,7 +14357,7 @@
         </p:nvSpPr>
         <p:spPr>
           <a:xfrm>
-            <a:off x="5149600" y="6660000"/>
+            <a:off x="6572000" y="6660000"/>
             <a:ext cx="540000" cy="198000"/>
           </a:xfrm>
           <a:prstGeom prst="rect">
@@ -14349,7 +14384,7 @@
         </p:nvSpPr>
         <p:spPr>
           <a:xfrm>
-            <a:off x="5041600" y="6660000"/>
+            <a:off x="6464000" y="6660000"/>
             <a:ext cx="648000" cy="198000"/>
           </a:xfrm>
           <a:prstGeom prst="rect">
@@ -14386,7 +14421,7 @@
 </p:sld>
 </file>
 
-<file path=ppt/slides/slide8.xml><?xml version="1.0" encoding="utf-8"?>
+<file path=ppt/slides/slide9.xml><?xml version="1.0" encoding="utf-8"?>
 <p:sld xmlns:a="http://schemas.openxmlformats.org/drawingml/2006/main" xmlns:r="http://schemas.openxmlformats.org/officeDocument/2006/relationships" xmlns:p="http://schemas.openxmlformats.org/presentationml/2006/main">
   <p:cSld>
     <p:spTree>
@@ -14493,733 +14528,42 @@
       </p:sp>
       <p:sp>
         <p:nvSpPr>
-          <p:cNvPr id="4" name="TextBox 3"/>
+          <p:cNvPr id="100" name="sp0"/>
           <p:cNvSpPr txBox="1"/>
           <p:nvPr/>
         </p:nvSpPr>
         <p:spPr>
           <a:xfrm>
-            <a:off x="365760" y="164592"/>
-            <a:ext cx="11430000" cy="685800"/>
+            <a:off x="360000" y="180000"/>
+            <a:ext cx="11448000" cy="684000"/>
           </a:xfrm>
           <a:prstGeom prst="rect">
             <a:avLst/>
           </a:prstGeom>
           <a:noFill/>
-        </p:spPr>
-        <p:txBody>
-          <a:bodyPr wrap="square">
-            <a:spAutoFit/>
-          </a:bodyPr>
-          <a:lstStyle/>
-          <a:p>
-            <a:pPr algn="l"/>
-            <a:r>
-              <a:rPr sz="2600" b="1" i="0">
-                <a:solidFill>
-                  <a:srgbClr val="FFFFFF"/>
-                </a:solidFill>
-                <a:latin typeface="Calibri"/>
-              </a:rPr>
-              <a:t>База данных PostgreSQL</a:t>
-            </a:r>
-          </a:p>
-        </p:txBody>
-      </p:sp>
-      <p:sp>
-        <p:nvSpPr>
-          <p:cNvPr id="6" name="TextBox 5"/>
-          <p:cNvSpPr txBox="1"/>
-          <p:nvPr/>
-        </p:nvSpPr>
-        <p:spPr>
-          <a:xfrm>
-            <a:off x="8412480" y="1143000"/>
-            <a:ext cx="3566160" cy="411480"/>
-          </a:xfrm>
-          <a:prstGeom prst="rect">
-            <a:avLst/>
-          </a:prstGeom>
-          <a:noFill/>
-        </p:spPr>
-        <p:txBody>
-          <a:bodyPr wrap="square">
-            <a:spAutoFit/>
-          </a:bodyPr>
-          <a:lstStyle/>
-          <a:p>
-            <a:pPr algn="l"/>
-            <a:r>
-              <a:rPr sz="1400" b="1" i="0">
-                <a:solidFill>
-                  <a:srgbClr val="23613F"/>
-                </a:solidFill>
-                <a:latin typeface="Calibri"/>
-              </a:rPr>
-              <a:t>Конфигурация: pg_config.py</a:t>
-            </a:r>
-          </a:p>
-        </p:txBody>
-      </p:sp>
-      <p:sp>
-        <p:nvSpPr>
-          <p:cNvPr id="7" name="TextBox 6"/>
-          <p:cNvSpPr txBox="1"/>
-          <p:nvPr/>
-        </p:nvSpPr>
-        <p:spPr>
-          <a:xfrm>
-            <a:off x="8412480" y="1600200"/>
-            <a:ext cx="3566160" cy="2011680"/>
-          </a:xfrm>
-          <a:prstGeom prst="rect">
-            <a:avLst/>
-          </a:prstGeom>
-          <a:noFill/>
-        </p:spPr>
-        <p:txBody>
-          <a:bodyPr wrap="square">
-            <a:spAutoFit/>
-          </a:bodyPr>
-          <a:lstStyle/>
-          <a:p>
-            <a:pPr algn="l"/>
-            <a:r>
-              <a:rPr sz="1200" b="0" i="0">
-                <a:solidFill>
-                  <a:srgbClr val="122017"/>
-                </a:solidFill>
-                <a:latin typeface="Calibri"/>
-              </a:rPr>
-              <a:t>PG_CONFIG = {
-  "host": "localhost",
-  "port": 5432,
-  "dbname": "openalex_db",
-  "client_encoding": "utf8"
-}</a:t>
-            </a:r>
-          </a:p>
-        </p:txBody>
-      </p:sp>
-      <p:sp>
-        <p:nvSpPr>
-          <p:cNvPr id="8" name="TextBox 7"/>
-          <p:cNvSpPr txBox="1"/>
-          <p:nvPr/>
-        </p:nvSpPr>
-        <p:spPr>
-          <a:xfrm>
-            <a:off x="8412480" y="3703320"/>
-            <a:ext cx="3566160" cy="822960"/>
-          </a:xfrm>
-          <a:prstGeom prst="rect">
-            <a:avLst/>
-          </a:prstGeom>
-          <a:noFill/>
-        </p:spPr>
-        <p:txBody>
-          <a:bodyPr wrap="square">
-            <a:spAutoFit/>
-          </a:bodyPr>
-          <a:lstStyle/>
-          <a:p>
-            <a:pPr algn="l"/>
-            <a:r>
-              <a:rPr sz="1200" b="0" i="1">
-                <a:solidFill>
-                  <a:srgbClr val="577166"/>
-                </a:solidFill>
-                <a:latin typeface="Calibri"/>
-              </a:rPr>
-              <a:t>client_encoding: utf8 — обязателен
-на Windows (иначе UnicodeDecodeError)</a:t>
-            </a:r>
-          </a:p>
-        </p:txBody>
-      </p:sp>
-      <p:sp>
-        <p:nvSpPr>
-          <p:cNvPr id="9" name="Rectangle 8"/>
-          <p:cNvSpPr/>
-          <p:nvPr/>
-        </p:nvSpPr>
-        <p:spPr>
-          <a:xfrm>
-            <a:off x="365760" y="5989320"/>
-            <a:ext cx="7772400" cy="548640"/>
-          </a:xfrm>
-          <a:prstGeom prst="rect">
-            <a:avLst/>
-          </a:prstGeom>
-          <a:solidFill>
-            <a:srgbClr val="163126"/>
-          </a:solidFill>
           <a:ln>
             <a:noFill/>
           </a:ln>
         </p:spPr>
-        <p:style>
-          <a:lnRef idx="1">
-            <a:schemeClr val="accent1"/>
-          </a:lnRef>
-          <a:fillRef idx="3">
-            <a:schemeClr val="accent1"/>
-          </a:fillRef>
-          <a:effectRef idx="2">
-            <a:schemeClr val="accent1"/>
-          </a:effectRef>
-          <a:fontRef idx="minor">
-            <a:schemeClr val="lt1"/>
-          </a:fontRef>
-        </p:style>
-        <p:txBody>
-          <a:bodyPr rtlCol="0" anchor="ctr"/>
-          <a:lstStyle/>
-          <a:p>
-            <a:pPr algn="ctr"/>
-            <a:endParaRPr/>
-          </a:p>
-        </p:txBody>
-      </p:sp>
-      <p:sp>
-        <p:nvSpPr>
-          <p:cNvPr id="10" name="TextBox 9"/>
-          <p:cNvSpPr txBox="1"/>
-          <p:nvPr/>
-        </p:nvSpPr>
-        <p:spPr>
-          <a:xfrm>
-            <a:off x="411480" y="6035040"/>
-            <a:ext cx="7680960" cy="457200"/>
-          </a:xfrm>
-          <a:prstGeom prst="rect">
-            <a:avLst/>
-          </a:prstGeom>
-          <a:noFill/>
-        </p:spPr>
-        <p:txBody>
-          <a:bodyPr wrap="square">
-            <a:spAutoFit/>
-          </a:bodyPr>
+        <p:txBody>
+          <a:bodyPr wrap="square" anchor="ctr"/>
           <a:lstStyle/>
           <a:p>
             <a:pPr algn="l"/>
             <a:r>
-              <a:rPr sz="1300" b="0" i="0">
+              <a:rPr lang="ru-RU" sz="2000" b="1">
                 <a:solidFill>
                   <a:srgbClr val="FFFFFF"/>
                 </a:solidFill>
-                <a:latin typeface="Calibri"/>
-              </a:rPr>
-              <a:t>Загрузка: ijson (потоковое чтение 200 МБ) + SAVEPOINT при конфликтах DOI → 9 994 публикаций</a:t>
-            </a:r>
-          </a:p>
-        </p:txBody>
-      </p:sp>
-      <p:graphicFrame>
-        <p:nvGraphicFramePr>
-          <p:cNvPr id="11" name="Table 10"/>
-          <p:cNvGraphicFramePr>
-            <a:graphicFrameLocks noGrp="1"/>
-          </p:cNvGraphicFramePr>
-          <p:nvPr/>
-        </p:nvGraphicFramePr>
-        <p:xfrm>
-          <a:off x="288000" y="1080000"/>
-          <a:ext cx="7920000" cy="4860000"/>
-        </p:xfrm>
-        <a:graphic>
-          <a:graphicData uri="http://schemas.openxmlformats.org/drawingml/2006/table">
-            <a:tbl>
-              <a:tblPr firstRow="1" bandRow="1">
-                <a:tableStyleId>{5C22544A-7EE6-4342-B048-85BDC9FD1C3A}</a:tableStyleId>
-              </a:tblPr>
-              <a:tblGrid>
-                <a:gridCol w="1980000">
-                  <a:extLst>
-                    <a:ext uri="{9D8B030D-6E8A-4147-A177-3AD203B41FA5}">
-                      <a16:colId xmlns:a16="http://schemas.microsoft.com/office/drawing/2014/main" val="20000"/>
-                    </a:ext>
-                  </a:extLst>
-                </a:gridCol>
-                <a:gridCol w="3240000">
-                  <a:extLst>
-                    <a:ext uri="{9D8B030D-6E8A-4147-A177-3AD203B41FA5}">
-                      <a16:colId xmlns:a16="http://schemas.microsoft.com/office/drawing/2014/main" val="20001"/>
-                    </a:ext>
-                  </a:extLst>
-                </a:gridCol>
-                <a:gridCol w="2700000">
-                  <a:extLst>
-                    <a:ext uri="{9D8B030D-6E8A-4147-A177-3AD203B41FA5}">
-                      <a16:colId xmlns:a16="http://schemas.microsoft.com/office/drawing/2014/main" val="20002"/>
-                    </a:ext>
-                  </a:extLst>
-                </a:gridCol>
-              </a:tblGrid>
-              <a:tr h="607500">
-                <a:tc>
-                  <a:txBody>
-                    <a:bodyPr/>
-                    <a:lstStyle/>
-                    <a:p>
-                      <a:r>
-                        <a:rPr sz="1100" b="1">
-                          <a:solidFill>
-                            <a:srgbClr val="FFFFFF"/>
-                          </a:solidFill>
-                        </a:rPr>
-                        <a:t>Таблица</a:t>
-                      </a:r>
-                    </a:p>
-                  </a:txBody>
-                  <a:tcPr>
-                    <a:solidFill>
-                      <a:srgbClr val="2C3E50"/>
-                    </a:solidFill>
-                  </a:tcPr>
-                </a:tc>
-                <a:tc>
-                  <a:txBody>
-                    <a:bodyPr/>
-                    <a:lstStyle/>
-                    <a:p>
-                      <a:r>
-                        <a:rPr sz="1100" b="1">
-                          <a:solidFill>
-                            <a:srgbClr val="FFFFFF"/>
-                          </a:solidFill>
-                        </a:rPr>
-                        <a:t>Назначение</a:t>
-                      </a:r>
-                    </a:p>
-                  </a:txBody>
-                  <a:tcPr>
-                    <a:solidFill>
-                      <a:srgbClr val="2C3E50"/>
-                    </a:solidFill>
-                  </a:tcPr>
-                </a:tc>
-                <a:tc>
-                  <a:txBody>
-                    <a:bodyPr/>
-                    <a:lstStyle/>
-                    <a:p>
-                      <a:r>
-                        <a:rPr sz="1100" b="1">
-                          <a:solidFill>
-                            <a:srgbClr val="FFFFFF"/>
-                          </a:solidFill>
-                        </a:rPr>
-                        <a:t>Ключевые поля</a:t>
-                      </a:r>
-                    </a:p>
-                  </a:txBody>
-                  <a:tcPr>
-                    <a:solidFill>
-                      <a:srgbClr val="2C3E50"/>
-                    </a:solidFill>
-                  </a:tcPr>
-                </a:tc>
-                <a:extLst>
-                  <a:ext uri="{0D108BD9-81ED-4DB2-BD59-A6C34878D82A}">
-                    <a16:rowId xmlns:a16="http://schemas.microsoft.com/office/drawing/2014/main" val="10000"/>
-                  </a:ext>
-                </a:extLst>
-              </a:tr>
-              <a:tr h="607500">
-                <a:tc>
-                  <a:txBody>
-                    <a:bodyPr/>
-                    <a:lstStyle/>
-                    <a:p>
-                      <a:r>
-                        <a:rPr sz="1000" b="1">
-                          <a:solidFill>
-                            <a:srgbClr val="1A5C3A"/>
-                          </a:solidFill>
-                        </a:rPr>
-                        <a:t>journals</a:t>
-                      </a:r>
-                    </a:p>
-                  </a:txBody>
-                  <a:tcPr/>
-                </a:tc>
-                <a:tc>
-                  <a:txBody>
-                    <a:bodyPr/>
-                    <a:lstStyle/>
-                    <a:p>
-                      <a:r>
-                        <a:rPr sz="1000" b="0"/>
-                        <a:t>Научные журналы</a:t>
-                      </a:r>
-                    </a:p>
-                  </a:txBody>
-                  <a:tcPr/>
-                </a:tc>
-                <a:tc>
-                  <a:txBody>
-                    <a:bodyPr/>
-                    <a:lstStyle/>
-                    <a:p>
-                      <a:r>
-                        <a:rPr sz="1000" b="0"/>
-                        <a:t>openalex_id, name, issn</a:t>
-                      </a:r>
-                    </a:p>
-                  </a:txBody>
-                  <a:tcPr/>
-                </a:tc>
-                <a:extLst>
-                  <a:ext uri="{0D108BD9-81ED-4DB2-BD59-A6C34878D82A}">
-                    <a16:rowId xmlns:a16="http://schemas.microsoft.com/office/drawing/2014/main" val="10001"/>
-                  </a:ext>
-                </a:extLst>
-              </a:tr>
-              <a:tr h="607500">
-                <a:tc>
-                  <a:txBody>
-                    <a:bodyPr/>
-                    <a:lstStyle/>
-                    <a:p>
-                      <a:r>
-                        <a:rPr sz="1000" b="1">
-                          <a:solidFill>
-                            <a:srgbClr val="1A5C3A"/>
-                          </a:solidFill>
-                        </a:rPr>
-                        <a:t>publications</a:t>
-                      </a:r>
-                    </a:p>
-                  </a:txBody>
-                  <a:tcPr>
-                    <a:solidFill>
-                      <a:srgbClr val="E8F5ED"/>
-                    </a:solidFill>
-                  </a:tcPr>
-                </a:tc>
-                <a:tc>
-                  <a:txBody>
-                    <a:bodyPr/>
-                    <a:lstStyle/>
-                    <a:p>
-                      <a:r>
-                        <a:rPr sz="1000" b="0"/>
-                        <a:t>Статьи и метаданные</a:t>
-                      </a:r>
-                    </a:p>
-                  </a:txBody>
-                  <a:tcPr>
-                    <a:solidFill>
-                      <a:srgbClr val="E8F5ED"/>
-                    </a:solidFill>
-                  </a:tcPr>
-                </a:tc>
-                <a:tc>
-                  <a:txBody>
-                    <a:bodyPr/>
-                    <a:lstStyle/>
-                    <a:p>
-                      <a:r>
-                        <a:rPr sz="1000" b="0"/>
-                        <a:t>title, doi, year, journal_id</a:t>
-                      </a:r>
-                    </a:p>
-                  </a:txBody>
-                  <a:tcPr>
-                    <a:solidFill>
-                      <a:srgbClr val="E8F5ED"/>
-                    </a:solidFill>
-                  </a:tcPr>
-                </a:tc>
-                <a:extLst>
-                  <a:ext uri="{0D108BD9-81ED-4DB2-BD59-A6C34878D82A}">
-                    <a16:rowId xmlns:a16="http://schemas.microsoft.com/office/drawing/2014/main" val="10002"/>
-                  </a:ext>
-                </a:extLst>
-              </a:tr>
-              <a:tr h="607500">
-                <a:tc>
-                  <a:txBody>
-                    <a:bodyPr/>
-                    <a:lstStyle/>
-                    <a:p>
-                      <a:r>
-                        <a:rPr sz="1000" b="1">
-                          <a:solidFill>
-                            <a:srgbClr val="1A5C3A"/>
-                          </a:solidFill>
-                        </a:rPr>
-                        <a:t>persons</a:t>
-                      </a:r>
-                    </a:p>
-                  </a:txBody>
-                  <a:tcPr/>
-                </a:tc>
-                <a:tc>
-                  <a:txBody>
-                    <a:bodyPr/>
-                    <a:lstStyle/>
-                    <a:p>
-                      <a:r>
-                        <a:rPr sz="1000" b="0"/>
-                        <a:t>Авторы</a:t>
-                      </a:r>
-                    </a:p>
-                  </a:txBody>
-                  <a:tcPr/>
-                </a:tc>
-                <a:tc>
-                  <a:txBody>
-                    <a:bodyPr/>
-                    <a:lstStyle/>
-                    <a:p>
-                      <a:r>
-                        <a:rPr sz="1000" b="0"/>
-                        <a:t>openalex_id, full_name, orcid</a:t>
-                      </a:r>
-                    </a:p>
-                  </a:txBody>
-                  <a:tcPr/>
-                </a:tc>
-                <a:extLst>
-                  <a:ext uri="{0D108BD9-81ED-4DB2-BD59-A6C34878D82A}">
-                    <a16:rowId xmlns:a16="http://schemas.microsoft.com/office/drawing/2014/main" val="10003"/>
-                  </a:ext>
-                </a:extLst>
-              </a:tr>
-              <a:tr h="607500">
-                <a:tc>
-                  <a:txBody>
-                    <a:bodyPr/>
-                    <a:lstStyle/>
-                    <a:p>
-                      <a:r>
-                        <a:rPr sz="1000" b="1">
-                          <a:solidFill>
-                            <a:srgbClr val="1A5C3A"/>
-                          </a:solidFill>
-                        </a:rPr>
-                        <a:t>affiliations</a:t>
-                      </a:r>
-                    </a:p>
-                  </a:txBody>
-                  <a:tcPr>
-                    <a:solidFill>
-                      <a:srgbClr val="E8F5ED"/>
-                    </a:solidFill>
-                  </a:tcPr>
-                </a:tc>
-                <a:tc>
-                  <a:txBody>
-                    <a:bodyPr/>
-                    <a:lstStyle/>
-                    <a:p>
-                      <a:r>
-                        <a:rPr sz="1000" b="0"/>
-                        <a:t>Организации + координаты</a:t>
-                      </a:r>
-                    </a:p>
-                  </a:txBody>
-                  <a:tcPr>
-                    <a:solidFill>
-                      <a:srgbClr val="E8F5ED"/>
-                    </a:solidFill>
-                  </a:tcPr>
-                </a:tc>
-                <a:tc>
-                  <a:txBody>
-                    <a:bodyPr/>
-                    <a:lstStyle/>
-                    <a:p>
-                      <a:r>
-                        <a:rPr sz="1000" b="0"/>
-                        <a:t>institution, latitude, longitude</a:t>
-                      </a:r>
-                    </a:p>
-                  </a:txBody>
-                  <a:tcPr>
-                    <a:solidFill>
-                      <a:srgbClr val="E8F5ED"/>
-                    </a:solidFill>
-                  </a:tcPr>
-                </a:tc>
-                <a:extLst>
-                  <a:ext uri="{0D108BD9-81ED-4DB2-BD59-A6C34878D82A}">
-                    <a16:rowId xmlns:a16="http://schemas.microsoft.com/office/drawing/2014/main" val="10004"/>
-                  </a:ext>
-                </a:extLst>
-              </a:tr>
-              <a:tr h="607500">
-                <a:tc>
-                  <a:txBody>
-                    <a:bodyPr/>
-                    <a:lstStyle/>
-                    <a:p>
-                      <a:r>
-                        <a:rPr sz="1000" b="1">
-                          <a:solidFill>
-                            <a:srgbClr val="1A5C3A"/>
-                          </a:solidFill>
-                        </a:rPr>
-                        <a:t>publication_authors</a:t>
-                      </a:r>
-                    </a:p>
-                  </a:txBody>
-                  <a:tcPr/>
-                </a:tc>
-                <a:tc>
-                  <a:txBody>
-                    <a:bodyPr/>
-                    <a:lstStyle/>
-                    <a:p>
-                      <a:r>
-                        <a:rPr sz="1000" b="0"/>
-                        <a:t>Публикация ↔ Автор</a:t>
-                      </a:r>
-                    </a:p>
-                  </a:txBody>
-                  <a:tcPr/>
-                </a:tc>
-                <a:tc>
-                  <a:txBody>
-                    <a:bodyPr/>
-                    <a:lstStyle/>
-                    <a:p>
-                      <a:r>
-                        <a:rPr sz="1000" b="0"/>
-                        <a:t>publication_id, person_id</a:t>
-                      </a:r>
-                    </a:p>
-                  </a:txBody>
-                  <a:tcPr/>
-                </a:tc>
-                <a:extLst>
-                  <a:ext uri="{0D108BD9-81ED-4DB2-BD59-A6C34878D82A}">
-                    <a16:rowId xmlns:a16="http://schemas.microsoft.com/office/drawing/2014/main" val="10005"/>
-                  </a:ext>
-                </a:extLst>
-              </a:tr>
-              <a:tr h="607500">
-                <a:tc>
-                  <a:txBody>
-                    <a:bodyPr/>
-                    <a:lstStyle/>
-                    <a:p>
-                      <a:r>
-                        <a:rPr sz="1000" b="1">
-                          <a:solidFill>
-                            <a:srgbClr val="1A5C3A"/>
-                          </a:solidFill>
-                        </a:rPr>
-                        <a:t>publication_topics</a:t>
-                      </a:r>
-                    </a:p>
-                  </a:txBody>
-                  <a:tcPr>
-                    <a:solidFill>
-                      <a:srgbClr val="E8F5ED"/>
-                    </a:solidFill>
-                  </a:tcPr>
-                </a:tc>
-                <a:tc>
-                  <a:txBody>
-                    <a:bodyPr/>
-                    <a:lstStyle/>
-                    <a:p>
-                      <a:r>
-                        <a:rPr sz="1000" b="0"/>
-                        <a:t>Тематические классификаторы</a:t>
-                      </a:r>
-                    </a:p>
-                  </a:txBody>
-                  <a:tcPr>
-                    <a:solidFill>
-                      <a:srgbClr val="E8F5ED"/>
-                    </a:solidFill>
-                  </a:tcPr>
-                </a:tc>
-                <a:tc>
-                  <a:txBody>
-                    <a:bodyPr/>
-                    <a:lstStyle/>
-                    <a:p>
-                      <a:r>
-                        <a:rPr sz="1000" b="0"/>
-                        <a:t>topic_name, score</a:t>
-                      </a:r>
-                    </a:p>
-                  </a:txBody>
-                  <a:tcPr>
-                    <a:solidFill>
-                      <a:srgbClr val="E8F5ED"/>
-                    </a:solidFill>
-                  </a:tcPr>
-                </a:tc>
-                <a:extLst>
-                  <a:ext uri="{0D108BD9-81ED-4DB2-BD59-A6C34878D82A}">
-                    <a16:rowId xmlns:a16="http://schemas.microsoft.com/office/drawing/2014/main" val="10006"/>
-                  </a:ext>
-                </a:extLst>
-              </a:tr>
-              <a:tr h="607500">
-                <a:tc>
-                  <a:txBody>
-                    <a:bodyPr/>
-                    <a:lstStyle/>
-                    <a:p>
-                      <a:r>
-                        <a:rPr sz="1000" b="1">
-                          <a:solidFill>
-                            <a:srgbClr val="1A5C3A"/>
-                          </a:solidFill>
-                        </a:rPr>
-                        <a:t>publication_keywords</a:t>
-                      </a:r>
-                    </a:p>
-                  </a:txBody>
-                  <a:tcPr/>
-                </a:tc>
-                <a:tc>
-                  <a:txBody>
-                    <a:bodyPr/>
-                    <a:lstStyle/>
-                    <a:p>
-                      <a:r>
-                        <a:rPr sz="1000" b="0"/>
-                        <a:t>Ключевые слова</a:t>
-                      </a:r>
-                    </a:p>
-                  </a:txBody>
-                  <a:tcPr/>
-                </a:tc>
-                <a:tc>
-                  <a:txBody>
-                    <a:bodyPr/>
-                    <a:lstStyle/>
-                    <a:p>
-                      <a:r>
-                        <a:rPr sz="1000" b="0"/>
-                        <a:t>keyword_name, score</a:t>
-                      </a:r>
-                    </a:p>
-                  </a:txBody>
-                  <a:tcPr/>
-                </a:tc>
-                <a:extLst>
-                  <a:ext uri="{0D108BD9-81ED-4DB2-BD59-A6C34878D82A}">
-                    <a16:rowId xmlns:a16="http://schemas.microsoft.com/office/drawing/2014/main" val="10007"/>
-                  </a:ext>
-                </a:extLst>
-              </a:tr>
-            </a:tbl>
-          </a:graphicData>
-        </a:graphic>
-      </p:graphicFrame>
-      <p:sp>
-        <p:nvSpPr>
-          <p:cNvPr id="9080" name="pb80"/>
+              </a:rPr>
+              <a:t>База данных — схема связей (ER-диаграмма)</a:t>
+            </a:r>
+          </a:p>
+        </p:txBody>
+      </p:sp>
+      <p:sp>
+        <p:nvSpPr>
+          <p:cNvPr id="9090" name="pb90"/>
           <p:cNvSpPr txBox="1"/>
           <p:nvPr/>
         </p:nvSpPr>
@@ -15241,19 +14585,21 @@
         <p:txBody>
           <a:bodyPr wrap="none" anchor="ctr"/>
           <a:lstStyle/>
-          <a:p/>
-        </p:txBody>
-      </p:sp>
-      <p:sp>
-        <p:nvSpPr>
-          <p:cNvPr id="9081" name="pb81"/>
+          <a:p>
+            <a:endParaRPr/>
+          </a:p>
+        </p:txBody>
+      </p:sp>
+      <p:sp>
+        <p:nvSpPr>
+          <p:cNvPr id="9091" name="pb91"/>
           <p:cNvSpPr txBox="1"/>
           <p:nvPr/>
         </p:nvSpPr>
         <p:spPr>
           <a:xfrm>
             <a:off x="0" y="6660000"/>
-            <a:ext cx="6502400" cy="198000"/>
+            <a:ext cx="7588000" cy="198000"/>
           </a:xfrm>
           <a:prstGeom prst="rect">
             <a:avLst/>
@@ -15268,18 +14614,20 @@
         <p:txBody>
           <a:bodyPr wrap="none" anchor="ctr"/>
           <a:lstStyle/>
-          <a:p/>
-        </p:txBody>
-      </p:sp>
-      <p:sp>
-        <p:nvSpPr>
-          <p:cNvPr id="9082" name="pb82"/>
+          <a:p>
+            <a:endParaRPr/>
+          </a:p>
+        </p:txBody>
+      </p:sp>
+      <p:sp>
+        <p:nvSpPr>
+          <p:cNvPr id="9092" name="pb92"/>
           <p:cNvSpPr txBox="1"/>
           <p:nvPr/>
         </p:nvSpPr>
         <p:spPr>
           <a:xfrm>
-            <a:off x="5962400" y="6660000"/>
+            <a:off x="7588000" y="6660000"/>
             <a:ext cx="540000" cy="198000"/>
           </a:xfrm>
           <a:prstGeom prst="rect">
@@ -15295,18 +14643,20 @@
         <p:txBody>
           <a:bodyPr wrap="none" anchor="ctr"/>
           <a:lstStyle/>
-          <a:p/>
-        </p:txBody>
-      </p:sp>
-      <p:sp>
-        <p:nvSpPr>
-          <p:cNvPr id="9083" name="pb83"/>
+          <a:p>
+            <a:endParaRPr/>
+          </a:p>
+        </p:txBody>
+      </p:sp>
+      <p:sp>
+        <p:nvSpPr>
+          <p:cNvPr id="9093" name="pb93"/>
           <p:cNvSpPr txBox="1"/>
           <p:nvPr/>
         </p:nvSpPr>
         <p:spPr>
           <a:xfrm>
-            <a:off x="5854400" y="6660000"/>
+            <a:off x="7480000" y="6660000"/>
             <a:ext cx="648000" cy="198000"/>
           </a:xfrm>
           <a:prstGeom prst="rect">
@@ -15335,1063 +14685,30 @@
           </a:p>
         </p:txBody>
       </p:sp>
-    </p:spTree>
-  </p:cSld>
-  <p:clrMapOvr>
-    <a:masterClrMapping/>
-  </p:clrMapOvr>
-</p:sld>
-</file>
-
-<file path=ppt/slides/slide9.xml><?xml version="1.0" encoding="utf-8"?>
-<p:sld xmlns:a="http://schemas.openxmlformats.org/drawingml/2006/main" xmlns:p="http://schemas.openxmlformats.org/presentationml/2006/main" xmlns:r="http://schemas.openxmlformats.org/officeDocument/2006/relationships">
-  <p:cSld>
-    <p:spTree>
-      <p:nvGrpSpPr>
-        <p:cNvPr id="1" name=""/>
-        <p:cNvGrpSpPr/>
-        <p:nvPr/>
-      </p:nvGrpSpPr>
-      <p:grpSpPr/>
-      <p:sp>
-        <p:nvSpPr>
-          <p:cNvPr id="2" name="Rectangle 1"/>
-          <p:cNvSpPr/>
-          <p:nvPr/>
-        </p:nvSpPr>
-        <p:spPr>
-          <a:xfrm>
-            <a:off x="0" y="0"/>
-            <a:ext cx="12188952" cy="6858000"/>
-          </a:xfrm>
-          <a:prstGeom prst="rect">
-            <a:avLst/>
-          </a:prstGeom>
-          <a:solidFill>
-            <a:srgbClr val="F7FBF8"/>
-          </a:solidFill>
-          <a:ln>
-            <a:noFill/>
-          </a:ln>
-        </p:spPr>
-        <p:style>
-          <a:lnRef idx="1">
-            <a:schemeClr val="accent1"/>
-          </a:lnRef>
-          <a:fillRef idx="3">
-            <a:schemeClr val="accent1"/>
-          </a:fillRef>
-          <a:effectRef idx="2">
-            <a:schemeClr val="accent1"/>
-          </a:effectRef>
-          <a:fontRef idx="minor">
-            <a:schemeClr val="lt1"/>
-          </a:fontRef>
-        </p:style>
-        <p:txBody>
-          <a:bodyPr rtlCol="0" anchor="ctr"/>
-          <a:lstStyle/>
-          <a:p>
-            <a:pPr algn="ctr"/>
-            <a:endParaRPr/>
-          </a:p>
-        </p:txBody>
-      </p:sp>
-      <p:sp>
-        <p:nvSpPr>
-          <p:cNvPr id="3" name="Rectangle 2"/>
-          <p:cNvSpPr/>
-          <p:nvPr/>
-        </p:nvSpPr>
-        <p:spPr>
-          <a:xfrm>
-            <a:off x="0" y="0"/>
-            <a:ext cx="12188952" cy="1005840"/>
-          </a:xfrm>
-          <a:prstGeom prst="rect">
-            <a:avLst/>
-          </a:prstGeom>
-          <a:solidFill>
-            <a:srgbClr val="163126"/>
-          </a:solidFill>
-          <a:ln>
-            <a:noFill/>
-          </a:ln>
-        </p:spPr>
-        <p:style>
-          <a:lnRef idx="1">
-            <a:schemeClr val="accent1"/>
-          </a:lnRef>
-          <a:fillRef idx="3">
-            <a:schemeClr val="accent1"/>
-          </a:fillRef>
-          <a:effectRef idx="2">
-            <a:schemeClr val="accent1"/>
-          </a:effectRef>
-          <a:fontRef idx="minor">
-            <a:schemeClr val="lt1"/>
-          </a:fontRef>
-        </p:style>
-        <p:txBody>
-          <a:bodyPr rtlCol="0" anchor="ctr"/>
-          <a:lstStyle/>
-          <a:p>
-            <a:pPr algn="ctr"/>
-            <a:endParaRPr/>
-          </a:p>
-        </p:txBody>
-      </p:sp>
-      <p:sp>
-        <p:nvSpPr>
-          <p:cNvPr id="100" name="sp0"/>
-          <p:cNvSpPr txBox="1"/>
-          <p:nvPr/>
-        </p:nvSpPr>
-        <p:spPr>
-          <a:xfrm>
-            <a:off x="360000" y="180000"/>
-            <a:ext cx="11448000" cy="684000"/>
-          </a:xfrm>
-          <a:prstGeom prst="rect">
-            <a:avLst/>
-          </a:prstGeom>
-          <a:noFill/>
-          <a:ln>
-            <a:noFill/>
-          </a:ln>
-        </p:spPr>
-        <p:txBody>
-          <a:bodyPr wrap="square" anchor="ctr"/>
-          <a:lstStyle/>
-          <a:p>
-            <a:pPr algn="l"/>
-            <a:r>
-              <a:rPr lang="ru-RU" sz="2000" b="1">
-                <a:solidFill>
-                  <a:srgbClr val="FFFFFF"/>
-                </a:solidFill>
-              </a:rPr>
-              <a:t>База данных — схема связей (ER-диаграмма)</a:t>
-            </a:r>
-          </a:p>
-        </p:txBody>
-      </p:sp>
-      <p:sp>
-        <p:nvSpPr>
-          <p:cNvPr id="101" name="sp1"/>
-          <p:cNvSpPr txBox="1"/>
-          <p:nvPr/>
-        </p:nvSpPr>
-        <p:spPr>
-          <a:xfrm>
-            <a:off x="4968000" y="1080000"/>
-            <a:ext cx="2160000" cy="270000"/>
-          </a:xfrm>
-          <a:prstGeom prst="roundRect">
-            <a:avLst>
-              <a:gd name="adj" fmla="val 20000"/>
-            </a:avLst>
-          </a:prstGeom>
-          <a:solidFill>
-            <a:srgbClr val="1A5C3A"/>
-          </a:solidFill>
-          <a:ln>
-            <a:noFill/>
-          </a:ln>
-        </p:spPr>
-        <p:txBody>
-          <a:bodyPr wrap="square" anchor="ctr"/>
-          <a:lstStyle/>
-          <a:p>
-            <a:pPr algn="ctr"/>
-            <a:r>
-              <a:rPr lang="ru-RU" sz="1000" b="1">
-                <a:solidFill>
-                  <a:srgbClr val="FFFFFF"/>
-                </a:solidFill>
-              </a:rPr>
-              <a:t>journals</a:t>
-            </a:r>
-          </a:p>
-        </p:txBody>
-      </p:sp>
-      <p:sp>
-        <p:nvSpPr>
-          <p:cNvPr id="102" name="sp2"/>
-          <p:cNvSpPr txBox="1"/>
-          <p:nvPr/>
-        </p:nvSpPr>
-        <p:spPr>
-          <a:xfrm>
-            <a:off x="4968000" y="1350000"/>
-            <a:ext cx="2160000" cy="810000"/>
-          </a:xfrm>
-          <a:prstGeom prst="rect">
-            <a:avLst/>
-          </a:prstGeom>
-          <a:solidFill>
-            <a:srgbClr val="F0F4F8"/>
-          </a:solidFill>
-          <a:ln w="12700">
-            <a:solidFill>
-              <a:srgbClr val="1A5C3A"/>
-            </a:solidFill>
-          </a:ln>
-        </p:spPr>
-        <p:txBody>
-          <a:bodyPr wrap="square" anchor="ctr"/>
-          <a:lstStyle/>
-          <a:p>
-            <a:pPr algn="l"/>
-            <a:r>
-              <a:rPr lang="ru-RU" sz="900" b="0">
-                <a:solidFill>
-                  <a:srgbClr val="222222"/>
-                </a:solidFill>
-              </a:rPr>
-              <a:t>openalex_id</a:t>
-            </a:r>
-          </a:p>
-          <a:p>
-            <a:pPr algn="l"/>
-            <a:r>
-              <a:rPr lang="ru-RU" sz="900" b="0">
-                <a:solidFill>
-                  <a:srgbClr val="222222"/>
-                </a:solidFill>
-              </a:rPr>
-              <a:t>name · issn</a:t>
-            </a:r>
-          </a:p>
-        </p:txBody>
-      </p:sp>
-      <p:sp>
-        <p:nvSpPr>
-          <p:cNvPr id="103" name="sp3"/>
-          <p:cNvSpPr txBox="1"/>
-          <p:nvPr/>
-        </p:nvSpPr>
-        <p:spPr>
-          <a:xfrm>
-            <a:off x="4968000" y="2700000"/>
-            <a:ext cx="2160000" cy="270000"/>
-          </a:xfrm>
-          <a:prstGeom prst="roundRect">
-            <a:avLst>
-              <a:gd name="adj" fmla="val 20000"/>
-            </a:avLst>
-          </a:prstGeom>
-          <a:solidFill>
-            <a:srgbClr val="1A3A2A"/>
-          </a:solidFill>
-          <a:ln>
-            <a:noFill/>
-          </a:ln>
-        </p:spPr>
-        <p:txBody>
-          <a:bodyPr wrap="square" anchor="ctr"/>
-          <a:lstStyle/>
-          <a:p>
-            <a:pPr algn="ctr"/>
-            <a:r>
-              <a:rPr lang="ru-RU" sz="1000" b="1">
-                <a:solidFill>
-                  <a:srgbClr val="FFFFFF"/>
-                </a:solidFill>
-              </a:rPr>
-              <a:t>publications</a:t>
-            </a:r>
-          </a:p>
-        </p:txBody>
-      </p:sp>
-      <p:sp>
-        <p:nvSpPr>
-          <p:cNvPr id="104" name="sp4"/>
-          <p:cNvSpPr txBox="1"/>
-          <p:nvPr/>
-        </p:nvSpPr>
-        <p:spPr>
-          <a:xfrm>
-            <a:off x="4968000" y="2970000"/>
-            <a:ext cx="2160000" cy="810000"/>
-          </a:xfrm>
-          <a:prstGeom prst="rect">
-            <a:avLst/>
-          </a:prstGeom>
-          <a:solidFill>
-            <a:srgbClr val="F0F4F8"/>
-          </a:solidFill>
-          <a:ln w="12700">
-            <a:solidFill>
-              <a:srgbClr val="1A3A2A"/>
-            </a:solidFill>
-          </a:ln>
-        </p:spPr>
-        <p:txBody>
-          <a:bodyPr wrap="square" anchor="ctr"/>
-          <a:lstStyle/>
-          <a:p>
-            <a:pPr algn="l"/>
-            <a:r>
-              <a:rPr lang="ru-RU" sz="900" b="0">
-                <a:solidFill>
-                  <a:srgbClr val="222222"/>
-                </a:solidFill>
-              </a:rPr>
-              <a:t>id · title · doi</a:t>
-            </a:r>
-          </a:p>
-          <a:p>
-            <a:pPr algn="l"/>
-            <a:r>
-              <a:rPr lang="ru-RU" sz="900" b="0">
-                <a:solidFill>
-                  <a:srgbClr val="222222"/>
-                </a:solidFill>
-              </a:rPr>
-              <a:t>year · journal_id →</a:t>
-            </a:r>
-          </a:p>
-        </p:txBody>
-      </p:sp>
-      <p:sp>
-        <p:nvSpPr>
-          <p:cNvPr id="105" name="sp5"/>
-          <p:cNvSpPr txBox="1"/>
-          <p:nvPr/>
-        </p:nvSpPr>
-        <p:spPr>
-          <a:xfrm>
-            <a:off x="8100000" y="2700000"/>
-            <a:ext cx="2160000" cy="270000"/>
-          </a:xfrm>
-          <a:prstGeom prst="roundRect">
-            <a:avLst>
-              <a:gd name="adj" fmla="val 20000"/>
-            </a:avLst>
-          </a:prstGeom>
-          <a:solidFill>
-            <a:srgbClr val="1A5C3A"/>
-          </a:solidFill>
-          <a:ln>
-            <a:noFill/>
-          </a:ln>
-        </p:spPr>
-        <p:txBody>
-          <a:bodyPr wrap="square" anchor="ctr"/>
-          <a:lstStyle/>
-          <a:p>
-            <a:pPr algn="ctr"/>
-            <a:r>
-              <a:rPr lang="ru-RU" sz="1000" b="1">
-                <a:solidFill>
-                  <a:srgbClr val="FFFFFF"/>
-                </a:solidFill>
-              </a:rPr>
-              <a:t>publication_authors</a:t>
-            </a:r>
-          </a:p>
-        </p:txBody>
-      </p:sp>
-      <p:sp>
-        <p:nvSpPr>
-          <p:cNvPr id="106" name="sp6"/>
-          <p:cNvSpPr txBox="1"/>
-          <p:nvPr/>
-        </p:nvSpPr>
-        <p:spPr>
-          <a:xfrm>
-            <a:off x="8100000" y="2970000"/>
-            <a:ext cx="2160000" cy="810000"/>
-          </a:xfrm>
-          <a:prstGeom prst="rect">
-            <a:avLst/>
-          </a:prstGeom>
-          <a:solidFill>
-            <a:srgbClr val="F0F4F8"/>
-          </a:solidFill>
-          <a:ln w="12700">
-            <a:solidFill>
-              <a:srgbClr val="1A5C3A"/>
-            </a:solidFill>
-          </a:ln>
-        </p:spPr>
-        <p:txBody>
-          <a:bodyPr wrap="square" anchor="ctr"/>
-          <a:lstStyle/>
-          <a:p>
-            <a:pPr algn="l"/>
-            <a:r>
-              <a:rPr lang="ru-RU" sz="900" b="0">
-                <a:solidFill>
-                  <a:srgbClr val="222222"/>
-                </a:solidFill>
-              </a:rPr>
-              <a:t>publication_id →</a:t>
-            </a:r>
-          </a:p>
-          <a:p>
-            <a:pPr algn="l"/>
-            <a:r>
-              <a:rPr lang="ru-RU" sz="900" b="0">
-                <a:solidFill>
-                  <a:srgbClr val="222222"/>
-                </a:solidFill>
-              </a:rPr>
-              <a:t>person_id →</a:t>
-            </a:r>
-          </a:p>
-        </p:txBody>
-      </p:sp>
-      <p:sp>
-        <p:nvSpPr>
-          <p:cNvPr id="107" name="sp7"/>
-          <p:cNvSpPr txBox="1"/>
-          <p:nvPr/>
-        </p:nvSpPr>
-        <p:spPr>
-          <a:xfrm>
-            <a:off x="8100000" y="4392000"/>
-            <a:ext cx="2160000" cy="270000"/>
-          </a:xfrm>
-          <a:prstGeom prst="roundRect">
-            <a:avLst>
-              <a:gd name="adj" fmla="val 20000"/>
-            </a:avLst>
-          </a:prstGeom>
-          <a:solidFill>
-            <a:srgbClr val="1A5C3A"/>
-          </a:solidFill>
-          <a:ln>
-            <a:noFill/>
-          </a:ln>
-        </p:spPr>
-        <p:txBody>
-          <a:bodyPr wrap="square" anchor="ctr"/>
-          <a:lstStyle/>
-          <a:p>
-            <a:pPr algn="ctr"/>
-            <a:r>
-              <a:rPr lang="ru-RU" sz="1000" b="1">
-                <a:solidFill>
-                  <a:srgbClr val="FFFFFF"/>
-                </a:solidFill>
-              </a:rPr>
-              <a:t>persons</a:t>
-            </a:r>
-          </a:p>
-        </p:txBody>
-      </p:sp>
-      <p:sp>
-        <p:nvSpPr>
-          <p:cNvPr id="108" name="sp8"/>
-          <p:cNvSpPr txBox="1"/>
-          <p:nvPr/>
-        </p:nvSpPr>
-        <p:spPr>
-          <a:xfrm>
-            <a:off x="8100000" y="4662000"/>
-            <a:ext cx="2160000" cy="810000"/>
-          </a:xfrm>
-          <a:prstGeom prst="rect">
-            <a:avLst/>
-          </a:prstGeom>
-          <a:solidFill>
-            <a:srgbClr val="F0F4F8"/>
-          </a:solidFill>
-          <a:ln w="12700">
-            <a:solidFill>
-              <a:srgbClr val="1A5C3A"/>
-            </a:solidFill>
-          </a:ln>
-        </p:spPr>
-        <p:txBody>
-          <a:bodyPr wrap="square" anchor="ctr"/>
-          <a:lstStyle/>
-          <a:p>
-            <a:pPr algn="l"/>
-            <a:r>
-              <a:rPr lang="ru-RU" sz="900" b="0">
-                <a:solidFill>
-                  <a:srgbClr val="222222"/>
-                </a:solidFill>
-              </a:rPr>
-              <a:t>openalex_id</a:t>
-            </a:r>
-          </a:p>
-          <a:p>
-            <a:pPr algn="l"/>
-            <a:r>
-              <a:rPr lang="ru-RU" sz="900" b="0">
-                <a:solidFill>
-                  <a:srgbClr val="222222"/>
-                </a:solidFill>
-              </a:rPr>
-              <a:t>full_name · orcid</a:t>
-            </a:r>
-          </a:p>
-        </p:txBody>
-      </p:sp>
-      <p:sp>
-        <p:nvSpPr>
-          <p:cNvPr id="109" name="sp9"/>
-          <p:cNvSpPr txBox="1"/>
-          <p:nvPr/>
-        </p:nvSpPr>
-        <p:spPr>
-          <a:xfrm>
-            <a:off x="10368000" y="4392000"/>
-            <a:ext cx="2160000" cy="270000"/>
-          </a:xfrm>
-          <a:prstGeom prst="roundRect">
-            <a:avLst>
-              <a:gd name="adj" fmla="val 20000"/>
-            </a:avLst>
-          </a:prstGeom>
-          <a:solidFill>
-            <a:srgbClr val="2D5544"/>
-          </a:solidFill>
-          <a:ln>
-            <a:noFill/>
-          </a:ln>
-        </p:spPr>
-        <p:txBody>
-          <a:bodyPr wrap="square" anchor="ctr"/>
-          <a:lstStyle/>
-          <a:p>
-            <a:pPr algn="ctr"/>
-            <a:r>
-              <a:rPr lang="ru-RU" sz="1000" b="1">
-                <a:solidFill>
-                  <a:srgbClr val="FFFFFF"/>
-                </a:solidFill>
-              </a:rPr>
-              <a:t>affiliations</a:t>
-            </a:r>
-          </a:p>
-        </p:txBody>
-      </p:sp>
-      <p:sp>
-        <p:nvSpPr>
-          <p:cNvPr id="110" name="sp10"/>
-          <p:cNvSpPr txBox="1"/>
-          <p:nvPr/>
-        </p:nvSpPr>
-        <p:spPr>
-          <a:xfrm>
-            <a:off x="10368000" y="4662000"/>
-            <a:ext cx="2160000" cy="810000"/>
-          </a:xfrm>
-          <a:prstGeom prst="rect">
-            <a:avLst/>
-          </a:prstGeom>
-          <a:solidFill>
-            <a:srgbClr val="F0F4F8"/>
-          </a:solidFill>
-          <a:ln w="12700">
-            <a:solidFill>
-              <a:srgbClr val="2D5544"/>
-            </a:solidFill>
-          </a:ln>
-        </p:spPr>
-        <p:txBody>
-          <a:bodyPr wrap="square" anchor="ctr"/>
-          <a:lstStyle/>
-          <a:p>
-            <a:pPr algn="l"/>
-            <a:r>
-              <a:rPr lang="ru-RU" sz="900" b="0">
-                <a:solidFill>
-                  <a:srgbClr val="222222"/>
-                </a:solidFill>
-              </a:rPr>
-              <a:t>institution</a:t>
-            </a:r>
-          </a:p>
-          <a:p>
-            <a:pPr algn="l"/>
-            <a:r>
-              <a:rPr lang="ru-RU" sz="900" b="0">
-                <a:solidFill>
-                  <a:srgbClr val="222222"/>
-                </a:solidFill>
-              </a:rPr>
-              <a:t>lat · lon</a:t>
-            </a:r>
-          </a:p>
-        </p:txBody>
-      </p:sp>
-      <p:sp>
-        <p:nvSpPr>
-          <p:cNvPr id="111" name="sp11"/>
-          <p:cNvSpPr txBox="1"/>
-          <p:nvPr/>
-        </p:nvSpPr>
-        <p:spPr>
-          <a:xfrm>
-            <a:off x="1800000" y="4392000"/>
-            <a:ext cx="2160000" cy="270000"/>
-          </a:xfrm>
-          <a:prstGeom prst="roundRect">
-            <a:avLst>
-              <a:gd name="adj" fmla="val 20000"/>
-            </a:avLst>
-          </a:prstGeom>
-          <a:solidFill>
-            <a:srgbClr val="3A6B55"/>
-          </a:solidFill>
-          <a:ln>
-            <a:noFill/>
-          </a:ln>
-        </p:spPr>
-        <p:txBody>
-          <a:bodyPr wrap="square" anchor="ctr"/>
-          <a:lstStyle/>
-          <a:p>
-            <a:pPr algn="ctr"/>
-            <a:r>
-              <a:rPr lang="ru-RU" sz="1000" b="1">
-                <a:solidFill>
-                  <a:srgbClr val="FFFFFF"/>
-                </a:solidFill>
-              </a:rPr>
-              <a:t>publication_topics</a:t>
-            </a:r>
-          </a:p>
-        </p:txBody>
-      </p:sp>
-      <p:sp>
-        <p:nvSpPr>
-          <p:cNvPr id="112" name="sp12"/>
-          <p:cNvSpPr txBox="1"/>
-          <p:nvPr/>
-        </p:nvSpPr>
-        <p:spPr>
-          <a:xfrm>
-            <a:off x="1800000" y="4662000"/>
-            <a:ext cx="2160000" cy="810000"/>
-          </a:xfrm>
-          <a:prstGeom prst="rect">
-            <a:avLst/>
-          </a:prstGeom>
-          <a:solidFill>
-            <a:srgbClr val="F0F4F8"/>
-          </a:solidFill>
-          <a:ln w="12700">
-            <a:solidFill>
-              <a:srgbClr val="3A6B55"/>
-            </a:solidFill>
-          </a:ln>
-        </p:spPr>
-        <p:txBody>
-          <a:bodyPr wrap="square" anchor="ctr"/>
-          <a:lstStyle/>
-          <a:p>
-            <a:pPr algn="l"/>
-            <a:r>
-              <a:rPr lang="ru-RU" sz="900" b="0">
-                <a:solidFill>
-                  <a:srgbClr val="222222"/>
-                </a:solidFill>
-              </a:rPr>
-              <a:t>publication_id →</a:t>
-            </a:r>
-          </a:p>
-          <a:p>
-            <a:pPr algn="l"/>
-            <a:r>
-              <a:rPr lang="ru-RU" sz="900" b="0">
-                <a:solidFill>
-                  <a:srgbClr val="222222"/>
-                </a:solidFill>
-              </a:rPr>
-              <a:t>topic · score</a:t>
-            </a:r>
-          </a:p>
-        </p:txBody>
-      </p:sp>
-      <p:sp>
-        <p:nvSpPr>
-          <p:cNvPr id="113" name="sp13"/>
-          <p:cNvSpPr txBox="1"/>
-          <p:nvPr/>
-        </p:nvSpPr>
-        <p:spPr>
-          <a:xfrm>
-            <a:off x="1800000" y="2700000"/>
-            <a:ext cx="2160000" cy="270000"/>
-          </a:xfrm>
-          <a:prstGeom prst="roundRect">
-            <a:avLst>
-              <a:gd name="adj" fmla="val 20000"/>
-            </a:avLst>
-          </a:prstGeom>
-          <a:solidFill>
-            <a:srgbClr val="3A6B55"/>
-          </a:solidFill>
-          <a:ln>
-            <a:noFill/>
-          </a:ln>
-        </p:spPr>
-        <p:txBody>
-          <a:bodyPr wrap="square" anchor="ctr"/>
-          <a:lstStyle/>
-          <a:p>
-            <a:pPr algn="ctr"/>
-            <a:r>
-              <a:rPr lang="ru-RU" sz="1000" b="1">
-                <a:solidFill>
-                  <a:srgbClr val="FFFFFF"/>
-                </a:solidFill>
-              </a:rPr>
-              <a:t>publication_keywords</a:t>
-            </a:r>
-          </a:p>
-        </p:txBody>
-      </p:sp>
-      <p:sp>
-        <p:nvSpPr>
-          <p:cNvPr id="114" name="sp14"/>
-          <p:cNvSpPr txBox="1"/>
-          <p:nvPr/>
-        </p:nvSpPr>
-        <p:spPr>
-          <a:xfrm>
-            <a:off x="1800000" y="2970000"/>
-            <a:ext cx="2160000" cy="810000"/>
-          </a:xfrm>
-          <a:prstGeom prst="rect">
-            <a:avLst/>
-          </a:prstGeom>
-          <a:solidFill>
-            <a:srgbClr val="F0F4F8"/>
-          </a:solidFill>
-          <a:ln w="12700">
-            <a:solidFill>
-              <a:srgbClr val="3A6B55"/>
-            </a:solidFill>
-          </a:ln>
-        </p:spPr>
-        <p:txBody>
-          <a:bodyPr wrap="square" anchor="ctr"/>
-          <a:lstStyle/>
-          <a:p>
-            <a:pPr algn="l"/>
-            <a:r>
-              <a:rPr lang="ru-RU" sz="900" b="0">
-                <a:solidFill>
-                  <a:srgbClr val="222222"/>
-                </a:solidFill>
-              </a:rPr>
-              <a:t>publication_id →</a:t>
-            </a:r>
-          </a:p>
-          <a:p>
-            <a:pPr algn="l"/>
-            <a:r>
-              <a:rPr lang="ru-RU" sz="900" b="0">
-                <a:solidFill>
-                  <a:srgbClr val="222222"/>
-                </a:solidFill>
-              </a:rPr>
-              <a:t>keyword · score</a:t>
-            </a:r>
-          </a:p>
-        </p:txBody>
-      </p:sp>
-      <p:sp>
-        <p:nvSpPr>
-          <p:cNvPr id="115" name="sp15"/>
-          <p:cNvSpPr txBox="1"/>
-          <p:nvPr/>
-        </p:nvSpPr>
-        <p:spPr>
-          <a:xfrm>
-            <a:off x="6048000" y="2232000"/>
-            <a:ext cx="540000" cy="180000"/>
-          </a:xfrm>
-          <a:prstGeom prst="rect">
-            <a:avLst/>
-          </a:prstGeom>
-          <a:noFill/>
-          <a:ln>
-            <a:noFill/>
-          </a:ln>
-        </p:spPr>
-        <p:txBody>
-          <a:bodyPr wrap="square" anchor="ctr"/>
-          <a:lstStyle/>
-          <a:p>
-            <a:pPr algn="ctr"/>
-            <a:r>
-              <a:rPr lang="ru-RU" sz="800" b="0">
-                <a:solidFill>
-                  <a:srgbClr val="8BB29A"/>
-                </a:solidFill>
-              </a:rPr>
-              <a:t>1 : N</a:t>
-            </a:r>
-          </a:p>
-        </p:txBody>
-      </p:sp>
-      <p:sp>
-        <p:nvSpPr>
-          <p:cNvPr id="116" name="sp16"/>
-          <p:cNvSpPr txBox="1"/>
-          <p:nvPr/>
-        </p:nvSpPr>
-        <p:spPr>
-          <a:xfrm>
-            <a:off x="7380000" y="3240000"/>
-            <a:ext cx="540000" cy="180000"/>
-          </a:xfrm>
-          <a:prstGeom prst="rect">
-            <a:avLst/>
-          </a:prstGeom>
-          <a:noFill/>
-          <a:ln>
-            <a:noFill/>
-          </a:ln>
-        </p:spPr>
-        <p:txBody>
-          <a:bodyPr wrap="square" anchor="ctr"/>
-          <a:lstStyle/>
-          <a:p>
-            <a:pPr algn="ctr"/>
-            <a:r>
-              <a:rPr lang="ru-RU" sz="800" b="0">
-                <a:solidFill>
-                  <a:srgbClr val="8BB29A"/>
-                </a:solidFill>
-              </a:rPr>
-              <a:t>1 : N</a:t>
-            </a:r>
-          </a:p>
-        </p:txBody>
-      </p:sp>
-      <p:sp>
-        <p:nvSpPr>
-          <p:cNvPr id="117" name="sp17"/>
-          <p:cNvSpPr txBox="1"/>
-          <p:nvPr/>
-        </p:nvSpPr>
-        <p:spPr>
-          <a:xfrm>
-            <a:off x="9180000" y="4031999"/>
-            <a:ext cx="540000" cy="180000"/>
-          </a:xfrm>
-          <a:prstGeom prst="rect">
-            <a:avLst/>
-          </a:prstGeom>
-          <a:noFill/>
-          <a:ln>
-            <a:noFill/>
-          </a:ln>
-        </p:spPr>
-        <p:txBody>
-          <a:bodyPr wrap="square" anchor="ctr"/>
-          <a:lstStyle/>
-          <a:p>
-            <a:pPr algn="ctr"/>
-            <a:r>
-              <a:rPr lang="ru-RU" sz="800" b="0">
-                <a:solidFill>
-                  <a:srgbClr val="8BB29A"/>
-                </a:solidFill>
-              </a:rPr>
-              <a:t>N : 1</a:t>
-            </a:r>
-          </a:p>
-        </p:txBody>
-      </p:sp>
-      <p:sp>
-        <p:nvSpPr>
-          <p:cNvPr id="118" name="sp18"/>
-          <p:cNvSpPr txBox="1"/>
-          <p:nvPr/>
-        </p:nvSpPr>
-        <p:spPr>
-          <a:xfrm>
-            <a:off x="4068000" y="3240000"/>
-            <a:ext cx="540000" cy="180000"/>
-          </a:xfrm>
-          <a:prstGeom prst="rect">
-            <a:avLst/>
-          </a:prstGeom>
-          <a:noFill/>
-          <a:ln>
-            <a:noFill/>
-          </a:ln>
-        </p:spPr>
-        <p:txBody>
-          <a:bodyPr wrap="square" anchor="ctr"/>
-          <a:lstStyle/>
-          <a:p>
-            <a:pPr algn="ctr"/>
-            <a:r>
-              <a:rPr lang="ru-RU" sz="800" b="0">
-                <a:solidFill>
-                  <a:srgbClr val="8BB29A"/>
-                </a:solidFill>
-              </a:rPr>
-              <a:t>1 : N</a:t>
-            </a:r>
-          </a:p>
-        </p:txBody>
-      </p:sp>
-      <p:sp>
-        <p:nvSpPr>
-          <p:cNvPr id="119" name="sp19"/>
-          <p:cNvSpPr txBox="1"/>
-          <p:nvPr/>
-        </p:nvSpPr>
-        <p:spPr>
-          <a:xfrm>
-            <a:off x="4068000" y="4031999"/>
-            <a:ext cx="540000" cy="180000"/>
-          </a:xfrm>
-          <a:prstGeom prst="rect">
-            <a:avLst/>
-          </a:prstGeom>
-          <a:noFill/>
-          <a:ln>
-            <a:noFill/>
-          </a:ln>
-        </p:spPr>
-        <p:txBody>
-          <a:bodyPr wrap="square" anchor="ctr"/>
-          <a:lstStyle/>
-          <a:p>
-            <a:pPr algn="ctr"/>
-            <a:r>
-              <a:rPr lang="ru-RU" sz="800" b="0">
-                <a:solidFill>
-                  <a:srgbClr val="8BB29A"/>
-                </a:solidFill>
-              </a:rPr>
-              <a:t>1 : N</a:t>
-            </a:r>
-          </a:p>
-        </p:txBody>
-      </p:sp>
-      <p:sp>
-        <p:nvSpPr>
-          <p:cNvPr id="9090" name="pb90"/>
-          <p:cNvSpPr txBox="1"/>
-          <p:nvPr/>
-        </p:nvSpPr>
-        <p:spPr>
-          <a:xfrm>
-            <a:off x="0" y="6660000"/>
-            <a:ext cx="12192000" cy="198000"/>
-          </a:xfrm>
-          <a:prstGeom prst="rect">
-            <a:avLst/>
-          </a:prstGeom>
-          <a:solidFill>
-            <a:srgbClr val="0D1F14"/>
-          </a:solidFill>
-          <a:ln>
-            <a:noFill/>
-          </a:ln>
-        </p:spPr>
-        <p:txBody>
-          <a:bodyPr wrap="none" anchor="ctr"/>
-          <a:lstStyle/>
-          <a:p/>
-        </p:txBody>
-      </p:sp>
-      <p:sp>
-        <p:nvSpPr>
-          <p:cNvPr id="9091" name="pb91"/>
-          <p:cNvSpPr txBox="1"/>
-          <p:nvPr/>
-        </p:nvSpPr>
-        <p:spPr>
-          <a:xfrm>
-            <a:off x="0" y="6660000"/>
-            <a:ext cx="7315200" cy="198000"/>
-          </a:xfrm>
-          <a:prstGeom prst="rect">
-            <a:avLst/>
-          </a:prstGeom>
-          <a:solidFill>
-            <a:srgbClr val="2D5544"/>
-          </a:solidFill>
-          <a:ln>
-            <a:noFill/>
-          </a:ln>
-        </p:spPr>
-        <p:txBody>
-          <a:bodyPr wrap="none" anchor="ctr"/>
-          <a:lstStyle/>
-          <a:p/>
-        </p:txBody>
-      </p:sp>
-      <p:sp>
-        <p:nvSpPr>
-          <p:cNvPr id="9092" name="pb92"/>
-          <p:cNvSpPr txBox="1"/>
-          <p:nvPr/>
-        </p:nvSpPr>
-        <p:spPr>
-          <a:xfrm>
-            <a:off x="6775200" y="6660000"/>
-            <a:ext cx="540000" cy="198000"/>
-          </a:xfrm>
-          <a:prstGeom prst="rect">
-            <a:avLst/>
-          </a:prstGeom>
-          <a:solidFill>
-            <a:srgbClr val="3A6B55"/>
-          </a:solidFill>
-          <a:ln>
-            <a:noFill/>
-          </a:ln>
-        </p:spPr>
-        <p:txBody>
-          <a:bodyPr wrap="none" anchor="ctr"/>
-          <a:lstStyle/>
-          <a:p/>
-        </p:txBody>
-      </p:sp>
-      <p:sp>
-        <p:nvSpPr>
-          <p:cNvPr id="9093" name="pb93"/>
-          <p:cNvSpPr txBox="1"/>
-          <p:nvPr/>
-        </p:nvSpPr>
-        <p:spPr>
-          <a:xfrm>
-            <a:off x="6667200" y="6660000"/>
-            <a:ext cx="648000" cy="198000"/>
-          </a:xfrm>
-          <a:prstGeom prst="rect">
-            <a:avLst/>
-          </a:prstGeom>
-          <a:solidFill>
-            <a:srgbClr val="23613F"/>
-          </a:solidFill>
-          <a:ln>
-            <a:noFill/>
-          </a:ln>
-        </p:spPr>
-        <p:txBody>
-          <a:bodyPr wrap="none" anchor="ctr"/>
-          <a:lstStyle/>
-          <a:p>
-            <a:pPr algn="ctr"/>
-            <a:r>
-              <a:rPr lang="ru-RU" sz="800" b="1">
-                <a:solidFill>
-                  <a:srgbClr val="FFFFFF"/>
-                </a:solidFill>
-              </a:rPr>
-              <a:t>9</a:t>
-            </a:r>
-          </a:p>
-        </p:txBody>
-      </p:sp>
+      <p:pic>
+        <p:nvPicPr>
+          <p:cNvPr id="4" name="Рисунок 3"/>
+          <p:cNvPicPr>
+            <a:picLocks noChangeAspect="1"/>
+          </p:cNvPicPr>
+          <p:nvPr/>
+        </p:nvPicPr>
+        <p:blipFill>
+          <a:blip r:embed="rId2"/>
+          <a:stretch>
+            <a:fillRect/>
+          </a:stretch>
+        </p:blipFill>
+        <p:spPr>
+          <a:xfrm>
+            <a:off x="498483" y="1005841"/>
+            <a:ext cx="11093749" cy="5680194"/>
+          </a:xfrm>
+          <a:prstGeom prst="rect">
+            <a:avLst/>
+          </a:prstGeom>
+        </p:spPr>
+      </p:pic>
     </p:spTree>
   </p:cSld>
   <p:clrMapOvr>

</xml_diff>

<commit_message>
Fix edge type text visibility on slide 10: set color to white
Text was CFE0D6/23613F on dark background — invisible.
</commit_message>
<xml_diff>
--- a/docs/Визуализация науки на основе метаданных публикаций и журналов.pptx
+++ b/docs/Визуализация науки на основе метаданных публикаций и журналов.pptx
@@ -6292,10 +6292,10 @@
             <a:pPr algn="l"/>
             <a:r>
               <a:rPr sz="1100" b="1" i="0">
-                <a:solidFill>
-                  <a:srgbClr val="23613F"/>
-                </a:solidFill>
                 <a:latin typeface="Calibri"/>
+                <a:solidFill>
+                  <a:srgbClr val="FFFFFF"/>
+                </a:solidFill>
               </a:rPr>
               <a:t>Типы связей:</a:t>
             </a:r>
@@ -6327,10 +6327,10 @@
             <a:pPr algn="ctr"/>
             <a:r>
               <a:rPr sz="1000" b="1" i="0">
-                <a:solidFill>
-                  <a:srgbClr val="CFE0D6"/>
-                </a:solidFill>
                 <a:latin typeface="Calibri"/>
+                <a:solidFill>
+                  <a:srgbClr val="FFFFFF"/>
+                </a:solidFill>
               </a:rPr>
               <a:t>Год → Статья</a:t>
             </a:r>
@@ -6362,10 +6362,10 @@
             <a:pPr algn="ctr"/>
             <a:r>
               <a:rPr sz="1000" b="1" i="0">
-                <a:solidFill>
-                  <a:srgbClr val="CFE0D6"/>
-                </a:solidFill>
                 <a:latin typeface="Calibri"/>
+                <a:solidFill>
+                  <a:srgbClr val="FFFFFF"/>
+                </a:solidFill>
               </a:rPr>
               <a:t>Журнал → Статья</a:t>
             </a:r>
@@ -6397,10 +6397,10 @@
             <a:pPr algn="ctr"/>
             <a:r>
               <a:rPr sz="1000" b="1" i="0">
-                <a:solidFill>
-                  <a:srgbClr val="CFE0D6"/>
-                </a:solidFill>
                 <a:latin typeface="Calibri"/>
+                <a:solidFill>
+                  <a:srgbClr val="FFFFFF"/>
+                </a:solidFill>
               </a:rPr>
               <a:t>Статья → Автор</a:t>
             </a:r>
@@ -6432,10 +6432,10 @@
             <a:pPr algn="ctr"/>
             <a:r>
               <a:rPr sz="1000" b="1" i="0">
-                <a:solidFill>
-                  <a:srgbClr val="CFE0D6"/>
-                </a:solidFill>
                 <a:latin typeface="Calibri"/>
+                <a:solidFill>
+                  <a:srgbClr val="FFFFFF"/>
+                </a:solidFill>
               </a:rPr>
               <a:t>Статья → Аффил.</a:t>
             </a:r>
@@ -6467,10 +6467,10 @@
             <a:pPr algn="ctr"/>
             <a:r>
               <a:rPr sz="1000" b="1" i="0">
-                <a:solidFill>
-                  <a:srgbClr val="CFE0D6"/>
-                </a:solidFill>
                 <a:latin typeface="Calibri"/>
+                <a:solidFill>
+                  <a:srgbClr val="FFFFFF"/>
+                </a:solidFill>
               </a:rPr>
               <a:t>Статья — Статья</a:t>
             </a:r>

</xml_diff>

<commit_message>
Fix node/edge type labels on graph slide: match colors and font sizes
</commit_message>
<xml_diff>
--- a/docs/Визуализация науки на основе метаданных публикаций и журналов.pptx
+++ b/docs/Визуализация науки на основе метаданных публикаций и журналов.pptx
@@ -5712,7 +5712,7 @@
             <a:r>
               <a:rPr sz="1400" b="1" i="0">
                 <a:solidFill>
-                  <a:srgbClr val="23613F"/>
+                  <a:srgbClr val="FFFFFF"/>
                 </a:solidFill>
                 <a:latin typeface="Calibri"/>
               </a:rPr>
@@ -6291,7 +6291,7 @@
           <a:p>
             <a:pPr algn="l"/>
             <a:r>
-              <a:rPr sz="1100" b="1" i="0">
+              <a:rPr sz="1400" b="1" i="0">
                 <a:latin typeface="Calibri"/>
                 <a:solidFill>
                   <a:srgbClr val="FFFFFF"/>
@@ -6326,7 +6326,7 @@
           <a:p>
             <a:pPr algn="ctr"/>
             <a:r>
-              <a:rPr sz="1000" b="1" i="0">
+              <a:rPr sz="1300" b="1" i="0">
                 <a:latin typeface="Calibri"/>
                 <a:solidFill>
                   <a:srgbClr val="FFFFFF"/>
@@ -6361,7 +6361,7 @@
           <a:p>
             <a:pPr algn="ctr"/>
             <a:r>
-              <a:rPr sz="1000" b="1" i="0">
+              <a:rPr sz="1300" b="1" i="0">
                 <a:latin typeface="Calibri"/>
                 <a:solidFill>
                   <a:srgbClr val="FFFFFF"/>
@@ -6396,7 +6396,7 @@
           <a:p>
             <a:pPr algn="ctr"/>
             <a:r>
-              <a:rPr sz="1000" b="1" i="0">
+              <a:rPr sz="1300" b="1" i="0">
                 <a:latin typeface="Calibri"/>
                 <a:solidFill>
                   <a:srgbClr val="FFFFFF"/>
@@ -6431,7 +6431,7 @@
           <a:p>
             <a:pPr algn="ctr"/>
             <a:r>
-              <a:rPr sz="1000" b="1" i="0">
+              <a:rPr sz="1300" b="1" i="0">
                 <a:latin typeface="Calibri"/>
                 <a:solidFill>
                   <a:srgbClr val="FFFFFF"/>
@@ -6466,7 +6466,7 @@
           <a:p>
             <a:pPr algn="ctr"/>
             <a:r>
-              <a:rPr sz="1000" b="1" i="0">
+              <a:rPr sz="1300" b="1" i="0">
                 <a:latin typeface="Calibri"/>
                 <a:solidFill>
                   <a:srgbClr val="FFFFFF"/>

</xml_diff>